<commit_message>
Adding volume change (effort) slide
</commit_message>
<xml_diff>
--- a/src/report_generator/presets/templates/portfolio-overview.pptx
+++ b/src/report_generator/presets/templates/portfolio-overview.pptx
@@ -5,10 +5,10 @@
     <p:sldMasterId id="2147483648" r:id="rId4"/>
   </p:sldMasterIdLst>
   <p:notesMasterIdLst>
-    <p:notesMasterId r:id="rId23"/>
+    <p:notesMasterId r:id="rId24"/>
   </p:notesMasterIdLst>
   <p:handoutMasterIdLst>
-    <p:handoutMasterId r:id="rId24"/>
+    <p:handoutMasterId r:id="rId25"/>
   </p:handoutMasterIdLst>
   <p:sldIdLst>
     <p:sldId id="561" r:id="rId5"/>
@@ -25,10 +25,11 @@
     <p:sldId id="10725" r:id="rId16"/>
     <p:sldId id="10721" r:id="rId17"/>
     <p:sldId id="10728" r:id="rId18"/>
-    <p:sldId id="10727" r:id="rId19"/>
-    <p:sldId id="10726" r:id="rId20"/>
-    <p:sldId id="10723" r:id="rId21"/>
-    <p:sldId id="597" r:id="rId22"/>
+    <p:sldId id="10729" r:id="rId19"/>
+    <p:sldId id="10727" r:id="rId20"/>
+    <p:sldId id="10726" r:id="rId21"/>
+    <p:sldId id="10723" r:id="rId22"/>
+    <p:sldId id="597" r:id="rId23"/>
   </p:sldIdLst>
   <p:sldSz cx="12192000" cy="6858000"/>
   <p:notesSz cx="6858000" cy="9144000"/>
@@ -573,6 +574,7 @@
     </c:plotArea>
     <c:plotVisOnly val="1"/>
     <c:dispBlanksAs val="gap"/>
+    <c:showDLblsOverMax val="0"/>
     <c:extLst xmlns:lc="http://schemas.openxmlformats.org/drawingml/2006/lockedCanvas" xmlns:comp="http://schemas.openxmlformats.org/drawingml/2006/compatibility" xmlns:we="http://schemas.microsoft.com/office/webextensions/webextension/2010/11" xmlns:wetp="http://schemas.microsoft.com/office/webextensions/taskpanes/2010/11" xmlns:w16cid="http://schemas.microsoft.com/office/word/2016/wordml/cid" xmlns:w16se="http://schemas.microsoft.com/office/word/2015/wordml/symex" xmlns:wps="http://schemas.microsoft.com/office/word/2010/wordprocessingShape" xmlns:b="http://schemas.openxmlformats.org/officeDocument/2006/bibliography" xmlns:odgm="http://opendope.org/SmartArt/DataHierarchy" xmlns:odi="http://opendope.org/components" xmlns:oda="http://opendope.org/answers" xmlns:odq="http://opendope.org/questions" xmlns:odc="http://opendope.org/conditions" xmlns:odx="http://opendope.org/xpaths" xmlns:cppr="http://schemas.microsoft.com/office/2006/coverPageProps" xmlns:pvml="urn:schemas-microsoft-com:office:powerpoint" xmlns:w10="urn:schemas-microsoft-com:office:word" xmlns:v="urn:schemas-microsoft-com:vml" xmlns:o="urn:schemas-microsoft-com:office:office" xmlns:xvml="urn:schemas-microsoft-com:office:excel" xmlns:dsp="http://schemas.microsoft.com/office/drawing/2008/diagram" xmlns:xdr="http://schemas.openxmlformats.org/drawingml/2006/spreadsheetDrawing" xmlns:pic="http://schemas.openxmlformats.org/drawingml/2006/picture" xmlns:dgm="http://schemas.openxmlformats.org/drawingml/2006/diagram" xmlns:c14="http://schemas.microsoft.com/office/drawing/2007/8/2/chart" xmlns:cdr="http://schemas.openxmlformats.org/drawingml/2006/chartDrawing" xmlns:wne="http://schemas.microsoft.com/office/word/2006/wordml" xmlns:sl="http://schemas.openxmlformats.org/schemaLibrary/2006/main" xmlns:mc="http://schemas.openxmlformats.org/markup-compatibility/2006" xmlns:wp14="http://schemas.microsoft.com/office/word/2010/wordprocessingDrawing" xmlns:wp="http://schemas.openxmlformats.org/drawingml/2006/wordprocessingDrawing" xmlns:m="http://schemas.openxmlformats.org/officeDocument/2006/math" xmlns:w14="http://schemas.microsoft.com/office/word/2010/wordml" xmlns:w15="http://schemas.microsoft.com/office/word/2012/wordml" xmlns:w="http://schemas.openxmlformats.org/wordprocessingml/2006/main">
       <c:ext xmlns:c16r3="http://schemas.microsoft.com/office/drawing/2017/03/chart" uri="{56B9EC1D-385E-4148-901F-78D8002777C0}">
         <c16r3:dataDisplayOptions16>
@@ -580,7 +582,6 @@
         </c16r3:dataDisplayOptions16>
       </c:ext>
     </c:extLst>
-    <c:showDLblsOverMax val="0"/>
   </c:chart>
   <c:spPr>
     <a:noFill/>
@@ -1321,6 +1322,7 @@
     </c:plotArea>
     <c:plotVisOnly val="1"/>
     <c:dispBlanksAs val="gap"/>
+    <c:showDLblsOverMax val="0"/>
     <c:extLst xmlns:w="http://schemas.openxmlformats.org/wordprocessingml/2006/main" xmlns:w15="http://schemas.microsoft.com/office/word/2012/wordml" xmlns:w14="http://schemas.microsoft.com/office/word/2010/wordml" xmlns:m="http://schemas.openxmlformats.org/officeDocument/2006/math" xmlns:wp="http://schemas.openxmlformats.org/drawingml/2006/wordprocessingDrawing" xmlns:wp14="http://schemas.microsoft.com/office/word/2010/wordprocessingDrawing" xmlns:mc="http://schemas.openxmlformats.org/markup-compatibility/2006" xmlns:sl="http://schemas.openxmlformats.org/schemaLibrary/2006/main" xmlns:wne="http://schemas.microsoft.com/office/word/2006/wordml" xmlns:cdr="http://schemas.openxmlformats.org/drawingml/2006/chartDrawing" xmlns:c14="http://schemas.microsoft.com/office/drawing/2007/8/2/chart" xmlns:dgm="http://schemas.openxmlformats.org/drawingml/2006/diagram" xmlns:pic="http://schemas.openxmlformats.org/drawingml/2006/picture" xmlns:xdr="http://schemas.openxmlformats.org/drawingml/2006/spreadsheetDrawing" xmlns:dsp="http://schemas.microsoft.com/office/drawing/2008/diagram" xmlns:xvml="urn:schemas-microsoft-com:office:excel" xmlns:o="urn:schemas-microsoft-com:office:office" xmlns:v="urn:schemas-microsoft-com:vml" xmlns:w10="urn:schemas-microsoft-com:office:word" xmlns:pvml="urn:schemas-microsoft-com:office:powerpoint" xmlns:cppr="http://schemas.microsoft.com/office/2006/coverPageProps" xmlns:odx="http://opendope.org/xpaths" xmlns:odc="http://opendope.org/conditions" xmlns:odq="http://opendope.org/questions" xmlns:oda="http://opendope.org/answers" xmlns:odi="http://opendope.org/components" xmlns:odgm="http://opendope.org/SmartArt/DataHierarchy" xmlns:b="http://schemas.openxmlformats.org/officeDocument/2006/bibliography" xmlns:wps="http://schemas.microsoft.com/office/word/2010/wordprocessingShape" xmlns:w16se="http://schemas.microsoft.com/office/word/2015/wordml/symex" xmlns:w16cid="http://schemas.microsoft.com/office/word/2016/wordml/cid" xmlns:wetp="http://schemas.microsoft.com/office/webextensions/taskpanes/2010/11" xmlns:we="http://schemas.microsoft.com/office/webextensions/webextension/2010/11" xmlns:comp="http://schemas.openxmlformats.org/drawingml/2006/compatibility" xmlns:lc="http://schemas.openxmlformats.org/drawingml/2006/lockedCanvas">
       <c:ext xmlns:c16r3="http://schemas.microsoft.com/office/drawing/2017/03/chart" uri="{56B9EC1D-385E-4148-901F-78D8002777C0}">
         <c16r3:dataDisplayOptions16>
@@ -1328,7 +1330,6 @@
         </c16r3:dataDisplayOptions16>
       </c:ext>
     </c:extLst>
-    <c:showDLblsOverMax val="0"/>
   </c:chart>
   <c:spPr>
     <a:noFill/>
@@ -2069,6 +2070,7 @@
     </c:plotArea>
     <c:plotVisOnly val="1"/>
     <c:dispBlanksAs val="gap"/>
+    <c:showDLblsOverMax val="0"/>
     <c:extLst xmlns:lc="http://schemas.openxmlformats.org/drawingml/2006/lockedCanvas" xmlns:comp="http://schemas.openxmlformats.org/drawingml/2006/compatibility" xmlns:we="http://schemas.microsoft.com/office/webextensions/webextension/2010/11" xmlns:wetp="http://schemas.microsoft.com/office/webextensions/taskpanes/2010/11" xmlns:w16cid="http://schemas.microsoft.com/office/word/2016/wordml/cid" xmlns:w16se="http://schemas.microsoft.com/office/word/2015/wordml/symex" xmlns:wps="http://schemas.microsoft.com/office/word/2010/wordprocessingShape" xmlns:b="http://schemas.openxmlformats.org/officeDocument/2006/bibliography" xmlns:odgm="http://opendope.org/SmartArt/DataHierarchy" xmlns:odi="http://opendope.org/components" xmlns:oda="http://opendope.org/answers" xmlns:odq="http://opendope.org/questions" xmlns:odc="http://opendope.org/conditions" xmlns:odx="http://opendope.org/xpaths" xmlns:cppr="http://schemas.microsoft.com/office/2006/coverPageProps" xmlns:pvml="urn:schemas-microsoft-com:office:powerpoint" xmlns:w10="urn:schemas-microsoft-com:office:word" xmlns:v="urn:schemas-microsoft-com:vml" xmlns:o="urn:schemas-microsoft-com:office:office" xmlns:xvml="urn:schemas-microsoft-com:office:excel" xmlns:dsp="http://schemas.microsoft.com/office/drawing/2008/diagram" xmlns:xdr="http://schemas.openxmlformats.org/drawingml/2006/spreadsheetDrawing" xmlns:pic="http://schemas.openxmlformats.org/drawingml/2006/picture" xmlns:dgm="http://schemas.openxmlformats.org/drawingml/2006/diagram" xmlns:c14="http://schemas.microsoft.com/office/drawing/2007/8/2/chart" xmlns:cdr="http://schemas.openxmlformats.org/drawingml/2006/chartDrawing" xmlns:wne="http://schemas.microsoft.com/office/word/2006/wordml" xmlns:sl="http://schemas.openxmlformats.org/schemaLibrary/2006/main" xmlns:mc="http://schemas.openxmlformats.org/markup-compatibility/2006" xmlns:wp14="http://schemas.microsoft.com/office/word/2010/wordprocessingDrawing" xmlns:wp="http://schemas.openxmlformats.org/drawingml/2006/wordprocessingDrawing" xmlns:m="http://schemas.openxmlformats.org/officeDocument/2006/math" xmlns:w14="http://schemas.microsoft.com/office/word/2010/wordml" xmlns:w15="http://schemas.microsoft.com/office/word/2012/wordml" xmlns:w="http://schemas.openxmlformats.org/wordprocessingml/2006/main">
       <c:ext xmlns:c16r3="http://schemas.microsoft.com/office/drawing/2017/03/chart" uri="{56B9EC1D-385E-4148-901F-78D8002777C0}">
         <c16r3:dataDisplayOptions16>
@@ -2076,7 +2078,6 @@
         </c16r3:dataDisplayOptions16>
       </c:ext>
     </c:extLst>
-    <c:showDLblsOverMax val="0"/>
   </c:chart>
   <c:spPr>
     <a:noFill/>
@@ -2877,6 +2878,7 @@
     </c:plotArea>
     <c:plotVisOnly val="1"/>
     <c:dispBlanksAs val="gap"/>
+    <c:showDLblsOverMax val="0"/>
     <c:extLst xmlns:w="http://schemas.openxmlformats.org/wordprocessingml/2006/main" xmlns:w15="http://schemas.microsoft.com/office/word/2012/wordml" xmlns:w14="http://schemas.microsoft.com/office/word/2010/wordml" xmlns:m="http://schemas.openxmlformats.org/officeDocument/2006/math" xmlns:wp="http://schemas.openxmlformats.org/drawingml/2006/wordprocessingDrawing" xmlns:wp14="http://schemas.microsoft.com/office/word/2010/wordprocessingDrawing" xmlns:mc="http://schemas.openxmlformats.org/markup-compatibility/2006" xmlns:sl="http://schemas.openxmlformats.org/schemaLibrary/2006/main" xmlns:wne="http://schemas.microsoft.com/office/word/2006/wordml" xmlns:cdr="http://schemas.openxmlformats.org/drawingml/2006/chartDrawing" xmlns:c14="http://schemas.microsoft.com/office/drawing/2007/8/2/chart" xmlns:dgm="http://schemas.openxmlformats.org/drawingml/2006/diagram" xmlns:pic="http://schemas.openxmlformats.org/drawingml/2006/picture" xmlns:xdr="http://schemas.openxmlformats.org/drawingml/2006/spreadsheetDrawing" xmlns:dsp="http://schemas.microsoft.com/office/drawing/2008/diagram" xmlns:xvml="urn:schemas-microsoft-com:office:excel" xmlns:o="urn:schemas-microsoft-com:office:office" xmlns:v="urn:schemas-microsoft-com:vml" xmlns:w10="urn:schemas-microsoft-com:office:word" xmlns:pvml="urn:schemas-microsoft-com:office:powerpoint" xmlns:cppr="http://schemas.microsoft.com/office/2006/coverPageProps" xmlns:odx="http://opendope.org/xpaths" xmlns:odc="http://opendope.org/conditions" xmlns:odq="http://opendope.org/questions" xmlns:oda="http://opendope.org/answers" xmlns:odi="http://opendope.org/components" xmlns:odgm="http://opendope.org/SmartArt/DataHierarchy" xmlns:b="http://schemas.openxmlformats.org/officeDocument/2006/bibliography" xmlns:wps="http://schemas.microsoft.com/office/word/2010/wordprocessingShape" xmlns:w16se="http://schemas.microsoft.com/office/word/2015/wordml/symex" xmlns:w16cid="http://schemas.microsoft.com/office/word/2016/wordml/cid" xmlns:wetp="http://schemas.microsoft.com/office/webextensions/taskpanes/2010/11" xmlns:we="http://schemas.microsoft.com/office/webextensions/webextension/2010/11" xmlns:comp="http://schemas.openxmlformats.org/drawingml/2006/compatibility" xmlns:lc="http://schemas.openxmlformats.org/drawingml/2006/lockedCanvas">
       <c:ext xmlns:c16r3="http://schemas.microsoft.com/office/drawing/2017/03/chart" uri="{56B9EC1D-385E-4148-901F-78D8002777C0}">
         <c16r3:dataDisplayOptions16>
@@ -2884,7 +2886,6 @@
         </c16r3:dataDisplayOptions16>
       </c:ext>
     </c:extLst>
-    <c:showDLblsOverMax val="0"/>
   </c:chart>
   <c:spPr>
     <a:noFill/>
@@ -3685,6 +3686,7 @@
     </c:plotArea>
     <c:plotVisOnly val="1"/>
     <c:dispBlanksAs val="gap"/>
+    <c:showDLblsOverMax val="0"/>
     <c:extLst xmlns:w="http://schemas.openxmlformats.org/wordprocessingml/2006/main" xmlns:w15="http://schemas.microsoft.com/office/word/2012/wordml" xmlns:w14="http://schemas.microsoft.com/office/word/2010/wordml" xmlns:m="http://schemas.openxmlformats.org/officeDocument/2006/math" xmlns:wp="http://schemas.openxmlformats.org/drawingml/2006/wordprocessingDrawing" xmlns:wp14="http://schemas.microsoft.com/office/word/2010/wordprocessingDrawing" xmlns:mc="http://schemas.openxmlformats.org/markup-compatibility/2006" xmlns:sl="http://schemas.openxmlformats.org/schemaLibrary/2006/main" xmlns:wne="http://schemas.microsoft.com/office/word/2006/wordml" xmlns:cdr="http://schemas.openxmlformats.org/drawingml/2006/chartDrawing" xmlns:c14="http://schemas.microsoft.com/office/drawing/2007/8/2/chart" xmlns:dgm="http://schemas.openxmlformats.org/drawingml/2006/diagram" xmlns:pic="http://schemas.openxmlformats.org/drawingml/2006/picture" xmlns:xdr="http://schemas.openxmlformats.org/drawingml/2006/spreadsheetDrawing" xmlns:dsp="http://schemas.microsoft.com/office/drawing/2008/diagram" xmlns:xvml="urn:schemas-microsoft-com:office:excel" xmlns:o="urn:schemas-microsoft-com:office:office" xmlns:v="urn:schemas-microsoft-com:vml" xmlns:w10="urn:schemas-microsoft-com:office:word" xmlns:pvml="urn:schemas-microsoft-com:office:powerpoint" xmlns:cppr="http://schemas.microsoft.com/office/2006/coverPageProps" xmlns:odx="http://opendope.org/xpaths" xmlns:odc="http://opendope.org/conditions" xmlns:odq="http://opendope.org/questions" xmlns:oda="http://opendope.org/answers" xmlns:odi="http://opendope.org/components" xmlns:odgm="http://opendope.org/SmartArt/DataHierarchy" xmlns:b="http://schemas.openxmlformats.org/officeDocument/2006/bibliography" xmlns:wps="http://schemas.microsoft.com/office/word/2010/wordprocessingShape" xmlns:w16se="http://schemas.microsoft.com/office/word/2015/wordml/symex" xmlns:w16cid="http://schemas.microsoft.com/office/word/2016/wordml/cid" xmlns:wetp="http://schemas.microsoft.com/office/webextensions/taskpanes/2010/11" xmlns:we="http://schemas.microsoft.com/office/webextensions/webextension/2010/11" xmlns:comp="http://schemas.openxmlformats.org/drawingml/2006/compatibility" xmlns:lc="http://schemas.openxmlformats.org/drawingml/2006/lockedCanvas">
       <c:ext xmlns:c16r3="http://schemas.microsoft.com/office/drawing/2017/03/chart" uri="{56B9EC1D-385E-4148-901F-78D8002777C0}">
         <c16r3:dataDisplayOptions16>
@@ -3692,7 +3694,6 @@
         </c16r3:dataDisplayOptions16>
       </c:ext>
     </c:extLst>
-    <c:showDLblsOverMax val="0"/>
   </c:chart>
   <c:spPr>
     <a:noFill/>
@@ -4493,6 +4494,7 @@
     </c:plotArea>
     <c:plotVisOnly val="1"/>
     <c:dispBlanksAs val="gap"/>
+    <c:showDLblsOverMax val="0"/>
     <c:extLst xmlns:lc="http://schemas.openxmlformats.org/drawingml/2006/lockedCanvas" xmlns:comp="http://schemas.openxmlformats.org/drawingml/2006/compatibility" xmlns:we="http://schemas.microsoft.com/office/webextensions/webextension/2010/11" xmlns:wetp="http://schemas.microsoft.com/office/webextensions/taskpanes/2010/11" xmlns:w16cid="http://schemas.microsoft.com/office/word/2016/wordml/cid" xmlns:w16se="http://schemas.microsoft.com/office/word/2015/wordml/symex" xmlns:wps="http://schemas.microsoft.com/office/word/2010/wordprocessingShape" xmlns:b="http://schemas.openxmlformats.org/officeDocument/2006/bibliography" xmlns:odgm="http://opendope.org/SmartArt/DataHierarchy" xmlns:odi="http://opendope.org/components" xmlns:oda="http://opendope.org/answers" xmlns:odq="http://opendope.org/questions" xmlns:odc="http://opendope.org/conditions" xmlns:odx="http://opendope.org/xpaths" xmlns:cppr="http://schemas.microsoft.com/office/2006/coverPageProps" xmlns:pvml="urn:schemas-microsoft-com:office:powerpoint" xmlns:w10="urn:schemas-microsoft-com:office:word" xmlns:v="urn:schemas-microsoft-com:vml" xmlns:o="urn:schemas-microsoft-com:office:office" xmlns:xvml="urn:schemas-microsoft-com:office:excel" xmlns:dsp="http://schemas.microsoft.com/office/drawing/2008/diagram" xmlns:xdr="http://schemas.openxmlformats.org/drawingml/2006/spreadsheetDrawing" xmlns:pic="http://schemas.openxmlformats.org/drawingml/2006/picture" xmlns:dgm="http://schemas.openxmlformats.org/drawingml/2006/diagram" xmlns:c14="http://schemas.microsoft.com/office/drawing/2007/8/2/chart" xmlns:cdr="http://schemas.openxmlformats.org/drawingml/2006/chartDrawing" xmlns:wne="http://schemas.microsoft.com/office/word/2006/wordml" xmlns:sl="http://schemas.openxmlformats.org/schemaLibrary/2006/main" xmlns:mc="http://schemas.openxmlformats.org/markup-compatibility/2006" xmlns:wp14="http://schemas.microsoft.com/office/word/2010/wordprocessingDrawing" xmlns:wp="http://schemas.openxmlformats.org/drawingml/2006/wordprocessingDrawing" xmlns:m="http://schemas.openxmlformats.org/officeDocument/2006/math" xmlns:w14="http://schemas.microsoft.com/office/word/2010/wordml" xmlns:w15="http://schemas.microsoft.com/office/word/2012/wordml" xmlns:w="http://schemas.openxmlformats.org/wordprocessingml/2006/main">
       <c:ext xmlns:c16r3="http://schemas.microsoft.com/office/drawing/2017/03/chart" uri="{56B9EC1D-385E-4148-901F-78D8002777C0}">
         <c16r3:dataDisplayOptions16>
@@ -4500,7 +4502,6 @@
         </c16r3:dataDisplayOptions16>
       </c:ext>
     </c:extLst>
-    <c:showDLblsOverMax val="0"/>
   </c:chart>
   <c:spPr>
     <a:noFill/>
@@ -5301,6 +5302,7 @@
     </c:plotArea>
     <c:plotVisOnly val="1"/>
     <c:dispBlanksAs val="gap"/>
+    <c:showDLblsOverMax val="0"/>
     <c:extLst xmlns:lc="http://schemas.openxmlformats.org/drawingml/2006/lockedCanvas" xmlns:comp="http://schemas.openxmlformats.org/drawingml/2006/compatibility" xmlns:we="http://schemas.microsoft.com/office/webextensions/webextension/2010/11" xmlns:wetp="http://schemas.microsoft.com/office/webextensions/taskpanes/2010/11" xmlns:w16cid="http://schemas.microsoft.com/office/word/2016/wordml/cid" xmlns:w16se="http://schemas.microsoft.com/office/word/2015/wordml/symex" xmlns:wps="http://schemas.microsoft.com/office/word/2010/wordprocessingShape" xmlns:b="http://schemas.openxmlformats.org/officeDocument/2006/bibliography" xmlns:odgm="http://opendope.org/SmartArt/DataHierarchy" xmlns:odi="http://opendope.org/components" xmlns:oda="http://opendope.org/answers" xmlns:odq="http://opendope.org/questions" xmlns:odc="http://opendope.org/conditions" xmlns:odx="http://opendope.org/xpaths" xmlns:cppr="http://schemas.microsoft.com/office/2006/coverPageProps" xmlns:pvml="urn:schemas-microsoft-com:office:powerpoint" xmlns:w10="urn:schemas-microsoft-com:office:word" xmlns:v="urn:schemas-microsoft-com:vml" xmlns:o="urn:schemas-microsoft-com:office:office" xmlns:xvml="urn:schemas-microsoft-com:office:excel" xmlns:dsp="http://schemas.microsoft.com/office/drawing/2008/diagram" xmlns:xdr="http://schemas.openxmlformats.org/drawingml/2006/spreadsheetDrawing" xmlns:pic="http://schemas.openxmlformats.org/drawingml/2006/picture" xmlns:dgm="http://schemas.openxmlformats.org/drawingml/2006/diagram" xmlns:c14="http://schemas.microsoft.com/office/drawing/2007/8/2/chart" xmlns:cdr="http://schemas.openxmlformats.org/drawingml/2006/chartDrawing" xmlns:wne="http://schemas.microsoft.com/office/word/2006/wordml" xmlns:sl="http://schemas.openxmlformats.org/schemaLibrary/2006/main" xmlns:mc="http://schemas.openxmlformats.org/markup-compatibility/2006" xmlns:wp14="http://schemas.microsoft.com/office/word/2010/wordprocessingDrawing" xmlns:wp="http://schemas.openxmlformats.org/drawingml/2006/wordprocessingDrawing" xmlns:m="http://schemas.openxmlformats.org/officeDocument/2006/math" xmlns:w14="http://schemas.microsoft.com/office/word/2010/wordml" xmlns:w15="http://schemas.microsoft.com/office/word/2012/wordml" xmlns:w="http://schemas.openxmlformats.org/wordprocessingml/2006/main">
       <c:ext xmlns:c16r3="http://schemas.microsoft.com/office/drawing/2017/03/chart" uri="{56B9EC1D-385E-4148-901F-78D8002777C0}">
         <c16r3:dataDisplayOptions16>
@@ -5308,7 +5310,6 @@
         </c16r3:dataDisplayOptions16>
       </c:ext>
     </c:extLst>
-    <c:showDLblsOverMax val="0"/>
   </c:chart>
   <c:spPr>
     <a:noFill/>
@@ -6109,6 +6110,7 @@
     </c:plotArea>
     <c:plotVisOnly val="1"/>
     <c:dispBlanksAs val="gap"/>
+    <c:showDLblsOverMax val="0"/>
     <c:extLst xmlns:lc="http://schemas.openxmlformats.org/drawingml/2006/lockedCanvas" xmlns:comp="http://schemas.openxmlformats.org/drawingml/2006/compatibility" xmlns:we="http://schemas.microsoft.com/office/webextensions/webextension/2010/11" xmlns:wetp="http://schemas.microsoft.com/office/webextensions/taskpanes/2010/11" xmlns:w16cid="http://schemas.microsoft.com/office/word/2016/wordml/cid" xmlns:w16se="http://schemas.microsoft.com/office/word/2015/wordml/symex" xmlns:wps="http://schemas.microsoft.com/office/word/2010/wordprocessingShape" xmlns:b="http://schemas.openxmlformats.org/officeDocument/2006/bibliography" xmlns:odgm="http://opendope.org/SmartArt/DataHierarchy" xmlns:odi="http://opendope.org/components" xmlns:oda="http://opendope.org/answers" xmlns:odq="http://opendope.org/questions" xmlns:odc="http://opendope.org/conditions" xmlns:odx="http://opendope.org/xpaths" xmlns:cppr="http://schemas.microsoft.com/office/2006/coverPageProps" xmlns:pvml="urn:schemas-microsoft-com:office:powerpoint" xmlns:w10="urn:schemas-microsoft-com:office:word" xmlns:v="urn:schemas-microsoft-com:vml" xmlns:o="urn:schemas-microsoft-com:office:office" xmlns:xvml="urn:schemas-microsoft-com:office:excel" xmlns:dsp="http://schemas.microsoft.com/office/drawing/2008/diagram" xmlns:xdr="http://schemas.openxmlformats.org/drawingml/2006/spreadsheetDrawing" xmlns:pic="http://schemas.openxmlformats.org/drawingml/2006/picture" xmlns:dgm="http://schemas.openxmlformats.org/drawingml/2006/diagram" xmlns:c14="http://schemas.microsoft.com/office/drawing/2007/8/2/chart" xmlns:cdr="http://schemas.openxmlformats.org/drawingml/2006/chartDrawing" xmlns:wne="http://schemas.microsoft.com/office/word/2006/wordml" xmlns:sl="http://schemas.openxmlformats.org/schemaLibrary/2006/main" xmlns:mc="http://schemas.openxmlformats.org/markup-compatibility/2006" xmlns:wp14="http://schemas.microsoft.com/office/word/2010/wordprocessingDrawing" xmlns:wp="http://schemas.openxmlformats.org/drawingml/2006/wordprocessingDrawing" xmlns:m="http://schemas.openxmlformats.org/officeDocument/2006/math" xmlns:w14="http://schemas.microsoft.com/office/word/2010/wordml" xmlns:w15="http://schemas.microsoft.com/office/word/2012/wordml" xmlns:w="http://schemas.openxmlformats.org/wordprocessingml/2006/main">
       <c:ext xmlns:c16r3="http://schemas.microsoft.com/office/drawing/2017/03/chart" uri="{56B9EC1D-385E-4148-901F-78D8002777C0}">
         <c16r3:dataDisplayOptions16>
@@ -6116,7 +6118,6 @@
         </c16r3:dataDisplayOptions16>
       </c:ext>
     </c:extLst>
-    <c:showDLblsOverMax val="0"/>
   </c:chart>
   <c:spPr>
     <a:noFill/>
@@ -10435,7 +10436,7 @@
           <a:p>
             <a:fld id="{C1255C68-584F-174D-BB81-51BF91708794}" type="datetimeFigureOut">
               <a:rPr lang="en-US" smtClean="0"/>
-              <a:t>8/9/25</a:t>
+              <a:t>8/22/25</a:t>
             </a:fld>
             <a:endParaRPr lang="en-US"/>
           </a:p>
@@ -10612,7 +10613,7 @@
           <a:p>
             <a:fld id="{A1EDAAC4-819D-C544-9EA1-C73624CFD70B}" type="datetimeFigureOut">
               <a:rPr lang="en-US" smtClean="0"/>
-              <a:t>8/9/25</a:t>
+              <a:t>8/22/25</a:t>
             </a:fld>
             <a:endParaRPr lang="en-US"/>
           </a:p>
@@ -37771,7 +37772,7 @@
         </p:nvSpPr>
         <p:spPr>
           <a:xfrm>
-            <a:off x="2643466" y="6054740"/>
+            <a:off x="1996335" y="6054740"/>
             <a:ext cx="1276460" cy="223844"/>
           </a:xfrm>
           <a:prstGeom prst="rect">
@@ -37809,621 +37810,6 @@
           </a:p>
         </p:txBody>
       </p:sp>
-      <p:grpSp>
-        <p:nvGrpSpPr>
-          <p:cNvPr id="32" name="Group 31">
-            <a:extLst>
-              <a:ext uri="{FF2B5EF4-FFF2-40B4-BE49-F238E27FC236}">
-                <a16:creationId xmlns:a16="http://schemas.microsoft.com/office/drawing/2014/main" id="{271E0BEF-A934-E57C-D6AA-D9A39E9BA2AC}"/>
-              </a:ext>
-            </a:extLst>
-          </p:cNvPr>
-          <p:cNvGrpSpPr/>
-          <p:nvPr/>
-        </p:nvGrpSpPr>
-        <p:grpSpPr>
-          <a:xfrm>
-            <a:off x="516802" y="6117354"/>
-            <a:ext cx="300732" cy="98617"/>
-            <a:chOff x="586253" y="6116391"/>
-            <a:chExt cx="300732" cy="98617"/>
-          </a:xfrm>
-        </p:grpSpPr>
-        <p:sp>
-          <p:nvSpPr>
-            <p:cNvPr id="34" name="TextBox 33">
-              <a:extLst>
-                <a:ext uri="{FF2B5EF4-FFF2-40B4-BE49-F238E27FC236}">
-                  <a16:creationId xmlns:a16="http://schemas.microsoft.com/office/drawing/2014/main" id="{1B4993B0-C574-1A0C-D2CC-601F9A816244}"/>
-                </a:ext>
-              </a:extLst>
-            </p:cNvPr>
-            <p:cNvSpPr txBox="1"/>
-            <p:nvPr/>
-          </p:nvSpPr>
-          <p:spPr>
-            <a:xfrm>
-              <a:off x="710655" y="6116391"/>
-              <a:ext cx="176330" cy="98617"/>
-            </a:xfrm>
-            <a:prstGeom prst="rect">
-              <a:avLst/>
-            </a:prstGeom>
-            <a:noFill/>
-          </p:spPr>
-          <p:txBody>
-            <a:bodyPr wrap="none" lIns="0" tIns="0" rIns="0" bIns="0" rtlCol="0" anchor="t">
-              <a:spAutoFit/>
-            </a:bodyPr>
-            <a:lstStyle/>
-            <a:p>
-              <a:pPr algn="l">
-                <a:lnSpc>
-                  <a:spcPct val="113000"/>
-                </a:lnSpc>
-              </a:pPr>
-              <a:r>
-                <a:rPr lang="en-US" sz="600" dirty="0">
-                  <a:solidFill>
-                    <a:schemeClr val="tx2"/>
-                  </a:solidFill>
-                </a:rPr>
-                <a:t>1 star</a:t>
-              </a:r>
-            </a:p>
-          </p:txBody>
-        </p:sp>
-        <p:sp>
-          <p:nvSpPr>
-            <p:cNvPr id="46" name="Rounded Rectangle 45">
-              <a:extLst>
-                <a:ext uri="{FF2B5EF4-FFF2-40B4-BE49-F238E27FC236}">
-                  <a16:creationId xmlns:a16="http://schemas.microsoft.com/office/drawing/2014/main" id="{2046A2AD-8B2F-9F91-38E9-693651680A21}"/>
-                </a:ext>
-              </a:extLst>
-            </p:cNvPr>
-            <p:cNvSpPr>
-              <a:spLocks noChangeAspect="1"/>
-            </p:cNvSpPr>
-            <p:nvPr/>
-          </p:nvSpPr>
-          <p:spPr>
-            <a:xfrm>
-              <a:off x="586253" y="6119980"/>
-              <a:ext cx="89812" cy="91440"/>
-            </a:xfrm>
-            <a:prstGeom prst="roundRect">
-              <a:avLst/>
-            </a:prstGeom>
-            <a:solidFill>
-              <a:srgbClr val="C04035"/>
-            </a:solidFill>
-            <a:ln>
-              <a:noFill/>
-            </a:ln>
-          </p:spPr>
-          <p:style>
-            <a:lnRef idx="2">
-              <a:schemeClr val="accent1">
-                <a:shade val="50000"/>
-              </a:schemeClr>
-            </a:lnRef>
-            <a:fillRef idx="1">
-              <a:schemeClr val="accent1"/>
-            </a:fillRef>
-            <a:effectRef idx="0">
-              <a:schemeClr val="accent1"/>
-            </a:effectRef>
-            <a:fontRef idx="minor">
-              <a:schemeClr val="lt1"/>
-            </a:fontRef>
-          </p:style>
-          <p:txBody>
-            <a:bodyPr lIns="108000" tIns="72000" rIns="108000" bIns="72000" rtlCol="0" anchor="ctr"/>
-            <a:lstStyle/>
-            <a:p>
-              <a:pPr algn="ctr"/>
-              <a:endParaRPr lang="en-US" sz="1600" dirty="0" err="1">
-                <a:solidFill>
-                  <a:schemeClr val="bg1"/>
-                </a:solidFill>
-              </a:endParaRPr>
-            </a:p>
-          </p:txBody>
-        </p:sp>
-      </p:grpSp>
-      <p:grpSp>
-        <p:nvGrpSpPr>
-          <p:cNvPr id="47" name="Group 46">
-            <a:extLst>
-              <a:ext uri="{FF2B5EF4-FFF2-40B4-BE49-F238E27FC236}">
-                <a16:creationId xmlns:a16="http://schemas.microsoft.com/office/drawing/2014/main" id="{F9B65C6B-8B79-6E62-4E92-AAA9B9C460B0}"/>
-              </a:ext>
-            </a:extLst>
-          </p:cNvPr>
-          <p:cNvGrpSpPr/>
-          <p:nvPr/>
-        </p:nvGrpSpPr>
-        <p:grpSpPr>
-          <a:xfrm>
-            <a:off x="934179" y="6117354"/>
-            <a:ext cx="331190" cy="98617"/>
-            <a:chOff x="961765" y="6117353"/>
-            <a:chExt cx="331190" cy="98617"/>
-          </a:xfrm>
-        </p:grpSpPr>
-        <p:sp>
-          <p:nvSpPr>
-            <p:cNvPr id="48" name="TextBox 47">
-              <a:extLst>
-                <a:ext uri="{FF2B5EF4-FFF2-40B4-BE49-F238E27FC236}">
-                  <a16:creationId xmlns:a16="http://schemas.microsoft.com/office/drawing/2014/main" id="{9484B3FD-FF0C-A3DF-1F66-2F211858D6AE}"/>
-                </a:ext>
-              </a:extLst>
-            </p:cNvPr>
-            <p:cNvSpPr txBox="1"/>
-            <p:nvPr/>
-          </p:nvSpPr>
-          <p:spPr>
-            <a:xfrm>
-              <a:off x="1086167" y="6117353"/>
-              <a:ext cx="206788" cy="98617"/>
-            </a:xfrm>
-            <a:prstGeom prst="rect">
-              <a:avLst/>
-            </a:prstGeom>
-            <a:noFill/>
-          </p:spPr>
-          <p:txBody>
-            <a:bodyPr wrap="none" lIns="0" tIns="0" rIns="0" bIns="0" rtlCol="0" anchor="t">
-              <a:spAutoFit/>
-            </a:bodyPr>
-            <a:lstStyle/>
-            <a:p>
-              <a:pPr algn="l">
-                <a:lnSpc>
-                  <a:spcPct val="113000"/>
-                </a:lnSpc>
-              </a:pPr>
-              <a:r>
-                <a:rPr lang="en-US" sz="600" dirty="0">
-                  <a:solidFill>
-                    <a:schemeClr val="tx2"/>
-                  </a:solidFill>
-                </a:rPr>
-                <a:t>2 stars</a:t>
-              </a:r>
-            </a:p>
-          </p:txBody>
-        </p:sp>
-        <p:sp>
-          <p:nvSpPr>
-            <p:cNvPr id="49" name="Rounded Rectangle 48">
-              <a:extLst>
-                <a:ext uri="{FF2B5EF4-FFF2-40B4-BE49-F238E27FC236}">
-                  <a16:creationId xmlns:a16="http://schemas.microsoft.com/office/drawing/2014/main" id="{EB27BC39-4A7E-FD5B-9709-BE7E9679DD1A}"/>
-                </a:ext>
-              </a:extLst>
-            </p:cNvPr>
-            <p:cNvSpPr>
-              <a:spLocks noChangeAspect="1"/>
-            </p:cNvSpPr>
-            <p:nvPr/>
-          </p:nvSpPr>
-          <p:spPr>
-            <a:xfrm>
-              <a:off x="961765" y="6120942"/>
-              <a:ext cx="89812" cy="91440"/>
-            </a:xfrm>
-            <a:prstGeom prst="roundRect">
-              <a:avLst/>
-            </a:prstGeom>
-            <a:solidFill>
-              <a:srgbClr val="EF9819"/>
-            </a:solidFill>
-            <a:ln>
-              <a:noFill/>
-            </a:ln>
-          </p:spPr>
-          <p:style>
-            <a:lnRef idx="2">
-              <a:schemeClr val="accent1">
-                <a:shade val="50000"/>
-              </a:schemeClr>
-            </a:lnRef>
-            <a:fillRef idx="1">
-              <a:schemeClr val="accent1"/>
-            </a:fillRef>
-            <a:effectRef idx="0">
-              <a:schemeClr val="accent1"/>
-            </a:effectRef>
-            <a:fontRef idx="minor">
-              <a:schemeClr val="lt1"/>
-            </a:fontRef>
-          </p:style>
-          <p:txBody>
-            <a:bodyPr lIns="108000" tIns="72000" rIns="108000" bIns="72000" rtlCol="0" anchor="ctr"/>
-            <a:lstStyle/>
-            <a:p>
-              <a:pPr algn="ctr"/>
-              <a:endParaRPr lang="en-US" sz="1600" dirty="0" err="1">
-                <a:solidFill>
-                  <a:schemeClr val="bg1"/>
-                </a:solidFill>
-              </a:endParaRPr>
-            </a:p>
-          </p:txBody>
-        </p:sp>
-      </p:grpSp>
-      <p:grpSp>
-        <p:nvGrpSpPr>
-          <p:cNvPr id="50" name="Group 49">
-            <a:extLst>
-              <a:ext uri="{FF2B5EF4-FFF2-40B4-BE49-F238E27FC236}">
-                <a16:creationId xmlns:a16="http://schemas.microsoft.com/office/drawing/2014/main" id="{B897F31D-CA5A-7192-8289-A08702399B1B}"/>
-              </a:ext>
-            </a:extLst>
-          </p:cNvPr>
-          <p:cNvGrpSpPr/>
-          <p:nvPr/>
-        </p:nvGrpSpPr>
-        <p:grpSpPr>
-          <a:xfrm>
-            <a:off x="1382015" y="6117354"/>
-            <a:ext cx="331190" cy="98617"/>
-            <a:chOff x="1114165" y="6269753"/>
-            <a:chExt cx="331190" cy="98617"/>
-          </a:xfrm>
-        </p:grpSpPr>
-        <p:sp>
-          <p:nvSpPr>
-            <p:cNvPr id="51" name="TextBox 50">
-              <a:extLst>
-                <a:ext uri="{FF2B5EF4-FFF2-40B4-BE49-F238E27FC236}">
-                  <a16:creationId xmlns:a16="http://schemas.microsoft.com/office/drawing/2014/main" id="{827BB7F0-3643-9FFC-0DC9-10F85BE4FE62}"/>
-                </a:ext>
-              </a:extLst>
-            </p:cNvPr>
-            <p:cNvSpPr txBox="1"/>
-            <p:nvPr/>
-          </p:nvSpPr>
-          <p:spPr>
-            <a:xfrm>
-              <a:off x="1238567" y="6269753"/>
-              <a:ext cx="206788" cy="98617"/>
-            </a:xfrm>
-            <a:prstGeom prst="rect">
-              <a:avLst/>
-            </a:prstGeom>
-            <a:noFill/>
-          </p:spPr>
-          <p:txBody>
-            <a:bodyPr wrap="none" lIns="0" tIns="0" rIns="0" bIns="0" rtlCol="0" anchor="t">
-              <a:spAutoFit/>
-            </a:bodyPr>
-            <a:lstStyle/>
-            <a:p>
-              <a:pPr algn="l">
-                <a:lnSpc>
-                  <a:spcPct val="113000"/>
-                </a:lnSpc>
-              </a:pPr>
-              <a:r>
-                <a:rPr lang="en-US" sz="600" dirty="0">
-                  <a:solidFill>
-                    <a:schemeClr val="tx2"/>
-                  </a:solidFill>
-                </a:rPr>
-                <a:t>3 stars</a:t>
-              </a:r>
-            </a:p>
-          </p:txBody>
-        </p:sp>
-        <p:sp>
-          <p:nvSpPr>
-            <p:cNvPr id="52" name="Rounded Rectangle 51">
-              <a:extLst>
-                <a:ext uri="{FF2B5EF4-FFF2-40B4-BE49-F238E27FC236}">
-                  <a16:creationId xmlns:a16="http://schemas.microsoft.com/office/drawing/2014/main" id="{AAE21101-175A-55DC-43FB-66EB38068ECD}"/>
-                </a:ext>
-              </a:extLst>
-            </p:cNvPr>
-            <p:cNvSpPr>
-              <a:spLocks noChangeAspect="1"/>
-            </p:cNvSpPr>
-            <p:nvPr/>
-          </p:nvSpPr>
-          <p:spPr>
-            <a:xfrm>
-              <a:off x="1114165" y="6273342"/>
-              <a:ext cx="89812" cy="91440"/>
-            </a:xfrm>
-            <a:prstGeom prst="roundRect">
-              <a:avLst/>
-            </a:prstGeom>
-            <a:solidFill>
-              <a:srgbClr val="F9C640"/>
-            </a:solidFill>
-            <a:ln>
-              <a:noFill/>
-            </a:ln>
-          </p:spPr>
-          <p:style>
-            <a:lnRef idx="2">
-              <a:schemeClr val="accent1">
-                <a:shade val="50000"/>
-              </a:schemeClr>
-            </a:lnRef>
-            <a:fillRef idx="1">
-              <a:schemeClr val="accent1"/>
-            </a:fillRef>
-            <a:effectRef idx="0">
-              <a:schemeClr val="accent1"/>
-            </a:effectRef>
-            <a:fontRef idx="minor">
-              <a:schemeClr val="lt1"/>
-            </a:fontRef>
-          </p:style>
-          <p:txBody>
-            <a:bodyPr lIns="108000" tIns="72000" rIns="108000" bIns="72000" rtlCol="0" anchor="ctr"/>
-            <a:lstStyle/>
-            <a:p>
-              <a:pPr algn="ctr"/>
-              <a:endParaRPr lang="en-US" sz="1600" dirty="0" err="1">
-                <a:solidFill>
-                  <a:schemeClr val="bg1"/>
-                </a:solidFill>
-              </a:endParaRPr>
-            </a:p>
-          </p:txBody>
-        </p:sp>
-      </p:grpSp>
-      <p:grpSp>
-        <p:nvGrpSpPr>
-          <p:cNvPr id="53" name="Group 52">
-            <a:extLst>
-              <a:ext uri="{FF2B5EF4-FFF2-40B4-BE49-F238E27FC236}">
-                <a16:creationId xmlns:a16="http://schemas.microsoft.com/office/drawing/2014/main" id="{B08ED80E-3C0A-1305-A82E-5A6A5F21483D}"/>
-              </a:ext>
-            </a:extLst>
-          </p:cNvPr>
-          <p:cNvGrpSpPr/>
-          <p:nvPr/>
-        </p:nvGrpSpPr>
-        <p:grpSpPr>
-          <a:xfrm>
-            <a:off x="1829851" y="6117354"/>
-            <a:ext cx="331190" cy="98617"/>
-            <a:chOff x="1114165" y="6269753"/>
-            <a:chExt cx="331190" cy="98617"/>
-          </a:xfrm>
-        </p:grpSpPr>
-        <p:sp>
-          <p:nvSpPr>
-            <p:cNvPr id="54" name="TextBox 53">
-              <a:extLst>
-                <a:ext uri="{FF2B5EF4-FFF2-40B4-BE49-F238E27FC236}">
-                  <a16:creationId xmlns:a16="http://schemas.microsoft.com/office/drawing/2014/main" id="{C724DD9C-4498-BDBF-D550-CD5BFAFB9441}"/>
-                </a:ext>
-              </a:extLst>
-            </p:cNvPr>
-            <p:cNvSpPr txBox="1"/>
-            <p:nvPr/>
-          </p:nvSpPr>
-          <p:spPr>
-            <a:xfrm>
-              <a:off x="1238567" y="6269753"/>
-              <a:ext cx="206788" cy="98617"/>
-            </a:xfrm>
-            <a:prstGeom prst="rect">
-              <a:avLst/>
-            </a:prstGeom>
-            <a:noFill/>
-          </p:spPr>
-          <p:txBody>
-            <a:bodyPr wrap="none" lIns="0" tIns="0" rIns="0" bIns="0" rtlCol="0" anchor="t">
-              <a:spAutoFit/>
-            </a:bodyPr>
-            <a:lstStyle/>
-            <a:p>
-              <a:pPr algn="l">
-                <a:lnSpc>
-                  <a:spcPct val="113000"/>
-                </a:lnSpc>
-              </a:pPr>
-              <a:r>
-                <a:rPr lang="en-US" sz="600" dirty="0">
-                  <a:solidFill>
-                    <a:schemeClr val="tx2"/>
-                  </a:solidFill>
-                </a:rPr>
-                <a:t>4 stars</a:t>
-              </a:r>
-            </a:p>
-          </p:txBody>
-        </p:sp>
-        <p:sp>
-          <p:nvSpPr>
-            <p:cNvPr id="55" name="Rounded Rectangle 54">
-              <a:extLst>
-                <a:ext uri="{FF2B5EF4-FFF2-40B4-BE49-F238E27FC236}">
-                  <a16:creationId xmlns:a16="http://schemas.microsoft.com/office/drawing/2014/main" id="{0C61241F-CCB1-DA71-4D2B-5453293279F6}"/>
-                </a:ext>
-              </a:extLst>
-            </p:cNvPr>
-            <p:cNvSpPr>
-              <a:spLocks noChangeAspect="1"/>
-            </p:cNvSpPr>
-            <p:nvPr/>
-          </p:nvSpPr>
-          <p:spPr>
-            <a:xfrm>
-              <a:off x="1114165" y="6273342"/>
-              <a:ext cx="89812" cy="91440"/>
-            </a:xfrm>
-            <a:prstGeom prst="roundRect">
-              <a:avLst/>
-            </a:prstGeom>
-            <a:solidFill>
-              <a:srgbClr val="57C968"/>
-            </a:solidFill>
-            <a:ln>
-              <a:noFill/>
-            </a:ln>
-          </p:spPr>
-          <p:style>
-            <a:lnRef idx="2">
-              <a:schemeClr val="accent1">
-                <a:shade val="50000"/>
-              </a:schemeClr>
-            </a:lnRef>
-            <a:fillRef idx="1">
-              <a:schemeClr val="accent1"/>
-            </a:fillRef>
-            <a:effectRef idx="0">
-              <a:schemeClr val="accent1"/>
-            </a:effectRef>
-            <a:fontRef idx="minor">
-              <a:schemeClr val="lt1"/>
-            </a:fontRef>
-          </p:style>
-          <p:txBody>
-            <a:bodyPr lIns="108000" tIns="72000" rIns="108000" bIns="72000" rtlCol="0" anchor="ctr"/>
-            <a:lstStyle/>
-            <a:p>
-              <a:pPr algn="ctr"/>
-              <a:endParaRPr lang="en-US" sz="1600" dirty="0" err="1">
-                <a:solidFill>
-                  <a:schemeClr val="bg1"/>
-                </a:solidFill>
-              </a:endParaRPr>
-            </a:p>
-          </p:txBody>
-        </p:sp>
-      </p:grpSp>
-      <p:grpSp>
-        <p:nvGrpSpPr>
-          <p:cNvPr id="56" name="Group 55">
-            <a:extLst>
-              <a:ext uri="{FF2B5EF4-FFF2-40B4-BE49-F238E27FC236}">
-                <a16:creationId xmlns:a16="http://schemas.microsoft.com/office/drawing/2014/main" id="{1E546F09-32A9-F3EC-B92C-062BC866C320}"/>
-              </a:ext>
-            </a:extLst>
-          </p:cNvPr>
-          <p:cNvGrpSpPr/>
-          <p:nvPr/>
-        </p:nvGrpSpPr>
-        <p:grpSpPr>
-          <a:xfrm>
-            <a:off x="2277686" y="6117354"/>
-            <a:ext cx="331190" cy="98617"/>
-            <a:chOff x="1114165" y="6269753"/>
-            <a:chExt cx="331190" cy="98617"/>
-          </a:xfrm>
-        </p:grpSpPr>
-        <p:sp>
-          <p:nvSpPr>
-            <p:cNvPr id="57" name="TextBox 56">
-              <a:extLst>
-                <a:ext uri="{FF2B5EF4-FFF2-40B4-BE49-F238E27FC236}">
-                  <a16:creationId xmlns:a16="http://schemas.microsoft.com/office/drawing/2014/main" id="{382ACFC0-E430-DE80-02D2-87BE9F92063B}"/>
-                </a:ext>
-              </a:extLst>
-            </p:cNvPr>
-            <p:cNvSpPr txBox="1"/>
-            <p:nvPr/>
-          </p:nvSpPr>
-          <p:spPr>
-            <a:xfrm>
-              <a:off x="1238567" y="6269753"/>
-              <a:ext cx="206788" cy="98617"/>
-            </a:xfrm>
-            <a:prstGeom prst="rect">
-              <a:avLst/>
-            </a:prstGeom>
-            <a:noFill/>
-          </p:spPr>
-          <p:txBody>
-            <a:bodyPr wrap="none" lIns="0" tIns="0" rIns="0" bIns="0" rtlCol="0" anchor="t">
-              <a:spAutoFit/>
-            </a:bodyPr>
-            <a:lstStyle/>
-            <a:p>
-              <a:pPr algn="l">
-                <a:lnSpc>
-                  <a:spcPct val="113000"/>
-                </a:lnSpc>
-              </a:pPr>
-              <a:r>
-                <a:rPr lang="en-US" sz="600" dirty="0">
-                  <a:solidFill>
-                    <a:schemeClr val="tx2"/>
-                  </a:solidFill>
-                </a:rPr>
-                <a:t>5 stars</a:t>
-              </a:r>
-            </a:p>
-          </p:txBody>
-        </p:sp>
-        <p:sp>
-          <p:nvSpPr>
-            <p:cNvPr id="58" name="Rounded Rectangle 57">
-              <a:extLst>
-                <a:ext uri="{FF2B5EF4-FFF2-40B4-BE49-F238E27FC236}">
-                  <a16:creationId xmlns:a16="http://schemas.microsoft.com/office/drawing/2014/main" id="{B04AB406-F121-B87F-E22D-C5E38B6AB539}"/>
-                </a:ext>
-              </a:extLst>
-            </p:cNvPr>
-            <p:cNvSpPr>
-              <a:spLocks noChangeAspect="1"/>
-            </p:cNvSpPr>
-            <p:nvPr/>
-          </p:nvSpPr>
-          <p:spPr>
-            <a:xfrm>
-              <a:off x="1114165" y="6273342"/>
-              <a:ext cx="89812" cy="91440"/>
-            </a:xfrm>
-            <a:prstGeom prst="roundRect">
-              <a:avLst/>
-            </a:prstGeom>
-            <a:solidFill>
-              <a:srgbClr val="2C963F"/>
-            </a:solidFill>
-            <a:ln>
-              <a:noFill/>
-            </a:ln>
-          </p:spPr>
-          <p:style>
-            <a:lnRef idx="2">
-              <a:schemeClr val="accent1">
-                <a:shade val="50000"/>
-              </a:schemeClr>
-            </a:lnRef>
-            <a:fillRef idx="1">
-              <a:schemeClr val="accent1"/>
-            </a:fillRef>
-            <a:effectRef idx="0">
-              <a:schemeClr val="accent1"/>
-            </a:effectRef>
-            <a:fontRef idx="minor">
-              <a:schemeClr val="lt1"/>
-            </a:fontRef>
-          </p:style>
-          <p:txBody>
-            <a:bodyPr lIns="108000" tIns="72000" rIns="108000" bIns="72000" rtlCol="0" anchor="ctr"/>
-            <a:lstStyle/>
-            <a:p>
-              <a:pPr algn="ctr"/>
-              <a:endParaRPr lang="en-US" sz="1600" dirty="0" err="1">
-                <a:solidFill>
-                  <a:schemeClr val="bg1"/>
-                </a:solidFill>
-              </a:endParaRPr>
-            </a:p>
-          </p:txBody>
-        </p:sp>
-      </p:grpSp>
       <p:sp>
         <p:nvSpPr>
           <p:cNvPr id="2" name="Rectangle 1">
@@ -39580,6 +38966,402 @@
           </a:p>
         </p:txBody>
       </p:sp>
+      <p:sp>
+        <p:nvSpPr>
+          <p:cNvPr id="73" name="Rounded Rectangle 72">
+            <a:extLst>
+              <a:ext uri="{FF2B5EF4-FFF2-40B4-BE49-F238E27FC236}">
+                <a16:creationId xmlns:a16="http://schemas.microsoft.com/office/drawing/2014/main" id="{C66490FF-9283-17EE-60CD-B822CD68EF25}"/>
+              </a:ext>
+            </a:extLst>
+          </p:cNvPr>
+          <p:cNvSpPr>
+            <a:spLocks noChangeAspect="1"/>
+          </p:cNvSpPr>
+          <p:nvPr/>
+        </p:nvSpPr>
+        <p:spPr>
+          <a:xfrm>
+            <a:off x="879122" y="6118505"/>
+            <a:ext cx="91440" cy="91440"/>
+          </a:xfrm>
+          <a:prstGeom prst="roundRect">
+            <a:avLst/>
+          </a:prstGeom>
+          <a:solidFill>
+            <a:srgbClr val="DC4A3D"/>
+          </a:solidFill>
+          <a:ln>
+            <a:noFill/>
+          </a:ln>
+        </p:spPr>
+        <p:style>
+          <a:lnRef idx="2">
+            <a:schemeClr val="accent1">
+              <a:shade val="50000"/>
+            </a:schemeClr>
+          </a:lnRef>
+          <a:fillRef idx="1">
+            <a:schemeClr val="accent1"/>
+          </a:fillRef>
+          <a:effectRef idx="0">
+            <a:schemeClr val="accent1"/>
+          </a:effectRef>
+          <a:fontRef idx="minor">
+            <a:schemeClr val="lt1"/>
+          </a:fontRef>
+        </p:style>
+        <p:txBody>
+          <a:bodyPr lIns="108000" tIns="72000" rIns="108000" bIns="72000" rtlCol="0" anchor="ctr"/>
+          <a:lstStyle/>
+          <a:p>
+            <a:pPr algn="ctr"/>
+            <a:endParaRPr lang="en-US" sz="1600" dirty="0" err="1">
+              <a:solidFill>
+                <a:schemeClr val="bg1"/>
+              </a:solidFill>
+            </a:endParaRPr>
+          </a:p>
+        </p:txBody>
+      </p:sp>
+      <p:sp>
+        <p:nvSpPr>
+          <p:cNvPr id="75" name="Rounded Rectangle 74">
+            <a:extLst>
+              <a:ext uri="{FF2B5EF4-FFF2-40B4-BE49-F238E27FC236}">
+                <a16:creationId xmlns:a16="http://schemas.microsoft.com/office/drawing/2014/main" id="{2ED98E80-10A2-5364-4091-6705DB3C9F96}"/>
+              </a:ext>
+            </a:extLst>
+          </p:cNvPr>
+          <p:cNvSpPr>
+            <a:spLocks noChangeAspect="1"/>
+          </p:cNvSpPr>
+          <p:nvPr/>
+        </p:nvSpPr>
+        <p:spPr>
+          <a:xfrm>
+            <a:off x="1038992" y="6118505"/>
+            <a:ext cx="91440" cy="91440"/>
+          </a:xfrm>
+          <a:prstGeom prst="roundRect">
+            <a:avLst/>
+          </a:prstGeom>
+          <a:solidFill>
+            <a:srgbClr val="F8DCD6"/>
+          </a:solidFill>
+          <a:ln>
+            <a:noFill/>
+          </a:ln>
+        </p:spPr>
+        <p:style>
+          <a:lnRef idx="2">
+            <a:schemeClr val="accent1">
+              <a:shade val="50000"/>
+            </a:schemeClr>
+          </a:lnRef>
+          <a:fillRef idx="1">
+            <a:schemeClr val="accent1"/>
+          </a:fillRef>
+          <a:effectRef idx="0">
+            <a:schemeClr val="accent1"/>
+          </a:effectRef>
+          <a:fontRef idx="minor">
+            <a:schemeClr val="lt1"/>
+          </a:fontRef>
+        </p:style>
+        <p:txBody>
+          <a:bodyPr lIns="108000" tIns="72000" rIns="108000" bIns="72000" rtlCol="0" anchor="ctr"/>
+          <a:lstStyle/>
+          <a:p>
+            <a:pPr algn="ctr"/>
+            <a:endParaRPr lang="en-US" sz="1600" dirty="0" err="1">
+              <a:solidFill>
+                <a:schemeClr val="bg1"/>
+              </a:solidFill>
+            </a:endParaRPr>
+          </a:p>
+        </p:txBody>
+      </p:sp>
+      <p:sp>
+        <p:nvSpPr>
+          <p:cNvPr id="76" name="Rounded Rectangle 75">
+            <a:extLst>
+              <a:ext uri="{FF2B5EF4-FFF2-40B4-BE49-F238E27FC236}">
+                <a16:creationId xmlns:a16="http://schemas.microsoft.com/office/drawing/2014/main" id="{CA16043E-840A-BD02-94E8-539D0B0A6B66}"/>
+              </a:ext>
+            </a:extLst>
+          </p:cNvPr>
+          <p:cNvSpPr>
+            <a:spLocks noChangeAspect="1"/>
+          </p:cNvSpPr>
+          <p:nvPr/>
+        </p:nvSpPr>
+        <p:spPr>
+          <a:xfrm>
+            <a:off x="1198862" y="6118505"/>
+            <a:ext cx="91440" cy="91440"/>
+          </a:xfrm>
+          <a:prstGeom prst="roundRect">
+            <a:avLst/>
+          </a:prstGeom>
+          <a:solidFill>
+            <a:srgbClr val="F7F9F8"/>
+          </a:solidFill>
+          <a:ln>
+            <a:noFill/>
+          </a:ln>
+        </p:spPr>
+        <p:style>
+          <a:lnRef idx="2">
+            <a:schemeClr val="accent1">
+              <a:shade val="50000"/>
+            </a:schemeClr>
+          </a:lnRef>
+          <a:fillRef idx="1">
+            <a:schemeClr val="accent1"/>
+          </a:fillRef>
+          <a:effectRef idx="0">
+            <a:schemeClr val="accent1"/>
+          </a:effectRef>
+          <a:fontRef idx="minor">
+            <a:schemeClr val="lt1"/>
+          </a:fontRef>
+        </p:style>
+        <p:txBody>
+          <a:bodyPr lIns="108000" tIns="72000" rIns="108000" bIns="72000" rtlCol="0" anchor="ctr"/>
+          <a:lstStyle/>
+          <a:p>
+            <a:pPr algn="ctr"/>
+            <a:endParaRPr lang="en-US" sz="1600" dirty="0" err="1">
+              <a:solidFill>
+                <a:schemeClr val="bg1"/>
+              </a:solidFill>
+            </a:endParaRPr>
+          </a:p>
+        </p:txBody>
+      </p:sp>
+      <p:sp>
+        <p:nvSpPr>
+          <p:cNvPr id="77" name="Rounded Rectangle 76">
+            <a:extLst>
+              <a:ext uri="{FF2B5EF4-FFF2-40B4-BE49-F238E27FC236}">
+                <a16:creationId xmlns:a16="http://schemas.microsoft.com/office/drawing/2014/main" id="{86149571-E7A7-CDC6-69D9-F2740A1FA902}"/>
+              </a:ext>
+            </a:extLst>
+          </p:cNvPr>
+          <p:cNvSpPr>
+            <a:spLocks noChangeAspect="1"/>
+          </p:cNvSpPr>
+          <p:nvPr/>
+        </p:nvSpPr>
+        <p:spPr>
+          <a:xfrm>
+            <a:off x="1358732" y="6118505"/>
+            <a:ext cx="91440" cy="91440"/>
+          </a:xfrm>
+          <a:prstGeom prst="roundRect">
+            <a:avLst/>
+          </a:prstGeom>
+          <a:solidFill>
+            <a:srgbClr val="D4EFDC"/>
+          </a:solidFill>
+          <a:ln>
+            <a:noFill/>
+          </a:ln>
+        </p:spPr>
+        <p:style>
+          <a:lnRef idx="2">
+            <a:schemeClr val="accent1">
+              <a:shade val="50000"/>
+            </a:schemeClr>
+          </a:lnRef>
+          <a:fillRef idx="1">
+            <a:schemeClr val="accent1"/>
+          </a:fillRef>
+          <a:effectRef idx="0">
+            <a:schemeClr val="accent1"/>
+          </a:effectRef>
+          <a:fontRef idx="minor">
+            <a:schemeClr val="lt1"/>
+          </a:fontRef>
+        </p:style>
+        <p:txBody>
+          <a:bodyPr lIns="108000" tIns="72000" rIns="108000" bIns="72000" rtlCol="0" anchor="ctr"/>
+          <a:lstStyle/>
+          <a:p>
+            <a:pPr algn="ctr"/>
+            <a:endParaRPr lang="en-US" sz="1600" dirty="0" err="1">
+              <a:solidFill>
+                <a:schemeClr val="bg1"/>
+              </a:solidFill>
+            </a:endParaRPr>
+          </a:p>
+        </p:txBody>
+      </p:sp>
+      <p:sp>
+        <p:nvSpPr>
+          <p:cNvPr id="78" name="Rounded Rectangle 77">
+            <a:extLst>
+              <a:ext uri="{FF2B5EF4-FFF2-40B4-BE49-F238E27FC236}">
+                <a16:creationId xmlns:a16="http://schemas.microsoft.com/office/drawing/2014/main" id="{4C82B2C7-705C-E893-F5EF-72FB1B097820}"/>
+              </a:ext>
+            </a:extLst>
+          </p:cNvPr>
+          <p:cNvSpPr>
+            <a:spLocks noChangeAspect="1"/>
+          </p:cNvSpPr>
+          <p:nvPr/>
+        </p:nvSpPr>
+        <p:spPr>
+          <a:xfrm>
+            <a:off x="1518602" y="6118505"/>
+            <a:ext cx="91440" cy="91440"/>
+          </a:xfrm>
+          <a:prstGeom prst="roundRect">
+            <a:avLst/>
+          </a:prstGeom>
+          <a:solidFill>
+            <a:srgbClr val="57C969"/>
+          </a:solidFill>
+          <a:ln>
+            <a:noFill/>
+          </a:ln>
+        </p:spPr>
+        <p:style>
+          <a:lnRef idx="2">
+            <a:schemeClr val="accent1">
+              <a:shade val="50000"/>
+            </a:schemeClr>
+          </a:lnRef>
+          <a:fillRef idx="1">
+            <a:schemeClr val="accent1"/>
+          </a:fillRef>
+          <a:effectRef idx="0">
+            <a:schemeClr val="accent1"/>
+          </a:effectRef>
+          <a:fontRef idx="minor">
+            <a:schemeClr val="lt1"/>
+          </a:fontRef>
+        </p:style>
+        <p:txBody>
+          <a:bodyPr lIns="108000" tIns="72000" rIns="108000" bIns="72000" rtlCol="0" anchor="ctr"/>
+          <a:lstStyle/>
+          <a:p>
+            <a:pPr algn="ctr"/>
+            <a:endParaRPr lang="en-US" sz="1600" dirty="0" err="1">
+              <a:solidFill>
+                <a:schemeClr val="bg1"/>
+              </a:solidFill>
+            </a:endParaRPr>
+          </a:p>
+        </p:txBody>
+      </p:sp>
+      <p:sp>
+        <p:nvSpPr>
+          <p:cNvPr id="80" name="TextBox 79">
+            <a:extLst>
+              <a:ext uri="{FF2B5EF4-FFF2-40B4-BE49-F238E27FC236}">
+                <a16:creationId xmlns:a16="http://schemas.microsoft.com/office/drawing/2014/main" id="{43A108D7-3656-C512-F32E-C7EC45AE7A92}"/>
+              </a:ext>
+            </a:extLst>
+          </p:cNvPr>
+          <p:cNvSpPr txBox="1"/>
+          <p:nvPr/>
+        </p:nvSpPr>
+        <p:spPr>
+          <a:xfrm>
+            <a:off x="1678471" y="6054740"/>
+            <a:ext cx="317864" cy="218971"/>
+          </a:xfrm>
+          <a:prstGeom prst="rect">
+            <a:avLst/>
+          </a:prstGeom>
+          <a:noFill/>
+        </p:spPr>
+        <p:txBody>
+          <a:bodyPr wrap="none" lIns="90000" rtlCol="0" anchor="t">
+            <a:spAutoFit/>
+          </a:bodyPr>
+          <a:lstStyle/>
+          <a:p>
+            <a:pPr algn="l">
+              <a:lnSpc>
+                <a:spcPct val="113000"/>
+              </a:lnSpc>
+            </a:pPr>
+            <a:r>
+              <a:rPr lang="en-US" sz="800" b="1" dirty="0">
+                <a:solidFill>
+                  <a:schemeClr val="tx2"/>
+                </a:solidFill>
+              </a:rPr>
+              <a:t>+</a:t>
+            </a:r>
+            <a:r>
+              <a:rPr lang="en-US" sz="800" b="1" dirty="0">
+                <a:solidFill>
+                  <a:schemeClr val="tx2"/>
+                </a:solidFill>
+                <a:latin typeface="Sigsterren" pitchFamily="2" charset="0"/>
+              </a:rPr>
+              <a:t>H</a:t>
+            </a:r>
+          </a:p>
+        </p:txBody>
+      </p:sp>
+      <p:sp>
+        <p:nvSpPr>
+          <p:cNvPr id="81" name="TextBox 80">
+            <a:extLst>
+              <a:ext uri="{FF2B5EF4-FFF2-40B4-BE49-F238E27FC236}">
+                <a16:creationId xmlns:a16="http://schemas.microsoft.com/office/drawing/2014/main" id="{12A9E222-BFFE-1E4D-AA0F-AED7EC6E745C}"/>
+              </a:ext>
+            </a:extLst>
+          </p:cNvPr>
+          <p:cNvSpPr txBox="1"/>
+          <p:nvPr/>
+        </p:nvSpPr>
+        <p:spPr>
+          <a:xfrm>
+            <a:off x="512064" y="6054740"/>
+            <a:ext cx="298628" cy="218971"/>
+          </a:xfrm>
+          <a:prstGeom prst="rect">
+            <a:avLst/>
+          </a:prstGeom>
+          <a:noFill/>
+        </p:spPr>
+        <p:txBody>
+          <a:bodyPr wrap="none" lIns="90000" rtlCol="0" anchor="t">
+            <a:spAutoFit/>
+          </a:bodyPr>
+          <a:lstStyle/>
+          <a:p>
+            <a:pPr algn="l">
+              <a:lnSpc>
+                <a:spcPct val="113000"/>
+              </a:lnSpc>
+            </a:pPr>
+            <a:r>
+              <a:rPr lang="en-US" sz="800" b="1" dirty="0">
+                <a:solidFill>
+                  <a:schemeClr val="tx2"/>
+                </a:solidFill>
+              </a:rPr>
+              <a:t>-</a:t>
+            </a:r>
+            <a:r>
+              <a:rPr lang="en-US" sz="800" b="1" dirty="0">
+                <a:solidFill>
+                  <a:schemeClr val="tx2"/>
+                </a:solidFill>
+                <a:latin typeface="Sigsterren" pitchFamily="2" charset="0"/>
+              </a:rPr>
+              <a:t>H</a:t>
+            </a:r>
+          </a:p>
+        </p:txBody>
+      </p:sp>
     </p:spTree>
     <p:extLst>
       <p:ext uri="{BB962C8B-B14F-4D97-AF65-F5344CB8AC3E}">
@@ -39601,7 +39383,7 @@
         <p:cNvPr id="1" name="">
           <a:extLst>
             <a:ext uri="{FF2B5EF4-FFF2-40B4-BE49-F238E27FC236}">
-              <a16:creationId xmlns:a16="http://schemas.microsoft.com/office/drawing/2014/main" id="{C876FA4F-56E0-38D4-2ADF-7F5EB3DFFC86}"/>
+              <a16:creationId xmlns:a16="http://schemas.microsoft.com/office/drawing/2014/main" id="{5611F161-B90E-8C56-2252-1512C9DAB159}"/>
             </a:ext>
           </a:extLst>
         </p:cNvPr>
@@ -39621,7 +39403,7 @@
           <p:cNvPr id="17" name="Rectangle 16">
             <a:extLst>
               <a:ext uri="{FF2B5EF4-FFF2-40B4-BE49-F238E27FC236}">
-                <a16:creationId xmlns:a16="http://schemas.microsoft.com/office/drawing/2014/main" id="{1FAB8F07-6D4B-916A-C1E3-E7E3096D579E}"/>
+                <a16:creationId xmlns:a16="http://schemas.microsoft.com/office/drawing/2014/main" id="{8DAC7CEC-8E23-EB2B-27B5-4ABF62FAB03B}"/>
               </a:ext>
             </a:extLst>
           </p:cNvPr>
@@ -39691,7 +39473,7 @@
           <p:cNvPr id="3" name="Slide Number Placeholder 2">
             <a:extLst>
               <a:ext uri="{FF2B5EF4-FFF2-40B4-BE49-F238E27FC236}">
-                <a16:creationId xmlns:a16="http://schemas.microsoft.com/office/drawing/2014/main" id="{76E08F0F-52CE-A816-71D0-86B4FA3FF4C4}"/>
+                <a16:creationId xmlns:a16="http://schemas.microsoft.com/office/drawing/2014/main" id="{4D65D14D-1CD8-2CDD-B941-6801777F2D65}"/>
               </a:ext>
             </a:extLst>
           </p:cNvPr>
@@ -39711,6 +39493,3653 @@
               <a:rPr lang="en-US" smtClean="0"/>
               <a:pPr/>
               <a:t>15</a:t>
+            </a:fld>
+            <a:endParaRPr lang="en-US"/>
+          </a:p>
+        </p:txBody>
+      </p:sp>
+      <p:sp>
+        <p:nvSpPr>
+          <p:cNvPr id="7" name="Text Placeholder 6">
+            <a:extLst>
+              <a:ext uri="{FF2B5EF4-FFF2-40B4-BE49-F238E27FC236}">
+                <a16:creationId xmlns:a16="http://schemas.microsoft.com/office/drawing/2014/main" id="{DBED9104-3218-FCCD-05C4-315211085058}"/>
+              </a:ext>
+            </a:extLst>
+          </p:cNvPr>
+          <p:cNvSpPr>
+            <a:spLocks noGrp="1"/>
+          </p:cNvSpPr>
+          <p:nvPr>
+            <p:ph type="body" sz="quarter" idx="12"/>
+          </p:nvPr>
+        </p:nvSpPr>
+        <p:spPr/>
+        <p:txBody>
+          <a:bodyPr/>
+          <a:lstStyle/>
+          <a:p>
+            <a:r>
+              <a:rPr lang="en-US" dirty="0"/>
+              <a:t>Findings – </a:t>
+            </a:r>
+            <a:r>
+              <a:rPr lang="en-US" dirty="0">
+                <a:solidFill>
+                  <a:schemeClr val="accent3"/>
+                </a:solidFill>
+              </a:rPr>
+              <a:t>Maintainability CHANGE</a:t>
+            </a:r>
+          </a:p>
+        </p:txBody>
+      </p:sp>
+      <p:sp>
+        <p:nvSpPr>
+          <p:cNvPr id="6" name="Title 5">
+            <a:extLst>
+              <a:ext uri="{FF2B5EF4-FFF2-40B4-BE49-F238E27FC236}">
+                <a16:creationId xmlns:a16="http://schemas.microsoft.com/office/drawing/2014/main" id="{4B8640D2-8DF8-0DC3-3C63-A111BDB9D98E}"/>
+              </a:ext>
+            </a:extLst>
+          </p:cNvPr>
+          <p:cNvSpPr>
+            <a:spLocks noGrp="1"/>
+          </p:cNvSpPr>
+          <p:nvPr>
+            <p:ph type="title"/>
+          </p:nvPr>
+        </p:nvSpPr>
+        <p:spPr/>
+        <p:txBody>
+          <a:bodyPr/>
+          <a:lstStyle/>
+          <a:p>
+            <a:r>
+              <a:rPr lang="en-US" noProof="0" dirty="0"/>
+              <a:t>@@</a:t>
+            </a:r>
+          </a:p>
+        </p:txBody>
+      </p:sp>
+      <p:sp>
+        <p:nvSpPr>
+          <p:cNvPr id="8" name="Content Placeholder 7">
+            <a:extLst>
+              <a:ext uri="{FF2B5EF4-FFF2-40B4-BE49-F238E27FC236}">
+                <a16:creationId xmlns:a16="http://schemas.microsoft.com/office/drawing/2014/main" id="{DD138AA3-B9FD-5715-B8FB-547CB65CF615}"/>
+              </a:ext>
+            </a:extLst>
+          </p:cNvPr>
+          <p:cNvSpPr>
+            <a:spLocks noGrp="1"/>
+          </p:cNvSpPr>
+          <p:nvPr>
+            <p:ph sz="quarter" idx="13"/>
+          </p:nvPr>
+        </p:nvSpPr>
+        <p:spPr>
+          <a:xfrm>
+            <a:off x="514800" y="1368000"/>
+            <a:ext cx="11232000" cy="1658842"/>
+          </a:xfrm>
+        </p:spPr>
+        <p:txBody>
+          <a:bodyPr anchor="ctr"/>
+          <a:lstStyle/>
+          <a:p>
+            <a:pPr marL="0" indent="0">
+              <a:buNone/>
+            </a:pPr>
+            <a:r>
+              <a:rPr lang="en-US" sz="1400" noProof="0" dirty="0"/>
+              <a:t>@@</a:t>
+            </a:r>
+            <a:endParaRPr lang="en-US" sz="1200" noProof="0" dirty="0"/>
+          </a:p>
+        </p:txBody>
+      </p:sp>
+      <p:sp>
+        <p:nvSpPr>
+          <p:cNvPr id="9" name="Rounded Rectangle 8">
+            <a:extLst>
+              <a:ext uri="{FF2B5EF4-FFF2-40B4-BE49-F238E27FC236}">
+                <a16:creationId xmlns:a16="http://schemas.microsoft.com/office/drawing/2014/main" id="{138A97F2-F17B-5AC4-1347-AFEFA455EF46}"/>
+              </a:ext>
+            </a:extLst>
+          </p:cNvPr>
+          <p:cNvSpPr/>
+          <p:nvPr/>
+        </p:nvSpPr>
+        <p:spPr>
+          <a:xfrm>
+            <a:off x="-270313" y="3154680"/>
+            <a:ext cx="9725209" cy="3163320"/>
+          </a:xfrm>
+          <a:prstGeom prst="roundRect">
+            <a:avLst>
+              <a:gd name="adj" fmla="val 3161"/>
+            </a:avLst>
+          </a:prstGeom>
+          <a:solidFill>
+            <a:schemeClr val="bg1"/>
+          </a:solidFill>
+          <a:ln>
+            <a:noFill/>
+          </a:ln>
+          <a:effectLst>
+            <a:outerShdw blurRad="190500" dist="38100" dir="2700000" algn="tl" rotWithShape="0">
+              <a:prstClr val="black">
+                <a:alpha val="15000"/>
+              </a:prstClr>
+            </a:outerShdw>
+          </a:effectLst>
+        </p:spPr>
+        <p:style>
+          <a:lnRef idx="2">
+            <a:schemeClr val="accent1">
+              <a:shade val="50000"/>
+            </a:schemeClr>
+          </a:lnRef>
+          <a:fillRef idx="1">
+            <a:schemeClr val="accent1"/>
+          </a:fillRef>
+          <a:effectRef idx="0">
+            <a:schemeClr val="accent1"/>
+          </a:effectRef>
+          <a:fontRef idx="minor">
+            <a:schemeClr val="lt1"/>
+          </a:fontRef>
+        </p:style>
+        <p:txBody>
+          <a:bodyPr lIns="731520" tIns="72000" rIns="108000" bIns="72000" rtlCol="0" anchor="ctr"/>
+          <a:lstStyle/>
+          <a:p>
+            <a:endParaRPr lang="nl-NL" sz="1200" b="1" noProof="0" dirty="0">
+              <a:solidFill>
+                <a:schemeClr val="accent1"/>
+              </a:solidFill>
+            </a:endParaRPr>
+          </a:p>
+        </p:txBody>
+      </p:sp>
+      <p:sp>
+        <p:nvSpPr>
+          <p:cNvPr id="16" name="Rounded Rectangle 15">
+            <a:extLst>
+              <a:ext uri="{FF2B5EF4-FFF2-40B4-BE49-F238E27FC236}">
+                <a16:creationId xmlns:a16="http://schemas.microsoft.com/office/drawing/2014/main" id="{1B2AF24D-3D52-BB15-9293-14CFD1E555D0}"/>
+              </a:ext>
+            </a:extLst>
+          </p:cNvPr>
+          <p:cNvSpPr/>
+          <p:nvPr/>
+        </p:nvSpPr>
+        <p:spPr>
+          <a:xfrm flipH="1">
+            <a:off x="9619488" y="3154680"/>
+            <a:ext cx="2724912" cy="3163320"/>
+          </a:xfrm>
+          <a:prstGeom prst="roundRect">
+            <a:avLst>
+              <a:gd name="adj" fmla="val 4851"/>
+            </a:avLst>
+          </a:prstGeom>
+          <a:gradFill>
+            <a:gsLst>
+              <a:gs pos="0">
+                <a:schemeClr val="bg1"/>
+              </a:gs>
+              <a:gs pos="100000">
+                <a:schemeClr val="bg2"/>
+              </a:gs>
+            </a:gsLst>
+            <a:lin ang="2700000" scaled="0"/>
+          </a:gradFill>
+          <a:ln>
+            <a:noFill/>
+          </a:ln>
+          <a:effectLst>
+            <a:outerShdw blurRad="190500" dist="38100" dir="2700000" algn="tl" rotWithShape="0">
+              <a:prstClr val="black">
+                <a:alpha val="15000"/>
+              </a:prstClr>
+            </a:outerShdw>
+          </a:effectLst>
+        </p:spPr>
+        <p:style>
+          <a:lnRef idx="2">
+            <a:schemeClr val="accent1">
+              <a:shade val="50000"/>
+            </a:schemeClr>
+          </a:lnRef>
+          <a:fillRef idx="1">
+            <a:schemeClr val="accent1"/>
+          </a:fillRef>
+          <a:effectRef idx="0">
+            <a:schemeClr val="accent1"/>
+          </a:effectRef>
+          <a:fontRef idx="minor">
+            <a:schemeClr val="lt1"/>
+          </a:fontRef>
+        </p:style>
+        <p:txBody>
+          <a:bodyPr lIns="731520" tIns="72000" rIns="108000" bIns="72000" rtlCol="0" anchor="ctr"/>
+          <a:lstStyle/>
+          <a:p>
+            <a:endParaRPr lang="nl-NL" sz="1200" b="1" noProof="0" dirty="0">
+              <a:solidFill>
+                <a:schemeClr val="accent1"/>
+              </a:solidFill>
+            </a:endParaRPr>
+          </a:p>
+        </p:txBody>
+      </p:sp>
+      <p:sp>
+        <p:nvSpPr>
+          <p:cNvPr id="28" name="TextBox 27">
+            <a:extLst>
+              <a:ext uri="{FF2B5EF4-FFF2-40B4-BE49-F238E27FC236}">
+                <a16:creationId xmlns:a16="http://schemas.microsoft.com/office/drawing/2014/main" id="{9AFB96E3-1052-4FF4-A79A-1B97C36C908D}"/>
+              </a:ext>
+            </a:extLst>
+          </p:cNvPr>
+          <p:cNvSpPr txBox="1"/>
+          <p:nvPr/>
+        </p:nvSpPr>
+        <p:spPr>
+          <a:xfrm>
+            <a:off x="-1221448" y="4419492"/>
+            <a:ext cx="628847" cy="633443"/>
+          </a:xfrm>
+          <a:prstGeom prst="rect">
+            <a:avLst/>
+          </a:prstGeom>
+          <a:noFill/>
+        </p:spPr>
+        <p:txBody>
+          <a:bodyPr wrap="none" lIns="90000" rtlCol="0" anchor="t">
+            <a:spAutoFit/>
+          </a:bodyPr>
+          <a:lstStyle/>
+          <a:p>
+            <a:pPr algn="l">
+              <a:lnSpc>
+                <a:spcPct val="113000"/>
+              </a:lnSpc>
+            </a:pPr>
+            <a:r>
+              <a:rPr lang="en-US" sz="1600" dirty="0">
+                <a:solidFill>
+                  <a:schemeClr val="tx2"/>
+                </a:solidFill>
+              </a:rPr>
+              <a:t>3.12”</a:t>
+            </a:r>
+          </a:p>
+          <a:p>
+            <a:pPr algn="l">
+              <a:lnSpc>
+                <a:spcPct val="113000"/>
+              </a:lnSpc>
+            </a:pPr>
+            <a:r>
+              <a:rPr lang="en-US" sz="1600" dirty="0">
+                <a:solidFill>
+                  <a:schemeClr val="tx2"/>
+                </a:solidFill>
+              </a:rPr>
+              <a:t>9.57"</a:t>
+            </a:r>
+          </a:p>
+        </p:txBody>
+      </p:sp>
+      <p:sp>
+        <p:nvSpPr>
+          <p:cNvPr id="35" name="Rounded Rectangle 34">
+            <a:extLst>
+              <a:ext uri="{FF2B5EF4-FFF2-40B4-BE49-F238E27FC236}">
+                <a16:creationId xmlns:a16="http://schemas.microsoft.com/office/drawing/2014/main" id="{F06D672E-20F8-989B-D512-BEC16897C474}"/>
+              </a:ext>
+            </a:extLst>
+          </p:cNvPr>
+          <p:cNvSpPr/>
+          <p:nvPr/>
+        </p:nvSpPr>
+        <p:spPr>
+          <a:xfrm>
+            <a:off x="9777184" y="4883651"/>
+            <a:ext cx="2573808" cy="326727"/>
+          </a:xfrm>
+          <a:prstGeom prst="roundRect">
+            <a:avLst>
+              <a:gd name="adj" fmla="val 31904"/>
+            </a:avLst>
+          </a:prstGeom>
+          <a:gradFill>
+            <a:gsLst>
+              <a:gs pos="0">
+                <a:srgbClr val="57C968"/>
+              </a:gs>
+              <a:gs pos="25000">
+                <a:schemeClr val="bg2"/>
+              </a:gs>
+            </a:gsLst>
+            <a:lin ang="2700000" scaled="0"/>
+          </a:gradFill>
+          <a:ln>
+            <a:noFill/>
+          </a:ln>
+          <a:effectLst>
+            <a:outerShdw blurRad="190500" dist="38100" dir="2700000" algn="tl" rotWithShape="0">
+              <a:prstClr val="black">
+                <a:alpha val="15000"/>
+              </a:prstClr>
+            </a:outerShdw>
+          </a:effectLst>
+        </p:spPr>
+        <p:style>
+          <a:lnRef idx="2">
+            <a:schemeClr val="accent1">
+              <a:shade val="50000"/>
+            </a:schemeClr>
+          </a:lnRef>
+          <a:fillRef idx="1">
+            <a:schemeClr val="accent1"/>
+          </a:fillRef>
+          <a:effectRef idx="0">
+            <a:schemeClr val="accent1"/>
+          </a:effectRef>
+          <a:fontRef idx="minor">
+            <a:schemeClr val="lt1"/>
+          </a:fontRef>
+        </p:style>
+        <p:txBody>
+          <a:bodyPr lIns="109728" tIns="72000" rIns="108000" bIns="72000" rtlCol="0" anchor="ctr"/>
+          <a:lstStyle/>
+          <a:p>
+            <a:r>
+              <a:rPr lang="nl-NL" sz="1000" b="1" noProof="0" dirty="0">
+                <a:solidFill>
+                  <a:schemeClr val="accent1"/>
+                </a:solidFill>
+              </a:rPr>
+              <a:t>@@</a:t>
+            </a:r>
+          </a:p>
+        </p:txBody>
+      </p:sp>
+      <p:sp>
+        <p:nvSpPr>
+          <p:cNvPr id="39" name="Rounded Rectangle 38">
+            <a:extLst>
+              <a:ext uri="{FF2B5EF4-FFF2-40B4-BE49-F238E27FC236}">
+                <a16:creationId xmlns:a16="http://schemas.microsoft.com/office/drawing/2014/main" id="{1320BB66-962E-E2CC-4146-E089D51FC7A4}"/>
+              </a:ext>
+            </a:extLst>
+          </p:cNvPr>
+          <p:cNvSpPr/>
+          <p:nvPr/>
+        </p:nvSpPr>
+        <p:spPr>
+          <a:xfrm>
+            <a:off x="9777184" y="4464888"/>
+            <a:ext cx="2573808" cy="326727"/>
+          </a:xfrm>
+          <a:prstGeom prst="roundRect">
+            <a:avLst>
+              <a:gd name="adj" fmla="val 31904"/>
+            </a:avLst>
+          </a:prstGeom>
+          <a:gradFill>
+            <a:gsLst>
+              <a:gs pos="0">
+                <a:srgbClr val="57C968"/>
+              </a:gs>
+              <a:gs pos="25000">
+                <a:schemeClr val="bg2"/>
+              </a:gs>
+            </a:gsLst>
+            <a:lin ang="2700000" scaled="0"/>
+          </a:gradFill>
+          <a:ln>
+            <a:noFill/>
+          </a:ln>
+          <a:effectLst>
+            <a:outerShdw blurRad="190500" dist="38100" dir="2700000" algn="tl" rotWithShape="0">
+              <a:prstClr val="black">
+                <a:alpha val="15000"/>
+              </a:prstClr>
+            </a:outerShdw>
+          </a:effectLst>
+        </p:spPr>
+        <p:style>
+          <a:lnRef idx="2">
+            <a:schemeClr val="accent1">
+              <a:shade val="50000"/>
+            </a:schemeClr>
+          </a:lnRef>
+          <a:fillRef idx="1">
+            <a:schemeClr val="accent1"/>
+          </a:fillRef>
+          <a:effectRef idx="0">
+            <a:schemeClr val="accent1"/>
+          </a:effectRef>
+          <a:fontRef idx="minor">
+            <a:schemeClr val="lt1"/>
+          </a:fontRef>
+        </p:style>
+        <p:txBody>
+          <a:bodyPr lIns="109728" tIns="72000" rIns="108000" bIns="72000" rtlCol="0" anchor="ctr"/>
+          <a:lstStyle/>
+          <a:p>
+            <a:r>
+              <a:rPr lang="nl-NL" sz="1000" b="1" noProof="0" dirty="0">
+                <a:solidFill>
+                  <a:schemeClr val="accent1"/>
+                </a:solidFill>
+              </a:rPr>
+              <a:t>@@</a:t>
+            </a:r>
+          </a:p>
+        </p:txBody>
+      </p:sp>
+      <p:sp>
+        <p:nvSpPr>
+          <p:cNvPr id="33" name="Rounded Rectangle 32">
+            <a:extLst>
+              <a:ext uri="{FF2B5EF4-FFF2-40B4-BE49-F238E27FC236}">
+                <a16:creationId xmlns:a16="http://schemas.microsoft.com/office/drawing/2014/main" id="{027E2554-5327-BA26-0784-AF99E93823B7}"/>
+              </a:ext>
+            </a:extLst>
+          </p:cNvPr>
+          <p:cNvSpPr/>
+          <p:nvPr/>
+        </p:nvSpPr>
+        <p:spPr>
+          <a:xfrm>
+            <a:off x="9777184" y="4046125"/>
+            <a:ext cx="2573808" cy="326727"/>
+          </a:xfrm>
+          <a:prstGeom prst="roundRect">
+            <a:avLst>
+              <a:gd name="adj" fmla="val 31904"/>
+            </a:avLst>
+          </a:prstGeom>
+          <a:gradFill>
+            <a:gsLst>
+              <a:gs pos="0">
+                <a:srgbClr val="F9C640"/>
+              </a:gs>
+              <a:gs pos="25000">
+                <a:schemeClr val="bg2"/>
+              </a:gs>
+            </a:gsLst>
+            <a:lin ang="2700000" scaled="0"/>
+          </a:gradFill>
+          <a:ln>
+            <a:noFill/>
+          </a:ln>
+          <a:effectLst>
+            <a:outerShdw blurRad="190500" dist="38100" dir="2700000" algn="tl" rotWithShape="0">
+              <a:prstClr val="black">
+                <a:alpha val="15000"/>
+              </a:prstClr>
+            </a:outerShdw>
+          </a:effectLst>
+        </p:spPr>
+        <p:style>
+          <a:lnRef idx="2">
+            <a:schemeClr val="accent1">
+              <a:shade val="50000"/>
+            </a:schemeClr>
+          </a:lnRef>
+          <a:fillRef idx="1">
+            <a:schemeClr val="accent1"/>
+          </a:fillRef>
+          <a:effectRef idx="0">
+            <a:schemeClr val="accent1"/>
+          </a:effectRef>
+          <a:fontRef idx="minor">
+            <a:schemeClr val="lt1"/>
+          </a:fontRef>
+        </p:style>
+        <p:txBody>
+          <a:bodyPr lIns="109728" tIns="72000" rIns="108000" bIns="72000" rtlCol="0" anchor="ctr"/>
+          <a:lstStyle/>
+          <a:p>
+            <a:r>
+              <a:rPr lang="nl-NL" sz="1000" b="1" noProof="0" dirty="0">
+                <a:solidFill>
+                  <a:schemeClr val="accent1"/>
+                </a:solidFill>
+              </a:rPr>
+              <a:t>@@</a:t>
+            </a:r>
+          </a:p>
+        </p:txBody>
+      </p:sp>
+      <p:sp>
+        <p:nvSpPr>
+          <p:cNvPr id="38" name="Rounded Rectangle 37">
+            <a:extLst>
+              <a:ext uri="{FF2B5EF4-FFF2-40B4-BE49-F238E27FC236}">
+                <a16:creationId xmlns:a16="http://schemas.microsoft.com/office/drawing/2014/main" id="{021D9100-D950-8106-46A1-6161331A7BDE}"/>
+              </a:ext>
+            </a:extLst>
+          </p:cNvPr>
+          <p:cNvSpPr/>
+          <p:nvPr/>
+        </p:nvSpPr>
+        <p:spPr>
+          <a:xfrm>
+            <a:off x="9777184" y="3627362"/>
+            <a:ext cx="2573808" cy="326727"/>
+          </a:xfrm>
+          <a:prstGeom prst="roundRect">
+            <a:avLst>
+              <a:gd name="adj" fmla="val 31904"/>
+            </a:avLst>
+          </a:prstGeom>
+          <a:gradFill>
+            <a:gsLst>
+              <a:gs pos="0">
+                <a:srgbClr val="F9C640"/>
+              </a:gs>
+              <a:gs pos="25000">
+                <a:schemeClr val="bg2"/>
+              </a:gs>
+            </a:gsLst>
+            <a:lin ang="2700000" scaled="0"/>
+          </a:gradFill>
+          <a:ln>
+            <a:noFill/>
+          </a:ln>
+          <a:effectLst>
+            <a:outerShdw blurRad="190500" dist="38100" dir="2700000" algn="tl" rotWithShape="0">
+              <a:prstClr val="black">
+                <a:alpha val="15000"/>
+              </a:prstClr>
+            </a:outerShdw>
+          </a:effectLst>
+        </p:spPr>
+        <p:style>
+          <a:lnRef idx="2">
+            <a:schemeClr val="accent1">
+              <a:shade val="50000"/>
+            </a:schemeClr>
+          </a:lnRef>
+          <a:fillRef idx="1">
+            <a:schemeClr val="accent1"/>
+          </a:fillRef>
+          <a:effectRef idx="0">
+            <a:schemeClr val="accent1"/>
+          </a:effectRef>
+          <a:fontRef idx="minor">
+            <a:schemeClr val="lt1"/>
+          </a:fontRef>
+        </p:style>
+        <p:txBody>
+          <a:bodyPr lIns="109728" tIns="72000" rIns="108000" bIns="72000" rtlCol="0" anchor="ctr"/>
+          <a:lstStyle/>
+          <a:p>
+            <a:r>
+              <a:rPr lang="nl-NL" sz="1000" b="1" noProof="0" dirty="0">
+                <a:solidFill>
+                  <a:schemeClr val="accent1"/>
+                </a:solidFill>
+              </a:rPr>
+              <a:t>@@</a:t>
+            </a:r>
+          </a:p>
+        </p:txBody>
+      </p:sp>
+      <p:sp>
+        <p:nvSpPr>
+          <p:cNvPr id="37" name="Rounded Rectangle 36">
+            <a:extLst>
+              <a:ext uri="{FF2B5EF4-FFF2-40B4-BE49-F238E27FC236}">
+                <a16:creationId xmlns:a16="http://schemas.microsoft.com/office/drawing/2014/main" id="{34973D1E-1D2C-D10C-30A4-1ACDA4370960}"/>
+              </a:ext>
+            </a:extLst>
+          </p:cNvPr>
+          <p:cNvSpPr/>
+          <p:nvPr/>
+        </p:nvSpPr>
+        <p:spPr>
+          <a:xfrm>
+            <a:off x="9777184" y="5721177"/>
+            <a:ext cx="2573808" cy="326727"/>
+          </a:xfrm>
+          <a:prstGeom prst="roundRect">
+            <a:avLst>
+              <a:gd name="adj" fmla="val 31904"/>
+            </a:avLst>
+          </a:prstGeom>
+          <a:gradFill>
+            <a:gsLst>
+              <a:gs pos="0">
+                <a:srgbClr val="57C968"/>
+              </a:gs>
+              <a:gs pos="25000">
+                <a:schemeClr val="bg2"/>
+              </a:gs>
+            </a:gsLst>
+            <a:lin ang="2700000" scaled="0"/>
+          </a:gradFill>
+          <a:ln>
+            <a:noFill/>
+          </a:ln>
+          <a:effectLst>
+            <a:outerShdw blurRad="190500" dist="38100" dir="2700000" algn="tl" rotWithShape="0">
+              <a:prstClr val="black">
+                <a:alpha val="15000"/>
+              </a:prstClr>
+            </a:outerShdw>
+          </a:effectLst>
+        </p:spPr>
+        <p:style>
+          <a:lnRef idx="2">
+            <a:schemeClr val="accent1">
+              <a:shade val="50000"/>
+            </a:schemeClr>
+          </a:lnRef>
+          <a:fillRef idx="1">
+            <a:schemeClr val="accent1"/>
+          </a:fillRef>
+          <a:effectRef idx="0">
+            <a:schemeClr val="accent1"/>
+          </a:effectRef>
+          <a:fontRef idx="minor">
+            <a:schemeClr val="lt1"/>
+          </a:fontRef>
+        </p:style>
+        <p:txBody>
+          <a:bodyPr lIns="109728" tIns="72000" rIns="108000" bIns="72000" rtlCol="0" anchor="ctr"/>
+          <a:lstStyle/>
+          <a:p>
+            <a:r>
+              <a:rPr lang="nl-NL" sz="1000" b="1" noProof="0" dirty="0">
+                <a:solidFill>
+                  <a:schemeClr val="accent1"/>
+                </a:solidFill>
+              </a:rPr>
+              <a:t>@@</a:t>
+            </a:r>
+          </a:p>
+        </p:txBody>
+      </p:sp>
+      <p:sp>
+        <p:nvSpPr>
+          <p:cNvPr id="36" name="Rounded Rectangle 35">
+            <a:extLst>
+              <a:ext uri="{FF2B5EF4-FFF2-40B4-BE49-F238E27FC236}">
+                <a16:creationId xmlns:a16="http://schemas.microsoft.com/office/drawing/2014/main" id="{64F1F953-480A-B7FA-15F6-5A9957C998CA}"/>
+              </a:ext>
+            </a:extLst>
+          </p:cNvPr>
+          <p:cNvSpPr/>
+          <p:nvPr/>
+        </p:nvSpPr>
+        <p:spPr>
+          <a:xfrm>
+            <a:off x="9777184" y="5302414"/>
+            <a:ext cx="2573808" cy="326727"/>
+          </a:xfrm>
+          <a:prstGeom prst="roundRect">
+            <a:avLst>
+              <a:gd name="adj" fmla="val 31904"/>
+            </a:avLst>
+          </a:prstGeom>
+          <a:gradFill>
+            <a:gsLst>
+              <a:gs pos="0">
+                <a:srgbClr val="57C968"/>
+              </a:gs>
+              <a:gs pos="25000">
+                <a:schemeClr val="bg2"/>
+              </a:gs>
+            </a:gsLst>
+            <a:lin ang="2700000" scaled="0"/>
+          </a:gradFill>
+          <a:ln>
+            <a:noFill/>
+          </a:ln>
+          <a:effectLst>
+            <a:outerShdw blurRad="190500" dist="38100" dir="2700000" algn="tl" rotWithShape="0">
+              <a:prstClr val="black">
+                <a:alpha val="15000"/>
+              </a:prstClr>
+            </a:outerShdw>
+          </a:effectLst>
+        </p:spPr>
+        <p:style>
+          <a:lnRef idx="2">
+            <a:schemeClr val="accent1">
+              <a:shade val="50000"/>
+            </a:schemeClr>
+          </a:lnRef>
+          <a:fillRef idx="1">
+            <a:schemeClr val="accent1"/>
+          </a:fillRef>
+          <a:effectRef idx="0">
+            <a:schemeClr val="accent1"/>
+          </a:effectRef>
+          <a:fontRef idx="minor">
+            <a:schemeClr val="lt1"/>
+          </a:fontRef>
+        </p:style>
+        <p:txBody>
+          <a:bodyPr lIns="109728" tIns="72000" rIns="108000" bIns="72000" rtlCol="0" anchor="ctr"/>
+          <a:lstStyle/>
+          <a:p>
+            <a:r>
+              <a:rPr lang="nl-NL" sz="1000" b="1" noProof="0" dirty="0">
+                <a:solidFill>
+                  <a:schemeClr val="accent1"/>
+                </a:solidFill>
+              </a:rPr>
+              <a:t>@@</a:t>
+            </a:r>
+          </a:p>
+        </p:txBody>
+      </p:sp>
+      <p:sp>
+        <p:nvSpPr>
+          <p:cNvPr id="40" name="TextBox 39">
+            <a:extLst>
+              <a:ext uri="{FF2B5EF4-FFF2-40B4-BE49-F238E27FC236}">
+                <a16:creationId xmlns:a16="http://schemas.microsoft.com/office/drawing/2014/main" id="{580EABAA-5E31-99C1-2148-99E3700D9B4E}"/>
+              </a:ext>
+            </a:extLst>
+          </p:cNvPr>
+          <p:cNvSpPr txBox="1"/>
+          <p:nvPr/>
+        </p:nvSpPr>
+        <p:spPr>
+          <a:xfrm>
+            <a:off x="11186130" y="4921755"/>
+            <a:ext cx="991126" cy="250518"/>
+          </a:xfrm>
+          <a:prstGeom prst="rect">
+            <a:avLst/>
+          </a:prstGeom>
+          <a:noFill/>
+        </p:spPr>
+        <p:txBody>
+          <a:bodyPr wrap="none" lIns="90000" rtlCol="0" anchor="t">
+            <a:spAutoFit/>
+          </a:bodyPr>
+          <a:lstStyle/>
+          <a:p>
+            <a:pPr algn="r">
+              <a:lnSpc>
+                <a:spcPct val="113000"/>
+              </a:lnSpc>
+            </a:pPr>
+            <a:r>
+              <a:rPr lang="en-US" sz="1000" b="1" dirty="0" err="1">
+                <a:solidFill>
+                  <a:schemeClr val="tx2"/>
+                </a:solidFill>
+                <a:latin typeface="Sigsterren" pitchFamily="2" charset="0"/>
+              </a:rPr>
+              <a:t>HHHHH</a:t>
+            </a:r>
+            <a:r>
+              <a:rPr lang="en-US" sz="1000" b="1" dirty="0">
+                <a:solidFill>
+                  <a:schemeClr val="tx2"/>
+                </a:solidFill>
+                <a:latin typeface="Sigsterren" pitchFamily="2" charset="0"/>
+              </a:rPr>
+              <a:t> </a:t>
+            </a:r>
+            <a:r>
+              <a:rPr lang="en-US" sz="1000" b="1" dirty="0">
+                <a:solidFill>
+                  <a:schemeClr val="tx2"/>
+                </a:solidFill>
+                <a:latin typeface="Calibri" panose="020F0502020204030204" pitchFamily="34" charset="0"/>
+                <a:cs typeface="Calibri" panose="020F0502020204030204" pitchFamily="34" charset="0"/>
+              </a:rPr>
+              <a:t>(</a:t>
+            </a:r>
+            <a:r>
+              <a:rPr lang="en-US" sz="1000" b="1" dirty="0" err="1">
+                <a:solidFill>
+                  <a:schemeClr val="tx2"/>
+                </a:solidFill>
+                <a:latin typeface="Calibri" panose="020F0502020204030204" pitchFamily="34" charset="0"/>
+                <a:cs typeface="Calibri" panose="020F0502020204030204" pitchFamily="34" charset="0"/>
+              </a:rPr>
+              <a:t>X.X</a:t>
+            </a:r>
+            <a:r>
+              <a:rPr lang="en-US" sz="1000" b="1" dirty="0">
+                <a:solidFill>
+                  <a:schemeClr val="tx2"/>
+                </a:solidFill>
+                <a:latin typeface="Calibri" panose="020F0502020204030204" pitchFamily="34" charset="0"/>
+                <a:cs typeface="Calibri" panose="020F0502020204030204" pitchFamily="34" charset="0"/>
+              </a:rPr>
+              <a:t>)</a:t>
+            </a:r>
+          </a:p>
+        </p:txBody>
+      </p:sp>
+      <p:sp>
+        <p:nvSpPr>
+          <p:cNvPr id="41" name="TextBox 40">
+            <a:extLst>
+              <a:ext uri="{FF2B5EF4-FFF2-40B4-BE49-F238E27FC236}">
+                <a16:creationId xmlns:a16="http://schemas.microsoft.com/office/drawing/2014/main" id="{1385F7DE-2691-8B2B-E114-2A862286A68A}"/>
+              </a:ext>
+            </a:extLst>
+          </p:cNvPr>
+          <p:cNvSpPr txBox="1"/>
+          <p:nvPr/>
+        </p:nvSpPr>
+        <p:spPr>
+          <a:xfrm>
+            <a:off x="11186130" y="4502992"/>
+            <a:ext cx="991126" cy="250518"/>
+          </a:xfrm>
+          <a:prstGeom prst="rect">
+            <a:avLst/>
+          </a:prstGeom>
+          <a:noFill/>
+        </p:spPr>
+        <p:txBody>
+          <a:bodyPr wrap="none" lIns="90000" rtlCol="0" anchor="t">
+            <a:spAutoFit/>
+          </a:bodyPr>
+          <a:lstStyle/>
+          <a:p>
+            <a:pPr algn="r">
+              <a:lnSpc>
+                <a:spcPct val="113000"/>
+              </a:lnSpc>
+            </a:pPr>
+            <a:r>
+              <a:rPr lang="en-US" sz="1000" b="1" dirty="0" err="1">
+                <a:solidFill>
+                  <a:schemeClr val="tx2"/>
+                </a:solidFill>
+                <a:latin typeface="Sigsterren" pitchFamily="2" charset="0"/>
+              </a:rPr>
+              <a:t>HHHHH</a:t>
+            </a:r>
+            <a:r>
+              <a:rPr lang="en-US" sz="1000" b="1" dirty="0">
+                <a:solidFill>
+                  <a:schemeClr val="tx2"/>
+                </a:solidFill>
+                <a:latin typeface="Sigsterren" pitchFamily="2" charset="0"/>
+              </a:rPr>
+              <a:t> </a:t>
+            </a:r>
+            <a:r>
+              <a:rPr lang="en-US" sz="1000" b="1" dirty="0">
+                <a:solidFill>
+                  <a:schemeClr val="tx2"/>
+                </a:solidFill>
+                <a:latin typeface="Calibri" panose="020F0502020204030204" pitchFamily="34" charset="0"/>
+                <a:cs typeface="Calibri" panose="020F0502020204030204" pitchFamily="34" charset="0"/>
+              </a:rPr>
+              <a:t>(</a:t>
+            </a:r>
+            <a:r>
+              <a:rPr lang="en-US" sz="1000" b="1" dirty="0" err="1">
+                <a:solidFill>
+                  <a:schemeClr val="tx2"/>
+                </a:solidFill>
+                <a:latin typeface="Calibri" panose="020F0502020204030204" pitchFamily="34" charset="0"/>
+                <a:cs typeface="Calibri" panose="020F0502020204030204" pitchFamily="34" charset="0"/>
+              </a:rPr>
+              <a:t>X.X</a:t>
+            </a:r>
+            <a:r>
+              <a:rPr lang="en-US" sz="1000" b="1" dirty="0">
+                <a:solidFill>
+                  <a:schemeClr val="tx2"/>
+                </a:solidFill>
+                <a:latin typeface="Calibri" panose="020F0502020204030204" pitchFamily="34" charset="0"/>
+                <a:cs typeface="Calibri" panose="020F0502020204030204" pitchFamily="34" charset="0"/>
+              </a:rPr>
+              <a:t>)</a:t>
+            </a:r>
+          </a:p>
+        </p:txBody>
+      </p:sp>
+      <p:sp>
+        <p:nvSpPr>
+          <p:cNvPr id="44" name="TextBox 43">
+            <a:extLst>
+              <a:ext uri="{FF2B5EF4-FFF2-40B4-BE49-F238E27FC236}">
+                <a16:creationId xmlns:a16="http://schemas.microsoft.com/office/drawing/2014/main" id="{47E7B9D5-733B-A6F5-4849-51C64E0BD4A9}"/>
+              </a:ext>
+            </a:extLst>
+          </p:cNvPr>
+          <p:cNvSpPr txBox="1"/>
+          <p:nvPr/>
+        </p:nvSpPr>
+        <p:spPr>
+          <a:xfrm>
+            <a:off x="11186130" y="5759281"/>
+            <a:ext cx="991126" cy="250518"/>
+          </a:xfrm>
+          <a:prstGeom prst="rect">
+            <a:avLst/>
+          </a:prstGeom>
+          <a:noFill/>
+        </p:spPr>
+        <p:txBody>
+          <a:bodyPr wrap="none" lIns="90000" rtlCol="0" anchor="t">
+            <a:spAutoFit/>
+          </a:bodyPr>
+          <a:lstStyle/>
+          <a:p>
+            <a:pPr algn="r">
+              <a:lnSpc>
+                <a:spcPct val="113000"/>
+              </a:lnSpc>
+            </a:pPr>
+            <a:r>
+              <a:rPr lang="en-US" sz="1000" b="1" dirty="0" err="1">
+                <a:solidFill>
+                  <a:schemeClr val="tx2"/>
+                </a:solidFill>
+                <a:latin typeface="Sigsterren" pitchFamily="2" charset="0"/>
+              </a:rPr>
+              <a:t>HHHHH</a:t>
+            </a:r>
+            <a:r>
+              <a:rPr lang="en-US" sz="1000" b="1" dirty="0">
+                <a:solidFill>
+                  <a:schemeClr val="tx2"/>
+                </a:solidFill>
+                <a:latin typeface="Sigsterren" pitchFamily="2" charset="0"/>
+              </a:rPr>
+              <a:t> </a:t>
+            </a:r>
+            <a:r>
+              <a:rPr lang="en-US" sz="1000" b="1" dirty="0">
+                <a:solidFill>
+                  <a:schemeClr val="tx2"/>
+                </a:solidFill>
+                <a:latin typeface="Calibri" panose="020F0502020204030204" pitchFamily="34" charset="0"/>
+                <a:cs typeface="Calibri" panose="020F0502020204030204" pitchFamily="34" charset="0"/>
+              </a:rPr>
+              <a:t>(</a:t>
+            </a:r>
+            <a:r>
+              <a:rPr lang="en-US" sz="1000" b="1" dirty="0" err="1">
+                <a:solidFill>
+                  <a:schemeClr val="tx2"/>
+                </a:solidFill>
+                <a:latin typeface="Calibri" panose="020F0502020204030204" pitchFamily="34" charset="0"/>
+                <a:cs typeface="Calibri" panose="020F0502020204030204" pitchFamily="34" charset="0"/>
+              </a:rPr>
+              <a:t>X.X</a:t>
+            </a:r>
+            <a:r>
+              <a:rPr lang="en-US" sz="1000" b="1" dirty="0">
+                <a:solidFill>
+                  <a:schemeClr val="tx2"/>
+                </a:solidFill>
+                <a:latin typeface="Calibri" panose="020F0502020204030204" pitchFamily="34" charset="0"/>
+                <a:cs typeface="Calibri" panose="020F0502020204030204" pitchFamily="34" charset="0"/>
+              </a:rPr>
+              <a:t>)</a:t>
+            </a:r>
+          </a:p>
+        </p:txBody>
+      </p:sp>
+      <p:sp>
+        <p:nvSpPr>
+          <p:cNvPr id="45" name="TextBox 44">
+            <a:extLst>
+              <a:ext uri="{FF2B5EF4-FFF2-40B4-BE49-F238E27FC236}">
+                <a16:creationId xmlns:a16="http://schemas.microsoft.com/office/drawing/2014/main" id="{CCE65E07-BEC6-D825-21DE-A526C8645BDD}"/>
+              </a:ext>
+            </a:extLst>
+          </p:cNvPr>
+          <p:cNvSpPr txBox="1"/>
+          <p:nvPr/>
+        </p:nvSpPr>
+        <p:spPr>
+          <a:xfrm>
+            <a:off x="11186130" y="5340518"/>
+            <a:ext cx="991126" cy="250518"/>
+          </a:xfrm>
+          <a:prstGeom prst="rect">
+            <a:avLst/>
+          </a:prstGeom>
+          <a:noFill/>
+        </p:spPr>
+        <p:txBody>
+          <a:bodyPr wrap="none" lIns="90000" rtlCol="0" anchor="t">
+            <a:spAutoFit/>
+          </a:bodyPr>
+          <a:lstStyle/>
+          <a:p>
+            <a:pPr algn="r">
+              <a:lnSpc>
+                <a:spcPct val="113000"/>
+              </a:lnSpc>
+            </a:pPr>
+            <a:r>
+              <a:rPr lang="en-US" sz="1000" b="1" dirty="0" err="1">
+                <a:solidFill>
+                  <a:schemeClr val="tx2"/>
+                </a:solidFill>
+                <a:latin typeface="Sigsterren" pitchFamily="2" charset="0"/>
+              </a:rPr>
+              <a:t>HHHHH</a:t>
+            </a:r>
+            <a:r>
+              <a:rPr lang="en-US" sz="1000" b="1" dirty="0">
+                <a:solidFill>
+                  <a:schemeClr val="tx2"/>
+                </a:solidFill>
+                <a:latin typeface="Sigsterren" pitchFamily="2" charset="0"/>
+              </a:rPr>
+              <a:t> </a:t>
+            </a:r>
+            <a:r>
+              <a:rPr lang="en-US" sz="1000" b="1" dirty="0">
+                <a:solidFill>
+                  <a:schemeClr val="tx2"/>
+                </a:solidFill>
+                <a:latin typeface="Calibri" panose="020F0502020204030204" pitchFamily="34" charset="0"/>
+                <a:cs typeface="Calibri" panose="020F0502020204030204" pitchFamily="34" charset="0"/>
+              </a:rPr>
+              <a:t>(</a:t>
+            </a:r>
+            <a:r>
+              <a:rPr lang="en-US" sz="1000" b="1" dirty="0" err="1">
+                <a:solidFill>
+                  <a:schemeClr val="tx2"/>
+                </a:solidFill>
+                <a:latin typeface="Calibri" panose="020F0502020204030204" pitchFamily="34" charset="0"/>
+                <a:cs typeface="Calibri" panose="020F0502020204030204" pitchFamily="34" charset="0"/>
+              </a:rPr>
+              <a:t>X.X</a:t>
+            </a:r>
+            <a:r>
+              <a:rPr lang="en-US" sz="1000" b="1" dirty="0">
+                <a:solidFill>
+                  <a:schemeClr val="tx2"/>
+                </a:solidFill>
+                <a:latin typeface="Calibri" panose="020F0502020204030204" pitchFamily="34" charset="0"/>
+                <a:cs typeface="Calibri" panose="020F0502020204030204" pitchFamily="34" charset="0"/>
+              </a:rPr>
+              <a:t>)</a:t>
+            </a:r>
+          </a:p>
+        </p:txBody>
+      </p:sp>
+      <p:sp>
+        <p:nvSpPr>
+          <p:cNvPr id="42" name="TextBox 41">
+            <a:extLst>
+              <a:ext uri="{FF2B5EF4-FFF2-40B4-BE49-F238E27FC236}">
+                <a16:creationId xmlns:a16="http://schemas.microsoft.com/office/drawing/2014/main" id="{7436BA12-022D-C6EB-815A-CD6115CB88FA}"/>
+              </a:ext>
+            </a:extLst>
+          </p:cNvPr>
+          <p:cNvSpPr txBox="1"/>
+          <p:nvPr/>
+        </p:nvSpPr>
+        <p:spPr>
+          <a:xfrm>
+            <a:off x="11186130" y="4084229"/>
+            <a:ext cx="991126" cy="250518"/>
+          </a:xfrm>
+          <a:prstGeom prst="rect">
+            <a:avLst/>
+          </a:prstGeom>
+          <a:noFill/>
+        </p:spPr>
+        <p:txBody>
+          <a:bodyPr wrap="none" lIns="90000" rtlCol="0" anchor="t">
+            <a:spAutoFit/>
+          </a:bodyPr>
+          <a:lstStyle/>
+          <a:p>
+            <a:pPr algn="r">
+              <a:lnSpc>
+                <a:spcPct val="113000"/>
+              </a:lnSpc>
+            </a:pPr>
+            <a:r>
+              <a:rPr lang="en-US" sz="1000" b="1" dirty="0" err="1">
+                <a:solidFill>
+                  <a:schemeClr val="tx2"/>
+                </a:solidFill>
+                <a:latin typeface="Sigsterren" pitchFamily="2" charset="0"/>
+              </a:rPr>
+              <a:t>HHHHH</a:t>
+            </a:r>
+            <a:r>
+              <a:rPr lang="en-US" sz="1000" b="1" dirty="0">
+                <a:solidFill>
+                  <a:schemeClr val="tx2"/>
+                </a:solidFill>
+                <a:latin typeface="Sigsterren" pitchFamily="2" charset="0"/>
+              </a:rPr>
+              <a:t> </a:t>
+            </a:r>
+            <a:r>
+              <a:rPr lang="en-US" sz="1000" b="1" dirty="0">
+                <a:solidFill>
+                  <a:schemeClr val="tx2"/>
+                </a:solidFill>
+                <a:latin typeface="Calibri" panose="020F0502020204030204" pitchFamily="34" charset="0"/>
+                <a:cs typeface="Calibri" panose="020F0502020204030204" pitchFamily="34" charset="0"/>
+              </a:rPr>
+              <a:t>(</a:t>
+            </a:r>
+            <a:r>
+              <a:rPr lang="en-US" sz="1000" b="1" dirty="0" err="1">
+                <a:solidFill>
+                  <a:schemeClr val="tx2"/>
+                </a:solidFill>
+                <a:latin typeface="Calibri" panose="020F0502020204030204" pitchFamily="34" charset="0"/>
+                <a:cs typeface="Calibri" panose="020F0502020204030204" pitchFamily="34" charset="0"/>
+              </a:rPr>
+              <a:t>X.X</a:t>
+            </a:r>
+            <a:r>
+              <a:rPr lang="en-US" sz="1000" b="1" dirty="0">
+                <a:solidFill>
+                  <a:schemeClr val="tx2"/>
+                </a:solidFill>
+                <a:latin typeface="Calibri" panose="020F0502020204030204" pitchFamily="34" charset="0"/>
+                <a:cs typeface="Calibri" panose="020F0502020204030204" pitchFamily="34" charset="0"/>
+              </a:rPr>
+              <a:t>)</a:t>
+            </a:r>
+          </a:p>
+        </p:txBody>
+      </p:sp>
+      <p:sp>
+        <p:nvSpPr>
+          <p:cNvPr id="43" name="TextBox 42">
+            <a:extLst>
+              <a:ext uri="{FF2B5EF4-FFF2-40B4-BE49-F238E27FC236}">
+                <a16:creationId xmlns:a16="http://schemas.microsoft.com/office/drawing/2014/main" id="{8D4EAEA8-1C55-F0B5-5438-0CE0DEA35D9A}"/>
+              </a:ext>
+            </a:extLst>
+          </p:cNvPr>
+          <p:cNvSpPr txBox="1"/>
+          <p:nvPr/>
+        </p:nvSpPr>
+        <p:spPr>
+          <a:xfrm>
+            <a:off x="11186130" y="3665466"/>
+            <a:ext cx="991126" cy="250518"/>
+          </a:xfrm>
+          <a:prstGeom prst="rect">
+            <a:avLst/>
+          </a:prstGeom>
+          <a:noFill/>
+        </p:spPr>
+        <p:txBody>
+          <a:bodyPr wrap="none" lIns="90000" rtlCol="0" anchor="t">
+            <a:spAutoFit/>
+          </a:bodyPr>
+          <a:lstStyle/>
+          <a:p>
+            <a:pPr algn="r">
+              <a:lnSpc>
+                <a:spcPct val="113000"/>
+              </a:lnSpc>
+            </a:pPr>
+            <a:r>
+              <a:rPr lang="en-US" sz="1000" b="1" dirty="0" err="1">
+                <a:solidFill>
+                  <a:schemeClr val="tx2"/>
+                </a:solidFill>
+                <a:latin typeface="Sigsterren" pitchFamily="2" charset="0"/>
+              </a:rPr>
+              <a:t>HHHHH</a:t>
+            </a:r>
+            <a:r>
+              <a:rPr lang="en-US" sz="1000" b="1" dirty="0">
+                <a:solidFill>
+                  <a:schemeClr val="tx2"/>
+                </a:solidFill>
+                <a:latin typeface="Sigsterren" pitchFamily="2" charset="0"/>
+              </a:rPr>
+              <a:t> </a:t>
+            </a:r>
+            <a:r>
+              <a:rPr lang="en-US" sz="1000" b="1" dirty="0">
+                <a:solidFill>
+                  <a:schemeClr val="tx2"/>
+                </a:solidFill>
+                <a:latin typeface="Calibri" panose="020F0502020204030204" pitchFamily="34" charset="0"/>
+                <a:cs typeface="Calibri" panose="020F0502020204030204" pitchFamily="34" charset="0"/>
+              </a:rPr>
+              <a:t>(</a:t>
+            </a:r>
+            <a:r>
+              <a:rPr lang="en-US" sz="1000" b="1" dirty="0" err="1">
+                <a:solidFill>
+                  <a:schemeClr val="tx2"/>
+                </a:solidFill>
+                <a:latin typeface="Calibri" panose="020F0502020204030204" pitchFamily="34" charset="0"/>
+                <a:cs typeface="Calibri" panose="020F0502020204030204" pitchFamily="34" charset="0"/>
+              </a:rPr>
+              <a:t>X.X</a:t>
+            </a:r>
+            <a:r>
+              <a:rPr lang="en-US" sz="1000" b="1" dirty="0">
+                <a:solidFill>
+                  <a:schemeClr val="tx2"/>
+                </a:solidFill>
+                <a:latin typeface="Calibri" panose="020F0502020204030204" pitchFamily="34" charset="0"/>
+                <a:cs typeface="Calibri" panose="020F0502020204030204" pitchFamily="34" charset="0"/>
+              </a:rPr>
+              <a:t>)</a:t>
+            </a:r>
+          </a:p>
+        </p:txBody>
+      </p:sp>
+      <p:sp>
+        <p:nvSpPr>
+          <p:cNvPr id="60" name="Triangle 59">
+            <a:extLst>
+              <a:ext uri="{FF2B5EF4-FFF2-40B4-BE49-F238E27FC236}">
+                <a16:creationId xmlns:a16="http://schemas.microsoft.com/office/drawing/2014/main" id="{14742EA5-7D83-21AA-EAEA-54537DBC17D6}"/>
+              </a:ext>
+            </a:extLst>
+          </p:cNvPr>
+          <p:cNvSpPr/>
+          <p:nvPr/>
+        </p:nvSpPr>
+        <p:spPr>
+          <a:xfrm rot="5400000">
+            <a:off x="11223517" y="97630"/>
+            <a:ext cx="113704" cy="91353"/>
+          </a:xfrm>
+          <a:prstGeom prst="triangle">
+            <a:avLst/>
+          </a:prstGeom>
+          <a:solidFill>
+            <a:schemeClr val="tx2"/>
+          </a:solidFill>
+          <a:ln>
+            <a:noFill/>
+          </a:ln>
+        </p:spPr>
+        <p:style>
+          <a:lnRef idx="2">
+            <a:schemeClr val="accent1">
+              <a:shade val="50000"/>
+            </a:schemeClr>
+          </a:lnRef>
+          <a:fillRef idx="1">
+            <a:schemeClr val="accent1"/>
+          </a:fillRef>
+          <a:effectRef idx="0">
+            <a:schemeClr val="accent1"/>
+          </a:effectRef>
+          <a:fontRef idx="minor">
+            <a:schemeClr val="lt1"/>
+          </a:fontRef>
+        </p:style>
+        <p:txBody>
+          <a:bodyPr lIns="108000" tIns="72000" rIns="108000" bIns="72000" rtlCol="0" anchor="ctr"/>
+          <a:lstStyle/>
+          <a:p>
+            <a:pPr algn="ctr"/>
+            <a:endParaRPr lang="en-US" sz="1600">
+              <a:solidFill>
+                <a:schemeClr val="bg1"/>
+              </a:solidFill>
+            </a:endParaRPr>
+          </a:p>
+        </p:txBody>
+      </p:sp>
+      <p:pic>
+        <p:nvPicPr>
+          <p:cNvPr id="61" name="Picture 60">
+            <a:extLst>
+              <a:ext uri="{FF2B5EF4-FFF2-40B4-BE49-F238E27FC236}">
+                <a16:creationId xmlns:a16="http://schemas.microsoft.com/office/drawing/2014/main" id="{67300D5D-E362-AAE7-A4AD-8CBAC4B39457}"/>
+              </a:ext>
+            </a:extLst>
+          </p:cNvPr>
+          <p:cNvPicPr>
+            <a:picLocks noChangeAspect="1"/>
+          </p:cNvPicPr>
+          <p:nvPr/>
+        </p:nvPicPr>
+        <p:blipFill>
+          <a:blip r:embed="rId2"/>
+          <a:stretch>
+            <a:fillRect/>
+          </a:stretch>
+        </p:blipFill>
+        <p:spPr>
+          <a:xfrm>
+            <a:off x="10267839" y="52613"/>
+            <a:ext cx="203103" cy="172639"/>
+          </a:xfrm>
+          <a:prstGeom prst="rect">
+            <a:avLst/>
+          </a:prstGeom>
+        </p:spPr>
+      </p:pic>
+      <p:sp>
+        <p:nvSpPr>
+          <p:cNvPr id="62" name="TextBox 61">
+            <a:extLst>
+              <a:ext uri="{FF2B5EF4-FFF2-40B4-BE49-F238E27FC236}">
+                <a16:creationId xmlns:a16="http://schemas.microsoft.com/office/drawing/2014/main" id="{5BA421D5-AA0C-CD2A-F80C-8A0A5D072D82}"/>
+              </a:ext>
+            </a:extLst>
+          </p:cNvPr>
+          <p:cNvSpPr txBox="1"/>
+          <p:nvPr/>
+        </p:nvSpPr>
+        <p:spPr>
+          <a:xfrm>
+            <a:off x="9145068" y="10898"/>
+            <a:ext cx="2110021" cy="264816"/>
+          </a:xfrm>
+          <a:prstGeom prst="rect">
+            <a:avLst/>
+          </a:prstGeom>
+          <a:noFill/>
+        </p:spPr>
+        <p:txBody>
+          <a:bodyPr wrap="none" lIns="90000" rtlCol="0" anchor="t">
+            <a:spAutoFit/>
+          </a:bodyPr>
+          <a:lstStyle/>
+          <a:p>
+            <a:pPr algn="r">
+              <a:lnSpc>
+                <a:spcPct val="113000"/>
+              </a:lnSpc>
+            </a:pPr>
+            <a:r>
+              <a:rPr lang="nl-NL" sz="1050" b="1" dirty="0" err="1">
+                <a:solidFill>
+                  <a:schemeClr val="bg1">
+                    <a:lumMod val="75000"/>
+                  </a:schemeClr>
+                </a:solidFill>
+              </a:rPr>
+              <a:t>PORTFOLIO_PERIOD_START_DATE</a:t>
+            </a:r>
+            <a:endParaRPr lang="nl-NL" sz="1050" b="1" dirty="0">
+              <a:solidFill>
+                <a:schemeClr val="bg1">
+                  <a:lumMod val="75000"/>
+                </a:schemeClr>
+              </a:solidFill>
+            </a:endParaRPr>
+          </a:p>
+        </p:txBody>
+      </p:sp>
+      <p:sp>
+        <p:nvSpPr>
+          <p:cNvPr id="63" name="TextBox 62">
+            <a:extLst>
+              <a:ext uri="{FF2B5EF4-FFF2-40B4-BE49-F238E27FC236}">
+                <a16:creationId xmlns:a16="http://schemas.microsoft.com/office/drawing/2014/main" id="{B322DB4E-35D4-2AB3-FDAB-2D94579C7E8C}"/>
+              </a:ext>
+            </a:extLst>
+          </p:cNvPr>
+          <p:cNvSpPr txBox="1"/>
+          <p:nvPr/>
+        </p:nvSpPr>
+        <p:spPr>
+          <a:xfrm>
+            <a:off x="11305651" y="10898"/>
+            <a:ext cx="1993003" cy="264816"/>
+          </a:xfrm>
+          <a:prstGeom prst="rect">
+            <a:avLst/>
+          </a:prstGeom>
+          <a:noFill/>
+        </p:spPr>
+        <p:txBody>
+          <a:bodyPr wrap="none" lIns="90000" rtlCol="0" anchor="t">
+            <a:spAutoFit/>
+          </a:bodyPr>
+          <a:lstStyle/>
+          <a:p>
+            <a:pPr>
+              <a:lnSpc>
+                <a:spcPct val="113000"/>
+              </a:lnSpc>
+            </a:pPr>
+            <a:r>
+              <a:rPr lang="nl-NL" sz="1050" b="1" dirty="0" err="1">
+                <a:solidFill>
+                  <a:schemeClr val="tx2"/>
+                </a:solidFill>
+              </a:rPr>
+              <a:t>PORTFOLIO_PERIOD_END_DATE</a:t>
+            </a:r>
+            <a:endParaRPr lang="nl-NL" sz="1050" b="1" noProof="0" dirty="0">
+              <a:solidFill>
+                <a:schemeClr val="tx2"/>
+              </a:solidFill>
+            </a:endParaRPr>
+          </a:p>
+        </p:txBody>
+      </p:sp>
+      <p:grpSp>
+        <p:nvGrpSpPr>
+          <p:cNvPr id="64" name="Group 63">
+            <a:extLst>
+              <a:ext uri="{FF2B5EF4-FFF2-40B4-BE49-F238E27FC236}">
+                <a16:creationId xmlns:a16="http://schemas.microsoft.com/office/drawing/2014/main" id="{453FAD79-26B3-4982-978D-C590116D68D9}"/>
+              </a:ext>
+            </a:extLst>
+          </p:cNvPr>
+          <p:cNvGrpSpPr>
+            <a:grpSpLocks noChangeAspect="1"/>
+          </p:cNvGrpSpPr>
+          <p:nvPr/>
+        </p:nvGrpSpPr>
+        <p:grpSpPr>
+          <a:xfrm>
+            <a:off x="-392105" y="2517185"/>
+            <a:ext cx="98115" cy="92576"/>
+            <a:chOff x="-331054" y="2564812"/>
+            <a:chExt cx="141517" cy="133528"/>
+          </a:xfrm>
+          <a:solidFill>
+            <a:srgbClr val="57C968"/>
+          </a:solidFill>
+        </p:grpSpPr>
+        <p:sp>
+          <p:nvSpPr>
+            <p:cNvPr id="65" name="Freeform 64">
+              <a:extLst>
+                <a:ext uri="{FF2B5EF4-FFF2-40B4-BE49-F238E27FC236}">
+                  <a16:creationId xmlns:a16="http://schemas.microsoft.com/office/drawing/2014/main" id="{08804C87-01D4-54E8-9068-56FE7267CE65}"/>
+                </a:ext>
+              </a:extLst>
+            </p:cNvPr>
+            <p:cNvSpPr/>
+            <p:nvPr/>
+          </p:nvSpPr>
+          <p:spPr>
+            <a:xfrm>
+              <a:off x="-331054" y="2564812"/>
+              <a:ext cx="141517" cy="82436"/>
+            </a:xfrm>
+            <a:custGeom>
+              <a:avLst/>
+              <a:gdLst>
+                <a:gd name="connsiteX0" fmla="*/ 70759 w 141517"/>
+                <a:gd name="connsiteY0" fmla="*/ 0 h 82436"/>
+                <a:gd name="connsiteX1" fmla="*/ 141517 w 141517"/>
+                <a:gd name="connsiteY1" fmla="*/ 82436 h 82436"/>
+                <a:gd name="connsiteX2" fmla="*/ 111805 w 141517"/>
+                <a:gd name="connsiteY2" fmla="*/ 82436 h 82436"/>
+                <a:gd name="connsiteX3" fmla="*/ 70759 w 141517"/>
+                <a:gd name="connsiteY3" fmla="*/ 34616 h 82436"/>
+                <a:gd name="connsiteX4" fmla="*/ 29713 w 141517"/>
+                <a:gd name="connsiteY4" fmla="*/ 82436 h 82436"/>
+                <a:gd name="connsiteX5" fmla="*/ 0 w 141517"/>
+                <a:gd name="connsiteY5" fmla="*/ 82436 h 82436"/>
+              </a:gdLst>
+              <a:ahLst/>
+              <a:cxnLst>
+                <a:cxn ang="0">
+                  <a:pos x="connsiteX0" y="connsiteY0"/>
+                </a:cxn>
+                <a:cxn ang="0">
+                  <a:pos x="connsiteX1" y="connsiteY1"/>
+                </a:cxn>
+                <a:cxn ang="0">
+                  <a:pos x="connsiteX2" y="connsiteY2"/>
+                </a:cxn>
+                <a:cxn ang="0">
+                  <a:pos x="connsiteX3" y="connsiteY3"/>
+                </a:cxn>
+                <a:cxn ang="0">
+                  <a:pos x="connsiteX4" y="connsiteY4"/>
+                </a:cxn>
+                <a:cxn ang="0">
+                  <a:pos x="connsiteX5" y="connsiteY5"/>
+                </a:cxn>
+              </a:cxnLst>
+              <a:rect l="l" t="t" r="r" b="b"/>
+              <a:pathLst>
+                <a:path w="141517" h="82436">
+                  <a:moveTo>
+                    <a:pt x="70759" y="0"/>
+                  </a:moveTo>
+                  <a:lnTo>
+                    <a:pt x="141517" y="82436"/>
+                  </a:lnTo>
+                  <a:lnTo>
+                    <a:pt x="111805" y="82436"/>
+                  </a:lnTo>
+                  <a:lnTo>
+                    <a:pt x="70759" y="34616"/>
+                  </a:lnTo>
+                  <a:lnTo>
+                    <a:pt x="29713" y="82436"/>
+                  </a:lnTo>
+                  <a:lnTo>
+                    <a:pt x="0" y="82436"/>
+                  </a:lnTo>
+                  <a:close/>
+                </a:path>
+              </a:pathLst>
+            </a:custGeom>
+            <a:grpFill/>
+            <a:ln>
+              <a:noFill/>
+            </a:ln>
+          </p:spPr>
+          <p:style>
+            <a:lnRef idx="2">
+              <a:schemeClr val="accent1">
+                <a:shade val="50000"/>
+              </a:schemeClr>
+            </a:lnRef>
+            <a:fillRef idx="1">
+              <a:schemeClr val="accent1"/>
+            </a:fillRef>
+            <a:effectRef idx="0">
+              <a:schemeClr val="accent1"/>
+            </a:effectRef>
+            <a:fontRef idx="minor">
+              <a:schemeClr val="lt1"/>
+            </a:fontRef>
+          </p:style>
+          <p:txBody>
+            <a:bodyPr wrap="square" lIns="108000" tIns="72000" rIns="108000" bIns="72000" rtlCol="0" anchor="ctr">
+              <a:noAutofit/>
+            </a:bodyPr>
+            <a:lstStyle/>
+            <a:p>
+              <a:pPr algn="ctr"/>
+              <a:endParaRPr lang="en-US" sz="1600" err="1">
+                <a:solidFill>
+                  <a:schemeClr val="bg1"/>
+                </a:solidFill>
+              </a:endParaRPr>
+            </a:p>
+          </p:txBody>
+        </p:sp>
+        <p:sp>
+          <p:nvSpPr>
+            <p:cNvPr id="66" name="Triangle 65">
+              <a:extLst>
+                <a:ext uri="{FF2B5EF4-FFF2-40B4-BE49-F238E27FC236}">
+                  <a16:creationId xmlns:a16="http://schemas.microsoft.com/office/drawing/2014/main" id="{7D4C245C-9737-17AF-E358-435BD21CEEF2}"/>
+                </a:ext>
+              </a:extLst>
+            </p:cNvPr>
+            <p:cNvSpPr/>
+            <p:nvPr/>
+          </p:nvSpPr>
+          <p:spPr>
+            <a:xfrm>
+              <a:off x="-331054" y="2615904"/>
+              <a:ext cx="141517" cy="82436"/>
+            </a:xfrm>
+            <a:prstGeom prst="triangle">
+              <a:avLst/>
+            </a:prstGeom>
+            <a:grpFill/>
+            <a:ln>
+              <a:noFill/>
+            </a:ln>
+          </p:spPr>
+          <p:style>
+            <a:lnRef idx="2">
+              <a:schemeClr val="accent1">
+                <a:shade val="50000"/>
+              </a:schemeClr>
+            </a:lnRef>
+            <a:fillRef idx="1">
+              <a:schemeClr val="accent1"/>
+            </a:fillRef>
+            <a:effectRef idx="0">
+              <a:schemeClr val="accent1"/>
+            </a:effectRef>
+            <a:fontRef idx="minor">
+              <a:schemeClr val="lt1"/>
+            </a:fontRef>
+          </p:style>
+          <p:txBody>
+            <a:bodyPr lIns="108000" tIns="72000" rIns="108000" bIns="72000" rtlCol="0" anchor="ctr"/>
+            <a:lstStyle/>
+            <a:p>
+              <a:pPr algn="ctr"/>
+              <a:endParaRPr lang="en-US" sz="1600" err="1">
+                <a:solidFill>
+                  <a:schemeClr val="bg1"/>
+                </a:solidFill>
+              </a:endParaRPr>
+            </a:p>
+          </p:txBody>
+        </p:sp>
+      </p:grpSp>
+      <p:grpSp>
+        <p:nvGrpSpPr>
+          <p:cNvPr id="67" name="Group 66">
+            <a:extLst>
+              <a:ext uri="{FF2B5EF4-FFF2-40B4-BE49-F238E27FC236}">
+                <a16:creationId xmlns:a16="http://schemas.microsoft.com/office/drawing/2014/main" id="{6BD7D30C-C1C2-93CB-3EBF-617F8C2C9532}"/>
+              </a:ext>
+            </a:extLst>
+          </p:cNvPr>
+          <p:cNvGrpSpPr>
+            <a:grpSpLocks noChangeAspect="1"/>
+          </p:cNvGrpSpPr>
+          <p:nvPr/>
+        </p:nvGrpSpPr>
+        <p:grpSpPr>
+          <a:xfrm rot="10800000">
+            <a:off x="-392106" y="2948284"/>
+            <a:ext cx="98115" cy="92576"/>
+            <a:chOff x="-331054" y="2564812"/>
+            <a:chExt cx="141517" cy="133528"/>
+          </a:xfrm>
+          <a:solidFill>
+            <a:srgbClr val="FFC000"/>
+          </a:solidFill>
+        </p:grpSpPr>
+        <p:sp>
+          <p:nvSpPr>
+            <p:cNvPr id="68" name="Freeform 67">
+              <a:extLst>
+                <a:ext uri="{FF2B5EF4-FFF2-40B4-BE49-F238E27FC236}">
+                  <a16:creationId xmlns:a16="http://schemas.microsoft.com/office/drawing/2014/main" id="{AF6FD9F3-8DA1-F1FE-9594-2A18CB71DB12}"/>
+                </a:ext>
+              </a:extLst>
+            </p:cNvPr>
+            <p:cNvSpPr/>
+            <p:nvPr/>
+          </p:nvSpPr>
+          <p:spPr>
+            <a:xfrm>
+              <a:off x="-331054" y="2564812"/>
+              <a:ext cx="141517" cy="82436"/>
+            </a:xfrm>
+            <a:custGeom>
+              <a:avLst/>
+              <a:gdLst>
+                <a:gd name="connsiteX0" fmla="*/ 70759 w 141517"/>
+                <a:gd name="connsiteY0" fmla="*/ 0 h 82436"/>
+                <a:gd name="connsiteX1" fmla="*/ 141517 w 141517"/>
+                <a:gd name="connsiteY1" fmla="*/ 82436 h 82436"/>
+                <a:gd name="connsiteX2" fmla="*/ 111805 w 141517"/>
+                <a:gd name="connsiteY2" fmla="*/ 82436 h 82436"/>
+                <a:gd name="connsiteX3" fmla="*/ 70759 w 141517"/>
+                <a:gd name="connsiteY3" fmla="*/ 34616 h 82436"/>
+                <a:gd name="connsiteX4" fmla="*/ 29713 w 141517"/>
+                <a:gd name="connsiteY4" fmla="*/ 82436 h 82436"/>
+                <a:gd name="connsiteX5" fmla="*/ 0 w 141517"/>
+                <a:gd name="connsiteY5" fmla="*/ 82436 h 82436"/>
+              </a:gdLst>
+              <a:ahLst/>
+              <a:cxnLst>
+                <a:cxn ang="0">
+                  <a:pos x="connsiteX0" y="connsiteY0"/>
+                </a:cxn>
+                <a:cxn ang="0">
+                  <a:pos x="connsiteX1" y="connsiteY1"/>
+                </a:cxn>
+                <a:cxn ang="0">
+                  <a:pos x="connsiteX2" y="connsiteY2"/>
+                </a:cxn>
+                <a:cxn ang="0">
+                  <a:pos x="connsiteX3" y="connsiteY3"/>
+                </a:cxn>
+                <a:cxn ang="0">
+                  <a:pos x="connsiteX4" y="connsiteY4"/>
+                </a:cxn>
+                <a:cxn ang="0">
+                  <a:pos x="connsiteX5" y="connsiteY5"/>
+                </a:cxn>
+              </a:cxnLst>
+              <a:rect l="l" t="t" r="r" b="b"/>
+              <a:pathLst>
+                <a:path w="141517" h="82436">
+                  <a:moveTo>
+                    <a:pt x="70759" y="0"/>
+                  </a:moveTo>
+                  <a:lnTo>
+                    <a:pt x="141517" y="82436"/>
+                  </a:lnTo>
+                  <a:lnTo>
+                    <a:pt x="111805" y="82436"/>
+                  </a:lnTo>
+                  <a:lnTo>
+                    <a:pt x="70759" y="34616"/>
+                  </a:lnTo>
+                  <a:lnTo>
+                    <a:pt x="29713" y="82436"/>
+                  </a:lnTo>
+                  <a:lnTo>
+                    <a:pt x="0" y="82436"/>
+                  </a:lnTo>
+                  <a:close/>
+                </a:path>
+              </a:pathLst>
+            </a:custGeom>
+            <a:grpFill/>
+            <a:ln>
+              <a:noFill/>
+            </a:ln>
+          </p:spPr>
+          <p:style>
+            <a:lnRef idx="2">
+              <a:schemeClr val="accent1">
+                <a:shade val="50000"/>
+              </a:schemeClr>
+            </a:lnRef>
+            <a:fillRef idx="1">
+              <a:schemeClr val="accent1"/>
+            </a:fillRef>
+            <a:effectRef idx="0">
+              <a:schemeClr val="accent1"/>
+            </a:effectRef>
+            <a:fontRef idx="minor">
+              <a:schemeClr val="lt1"/>
+            </a:fontRef>
+          </p:style>
+          <p:txBody>
+            <a:bodyPr wrap="square" lIns="108000" tIns="72000" rIns="108000" bIns="72000" rtlCol="0" anchor="ctr">
+              <a:noAutofit/>
+            </a:bodyPr>
+            <a:lstStyle/>
+            <a:p>
+              <a:pPr algn="ctr"/>
+              <a:endParaRPr lang="en-US" sz="1600" err="1">
+                <a:solidFill>
+                  <a:schemeClr val="bg1"/>
+                </a:solidFill>
+              </a:endParaRPr>
+            </a:p>
+          </p:txBody>
+        </p:sp>
+        <p:sp>
+          <p:nvSpPr>
+            <p:cNvPr id="69" name="Triangle 68">
+              <a:extLst>
+                <a:ext uri="{FF2B5EF4-FFF2-40B4-BE49-F238E27FC236}">
+                  <a16:creationId xmlns:a16="http://schemas.microsoft.com/office/drawing/2014/main" id="{9262797A-1920-B04D-0831-ECA6811546BB}"/>
+                </a:ext>
+              </a:extLst>
+            </p:cNvPr>
+            <p:cNvSpPr/>
+            <p:nvPr/>
+          </p:nvSpPr>
+          <p:spPr>
+            <a:xfrm>
+              <a:off x="-331054" y="2615904"/>
+              <a:ext cx="141517" cy="82436"/>
+            </a:xfrm>
+            <a:prstGeom prst="triangle">
+              <a:avLst/>
+            </a:prstGeom>
+            <a:grpFill/>
+            <a:ln>
+              <a:noFill/>
+            </a:ln>
+          </p:spPr>
+          <p:style>
+            <a:lnRef idx="2">
+              <a:schemeClr val="accent1">
+                <a:shade val="50000"/>
+              </a:schemeClr>
+            </a:lnRef>
+            <a:fillRef idx="1">
+              <a:schemeClr val="accent1"/>
+            </a:fillRef>
+            <a:effectRef idx="0">
+              <a:schemeClr val="accent1"/>
+            </a:effectRef>
+            <a:fontRef idx="minor">
+              <a:schemeClr val="lt1"/>
+            </a:fontRef>
+          </p:style>
+          <p:txBody>
+            <a:bodyPr lIns="108000" tIns="72000" rIns="108000" bIns="72000" rtlCol="0" anchor="ctr"/>
+            <a:lstStyle/>
+            <a:p>
+              <a:pPr algn="ctr"/>
+              <a:endParaRPr lang="en-US" sz="1600" err="1">
+                <a:solidFill>
+                  <a:schemeClr val="bg1"/>
+                </a:solidFill>
+              </a:endParaRPr>
+            </a:p>
+          </p:txBody>
+        </p:sp>
+      </p:grpSp>
+      <p:sp>
+        <p:nvSpPr>
+          <p:cNvPr id="72" name="TextBox 71">
+            <a:extLst>
+              <a:ext uri="{FF2B5EF4-FFF2-40B4-BE49-F238E27FC236}">
+                <a16:creationId xmlns:a16="http://schemas.microsoft.com/office/drawing/2014/main" id="{CC751F7C-4517-B5C9-D24B-490BDC364E63}"/>
+              </a:ext>
+            </a:extLst>
+          </p:cNvPr>
+          <p:cNvSpPr txBox="1"/>
+          <p:nvPr/>
+        </p:nvSpPr>
+        <p:spPr>
+          <a:xfrm>
+            <a:off x="9777184" y="3305030"/>
+            <a:ext cx="579667" cy="322332"/>
+          </a:xfrm>
+          <a:prstGeom prst="rect">
+            <a:avLst/>
+          </a:prstGeom>
+          <a:noFill/>
+        </p:spPr>
+        <p:txBody>
+          <a:bodyPr wrap="none" lIns="90000" rtlCol="0" anchor="t">
+            <a:spAutoFit/>
+          </a:bodyPr>
+          <a:lstStyle/>
+          <a:p>
+            <a:pPr algn="l">
+              <a:lnSpc>
+                <a:spcPct val="113000"/>
+              </a:lnSpc>
+            </a:pPr>
+            <a:r>
+              <a:rPr lang="en-US" sz="1400" b="1" dirty="0">
+                <a:solidFill>
+                  <a:schemeClr val="tx2"/>
+                </a:solidFill>
+              </a:rPr>
+              <a:t>Team</a:t>
+            </a:r>
+          </a:p>
+        </p:txBody>
+      </p:sp>
+      <p:pic>
+        <p:nvPicPr>
+          <p:cNvPr id="12" name="Graphic 11">
+            <a:extLst>
+              <a:ext uri="{FF2B5EF4-FFF2-40B4-BE49-F238E27FC236}">
+                <a16:creationId xmlns:a16="http://schemas.microsoft.com/office/drawing/2014/main" id="{F9415B8D-D15B-CD76-E298-4ECC8261967F}"/>
+              </a:ext>
+            </a:extLst>
+          </p:cNvPr>
+          <p:cNvPicPr>
+            <a:picLocks noChangeAspect="1"/>
+          </p:cNvPicPr>
+          <p:nvPr/>
+        </p:nvPicPr>
+        <p:blipFill>
+          <a:blip r:embed="rId3">
+            <a:extLst>
+              <a:ext uri="{96DAC541-7B7A-43D3-8B79-37D633B846F1}">
+                <asvg:svgBlip xmlns:asvg="http://schemas.microsoft.com/office/drawing/2016/SVG/main" r:embed="rId4"/>
+              </a:ext>
+            </a:extLst>
+          </a:blip>
+          <a:stretch>
+            <a:fillRect/>
+          </a:stretch>
+        </p:blipFill>
+        <p:spPr>
+          <a:xfrm>
+            <a:off x="8838256" y="6071736"/>
+            <a:ext cx="371130" cy="206558"/>
+          </a:xfrm>
+          <a:prstGeom prst="rect">
+            <a:avLst/>
+          </a:prstGeom>
+        </p:spPr>
+      </p:pic>
+      <p:sp>
+        <p:nvSpPr>
+          <p:cNvPr id="11" name="Rectangle 10">
+            <a:extLst>
+              <a:ext uri="{FF2B5EF4-FFF2-40B4-BE49-F238E27FC236}">
+                <a16:creationId xmlns:a16="http://schemas.microsoft.com/office/drawing/2014/main" id="{1AE5624D-19A2-5427-E6A7-6529A2C96C48}"/>
+              </a:ext>
+            </a:extLst>
+          </p:cNvPr>
+          <p:cNvSpPr/>
+          <p:nvPr/>
+        </p:nvSpPr>
+        <p:spPr>
+          <a:xfrm>
+            <a:off x="512064" y="3200400"/>
+            <a:ext cx="8750808" cy="2843784"/>
+          </a:xfrm>
+          <a:prstGeom prst="rect">
+            <a:avLst/>
+          </a:prstGeom>
+          <a:solidFill>
+            <a:srgbClr val="F0089F"/>
+          </a:solidFill>
+          <a:ln>
+            <a:noFill/>
+          </a:ln>
+        </p:spPr>
+        <p:style>
+          <a:lnRef idx="2">
+            <a:schemeClr val="accent1">
+              <a:shade val="50000"/>
+            </a:schemeClr>
+          </a:lnRef>
+          <a:fillRef idx="1">
+            <a:schemeClr val="accent1"/>
+          </a:fillRef>
+          <a:effectRef idx="0">
+            <a:schemeClr val="accent1"/>
+          </a:effectRef>
+          <a:fontRef idx="minor">
+            <a:schemeClr val="lt1"/>
+          </a:fontRef>
+        </p:style>
+        <p:txBody>
+          <a:bodyPr lIns="108000" tIns="72000" rIns="108000" bIns="72000" rtlCol="0" anchor="ctr"/>
+          <a:lstStyle/>
+          <a:p>
+            <a:pPr algn="ctr"/>
+            <a:r>
+              <a:rPr lang="en-US" sz="1600" dirty="0" err="1">
+                <a:solidFill>
+                  <a:schemeClr val="bg1"/>
+                </a:solidFill>
+              </a:rPr>
+              <a:t>PORTFOLIO_PERIOD_VOLUME_CHANGE</a:t>
+            </a:r>
+            <a:endParaRPr lang="en-US" sz="1600" dirty="0">
+              <a:solidFill>
+                <a:schemeClr val="bg1"/>
+              </a:solidFill>
+            </a:endParaRPr>
+          </a:p>
+        </p:txBody>
+      </p:sp>
+      <p:sp>
+        <p:nvSpPr>
+          <p:cNvPr id="2" name="Rectangle 1">
+            <a:extLst>
+              <a:ext uri="{FF2B5EF4-FFF2-40B4-BE49-F238E27FC236}">
+                <a16:creationId xmlns:a16="http://schemas.microsoft.com/office/drawing/2014/main" id="{A2FDACCF-411C-27FA-BBD4-078D2DB0BFE0}"/>
+              </a:ext>
+            </a:extLst>
+          </p:cNvPr>
+          <p:cNvSpPr/>
+          <p:nvPr/>
+        </p:nvSpPr>
+        <p:spPr>
+          <a:xfrm>
+            <a:off x="1250238" y="7283752"/>
+            <a:ext cx="353366" cy="333633"/>
+          </a:xfrm>
+          <a:prstGeom prst="rect">
+            <a:avLst/>
+          </a:prstGeom>
+          <a:solidFill>
+            <a:srgbClr val="F69400"/>
+          </a:solidFill>
+          <a:ln>
+            <a:noFill/>
+          </a:ln>
+        </p:spPr>
+        <p:style>
+          <a:lnRef idx="2">
+            <a:schemeClr val="accent1">
+              <a:shade val="50000"/>
+            </a:schemeClr>
+          </a:lnRef>
+          <a:fillRef idx="1">
+            <a:schemeClr val="accent1"/>
+          </a:fillRef>
+          <a:effectRef idx="0">
+            <a:schemeClr val="accent1"/>
+          </a:effectRef>
+          <a:fontRef idx="minor">
+            <a:schemeClr val="lt1"/>
+          </a:fontRef>
+        </p:style>
+        <p:txBody>
+          <a:bodyPr lIns="108000" tIns="72000" rIns="108000" bIns="72000" rtlCol="0" anchor="ctr"/>
+          <a:lstStyle/>
+          <a:p>
+            <a:pPr algn="ctr"/>
+            <a:endParaRPr lang="en-US" sz="1600" dirty="0" err="1">
+              <a:solidFill>
+                <a:schemeClr val="bg1"/>
+              </a:solidFill>
+            </a:endParaRPr>
+          </a:p>
+        </p:txBody>
+      </p:sp>
+      <p:sp>
+        <p:nvSpPr>
+          <p:cNvPr id="4" name="Rectangle 3">
+            <a:extLst>
+              <a:ext uri="{FF2B5EF4-FFF2-40B4-BE49-F238E27FC236}">
+                <a16:creationId xmlns:a16="http://schemas.microsoft.com/office/drawing/2014/main" id="{F88F8F6B-037D-C8CB-4482-D3A48B51A6D1}"/>
+              </a:ext>
+            </a:extLst>
+          </p:cNvPr>
+          <p:cNvSpPr/>
+          <p:nvPr/>
+        </p:nvSpPr>
+        <p:spPr>
+          <a:xfrm>
+            <a:off x="2184054" y="7283752"/>
+            <a:ext cx="353366" cy="333633"/>
+          </a:xfrm>
+          <a:prstGeom prst="rect">
+            <a:avLst/>
+          </a:prstGeom>
+          <a:solidFill>
+            <a:schemeClr val="bg1"/>
+          </a:solidFill>
+          <a:ln>
+            <a:noFill/>
+          </a:ln>
+        </p:spPr>
+        <p:style>
+          <a:lnRef idx="2">
+            <a:schemeClr val="accent1">
+              <a:shade val="50000"/>
+            </a:schemeClr>
+          </a:lnRef>
+          <a:fillRef idx="1">
+            <a:schemeClr val="accent1"/>
+          </a:fillRef>
+          <a:effectRef idx="0">
+            <a:schemeClr val="accent1"/>
+          </a:effectRef>
+          <a:fontRef idx="minor">
+            <a:schemeClr val="lt1"/>
+          </a:fontRef>
+        </p:style>
+        <p:txBody>
+          <a:bodyPr lIns="108000" tIns="72000" rIns="108000" bIns="72000" rtlCol="0" anchor="ctr"/>
+          <a:lstStyle/>
+          <a:p>
+            <a:pPr algn="ctr"/>
+            <a:endParaRPr lang="en-US" sz="1600" dirty="0" err="1">
+              <a:solidFill>
+                <a:schemeClr val="bg1"/>
+              </a:solidFill>
+            </a:endParaRPr>
+          </a:p>
+        </p:txBody>
+      </p:sp>
+      <p:sp>
+        <p:nvSpPr>
+          <p:cNvPr id="5" name="Rectangle 4">
+            <a:extLst>
+              <a:ext uri="{FF2B5EF4-FFF2-40B4-BE49-F238E27FC236}">
+                <a16:creationId xmlns:a16="http://schemas.microsoft.com/office/drawing/2014/main" id="{790C8805-C845-FCCC-468D-3A73CE61C6F6}"/>
+              </a:ext>
+            </a:extLst>
+          </p:cNvPr>
+          <p:cNvSpPr/>
+          <p:nvPr/>
+        </p:nvSpPr>
+        <p:spPr>
+          <a:xfrm>
+            <a:off x="3117870" y="7283752"/>
+            <a:ext cx="353366" cy="333633"/>
+          </a:xfrm>
+          <a:prstGeom prst="rect">
+            <a:avLst/>
+          </a:prstGeom>
+          <a:solidFill>
+            <a:schemeClr val="bg1"/>
+          </a:solidFill>
+          <a:ln>
+            <a:noFill/>
+          </a:ln>
+        </p:spPr>
+        <p:style>
+          <a:lnRef idx="2">
+            <a:schemeClr val="accent1">
+              <a:shade val="50000"/>
+            </a:schemeClr>
+          </a:lnRef>
+          <a:fillRef idx="1">
+            <a:schemeClr val="accent1"/>
+          </a:fillRef>
+          <a:effectRef idx="0">
+            <a:schemeClr val="accent1"/>
+          </a:effectRef>
+          <a:fontRef idx="minor">
+            <a:schemeClr val="lt1"/>
+          </a:fontRef>
+        </p:style>
+        <p:txBody>
+          <a:bodyPr lIns="108000" tIns="72000" rIns="108000" bIns="72000" rtlCol="0" anchor="ctr"/>
+          <a:lstStyle/>
+          <a:p>
+            <a:pPr algn="ctr"/>
+            <a:endParaRPr lang="en-US" sz="1600" dirty="0" err="1">
+              <a:solidFill>
+                <a:schemeClr val="bg1"/>
+              </a:solidFill>
+            </a:endParaRPr>
+          </a:p>
+        </p:txBody>
+      </p:sp>
+      <p:sp>
+        <p:nvSpPr>
+          <p:cNvPr id="13" name="Rectangle 12">
+            <a:extLst>
+              <a:ext uri="{FF2B5EF4-FFF2-40B4-BE49-F238E27FC236}">
+                <a16:creationId xmlns:a16="http://schemas.microsoft.com/office/drawing/2014/main" id="{B71D1437-7B12-0193-A1DF-96A590196EFF}"/>
+              </a:ext>
+            </a:extLst>
+          </p:cNvPr>
+          <p:cNvSpPr/>
+          <p:nvPr/>
+        </p:nvSpPr>
+        <p:spPr>
+          <a:xfrm>
+            <a:off x="4051686" y="7283752"/>
+            <a:ext cx="353366" cy="333633"/>
+          </a:xfrm>
+          <a:prstGeom prst="rect">
+            <a:avLst/>
+          </a:prstGeom>
+          <a:solidFill>
+            <a:schemeClr val="bg1"/>
+          </a:solidFill>
+          <a:ln>
+            <a:noFill/>
+          </a:ln>
+        </p:spPr>
+        <p:style>
+          <a:lnRef idx="2">
+            <a:schemeClr val="accent1">
+              <a:shade val="50000"/>
+            </a:schemeClr>
+          </a:lnRef>
+          <a:fillRef idx="1">
+            <a:schemeClr val="accent1"/>
+          </a:fillRef>
+          <a:effectRef idx="0">
+            <a:schemeClr val="accent1"/>
+          </a:effectRef>
+          <a:fontRef idx="minor">
+            <a:schemeClr val="lt1"/>
+          </a:fontRef>
+        </p:style>
+        <p:txBody>
+          <a:bodyPr lIns="108000" tIns="72000" rIns="108000" bIns="72000" rtlCol="0" anchor="ctr"/>
+          <a:lstStyle/>
+          <a:p>
+            <a:pPr algn="ctr"/>
+            <a:endParaRPr lang="en-US" sz="1600" dirty="0" err="1">
+              <a:solidFill>
+                <a:schemeClr val="bg1"/>
+              </a:solidFill>
+            </a:endParaRPr>
+          </a:p>
+        </p:txBody>
+      </p:sp>
+      <p:sp>
+        <p:nvSpPr>
+          <p:cNvPr id="14" name="Rectangle 13">
+            <a:extLst>
+              <a:ext uri="{FF2B5EF4-FFF2-40B4-BE49-F238E27FC236}">
+                <a16:creationId xmlns:a16="http://schemas.microsoft.com/office/drawing/2014/main" id="{94A400C9-59D6-7394-BC5C-3D9A63D9F567}"/>
+              </a:ext>
+            </a:extLst>
+          </p:cNvPr>
+          <p:cNvSpPr/>
+          <p:nvPr/>
+        </p:nvSpPr>
+        <p:spPr>
+          <a:xfrm>
+            <a:off x="4985502" y="7283752"/>
+            <a:ext cx="353366" cy="333633"/>
+          </a:xfrm>
+          <a:prstGeom prst="rect">
+            <a:avLst/>
+          </a:prstGeom>
+          <a:solidFill>
+            <a:srgbClr val="EFE6DA"/>
+          </a:solidFill>
+          <a:ln>
+            <a:noFill/>
+          </a:ln>
+        </p:spPr>
+        <p:style>
+          <a:lnRef idx="2">
+            <a:schemeClr val="accent1">
+              <a:shade val="50000"/>
+            </a:schemeClr>
+          </a:lnRef>
+          <a:fillRef idx="1">
+            <a:schemeClr val="accent1"/>
+          </a:fillRef>
+          <a:effectRef idx="0">
+            <a:schemeClr val="accent1"/>
+          </a:effectRef>
+          <a:fontRef idx="minor">
+            <a:schemeClr val="lt1"/>
+          </a:fontRef>
+        </p:style>
+        <p:txBody>
+          <a:bodyPr lIns="108000" tIns="72000" rIns="108000" bIns="72000" rtlCol="0" anchor="ctr"/>
+          <a:lstStyle/>
+          <a:p>
+            <a:pPr algn="ctr"/>
+            <a:endParaRPr lang="en-US" sz="1600" dirty="0" err="1">
+              <a:solidFill>
+                <a:schemeClr val="bg1"/>
+              </a:solidFill>
+            </a:endParaRPr>
+          </a:p>
+        </p:txBody>
+      </p:sp>
+      <p:sp>
+        <p:nvSpPr>
+          <p:cNvPr id="15" name="Rectangle 14">
+            <a:extLst>
+              <a:ext uri="{FF2B5EF4-FFF2-40B4-BE49-F238E27FC236}">
+                <a16:creationId xmlns:a16="http://schemas.microsoft.com/office/drawing/2014/main" id="{A8503177-3304-EE28-18F3-C435DBDA2DE5}"/>
+              </a:ext>
+            </a:extLst>
+          </p:cNvPr>
+          <p:cNvSpPr/>
+          <p:nvPr/>
+        </p:nvSpPr>
+        <p:spPr>
+          <a:xfrm>
+            <a:off x="5919318" y="7283752"/>
+            <a:ext cx="353366" cy="333633"/>
+          </a:xfrm>
+          <a:prstGeom prst="rect">
+            <a:avLst/>
+          </a:prstGeom>
+          <a:solidFill>
+            <a:srgbClr val="F7F9F8"/>
+          </a:solidFill>
+          <a:ln>
+            <a:noFill/>
+          </a:ln>
+        </p:spPr>
+        <p:style>
+          <a:lnRef idx="2">
+            <a:schemeClr val="accent1">
+              <a:shade val="50000"/>
+            </a:schemeClr>
+          </a:lnRef>
+          <a:fillRef idx="1">
+            <a:schemeClr val="accent1"/>
+          </a:fillRef>
+          <a:effectRef idx="0">
+            <a:schemeClr val="accent1"/>
+          </a:effectRef>
+          <a:fontRef idx="minor">
+            <a:schemeClr val="lt1"/>
+          </a:fontRef>
+        </p:style>
+        <p:txBody>
+          <a:bodyPr lIns="108000" tIns="72000" rIns="108000" bIns="72000" rtlCol="0" anchor="ctr"/>
+          <a:lstStyle/>
+          <a:p>
+            <a:pPr algn="ctr"/>
+            <a:endParaRPr lang="en-US" sz="1600" dirty="0" err="1">
+              <a:solidFill>
+                <a:schemeClr val="bg1"/>
+              </a:solidFill>
+            </a:endParaRPr>
+          </a:p>
+        </p:txBody>
+      </p:sp>
+      <p:sp>
+        <p:nvSpPr>
+          <p:cNvPr id="18" name="Rectangle 17">
+            <a:extLst>
+              <a:ext uri="{FF2B5EF4-FFF2-40B4-BE49-F238E27FC236}">
+                <a16:creationId xmlns:a16="http://schemas.microsoft.com/office/drawing/2014/main" id="{C550B0B0-1146-C1D1-B295-E39F9836096C}"/>
+              </a:ext>
+            </a:extLst>
+          </p:cNvPr>
+          <p:cNvSpPr/>
+          <p:nvPr/>
+        </p:nvSpPr>
+        <p:spPr>
+          <a:xfrm>
+            <a:off x="6853134" y="7283752"/>
+            <a:ext cx="353366" cy="333633"/>
+          </a:xfrm>
+          <a:prstGeom prst="rect">
+            <a:avLst/>
+          </a:prstGeom>
+          <a:solidFill>
+            <a:srgbClr val="D8E9EC"/>
+          </a:solidFill>
+          <a:ln>
+            <a:noFill/>
+          </a:ln>
+        </p:spPr>
+        <p:style>
+          <a:lnRef idx="2">
+            <a:schemeClr val="accent1">
+              <a:shade val="50000"/>
+            </a:schemeClr>
+          </a:lnRef>
+          <a:fillRef idx="1">
+            <a:schemeClr val="accent1"/>
+          </a:fillRef>
+          <a:effectRef idx="0">
+            <a:schemeClr val="accent1"/>
+          </a:effectRef>
+          <a:fontRef idx="minor">
+            <a:schemeClr val="lt1"/>
+          </a:fontRef>
+        </p:style>
+        <p:txBody>
+          <a:bodyPr lIns="108000" tIns="72000" rIns="108000" bIns="72000" rtlCol="0" anchor="ctr"/>
+          <a:lstStyle/>
+          <a:p>
+            <a:pPr algn="ctr"/>
+            <a:endParaRPr lang="en-US" sz="1600" dirty="0" err="1">
+              <a:solidFill>
+                <a:schemeClr val="bg1"/>
+              </a:solidFill>
+            </a:endParaRPr>
+          </a:p>
+        </p:txBody>
+      </p:sp>
+      <p:sp>
+        <p:nvSpPr>
+          <p:cNvPr id="19" name="Rectangle 18">
+            <a:extLst>
+              <a:ext uri="{FF2B5EF4-FFF2-40B4-BE49-F238E27FC236}">
+                <a16:creationId xmlns:a16="http://schemas.microsoft.com/office/drawing/2014/main" id="{5840F528-4469-DBF0-BD9A-B7523BE92996}"/>
+              </a:ext>
+            </a:extLst>
+          </p:cNvPr>
+          <p:cNvSpPr/>
+          <p:nvPr/>
+        </p:nvSpPr>
+        <p:spPr>
+          <a:xfrm>
+            <a:off x="7786950" y="7283752"/>
+            <a:ext cx="353366" cy="333633"/>
+          </a:xfrm>
+          <a:prstGeom prst="rect">
+            <a:avLst/>
+          </a:prstGeom>
+          <a:solidFill>
+            <a:schemeClr val="bg1"/>
+          </a:solidFill>
+          <a:ln>
+            <a:noFill/>
+          </a:ln>
+        </p:spPr>
+        <p:style>
+          <a:lnRef idx="2">
+            <a:schemeClr val="accent1">
+              <a:shade val="50000"/>
+            </a:schemeClr>
+          </a:lnRef>
+          <a:fillRef idx="1">
+            <a:schemeClr val="accent1"/>
+          </a:fillRef>
+          <a:effectRef idx="0">
+            <a:schemeClr val="accent1"/>
+          </a:effectRef>
+          <a:fontRef idx="minor">
+            <a:schemeClr val="lt1"/>
+          </a:fontRef>
+        </p:style>
+        <p:txBody>
+          <a:bodyPr lIns="108000" tIns="72000" rIns="108000" bIns="72000" rtlCol="0" anchor="ctr"/>
+          <a:lstStyle/>
+          <a:p>
+            <a:pPr algn="ctr"/>
+            <a:endParaRPr lang="en-US" sz="1600" dirty="0" err="1">
+              <a:solidFill>
+                <a:schemeClr val="bg1"/>
+              </a:solidFill>
+            </a:endParaRPr>
+          </a:p>
+        </p:txBody>
+      </p:sp>
+      <p:sp>
+        <p:nvSpPr>
+          <p:cNvPr id="20" name="Rectangle 19">
+            <a:extLst>
+              <a:ext uri="{FF2B5EF4-FFF2-40B4-BE49-F238E27FC236}">
+                <a16:creationId xmlns:a16="http://schemas.microsoft.com/office/drawing/2014/main" id="{5C8D7B00-5EE0-60D9-7256-2671E337C793}"/>
+              </a:ext>
+            </a:extLst>
+          </p:cNvPr>
+          <p:cNvSpPr/>
+          <p:nvPr/>
+        </p:nvSpPr>
+        <p:spPr>
+          <a:xfrm>
+            <a:off x="8720766" y="7283752"/>
+            <a:ext cx="353366" cy="333633"/>
+          </a:xfrm>
+          <a:prstGeom prst="rect">
+            <a:avLst/>
+          </a:prstGeom>
+          <a:solidFill>
+            <a:schemeClr val="bg1"/>
+          </a:solidFill>
+          <a:ln>
+            <a:noFill/>
+          </a:ln>
+        </p:spPr>
+        <p:style>
+          <a:lnRef idx="2">
+            <a:schemeClr val="accent1">
+              <a:shade val="50000"/>
+            </a:schemeClr>
+          </a:lnRef>
+          <a:fillRef idx="1">
+            <a:schemeClr val="accent1"/>
+          </a:fillRef>
+          <a:effectRef idx="0">
+            <a:schemeClr val="accent1"/>
+          </a:effectRef>
+          <a:fontRef idx="minor">
+            <a:schemeClr val="lt1"/>
+          </a:fontRef>
+        </p:style>
+        <p:txBody>
+          <a:bodyPr lIns="108000" tIns="72000" rIns="108000" bIns="72000" rtlCol="0" anchor="ctr"/>
+          <a:lstStyle/>
+          <a:p>
+            <a:pPr algn="ctr"/>
+            <a:endParaRPr lang="en-US" sz="1600" dirty="0" err="1">
+              <a:solidFill>
+                <a:schemeClr val="bg1"/>
+              </a:solidFill>
+            </a:endParaRPr>
+          </a:p>
+        </p:txBody>
+      </p:sp>
+      <p:sp>
+        <p:nvSpPr>
+          <p:cNvPr id="21" name="Rectangle 20">
+            <a:extLst>
+              <a:ext uri="{FF2B5EF4-FFF2-40B4-BE49-F238E27FC236}">
+                <a16:creationId xmlns:a16="http://schemas.microsoft.com/office/drawing/2014/main" id="{1CC90C5E-E776-BCBA-83EC-58AD68239D51}"/>
+              </a:ext>
+            </a:extLst>
+          </p:cNvPr>
+          <p:cNvSpPr/>
+          <p:nvPr/>
+        </p:nvSpPr>
+        <p:spPr>
+          <a:xfrm>
+            <a:off x="9654582" y="7283752"/>
+            <a:ext cx="353366" cy="333633"/>
+          </a:xfrm>
+          <a:prstGeom prst="rect">
+            <a:avLst/>
+          </a:prstGeom>
+          <a:solidFill>
+            <a:schemeClr val="bg1"/>
+          </a:solidFill>
+          <a:ln>
+            <a:noFill/>
+          </a:ln>
+        </p:spPr>
+        <p:style>
+          <a:lnRef idx="2">
+            <a:schemeClr val="accent1">
+              <a:shade val="50000"/>
+            </a:schemeClr>
+          </a:lnRef>
+          <a:fillRef idx="1">
+            <a:schemeClr val="accent1"/>
+          </a:fillRef>
+          <a:effectRef idx="0">
+            <a:schemeClr val="accent1"/>
+          </a:effectRef>
+          <a:fontRef idx="minor">
+            <a:schemeClr val="lt1"/>
+          </a:fontRef>
+        </p:style>
+        <p:txBody>
+          <a:bodyPr lIns="108000" tIns="72000" rIns="108000" bIns="72000" rtlCol="0" anchor="ctr"/>
+          <a:lstStyle/>
+          <a:p>
+            <a:pPr algn="ctr"/>
+            <a:endParaRPr lang="en-US" sz="1600" dirty="0" err="1">
+              <a:solidFill>
+                <a:schemeClr val="bg1"/>
+              </a:solidFill>
+            </a:endParaRPr>
+          </a:p>
+        </p:txBody>
+      </p:sp>
+      <p:sp>
+        <p:nvSpPr>
+          <p:cNvPr id="22" name="Rectangle 21">
+            <a:extLst>
+              <a:ext uri="{FF2B5EF4-FFF2-40B4-BE49-F238E27FC236}">
+                <a16:creationId xmlns:a16="http://schemas.microsoft.com/office/drawing/2014/main" id="{F8036F1E-4ACB-B76C-8626-F436F31EE77B}"/>
+              </a:ext>
+            </a:extLst>
+          </p:cNvPr>
+          <p:cNvSpPr/>
+          <p:nvPr/>
+        </p:nvSpPr>
+        <p:spPr>
+          <a:xfrm>
+            <a:off x="10588396" y="7283752"/>
+            <a:ext cx="353366" cy="333633"/>
+          </a:xfrm>
+          <a:prstGeom prst="rect">
+            <a:avLst/>
+          </a:prstGeom>
+          <a:solidFill>
+            <a:srgbClr val="58B8CC"/>
+          </a:solidFill>
+          <a:ln>
+            <a:noFill/>
+          </a:ln>
+        </p:spPr>
+        <p:style>
+          <a:lnRef idx="2">
+            <a:schemeClr val="accent1">
+              <a:shade val="50000"/>
+            </a:schemeClr>
+          </a:lnRef>
+          <a:fillRef idx="1">
+            <a:schemeClr val="accent1"/>
+          </a:fillRef>
+          <a:effectRef idx="0">
+            <a:schemeClr val="accent1"/>
+          </a:effectRef>
+          <a:fontRef idx="minor">
+            <a:schemeClr val="lt1"/>
+          </a:fontRef>
+        </p:style>
+        <p:txBody>
+          <a:bodyPr lIns="108000" tIns="72000" rIns="108000" bIns="72000" rtlCol="0" anchor="ctr"/>
+          <a:lstStyle/>
+          <a:p>
+            <a:pPr algn="ctr"/>
+            <a:endParaRPr lang="en-US" sz="1600" dirty="0" err="1">
+              <a:solidFill>
+                <a:schemeClr val="bg1"/>
+              </a:solidFill>
+            </a:endParaRPr>
+          </a:p>
+        </p:txBody>
+      </p:sp>
+      <p:sp>
+        <p:nvSpPr>
+          <p:cNvPr id="23" name="TextBox 22">
+            <a:extLst>
+              <a:ext uri="{FF2B5EF4-FFF2-40B4-BE49-F238E27FC236}">
+                <a16:creationId xmlns:a16="http://schemas.microsoft.com/office/drawing/2014/main" id="{DCE0B2B8-5161-B8B3-C2F7-8B3609ABB1FC}"/>
+              </a:ext>
+            </a:extLst>
+          </p:cNvPr>
+          <p:cNvSpPr txBox="1"/>
+          <p:nvPr/>
+        </p:nvSpPr>
+        <p:spPr>
+          <a:xfrm>
+            <a:off x="1016317" y="7795967"/>
+            <a:ext cx="821207" cy="355162"/>
+          </a:xfrm>
+          <a:prstGeom prst="rect">
+            <a:avLst/>
+          </a:prstGeom>
+          <a:noFill/>
+        </p:spPr>
+        <p:txBody>
+          <a:bodyPr wrap="none" lIns="90000" rtlCol="0" anchor="t">
+            <a:spAutoFit/>
+          </a:bodyPr>
+          <a:lstStyle/>
+          <a:p>
+            <a:pPr algn="ctr">
+              <a:lnSpc>
+                <a:spcPct val="113000"/>
+              </a:lnSpc>
+            </a:pPr>
+            <a:r>
+              <a:rPr lang="en-US" sz="1600" dirty="0">
+                <a:solidFill>
+                  <a:schemeClr val="tx2"/>
+                </a:solidFill>
+              </a:rPr>
+              <a:t>E89936</a:t>
+            </a:r>
+          </a:p>
+        </p:txBody>
+      </p:sp>
+      <p:sp>
+        <p:nvSpPr>
+          <p:cNvPr id="24" name="TextBox 23">
+            <a:extLst>
+              <a:ext uri="{FF2B5EF4-FFF2-40B4-BE49-F238E27FC236}">
+                <a16:creationId xmlns:a16="http://schemas.microsoft.com/office/drawing/2014/main" id="{0D6E5742-5196-1802-81AE-D4F0F712009E}"/>
+              </a:ext>
+            </a:extLst>
+          </p:cNvPr>
+          <p:cNvSpPr txBox="1"/>
+          <p:nvPr/>
+        </p:nvSpPr>
+        <p:spPr>
+          <a:xfrm>
+            <a:off x="2191705" y="7795967"/>
+            <a:ext cx="548697" cy="355162"/>
+          </a:xfrm>
+          <a:prstGeom prst="rect">
+            <a:avLst/>
+          </a:prstGeom>
+          <a:noFill/>
+        </p:spPr>
+        <p:txBody>
+          <a:bodyPr wrap="none" lIns="90000" rtlCol="0" anchor="t">
+            <a:spAutoFit/>
+          </a:bodyPr>
+          <a:lstStyle/>
+          <a:p>
+            <a:pPr algn="ctr">
+              <a:lnSpc>
+                <a:spcPct val="113000"/>
+              </a:lnSpc>
+            </a:pPr>
+            <a:r>
+              <a:rPr lang="en-US" sz="1600" dirty="0">
+                <a:solidFill>
+                  <a:schemeClr val="tx2"/>
+                </a:solidFill>
+              </a:rPr>
+              <a:t>@@</a:t>
+            </a:r>
+          </a:p>
+        </p:txBody>
+      </p:sp>
+      <p:sp>
+        <p:nvSpPr>
+          <p:cNvPr id="25" name="TextBox 24">
+            <a:extLst>
+              <a:ext uri="{FF2B5EF4-FFF2-40B4-BE49-F238E27FC236}">
+                <a16:creationId xmlns:a16="http://schemas.microsoft.com/office/drawing/2014/main" id="{5DB28342-516A-64C9-2577-7ACBB2DD74D0}"/>
+              </a:ext>
+            </a:extLst>
+          </p:cNvPr>
+          <p:cNvSpPr txBox="1"/>
+          <p:nvPr/>
+        </p:nvSpPr>
+        <p:spPr>
+          <a:xfrm>
+            <a:off x="10354476" y="7795967"/>
+            <a:ext cx="821207" cy="355162"/>
+          </a:xfrm>
+          <a:prstGeom prst="rect">
+            <a:avLst/>
+          </a:prstGeom>
+          <a:noFill/>
+        </p:spPr>
+        <p:txBody>
+          <a:bodyPr wrap="none" lIns="90000" rtlCol="0" anchor="t">
+            <a:spAutoFit/>
+          </a:bodyPr>
+          <a:lstStyle/>
+          <a:p>
+            <a:pPr algn="ctr">
+              <a:lnSpc>
+                <a:spcPct val="113000"/>
+              </a:lnSpc>
+            </a:pPr>
+            <a:r>
+              <a:rPr lang="en-US" sz="1600" dirty="0">
+                <a:solidFill>
+                  <a:schemeClr val="tx2"/>
+                </a:solidFill>
+              </a:rPr>
+              <a:t>71B6C9</a:t>
+            </a:r>
+          </a:p>
+        </p:txBody>
+      </p:sp>
+      <p:sp>
+        <p:nvSpPr>
+          <p:cNvPr id="26" name="TextBox 25">
+            <a:extLst>
+              <a:ext uri="{FF2B5EF4-FFF2-40B4-BE49-F238E27FC236}">
+                <a16:creationId xmlns:a16="http://schemas.microsoft.com/office/drawing/2014/main" id="{42F01AB8-21D9-ACA7-C061-24D7AE18314B}"/>
+              </a:ext>
+            </a:extLst>
+          </p:cNvPr>
+          <p:cNvSpPr txBox="1"/>
+          <p:nvPr/>
+        </p:nvSpPr>
+        <p:spPr>
+          <a:xfrm>
+            <a:off x="3997461" y="7795967"/>
+            <a:ext cx="548697" cy="355162"/>
+          </a:xfrm>
+          <a:prstGeom prst="rect">
+            <a:avLst/>
+          </a:prstGeom>
+          <a:noFill/>
+        </p:spPr>
+        <p:txBody>
+          <a:bodyPr wrap="none" lIns="90000" rtlCol="0" anchor="t">
+            <a:spAutoFit/>
+          </a:bodyPr>
+          <a:lstStyle/>
+          <a:p>
+            <a:pPr algn="ctr">
+              <a:lnSpc>
+                <a:spcPct val="113000"/>
+              </a:lnSpc>
+            </a:pPr>
+            <a:r>
+              <a:rPr lang="en-US" sz="1600" dirty="0">
+                <a:solidFill>
+                  <a:schemeClr val="tx2"/>
+                </a:solidFill>
+              </a:rPr>
+              <a:t>@@</a:t>
+            </a:r>
+          </a:p>
+        </p:txBody>
+      </p:sp>
+      <p:sp>
+        <p:nvSpPr>
+          <p:cNvPr id="27" name="TextBox 26">
+            <a:extLst>
+              <a:ext uri="{FF2B5EF4-FFF2-40B4-BE49-F238E27FC236}">
+                <a16:creationId xmlns:a16="http://schemas.microsoft.com/office/drawing/2014/main" id="{E9B3A48E-4D8B-D6D9-7A0E-97078C12B47E}"/>
+              </a:ext>
+            </a:extLst>
+          </p:cNvPr>
+          <p:cNvSpPr txBox="1"/>
+          <p:nvPr/>
+        </p:nvSpPr>
+        <p:spPr>
+          <a:xfrm>
+            <a:off x="3094584" y="7795967"/>
+            <a:ext cx="548697" cy="355162"/>
+          </a:xfrm>
+          <a:prstGeom prst="rect">
+            <a:avLst/>
+          </a:prstGeom>
+          <a:noFill/>
+        </p:spPr>
+        <p:txBody>
+          <a:bodyPr wrap="none" lIns="90000" rtlCol="0" anchor="t">
+            <a:spAutoFit/>
+          </a:bodyPr>
+          <a:lstStyle/>
+          <a:p>
+            <a:pPr algn="ctr">
+              <a:lnSpc>
+                <a:spcPct val="113000"/>
+              </a:lnSpc>
+            </a:pPr>
+            <a:r>
+              <a:rPr lang="en-US" sz="1600" dirty="0">
+                <a:solidFill>
+                  <a:schemeClr val="tx2"/>
+                </a:solidFill>
+              </a:rPr>
+              <a:t>@@</a:t>
+            </a:r>
+          </a:p>
+        </p:txBody>
+      </p:sp>
+      <p:sp>
+        <p:nvSpPr>
+          <p:cNvPr id="29" name="TextBox 28">
+            <a:extLst>
+              <a:ext uri="{FF2B5EF4-FFF2-40B4-BE49-F238E27FC236}">
+                <a16:creationId xmlns:a16="http://schemas.microsoft.com/office/drawing/2014/main" id="{689CCD63-0F65-592D-CE91-8C09FE5930F3}"/>
+              </a:ext>
+            </a:extLst>
+          </p:cNvPr>
+          <p:cNvSpPr txBox="1"/>
+          <p:nvPr/>
+        </p:nvSpPr>
+        <p:spPr>
+          <a:xfrm>
+            <a:off x="4747253" y="7795967"/>
+            <a:ext cx="854871" cy="355162"/>
+          </a:xfrm>
+          <a:prstGeom prst="rect">
+            <a:avLst/>
+          </a:prstGeom>
+          <a:noFill/>
+        </p:spPr>
+        <p:txBody>
+          <a:bodyPr wrap="none" lIns="90000" rtlCol="0" anchor="t">
+            <a:spAutoFit/>
+          </a:bodyPr>
+          <a:lstStyle/>
+          <a:p>
+            <a:pPr algn="ctr">
+              <a:lnSpc>
+                <a:spcPct val="113000"/>
+              </a:lnSpc>
+            </a:pPr>
+            <a:r>
+              <a:rPr lang="en-US" sz="1600" dirty="0">
+                <a:solidFill>
+                  <a:schemeClr val="tx2"/>
+                </a:solidFill>
+              </a:rPr>
+              <a:t>EDE6DB</a:t>
+            </a:r>
+          </a:p>
+        </p:txBody>
+      </p:sp>
+      <p:sp>
+        <p:nvSpPr>
+          <p:cNvPr id="30" name="TextBox 29">
+            <a:extLst>
+              <a:ext uri="{FF2B5EF4-FFF2-40B4-BE49-F238E27FC236}">
+                <a16:creationId xmlns:a16="http://schemas.microsoft.com/office/drawing/2014/main" id="{0CFA9813-9287-05F5-D861-7701EF1F0628}"/>
+              </a:ext>
+            </a:extLst>
+          </p:cNvPr>
+          <p:cNvSpPr txBox="1"/>
+          <p:nvPr/>
+        </p:nvSpPr>
+        <p:spPr>
+          <a:xfrm>
+            <a:off x="6560222" y="7795967"/>
+            <a:ext cx="840444" cy="355162"/>
+          </a:xfrm>
+          <a:prstGeom prst="rect">
+            <a:avLst/>
+          </a:prstGeom>
+          <a:noFill/>
+        </p:spPr>
+        <p:txBody>
+          <a:bodyPr wrap="none" lIns="90000" rtlCol="0" anchor="t">
+            <a:spAutoFit/>
+          </a:bodyPr>
+          <a:lstStyle/>
+          <a:p>
+            <a:pPr algn="ctr">
+              <a:lnSpc>
+                <a:spcPct val="113000"/>
+              </a:lnSpc>
+            </a:pPr>
+            <a:r>
+              <a:rPr lang="en-US" sz="1600">
+                <a:solidFill>
+                  <a:schemeClr val="tx2"/>
+                </a:solidFill>
+              </a:rPr>
+              <a:t>DBE8EB</a:t>
+            </a:r>
+            <a:endParaRPr lang="en-US" sz="1600" dirty="0">
+              <a:solidFill>
+                <a:schemeClr val="tx2"/>
+              </a:solidFill>
+            </a:endParaRPr>
+          </a:p>
+        </p:txBody>
+      </p:sp>
+      <p:sp>
+        <p:nvSpPr>
+          <p:cNvPr id="31" name="TextBox 30">
+            <a:extLst>
+              <a:ext uri="{FF2B5EF4-FFF2-40B4-BE49-F238E27FC236}">
+                <a16:creationId xmlns:a16="http://schemas.microsoft.com/office/drawing/2014/main" id="{67EAE6E1-E5B9-A437-9A45-839DFD4245EE}"/>
+              </a:ext>
+            </a:extLst>
+          </p:cNvPr>
+          <p:cNvSpPr txBox="1"/>
+          <p:nvPr/>
+        </p:nvSpPr>
+        <p:spPr>
+          <a:xfrm>
+            <a:off x="5687801" y="7795967"/>
+            <a:ext cx="779529" cy="355162"/>
+          </a:xfrm>
+          <a:prstGeom prst="rect">
+            <a:avLst/>
+          </a:prstGeom>
+          <a:noFill/>
+        </p:spPr>
+        <p:txBody>
+          <a:bodyPr wrap="none" lIns="90000" rtlCol="0" anchor="t">
+            <a:spAutoFit/>
+          </a:bodyPr>
+          <a:lstStyle/>
+          <a:p>
+            <a:pPr algn="ctr">
+              <a:lnSpc>
+                <a:spcPct val="113000"/>
+              </a:lnSpc>
+            </a:pPr>
+            <a:r>
+              <a:rPr lang="en-US" sz="1600" dirty="0">
+                <a:solidFill>
+                  <a:schemeClr val="tx2"/>
+                </a:solidFill>
+              </a:rPr>
+              <a:t>F8F8F8</a:t>
+            </a:r>
+          </a:p>
+        </p:txBody>
+      </p:sp>
+      <p:sp>
+        <p:nvSpPr>
+          <p:cNvPr id="59" name="TextBox 58">
+            <a:extLst>
+              <a:ext uri="{FF2B5EF4-FFF2-40B4-BE49-F238E27FC236}">
+                <a16:creationId xmlns:a16="http://schemas.microsoft.com/office/drawing/2014/main" id="{FFBDD5D6-BDE5-11E3-4A2F-8C61BCDF5872}"/>
+              </a:ext>
+            </a:extLst>
+          </p:cNvPr>
+          <p:cNvSpPr txBox="1"/>
+          <p:nvPr/>
+        </p:nvSpPr>
+        <p:spPr>
+          <a:xfrm>
+            <a:off x="8350654" y="7795967"/>
+            <a:ext cx="871092" cy="355162"/>
+          </a:xfrm>
+          <a:prstGeom prst="rect">
+            <a:avLst/>
+          </a:prstGeom>
+          <a:noFill/>
+        </p:spPr>
+        <p:txBody>
+          <a:bodyPr wrap="none" lIns="90000" rtlCol="0" anchor="t">
+            <a:spAutoFit/>
+          </a:bodyPr>
+          <a:lstStyle/>
+          <a:p>
+            <a:pPr algn="ctr">
+              <a:lnSpc>
+                <a:spcPct val="113000"/>
+              </a:lnSpc>
+            </a:pPr>
+            <a:r>
+              <a:rPr lang="en-US" sz="1600" dirty="0">
+                <a:solidFill>
+                  <a:schemeClr val="tx2"/>
+                </a:solidFill>
+              </a:rPr>
+              <a:t>A6DAA7</a:t>
+            </a:r>
+          </a:p>
+        </p:txBody>
+      </p:sp>
+      <p:sp>
+        <p:nvSpPr>
+          <p:cNvPr id="70" name="TextBox 69">
+            <a:extLst>
+              <a:ext uri="{FF2B5EF4-FFF2-40B4-BE49-F238E27FC236}">
+                <a16:creationId xmlns:a16="http://schemas.microsoft.com/office/drawing/2014/main" id="{8BE26167-74AB-CC0A-DA60-831BB1B791FF}"/>
+              </a:ext>
+            </a:extLst>
+          </p:cNvPr>
+          <p:cNvSpPr txBox="1"/>
+          <p:nvPr/>
+        </p:nvSpPr>
+        <p:spPr>
+          <a:xfrm>
+            <a:off x="7608973" y="7795967"/>
+            <a:ext cx="548697" cy="355162"/>
+          </a:xfrm>
+          <a:prstGeom prst="rect">
+            <a:avLst/>
+          </a:prstGeom>
+          <a:noFill/>
+        </p:spPr>
+        <p:txBody>
+          <a:bodyPr wrap="none" lIns="90000" rtlCol="0" anchor="t">
+            <a:spAutoFit/>
+          </a:bodyPr>
+          <a:lstStyle/>
+          <a:p>
+            <a:pPr algn="ctr">
+              <a:lnSpc>
+                <a:spcPct val="113000"/>
+              </a:lnSpc>
+            </a:pPr>
+            <a:r>
+              <a:rPr lang="en-US" sz="1600" dirty="0">
+                <a:solidFill>
+                  <a:schemeClr val="tx2"/>
+                </a:solidFill>
+              </a:rPr>
+              <a:t>@@</a:t>
+            </a:r>
+          </a:p>
+        </p:txBody>
+      </p:sp>
+      <p:sp>
+        <p:nvSpPr>
+          <p:cNvPr id="71" name="TextBox 70">
+            <a:extLst>
+              <a:ext uri="{FF2B5EF4-FFF2-40B4-BE49-F238E27FC236}">
+                <a16:creationId xmlns:a16="http://schemas.microsoft.com/office/drawing/2014/main" id="{ACB144E7-F79E-1B66-500E-AA10E537F6C7}"/>
+              </a:ext>
+            </a:extLst>
+          </p:cNvPr>
+          <p:cNvSpPr txBox="1"/>
+          <p:nvPr/>
+        </p:nvSpPr>
+        <p:spPr>
+          <a:xfrm>
+            <a:off x="9414729" y="7795967"/>
+            <a:ext cx="548697" cy="355162"/>
+          </a:xfrm>
+          <a:prstGeom prst="rect">
+            <a:avLst/>
+          </a:prstGeom>
+          <a:noFill/>
+        </p:spPr>
+        <p:txBody>
+          <a:bodyPr wrap="none" lIns="90000" rtlCol="0" anchor="t">
+            <a:spAutoFit/>
+          </a:bodyPr>
+          <a:lstStyle/>
+          <a:p>
+            <a:pPr algn="ctr">
+              <a:lnSpc>
+                <a:spcPct val="113000"/>
+              </a:lnSpc>
+            </a:pPr>
+            <a:r>
+              <a:rPr lang="en-US" sz="1600" dirty="0">
+                <a:solidFill>
+                  <a:schemeClr val="tx2"/>
+                </a:solidFill>
+              </a:rPr>
+              <a:t>@@</a:t>
+            </a:r>
+          </a:p>
+        </p:txBody>
+      </p:sp>
+      <p:sp>
+        <p:nvSpPr>
+          <p:cNvPr id="73" name="TextBox 72">
+            <a:extLst>
+              <a:ext uri="{FF2B5EF4-FFF2-40B4-BE49-F238E27FC236}">
+                <a16:creationId xmlns:a16="http://schemas.microsoft.com/office/drawing/2014/main" id="{150380C7-E952-85A6-1AE2-B3B2DD1481A4}"/>
+              </a:ext>
+            </a:extLst>
+          </p:cNvPr>
+          <p:cNvSpPr txBox="1"/>
+          <p:nvPr/>
+        </p:nvSpPr>
+        <p:spPr>
+          <a:xfrm>
+            <a:off x="1996335" y="6054740"/>
+            <a:ext cx="1276460" cy="223844"/>
+          </a:xfrm>
+          <a:prstGeom prst="rect">
+            <a:avLst/>
+          </a:prstGeom>
+          <a:noFill/>
+        </p:spPr>
+        <p:txBody>
+          <a:bodyPr wrap="none" lIns="90000" rtlCol="0" anchor="t">
+            <a:spAutoFit/>
+          </a:bodyPr>
+          <a:lstStyle/>
+          <a:p>
+            <a:pPr algn="l">
+              <a:lnSpc>
+                <a:spcPct val="113000"/>
+              </a:lnSpc>
+            </a:pPr>
+            <a:r>
+              <a:rPr lang="en-US" sz="800" dirty="0">
+                <a:solidFill>
+                  <a:schemeClr val="accent3"/>
+                </a:solidFill>
+              </a:rPr>
+              <a:t>Systems grouped by </a:t>
+            </a:r>
+            <a:r>
+              <a:rPr lang="en-US" sz="800" b="1" dirty="0">
+                <a:solidFill>
+                  <a:schemeClr val="accent3"/>
+                </a:solidFill>
+              </a:rPr>
+              <a:t>Team</a:t>
+            </a:r>
+          </a:p>
+        </p:txBody>
+      </p:sp>
+      <p:sp>
+        <p:nvSpPr>
+          <p:cNvPr id="74" name="Rounded Rectangle 73">
+            <a:extLst>
+              <a:ext uri="{FF2B5EF4-FFF2-40B4-BE49-F238E27FC236}">
+                <a16:creationId xmlns:a16="http://schemas.microsoft.com/office/drawing/2014/main" id="{59104847-769B-8437-1755-175EFDCB9FDF}"/>
+              </a:ext>
+            </a:extLst>
+          </p:cNvPr>
+          <p:cNvSpPr>
+            <a:spLocks noChangeAspect="1"/>
+          </p:cNvSpPr>
+          <p:nvPr/>
+        </p:nvSpPr>
+        <p:spPr>
+          <a:xfrm>
+            <a:off x="879122" y="6118505"/>
+            <a:ext cx="91440" cy="91440"/>
+          </a:xfrm>
+          <a:prstGeom prst="roundRect">
+            <a:avLst/>
+          </a:prstGeom>
+          <a:solidFill>
+            <a:srgbClr val="F69400"/>
+          </a:solidFill>
+          <a:ln>
+            <a:noFill/>
+          </a:ln>
+        </p:spPr>
+        <p:style>
+          <a:lnRef idx="2">
+            <a:schemeClr val="accent1">
+              <a:shade val="50000"/>
+            </a:schemeClr>
+          </a:lnRef>
+          <a:fillRef idx="1">
+            <a:schemeClr val="accent1"/>
+          </a:fillRef>
+          <a:effectRef idx="0">
+            <a:schemeClr val="accent1"/>
+          </a:effectRef>
+          <a:fontRef idx="minor">
+            <a:schemeClr val="lt1"/>
+          </a:fontRef>
+        </p:style>
+        <p:txBody>
+          <a:bodyPr lIns="108000" tIns="72000" rIns="108000" bIns="72000" rtlCol="0" anchor="ctr"/>
+          <a:lstStyle/>
+          <a:p>
+            <a:pPr algn="ctr"/>
+            <a:endParaRPr lang="en-US" sz="1600" dirty="0" err="1">
+              <a:solidFill>
+                <a:schemeClr val="bg1"/>
+              </a:solidFill>
+            </a:endParaRPr>
+          </a:p>
+        </p:txBody>
+      </p:sp>
+      <p:sp>
+        <p:nvSpPr>
+          <p:cNvPr id="75" name="Rounded Rectangle 74">
+            <a:extLst>
+              <a:ext uri="{FF2B5EF4-FFF2-40B4-BE49-F238E27FC236}">
+                <a16:creationId xmlns:a16="http://schemas.microsoft.com/office/drawing/2014/main" id="{094EB900-65EE-BC99-0D51-4E0EC2BBCAC1}"/>
+              </a:ext>
+            </a:extLst>
+          </p:cNvPr>
+          <p:cNvSpPr>
+            <a:spLocks noChangeAspect="1"/>
+          </p:cNvSpPr>
+          <p:nvPr/>
+        </p:nvSpPr>
+        <p:spPr>
+          <a:xfrm>
+            <a:off x="1038992" y="6118505"/>
+            <a:ext cx="91440" cy="91440"/>
+          </a:xfrm>
+          <a:prstGeom prst="roundRect">
+            <a:avLst/>
+          </a:prstGeom>
+          <a:solidFill>
+            <a:srgbClr val="EFE6DA"/>
+          </a:solidFill>
+          <a:ln>
+            <a:noFill/>
+          </a:ln>
+        </p:spPr>
+        <p:style>
+          <a:lnRef idx="2">
+            <a:schemeClr val="accent1">
+              <a:shade val="50000"/>
+            </a:schemeClr>
+          </a:lnRef>
+          <a:fillRef idx="1">
+            <a:schemeClr val="accent1"/>
+          </a:fillRef>
+          <a:effectRef idx="0">
+            <a:schemeClr val="accent1"/>
+          </a:effectRef>
+          <a:fontRef idx="minor">
+            <a:schemeClr val="lt1"/>
+          </a:fontRef>
+        </p:style>
+        <p:txBody>
+          <a:bodyPr lIns="108000" tIns="72000" rIns="108000" bIns="72000" rtlCol="0" anchor="ctr"/>
+          <a:lstStyle/>
+          <a:p>
+            <a:pPr algn="ctr"/>
+            <a:endParaRPr lang="en-US" sz="1600" dirty="0" err="1">
+              <a:solidFill>
+                <a:schemeClr val="bg1"/>
+              </a:solidFill>
+            </a:endParaRPr>
+          </a:p>
+        </p:txBody>
+      </p:sp>
+      <p:sp>
+        <p:nvSpPr>
+          <p:cNvPr id="76" name="Rounded Rectangle 75">
+            <a:extLst>
+              <a:ext uri="{FF2B5EF4-FFF2-40B4-BE49-F238E27FC236}">
+                <a16:creationId xmlns:a16="http://schemas.microsoft.com/office/drawing/2014/main" id="{389CFB48-4110-5C21-AAC2-B369130A2214}"/>
+              </a:ext>
+            </a:extLst>
+          </p:cNvPr>
+          <p:cNvSpPr>
+            <a:spLocks noChangeAspect="1"/>
+          </p:cNvSpPr>
+          <p:nvPr/>
+        </p:nvSpPr>
+        <p:spPr>
+          <a:xfrm>
+            <a:off x="1198862" y="6118505"/>
+            <a:ext cx="91440" cy="91440"/>
+          </a:xfrm>
+          <a:prstGeom prst="roundRect">
+            <a:avLst/>
+          </a:prstGeom>
+          <a:solidFill>
+            <a:srgbClr val="F7F9F8"/>
+          </a:solidFill>
+          <a:ln>
+            <a:noFill/>
+          </a:ln>
+        </p:spPr>
+        <p:style>
+          <a:lnRef idx="2">
+            <a:schemeClr val="accent1">
+              <a:shade val="50000"/>
+            </a:schemeClr>
+          </a:lnRef>
+          <a:fillRef idx="1">
+            <a:schemeClr val="accent1"/>
+          </a:fillRef>
+          <a:effectRef idx="0">
+            <a:schemeClr val="accent1"/>
+          </a:effectRef>
+          <a:fontRef idx="minor">
+            <a:schemeClr val="lt1"/>
+          </a:fontRef>
+        </p:style>
+        <p:txBody>
+          <a:bodyPr lIns="108000" tIns="72000" rIns="108000" bIns="72000" rtlCol="0" anchor="ctr"/>
+          <a:lstStyle/>
+          <a:p>
+            <a:pPr algn="ctr"/>
+            <a:endParaRPr lang="en-US" sz="1600" dirty="0" err="1">
+              <a:solidFill>
+                <a:schemeClr val="bg1"/>
+              </a:solidFill>
+            </a:endParaRPr>
+          </a:p>
+        </p:txBody>
+      </p:sp>
+      <p:sp>
+        <p:nvSpPr>
+          <p:cNvPr id="77" name="Rounded Rectangle 76">
+            <a:extLst>
+              <a:ext uri="{FF2B5EF4-FFF2-40B4-BE49-F238E27FC236}">
+                <a16:creationId xmlns:a16="http://schemas.microsoft.com/office/drawing/2014/main" id="{7A857DDB-57EA-245B-6D2D-490CBAEF0CD0}"/>
+              </a:ext>
+            </a:extLst>
+          </p:cNvPr>
+          <p:cNvSpPr>
+            <a:spLocks noChangeAspect="1"/>
+          </p:cNvSpPr>
+          <p:nvPr/>
+        </p:nvSpPr>
+        <p:spPr>
+          <a:xfrm>
+            <a:off x="1358732" y="6118505"/>
+            <a:ext cx="91440" cy="91440"/>
+          </a:xfrm>
+          <a:prstGeom prst="roundRect">
+            <a:avLst/>
+          </a:prstGeom>
+          <a:solidFill>
+            <a:srgbClr val="D8E9EC"/>
+          </a:solidFill>
+          <a:ln>
+            <a:noFill/>
+          </a:ln>
+        </p:spPr>
+        <p:style>
+          <a:lnRef idx="2">
+            <a:schemeClr val="accent1">
+              <a:shade val="50000"/>
+            </a:schemeClr>
+          </a:lnRef>
+          <a:fillRef idx="1">
+            <a:schemeClr val="accent1"/>
+          </a:fillRef>
+          <a:effectRef idx="0">
+            <a:schemeClr val="accent1"/>
+          </a:effectRef>
+          <a:fontRef idx="minor">
+            <a:schemeClr val="lt1"/>
+          </a:fontRef>
+        </p:style>
+        <p:txBody>
+          <a:bodyPr lIns="108000" tIns="72000" rIns="108000" bIns="72000" rtlCol="0" anchor="ctr"/>
+          <a:lstStyle/>
+          <a:p>
+            <a:pPr algn="ctr"/>
+            <a:endParaRPr lang="en-US" sz="1600" dirty="0" err="1">
+              <a:solidFill>
+                <a:schemeClr val="bg1"/>
+              </a:solidFill>
+            </a:endParaRPr>
+          </a:p>
+        </p:txBody>
+      </p:sp>
+      <p:sp>
+        <p:nvSpPr>
+          <p:cNvPr id="78" name="Rounded Rectangle 77">
+            <a:extLst>
+              <a:ext uri="{FF2B5EF4-FFF2-40B4-BE49-F238E27FC236}">
+                <a16:creationId xmlns:a16="http://schemas.microsoft.com/office/drawing/2014/main" id="{48865371-B36B-5B6E-7714-7ACC2FA510F7}"/>
+              </a:ext>
+            </a:extLst>
+          </p:cNvPr>
+          <p:cNvSpPr>
+            <a:spLocks noChangeAspect="1"/>
+          </p:cNvSpPr>
+          <p:nvPr/>
+        </p:nvSpPr>
+        <p:spPr>
+          <a:xfrm>
+            <a:off x="1518602" y="6118505"/>
+            <a:ext cx="91440" cy="91440"/>
+          </a:xfrm>
+          <a:prstGeom prst="roundRect">
+            <a:avLst/>
+          </a:prstGeom>
+          <a:solidFill>
+            <a:srgbClr val="58B8CC"/>
+          </a:solidFill>
+          <a:ln>
+            <a:noFill/>
+          </a:ln>
+        </p:spPr>
+        <p:style>
+          <a:lnRef idx="2">
+            <a:schemeClr val="accent1">
+              <a:shade val="50000"/>
+            </a:schemeClr>
+          </a:lnRef>
+          <a:fillRef idx="1">
+            <a:schemeClr val="accent1"/>
+          </a:fillRef>
+          <a:effectRef idx="0">
+            <a:schemeClr val="accent1"/>
+          </a:effectRef>
+          <a:fontRef idx="minor">
+            <a:schemeClr val="lt1"/>
+          </a:fontRef>
+        </p:style>
+        <p:txBody>
+          <a:bodyPr lIns="108000" tIns="72000" rIns="108000" bIns="72000" rtlCol="0" anchor="ctr"/>
+          <a:lstStyle/>
+          <a:p>
+            <a:pPr algn="ctr"/>
+            <a:endParaRPr lang="en-US" sz="1600" dirty="0" err="1">
+              <a:solidFill>
+                <a:schemeClr val="bg1"/>
+              </a:solidFill>
+            </a:endParaRPr>
+          </a:p>
+        </p:txBody>
+      </p:sp>
+      <p:sp>
+        <p:nvSpPr>
+          <p:cNvPr id="79" name="TextBox 78">
+            <a:extLst>
+              <a:ext uri="{FF2B5EF4-FFF2-40B4-BE49-F238E27FC236}">
+                <a16:creationId xmlns:a16="http://schemas.microsoft.com/office/drawing/2014/main" id="{FEDB3023-F101-0DF5-9A9E-B5CA1AEF0182}"/>
+              </a:ext>
+            </a:extLst>
+          </p:cNvPr>
+          <p:cNvSpPr txBox="1"/>
+          <p:nvPr/>
+        </p:nvSpPr>
+        <p:spPr>
+          <a:xfrm>
+            <a:off x="1678471" y="6054740"/>
+            <a:ext cx="341910" cy="223844"/>
+          </a:xfrm>
+          <a:prstGeom prst="rect">
+            <a:avLst/>
+          </a:prstGeom>
+          <a:noFill/>
+        </p:spPr>
+        <p:txBody>
+          <a:bodyPr wrap="none" lIns="90000" rtlCol="0" anchor="t">
+            <a:spAutoFit/>
+          </a:bodyPr>
+          <a:lstStyle/>
+          <a:p>
+            <a:pPr algn="l">
+              <a:lnSpc>
+                <a:spcPct val="113000"/>
+              </a:lnSpc>
+            </a:pPr>
+            <a:r>
+              <a:rPr lang="en-US" sz="800" b="1" dirty="0">
+                <a:solidFill>
+                  <a:schemeClr val="tx2"/>
+                </a:solidFill>
+                <a:latin typeface="Calibri" panose="020F0502020204030204" pitchFamily="34" charset="0"/>
+                <a:cs typeface="Calibri" panose="020F0502020204030204" pitchFamily="34" charset="0"/>
+              </a:rPr>
+              <a:t>+PY</a:t>
+            </a:r>
+          </a:p>
+        </p:txBody>
+      </p:sp>
+      <p:sp>
+        <p:nvSpPr>
+          <p:cNvPr id="80" name="TextBox 79">
+            <a:extLst>
+              <a:ext uri="{FF2B5EF4-FFF2-40B4-BE49-F238E27FC236}">
+                <a16:creationId xmlns:a16="http://schemas.microsoft.com/office/drawing/2014/main" id="{E369CF98-A48E-2A4E-09CB-F43B24C77E01}"/>
+              </a:ext>
+            </a:extLst>
+          </p:cNvPr>
+          <p:cNvSpPr txBox="1"/>
+          <p:nvPr/>
+        </p:nvSpPr>
+        <p:spPr>
+          <a:xfrm>
+            <a:off x="512064" y="6054740"/>
+            <a:ext cx="322674" cy="223844"/>
+          </a:xfrm>
+          <a:prstGeom prst="rect">
+            <a:avLst/>
+          </a:prstGeom>
+          <a:noFill/>
+        </p:spPr>
+        <p:txBody>
+          <a:bodyPr wrap="none" lIns="90000" rtlCol="0" anchor="t">
+            <a:spAutoFit/>
+          </a:bodyPr>
+          <a:lstStyle/>
+          <a:p>
+            <a:pPr algn="l">
+              <a:lnSpc>
+                <a:spcPct val="113000"/>
+              </a:lnSpc>
+            </a:pPr>
+            <a:r>
+              <a:rPr lang="en-US" sz="800" b="1" dirty="0">
+                <a:solidFill>
+                  <a:schemeClr val="tx2"/>
+                </a:solidFill>
+                <a:latin typeface="Calibri" panose="020F0502020204030204" pitchFamily="34" charset="0"/>
+                <a:cs typeface="Calibri" panose="020F0502020204030204" pitchFamily="34" charset="0"/>
+              </a:rPr>
+              <a:t>-PY</a:t>
+            </a:r>
+          </a:p>
+        </p:txBody>
+      </p:sp>
+    </p:spTree>
+    <p:extLst>
+      <p:ext uri="{BB962C8B-B14F-4D97-AF65-F5344CB8AC3E}">
+        <p14:creationId xmlns:p14="http://schemas.microsoft.com/office/powerpoint/2010/main" val="4040454971"/>
+      </p:ext>
+    </p:extLst>
+  </p:cSld>
+  <p:clrMapOvr>
+    <a:masterClrMapping/>
+  </p:clrMapOvr>
+</p:sld>
+</file>
+
+<file path=ppt/slides/slide16.xml><?xml version="1.0" encoding="utf-8"?>
+<p:sld xmlns:a="http://schemas.openxmlformats.org/drawingml/2006/main" xmlns:r="http://schemas.openxmlformats.org/officeDocument/2006/relationships" xmlns:p="http://schemas.openxmlformats.org/presentationml/2006/main">
+  <p:cSld>
+    <p:spTree>
+      <p:nvGrpSpPr>
+        <p:cNvPr id="1" name="">
+          <a:extLst>
+            <a:ext uri="{FF2B5EF4-FFF2-40B4-BE49-F238E27FC236}">
+              <a16:creationId xmlns:a16="http://schemas.microsoft.com/office/drawing/2014/main" id="{C876FA4F-56E0-38D4-2ADF-7F5EB3DFFC86}"/>
+            </a:ext>
+          </a:extLst>
+        </p:cNvPr>
+        <p:cNvGrpSpPr/>
+        <p:nvPr/>
+      </p:nvGrpSpPr>
+      <p:grpSpPr>
+        <a:xfrm>
+          <a:off x="0" y="0"/>
+          <a:ext cx="0" cy="0"/>
+          <a:chOff x="0" y="0"/>
+          <a:chExt cx="0" cy="0"/>
+        </a:xfrm>
+      </p:grpSpPr>
+      <p:sp>
+        <p:nvSpPr>
+          <p:cNvPr id="17" name="Rectangle 16">
+            <a:extLst>
+              <a:ext uri="{FF2B5EF4-FFF2-40B4-BE49-F238E27FC236}">
+                <a16:creationId xmlns:a16="http://schemas.microsoft.com/office/drawing/2014/main" id="{1FAB8F07-6D4B-916A-C1E3-E7E3096D579E}"/>
+              </a:ext>
+            </a:extLst>
+          </p:cNvPr>
+          <p:cNvSpPr/>
+          <p:nvPr/>
+        </p:nvSpPr>
+        <p:spPr>
+          <a:xfrm flipH="1">
+            <a:off x="0" y="1368000"/>
+            <a:ext cx="12192000" cy="1658842"/>
+          </a:xfrm>
+          <a:prstGeom prst="rect">
+            <a:avLst/>
+          </a:prstGeom>
+          <a:gradFill>
+            <a:gsLst>
+              <a:gs pos="0">
+                <a:schemeClr val="bg1"/>
+              </a:gs>
+              <a:gs pos="100000">
+                <a:schemeClr val="bg2"/>
+              </a:gs>
+            </a:gsLst>
+            <a:lin ang="2700000" scaled="0"/>
+          </a:gradFill>
+          <a:ln>
+            <a:noFill/>
+          </a:ln>
+          <a:effectLst>
+            <a:outerShdw blurRad="190500" dist="38100" dir="2700000" algn="tl" rotWithShape="0">
+              <a:prstClr val="black">
+                <a:alpha val="15000"/>
+              </a:prstClr>
+            </a:outerShdw>
+          </a:effectLst>
+        </p:spPr>
+        <p:style>
+          <a:lnRef idx="2">
+            <a:schemeClr val="accent1">
+              <a:shade val="50000"/>
+            </a:schemeClr>
+          </a:lnRef>
+          <a:fillRef idx="1">
+            <a:schemeClr val="accent1"/>
+          </a:fillRef>
+          <a:effectRef idx="0">
+            <a:schemeClr val="accent1"/>
+          </a:effectRef>
+          <a:fontRef idx="minor">
+            <a:schemeClr val="lt1"/>
+          </a:fontRef>
+        </p:style>
+        <p:txBody>
+          <a:bodyPr lIns="731520" tIns="72000" rIns="108000" bIns="72000" rtlCol="0" anchor="ctr"/>
+          <a:lstStyle/>
+          <a:p>
+            <a:endParaRPr lang="nl-NL" sz="1200" b="1" noProof="0" dirty="0">
+              <a:solidFill>
+                <a:schemeClr val="accent1"/>
+              </a:solidFill>
+            </a:endParaRPr>
+          </a:p>
+        </p:txBody>
+      </p:sp>
+      <p:sp>
+        <p:nvSpPr>
+          <p:cNvPr id="3" name="Slide Number Placeholder 2">
+            <a:extLst>
+              <a:ext uri="{FF2B5EF4-FFF2-40B4-BE49-F238E27FC236}">
+                <a16:creationId xmlns:a16="http://schemas.microsoft.com/office/drawing/2014/main" id="{76E08F0F-52CE-A816-71D0-86B4FA3FF4C4}"/>
+              </a:ext>
+            </a:extLst>
+          </p:cNvPr>
+          <p:cNvSpPr>
+            <a:spLocks noGrp="1"/>
+          </p:cNvSpPr>
+          <p:nvPr>
+            <p:ph type="sldNum" sz="quarter" idx="4"/>
+          </p:nvPr>
+        </p:nvSpPr>
+        <p:spPr/>
+        <p:txBody>
+          <a:bodyPr/>
+          <a:lstStyle/>
+          <a:p>
+            <a:fld id="{E242BD21-9B61-2246-BCB1-4BE5E1BEBE1C}" type="slidenum">
+              <a:rPr lang="en-US" smtClean="0"/>
+              <a:pPr/>
+              <a:t>16</a:t>
             </a:fld>
             <a:endParaRPr lang="en-US"/>
           </a:p>
@@ -42368,7 +45797,7 @@
 </p:sld>
 </file>
 
-<file path=ppt/slides/slide16.xml><?xml version="1.0" encoding="utf-8"?>
+<file path=ppt/slides/slide17.xml><?xml version="1.0" encoding="utf-8"?>
 <p:sld xmlns:a="http://schemas.openxmlformats.org/drawingml/2006/main" xmlns:r="http://schemas.openxmlformats.org/officeDocument/2006/relationships" xmlns:p="http://schemas.openxmlformats.org/presentationml/2006/main">
   <p:cSld>
     <p:spTree>
@@ -42485,7 +45914,7 @@
             <a:fld id="{E242BD21-9B61-2246-BCB1-4BE5E1BEBE1C}" type="slidenum">
               <a:rPr lang="en-US" smtClean="0"/>
               <a:pPr/>
-              <a:t>16</a:t>
+              <a:t>17</a:t>
             </a:fld>
             <a:endParaRPr lang="en-US"/>
           </a:p>
@@ -45143,7 +48572,7 @@
 </p:sld>
 </file>
 
-<file path=ppt/slides/slide17.xml><?xml version="1.0" encoding="utf-8"?>
+<file path=ppt/slides/slide18.xml><?xml version="1.0" encoding="utf-8"?>
 <p:sld xmlns:a="http://schemas.openxmlformats.org/drawingml/2006/main" xmlns:r="http://schemas.openxmlformats.org/officeDocument/2006/relationships" xmlns:p="http://schemas.openxmlformats.org/presentationml/2006/main">
   <p:cSld>
     <p:spTree>
@@ -45260,7 +48689,7 @@
             <a:fld id="{E242BD21-9B61-2246-BCB1-4BE5E1BEBE1C}" type="slidenum">
               <a:rPr lang="en-US" smtClean="0"/>
               <a:pPr/>
-              <a:t>17</a:t>
+              <a:t>18</a:t>
             </a:fld>
             <a:endParaRPr lang="en-US"/>
           </a:p>
@@ -47918,7 +51347,7 @@
 </p:sld>
 </file>
 
-<file path=ppt/slides/slide18.xml><?xml version="1.0" encoding="utf-8"?>
+<file path=ppt/slides/slide19.xml><?xml version="1.0" encoding="utf-8"?>
 <p:sld xmlns:a="http://schemas.openxmlformats.org/drawingml/2006/main" xmlns:r="http://schemas.openxmlformats.org/officeDocument/2006/relationships" xmlns:p="http://schemas.openxmlformats.org/presentationml/2006/main">
   <p:cSld>
     <p:spTree>

</xml_diff>

<commit_message>
Adding support for security dashboard findings
</commit_message>
<xml_diff>
--- a/src/report_generator/presets/templates/portfolio-overview.pptx
+++ b/src/report_generator/presets/templates/portfolio-overview.pptx
@@ -5,10 +5,10 @@
     <p:sldMasterId id="2147483648" r:id="rId4"/>
   </p:sldMasterIdLst>
   <p:notesMasterIdLst>
-    <p:notesMasterId r:id="rId24"/>
+    <p:notesMasterId r:id="rId25"/>
   </p:notesMasterIdLst>
   <p:handoutMasterIdLst>
-    <p:handoutMasterId r:id="rId25"/>
+    <p:handoutMasterId r:id="rId26"/>
   </p:handoutMasterIdLst>
   <p:sldIdLst>
     <p:sldId id="561" r:id="rId5"/>
@@ -28,8 +28,9 @@
     <p:sldId id="10729" r:id="rId19"/>
     <p:sldId id="10727" r:id="rId20"/>
     <p:sldId id="10726" r:id="rId21"/>
-    <p:sldId id="10723" r:id="rId22"/>
-    <p:sldId id="597" r:id="rId23"/>
+    <p:sldId id="10730" r:id="rId22"/>
+    <p:sldId id="10723" r:id="rId23"/>
+    <p:sldId id="597" r:id="rId24"/>
   </p:sldIdLst>
   <p:sldSz cx="12192000" cy="6858000"/>
   <p:notesSz cx="6858000" cy="9144000"/>
@@ -10436,7 +10437,7 @@
           <a:p>
             <a:fld id="{C1255C68-584F-174D-BB81-51BF91708794}" type="datetimeFigureOut">
               <a:rPr lang="en-US" smtClean="0"/>
-              <a:t>8/22/25</a:t>
+              <a:t>8/23/25</a:t>
             </a:fld>
             <a:endParaRPr lang="en-US"/>
           </a:p>
@@ -10613,7 +10614,7 @@
           <a:p>
             <a:fld id="{A1EDAAC4-819D-C544-9EA1-C73624CFD70B}" type="datetimeFigureOut">
               <a:rPr lang="en-US" smtClean="0"/>
-              <a:t>8/22/25</a:t>
+              <a:t>8/23/25</a:t>
             </a:fld>
             <a:endParaRPr lang="en-US"/>
           </a:p>
@@ -48580,7 +48581,7 @@
         <p:cNvPr id="1" name="">
           <a:extLst>
             <a:ext uri="{FF2B5EF4-FFF2-40B4-BE49-F238E27FC236}">
-              <a16:creationId xmlns:a16="http://schemas.microsoft.com/office/drawing/2014/main" id="{2A447711-2F95-8D02-EF61-9DFDAFBAAE27}"/>
+              <a16:creationId xmlns:a16="http://schemas.microsoft.com/office/drawing/2014/main" id="{97008932-67FE-3479-AEE1-B79D9C3C59C1}"/>
             </a:ext>
           </a:extLst>
         </p:cNvPr>
@@ -48600,7 +48601,7 @@
           <p:cNvPr id="17" name="Rectangle 16">
             <a:extLst>
               <a:ext uri="{FF2B5EF4-FFF2-40B4-BE49-F238E27FC236}">
-                <a16:creationId xmlns:a16="http://schemas.microsoft.com/office/drawing/2014/main" id="{ED508E6A-8D1D-AB1F-259E-339FCAE0BA97}"/>
+                <a16:creationId xmlns:a16="http://schemas.microsoft.com/office/drawing/2014/main" id="{ABDCAA79-36DA-0C0E-7EC3-23BEA35C7716}"/>
               </a:ext>
             </a:extLst>
           </p:cNvPr>
@@ -48670,7 +48671,7 @@
           <p:cNvPr id="3" name="Slide Number Placeholder 2">
             <a:extLst>
               <a:ext uri="{FF2B5EF4-FFF2-40B4-BE49-F238E27FC236}">
-                <a16:creationId xmlns:a16="http://schemas.microsoft.com/office/drawing/2014/main" id="{B67F47A6-2E30-A3A2-1FA6-ADC44FB6A75A}"/>
+                <a16:creationId xmlns:a16="http://schemas.microsoft.com/office/drawing/2014/main" id="{99741DF7-A2F7-DE2C-4980-7DA07FA9D51E}"/>
               </a:ext>
             </a:extLst>
           </p:cNvPr>
@@ -48690,6 +48691,2830 @@
               <a:rPr lang="en-US" smtClean="0"/>
               <a:pPr/>
               <a:t>18</a:t>
+            </a:fld>
+            <a:endParaRPr lang="en-US"/>
+          </a:p>
+        </p:txBody>
+      </p:sp>
+      <p:sp>
+        <p:nvSpPr>
+          <p:cNvPr id="7" name="Text Placeholder 6">
+            <a:extLst>
+              <a:ext uri="{FF2B5EF4-FFF2-40B4-BE49-F238E27FC236}">
+                <a16:creationId xmlns:a16="http://schemas.microsoft.com/office/drawing/2014/main" id="{6F4D386A-EB7E-8B9F-F213-5AAB72238BEB}"/>
+              </a:ext>
+            </a:extLst>
+          </p:cNvPr>
+          <p:cNvSpPr>
+            <a:spLocks noGrp="1"/>
+          </p:cNvSpPr>
+          <p:nvPr>
+            <p:ph type="body" sz="quarter" idx="12"/>
+          </p:nvPr>
+        </p:nvSpPr>
+        <p:spPr/>
+        <p:txBody>
+          <a:bodyPr/>
+          <a:lstStyle/>
+          <a:p>
+            <a:r>
+              <a:rPr lang="en-US" dirty="0"/>
+              <a:t>Findings – </a:t>
+            </a:r>
+            <a:r>
+              <a:rPr lang="en-US" dirty="0">
+                <a:solidFill>
+                  <a:schemeClr val="accent3"/>
+                </a:solidFill>
+              </a:rPr>
+              <a:t>SECURITY</a:t>
+            </a:r>
+          </a:p>
+        </p:txBody>
+      </p:sp>
+      <p:sp>
+        <p:nvSpPr>
+          <p:cNvPr id="6" name="Title 5">
+            <a:extLst>
+              <a:ext uri="{FF2B5EF4-FFF2-40B4-BE49-F238E27FC236}">
+                <a16:creationId xmlns:a16="http://schemas.microsoft.com/office/drawing/2014/main" id="{0CB3DF4B-7F1B-6565-0112-AF77D9AE5E9E}"/>
+              </a:ext>
+            </a:extLst>
+          </p:cNvPr>
+          <p:cNvSpPr>
+            <a:spLocks noGrp="1"/>
+          </p:cNvSpPr>
+          <p:nvPr>
+            <p:ph type="title"/>
+          </p:nvPr>
+        </p:nvSpPr>
+        <p:spPr/>
+        <p:txBody>
+          <a:bodyPr/>
+          <a:lstStyle/>
+          <a:p>
+            <a:r>
+              <a:rPr lang="en-US" noProof="0" dirty="0"/>
+              <a:t>@@</a:t>
+            </a:r>
+          </a:p>
+        </p:txBody>
+      </p:sp>
+      <p:sp>
+        <p:nvSpPr>
+          <p:cNvPr id="8" name="Content Placeholder 7">
+            <a:extLst>
+              <a:ext uri="{FF2B5EF4-FFF2-40B4-BE49-F238E27FC236}">
+                <a16:creationId xmlns:a16="http://schemas.microsoft.com/office/drawing/2014/main" id="{0AA92ECD-1BDA-FBEF-7C64-ECD0BA7B4BA3}"/>
+              </a:ext>
+            </a:extLst>
+          </p:cNvPr>
+          <p:cNvSpPr>
+            <a:spLocks noGrp="1"/>
+          </p:cNvSpPr>
+          <p:nvPr>
+            <p:ph sz="quarter" idx="13"/>
+          </p:nvPr>
+        </p:nvSpPr>
+        <p:spPr>
+          <a:xfrm>
+            <a:off x="514800" y="1368000"/>
+            <a:ext cx="11232000" cy="1658842"/>
+          </a:xfrm>
+        </p:spPr>
+        <p:txBody>
+          <a:bodyPr anchor="ctr"/>
+          <a:lstStyle/>
+          <a:p>
+            <a:pPr marL="0" indent="0">
+              <a:buNone/>
+            </a:pPr>
+            <a:r>
+              <a:rPr lang="en-US" sz="1400" noProof="0" dirty="0"/>
+              <a:t>@@</a:t>
+            </a:r>
+            <a:endParaRPr lang="en-US" sz="1200" noProof="0" dirty="0"/>
+          </a:p>
+        </p:txBody>
+      </p:sp>
+      <p:sp>
+        <p:nvSpPr>
+          <p:cNvPr id="28" name="TextBox 27">
+            <a:extLst>
+              <a:ext uri="{FF2B5EF4-FFF2-40B4-BE49-F238E27FC236}">
+                <a16:creationId xmlns:a16="http://schemas.microsoft.com/office/drawing/2014/main" id="{6F7F77EA-7E26-BE49-1757-A4CD9A5566EB}"/>
+              </a:ext>
+            </a:extLst>
+          </p:cNvPr>
+          <p:cNvSpPr txBox="1"/>
+          <p:nvPr/>
+        </p:nvSpPr>
+        <p:spPr>
+          <a:xfrm>
+            <a:off x="-1221448" y="4419492"/>
+            <a:ext cx="628847" cy="633443"/>
+          </a:xfrm>
+          <a:prstGeom prst="rect">
+            <a:avLst/>
+          </a:prstGeom>
+          <a:noFill/>
+        </p:spPr>
+        <p:txBody>
+          <a:bodyPr wrap="none" lIns="90000" rtlCol="0" anchor="t">
+            <a:spAutoFit/>
+          </a:bodyPr>
+          <a:lstStyle/>
+          <a:p>
+            <a:pPr algn="l">
+              <a:lnSpc>
+                <a:spcPct val="113000"/>
+              </a:lnSpc>
+            </a:pPr>
+            <a:r>
+              <a:rPr lang="en-US" sz="1600" dirty="0">
+                <a:solidFill>
+                  <a:schemeClr val="tx2"/>
+                </a:solidFill>
+              </a:rPr>
+              <a:t>3.12”</a:t>
+            </a:r>
+          </a:p>
+          <a:p>
+            <a:pPr algn="l">
+              <a:lnSpc>
+                <a:spcPct val="113000"/>
+              </a:lnSpc>
+            </a:pPr>
+            <a:r>
+              <a:rPr lang="en-US" sz="1600" dirty="0">
+                <a:solidFill>
+                  <a:schemeClr val="tx2"/>
+                </a:solidFill>
+              </a:rPr>
+              <a:t>9.57"</a:t>
+            </a:r>
+          </a:p>
+        </p:txBody>
+      </p:sp>
+      <p:sp>
+        <p:nvSpPr>
+          <p:cNvPr id="60" name="Triangle 59">
+            <a:extLst>
+              <a:ext uri="{FF2B5EF4-FFF2-40B4-BE49-F238E27FC236}">
+                <a16:creationId xmlns:a16="http://schemas.microsoft.com/office/drawing/2014/main" id="{0E164206-2345-E6D1-3746-641DBCAA683B}"/>
+              </a:ext>
+            </a:extLst>
+          </p:cNvPr>
+          <p:cNvSpPr/>
+          <p:nvPr/>
+        </p:nvSpPr>
+        <p:spPr>
+          <a:xfrm rot="5400000">
+            <a:off x="11223517" y="97630"/>
+            <a:ext cx="113704" cy="91353"/>
+          </a:xfrm>
+          <a:prstGeom prst="triangle">
+            <a:avLst/>
+          </a:prstGeom>
+          <a:solidFill>
+            <a:schemeClr val="tx2"/>
+          </a:solidFill>
+          <a:ln>
+            <a:noFill/>
+          </a:ln>
+        </p:spPr>
+        <p:style>
+          <a:lnRef idx="2">
+            <a:schemeClr val="accent1">
+              <a:shade val="50000"/>
+            </a:schemeClr>
+          </a:lnRef>
+          <a:fillRef idx="1">
+            <a:schemeClr val="accent1"/>
+          </a:fillRef>
+          <a:effectRef idx="0">
+            <a:schemeClr val="accent1"/>
+          </a:effectRef>
+          <a:fontRef idx="minor">
+            <a:schemeClr val="lt1"/>
+          </a:fontRef>
+        </p:style>
+        <p:txBody>
+          <a:bodyPr lIns="108000" tIns="72000" rIns="108000" bIns="72000" rtlCol="0" anchor="ctr"/>
+          <a:lstStyle/>
+          <a:p>
+            <a:pPr algn="ctr"/>
+            <a:endParaRPr lang="en-US" sz="1600">
+              <a:solidFill>
+                <a:schemeClr val="bg1"/>
+              </a:solidFill>
+            </a:endParaRPr>
+          </a:p>
+        </p:txBody>
+      </p:sp>
+      <p:pic>
+        <p:nvPicPr>
+          <p:cNvPr id="61" name="Picture 60">
+            <a:extLst>
+              <a:ext uri="{FF2B5EF4-FFF2-40B4-BE49-F238E27FC236}">
+                <a16:creationId xmlns:a16="http://schemas.microsoft.com/office/drawing/2014/main" id="{6786EE57-08F8-578E-A94E-4382E2E675E1}"/>
+              </a:ext>
+            </a:extLst>
+          </p:cNvPr>
+          <p:cNvPicPr>
+            <a:picLocks noChangeAspect="1"/>
+          </p:cNvPicPr>
+          <p:nvPr/>
+        </p:nvPicPr>
+        <p:blipFill>
+          <a:blip r:embed="rId2"/>
+          <a:stretch>
+            <a:fillRect/>
+          </a:stretch>
+        </p:blipFill>
+        <p:spPr>
+          <a:xfrm>
+            <a:off x="10267839" y="52613"/>
+            <a:ext cx="203103" cy="172639"/>
+          </a:xfrm>
+          <a:prstGeom prst="rect">
+            <a:avLst/>
+          </a:prstGeom>
+        </p:spPr>
+      </p:pic>
+      <p:sp>
+        <p:nvSpPr>
+          <p:cNvPr id="62" name="TextBox 61">
+            <a:extLst>
+              <a:ext uri="{FF2B5EF4-FFF2-40B4-BE49-F238E27FC236}">
+                <a16:creationId xmlns:a16="http://schemas.microsoft.com/office/drawing/2014/main" id="{9DD3010D-284B-FFE8-00DA-5B6B519F38C7}"/>
+              </a:ext>
+            </a:extLst>
+          </p:cNvPr>
+          <p:cNvSpPr txBox="1"/>
+          <p:nvPr/>
+        </p:nvSpPr>
+        <p:spPr>
+          <a:xfrm>
+            <a:off x="9145068" y="10898"/>
+            <a:ext cx="2110021" cy="264816"/>
+          </a:xfrm>
+          <a:prstGeom prst="rect">
+            <a:avLst/>
+          </a:prstGeom>
+          <a:noFill/>
+        </p:spPr>
+        <p:txBody>
+          <a:bodyPr wrap="none" lIns="90000" rtlCol="0" anchor="t">
+            <a:spAutoFit/>
+          </a:bodyPr>
+          <a:lstStyle/>
+          <a:p>
+            <a:pPr algn="r">
+              <a:lnSpc>
+                <a:spcPct val="113000"/>
+              </a:lnSpc>
+            </a:pPr>
+            <a:r>
+              <a:rPr lang="nl-NL" sz="1050" b="1" dirty="0" err="1">
+                <a:solidFill>
+                  <a:schemeClr val="bg1">
+                    <a:lumMod val="75000"/>
+                  </a:schemeClr>
+                </a:solidFill>
+              </a:rPr>
+              <a:t>PORTFOLIO_PERIOD_START_DATE</a:t>
+            </a:r>
+            <a:endParaRPr lang="nl-NL" sz="1050" b="1" dirty="0">
+              <a:solidFill>
+                <a:schemeClr val="bg1">
+                  <a:lumMod val="75000"/>
+                </a:schemeClr>
+              </a:solidFill>
+            </a:endParaRPr>
+          </a:p>
+        </p:txBody>
+      </p:sp>
+      <p:sp>
+        <p:nvSpPr>
+          <p:cNvPr id="63" name="TextBox 62">
+            <a:extLst>
+              <a:ext uri="{FF2B5EF4-FFF2-40B4-BE49-F238E27FC236}">
+                <a16:creationId xmlns:a16="http://schemas.microsoft.com/office/drawing/2014/main" id="{AAF65DDF-8D18-FC3B-861E-407B8366FA77}"/>
+              </a:ext>
+            </a:extLst>
+          </p:cNvPr>
+          <p:cNvSpPr txBox="1"/>
+          <p:nvPr/>
+        </p:nvSpPr>
+        <p:spPr>
+          <a:xfrm>
+            <a:off x="11305651" y="10898"/>
+            <a:ext cx="1993003" cy="264816"/>
+          </a:xfrm>
+          <a:prstGeom prst="rect">
+            <a:avLst/>
+          </a:prstGeom>
+          <a:noFill/>
+        </p:spPr>
+        <p:txBody>
+          <a:bodyPr wrap="none" lIns="90000" rtlCol="0" anchor="t">
+            <a:spAutoFit/>
+          </a:bodyPr>
+          <a:lstStyle/>
+          <a:p>
+            <a:pPr>
+              <a:lnSpc>
+                <a:spcPct val="113000"/>
+              </a:lnSpc>
+            </a:pPr>
+            <a:r>
+              <a:rPr lang="nl-NL" sz="1050" b="1" dirty="0" err="1">
+                <a:solidFill>
+                  <a:schemeClr val="tx2"/>
+                </a:solidFill>
+              </a:rPr>
+              <a:t>PORTFOLIO_PERIOD_END_DATE</a:t>
+            </a:r>
+            <a:endParaRPr lang="nl-NL" sz="1050" b="1" dirty="0">
+              <a:solidFill>
+                <a:schemeClr val="tx2"/>
+              </a:solidFill>
+            </a:endParaRPr>
+          </a:p>
+        </p:txBody>
+      </p:sp>
+      <p:grpSp>
+        <p:nvGrpSpPr>
+          <p:cNvPr id="64" name="Group 63">
+            <a:extLst>
+              <a:ext uri="{FF2B5EF4-FFF2-40B4-BE49-F238E27FC236}">
+                <a16:creationId xmlns:a16="http://schemas.microsoft.com/office/drawing/2014/main" id="{C15C3881-1CF2-F1D2-4215-9BE451E8DB22}"/>
+              </a:ext>
+            </a:extLst>
+          </p:cNvPr>
+          <p:cNvGrpSpPr>
+            <a:grpSpLocks noChangeAspect="1"/>
+          </p:cNvGrpSpPr>
+          <p:nvPr/>
+        </p:nvGrpSpPr>
+        <p:grpSpPr>
+          <a:xfrm>
+            <a:off x="-392105" y="2517185"/>
+            <a:ext cx="98115" cy="92576"/>
+            <a:chOff x="-331054" y="2564812"/>
+            <a:chExt cx="141517" cy="133528"/>
+          </a:xfrm>
+          <a:solidFill>
+            <a:srgbClr val="57C968"/>
+          </a:solidFill>
+        </p:grpSpPr>
+        <p:sp>
+          <p:nvSpPr>
+            <p:cNvPr id="65" name="Freeform 64">
+              <a:extLst>
+                <a:ext uri="{FF2B5EF4-FFF2-40B4-BE49-F238E27FC236}">
+                  <a16:creationId xmlns:a16="http://schemas.microsoft.com/office/drawing/2014/main" id="{0301DAEA-569B-4BFD-ADCC-7840C9E2C91C}"/>
+                </a:ext>
+              </a:extLst>
+            </p:cNvPr>
+            <p:cNvSpPr/>
+            <p:nvPr/>
+          </p:nvSpPr>
+          <p:spPr>
+            <a:xfrm>
+              <a:off x="-331054" y="2564812"/>
+              <a:ext cx="141517" cy="82436"/>
+            </a:xfrm>
+            <a:custGeom>
+              <a:avLst/>
+              <a:gdLst>
+                <a:gd name="connsiteX0" fmla="*/ 70759 w 141517"/>
+                <a:gd name="connsiteY0" fmla="*/ 0 h 82436"/>
+                <a:gd name="connsiteX1" fmla="*/ 141517 w 141517"/>
+                <a:gd name="connsiteY1" fmla="*/ 82436 h 82436"/>
+                <a:gd name="connsiteX2" fmla="*/ 111805 w 141517"/>
+                <a:gd name="connsiteY2" fmla="*/ 82436 h 82436"/>
+                <a:gd name="connsiteX3" fmla="*/ 70759 w 141517"/>
+                <a:gd name="connsiteY3" fmla="*/ 34616 h 82436"/>
+                <a:gd name="connsiteX4" fmla="*/ 29713 w 141517"/>
+                <a:gd name="connsiteY4" fmla="*/ 82436 h 82436"/>
+                <a:gd name="connsiteX5" fmla="*/ 0 w 141517"/>
+                <a:gd name="connsiteY5" fmla="*/ 82436 h 82436"/>
+              </a:gdLst>
+              <a:ahLst/>
+              <a:cxnLst>
+                <a:cxn ang="0">
+                  <a:pos x="connsiteX0" y="connsiteY0"/>
+                </a:cxn>
+                <a:cxn ang="0">
+                  <a:pos x="connsiteX1" y="connsiteY1"/>
+                </a:cxn>
+                <a:cxn ang="0">
+                  <a:pos x="connsiteX2" y="connsiteY2"/>
+                </a:cxn>
+                <a:cxn ang="0">
+                  <a:pos x="connsiteX3" y="connsiteY3"/>
+                </a:cxn>
+                <a:cxn ang="0">
+                  <a:pos x="connsiteX4" y="connsiteY4"/>
+                </a:cxn>
+                <a:cxn ang="0">
+                  <a:pos x="connsiteX5" y="connsiteY5"/>
+                </a:cxn>
+              </a:cxnLst>
+              <a:rect l="l" t="t" r="r" b="b"/>
+              <a:pathLst>
+                <a:path w="141517" h="82436">
+                  <a:moveTo>
+                    <a:pt x="70759" y="0"/>
+                  </a:moveTo>
+                  <a:lnTo>
+                    <a:pt x="141517" y="82436"/>
+                  </a:lnTo>
+                  <a:lnTo>
+                    <a:pt x="111805" y="82436"/>
+                  </a:lnTo>
+                  <a:lnTo>
+                    <a:pt x="70759" y="34616"/>
+                  </a:lnTo>
+                  <a:lnTo>
+                    <a:pt x="29713" y="82436"/>
+                  </a:lnTo>
+                  <a:lnTo>
+                    <a:pt x="0" y="82436"/>
+                  </a:lnTo>
+                  <a:close/>
+                </a:path>
+              </a:pathLst>
+            </a:custGeom>
+            <a:grpFill/>
+            <a:ln>
+              <a:noFill/>
+            </a:ln>
+          </p:spPr>
+          <p:style>
+            <a:lnRef idx="2">
+              <a:schemeClr val="accent1">
+                <a:shade val="50000"/>
+              </a:schemeClr>
+            </a:lnRef>
+            <a:fillRef idx="1">
+              <a:schemeClr val="accent1"/>
+            </a:fillRef>
+            <a:effectRef idx="0">
+              <a:schemeClr val="accent1"/>
+            </a:effectRef>
+            <a:fontRef idx="minor">
+              <a:schemeClr val="lt1"/>
+            </a:fontRef>
+          </p:style>
+          <p:txBody>
+            <a:bodyPr wrap="square" lIns="108000" tIns="72000" rIns="108000" bIns="72000" rtlCol="0" anchor="ctr">
+              <a:noAutofit/>
+            </a:bodyPr>
+            <a:lstStyle/>
+            <a:p>
+              <a:pPr algn="ctr"/>
+              <a:endParaRPr lang="en-US" sz="1600" err="1">
+                <a:solidFill>
+                  <a:schemeClr val="bg1"/>
+                </a:solidFill>
+              </a:endParaRPr>
+            </a:p>
+          </p:txBody>
+        </p:sp>
+        <p:sp>
+          <p:nvSpPr>
+            <p:cNvPr id="66" name="Triangle 65">
+              <a:extLst>
+                <a:ext uri="{FF2B5EF4-FFF2-40B4-BE49-F238E27FC236}">
+                  <a16:creationId xmlns:a16="http://schemas.microsoft.com/office/drawing/2014/main" id="{BF2D4EA4-AC1B-DA7D-2EDB-28604D9FA58C}"/>
+                </a:ext>
+              </a:extLst>
+            </p:cNvPr>
+            <p:cNvSpPr/>
+            <p:nvPr/>
+          </p:nvSpPr>
+          <p:spPr>
+            <a:xfrm>
+              <a:off x="-331054" y="2615904"/>
+              <a:ext cx="141517" cy="82436"/>
+            </a:xfrm>
+            <a:prstGeom prst="triangle">
+              <a:avLst/>
+            </a:prstGeom>
+            <a:grpFill/>
+            <a:ln>
+              <a:noFill/>
+            </a:ln>
+          </p:spPr>
+          <p:style>
+            <a:lnRef idx="2">
+              <a:schemeClr val="accent1">
+                <a:shade val="50000"/>
+              </a:schemeClr>
+            </a:lnRef>
+            <a:fillRef idx="1">
+              <a:schemeClr val="accent1"/>
+            </a:fillRef>
+            <a:effectRef idx="0">
+              <a:schemeClr val="accent1"/>
+            </a:effectRef>
+            <a:fontRef idx="minor">
+              <a:schemeClr val="lt1"/>
+            </a:fontRef>
+          </p:style>
+          <p:txBody>
+            <a:bodyPr lIns="108000" tIns="72000" rIns="108000" bIns="72000" rtlCol="0" anchor="ctr"/>
+            <a:lstStyle/>
+            <a:p>
+              <a:pPr algn="ctr"/>
+              <a:endParaRPr lang="en-US" sz="1600" err="1">
+                <a:solidFill>
+                  <a:schemeClr val="bg1"/>
+                </a:solidFill>
+              </a:endParaRPr>
+            </a:p>
+          </p:txBody>
+        </p:sp>
+      </p:grpSp>
+      <p:grpSp>
+        <p:nvGrpSpPr>
+          <p:cNvPr id="67" name="Group 66">
+            <a:extLst>
+              <a:ext uri="{FF2B5EF4-FFF2-40B4-BE49-F238E27FC236}">
+                <a16:creationId xmlns:a16="http://schemas.microsoft.com/office/drawing/2014/main" id="{A5B5F588-AE14-1A44-72CB-7290D2B83CA1}"/>
+              </a:ext>
+            </a:extLst>
+          </p:cNvPr>
+          <p:cNvGrpSpPr>
+            <a:grpSpLocks noChangeAspect="1"/>
+          </p:cNvGrpSpPr>
+          <p:nvPr/>
+        </p:nvGrpSpPr>
+        <p:grpSpPr>
+          <a:xfrm rot="10800000">
+            <a:off x="-392106" y="2948284"/>
+            <a:ext cx="98115" cy="92576"/>
+            <a:chOff x="-331054" y="2564812"/>
+            <a:chExt cx="141517" cy="133528"/>
+          </a:xfrm>
+          <a:solidFill>
+            <a:srgbClr val="FFC000"/>
+          </a:solidFill>
+        </p:grpSpPr>
+        <p:sp>
+          <p:nvSpPr>
+            <p:cNvPr id="68" name="Freeform 67">
+              <a:extLst>
+                <a:ext uri="{FF2B5EF4-FFF2-40B4-BE49-F238E27FC236}">
+                  <a16:creationId xmlns:a16="http://schemas.microsoft.com/office/drawing/2014/main" id="{64C617FB-D78D-A196-6ADD-360D8179B451}"/>
+                </a:ext>
+              </a:extLst>
+            </p:cNvPr>
+            <p:cNvSpPr/>
+            <p:nvPr/>
+          </p:nvSpPr>
+          <p:spPr>
+            <a:xfrm>
+              <a:off x="-331054" y="2564812"/>
+              <a:ext cx="141517" cy="82436"/>
+            </a:xfrm>
+            <a:custGeom>
+              <a:avLst/>
+              <a:gdLst>
+                <a:gd name="connsiteX0" fmla="*/ 70759 w 141517"/>
+                <a:gd name="connsiteY0" fmla="*/ 0 h 82436"/>
+                <a:gd name="connsiteX1" fmla="*/ 141517 w 141517"/>
+                <a:gd name="connsiteY1" fmla="*/ 82436 h 82436"/>
+                <a:gd name="connsiteX2" fmla="*/ 111805 w 141517"/>
+                <a:gd name="connsiteY2" fmla="*/ 82436 h 82436"/>
+                <a:gd name="connsiteX3" fmla="*/ 70759 w 141517"/>
+                <a:gd name="connsiteY3" fmla="*/ 34616 h 82436"/>
+                <a:gd name="connsiteX4" fmla="*/ 29713 w 141517"/>
+                <a:gd name="connsiteY4" fmla="*/ 82436 h 82436"/>
+                <a:gd name="connsiteX5" fmla="*/ 0 w 141517"/>
+                <a:gd name="connsiteY5" fmla="*/ 82436 h 82436"/>
+              </a:gdLst>
+              <a:ahLst/>
+              <a:cxnLst>
+                <a:cxn ang="0">
+                  <a:pos x="connsiteX0" y="connsiteY0"/>
+                </a:cxn>
+                <a:cxn ang="0">
+                  <a:pos x="connsiteX1" y="connsiteY1"/>
+                </a:cxn>
+                <a:cxn ang="0">
+                  <a:pos x="connsiteX2" y="connsiteY2"/>
+                </a:cxn>
+                <a:cxn ang="0">
+                  <a:pos x="connsiteX3" y="connsiteY3"/>
+                </a:cxn>
+                <a:cxn ang="0">
+                  <a:pos x="connsiteX4" y="connsiteY4"/>
+                </a:cxn>
+                <a:cxn ang="0">
+                  <a:pos x="connsiteX5" y="connsiteY5"/>
+                </a:cxn>
+              </a:cxnLst>
+              <a:rect l="l" t="t" r="r" b="b"/>
+              <a:pathLst>
+                <a:path w="141517" h="82436">
+                  <a:moveTo>
+                    <a:pt x="70759" y="0"/>
+                  </a:moveTo>
+                  <a:lnTo>
+                    <a:pt x="141517" y="82436"/>
+                  </a:lnTo>
+                  <a:lnTo>
+                    <a:pt x="111805" y="82436"/>
+                  </a:lnTo>
+                  <a:lnTo>
+                    <a:pt x="70759" y="34616"/>
+                  </a:lnTo>
+                  <a:lnTo>
+                    <a:pt x="29713" y="82436"/>
+                  </a:lnTo>
+                  <a:lnTo>
+                    <a:pt x="0" y="82436"/>
+                  </a:lnTo>
+                  <a:close/>
+                </a:path>
+              </a:pathLst>
+            </a:custGeom>
+            <a:grpFill/>
+            <a:ln>
+              <a:noFill/>
+            </a:ln>
+          </p:spPr>
+          <p:style>
+            <a:lnRef idx="2">
+              <a:schemeClr val="accent1">
+                <a:shade val="50000"/>
+              </a:schemeClr>
+            </a:lnRef>
+            <a:fillRef idx="1">
+              <a:schemeClr val="accent1"/>
+            </a:fillRef>
+            <a:effectRef idx="0">
+              <a:schemeClr val="accent1"/>
+            </a:effectRef>
+            <a:fontRef idx="minor">
+              <a:schemeClr val="lt1"/>
+            </a:fontRef>
+          </p:style>
+          <p:txBody>
+            <a:bodyPr wrap="square" lIns="108000" tIns="72000" rIns="108000" bIns="72000" rtlCol="0" anchor="ctr">
+              <a:noAutofit/>
+            </a:bodyPr>
+            <a:lstStyle/>
+            <a:p>
+              <a:pPr algn="ctr"/>
+              <a:endParaRPr lang="en-US" sz="1600" err="1">
+                <a:solidFill>
+                  <a:schemeClr val="bg1"/>
+                </a:solidFill>
+              </a:endParaRPr>
+            </a:p>
+          </p:txBody>
+        </p:sp>
+        <p:sp>
+          <p:nvSpPr>
+            <p:cNvPr id="69" name="Triangle 68">
+              <a:extLst>
+                <a:ext uri="{FF2B5EF4-FFF2-40B4-BE49-F238E27FC236}">
+                  <a16:creationId xmlns:a16="http://schemas.microsoft.com/office/drawing/2014/main" id="{3663B325-18F9-3426-D584-BA9F7DB8CABE}"/>
+                </a:ext>
+              </a:extLst>
+            </p:cNvPr>
+            <p:cNvSpPr/>
+            <p:nvPr/>
+          </p:nvSpPr>
+          <p:spPr>
+            <a:xfrm>
+              <a:off x="-331054" y="2615904"/>
+              <a:ext cx="141517" cy="82436"/>
+            </a:xfrm>
+            <a:prstGeom prst="triangle">
+              <a:avLst/>
+            </a:prstGeom>
+            <a:grpFill/>
+            <a:ln>
+              <a:noFill/>
+            </a:ln>
+          </p:spPr>
+          <p:style>
+            <a:lnRef idx="2">
+              <a:schemeClr val="accent1">
+                <a:shade val="50000"/>
+              </a:schemeClr>
+            </a:lnRef>
+            <a:fillRef idx="1">
+              <a:schemeClr val="accent1"/>
+            </a:fillRef>
+            <a:effectRef idx="0">
+              <a:schemeClr val="accent1"/>
+            </a:effectRef>
+            <a:fontRef idx="minor">
+              <a:schemeClr val="lt1"/>
+            </a:fontRef>
+          </p:style>
+          <p:txBody>
+            <a:bodyPr lIns="108000" tIns="72000" rIns="108000" bIns="72000" rtlCol="0" anchor="ctr"/>
+            <a:lstStyle/>
+            <a:p>
+              <a:pPr algn="ctr"/>
+              <a:endParaRPr lang="en-US" sz="1600" err="1">
+                <a:solidFill>
+                  <a:schemeClr val="bg1"/>
+                </a:solidFill>
+              </a:endParaRPr>
+            </a:p>
+          </p:txBody>
+        </p:sp>
+      </p:grpSp>
+      <p:sp>
+        <p:nvSpPr>
+          <p:cNvPr id="32" name="Rectangle 31">
+            <a:extLst>
+              <a:ext uri="{FF2B5EF4-FFF2-40B4-BE49-F238E27FC236}">
+                <a16:creationId xmlns:a16="http://schemas.microsoft.com/office/drawing/2014/main" id="{B04A86CB-042C-A526-AA66-032348B7C9D9}"/>
+              </a:ext>
+            </a:extLst>
+          </p:cNvPr>
+          <p:cNvSpPr/>
+          <p:nvPr/>
+        </p:nvSpPr>
+        <p:spPr>
+          <a:xfrm>
+            <a:off x="1" y="3154680"/>
+            <a:ext cx="12191999" cy="3163320"/>
+          </a:xfrm>
+          <a:prstGeom prst="rect">
+            <a:avLst/>
+          </a:prstGeom>
+          <a:gradFill>
+            <a:gsLst>
+              <a:gs pos="0">
+                <a:schemeClr val="bg1"/>
+              </a:gs>
+              <a:gs pos="100000">
+                <a:schemeClr val="bg2"/>
+              </a:gs>
+            </a:gsLst>
+            <a:lin ang="2700000" scaled="0"/>
+          </a:gradFill>
+          <a:ln>
+            <a:noFill/>
+          </a:ln>
+          <a:effectLst>
+            <a:outerShdw blurRad="190500" dist="38100" dir="2700000" algn="tl" rotWithShape="0">
+              <a:prstClr val="black">
+                <a:alpha val="15000"/>
+              </a:prstClr>
+            </a:outerShdw>
+          </a:effectLst>
+        </p:spPr>
+        <p:style>
+          <a:lnRef idx="2">
+            <a:schemeClr val="accent1">
+              <a:shade val="50000"/>
+            </a:schemeClr>
+          </a:lnRef>
+          <a:fillRef idx="1">
+            <a:schemeClr val="accent1"/>
+          </a:fillRef>
+          <a:effectRef idx="0">
+            <a:schemeClr val="accent1"/>
+          </a:effectRef>
+          <a:fontRef idx="minor">
+            <a:schemeClr val="lt1"/>
+          </a:fontRef>
+        </p:style>
+        <p:txBody>
+          <a:bodyPr lIns="731520" tIns="72000" rIns="108000" bIns="72000" rtlCol="0" anchor="ctr"/>
+          <a:lstStyle/>
+          <a:p>
+            <a:endParaRPr lang="nl-NL" sz="1200" b="1" noProof="0" dirty="0">
+              <a:solidFill>
+                <a:schemeClr val="accent1"/>
+              </a:solidFill>
+            </a:endParaRPr>
+          </a:p>
+        </p:txBody>
+      </p:sp>
+      <p:pic>
+        <p:nvPicPr>
+          <p:cNvPr id="34" name="Graphic 33">
+            <a:extLst>
+              <a:ext uri="{FF2B5EF4-FFF2-40B4-BE49-F238E27FC236}">
+                <a16:creationId xmlns:a16="http://schemas.microsoft.com/office/drawing/2014/main" id="{B102D423-A941-90C8-5743-AA30ED2966A7}"/>
+              </a:ext>
+            </a:extLst>
+          </p:cNvPr>
+          <p:cNvPicPr>
+            <a:picLocks noChangeAspect="1"/>
+          </p:cNvPicPr>
+          <p:nvPr/>
+        </p:nvPicPr>
+        <p:blipFill>
+          <a:blip r:embed="rId3">
+            <a:extLst>
+              <a:ext uri="{96DAC541-7B7A-43D3-8B79-37D633B846F1}">
+                <asvg:svgBlip xmlns:asvg="http://schemas.microsoft.com/office/drawing/2016/SVG/main" r:embed="rId4"/>
+              </a:ext>
+            </a:extLst>
+          </a:blip>
+          <a:stretch>
+            <a:fillRect/>
+          </a:stretch>
+        </p:blipFill>
+        <p:spPr>
+          <a:xfrm>
+            <a:off x="11773775" y="6070942"/>
+            <a:ext cx="371130" cy="206558"/>
+          </a:xfrm>
+          <a:prstGeom prst="rect">
+            <a:avLst/>
+          </a:prstGeom>
+        </p:spPr>
+      </p:pic>
+      <p:sp>
+        <p:nvSpPr>
+          <p:cNvPr id="46" name="Rounded Rectangle 45">
+            <a:extLst>
+              <a:ext uri="{FF2B5EF4-FFF2-40B4-BE49-F238E27FC236}">
+                <a16:creationId xmlns:a16="http://schemas.microsoft.com/office/drawing/2014/main" id="{67C0D00E-17C9-7B3E-1EE5-6A1653E68281}"/>
+              </a:ext>
+            </a:extLst>
+          </p:cNvPr>
+          <p:cNvSpPr/>
+          <p:nvPr/>
+        </p:nvSpPr>
+        <p:spPr>
+          <a:xfrm flipH="1">
+            <a:off x="841767" y="3237334"/>
+            <a:ext cx="3086538" cy="3031905"/>
+          </a:xfrm>
+          <a:prstGeom prst="roundRect">
+            <a:avLst>
+              <a:gd name="adj" fmla="val 3988"/>
+            </a:avLst>
+          </a:prstGeom>
+          <a:gradFill>
+            <a:gsLst>
+              <a:gs pos="0">
+                <a:schemeClr val="bg1"/>
+              </a:gs>
+              <a:gs pos="100000">
+                <a:schemeClr val="bg2"/>
+              </a:gs>
+            </a:gsLst>
+            <a:lin ang="2700000" scaled="0"/>
+          </a:gradFill>
+          <a:ln>
+            <a:noFill/>
+          </a:ln>
+          <a:effectLst>
+            <a:outerShdw blurRad="190500" dist="38100" dir="2700000" algn="tl" rotWithShape="0">
+              <a:prstClr val="black">
+                <a:alpha val="15000"/>
+              </a:prstClr>
+            </a:outerShdw>
+          </a:effectLst>
+        </p:spPr>
+        <p:style>
+          <a:lnRef idx="2">
+            <a:schemeClr val="accent1">
+              <a:shade val="50000"/>
+            </a:schemeClr>
+          </a:lnRef>
+          <a:fillRef idx="1">
+            <a:schemeClr val="accent1"/>
+          </a:fillRef>
+          <a:effectRef idx="0">
+            <a:schemeClr val="accent1"/>
+          </a:effectRef>
+          <a:fontRef idx="minor">
+            <a:schemeClr val="lt1"/>
+          </a:fontRef>
+        </p:style>
+        <p:txBody>
+          <a:bodyPr lIns="73152" tIns="0" rIns="73152" bIns="0" rtlCol="0" anchor="t"/>
+          <a:lstStyle/>
+          <a:p>
+            <a:pPr algn="ctr"/>
+            <a:r>
+              <a:rPr lang="nl-NL" sz="1200" b="1" noProof="0" dirty="0">
+                <a:solidFill>
+                  <a:srgbClr val="910714"/>
+                </a:solidFill>
+              </a:rPr>
+              <a:t>Critical</a:t>
+            </a:r>
+          </a:p>
+        </p:txBody>
+      </p:sp>
+      <p:sp>
+        <p:nvSpPr>
+          <p:cNvPr id="47" name="Rounded Rectangle 46">
+            <a:extLst>
+              <a:ext uri="{FF2B5EF4-FFF2-40B4-BE49-F238E27FC236}">
+                <a16:creationId xmlns:a16="http://schemas.microsoft.com/office/drawing/2014/main" id="{687937C5-61E6-B270-981B-2D0C53A4713E}"/>
+              </a:ext>
+            </a:extLst>
+          </p:cNvPr>
+          <p:cNvSpPr/>
+          <p:nvPr/>
+        </p:nvSpPr>
+        <p:spPr>
+          <a:xfrm flipH="1">
+            <a:off x="4117074" y="3237334"/>
+            <a:ext cx="3086538" cy="3031905"/>
+          </a:xfrm>
+          <a:prstGeom prst="roundRect">
+            <a:avLst>
+              <a:gd name="adj" fmla="val 3987"/>
+            </a:avLst>
+          </a:prstGeom>
+          <a:gradFill>
+            <a:gsLst>
+              <a:gs pos="0">
+                <a:schemeClr val="bg1"/>
+              </a:gs>
+              <a:gs pos="100000">
+                <a:schemeClr val="bg2"/>
+              </a:gs>
+            </a:gsLst>
+            <a:lin ang="2700000" scaled="0"/>
+          </a:gradFill>
+          <a:ln>
+            <a:noFill/>
+          </a:ln>
+          <a:effectLst>
+            <a:outerShdw blurRad="190500" dist="38100" dir="2700000" algn="tl" rotWithShape="0">
+              <a:prstClr val="black">
+                <a:alpha val="15000"/>
+              </a:prstClr>
+            </a:outerShdw>
+          </a:effectLst>
+        </p:spPr>
+        <p:style>
+          <a:lnRef idx="2">
+            <a:schemeClr val="accent1">
+              <a:shade val="50000"/>
+            </a:schemeClr>
+          </a:lnRef>
+          <a:fillRef idx="1">
+            <a:schemeClr val="accent1"/>
+          </a:fillRef>
+          <a:effectRef idx="0">
+            <a:schemeClr val="accent1"/>
+          </a:effectRef>
+          <a:fontRef idx="minor">
+            <a:schemeClr val="lt1"/>
+          </a:fontRef>
+        </p:style>
+        <p:txBody>
+          <a:bodyPr lIns="73152" tIns="0" rIns="73152" bIns="0" rtlCol="0" anchor="t"/>
+          <a:lstStyle/>
+          <a:p>
+            <a:pPr algn="ctr"/>
+            <a:r>
+              <a:rPr lang="nl-NL" sz="1200" b="1" noProof="0" dirty="0">
+                <a:solidFill>
+                  <a:srgbClr val="DB4A3D"/>
+                </a:solidFill>
+              </a:rPr>
+              <a:t>High</a:t>
+            </a:r>
+          </a:p>
+        </p:txBody>
+      </p:sp>
+      <p:sp>
+        <p:nvSpPr>
+          <p:cNvPr id="48" name="Rounded Rectangle 47">
+            <a:extLst>
+              <a:ext uri="{FF2B5EF4-FFF2-40B4-BE49-F238E27FC236}">
+                <a16:creationId xmlns:a16="http://schemas.microsoft.com/office/drawing/2014/main" id="{425C641F-B66E-DC80-C38D-822A10B95814}"/>
+              </a:ext>
+            </a:extLst>
+          </p:cNvPr>
+          <p:cNvSpPr/>
+          <p:nvPr/>
+        </p:nvSpPr>
+        <p:spPr>
+          <a:xfrm flipH="1">
+            <a:off x="7392380" y="3237334"/>
+            <a:ext cx="3086538" cy="3031905"/>
+          </a:xfrm>
+          <a:prstGeom prst="roundRect">
+            <a:avLst>
+              <a:gd name="adj" fmla="val 3837"/>
+            </a:avLst>
+          </a:prstGeom>
+          <a:gradFill>
+            <a:gsLst>
+              <a:gs pos="0">
+                <a:schemeClr val="bg1"/>
+              </a:gs>
+              <a:gs pos="100000">
+                <a:schemeClr val="bg2"/>
+              </a:gs>
+            </a:gsLst>
+            <a:lin ang="2700000" scaled="0"/>
+          </a:gradFill>
+          <a:ln>
+            <a:noFill/>
+          </a:ln>
+          <a:effectLst>
+            <a:outerShdw blurRad="190500" dist="38100" dir="2700000" algn="tl" rotWithShape="0">
+              <a:prstClr val="black">
+                <a:alpha val="15000"/>
+              </a:prstClr>
+            </a:outerShdw>
+          </a:effectLst>
+        </p:spPr>
+        <p:style>
+          <a:lnRef idx="2">
+            <a:schemeClr val="accent1">
+              <a:shade val="50000"/>
+            </a:schemeClr>
+          </a:lnRef>
+          <a:fillRef idx="1">
+            <a:schemeClr val="accent1"/>
+          </a:fillRef>
+          <a:effectRef idx="0">
+            <a:schemeClr val="accent1"/>
+          </a:effectRef>
+          <a:fontRef idx="minor">
+            <a:schemeClr val="lt1"/>
+          </a:fontRef>
+        </p:style>
+        <p:txBody>
+          <a:bodyPr lIns="73152" tIns="0" rIns="73152" bIns="0" rtlCol="0" anchor="t"/>
+          <a:lstStyle/>
+          <a:p>
+            <a:pPr algn="ctr"/>
+            <a:r>
+              <a:rPr lang="nl-NL" sz="1200" b="1" noProof="0" dirty="0">
+                <a:solidFill>
+                  <a:srgbClr val="F09819"/>
+                </a:solidFill>
+              </a:rPr>
+              <a:t>Medium</a:t>
+            </a:r>
+          </a:p>
+        </p:txBody>
+      </p:sp>
+      <p:sp>
+        <p:nvSpPr>
+          <p:cNvPr id="49" name="Rounded Rectangle 48">
+            <a:extLst>
+              <a:ext uri="{FF2B5EF4-FFF2-40B4-BE49-F238E27FC236}">
+                <a16:creationId xmlns:a16="http://schemas.microsoft.com/office/drawing/2014/main" id="{CD49DD0C-66C3-9266-E636-A03AE7C9DFA7}"/>
+              </a:ext>
+            </a:extLst>
+          </p:cNvPr>
+          <p:cNvSpPr/>
+          <p:nvPr/>
+        </p:nvSpPr>
+        <p:spPr>
+          <a:xfrm>
+            <a:off x="207003" y="3495726"/>
+            <a:ext cx="11480030" cy="1314054"/>
+          </a:xfrm>
+          <a:prstGeom prst="roundRect">
+            <a:avLst>
+              <a:gd name="adj" fmla="val 7068"/>
+            </a:avLst>
+          </a:prstGeom>
+          <a:gradFill>
+            <a:gsLst>
+              <a:gs pos="0">
+                <a:schemeClr val="bg1"/>
+              </a:gs>
+              <a:gs pos="100000">
+                <a:schemeClr val="bg2"/>
+              </a:gs>
+            </a:gsLst>
+            <a:lin ang="2700000" scaled="0"/>
+          </a:gradFill>
+          <a:ln>
+            <a:noFill/>
+          </a:ln>
+          <a:effectLst>
+            <a:outerShdw blurRad="190500" dist="38100" dir="2700000" algn="tl" rotWithShape="0">
+              <a:prstClr val="black">
+                <a:alpha val="15000"/>
+              </a:prstClr>
+            </a:outerShdw>
+          </a:effectLst>
+        </p:spPr>
+        <p:style>
+          <a:lnRef idx="2">
+            <a:schemeClr val="accent1">
+              <a:shade val="50000"/>
+            </a:schemeClr>
+          </a:lnRef>
+          <a:fillRef idx="1">
+            <a:schemeClr val="accent1"/>
+          </a:fillRef>
+          <a:effectRef idx="0">
+            <a:schemeClr val="accent1"/>
+          </a:effectRef>
+          <a:fontRef idx="minor">
+            <a:schemeClr val="lt1"/>
+          </a:fontRef>
+        </p:style>
+        <p:txBody>
+          <a:bodyPr vert="vert270" lIns="0" tIns="73152" rIns="0" bIns="73152" rtlCol="0" anchor="t"/>
+          <a:lstStyle/>
+          <a:p>
+            <a:pPr algn="ctr"/>
+            <a:r>
+              <a:rPr lang="en-US" sz="1200" b="1" noProof="0" dirty="0">
+                <a:solidFill>
+                  <a:schemeClr val="accent1"/>
+                </a:solidFill>
+              </a:rPr>
+              <a:t>Open and resolved findings</a:t>
+            </a:r>
+          </a:p>
+        </p:txBody>
+      </p:sp>
+      <p:sp>
+        <p:nvSpPr>
+          <p:cNvPr id="50" name="Rounded Rectangle 49">
+            <a:extLst>
+              <a:ext uri="{FF2B5EF4-FFF2-40B4-BE49-F238E27FC236}">
+                <a16:creationId xmlns:a16="http://schemas.microsoft.com/office/drawing/2014/main" id="{9541F284-CD2B-8E13-4326-72177237DE8A}"/>
+              </a:ext>
+            </a:extLst>
+          </p:cNvPr>
+          <p:cNvSpPr/>
+          <p:nvPr/>
+        </p:nvSpPr>
+        <p:spPr>
+          <a:xfrm>
+            <a:off x="207003" y="4876643"/>
+            <a:ext cx="11480030" cy="1314054"/>
+          </a:xfrm>
+          <a:prstGeom prst="roundRect">
+            <a:avLst>
+              <a:gd name="adj" fmla="val 7068"/>
+            </a:avLst>
+          </a:prstGeom>
+          <a:gradFill>
+            <a:gsLst>
+              <a:gs pos="0">
+                <a:schemeClr val="bg1"/>
+              </a:gs>
+              <a:gs pos="100000">
+                <a:schemeClr val="bg2"/>
+              </a:gs>
+            </a:gsLst>
+            <a:lin ang="2700000" scaled="0"/>
+          </a:gradFill>
+          <a:ln>
+            <a:noFill/>
+          </a:ln>
+          <a:effectLst>
+            <a:outerShdw blurRad="190500" dist="38100" dir="2700000" algn="tl" rotWithShape="0">
+              <a:prstClr val="black">
+                <a:alpha val="15000"/>
+              </a:prstClr>
+            </a:outerShdw>
+          </a:effectLst>
+        </p:spPr>
+        <p:style>
+          <a:lnRef idx="2">
+            <a:schemeClr val="accent1">
+              <a:shade val="50000"/>
+            </a:schemeClr>
+          </a:lnRef>
+          <a:fillRef idx="1">
+            <a:schemeClr val="accent1"/>
+          </a:fillRef>
+          <a:effectRef idx="0">
+            <a:schemeClr val="accent1"/>
+          </a:effectRef>
+          <a:fontRef idx="minor">
+            <a:schemeClr val="lt1"/>
+          </a:fontRef>
+        </p:style>
+        <p:txBody>
+          <a:bodyPr vert="vert270" lIns="0" tIns="73152" rIns="0" bIns="73152" rtlCol="0" anchor="t"/>
+          <a:lstStyle/>
+          <a:p>
+            <a:pPr algn="ctr"/>
+            <a:r>
+              <a:rPr lang="en-US" sz="1200" b="1" noProof="0" dirty="0">
+                <a:solidFill>
+                  <a:schemeClr val="accent1"/>
+                </a:solidFill>
+              </a:rPr>
+              <a:t>Resolution time</a:t>
+            </a:r>
+          </a:p>
+        </p:txBody>
+      </p:sp>
+      <p:sp>
+        <p:nvSpPr>
+          <p:cNvPr id="57" name="TextBox 56">
+            <a:extLst>
+              <a:ext uri="{FF2B5EF4-FFF2-40B4-BE49-F238E27FC236}">
+                <a16:creationId xmlns:a16="http://schemas.microsoft.com/office/drawing/2014/main" id="{571CFFAB-EFDD-8C98-85AC-DBE00381AB5A}"/>
+              </a:ext>
+            </a:extLst>
+          </p:cNvPr>
+          <p:cNvSpPr txBox="1"/>
+          <p:nvPr/>
+        </p:nvSpPr>
+        <p:spPr>
+          <a:xfrm>
+            <a:off x="10685920" y="3914480"/>
+            <a:ext cx="856473" cy="223779"/>
+          </a:xfrm>
+          <a:prstGeom prst="rect">
+            <a:avLst/>
+          </a:prstGeom>
+          <a:noFill/>
+        </p:spPr>
+        <p:txBody>
+          <a:bodyPr wrap="none" lIns="90000" rtlCol="0" anchor="t">
+            <a:spAutoFit/>
+          </a:bodyPr>
+          <a:lstStyle/>
+          <a:p>
+            <a:pPr algn="l">
+              <a:lnSpc>
+                <a:spcPct val="113000"/>
+              </a:lnSpc>
+            </a:pPr>
+            <a:r>
+              <a:rPr lang="en-US" sz="800" dirty="0">
+                <a:solidFill>
+                  <a:schemeClr val="tx2"/>
+                </a:solidFill>
+              </a:rPr>
+              <a:t>Existing findings</a:t>
+            </a:r>
+          </a:p>
+        </p:txBody>
+      </p:sp>
+      <p:sp>
+        <p:nvSpPr>
+          <p:cNvPr id="58" name="TextBox 57">
+            <a:extLst>
+              <a:ext uri="{FF2B5EF4-FFF2-40B4-BE49-F238E27FC236}">
+                <a16:creationId xmlns:a16="http://schemas.microsoft.com/office/drawing/2014/main" id="{E49AE532-6CF4-ED36-78E9-50B68ABEFD32}"/>
+              </a:ext>
+            </a:extLst>
+          </p:cNvPr>
+          <p:cNvSpPr txBox="1"/>
+          <p:nvPr/>
+        </p:nvSpPr>
+        <p:spPr>
+          <a:xfrm>
+            <a:off x="10685920" y="4096769"/>
+            <a:ext cx="728233" cy="223779"/>
+          </a:xfrm>
+          <a:prstGeom prst="rect">
+            <a:avLst/>
+          </a:prstGeom>
+          <a:noFill/>
+        </p:spPr>
+        <p:txBody>
+          <a:bodyPr wrap="none" lIns="90000" rtlCol="0" anchor="t">
+            <a:spAutoFit/>
+          </a:bodyPr>
+          <a:lstStyle/>
+          <a:p>
+            <a:pPr algn="l">
+              <a:lnSpc>
+                <a:spcPct val="113000"/>
+              </a:lnSpc>
+            </a:pPr>
+            <a:r>
+              <a:rPr lang="en-US" sz="800" dirty="0">
+                <a:solidFill>
+                  <a:schemeClr val="tx2"/>
+                </a:solidFill>
+              </a:rPr>
+              <a:t>New findings</a:t>
+            </a:r>
+          </a:p>
+        </p:txBody>
+      </p:sp>
+      <p:sp>
+        <p:nvSpPr>
+          <p:cNvPr id="85" name="TextBox 84">
+            <a:extLst>
+              <a:ext uri="{FF2B5EF4-FFF2-40B4-BE49-F238E27FC236}">
+                <a16:creationId xmlns:a16="http://schemas.microsoft.com/office/drawing/2014/main" id="{5ABF7308-37F3-8EA2-975F-F6C558C139C2}"/>
+              </a:ext>
+            </a:extLst>
+          </p:cNvPr>
+          <p:cNvSpPr txBox="1"/>
+          <p:nvPr/>
+        </p:nvSpPr>
+        <p:spPr>
+          <a:xfrm>
+            <a:off x="10685920" y="4279058"/>
+            <a:ext cx="915785" cy="223779"/>
+          </a:xfrm>
+          <a:prstGeom prst="rect">
+            <a:avLst/>
+          </a:prstGeom>
+          <a:noFill/>
+        </p:spPr>
+        <p:txBody>
+          <a:bodyPr wrap="none" lIns="90000" rtlCol="0" anchor="t">
+            <a:spAutoFit/>
+          </a:bodyPr>
+          <a:lstStyle/>
+          <a:p>
+            <a:pPr algn="l">
+              <a:lnSpc>
+                <a:spcPct val="113000"/>
+              </a:lnSpc>
+            </a:pPr>
+            <a:r>
+              <a:rPr lang="en-US" sz="800" dirty="0">
+                <a:solidFill>
+                  <a:schemeClr val="tx2"/>
+                </a:solidFill>
+              </a:rPr>
+              <a:t>Resolved findings</a:t>
+            </a:r>
+          </a:p>
+        </p:txBody>
+      </p:sp>
+      <p:sp>
+        <p:nvSpPr>
+          <p:cNvPr id="86" name="TextBox 85">
+            <a:extLst>
+              <a:ext uri="{FF2B5EF4-FFF2-40B4-BE49-F238E27FC236}">
+                <a16:creationId xmlns:a16="http://schemas.microsoft.com/office/drawing/2014/main" id="{F66E8A60-AACC-3A37-E7C3-8E8EA1357414}"/>
+              </a:ext>
+            </a:extLst>
+          </p:cNvPr>
+          <p:cNvSpPr txBox="1"/>
+          <p:nvPr/>
+        </p:nvSpPr>
+        <p:spPr>
+          <a:xfrm>
+            <a:off x="10685920" y="5203409"/>
+            <a:ext cx="846855" cy="223779"/>
+          </a:xfrm>
+          <a:prstGeom prst="rect">
+            <a:avLst/>
+          </a:prstGeom>
+          <a:noFill/>
+        </p:spPr>
+        <p:txBody>
+          <a:bodyPr wrap="none" lIns="90000" rtlCol="0" anchor="t">
+            <a:spAutoFit/>
+          </a:bodyPr>
+          <a:lstStyle/>
+          <a:p>
+            <a:pPr algn="l">
+              <a:lnSpc>
+                <a:spcPct val="113000"/>
+              </a:lnSpc>
+            </a:pPr>
+            <a:r>
+              <a:rPr lang="en-US" sz="800" dirty="0">
+                <a:solidFill>
+                  <a:schemeClr val="tx2"/>
+                </a:solidFill>
+              </a:rPr>
+              <a:t>At most 30 days</a:t>
+            </a:r>
+          </a:p>
+        </p:txBody>
+      </p:sp>
+      <p:sp>
+        <p:nvSpPr>
+          <p:cNvPr id="87" name="TextBox 86">
+            <a:extLst>
+              <a:ext uri="{FF2B5EF4-FFF2-40B4-BE49-F238E27FC236}">
+                <a16:creationId xmlns:a16="http://schemas.microsoft.com/office/drawing/2014/main" id="{219DFB87-5463-8FF3-0A60-20E4C1163724}"/>
+              </a:ext>
+            </a:extLst>
+          </p:cNvPr>
+          <p:cNvSpPr txBox="1"/>
+          <p:nvPr/>
+        </p:nvSpPr>
+        <p:spPr>
+          <a:xfrm>
+            <a:off x="10685920" y="5385698"/>
+            <a:ext cx="684952" cy="223779"/>
+          </a:xfrm>
+          <a:prstGeom prst="rect">
+            <a:avLst/>
+          </a:prstGeom>
+          <a:noFill/>
+        </p:spPr>
+        <p:txBody>
+          <a:bodyPr wrap="none" lIns="90000" rtlCol="0" anchor="t">
+            <a:spAutoFit/>
+          </a:bodyPr>
+          <a:lstStyle/>
+          <a:p>
+            <a:pPr algn="l">
+              <a:lnSpc>
+                <a:spcPct val="113000"/>
+              </a:lnSpc>
+            </a:pPr>
+            <a:r>
+              <a:rPr lang="en-US" sz="800" dirty="0">
+                <a:solidFill>
+                  <a:schemeClr val="tx2"/>
+                </a:solidFill>
+              </a:rPr>
+              <a:t>30-180 days</a:t>
+            </a:r>
+          </a:p>
+        </p:txBody>
+      </p:sp>
+      <p:sp>
+        <p:nvSpPr>
+          <p:cNvPr id="88" name="TextBox 87">
+            <a:extLst>
+              <a:ext uri="{FF2B5EF4-FFF2-40B4-BE49-F238E27FC236}">
+                <a16:creationId xmlns:a16="http://schemas.microsoft.com/office/drawing/2014/main" id="{79099BC1-E198-5D17-B560-93946792D4F1}"/>
+              </a:ext>
+            </a:extLst>
+          </p:cNvPr>
+          <p:cNvSpPr txBox="1"/>
+          <p:nvPr/>
+        </p:nvSpPr>
+        <p:spPr>
+          <a:xfrm>
+            <a:off x="10685920" y="5567987"/>
+            <a:ext cx="736248" cy="223779"/>
+          </a:xfrm>
+          <a:prstGeom prst="rect">
+            <a:avLst/>
+          </a:prstGeom>
+          <a:noFill/>
+        </p:spPr>
+        <p:txBody>
+          <a:bodyPr wrap="none" lIns="90000" rtlCol="0" anchor="t">
+            <a:spAutoFit/>
+          </a:bodyPr>
+          <a:lstStyle/>
+          <a:p>
+            <a:pPr algn="l">
+              <a:lnSpc>
+                <a:spcPct val="113000"/>
+              </a:lnSpc>
+            </a:pPr>
+            <a:r>
+              <a:rPr lang="en-US" sz="800" dirty="0">
+                <a:solidFill>
+                  <a:schemeClr val="tx2"/>
+                </a:solidFill>
+              </a:rPr>
+              <a:t>180-365 days</a:t>
+            </a:r>
+          </a:p>
+        </p:txBody>
+      </p:sp>
+      <p:sp>
+        <p:nvSpPr>
+          <p:cNvPr id="89" name="TextBox 88">
+            <a:extLst>
+              <a:ext uri="{FF2B5EF4-FFF2-40B4-BE49-F238E27FC236}">
+                <a16:creationId xmlns:a16="http://schemas.microsoft.com/office/drawing/2014/main" id="{76D3C359-CD68-8B7A-9AD9-800D632925E5}"/>
+              </a:ext>
+            </a:extLst>
+          </p:cNvPr>
+          <p:cNvSpPr txBox="1"/>
+          <p:nvPr/>
+        </p:nvSpPr>
+        <p:spPr>
+          <a:xfrm>
+            <a:off x="10685920" y="5750276"/>
+            <a:ext cx="886931" cy="223779"/>
+          </a:xfrm>
+          <a:prstGeom prst="rect">
+            <a:avLst/>
+          </a:prstGeom>
+          <a:noFill/>
+        </p:spPr>
+        <p:txBody>
+          <a:bodyPr wrap="none" lIns="90000" rtlCol="0" anchor="t">
+            <a:spAutoFit/>
+          </a:bodyPr>
+          <a:lstStyle/>
+          <a:p>
+            <a:pPr algn="l">
+              <a:lnSpc>
+                <a:spcPct val="113000"/>
+              </a:lnSpc>
+            </a:pPr>
+            <a:r>
+              <a:rPr lang="en-US" sz="800" dirty="0">
+                <a:solidFill>
+                  <a:schemeClr val="tx2"/>
+                </a:solidFill>
+              </a:rPr>
+              <a:t>At least 365 days</a:t>
+            </a:r>
+          </a:p>
+        </p:txBody>
+      </p:sp>
+      <p:sp>
+        <p:nvSpPr>
+          <p:cNvPr id="90" name="Rounded Rectangle 89">
+            <a:extLst>
+              <a:ext uri="{FF2B5EF4-FFF2-40B4-BE49-F238E27FC236}">
+                <a16:creationId xmlns:a16="http://schemas.microsoft.com/office/drawing/2014/main" id="{F0ACD575-00A0-9ADB-615A-2516E8D62FE6}"/>
+              </a:ext>
+            </a:extLst>
+          </p:cNvPr>
+          <p:cNvSpPr/>
+          <p:nvPr/>
+        </p:nvSpPr>
+        <p:spPr>
+          <a:xfrm>
+            <a:off x="10555012" y="5277286"/>
+            <a:ext cx="168322" cy="91833"/>
+          </a:xfrm>
+          <a:prstGeom prst="roundRect">
+            <a:avLst/>
+          </a:prstGeom>
+          <a:solidFill>
+            <a:srgbClr val="C6CD60"/>
+          </a:solidFill>
+          <a:ln>
+            <a:noFill/>
+          </a:ln>
+        </p:spPr>
+        <p:style>
+          <a:lnRef idx="2">
+            <a:schemeClr val="accent1">
+              <a:shade val="50000"/>
+            </a:schemeClr>
+          </a:lnRef>
+          <a:fillRef idx="1">
+            <a:schemeClr val="accent1"/>
+          </a:fillRef>
+          <a:effectRef idx="0">
+            <a:schemeClr val="accent1"/>
+          </a:effectRef>
+          <a:fontRef idx="minor">
+            <a:schemeClr val="lt1"/>
+          </a:fontRef>
+        </p:style>
+        <p:txBody>
+          <a:bodyPr lIns="108000" tIns="72000" rIns="108000" bIns="72000" rtlCol="0" anchor="ctr"/>
+          <a:lstStyle/>
+          <a:p>
+            <a:pPr algn="ctr"/>
+            <a:endParaRPr lang="en-US" sz="1600" dirty="0" err="1">
+              <a:solidFill>
+                <a:schemeClr val="bg1"/>
+              </a:solidFill>
+            </a:endParaRPr>
+          </a:p>
+        </p:txBody>
+      </p:sp>
+      <p:sp>
+        <p:nvSpPr>
+          <p:cNvPr id="91" name="Rounded Rectangle 90">
+            <a:extLst>
+              <a:ext uri="{FF2B5EF4-FFF2-40B4-BE49-F238E27FC236}">
+                <a16:creationId xmlns:a16="http://schemas.microsoft.com/office/drawing/2014/main" id="{BD5B81D3-8D2C-5BA1-AD33-C5B66FA98BDE}"/>
+              </a:ext>
+            </a:extLst>
+          </p:cNvPr>
+          <p:cNvSpPr/>
+          <p:nvPr/>
+        </p:nvSpPr>
+        <p:spPr>
+          <a:xfrm>
+            <a:off x="10555012" y="5458208"/>
+            <a:ext cx="168322" cy="91833"/>
+          </a:xfrm>
+          <a:prstGeom prst="roundRect">
+            <a:avLst/>
+          </a:prstGeom>
+          <a:solidFill>
+            <a:srgbClr val="C8BED7"/>
+          </a:solidFill>
+          <a:ln>
+            <a:noFill/>
+          </a:ln>
+        </p:spPr>
+        <p:style>
+          <a:lnRef idx="2">
+            <a:schemeClr val="accent1">
+              <a:shade val="50000"/>
+            </a:schemeClr>
+          </a:lnRef>
+          <a:fillRef idx="1">
+            <a:schemeClr val="accent1"/>
+          </a:fillRef>
+          <a:effectRef idx="0">
+            <a:schemeClr val="accent1"/>
+          </a:effectRef>
+          <a:fontRef idx="minor">
+            <a:schemeClr val="lt1"/>
+          </a:fontRef>
+        </p:style>
+        <p:txBody>
+          <a:bodyPr lIns="108000" tIns="72000" rIns="108000" bIns="72000" rtlCol="0" anchor="ctr"/>
+          <a:lstStyle/>
+          <a:p>
+            <a:pPr algn="ctr"/>
+            <a:endParaRPr lang="en-US" sz="1600" dirty="0" err="1">
+              <a:solidFill>
+                <a:schemeClr val="bg1"/>
+              </a:solidFill>
+            </a:endParaRPr>
+          </a:p>
+        </p:txBody>
+      </p:sp>
+      <p:sp>
+        <p:nvSpPr>
+          <p:cNvPr id="92" name="Rounded Rectangle 91">
+            <a:extLst>
+              <a:ext uri="{FF2B5EF4-FFF2-40B4-BE49-F238E27FC236}">
+                <a16:creationId xmlns:a16="http://schemas.microsoft.com/office/drawing/2014/main" id="{C1406FCC-71DD-1FDC-A2A4-7B7F1E4B91FC}"/>
+              </a:ext>
+            </a:extLst>
+          </p:cNvPr>
+          <p:cNvSpPr/>
+          <p:nvPr/>
+        </p:nvSpPr>
+        <p:spPr>
+          <a:xfrm>
+            <a:off x="10555012" y="5639130"/>
+            <a:ext cx="168322" cy="91833"/>
+          </a:xfrm>
+          <a:prstGeom prst="roundRect">
+            <a:avLst/>
+          </a:prstGeom>
+          <a:solidFill>
+            <a:srgbClr val="A694BE"/>
+          </a:solidFill>
+          <a:ln>
+            <a:noFill/>
+          </a:ln>
+        </p:spPr>
+        <p:style>
+          <a:lnRef idx="2">
+            <a:schemeClr val="accent1">
+              <a:shade val="50000"/>
+            </a:schemeClr>
+          </a:lnRef>
+          <a:fillRef idx="1">
+            <a:schemeClr val="accent1"/>
+          </a:fillRef>
+          <a:effectRef idx="0">
+            <a:schemeClr val="accent1"/>
+          </a:effectRef>
+          <a:fontRef idx="minor">
+            <a:schemeClr val="lt1"/>
+          </a:fontRef>
+        </p:style>
+        <p:txBody>
+          <a:bodyPr lIns="108000" tIns="72000" rIns="108000" bIns="72000" rtlCol="0" anchor="ctr"/>
+          <a:lstStyle/>
+          <a:p>
+            <a:pPr algn="ctr"/>
+            <a:endParaRPr lang="en-US" sz="1600" dirty="0" err="1">
+              <a:solidFill>
+                <a:schemeClr val="bg1"/>
+              </a:solidFill>
+            </a:endParaRPr>
+          </a:p>
+        </p:txBody>
+      </p:sp>
+      <p:sp>
+        <p:nvSpPr>
+          <p:cNvPr id="93" name="Rounded Rectangle 92">
+            <a:extLst>
+              <a:ext uri="{FF2B5EF4-FFF2-40B4-BE49-F238E27FC236}">
+                <a16:creationId xmlns:a16="http://schemas.microsoft.com/office/drawing/2014/main" id="{C88CBBCA-EDC1-BFE3-5202-969B344A3C5E}"/>
+              </a:ext>
+            </a:extLst>
+          </p:cNvPr>
+          <p:cNvSpPr/>
+          <p:nvPr/>
+        </p:nvSpPr>
+        <p:spPr>
+          <a:xfrm>
+            <a:off x="10555012" y="5820051"/>
+            <a:ext cx="168322" cy="91833"/>
+          </a:xfrm>
+          <a:prstGeom prst="roundRect">
+            <a:avLst/>
+          </a:prstGeom>
+          <a:solidFill>
+            <a:srgbClr val="836BA5"/>
+          </a:solidFill>
+          <a:ln>
+            <a:noFill/>
+          </a:ln>
+        </p:spPr>
+        <p:style>
+          <a:lnRef idx="2">
+            <a:schemeClr val="accent1">
+              <a:shade val="50000"/>
+            </a:schemeClr>
+          </a:lnRef>
+          <a:fillRef idx="1">
+            <a:schemeClr val="accent1"/>
+          </a:fillRef>
+          <a:effectRef idx="0">
+            <a:schemeClr val="accent1"/>
+          </a:effectRef>
+          <a:fontRef idx="minor">
+            <a:schemeClr val="lt1"/>
+          </a:fontRef>
+        </p:style>
+        <p:txBody>
+          <a:bodyPr lIns="108000" tIns="72000" rIns="108000" bIns="72000" rtlCol="0" anchor="ctr"/>
+          <a:lstStyle/>
+          <a:p>
+            <a:pPr algn="ctr"/>
+            <a:endParaRPr lang="en-US" sz="1600" dirty="0" err="1">
+              <a:solidFill>
+                <a:schemeClr val="bg1"/>
+              </a:solidFill>
+            </a:endParaRPr>
+          </a:p>
+        </p:txBody>
+      </p:sp>
+      <p:sp>
+        <p:nvSpPr>
+          <p:cNvPr id="94" name="Rounded Rectangle 93">
+            <a:extLst>
+              <a:ext uri="{FF2B5EF4-FFF2-40B4-BE49-F238E27FC236}">
+                <a16:creationId xmlns:a16="http://schemas.microsoft.com/office/drawing/2014/main" id="{B5B03021-B0E1-D3DF-666F-604DCD5CD0D4}"/>
+              </a:ext>
+            </a:extLst>
+          </p:cNvPr>
+          <p:cNvSpPr/>
+          <p:nvPr/>
+        </p:nvSpPr>
+        <p:spPr>
+          <a:xfrm>
+            <a:off x="10555012" y="3982475"/>
+            <a:ext cx="168322" cy="91833"/>
+          </a:xfrm>
+          <a:prstGeom prst="roundRect">
+            <a:avLst/>
+          </a:prstGeom>
+          <a:solidFill>
+            <a:srgbClr val="334E68"/>
+          </a:solidFill>
+          <a:ln>
+            <a:noFill/>
+          </a:ln>
+        </p:spPr>
+        <p:style>
+          <a:lnRef idx="2">
+            <a:schemeClr val="accent1">
+              <a:shade val="50000"/>
+            </a:schemeClr>
+          </a:lnRef>
+          <a:fillRef idx="1">
+            <a:schemeClr val="accent1"/>
+          </a:fillRef>
+          <a:effectRef idx="0">
+            <a:schemeClr val="accent1"/>
+          </a:effectRef>
+          <a:fontRef idx="minor">
+            <a:schemeClr val="lt1"/>
+          </a:fontRef>
+        </p:style>
+        <p:txBody>
+          <a:bodyPr lIns="108000" tIns="72000" rIns="108000" bIns="72000" rtlCol="0" anchor="ctr"/>
+          <a:lstStyle/>
+          <a:p>
+            <a:pPr algn="ctr"/>
+            <a:endParaRPr lang="en-US" sz="1600" dirty="0" err="1">
+              <a:solidFill>
+                <a:schemeClr val="bg1"/>
+              </a:solidFill>
+            </a:endParaRPr>
+          </a:p>
+        </p:txBody>
+      </p:sp>
+      <p:sp>
+        <p:nvSpPr>
+          <p:cNvPr id="95" name="Rounded Rectangle 94">
+            <a:extLst>
+              <a:ext uri="{FF2B5EF4-FFF2-40B4-BE49-F238E27FC236}">
+                <a16:creationId xmlns:a16="http://schemas.microsoft.com/office/drawing/2014/main" id="{7732D24F-0C97-A5E3-5BE3-86EB1DD5A459}"/>
+              </a:ext>
+            </a:extLst>
+          </p:cNvPr>
+          <p:cNvSpPr/>
+          <p:nvPr/>
+        </p:nvSpPr>
+        <p:spPr>
+          <a:xfrm>
+            <a:off x="10555012" y="4165683"/>
+            <a:ext cx="168322" cy="91833"/>
+          </a:xfrm>
+          <a:prstGeom prst="roundRect">
+            <a:avLst/>
+          </a:prstGeom>
+          <a:solidFill>
+            <a:srgbClr val="9DAAB7"/>
+          </a:solidFill>
+          <a:ln>
+            <a:noFill/>
+          </a:ln>
+        </p:spPr>
+        <p:style>
+          <a:lnRef idx="2">
+            <a:schemeClr val="accent1">
+              <a:shade val="50000"/>
+            </a:schemeClr>
+          </a:lnRef>
+          <a:fillRef idx="1">
+            <a:schemeClr val="accent1"/>
+          </a:fillRef>
+          <a:effectRef idx="0">
+            <a:schemeClr val="accent1"/>
+          </a:effectRef>
+          <a:fontRef idx="minor">
+            <a:schemeClr val="lt1"/>
+          </a:fontRef>
+        </p:style>
+        <p:txBody>
+          <a:bodyPr lIns="108000" tIns="72000" rIns="108000" bIns="72000" rtlCol="0" anchor="ctr"/>
+          <a:lstStyle/>
+          <a:p>
+            <a:pPr algn="ctr"/>
+            <a:endParaRPr lang="en-US" sz="1600" dirty="0" err="1">
+              <a:solidFill>
+                <a:schemeClr val="bg1"/>
+              </a:solidFill>
+            </a:endParaRPr>
+          </a:p>
+        </p:txBody>
+      </p:sp>
+      <p:sp>
+        <p:nvSpPr>
+          <p:cNvPr id="96" name="Rounded Rectangle 95">
+            <a:extLst>
+              <a:ext uri="{FF2B5EF4-FFF2-40B4-BE49-F238E27FC236}">
+                <a16:creationId xmlns:a16="http://schemas.microsoft.com/office/drawing/2014/main" id="{664468DD-F725-773E-BAB7-98DCF200E9F7}"/>
+              </a:ext>
+            </a:extLst>
+          </p:cNvPr>
+          <p:cNvSpPr/>
+          <p:nvPr/>
+        </p:nvSpPr>
+        <p:spPr>
+          <a:xfrm>
+            <a:off x="10555012" y="4348891"/>
+            <a:ext cx="168322" cy="91833"/>
+          </a:xfrm>
+          <a:prstGeom prst="roundRect">
+            <a:avLst/>
+          </a:prstGeom>
+          <a:solidFill>
+            <a:srgbClr val="C6CD60"/>
+          </a:solidFill>
+          <a:ln>
+            <a:noFill/>
+          </a:ln>
+        </p:spPr>
+        <p:style>
+          <a:lnRef idx="2">
+            <a:schemeClr val="accent1">
+              <a:shade val="50000"/>
+            </a:schemeClr>
+          </a:lnRef>
+          <a:fillRef idx="1">
+            <a:schemeClr val="accent1"/>
+          </a:fillRef>
+          <a:effectRef idx="0">
+            <a:schemeClr val="accent1"/>
+          </a:effectRef>
+          <a:fontRef idx="minor">
+            <a:schemeClr val="lt1"/>
+          </a:fontRef>
+        </p:style>
+        <p:txBody>
+          <a:bodyPr lIns="108000" tIns="72000" rIns="108000" bIns="72000" rtlCol="0" anchor="ctr"/>
+          <a:lstStyle/>
+          <a:p>
+            <a:pPr algn="ctr"/>
+            <a:endParaRPr lang="en-US" sz="1600" dirty="0" err="1">
+              <a:solidFill>
+                <a:schemeClr val="bg1"/>
+              </a:solidFill>
+            </a:endParaRPr>
+          </a:p>
+        </p:txBody>
+      </p:sp>
+      <p:sp>
+        <p:nvSpPr>
+          <p:cNvPr id="4" name="TextBox 3">
+            <a:extLst>
+              <a:ext uri="{FF2B5EF4-FFF2-40B4-BE49-F238E27FC236}">
+                <a16:creationId xmlns:a16="http://schemas.microsoft.com/office/drawing/2014/main" id="{69D0D5CB-F67C-03CB-84F5-8ADF2D529748}"/>
+              </a:ext>
+            </a:extLst>
+          </p:cNvPr>
+          <p:cNvSpPr txBox="1"/>
+          <p:nvPr/>
+        </p:nvSpPr>
+        <p:spPr>
+          <a:xfrm>
+            <a:off x="3847211" y="6948976"/>
+            <a:ext cx="1125778" cy="223844"/>
+          </a:xfrm>
+          <a:prstGeom prst="rect">
+            <a:avLst/>
+          </a:prstGeom>
+          <a:noFill/>
+        </p:spPr>
+        <p:txBody>
+          <a:bodyPr wrap="none" lIns="90000" rtlCol="0" anchor="t">
+            <a:spAutoFit/>
+          </a:bodyPr>
+          <a:lstStyle/>
+          <a:p>
+            <a:pPr algn="l">
+              <a:lnSpc>
+                <a:spcPct val="113000"/>
+              </a:lnSpc>
+            </a:pPr>
+            <a:r>
+              <a:rPr lang="en-US" sz="800" dirty="0">
+                <a:solidFill>
+                  <a:schemeClr val="tx2"/>
+                </a:solidFill>
+              </a:rPr>
+              <a:t>New findings (2D6BFF)</a:t>
+            </a:r>
+          </a:p>
+        </p:txBody>
+      </p:sp>
+      <p:sp>
+        <p:nvSpPr>
+          <p:cNvPr id="5" name="TextBox 4">
+            <a:extLst>
+              <a:ext uri="{FF2B5EF4-FFF2-40B4-BE49-F238E27FC236}">
+                <a16:creationId xmlns:a16="http://schemas.microsoft.com/office/drawing/2014/main" id="{ABFB516C-5A42-1576-24CA-C03D1717DE69}"/>
+              </a:ext>
+            </a:extLst>
+          </p:cNvPr>
+          <p:cNvSpPr txBox="1"/>
+          <p:nvPr/>
+        </p:nvSpPr>
+        <p:spPr>
+          <a:xfrm>
+            <a:off x="3847211" y="7131265"/>
+            <a:ext cx="1258827" cy="223844"/>
+          </a:xfrm>
+          <a:prstGeom prst="rect">
+            <a:avLst/>
+          </a:prstGeom>
+          <a:noFill/>
+        </p:spPr>
+        <p:txBody>
+          <a:bodyPr wrap="none" lIns="90000" rtlCol="0" anchor="t">
+            <a:spAutoFit/>
+          </a:bodyPr>
+          <a:lstStyle/>
+          <a:p>
+            <a:pPr algn="l">
+              <a:lnSpc>
+                <a:spcPct val="113000"/>
+              </a:lnSpc>
+            </a:pPr>
+            <a:r>
+              <a:rPr lang="en-US" sz="800" dirty="0">
+                <a:solidFill>
+                  <a:schemeClr val="tx2"/>
+                </a:solidFill>
+              </a:rPr>
+              <a:t>Existing findings (B8C3FA)</a:t>
+            </a:r>
+          </a:p>
+        </p:txBody>
+      </p:sp>
+      <p:sp>
+        <p:nvSpPr>
+          <p:cNvPr id="9" name="TextBox 8">
+            <a:extLst>
+              <a:ext uri="{FF2B5EF4-FFF2-40B4-BE49-F238E27FC236}">
+                <a16:creationId xmlns:a16="http://schemas.microsoft.com/office/drawing/2014/main" id="{336EDEA9-04DF-E723-1F5B-FACCD40A8CF2}"/>
+              </a:ext>
+            </a:extLst>
+          </p:cNvPr>
+          <p:cNvSpPr txBox="1"/>
+          <p:nvPr/>
+        </p:nvSpPr>
+        <p:spPr>
+          <a:xfrm>
+            <a:off x="3847211" y="7313554"/>
+            <a:ext cx="1308520" cy="223844"/>
+          </a:xfrm>
+          <a:prstGeom prst="rect">
+            <a:avLst/>
+          </a:prstGeom>
+          <a:noFill/>
+        </p:spPr>
+        <p:txBody>
+          <a:bodyPr wrap="none" lIns="90000" rtlCol="0" anchor="t">
+            <a:spAutoFit/>
+          </a:bodyPr>
+          <a:lstStyle/>
+          <a:p>
+            <a:pPr algn="l">
+              <a:lnSpc>
+                <a:spcPct val="113000"/>
+              </a:lnSpc>
+            </a:pPr>
+            <a:r>
+              <a:rPr lang="en-US" sz="800" dirty="0">
+                <a:solidFill>
+                  <a:schemeClr val="tx2"/>
+                </a:solidFill>
+              </a:rPr>
+              <a:t>Resolved findings (E9C343)</a:t>
+            </a:r>
+          </a:p>
+        </p:txBody>
+      </p:sp>
+      <p:sp>
+        <p:nvSpPr>
+          <p:cNvPr id="10" name="Rounded Rectangle 9">
+            <a:extLst>
+              <a:ext uri="{FF2B5EF4-FFF2-40B4-BE49-F238E27FC236}">
+                <a16:creationId xmlns:a16="http://schemas.microsoft.com/office/drawing/2014/main" id="{B824A3D6-404E-6681-8BD2-1FB97DED7179}"/>
+              </a:ext>
+            </a:extLst>
+          </p:cNvPr>
+          <p:cNvSpPr/>
+          <p:nvPr/>
+        </p:nvSpPr>
+        <p:spPr>
+          <a:xfrm>
+            <a:off x="3716303" y="7016971"/>
+            <a:ext cx="168322" cy="91833"/>
+          </a:xfrm>
+          <a:prstGeom prst="roundRect">
+            <a:avLst/>
+          </a:prstGeom>
+          <a:solidFill>
+            <a:srgbClr val="2D6BFF"/>
+          </a:solidFill>
+          <a:ln>
+            <a:noFill/>
+          </a:ln>
+        </p:spPr>
+        <p:style>
+          <a:lnRef idx="2">
+            <a:schemeClr val="accent1">
+              <a:shade val="50000"/>
+            </a:schemeClr>
+          </a:lnRef>
+          <a:fillRef idx="1">
+            <a:schemeClr val="accent1"/>
+          </a:fillRef>
+          <a:effectRef idx="0">
+            <a:schemeClr val="accent1"/>
+          </a:effectRef>
+          <a:fontRef idx="minor">
+            <a:schemeClr val="lt1"/>
+          </a:fontRef>
+        </p:style>
+        <p:txBody>
+          <a:bodyPr lIns="108000" tIns="72000" rIns="108000" bIns="72000" rtlCol="0" anchor="ctr"/>
+          <a:lstStyle/>
+          <a:p>
+            <a:pPr algn="ctr"/>
+            <a:endParaRPr lang="en-US" sz="1600" dirty="0" err="1">
+              <a:solidFill>
+                <a:schemeClr val="bg1"/>
+              </a:solidFill>
+            </a:endParaRPr>
+          </a:p>
+        </p:txBody>
+      </p:sp>
+      <p:sp>
+        <p:nvSpPr>
+          <p:cNvPr id="11" name="Rounded Rectangle 10">
+            <a:extLst>
+              <a:ext uri="{FF2B5EF4-FFF2-40B4-BE49-F238E27FC236}">
+                <a16:creationId xmlns:a16="http://schemas.microsoft.com/office/drawing/2014/main" id="{E5D8105E-4BD3-946A-3386-67F8816B5245}"/>
+              </a:ext>
+            </a:extLst>
+          </p:cNvPr>
+          <p:cNvSpPr/>
+          <p:nvPr/>
+        </p:nvSpPr>
+        <p:spPr>
+          <a:xfrm>
+            <a:off x="3716303" y="7200179"/>
+            <a:ext cx="168322" cy="91833"/>
+          </a:xfrm>
+          <a:prstGeom prst="roundRect">
+            <a:avLst/>
+          </a:prstGeom>
+          <a:solidFill>
+            <a:srgbClr val="B6C4FF"/>
+          </a:solidFill>
+          <a:ln>
+            <a:noFill/>
+          </a:ln>
+        </p:spPr>
+        <p:style>
+          <a:lnRef idx="2">
+            <a:schemeClr val="accent1">
+              <a:shade val="50000"/>
+            </a:schemeClr>
+          </a:lnRef>
+          <a:fillRef idx="1">
+            <a:schemeClr val="accent1"/>
+          </a:fillRef>
+          <a:effectRef idx="0">
+            <a:schemeClr val="accent1"/>
+          </a:effectRef>
+          <a:fontRef idx="minor">
+            <a:schemeClr val="lt1"/>
+          </a:fontRef>
+        </p:style>
+        <p:txBody>
+          <a:bodyPr lIns="108000" tIns="72000" rIns="108000" bIns="72000" rtlCol="0" anchor="ctr"/>
+          <a:lstStyle/>
+          <a:p>
+            <a:pPr algn="ctr"/>
+            <a:endParaRPr lang="en-US" sz="1600" dirty="0" err="1">
+              <a:solidFill>
+                <a:schemeClr val="bg1"/>
+              </a:solidFill>
+            </a:endParaRPr>
+          </a:p>
+        </p:txBody>
+      </p:sp>
+      <p:sp>
+        <p:nvSpPr>
+          <p:cNvPr id="12" name="Rounded Rectangle 11">
+            <a:extLst>
+              <a:ext uri="{FF2B5EF4-FFF2-40B4-BE49-F238E27FC236}">
+                <a16:creationId xmlns:a16="http://schemas.microsoft.com/office/drawing/2014/main" id="{F708B75B-A95C-C433-F392-F80FA8AED1D8}"/>
+              </a:ext>
+            </a:extLst>
+          </p:cNvPr>
+          <p:cNvSpPr/>
+          <p:nvPr/>
+        </p:nvSpPr>
+        <p:spPr>
+          <a:xfrm>
+            <a:off x="3716303" y="7383387"/>
+            <a:ext cx="168322" cy="91833"/>
+          </a:xfrm>
+          <a:prstGeom prst="roundRect">
+            <a:avLst/>
+          </a:prstGeom>
+          <a:solidFill>
+            <a:srgbClr val="F1C109"/>
+          </a:solidFill>
+          <a:ln>
+            <a:noFill/>
+          </a:ln>
+        </p:spPr>
+        <p:style>
+          <a:lnRef idx="2">
+            <a:schemeClr val="accent1">
+              <a:shade val="50000"/>
+            </a:schemeClr>
+          </a:lnRef>
+          <a:fillRef idx="1">
+            <a:schemeClr val="accent1"/>
+          </a:fillRef>
+          <a:effectRef idx="0">
+            <a:schemeClr val="accent1"/>
+          </a:effectRef>
+          <a:fontRef idx="minor">
+            <a:schemeClr val="lt1"/>
+          </a:fontRef>
+        </p:style>
+        <p:txBody>
+          <a:bodyPr lIns="108000" tIns="72000" rIns="108000" bIns="72000" rtlCol="0" anchor="ctr"/>
+          <a:lstStyle/>
+          <a:p>
+            <a:pPr algn="ctr"/>
+            <a:endParaRPr lang="en-US" sz="1600" dirty="0" err="1">
+              <a:solidFill>
+                <a:schemeClr val="bg1"/>
+              </a:solidFill>
+            </a:endParaRPr>
+          </a:p>
+        </p:txBody>
+      </p:sp>
+      <p:sp>
+        <p:nvSpPr>
+          <p:cNvPr id="13" name="TextBox 12">
+            <a:extLst>
+              <a:ext uri="{FF2B5EF4-FFF2-40B4-BE49-F238E27FC236}">
+                <a16:creationId xmlns:a16="http://schemas.microsoft.com/office/drawing/2014/main" id="{EDD86F90-B83C-95D2-0263-C0960F4176D9}"/>
+              </a:ext>
+            </a:extLst>
+          </p:cNvPr>
+          <p:cNvSpPr txBox="1"/>
+          <p:nvPr/>
+        </p:nvSpPr>
+        <p:spPr>
+          <a:xfrm>
+            <a:off x="6355405" y="6948976"/>
+            <a:ext cx="1645151" cy="223844"/>
+          </a:xfrm>
+          <a:prstGeom prst="rect">
+            <a:avLst/>
+          </a:prstGeom>
+          <a:noFill/>
+        </p:spPr>
+        <p:txBody>
+          <a:bodyPr wrap="none" lIns="90000" rtlCol="0" anchor="t">
+            <a:spAutoFit/>
+          </a:bodyPr>
+          <a:lstStyle/>
+          <a:p>
+            <a:pPr>
+              <a:lnSpc>
+                <a:spcPct val="113000"/>
+              </a:lnSpc>
+            </a:pPr>
+            <a:r>
+              <a:rPr lang="en-US" sz="800" dirty="0">
+                <a:solidFill>
+                  <a:schemeClr val="tx2"/>
+                </a:solidFill>
+              </a:rPr>
+              <a:t>At most 7 / 14 / 30 /  days (2D6BFF)</a:t>
+            </a:r>
+          </a:p>
+        </p:txBody>
+      </p:sp>
+      <p:sp>
+        <p:nvSpPr>
+          <p:cNvPr id="14" name="TextBox 13">
+            <a:extLst>
+              <a:ext uri="{FF2B5EF4-FFF2-40B4-BE49-F238E27FC236}">
+                <a16:creationId xmlns:a16="http://schemas.microsoft.com/office/drawing/2014/main" id="{F934EFB9-5610-46A8-02BF-DD91B6F97E06}"/>
+              </a:ext>
+            </a:extLst>
+          </p:cNvPr>
+          <p:cNvSpPr txBox="1"/>
+          <p:nvPr/>
+        </p:nvSpPr>
+        <p:spPr>
+          <a:xfrm>
+            <a:off x="6355405" y="7131265"/>
+            <a:ext cx="1670799" cy="223844"/>
+          </a:xfrm>
+          <a:prstGeom prst="rect">
+            <a:avLst/>
+          </a:prstGeom>
+          <a:noFill/>
+        </p:spPr>
+        <p:txBody>
+          <a:bodyPr wrap="none" lIns="90000" rtlCol="0" anchor="t">
+            <a:spAutoFit/>
+          </a:bodyPr>
+          <a:lstStyle/>
+          <a:p>
+            <a:pPr algn="l">
+              <a:lnSpc>
+                <a:spcPct val="113000"/>
+              </a:lnSpc>
+            </a:pPr>
+            <a:r>
+              <a:rPr lang="en-US" sz="800" dirty="0">
+                <a:solidFill>
+                  <a:schemeClr val="tx2"/>
+                </a:solidFill>
+              </a:rPr>
+              <a:t>7-14 / 14-30 / 30-180 days (E9C343)</a:t>
+            </a:r>
+          </a:p>
+        </p:txBody>
+      </p:sp>
+      <p:sp>
+        <p:nvSpPr>
+          <p:cNvPr id="15" name="TextBox 14">
+            <a:extLst>
+              <a:ext uri="{FF2B5EF4-FFF2-40B4-BE49-F238E27FC236}">
+                <a16:creationId xmlns:a16="http://schemas.microsoft.com/office/drawing/2014/main" id="{02ED2BEC-6CE3-1F2A-CDC3-36BB37E09BD1}"/>
+              </a:ext>
+            </a:extLst>
+          </p:cNvPr>
+          <p:cNvSpPr txBox="1"/>
+          <p:nvPr/>
+        </p:nvSpPr>
+        <p:spPr>
+          <a:xfrm>
+            <a:off x="6355405" y="7313554"/>
+            <a:ext cx="1834305" cy="223844"/>
+          </a:xfrm>
+          <a:prstGeom prst="rect">
+            <a:avLst/>
+          </a:prstGeom>
+          <a:noFill/>
+        </p:spPr>
+        <p:txBody>
+          <a:bodyPr wrap="none" lIns="90000" rtlCol="0" anchor="t">
+            <a:spAutoFit/>
+          </a:bodyPr>
+          <a:lstStyle/>
+          <a:p>
+            <a:pPr algn="l">
+              <a:lnSpc>
+                <a:spcPct val="113000"/>
+              </a:lnSpc>
+            </a:pPr>
+            <a:r>
+              <a:rPr lang="en-US" sz="800" dirty="0">
+                <a:solidFill>
+                  <a:schemeClr val="tx2"/>
+                </a:solidFill>
+              </a:rPr>
+              <a:t>14-30 / 30-180 / 180-365 days (C9A837)</a:t>
+            </a:r>
+          </a:p>
+        </p:txBody>
+      </p:sp>
+      <p:sp>
+        <p:nvSpPr>
+          <p:cNvPr id="16" name="TextBox 15">
+            <a:extLst>
+              <a:ext uri="{FF2B5EF4-FFF2-40B4-BE49-F238E27FC236}">
+                <a16:creationId xmlns:a16="http://schemas.microsoft.com/office/drawing/2014/main" id="{18540858-2D95-20D2-168F-EB118164412E}"/>
+              </a:ext>
+            </a:extLst>
+          </p:cNvPr>
+          <p:cNvSpPr txBox="1"/>
+          <p:nvPr/>
+        </p:nvSpPr>
+        <p:spPr>
+          <a:xfrm>
+            <a:off x="6355405" y="7495843"/>
+            <a:ext cx="1739728" cy="223844"/>
+          </a:xfrm>
+          <a:prstGeom prst="rect">
+            <a:avLst/>
+          </a:prstGeom>
+          <a:noFill/>
+        </p:spPr>
+        <p:txBody>
+          <a:bodyPr wrap="none" lIns="90000" rtlCol="0" anchor="t">
+            <a:spAutoFit/>
+          </a:bodyPr>
+          <a:lstStyle/>
+          <a:p>
+            <a:pPr>
+              <a:lnSpc>
+                <a:spcPct val="113000"/>
+              </a:lnSpc>
+            </a:pPr>
+            <a:r>
+              <a:rPr lang="en-US" sz="800" dirty="0">
+                <a:solidFill>
+                  <a:schemeClr val="tx2"/>
+                </a:solidFill>
+              </a:rPr>
+              <a:t>At least 30 / 180 / 365 days (AB8D2D)</a:t>
+            </a:r>
+          </a:p>
+        </p:txBody>
+      </p:sp>
+      <p:sp>
+        <p:nvSpPr>
+          <p:cNvPr id="18" name="Rounded Rectangle 17">
+            <a:extLst>
+              <a:ext uri="{FF2B5EF4-FFF2-40B4-BE49-F238E27FC236}">
+                <a16:creationId xmlns:a16="http://schemas.microsoft.com/office/drawing/2014/main" id="{04E8A7ED-0584-2528-F05E-FBF4834260FD}"/>
+              </a:ext>
+            </a:extLst>
+          </p:cNvPr>
+          <p:cNvSpPr/>
+          <p:nvPr/>
+        </p:nvSpPr>
+        <p:spPr>
+          <a:xfrm>
+            <a:off x="6224497" y="7022853"/>
+            <a:ext cx="168322" cy="91833"/>
+          </a:xfrm>
+          <a:prstGeom prst="roundRect">
+            <a:avLst/>
+          </a:prstGeom>
+          <a:solidFill>
+            <a:srgbClr val="2F6BFE"/>
+          </a:solidFill>
+          <a:ln>
+            <a:noFill/>
+          </a:ln>
+        </p:spPr>
+        <p:style>
+          <a:lnRef idx="2">
+            <a:schemeClr val="accent1">
+              <a:shade val="50000"/>
+            </a:schemeClr>
+          </a:lnRef>
+          <a:fillRef idx="1">
+            <a:schemeClr val="accent1"/>
+          </a:fillRef>
+          <a:effectRef idx="0">
+            <a:schemeClr val="accent1"/>
+          </a:effectRef>
+          <a:fontRef idx="minor">
+            <a:schemeClr val="lt1"/>
+          </a:fontRef>
+        </p:style>
+        <p:txBody>
+          <a:bodyPr lIns="108000" tIns="72000" rIns="108000" bIns="72000" rtlCol="0" anchor="ctr"/>
+          <a:lstStyle/>
+          <a:p>
+            <a:pPr algn="ctr"/>
+            <a:endParaRPr lang="en-US" sz="1600" dirty="0" err="1">
+              <a:solidFill>
+                <a:schemeClr val="bg1"/>
+              </a:solidFill>
+            </a:endParaRPr>
+          </a:p>
+        </p:txBody>
+      </p:sp>
+      <p:sp>
+        <p:nvSpPr>
+          <p:cNvPr id="19" name="Rounded Rectangle 18">
+            <a:extLst>
+              <a:ext uri="{FF2B5EF4-FFF2-40B4-BE49-F238E27FC236}">
+                <a16:creationId xmlns:a16="http://schemas.microsoft.com/office/drawing/2014/main" id="{F57996B4-400A-1707-6FAF-47CE0D1132CE}"/>
+              </a:ext>
+            </a:extLst>
+          </p:cNvPr>
+          <p:cNvSpPr/>
+          <p:nvPr/>
+        </p:nvSpPr>
+        <p:spPr>
+          <a:xfrm>
+            <a:off x="6224497" y="7203775"/>
+            <a:ext cx="168322" cy="91833"/>
+          </a:xfrm>
+          <a:prstGeom prst="roundRect">
+            <a:avLst/>
+          </a:prstGeom>
+          <a:solidFill>
+            <a:srgbClr val="E9C343"/>
+          </a:solidFill>
+          <a:ln>
+            <a:noFill/>
+          </a:ln>
+        </p:spPr>
+        <p:style>
+          <a:lnRef idx="2">
+            <a:schemeClr val="accent1">
+              <a:shade val="50000"/>
+            </a:schemeClr>
+          </a:lnRef>
+          <a:fillRef idx="1">
+            <a:schemeClr val="accent1"/>
+          </a:fillRef>
+          <a:effectRef idx="0">
+            <a:schemeClr val="accent1"/>
+          </a:effectRef>
+          <a:fontRef idx="minor">
+            <a:schemeClr val="lt1"/>
+          </a:fontRef>
+        </p:style>
+        <p:txBody>
+          <a:bodyPr lIns="108000" tIns="72000" rIns="108000" bIns="72000" rtlCol="0" anchor="ctr"/>
+          <a:lstStyle/>
+          <a:p>
+            <a:pPr algn="ctr"/>
+            <a:endParaRPr lang="en-US" sz="1600" dirty="0" err="1">
+              <a:solidFill>
+                <a:schemeClr val="bg1"/>
+              </a:solidFill>
+            </a:endParaRPr>
+          </a:p>
+        </p:txBody>
+      </p:sp>
+      <p:sp>
+        <p:nvSpPr>
+          <p:cNvPr id="20" name="Rounded Rectangle 19">
+            <a:extLst>
+              <a:ext uri="{FF2B5EF4-FFF2-40B4-BE49-F238E27FC236}">
+                <a16:creationId xmlns:a16="http://schemas.microsoft.com/office/drawing/2014/main" id="{D51F3CF7-5C41-A6BD-B496-E231C2433787}"/>
+              </a:ext>
+            </a:extLst>
+          </p:cNvPr>
+          <p:cNvSpPr/>
+          <p:nvPr/>
+        </p:nvSpPr>
+        <p:spPr>
+          <a:xfrm>
+            <a:off x="6224497" y="7384697"/>
+            <a:ext cx="168322" cy="91833"/>
+          </a:xfrm>
+          <a:prstGeom prst="roundRect">
+            <a:avLst/>
+          </a:prstGeom>
+          <a:solidFill>
+            <a:srgbClr val="D0A700"/>
+          </a:solidFill>
+          <a:ln>
+            <a:noFill/>
+          </a:ln>
+        </p:spPr>
+        <p:style>
+          <a:lnRef idx="2">
+            <a:schemeClr val="accent1">
+              <a:shade val="50000"/>
+            </a:schemeClr>
+          </a:lnRef>
+          <a:fillRef idx="1">
+            <a:schemeClr val="accent1"/>
+          </a:fillRef>
+          <a:effectRef idx="0">
+            <a:schemeClr val="accent1"/>
+          </a:effectRef>
+          <a:fontRef idx="minor">
+            <a:schemeClr val="lt1"/>
+          </a:fontRef>
+        </p:style>
+        <p:txBody>
+          <a:bodyPr lIns="108000" tIns="72000" rIns="108000" bIns="72000" rtlCol="0" anchor="ctr"/>
+          <a:lstStyle/>
+          <a:p>
+            <a:pPr algn="ctr"/>
+            <a:endParaRPr lang="en-US" sz="1600" dirty="0" err="1">
+              <a:solidFill>
+                <a:schemeClr val="bg1"/>
+              </a:solidFill>
+            </a:endParaRPr>
+          </a:p>
+        </p:txBody>
+      </p:sp>
+      <p:sp>
+        <p:nvSpPr>
+          <p:cNvPr id="21" name="Rounded Rectangle 20">
+            <a:extLst>
+              <a:ext uri="{FF2B5EF4-FFF2-40B4-BE49-F238E27FC236}">
+                <a16:creationId xmlns:a16="http://schemas.microsoft.com/office/drawing/2014/main" id="{AD0A3B9C-2E25-9487-B93D-6859968E49CD}"/>
+              </a:ext>
+            </a:extLst>
+          </p:cNvPr>
+          <p:cNvSpPr/>
+          <p:nvPr/>
+        </p:nvSpPr>
+        <p:spPr>
+          <a:xfrm>
+            <a:off x="6224497" y="7565618"/>
+            <a:ext cx="168322" cy="91833"/>
+          </a:xfrm>
+          <a:prstGeom prst="roundRect">
+            <a:avLst/>
+          </a:prstGeom>
+          <a:solidFill>
+            <a:srgbClr val="B18C00"/>
+          </a:solidFill>
+          <a:ln>
+            <a:noFill/>
+          </a:ln>
+        </p:spPr>
+        <p:style>
+          <a:lnRef idx="2">
+            <a:schemeClr val="accent1">
+              <a:shade val="50000"/>
+            </a:schemeClr>
+          </a:lnRef>
+          <a:fillRef idx="1">
+            <a:schemeClr val="accent1"/>
+          </a:fillRef>
+          <a:effectRef idx="0">
+            <a:schemeClr val="accent1"/>
+          </a:effectRef>
+          <a:fontRef idx="minor">
+            <a:schemeClr val="lt1"/>
+          </a:fontRef>
+        </p:style>
+        <p:txBody>
+          <a:bodyPr lIns="108000" tIns="72000" rIns="108000" bIns="72000" rtlCol="0" anchor="ctr"/>
+          <a:lstStyle/>
+          <a:p>
+            <a:pPr algn="ctr"/>
+            <a:endParaRPr lang="en-US" sz="1600" dirty="0" err="1">
+              <a:solidFill>
+                <a:schemeClr val="bg1"/>
+              </a:solidFill>
+            </a:endParaRPr>
+          </a:p>
+        </p:txBody>
+      </p:sp>
+      <p:sp>
+        <p:nvSpPr>
+          <p:cNvPr id="2" name="Rectangle 1">
+            <a:extLst>
+              <a:ext uri="{FF2B5EF4-FFF2-40B4-BE49-F238E27FC236}">
+                <a16:creationId xmlns:a16="http://schemas.microsoft.com/office/drawing/2014/main" id="{2738C682-48A6-D670-7903-E8184035BEC7}"/>
+              </a:ext>
+            </a:extLst>
+          </p:cNvPr>
+          <p:cNvSpPr/>
+          <p:nvPr/>
+        </p:nvSpPr>
+        <p:spPr>
+          <a:xfrm>
+            <a:off x="926285" y="3569394"/>
+            <a:ext cx="6149934" cy="2501548"/>
+          </a:xfrm>
+          <a:prstGeom prst="rect">
+            <a:avLst/>
+          </a:prstGeom>
+          <a:solidFill>
+            <a:srgbClr val="F0089F"/>
+          </a:solidFill>
+          <a:ln>
+            <a:noFill/>
+          </a:ln>
+        </p:spPr>
+        <p:style>
+          <a:lnRef idx="2">
+            <a:schemeClr val="accent1">
+              <a:shade val="50000"/>
+            </a:schemeClr>
+          </a:lnRef>
+          <a:fillRef idx="1">
+            <a:schemeClr val="accent1"/>
+          </a:fillRef>
+          <a:effectRef idx="0">
+            <a:schemeClr val="accent1"/>
+          </a:effectRef>
+          <a:fontRef idx="minor">
+            <a:schemeClr val="lt1"/>
+          </a:fontRef>
+        </p:style>
+        <p:txBody>
+          <a:bodyPr lIns="108000" tIns="72000" rIns="108000" bIns="72000" rtlCol="0" anchor="ctr"/>
+          <a:lstStyle/>
+          <a:p>
+            <a:pPr algn="ctr"/>
+            <a:r>
+              <a:rPr lang="en-US" sz="1600" dirty="0" err="1">
+                <a:solidFill>
+                  <a:schemeClr val="bg1"/>
+                </a:solidFill>
+              </a:rPr>
+              <a:t>PORTFOLIO_PERIOD_SECURITY_DASHBOARD_FINDINGS</a:t>
+            </a:r>
+            <a:endParaRPr lang="en-US" sz="1600" dirty="0">
+              <a:solidFill>
+                <a:schemeClr val="bg1"/>
+              </a:solidFill>
+            </a:endParaRPr>
+          </a:p>
+        </p:txBody>
+      </p:sp>
+    </p:spTree>
+    <p:extLst>
+      <p:ext uri="{BB962C8B-B14F-4D97-AF65-F5344CB8AC3E}">
+        <p14:creationId xmlns:p14="http://schemas.microsoft.com/office/powerpoint/2010/main" val="3904381800"/>
+      </p:ext>
+    </p:extLst>
+  </p:cSld>
+  <p:clrMapOvr>
+    <a:masterClrMapping/>
+  </p:clrMapOvr>
+</p:sld>
+</file>
+
+<file path=ppt/slides/slide19.xml><?xml version="1.0" encoding="utf-8"?>
+<p:sld xmlns:a="http://schemas.openxmlformats.org/drawingml/2006/main" xmlns:r="http://schemas.openxmlformats.org/officeDocument/2006/relationships" xmlns:p="http://schemas.openxmlformats.org/presentationml/2006/main">
+  <p:cSld>
+    <p:spTree>
+      <p:nvGrpSpPr>
+        <p:cNvPr id="1" name="">
+          <a:extLst>
+            <a:ext uri="{FF2B5EF4-FFF2-40B4-BE49-F238E27FC236}">
+              <a16:creationId xmlns:a16="http://schemas.microsoft.com/office/drawing/2014/main" id="{2A447711-2F95-8D02-EF61-9DFDAFBAAE27}"/>
+            </a:ext>
+          </a:extLst>
+        </p:cNvPr>
+        <p:cNvGrpSpPr/>
+        <p:nvPr/>
+      </p:nvGrpSpPr>
+      <p:grpSpPr>
+        <a:xfrm>
+          <a:off x="0" y="0"/>
+          <a:ext cx="0" cy="0"/>
+          <a:chOff x="0" y="0"/>
+          <a:chExt cx="0" cy="0"/>
+        </a:xfrm>
+      </p:grpSpPr>
+      <p:sp>
+        <p:nvSpPr>
+          <p:cNvPr id="17" name="Rectangle 16">
+            <a:extLst>
+              <a:ext uri="{FF2B5EF4-FFF2-40B4-BE49-F238E27FC236}">
+                <a16:creationId xmlns:a16="http://schemas.microsoft.com/office/drawing/2014/main" id="{ED508E6A-8D1D-AB1F-259E-339FCAE0BA97}"/>
+              </a:ext>
+            </a:extLst>
+          </p:cNvPr>
+          <p:cNvSpPr/>
+          <p:nvPr/>
+        </p:nvSpPr>
+        <p:spPr>
+          <a:xfrm flipH="1">
+            <a:off x="0" y="1368000"/>
+            <a:ext cx="12192000" cy="1658842"/>
+          </a:xfrm>
+          <a:prstGeom prst="rect">
+            <a:avLst/>
+          </a:prstGeom>
+          <a:gradFill>
+            <a:gsLst>
+              <a:gs pos="0">
+                <a:schemeClr val="bg1"/>
+              </a:gs>
+              <a:gs pos="100000">
+                <a:schemeClr val="bg2"/>
+              </a:gs>
+            </a:gsLst>
+            <a:lin ang="2700000" scaled="0"/>
+          </a:gradFill>
+          <a:ln>
+            <a:noFill/>
+          </a:ln>
+          <a:effectLst>
+            <a:outerShdw blurRad="190500" dist="38100" dir="2700000" algn="tl" rotWithShape="0">
+              <a:prstClr val="black">
+                <a:alpha val="15000"/>
+              </a:prstClr>
+            </a:outerShdw>
+          </a:effectLst>
+        </p:spPr>
+        <p:style>
+          <a:lnRef idx="2">
+            <a:schemeClr val="accent1">
+              <a:shade val="50000"/>
+            </a:schemeClr>
+          </a:lnRef>
+          <a:fillRef idx="1">
+            <a:schemeClr val="accent1"/>
+          </a:fillRef>
+          <a:effectRef idx="0">
+            <a:schemeClr val="accent1"/>
+          </a:effectRef>
+          <a:fontRef idx="minor">
+            <a:schemeClr val="lt1"/>
+          </a:fontRef>
+        </p:style>
+        <p:txBody>
+          <a:bodyPr lIns="731520" tIns="72000" rIns="108000" bIns="72000" rtlCol="0" anchor="ctr"/>
+          <a:lstStyle/>
+          <a:p>
+            <a:endParaRPr lang="nl-NL" sz="1200" b="1" noProof="0" dirty="0">
+              <a:solidFill>
+                <a:schemeClr val="accent1"/>
+              </a:solidFill>
+            </a:endParaRPr>
+          </a:p>
+        </p:txBody>
+      </p:sp>
+      <p:sp>
+        <p:nvSpPr>
+          <p:cNvPr id="3" name="Slide Number Placeholder 2">
+            <a:extLst>
+              <a:ext uri="{FF2B5EF4-FFF2-40B4-BE49-F238E27FC236}">
+                <a16:creationId xmlns:a16="http://schemas.microsoft.com/office/drawing/2014/main" id="{B67F47A6-2E30-A3A2-1FA6-ADC44FB6A75A}"/>
+              </a:ext>
+            </a:extLst>
+          </p:cNvPr>
+          <p:cNvSpPr>
+            <a:spLocks noGrp="1"/>
+          </p:cNvSpPr>
+          <p:nvPr>
+            <p:ph type="sldNum" sz="quarter" idx="4"/>
+          </p:nvPr>
+        </p:nvSpPr>
+        <p:spPr/>
+        <p:txBody>
+          <a:bodyPr/>
+          <a:lstStyle/>
+          <a:p>
+            <a:fld id="{E242BD21-9B61-2246-BCB1-4BE5E1BEBE1C}" type="slidenum">
+              <a:rPr lang="en-US" smtClean="0"/>
+              <a:pPr/>
+              <a:t>19</a:t>
             </a:fld>
             <a:endParaRPr lang="en-US"/>
           </a:p>
@@ -51347,36 +54172,6 @@
 </p:sld>
 </file>
 
-<file path=ppt/slides/slide19.xml><?xml version="1.0" encoding="utf-8"?>
-<p:sld xmlns:a="http://schemas.openxmlformats.org/drawingml/2006/main" xmlns:r="http://schemas.openxmlformats.org/officeDocument/2006/relationships" xmlns:p="http://schemas.openxmlformats.org/presentationml/2006/main">
-  <p:cSld>
-    <p:spTree>
-      <p:nvGrpSpPr>
-        <p:cNvPr id="1" name=""/>
-        <p:cNvGrpSpPr/>
-        <p:nvPr/>
-      </p:nvGrpSpPr>
-      <p:grpSpPr>
-        <a:xfrm>
-          <a:off x="0" y="0"/>
-          <a:ext cx="0" cy="0"/>
-          <a:chOff x="0" y="0"/>
-          <a:chExt cx="0" cy="0"/>
-        </a:xfrm>
-      </p:grpSpPr>
-    </p:spTree>
-    <p:extLst>
-      <p:ext uri="{BB962C8B-B14F-4D97-AF65-F5344CB8AC3E}">
-        <p14:creationId xmlns:p14="http://schemas.microsoft.com/office/powerpoint/2010/main" val="3392309048"/>
-      </p:ext>
-    </p:extLst>
-  </p:cSld>
-  <p:clrMapOvr>
-    <a:masterClrMapping/>
-  </p:clrMapOvr>
-</p:sld>
-</file>
-
 <file path=ppt/slides/slide2.xml><?xml version="1.0" encoding="utf-8"?>
 <p:sld xmlns:a="http://schemas.openxmlformats.org/drawingml/2006/main" xmlns:r="http://schemas.openxmlformats.org/officeDocument/2006/relationships" xmlns:p="http://schemas.openxmlformats.org/presentationml/2006/main">
   <p:cSld>
@@ -51589,6 +54384,36 @@
     <p:extLst>
       <p:ext uri="{BB962C8B-B14F-4D97-AF65-F5344CB8AC3E}">
         <p14:creationId xmlns:p14="http://schemas.microsoft.com/office/powerpoint/2010/main" val="1721077860"/>
+      </p:ext>
+    </p:extLst>
+  </p:cSld>
+  <p:clrMapOvr>
+    <a:masterClrMapping/>
+  </p:clrMapOvr>
+</p:sld>
+</file>
+
+<file path=ppt/slides/slide20.xml><?xml version="1.0" encoding="utf-8"?>
+<p:sld xmlns:a="http://schemas.openxmlformats.org/drawingml/2006/main" xmlns:r="http://schemas.openxmlformats.org/officeDocument/2006/relationships" xmlns:p="http://schemas.openxmlformats.org/presentationml/2006/main">
+  <p:cSld>
+    <p:spTree>
+      <p:nvGrpSpPr>
+        <p:cNvPr id="1" name=""/>
+        <p:cNvGrpSpPr/>
+        <p:nvPr/>
+      </p:nvGrpSpPr>
+      <p:grpSpPr>
+        <a:xfrm>
+          <a:off x="0" y="0"/>
+          <a:ext cx="0" cy="0"/>
+          <a:chOff x="0" y="0"/>
+          <a:chExt cx="0" cy="0"/>
+        </a:xfrm>
+      </p:grpSpPr>
+    </p:spTree>
+    <p:extLst>
+      <p:ext uri="{BB962C8B-B14F-4D97-AF65-F5344CB8AC3E}">
+        <p14:creationId xmlns:p14="http://schemas.microsoft.com/office/powerpoint/2010/main" val="3392309048"/>
       </p:ext>
     </p:extLst>
   </p:cSld>

</xml_diff>

<commit_message>
Adding high and medium security dashboard findings
</commit_message>
<xml_diff>
--- a/src/report_generator/presets/templates/portfolio-overview.pptx
+++ b/src/report_generator/presets/templates/portfolio-overview.pptx
@@ -28,7 +28,7 @@
     <p:sldId id="10729" r:id="rId19"/>
     <p:sldId id="10727" r:id="rId20"/>
     <p:sldId id="10726" r:id="rId21"/>
-    <p:sldId id="10730" r:id="rId22"/>
+    <p:sldId id="10731" r:id="rId22"/>
     <p:sldId id="10723" r:id="rId23"/>
     <p:sldId id="597" r:id="rId24"/>
   </p:sldIdLst>
@@ -230,7 +230,7 @@
                 </a:outerShdw>
               </a:effectLst>
             </c:spPr>
-            <c:extLst xmlns:lc="http://schemas.openxmlformats.org/drawingml/2006/lockedCanvas" xmlns:comp="http://schemas.openxmlformats.org/drawingml/2006/compatibility" xmlns:we="http://schemas.microsoft.com/office/webextensions/webextension/2010/11" xmlns:wetp="http://schemas.microsoft.com/office/webextensions/taskpanes/2010/11" xmlns:w16cid="http://schemas.microsoft.com/office/word/2016/wordml/cid" xmlns:w16se="http://schemas.microsoft.com/office/word/2015/wordml/symex" xmlns:wps="http://schemas.microsoft.com/office/word/2010/wordprocessingShape" xmlns:b="http://schemas.openxmlformats.org/officeDocument/2006/bibliography" xmlns:odgm="http://opendope.org/SmartArt/DataHierarchy" xmlns:odi="http://opendope.org/components" xmlns:oda="http://opendope.org/answers" xmlns:odq="http://opendope.org/questions" xmlns:odc="http://opendope.org/conditions" xmlns:odx="http://opendope.org/xpaths" xmlns:cppr="http://schemas.microsoft.com/office/2006/coverPageProps" xmlns:pvml="urn:schemas-microsoft-com:office:powerpoint" xmlns:w10="urn:schemas-microsoft-com:office:word" xmlns:v="urn:schemas-microsoft-com:vml" xmlns:o="urn:schemas-microsoft-com:office:office" xmlns:xvml="urn:schemas-microsoft-com:office:excel" xmlns:dsp="http://schemas.microsoft.com/office/drawing/2008/diagram" xmlns:xdr="http://schemas.openxmlformats.org/drawingml/2006/spreadsheetDrawing" xmlns:pic="http://schemas.openxmlformats.org/drawingml/2006/picture" xmlns:dgm="http://schemas.openxmlformats.org/drawingml/2006/diagram" xmlns:c14="http://schemas.microsoft.com/office/drawing/2007/8/2/chart" xmlns:cdr="http://schemas.openxmlformats.org/drawingml/2006/chartDrawing" xmlns:wne="http://schemas.microsoft.com/office/word/2006/wordml" xmlns:sl="http://schemas.openxmlformats.org/schemaLibrary/2006/main" xmlns:mc="http://schemas.openxmlformats.org/markup-compatibility/2006" xmlns:wp14="http://schemas.microsoft.com/office/word/2010/wordprocessingDrawing" xmlns:wp="http://schemas.openxmlformats.org/drawingml/2006/wordprocessingDrawing" xmlns:m="http://schemas.openxmlformats.org/officeDocument/2006/math" xmlns:w14="http://schemas.microsoft.com/office/word/2010/wordml" xmlns:w15="http://schemas.microsoft.com/office/word/2012/wordml" xmlns:w="http://schemas.openxmlformats.org/wordprocessingml/2006/main">
+            <c:extLst xmlns:w="http://schemas.openxmlformats.org/wordprocessingml/2006/main" xmlns:w15="http://schemas.microsoft.com/office/word/2012/wordml" xmlns:w14="http://schemas.microsoft.com/office/word/2010/wordml" xmlns:m="http://schemas.openxmlformats.org/officeDocument/2006/math" xmlns:wp="http://schemas.openxmlformats.org/drawingml/2006/wordprocessingDrawing" xmlns:wp14="http://schemas.microsoft.com/office/word/2010/wordprocessingDrawing" xmlns:mc="http://schemas.openxmlformats.org/markup-compatibility/2006" xmlns:sl="http://schemas.openxmlformats.org/schemaLibrary/2006/main" xmlns:wne="http://schemas.microsoft.com/office/word/2006/wordml" xmlns:cdr="http://schemas.openxmlformats.org/drawingml/2006/chartDrawing" xmlns:c14="http://schemas.microsoft.com/office/drawing/2007/8/2/chart" xmlns:dgm="http://schemas.openxmlformats.org/drawingml/2006/diagram" xmlns:pic="http://schemas.openxmlformats.org/drawingml/2006/picture" xmlns:xdr="http://schemas.openxmlformats.org/drawingml/2006/spreadsheetDrawing" xmlns:dsp="http://schemas.microsoft.com/office/drawing/2008/diagram" xmlns:xvml="urn:schemas-microsoft-com:office:excel" xmlns:o="urn:schemas-microsoft-com:office:office" xmlns:v="urn:schemas-microsoft-com:vml" xmlns:w10="urn:schemas-microsoft-com:office:word" xmlns:pvml="urn:schemas-microsoft-com:office:powerpoint" xmlns:cppr="http://schemas.microsoft.com/office/2006/coverPageProps" xmlns:odx="http://opendope.org/xpaths" xmlns:odc="http://opendope.org/conditions" xmlns:odq="http://opendope.org/questions" xmlns:oda="http://opendope.org/answers" xmlns:odi="http://opendope.org/components" xmlns:odgm="http://opendope.org/SmartArt/DataHierarchy" xmlns:b="http://schemas.openxmlformats.org/officeDocument/2006/bibliography" xmlns:wps="http://schemas.microsoft.com/office/word/2010/wordprocessingShape" xmlns:w16se="http://schemas.microsoft.com/office/word/2015/wordml/symex" xmlns:w16cid="http://schemas.microsoft.com/office/word/2016/wordml/cid" xmlns:wetp="http://schemas.microsoft.com/office/webextensions/taskpanes/2010/11" xmlns:we="http://schemas.microsoft.com/office/webextensions/webextension/2010/11" xmlns:comp="http://schemas.openxmlformats.org/drawingml/2006/compatibility" xmlns:lc="http://schemas.openxmlformats.org/drawingml/2006/lockedCanvas">
               <c:ext xmlns:c16="http://schemas.microsoft.com/office/drawing/2014/chart" uri="{C3380CC4-5D6E-409C-BE32-E72D297353CC}">
                 <c16:uniqueId val="{00000001-6147-E74A-AA7B-5531F0E4EE0C}"/>
               </c:ext>
@@ -259,7 +259,7 @@
               </c:numCache>
             </c:numRef>
           </c:val>
-          <c:extLst xmlns:lc="http://schemas.openxmlformats.org/drawingml/2006/lockedCanvas" xmlns:comp="http://schemas.openxmlformats.org/drawingml/2006/compatibility" xmlns:we="http://schemas.microsoft.com/office/webextensions/webextension/2010/11" xmlns:wetp="http://schemas.microsoft.com/office/webextensions/taskpanes/2010/11" xmlns:w16cid="http://schemas.microsoft.com/office/word/2016/wordml/cid" xmlns:w16se="http://schemas.microsoft.com/office/word/2015/wordml/symex" xmlns:wps="http://schemas.microsoft.com/office/word/2010/wordprocessingShape" xmlns:b="http://schemas.openxmlformats.org/officeDocument/2006/bibliography" xmlns:odgm="http://opendope.org/SmartArt/DataHierarchy" xmlns:odi="http://opendope.org/components" xmlns:oda="http://opendope.org/answers" xmlns:odq="http://opendope.org/questions" xmlns:odc="http://opendope.org/conditions" xmlns:odx="http://opendope.org/xpaths" xmlns:cppr="http://schemas.microsoft.com/office/2006/coverPageProps" xmlns:pvml="urn:schemas-microsoft-com:office:powerpoint" xmlns:w10="urn:schemas-microsoft-com:office:word" xmlns:v="urn:schemas-microsoft-com:vml" xmlns:o="urn:schemas-microsoft-com:office:office" xmlns:xvml="urn:schemas-microsoft-com:office:excel" xmlns:dsp="http://schemas.microsoft.com/office/drawing/2008/diagram" xmlns:xdr="http://schemas.openxmlformats.org/drawingml/2006/spreadsheetDrawing" xmlns:pic="http://schemas.openxmlformats.org/drawingml/2006/picture" xmlns:dgm="http://schemas.openxmlformats.org/drawingml/2006/diagram" xmlns:c14="http://schemas.microsoft.com/office/drawing/2007/8/2/chart" xmlns:cdr="http://schemas.openxmlformats.org/drawingml/2006/chartDrawing" xmlns:wne="http://schemas.microsoft.com/office/word/2006/wordml" xmlns:sl="http://schemas.openxmlformats.org/schemaLibrary/2006/main" xmlns:mc="http://schemas.openxmlformats.org/markup-compatibility/2006" xmlns:wp14="http://schemas.microsoft.com/office/word/2010/wordprocessingDrawing" xmlns:wp="http://schemas.openxmlformats.org/drawingml/2006/wordprocessingDrawing" xmlns:m="http://schemas.openxmlformats.org/officeDocument/2006/math" xmlns:w14="http://schemas.microsoft.com/office/word/2010/wordml" xmlns:w15="http://schemas.microsoft.com/office/word/2012/wordml" xmlns:w="http://schemas.openxmlformats.org/wordprocessingml/2006/main">
+          <c:extLst xmlns:w="http://schemas.openxmlformats.org/wordprocessingml/2006/main" xmlns:w15="http://schemas.microsoft.com/office/word/2012/wordml" xmlns:w14="http://schemas.microsoft.com/office/word/2010/wordml" xmlns:m="http://schemas.openxmlformats.org/officeDocument/2006/math" xmlns:wp="http://schemas.openxmlformats.org/drawingml/2006/wordprocessingDrawing" xmlns:wp14="http://schemas.microsoft.com/office/word/2010/wordprocessingDrawing" xmlns:mc="http://schemas.openxmlformats.org/markup-compatibility/2006" xmlns:sl="http://schemas.openxmlformats.org/schemaLibrary/2006/main" xmlns:wne="http://schemas.microsoft.com/office/word/2006/wordml" xmlns:cdr="http://schemas.openxmlformats.org/drawingml/2006/chartDrawing" xmlns:c14="http://schemas.microsoft.com/office/drawing/2007/8/2/chart" xmlns:dgm="http://schemas.openxmlformats.org/drawingml/2006/diagram" xmlns:pic="http://schemas.openxmlformats.org/drawingml/2006/picture" xmlns:xdr="http://schemas.openxmlformats.org/drawingml/2006/spreadsheetDrawing" xmlns:dsp="http://schemas.microsoft.com/office/drawing/2008/diagram" xmlns:xvml="urn:schemas-microsoft-com:office:excel" xmlns:o="urn:schemas-microsoft-com:office:office" xmlns:v="urn:schemas-microsoft-com:vml" xmlns:w10="urn:schemas-microsoft-com:office:word" xmlns:pvml="urn:schemas-microsoft-com:office:powerpoint" xmlns:cppr="http://schemas.microsoft.com/office/2006/coverPageProps" xmlns:odx="http://opendope.org/xpaths" xmlns:odc="http://opendope.org/conditions" xmlns:odq="http://opendope.org/questions" xmlns:oda="http://opendope.org/answers" xmlns:odi="http://opendope.org/components" xmlns:odgm="http://opendope.org/SmartArt/DataHierarchy" xmlns:b="http://schemas.openxmlformats.org/officeDocument/2006/bibliography" xmlns:wps="http://schemas.microsoft.com/office/word/2010/wordprocessingShape" xmlns:w16se="http://schemas.microsoft.com/office/word/2015/wordml/symex" xmlns:w16cid="http://schemas.microsoft.com/office/word/2016/wordml/cid" xmlns:wetp="http://schemas.microsoft.com/office/webextensions/taskpanes/2010/11" xmlns:we="http://schemas.microsoft.com/office/webextensions/webextension/2010/11" xmlns:comp="http://schemas.openxmlformats.org/drawingml/2006/compatibility" xmlns:lc="http://schemas.openxmlformats.org/drawingml/2006/lockedCanvas">
             <c:ext xmlns:c16="http://schemas.microsoft.com/office/drawing/2014/chart" uri="{C3380CC4-5D6E-409C-BE32-E72D297353CC}">
               <c16:uniqueId val="{00000002-6147-E74A-AA7B-5531F0E4EE0C}"/>
             </c:ext>
@@ -576,7 +576,7 @@
     <c:plotVisOnly val="1"/>
     <c:dispBlanksAs val="gap"/>
     <c:showDLblsOverMax val="0"/>
-    <c:extLst xmlns:lc="http://schemas.openxmlformats.org/drawingml/2006/lockedCanvas" xmlns:comp="http://schemas.openxmlformats.org/drawingml/2006/compatibility" xmlns:we="http://schemas.microsoft.com/office/webextensions/webextension/2010/11" xmlns:wetp="http://schemas.microsoft.com/office/webextensions/taskpanes/2010/11" xmlns:w16cid="http://schemas.microsoft.com/office/word/2016/wordml/cid" xmlns:w16se="http://schemas.microsoft.com/office/word/2015/wordml/symex" xmlns:wps="http://schemas.microsoft.com/office/word/2010/wordprocessingShape" xmlns:b="http://schemas.openxmlformats.org/officeDocument/2006/bibliography" xmlns:odgm="http://opendope.org/SmartArt/DataHierarchy" xmlns:odi="http://opendope.org/components" xmlns:oda="http://opendope.org/answers" xmlns:odq="http://opendope.org/questions" xmlns:odc="http://opendope.org/conditions" xmlns:odx="http://opendope.org/xpaths" xmlns:cppr="http://schemas.microsoft.com/office/2006/coverPageProps" xmlns:pvml="urn:schemas-microsoft-com:office:powerpoint" xmlns:w10="urn:schemas-microsoft-com:office:word" xmlns:v="urn:schemas-microsoft-com:vml" xmlns:o="urn:schemas-microsoft-com:office:office" xmlns:xvml="urn:schemas-microsoft-com:office:excel" xmlns:dsp="http://schemas.microsoft.com/office/drawing/2008/diagram" xmlns:xdr="http://schemas.openxmlformats.org/drawingml/2006/spreadsheetDrawing" xmlns:pic="http://schemas.openxmlformats.org/drawingml/2006/picture" xmlns:dgm="http://schemas.openxmlformats.org/drawingml/2006/diagram" xmlns:c14="http://schemas.microsoft.com/office/drawing/2007/8/2/chart" xmlns:cdr="http://schemas.openxmlformats.org/drawingml/2006/chartDrawing" xmlns:wne="http://schemas.microsoft.com/office/word/2006/wordml" xmlns:sl="http://schemas.openxmlformats.org/schemaLibrary/2006/main" xmlns:mc="http://schemas.openxmlformats.org/markup-compatibility/2006" xmlns:wp14="http://schemas.microsoft.com/office/word/2010/wordprocessingDrawing" xmlns:wp="http://schemas.openxmlformats.org/drawingml/2006/wordprocessingDrawing" xmlns:m="http://schemas.openxmlformats.org/officeDocument/2006/math" xmlns:w14="http://schemas.microsoft.com/office/word/2010/wordml" xmlns:w15="http://schemas.microsoft.com/office/word/2012/wordml" xmlns:w="http://schemas.openxmlformats.org/wordprocessingml/2006/main">
+    <c:extLst xmlns:w="http://schemas.openxmlformats.org/wordprocessingml/2006/main" xmlns:w15="http://schemas.microsoft.com/office/word/2012/wordml" xmlns:w14="http://schemas.microsoft.com/office/word/2010/wordml" xmlns:m="http://schemas.openxmlformats.org/officeDocument/2006/math" xmlns:wp="http://schemas.openxmlformats.org/drawingml/2006/wordprocessingDrawing" xmlns:wp14="http://schemas.microsoft.com/office/word/2010/wordprocessingDrawing" xmlns:mc="http://schemas.openxmlformats.org/markup-compatibility/2006" xmlns:sl="http://schemas.openxmlformats.org/schemaLibrary/2006/main" xmlns:wne="http://schemas.microsoft.com/office/word/2006/wordml" xmlns:cdr="http://schemas.openxmlformats.org/drawingml/2006/chartDrawing" xmlns:c14="http://schemas.microsoft.com/office/drawing/2007/8/2/chart" xmlns:dgm="http://schemas.openxmlformats.org/drawingml/2006/diagram" xmlns:pic="http://schemas.openxmlformats.org/drawingml/2006/picture" xmlns:xdr="http://schemas.openxmlformats.org/drawingml/2006/spreadsheetDrawing" xmlns:dsp="http://schemas.microsoft.com/office/drawing/2008/diagram" xmlns:xvml="urn:schemas-microsoft-com:office:excel" xmlns:o="urn:schemas-microsoft-com:office:office" xmlns:v="urn:schemas-microsoft-com:vml" xmlns:w10="urn:schemas-microsoft-com:office:word" xmlns:pvml="urn:schemas-microsoft-com:office:powerpoint" xmlns:cppr="http://schemas.microsoft.com/office/2006/coverPageProps" xmlns:odx="http://opendope.org/xpaths" xmlns:odc="http://opendope.org/conditions" xmlns:odq="http://opendope.org/questions" xmlns:oda="http://opendope.org/answers" xmlns:odi="http://opendope.org/components" xmlns:odgm="http://opendope.org/SmartArt/DataHierarchy" xmlns:b="http://schemas.openxmlformats.org/officeDocument/2006/bibliography" xmlns:wps="http://schemas.microsoft.com/office/word/2010/wordprocessingShape" xmlns:w16se="http://schemas.microsoft.com/office/word/2015/wordml/symex" xmlns:w16cid="http://schemas.microsoft.com/office/word/2016/wordml/cid" xmlns:wetp="http://schemas.microsoft.com/office/webextensions/taskpanes/2010/11" xmlns:we="http://schemas.microsoft.com/office/webextensions/webextension/2010/11" xmlns:comp="http://schemas.openxmlformats.org/drawingml/2006/compatibility" xmlns:lc="http://schemas.openxmlformats.org/drawingml/2006/lockedCanvas">
       <c:ext xmlns:c16r3="http://schemas.microsoft.com/office/drawing/2017/03/chart" uri="{56B9EC1D-385E-4148-901F-78D8002777C0}">
         <c16r3:dataDisplayOptions16>
           <c16r3:dispNaAsBlank val="1"/>
@@ -678,7 +678,7 @@
                 </a:outerShdw>
               </a:effectLst>
             </c:spPr>
-            <c:extLst xmlns:w="http://schemas.openxmlformats.org/wordprocessingml/2006/main" xmlns:w15="http://schemas.microsoft.com/office/word/2012/wordml" xmlns:w14="http://schemas.microsoft.com/office/word/2010/wordml" xmlns:m="http://schemas.openxmlformats.org/officeDocument/2006/math" xmlns:wp="http://schemas.openxmlformats.org/drawingml/2006/wordprocessingDrawing" xmlns:wp14="http://schemas.microsoft.com/office/word/2010/wordprocessingDrawing" xmlns:mc="http://schemas.openxmlformats.org/markup-compatibility/2006" xmlns:sl="http://schemas.openxmlformats.org/schemaLibrary/2006/main" xmlns:wne="http://schemas.microsoft.com/office/word/2006/wordml" xmlns:cdr="http://schemas.openxmlformats.org/drawingml/2006/chartDrawing" xmlns:c14="http://schemas.microsoft.com/office/drawing/2007/8/2/chart" xmlns:dgm="http://schemas.openxmlformats.org/drawingml/2006/diagram" xmlns:pic="http://schemas.openxmlformats.org/drawingml/2006/picture" xmlns:xdr="http://schemas.openxmlformats.org/drawingml/2006/spreadsheetDrawing" xmlns:dsp="http://schemas.microsoft.com/office/drawing/2008/diagram" xmlns:xvml="urn:schemas-microsoft-com:office:excel" xmlns:o="urn:schemas-microsoft-com:office:office" xmlns:v="urn:schemas-microsoft-com:vml" xmlns:w10="urn:schemas-microsoft-com:office:word" xmlns:pvml="urn:schemas-microsoft-com:office:powerpoint" xmlns:cppr="http://schemas.microsoft.com/office/2006/coverPageProps" xmlns:odx="http://opendope.org/xpaths" xmlns:odc="http://opendope.org/conditions" xmlns:odq="http://opendope.org/questions" xmlns:oda="http://opendope.org/answers" xmlns:odi="http://opendope.org/components" xmlns:odgm="http://opendope.org/SmartArt/DataHierarchy" xmlns:b="http://schemas.openxmlformats.org/officeDocument/2006/bibliography" xmlns:wps="http://schemas.microsoft.com/office/word/2010/wordprocessingShape" xmlns:w16se="http://schemas.microsoft.com/office/word/2015/wordml/symex" xmlns:w16cid="http://schemas.microsoft.com/office/word/2016/wordml/cid" xmlns:wetp="http://schemas.microsoft.com/office/webextensions/taskpanes/2010/11" xmlns:we="http://schemas.microsoft.com/office/webextensions/webextension/2010/11" xmlns:comp="http://schemas.openxmlformats.org/drawingml/2006/compatibility" xmlns:lc="http://schemas.openxmlformats.org/drawingml/2006/lockedCanvas">
+            <c:extLst xmlns:lc="http://schemas.openxmlformats.org/drawingml/2006/lockedCanvas" xmlns:comp="http://schemas.openxmlformats.org/drawingml/2006/compatibility" xmlns:we="http://schemas.microsoft.com/office/webextensions/webextension/2010/11" xmlns:wetp="http://schemas.microsoft.com/office/webextensions/taskpanes/2010/11" xmlns:w16cid="http://schemas.microsoft.com/office/word/2016/wordml/cid" xmlns:w16se="http://schemas.microsoft.com/office/word/2015/wordml/symex" xmlns:wps="http://schemas.microsoft.com/office/word/2010/wordprocessingShape" xmlns:b="http://schemas.openxmlformats.org/officeDocument/2006/bibliography" xmlns:odgm="http://opendope.org/SmartArt/DataHierarchy" xmlns:odi="http://opendope.org/components" xmlns:oda="http://opendope.org/answers" xmlns:odq="http://opendope.org/questions" xmlns:odc="http://opendope.org/conditions" xmlns:odx="http://opendope.org/xpaths" xmlns:cppr="http://schemas.microsoft.com/office/2006/coverPageProps" xmlns:pvml="urn:schemas-microsoft-com:office:powerpoint" xmlns:w10="urn:schemas-microsoft-com:office:word" xmlns:v="urn:schemas-microsoft-com:vml" xmlns:o="urn:schemas-microsoft-com:office:office" xmlns:xvml="urn:schemas-microsoft-com:office:excel" xmlns:dsp="http://schemas.microsoft.com/office/drawing/2008/diagram" xmlns:xdr="http://schemas.openxmlformats.org/drawingml/2006/spreadsheetDrawing" xmlns:pic="http://schemas.openxmlformats.org/drawingml/2006/picture" xmlns:dgm="http://schemas.openxmlformats.org/drawingml/2006/diagram" xmlns:c14="http://schemas.microsoft.com/office/drawing/2007/8/2/chart" xmlns:cdr="http://schemas.openxmlformats.org/drawingml/2006/chartDrawing" xmlns:wne="http://schemas.microsoft.com/office/word/2006/wordml" xmlns:sl="http://schemas.openxmlformats.org/schemaLibrary/2006/main" xmlns:mc="http://schemas.openxmlformats.org/markup-compatibility/2006" xmlns:wp14="http://schemas.microsoft.com/office/word/2010/wordprocessingDrawing" xmlns:wp="http://schemas.openxmlformats.org/drawingml/2006/wordprocessingDrawing" xmlns:m="http://schemas.openxmlformats.org/officeDocument/2006/math" xmlns:w14="http://schemas.microsoft.com/office/word/2010/wordml" xmlns:w15="http://schemas.microsoft.com/office/word/2012/wordml" xmlns:w="http://schemas.openxmlformats.org/wordprocessingml/2006/main">
               <c:ext xmlns:c16="http://schemas.microsoft.com/office/drawing/2014/chart" uri="{C3380CC4-5D6E-409C-BE32-E72D297353CC}">
                 <c16:uniqueId val="{00000001-6147-E74A-AA7B-5531F0E4EE0C}"/>
               </c:ext>
@@ -761,7 +761,7 @@
               </c:numCache>
             </c:numRef>
           </c:val>
-          <c:extLst xmlns:w="http://schemas.openxmlformats.org/wordprocessingml/2006/main" xmlns:w15="http://schemas.microsoft.com/office/word/2012/wordml" xmlns:w14="http://schemas.microsoft.com/office/word/2010/wordml" xmlns:m="http://schemas.openxmlformats.org/officeDocument/2006/math" xmlns:wp="http://schemas.openxmlformats.org/drawingml/2006/wordprocessingDrawing" xmlns:wp14="http://schemas.microsoft.com/office/word/2010/wordprocessingDrawing" xmlns:mc="http://schemas.openxmlformats.org/markup-compatibility/2006" xmlns:sl="http://schemas.openxmlformats.org/schemaLibrary/2006/main" xmlns:wne="http://schemas.microsoft.com/office/word/2006/wordml" xmlns:cdr="http://schemas.openxmlformats.org/drawingml/2006/chartDrawing" xmlns:c14="http://schemas.microsoft.com/office/drawing/2007/8/2/chart" xmlns:dgm="http://schemas.openxmlformats.org/drawingml/2006/diagram" xmlns:pic="http://schemas.openxmlformats.org/drawingml/2006/picture" xmlns:xdr="http://schemas.openxmlformats.org/drawingml/2006/spreadsheetDrawing" xmlns:dsp="http://schemas.microsoft.com/office/drawing/2008/diagram" xmlns:xvml="urn:schemas-microsoft-com:office:excel" xmlns:o="urn:schemas-microsoft-com:office:office" xmlns:v="urn:schemas-microsoft-com:vml" xmlns:w10="urn:schemas-microsoft-com:office:word" xmlns:pvml="urn:schemas-microsoft-com:office:powerpoint" xmlns:cppr="http://schemas.microsoft.com/office/2006/coverPageProps" xmlns:odx="http://opendope.org/xpaths" xmlns:odc="http://opendope.org/conditions" xmlns:odq="http://opendope.org/questions" xmlns:oda="http://opendope.org/answers" xmlns:odi="http://opendope.org/components" xmlns:odgm="http://opendope.org/SmartArt/DataHierarchy" xmlns:b="http://schemas.openxmlformats.org/officeDocument/2006/bibliography" xmlns:wps="http://schemas.microsoft.com/office/word/2010/wordprocessingShape" xmlns:w16se="http://schemas.microsoft.com/office/word/2015/wordml/symex" xmlns:w16cid="http://schemas.microsoft.com/office/word/2016/wordml/cid" xmlns:wetp="http://schemas.microsoft.com/office/webextensions/taskpanes/2010/11" xmlns:we="http://schemas.microsoft.com/office/webextensions/webextension/2010/11" xmlns:comp="http://schemas.openxmlformats.org/drawingml/2006/compatibility" xmlns:lc="http://schemas.openxmlformats.org/drawingml/2006/lockedCanvas">
+          <c:extLst xmlns:lc="http://schemas.openxmlformats.org/drawingml/2006/lockedCanvas" xmlns:comp="http://schemas.openxmlformats.org/drawingml/2006/compatibility" xmlns:we="http://schemas.microsoft.com/office/webextensions/webextension/2010/11" xmlns:wetp="http://schemas.microsoft.com/office/webextensions/taskpanes/2010/11" xmlns:w16cid="http://schemas.microsoft.com/office/word/2016/wordml/cid" xmlns:w16se="http://schemas.microsoft.com/office/word/2015/wordml/symex" xmlns:wps="http://schemas.microsoft.com/office/word/2010/wordprocessingShape" xmlns:b="http://schemas.openxmlformats.org/officeDocument/2006/bibliography" xmlns:odgm="http://opendope.org/SmartArt/DataHierarchy" xmlns:odi="http://opendope.org/components" xmlns:oda="http://opendope.org/answers" xmlns:odq="http://opendope.org/questions" xmlns:odc="http://opendope.org/conditions" xmlns:odx="http://opendope.org/xpaths" xmlns:cppr="http://schemas.microsoft.com/office/2006/coverPageProps" xmlns:pvml="urn:schemas-microsoft-com:office:powerpoint" xmlns:w10="urn:schemas-microsoft-com:office:word" xmlns:v="urn:schemas-microsoft-com:vml" xmlns:o="urn:schemas-microsoft-com:office:office" xmlns:xvml="urn:schemas-microsoft-com:office:excel" xmlns:dsp="http://schemas.microsoft.com/office/drawing/2008/diagram" xmlns:xdr="http://schemas.openxmlformats.org/drawingml/2006/spreadsheetDrawing" xmlns:pic="http://schemas.openxmlformats.org/drawingml/2006/picture" xmlns:dgm="http://schemas.openxmlformats.org/drawingml/2006/diagram" xmlns:c14="http://schemas.microsoft.com/office/drawing/2007/8/2/chart" xmlns:cdr="http://schemas.openxmlformats.org/drawingml/2006/chartDrawing" xmlns:wne="http://schemas.microsoft.com/office/word/2006/wordml" xmlns:sl="http://schemas.openxmlformats.org/schemaLibrary/2006/main" xmlns:mc="http://schemas.openxmlformats.org/markup-compatibility/2006" xmlns:wp14="http://schemas.microsoft.com/office/word/2010/wordprocessingDrawing" xmlns:wp="http://schemas.openxmlformats.org/drawingml/2006/wordprocessingDrawing" xmlns:m="http://schemas.openxmlformats.org/officeDocument/2006/math" xmlns:w14="http://schemas.microsoft.com/office/word/2010/wordml" xmlns:w15="http://schemas.microsoft.com/office/word/2012/wordml" xmlns:w="http://schemas.openxmlformats.org/wordprocessingml/2006/main">
             <c:ext xmlns:c16="http://schemas.microsoft.com/office/drawing/2014/chart" uri="{C3380CC4-5D6E-409C-BE32-E72D297353CC}">
               <c16:uniqueId val="{00000002-6147-E74A-AA7B-5531F0E4EE0C}"/>
             </c:ext>
@@ -1324,7 +1324,7 @@
     <c:plotVisOnly val="1"/>
     <c:dispBlanksAs val="gap"/>
     <c:showDLblsOverMax val="0"/>
-    <c:extLst xmlns:w="http://schemas.openxmlformats.org/wordprocessingml/2006/main" xmlns:w15="http://schemas.microsoft.com/office/word/2012/wordml" xmlns:w14="http://schemas.microsoft.com/office/word/2010/wordml" xmlns:m="http://schemas.openxmlformats.org/officeDocument/2006/math" xmlns:wp="http://schemas.openxmlformats.org/drawingml/2006/wordprocessingDrawing" xmlns:wp14="http://schemas.microsoft.com/office/word/2010/wordprocessingDrawing" xmlns:mc="http://schemas.openxmlformats.org/markup-compatibility/2006" xmlns:sl="http://schemas.openxmlformats.org/schemaLibrary/2006/main" xmlns:wne="http://schemas.microsoft.com/office/word/2006/wordml" xmlns:cdr="http://schemas.openxmlformats.org/drawingml/2006/chartDrawing" xmlns:c14="http://schemas.microsoft.com/office/drawing/2007/8/2/chart" xmlns:dgm="http://schemas.openxmlformats.org/drawingml/2006/diagram" xmlns:pic="http://schemas.openxmlformats.org/drawingml/2006/picture" xmlns:xdr="http://schemas.openxmlformats.org/drawingml/2006/spreadsheetDrawing" xmlns:dsp="http://schemas.microsoft.com/office/drawing/2008/diagram" xmlns:xvml="urn:schemas-microsoft-com:office:excel" xmlns:o="urn:schemas-microsoft-com:office:office" xmlns:v="urn:schemas-microsoft-com:vml" xmlns:w10="urn:schemas-microsoft-com:office:word" xmlns:pvml="urn:schemas-microsoft-com:office:powerpoint" xmlns:cppr="http://schemas.microsoft.com/office/2006/coverPageProps" xmlns:odx="http://opendope.org/xpaths" xmlns:odc="http://opendope.org/conditions" xmlns:odq="http://opendope.org/questions" xmlns:oda="http://opendope.org/answers" xmlns:odi="http://opendope.org/components" xmlns:odgm="http://opendope.org/SmartArt/DataHierarchy" xmlns:b="http://schemas.openxmlformats.org/officeDocument/2006/bibliography" xmlns:wps="http://schemas.microsoft.com/office/word/2010/wordprocessingShape" xmlns:w16se="http://schemas.microsoft.com/office/word/2015/wordml/symex" xmlns:w16cid="http://schemas.microsoft.com/office/word/2016/wordml/cid" xmlns:wetp="http://schemas.microsoft.com/office/webextensions/taskpanes/2010/11" xmlns:we="http://schemas.microsoft.com/office/webextensions/webextension/2010/11" xmlns:comp="http://schemas.openxmlformats.org/drawingml/2006/compatibility" xmlns:lc="http://schemas.openxmlformats.org/drawingml/2006/lockedCanvas">
+    <c:extLst xmlns:lc="http://schemas.openxmlformats.org/drawingml/2006/lockedCanvas" xmlns:comp="http://schemas.openxmlformats.org/drawingml/2006/compatibility" xmlns:we="http://schemas.microsoft.com/office/webextensions/webextension/2010/11" xmlns:wetp="http://schemas.microsoft.com/office/webextensions/taskpanes/2010/11" xmlns:w16cid="http://schemas.microsoft.com/office/word/2016/wordml/cid" xmlns:w16se="http://schemas.microsoft.com/office/word/2015/wordml/symex" xmlns:wps="http://schemas.microsoft.com/office/word/2010/wordprocessingShape" xmlns:b="http://schemas.openxmlformats.org/officeDocument/2006/bibliography" xmlns:odgm="http://opendope.org/SmartArt/DataHierarchy" xmlns:odi="http://opendope.org/components" xmlns:oda="http://opendope.org/answers" xmlns:odq="http://opendope.org/questions" xmlns:odc="http://opendope.org/conditions" xmlns:odx="http://opendope.org/xpaths" xmlns:cppr="http://schemas.microsoft.com/office/2006/coverPageProps" xmlns:pvml="urn:schemas-microsoft-com:office:powerpoint" xmlns:w10="urn:schemas-microsoft-com:office:word" xmlns:v="urn:schemas-microsoft-com:vml" xmlns:o="urn:schemas-microsoft-com:office:office" xmlns:xvml="urn:schemas-microsoft-com:office:excel" xmlns:dsp="http://schemas.microsoft.com/office/drawing/2008/diagram" xmlns:xdr="http://schemas.openxmlformats.org/drawingml/2006/spreadsheetDrawing" xmlns:pic="http://schemas.openxmlformats.org/drawingml/2006/picture" xmlns:dgm="http://schemas.openxmlformats.org/drawingml/2006/diagram" xmlns:c14="http://schemas.microsoft.com/office/drawing/2007/8/2/chart" xmlns:cdr="http://schemas.openxmlformats.org/drawingml/2006/chartDrawing" xmlns:wne="http://schemas.microsoft.com/office/word/2006/wordml" xmlns:sl="http://schemas.openxmlformats.org/schemaLibrary/2006/main" xmlns:mc="http://schemas.openxmlformats.org/markup-compatibility/2006" xmlns:wp14="http://schemas.microsoft.com/office/word/2010/wordprocessingDrawing" xmlns:wp="http://schemas.openxmlformats.org/drawingml/2006/wordprocessingDrawing" xmlns:m="http://schemas.openxmlformats.org/officeDocument/2006/math" xmlns:w14="http://schemas.microsoft.com/office/word/2010/wordml" xmlns:w15="http://schemas.microsoft.com/office/word/2012/wordml" xmlns:w="http://schemas.openxmlformats.org/wordprocessingml/2006/main">
       <c:ext xmlns:c16r3="http://schemas.microsoft.com/office/drawing/2017/03/chart" uri="{56B9EC1D-385E-4148-901F-78D8002777C0}">
         <c16r3:dataDisplayOptions16>
           <c16r3:dispNaAsBlank val="1"/>
@@ -1426,7 +1426,7 @@
                 </a:outerShdw>
               </a:effectLst>
             </c:spPr>
-            <c:extLst xmlns:lc="http://schemas.openxmlformats.org/drawingml/2006/lockedCanvas" xmlns:comp="http://schemas.openxmlformats.org/drawingml/2006/compatibility" xmlns:we="http://schemas.microsoft.com/office/webextensions/webextension/2010/11" xmlns:wetp="http://schemas.microsoft.com/office/webextensions/taskpanes/2010/11" xmlns:w16cid="http://schemas.microsoft.com/office/word/2016/wordml/cid" xmlns:w16se="http://schemas.microsoft.com/office/word/2015/wordml/symex" xmlns:wps="http://schemas.microsoft.com/office/word/2010/wordprocessingShape" xmlns:b="http://schemas.openxmlformats.org/officeDocument/2006/bibliography" xmlns:odgm="http://opendope.org/SmartArt/DataHierarchy" xmlns:odi="http://opendope.org/components" xmlns:oda="http://opendope.org/answers" xmlns:odq="http://opendope.org/questions" xmlns:odc="http://opendope.org/conditions" xmlns:odx="http://opendope.org/xpaths" xmlns:cppr="http://schemas.microsoft.com/office/2006/coverPageProps" xmlns:pvml="urn:schemas-microsoft-com:office:powerpoint" xmlns:w10="urn:schemas-microsoft-com:office:word" xmlns:v="urn:schemas-microsoft-com:vml" xmlns:o="urn:schemas-microsoft-com:office:office" xmlns:xvml="urn:schemas-microsoft-com:office:excel" xmlns:dsp="http://schemas.microsoft.com/office/drawing/2008/diagram" xmlns:xdr="http://schemas.openxmlformats.org/drawingml/2006/spreadsheetDrawing" xmlns:pic="http://schemas.openxmlformats.org/drawingml/2006/picture" xmlns:dgm="http://schemas.openxmlformats.org/drawingml/2006/diagram" xmlns:c14="http://schemas.microsoft.com/office/drawing/2007/8/2/chart" xmlns:cdr="http://schemas.openxmlformats.org/drawingml/2006/chartDrawing" xmlns:wne="http://schemas.microsoft.com/office/word/2006/wordml" xmlns:sl="http://schemas.openxmlformats.org/schemaLibrary/2006/main" xmlns:mc="http://schemas.openxmlformats.org/markup-compatibility/2006" xmlns:wp14="http://schemas.microsoft.com/office/word/2010/wordprocessingDrawing" xmlns:wp="http://schemas.openxmlformats.org/drawingml/2006/wordprocessingDrawing" xmlns:m="http://schemas.openxmlformats.org/officeDocument/2006/math" xmlns:w14="http://schemas.microsoft.com/office/word/2010/wordml" xmlns:w15="http://schemas.microsoft.com/office/word/2012/wordml" xmlns:w="http://schemas.openxmlformats.org/wordprocessingml/2006/main">
+            <c:extLst xmlns:w="http://schemas.openxmlformats.org/wordprocessingml/2006/main" xmlns:w15="http://schemas.microsoft.com/office/word/2012/wordml" xmlns:w14="http://schemas.microsoft.com/office/word/2010/wordml" xmlns:m="http://schemas.openxmlformats.org/officeDocument/2006/math" xmlns:wp="http://schemas.openxmlformats.org/drawingml/2006/wordprocessingDrawing" xmlns:wp14="http://schemas.microsoft.com/office/word/2010/wordprocessingDrawing" xmlns:mc="http://schemas.openxmlformats.org/markup-compatibility/2006" xmlns:sl="http://schemas.openxmlformats.org/schemaLibrary/2006/main" xmlns:wne="http://schemas.microsoft.com/office/word/2006/wordml" xmlns:cdr="http://schemas.openxmlformats.org/drawingml/2006/chartDrawing" xmlns:c14="http://schemas.microsoft.com/office/drawing/2007/8/2/chart" xmlns:dgm="http://schemas.openxmlformats.org/drawingml/2006/diagram" xmlns:pic="http://schemas.openxmlformats.org/drawingml/2006/picture" xmlns:xdr="http://schemas.openxmlformats.org/drawingml/2006/spreadsheetDrawing" xmlns:dsp="http://schemas.microsoft.com/office/drawing/2008/diagram" xmlns:xvml="urn:schemas-microsoft-com:office:excel" xmlns:o="urn:schemas-microsoft-com:office:office" xmlns:v="urn:schemas-microsoft-com:vml" xmlns:w10="urn:schemas-microsoft-com:office:word" xmlns:pvml="urn:schemas-microsoft-com:office:powerpoint" xmlns:cppr="http://schemas.microsoft.com/office/2006/coverPageProps" xmlns:odx="http://opendope.org/xpaths" xmlns:odc="http://opendope.org/conditions" xmlns:odq="http://opendope.org/questions" xmlns:oda="http://opendope.org/answers" xmlns:odi="http://opendope.org/components" xmlns:odgm="http://opendope.org/SmartArt/DataHierarchy" xmlns:b="http://schemas.openxmlformats.org/officeDocument/2006/bibliography" xmlns:wps="http://schemas.microsoft.com/office/word/2010/wordprocessingShape" xmlns:w16se="http://schemas.microsoft.com/office/word/2015/wordml/symex" xmlns:w16cid="http://schemas.microsoft.com/office/word/2016/wordml/cid" xmlns:wetp="http://schemas.microsoft.com/office/webextensions/taskpanes/2010/11" xmlns:we="http://schemas.microsoft.com/office/webextensions/webextension/2010/11" xmlns:comp="http://schemas.openxmlformats.org/drawingml/2006/compatibility" xmlns:lc="http://schemas.openxmlformats.org/drawingml/2006/lockedCanvas">
               <c:ext xmlns:c16="http://schemas.microsoft.com/office/drawing/2014/chart" uri="{C3380CC4-5D6E-409C-BE32-E72D297353CC}">
                 <c16:uniqueId val="{00000001-6147-E74A-AA7B-5531F0E4EE0C}"/>
               </c:ext>
@@ -1509,7 +1509,7 @@
               </c:numCache>
             </c:numRef>
           </c:val>
-          <c:extLst xmlns:lc="http://schemas.openxmlformats.org/drawingml/2006/lockedCanvas" xmlns:comp="http://schemas.openxmlformats.org/drawingml/2006/compatibility" xmlns:we="http://schemas.microsoft.com/office/webextensions/webextension/2010/11" xmlns:wetp="http://schemas.microsoft.com/office/webextensions/taskpanes/2010/11" xmlns:w16cid="http://schemas.microsoft.com/office/word/2016/wordml/cid" xmlns:w16se="http://schemas.microsoft.com/office/word/2015/wordml/symex" xmlns:wps="http://schemas.microsoft.com/office/word/2010/wordprocessingShape" xmlns:b="http://schemas.openxmlformats.org/officeDocument/2006/bibliography" xmlns:odgm="http://opendope.org/SmartArt/DataHierarchy" xmlns:odi="http://opendope.org/components" xmlns:oda="http://opendope.org/answers" xmlns:odq="http://opendope.org/questions" xmlns:odc="http://opendope.org/conditions" xmlns:odx="http://opendope.org/xpaths" xmlns:cppr="http://schemas.microsoft.com/office/2006/coverPageProps" xmlns:pvml="urn:schemas-microsoft-com:office:powerpoint" xmlns:w10="urn:schemas-microsoft-com:office:word" xmlns:v="urn:schemas-microsoft-com:vml" xmlns:o="urn:schemas-microsoft-com:office:office" xmlns:xvml="urn:schemas-microsoft-com:office:excel" xmlns:dsp="http://schemas.microsoft.com/office/drawing/2008/diagram" xmlns:xdr="http://schemas.openxmlformats.org/drawingml/2006/spreadsheetDrawing" xmlns:pic="http://schemas.openxmlformats.org/drawingml/2006/picture" xmlns:dgm="http://schemas.openxmlformats.org/drawingml/2006/diagram" xmlns:c14="http://schemas.microsoft.com/office/drawing/2007/8/2/chart" xmlns:cdr="http://schemas.openxmlformats.org/drawingml/2006/chartDrawing" xmlns:wne="http://schemas.microsoft.com/office/word/2006/wordml" xmlns:sl="http://schemas.openxmlformats.org/schemaLibrary/2006/main" xmlns:mc="http://schemas.openxmlformats.org/markup-compatibility/2006" xmlns:wp14="http://schemas.microsoft.com/office/word/2010/wordprocessingDrawing" xmlns:wp="http://schemas.openxmlformats.org/drawingml/2006/wordprocessingDrawing" xmlns:m="http://schemas.openxmlformats.org/officeDocument/2006/math" xmlns:w14="http://schemas.microsoft.com/office/word/2010/wordml" xmlns:w15="http://schemas.microsoft.com/office/word/2012/wordml" xmlns:w="http://schemas.openxmlformats.org/wordprocessingml/2006/main">
+          <c:extLst xmlns:w="http://schemas.openxmlformats.org/wordprocessingml/2006/main" xmlns:w15="http://schemas.microsoft.com/office/word/2012/wordml" xmlns:w14="http://schemas.microsoft.com/office/word/2010/wordml" xmlns:m="http://schemas.openxmlformats.org/officeDocument/2006/math" xmlns:wp="http://schemas.openxmlformats.org/drawingml/2006/wordprocessingDrawing" xmlns:wp14="http://schemas.microsoft.com/office/word/2010/wordprocessingDrawing" xmlns:mc="http://schemas.openxmlformats.org/markup-compatibility/2006" xmlns:sl="http://schemas.openxmlformats.org/schemaLibrary/2006/main" xmlns:wne="http://schemas.microsoft.com/office/word/2006/wordml" xmlns:cdr="http://schemas.openxmlformats.org/drawingml/2006/chartDrawing" xmlns:c14="http://schemas.microsoft.com/office/drawing/2007/8/2/chart" xmlns:dgm="http://schemas.openxmlformats.org/drawingml/2006/diagram" xmlns:pic="http://schemas.openxmlformats.org/drawingml/2006/picture" xmlns:xdr="http://schemas.openxmlformats.org/drawingml/2006/spreadsheetDrawing" xmlns:dsp="http://schemas.microsoft.com/office/drawing/2008/diagram" xmlns:xvml="urn:schemas-microsoft-com:office:excel" xmlns:o="urn:schemas-microsoft-com:office:office" xmlns:v="urn:schemas-microsoft-com:vml" xmlns:w10="urn:schemas-microsoft-com:office:word" xmlns:pvml="urn:schemas-microsoft-com:office:powerpoint" xmlns:cppr="http://schemas.microsoft.com/office/2006/coverPageProps" xmlns:odx="http://opendope.org/xpaths" xmlns:odc="http://opendope.org/conditions" xmlns:odq="http://opendope.org/questions" xmlns:oda="http://opendope.org/answers" xmlns:odi="http://opendope.org/components" xmlns:odgm="http://opendope.org/SmartArt/DataHierarchy" xmlns:b="http://schemas.openxmlformats.org/officeDocument/2006/bibliography" xmlns:wps="http://schemas.microsoft.com/office/word/2010/wordprocessingShape" xmlns:w16se="http://schemas.microsoft.com/office/word/2015/wordml/symex" xmlns:w16cid="http://schemas.microsoft.com/office/word/2016/wordml/cid" xmlns:wetp="http://schemas.microsoft.com/office/webextensions/taskpanes/2010/11" xmlns:we="http://schemas.microsoft.com/office/webextensions/webextension/2010/11" xmlns:comp="http://schemas.openxmlformats.org/drawingml/2006/compatibility" xmlns:lc="http://schemas.openxmlformats.org/drawingml/2006/lockedCanvas">
             <c:ext xmlns:c16="http://schemas.microsoft.com/office/drawing/2014/chart" uri="{C3380CC4-5D6E-409C-BE32-E72D297353CC}">
               <c16:uniqueId val="{00000002-6147-E74A-AA7B-5531F0E4EE0C}"/>
             </c:ext>
@@ -2072,7 +2072,7 @@
     <c:plotVisOnly val="1"/>
     <c:dispBlanksAs val="gap"/>
     <c:showDLblsOverMax val="0"/>
-    <c:extLst xmlns:lc="http://schemas.openxmlformats.org/drawingml/2006/lockedCanvas" xmlns:comp="http://schemas.openxmlformats.org/drawingml/2006/compatibility" xmlns:we="http://schemas.microsoft.com/office/webextensions/webextension/2010/11" xmlns:wetp="http://schemas.microsoft.com/office/webextensions/taskpanes/2010/11" xmlns:w16cid="http://schemas.microsoft.com/office/word/2016/wordml/cid" xmlns:w16se="http://schemas.microsoft.com/office/word/2015/wordml/symex" xmlns:wps="http://schemas.microsoft.com/office/word/2010/wordprocessingShape" xmlns:b="http://schemas.openxmlformats.org/officeDocument/2006/bibliography" xmlns:odgm="http://opendope.org/SmartArt/DataHierarchy" xmlns:odi="http://opendope.org/components" xmlns:oda="http://opendope.org/answers" xmlns:odq="http://opendope.org/questions" xmlns:odc="http://opendope.org/conditions" xmlns:odx="http://opendope.org/xpaths" xmlns:cppr="http://schemas.microsoft.com/office/2006/coverPageProps" xmlns:pvml="urn:schemas-microsoft-com:office:powerpoint" xmlns:w10="urn:schemas-microsoft-com:office:word" xmlns:v="urn:schemas-microsoft-com:vml" xmlns:o="urn:schemas-microsoft-com:office:office" xmlns:xvml="urn:schemas-microsoft-com:office:excel" xmlns:dsp="http://schemas.microsoft.com/office/drawing/2008/diagram" xmlns:xdr="http://schemas.openxmlformats.org/drawingml/2006/spreadsheetDrawing" xmlns:pic="http://schemas.openxmlformats.org/drawingml/2006/picture" xmlns:dgm="http://schemas.openxmlformats.org/drawingml/2006/diagram" xmlns:c14="http://schemas.microsoft.com/office/drawing/2007/8/2/chart" xmlns:cdr="http://schemas.openxmlformats.org/drawingml/2006/chartDrawing" xmlns:wne="http://schemas.microsoft.com/office/word/2006/wordml" xmlns:sl="http://schemas.openxmlformats.org/schemaLibrary/2006/main" xmlns:mc="http://schemas.openxmlformats.org/markup-compatibility/2006" xmlns:wp14="http://schemas.microsoft.com/office/word/2010/wordprocessingDrawing" xmlns:wp="http://schemas.openxmlformats.org/drawingml/2006/wordprocessingDrawing" xmlns:m="http://schemas.openxmlformats.org/officeDocument/2006/math" xmlns:w14="http://schemas.microsoft.com/office/word/2010/wordml" xmlns:w15="http://schemas.microsoft.com/office/word/2012/wordml" xmlns:w="http://schemas.openxmlformats.org/wordprocessingml/2006/main">
+    <c:extLst xmlns:w="http://schemas.openxmlformats.org/wordprocessingml/2006/main" xmlns:w15="http://schemas.microsoft.com/office/word/2012/wordml" xmlns:w14="http://schemas.microsoft.com/office/word/2010/wordml" xmlns:m="http://schemas.openxmlformats.org/officeDocument/2006/math" xmlns:wp="http://schemas.openxmlformats.org/drawingml/2006/wordprocessingDrawing" xmlns:wp14="http://schemas.microsoft.com/office/word/2010/wordprocessingDrawing" xmlns:mc="http://schemas.openxmlformats.org/markup-compatibility/2006" xmlns:sl="http://schemas.openxmlformats.org/schemaLibrary/2006/main" xmlns:wne="http://schemas.microsoft.com/office/word/2006/wordml" xmlns:cdr="http://schemas.openxmlformats.org/drawingml/2006/chartDrawing" xmlns:c14="http://schemas.microsoft.com/office/drawing/2007/8/2/chart" xmlns:dgm="http://schemas.openxmlformats.org/drawingml/2006/diagram" xmlns:pic="http://schemas.openxmlformats.org/drawingml/2006/picture" xmlns:xdr="http://schemas.openxmlformats.org/drawingml/2006/spreadsheetDrawing" xmlns:dsp="http://schemas.microsoft.com/office/drawing/2008/diagram" xmlns:xvml="urn:schemas-microsoft-com:office:excel" xmlns:o="urn:schemas-microsoft-com:office:office" xmlns:v="urn:schemas-microsoft-com:vml" xmlns:w10="urn:schemas-microsoft-com:office:word" xmlns:pvml="urn:schemas-microsoft-com:office:powerpoint" xmlns:cppr="http://schemas.microsoft.com/office/2006/coverPageProps" xmlns:odx="http://opendope.org/xpaths" xmlns:odc="http://opendope.org/conditions" xmlns:odq="http://opendope.org/questions" xmlns:oda="http://opendope.org/answers" xmlns:odi="http://opendope.org/components" xmlns:odgm="http://opendope.org/SmartArt/DataHierarchy" xmlns:b="http://schemas.openxmlformats.org/officeDocument/2006/bibliography" xmlns:wps="http://schemas.microsoft.com/office/word/2010/wordprocessingShape" xmlns:w16se="http://schemas.microsoft.com/office/word/2015/wordml/symex" xmlns:w16cid="http://schemas.microsoft.com/office/word/2016/wordml/cid" xmlns:wetp="http://schemas.microsoft.com/office/webextensions/taskpanes/2010/11" xmlns:we="http://schemas.microsoft.com/office/webextensions/webextension/2010/11" xmlns:comp="http://schemas.openxmlformats.org/drawingml/2006/compatibility" xmlns:lc="http://schemas.openxmlformats.org/drawingml/2006/lockedCanvas">
       <c:ext xmlns:c16r3="http://schemas.microsoft.com/office/drawing/2017/03/chart" uri="{56B9EC1D-385E-4148-901F-78D8002777C0}">
         <c16r3:dataDisplayOptions16>
           <c16r3:dispNaAsBlank val="1"/>
@@ -2174,7 +2174,7 @@
                 </a:outerShdw>
               </a:effectLst>
             </c:spPr>
-            <c:extLst xmlns:w="http://schemas.openxmlformats.org/wordprocessingml/2006/main" xmlns:w15="http://schemas.microsoft.com/office/word/2012/wordml" xmlns:w14="http://schemas.microsoft.com/office/word/2010/wordml" xmlns:m="http://schemas.openxmlformats.org/officeDocument/2006/math" xmlns:wp="http://schemas.openxmlformats.org/drawingml/2006/wordprocessingDrawing" xmlns:wp14="http://schemas.microsoft.com/office/word/2010/wordprocessingDrawing" xmlns:mc="http://schemas.openxmlformats.org/markup-compatibility/2006" xmlns:sl="http://schemas.openxmlformats.org/schemaLibrary/2006/main" xmlns:wne="http://schemas.microsoft.com/office/word/2006/wordml" xmlns:cdr="http://schemas.openxmlformats.org/drawingml/2006/chartDrawing" xmlns:c14="http://schemas.microsoft.com/office/drawing/2007/8/2/chart" xmlns:dgm="http://schemas.openxmlformats.org/drawingml/2006/diagram" xmlns:pic="http://schemas.openxmlformats.org/drawingml/2006/picture" xmlns:xdr="http://schemas.openxmlformats.org/drawingml/2006/spreadsheetDrawing" xmlns:dsp="http://schemas.microsoft.com/office/drawing/2008/diagram" xmlns:xvml="urn:schemas-microsoft-com:office:excel" xmlns:o="urn:schemas-microsoft-com:office:office" xmlns:v="urn:schemas-microsoft-com:vml" xmlns:w10="urn:schemas-microsoft-com:office:word" xmlns:pvml="urn:schemas-microsoft-com:office:powerpoint" xmlns:cppr="http://schemas.microsoft.com/office/2006/coverPageProps" xmlns:odx="http://opendope.org/xpaths" xmlns:odc="http://opendope.org/conditions" xmlns:odq="http://opendope.org/questions" xmlns:oda="http://opendope.org/answers" xmlns:odi="http://opendope.org/components" xmlns:odgm="http://opendope.org/SmartArt/DataHierarchy" xmlns:b="http://schemas.openxmlformats.org/officeDocument/2006/bibliography" xmlns:wps="http://schemas.microsoft.com/office/word/2010/wordprocessingShape" xmlns:w16se="http://schemas.microsoft.com/office/word/2015/wordml/symex" xmlns:w16cid="http://schemas.microsoft.com/office/word/2016/wordml/cid" xmlns:wetp="http://schemas.microsoft.com/office/webextensions/taskpanes/2010/11" xmlns:we="http://schemas.microsoft.com/office/webextensions/webextension/2010/11" xmlns:comp="http://schemas.openxmlformats.org/drawingml/2006/compatibility" xmlns:lc="http://schemas.openxmlformats.org/drawingml/2006/lockedCanvas">
+            <c:extLst xmlns:lc="http://schemas.openxmlformats.org/drawingml/2006/lockedCanvas" xmlns:comp="http://schemas.openxmlformats.org/drawingml/2006/compatibility" xmlns:we="http://schemas.microsoft.com/office/webextensions/webextension/2010/11" xmlns:wetp="http://schemas.microsoft.com/office/webextensions/taskpanes/2010/11" xmlns:w16cid="http://schemas.microsoft.com/office/word/2016/wordml/cid" xmlns:w16se="http://schemas.microsoft.com/office/word/2015/wordml/symex" xmlns:wps="http://schemas.microsoft.com/office/word/2010/wordprocessingShape" xmlns:b="http://schemas.openxmlformats.org/officeDocument/2006/bibliography" xmlns:odgm="http://opendope.org/SmartArt/DataHierarchy" xmlns:odi="http://opendope.org/components" xmlns:oda="http://opendope.org/answers" xmlns:odq="http://opendope.org/questions" xmlns:odc="http://opendope.org/conditions" xmlns:odx="http://opendope.org/xpaths" xmlns:cppr="http://schemas.microsoft.com/office/2006/coverPageProps" xmlns:pvml="urn:schemas-microsoft-com:office:powerpoint" xmlns:w10="urn:schemas-microsoft-com:office:word" xmlns:v="urn:schemas-microsoft-com:vml" xmlns:o="urn:schemas-microsoft-com:office:office" xmlns:xvml="urn:schemas-microsoft-com:office:excel" xmlns:dsp="http://schemas.microsoft.com/office/drawing/2008/diagram" xmlns:xdr="http://schemas.openxmlformats.org/drawingml/2006/spreadsheetDrawing" xmlns:pic="http://schemas.openxmlformats.org/drawingml/2006/picture" xmlns:dgm="http://schemas.openxmlformats.org/drawingml/2006/diagram" xmlns:c14="http://schemas.microsoft.com/office/drawing/2007/8/2/chart" xmlns:cdr="http://schemas.openxmlformats.org/drawingml/2006/chartDrawing" xmlns:wne="http://schemas.microsoft.com/office/word/2006/wordml" xmlns:sl="http://schemas.openxmlformats.org/schemaLibrary/2006/main" xmlns:mc="http://schemas.openxmlformats.org/markup-compatibility/2006" xmlns:wp14="http://schemas.microsoft.com/office/word/2010/wordprocessingDrawing" xmlns:wp="http://schemas.openxmlformats.org/drawingml/2006/wordprocessingDrawing" xmlns:m="http://schemas.openxmlformats.org/officeDocument/2006/math" xmlns:w14="http://schemas.microsoft.com/office/word/2010/wordml" xmlns:w15="http://schemas.microsoft.com/office/word/2012/wordml" xmlns:w="http://schemas.openxmlformats.org/wordprocessingml/2006/main">
               <c:ext xmlns:c16="http://schemas.microsoft.com/office/drawing/2014/chart" uri="{C3380CC4-5D6E-409C-BE32-E72D297353CC}">
                 <c16:uniqueId val="{00000001-6147-E74A-AA7B-5531F0E4EE0C}"/>
               </c:ext>
@@ -2269,7 +2269,7 @@
               </c:numCache>
             </c:numRef>
           </c:val>
-          <c:extLst xmlns:w="http://schemas.openxmlformats.org/wordprocessingml/2006/main" xmlns:w15="http://schemas.microsoft.com/office/word/2012/wordml" xmlns:w14="http://schemas.microsoft.com/office/word/2010/wordml" xmlns:m="http://schemas.openxmlformats.org/officeDocument/2006/math" xmlns:wp="http://schemas.openxmlformats.org/drawingml/2006/wordprocessingDrawing" xmlns:wp14="http://schemas.microsoft.com/office/word/2010/wordprocessingDrawing" xmlns:mc="http://schemas.openxmlformats.org/markup-compatibility/2006" xmlns:sl="http://schemas.openxmlformats.org/schemaLibrary/2006/main" xmlns:wne="http://schemas.microsoft.com/office/word/2006/wordml" xmlns:cdr="http://schemas.openxmlformats.org/drawingml/2006/chartDrawing" xmlns:c14="http://schemas.microsoft.com/office/drawing/2007/8/2/chart" xmlns:dgm="http://schemas.openxmlformats.org/drawingml/2006/diagram" xmlns:pic="http://schemas.openxmlformats.org/drawingml/2006/picture" xmlns:xdr="http://schemas.openxmlformats.org/drawingml/2006/spreadsheetDrawing" xmlns:dsp="http://schemas.microsoft.com/office/drawing/2008/diagram" xmlns:xvml="urn:schemas-microsoft-com:office:excel" xmlns:o="urn:schemas-microsoft-com:office:office" xmlns:v="urn:schemas-microsoft-com:vml" xmlns:w10="urn:schemas-microsoft-com:office:word" xmlns:pvml="urn:schemas-microsoft-com:office:powerpoint" xmlns:cppr="http://schemas.microsoft.com/office/2006/coverPageProps" xmlns:odx="http://opendope.org/xpaths" xmlns:odc="http://opendope.org/conditions" xmlns:odq="http://opendope.org/questions" xmlns:oda="http://opendope.org/answers" xmlns:odi="http://opendope.org/components" xmlns:odgm="http://opendope.org/SmartArt/DataHierarchy" xmlns:b="http://schemas.openxmlformats.org/officeDocument/2006/bibliography" xmlns:wps="http://schemas.microsoft.com/office/word/2010/wordprocessingShape" xmlns:w16se="http://schemas.microsoft.com/office/word/2015/wordml/symex" xmlns:w16cid="http://schemas.microsoft.com/office/word/2016/wordml/cid" xmlns:wetp="http://schemas.microsoft.com/office/webextensions/taskpanes/2010/11" xmlns:we="http://schemas.microsoft.com/office/webextensions/webextension/2010/11" xmlns:comp="http://schemas.openxmlformats.org/drawingml/2006/compatibility" xmlns:lc="http://schemas.openxmlformats.org/drawingml/2006/lockedCanvas">
+          <c:extLst xmlns:lc="http://schemas.openxmlformats.org/drawingml/2006/lockedCanvas" xmlns:comp="http://schemas.openxmlformats.org/drawingml/2006/compatibility" xmlns:we="http://schemas.microsoft.com/office/webextensions/webextension/2010/11" xmlns:wetp="http://schemas.microsoft.com/office/webextensions/taskpanes/2010/11" xmlns:w16cid="http://schemas.microsoft.com/office/word/2016/wordml/cid" xmlns:w16se="http://schemas.microsoft.com/office/word/2015/wordml/symex" xmlns:wps="http://schemas.microsoft.com/office/word/2010/wordprocessingShape" xmlns:b="http://schemas.openxmlformats.org/officeDocument/2006/bibliography" xmlns:odgm="http://opendope.org/SmartArt/DataHierarchy" xmlns:odi="http://opendope.org/components" xmlns:oda="http://opendope.org/answers" xmlns:odq="http://opendope.org/questions" xmlns:odc="http://opendope.org/conditions" xmlns:odx="http://opendope.org/xpaths" xmlns:cppr="http://schemas.microsoft.com/office/2006/coverPageProps" xmlns:pvml="urn:schemas-microsoft-com:office:powerpoint" xmlns:w10="urn:schemas-microsoft-com:office:word" xmlns:v="urn:schemas-microsoft-com:vml" xmlns:o="urn:schemas-microsoft-com:office:office" xmlns:xvml="urn:schemas-microsoft-com:office:excel" xmlns:dsp="http://schemas.microsoft.com/office/drawing/2008/diagram" xmlns:xdr="http://schemas.openxmlformats.org/drawingml/2006/spreadsheetDrawing" xmlns:pic="http://schemas.openxmlformats.org/drawingml/2006/picture" xmlns:dgm="http://schemas.openxmlformats.org/drawingml/2006/diagram" xmlns:c14="http://schemas.microsoft.com/office/drawing/2007/8/2/chart" xmlns:cdr="http://schemas.openxmlformats.org/drawingml/2006/chartDrawing" xmlns:wne="http://schemas.microsoft.com/office/word/2006/wordml" xmlns:sl="http://schemas.openxmlformats.org/schemaLibrary/2006/main" xmlns:mc="http://schemas.openxmlformats.org/markup-compatibility/2006" xmlns:wp14="http://schemas.microsoft.com/office/word/2010/wordprocessingDrawing" xmlns:wp="http://schemas.openxmlformats.org/drawingml/2006/wordprocessingDrawing" xmlns:m="http://schemas.openxmlformats.org/officeDocument/2006/math" xmlns:w14="http://schemas.microsoft.com/office/word/2010/wordml" xmlns:w15="http://schemas.microsoft.com/office/word/2012/wordml" xmlns:w="http://schemas.openxmlformats.org/wordprocessingml/2006/main">
             <c:ext xmlns:c16="http://schemas.microsoft.com/office/drawing/2014/chart" uri="{C3380CC4-5D6E-409C-BE32-E72D297353CC}">
               <c16:uniqueId val="{00000002-6147-E74A-AA7B-5531F0E4EE0C}"/>
             </c:ext>
@@ -2880,7 +2880,7 @@
     <c:plotVisOnly val="1"/>
     <c:dispBlanksAs val="gap"/>
     <c:showDLblsOverMax val="0"/>
-    <c:extLst xmlns:w="http://schemas.openxmlformats.org/wordprocessingml/2006/main" xmlns:w15="http://schemas.microsoft.com/office/word/2012/wordml" xmlns:w14="http://schemas.microsoft.com/office/word/2010/wordml" xmlns:m="http://schemas.openxmlformats.org/officeDocument/2006/math" xmlns:wp="http://schemas.openxmlformats.org/drawingml/2006/wordprocessingDrawing" xmlns:wp14="http://schemas.microsoft.com/office/word/2010/wordprocessingDrawing" xmlns:mc="http://schemas.openxmlformats.org/markup-compatibility/2006" xmlns:sl="http://schemas.openxmlformats.org/schemaLibrary/2006/main" xmlns:wne="http://schemas.microsoft.com/office/word/2006/wordml" xmlns:cdr="http://schemas.openxmlformats.org/drawingml/2006/chartDrawing" xmlns:c14="http://schemas.microsoft.com/office/drawing/2007/8/2/chart" xmlns:dgm="http://schemas.openxmlformats.org/drawingml/2006/diagram" xmlns:pic="http://schemas.openxmlformats.org/drawingml/2006/picture" xmlns:xdr="http://schemas.openxmlformats.org/drawingml/2006/spreadsheetDrawing" xmlns:dsp="http://schemas.microsoft.com/office/drawing/2008/diagram" xmlns:xvml="urn:schemas-microsoft-com:office:excel" xmlns:o="urn:schemas-microsoft-com:office:office" xmlns:v="urn:schemas-microsoft-com:vml" xmlns:w10="urn:schemas-microsoft-com:office:word" xmlns:pvml="urn:schemas-microsoft-com:office:powerpoint" xmlns:cppr="http://schemas.microsoft.com/office/2006/coverPageProps" xmlns:odx="http://opendope.org/xpaths" xmlns:odc="http://opendope.org/conditions" xmlns:odq="http://opendope.org/questions" xmlns:oda="http://opendope.org/answers" xmlns:odi="http://opendope.org/components" xmlns:odgm="http://opendope.org/SmartArt/DataHierarchy" xmlns:b="http://schemas.openxmlformats.org/officeDocument/2006/bibliography" xmlns:wps="http://schemas.microsoft.com/office/word/2010/wordprocessingShape" xmlns:w16se="http://schemas.microsoft.com/office/word/2015/wordml/symex" xmlns:w16cid="http://schemas.microsoft.com/office/word/2016/wordml/cid" xmlns:wetp="http://schemas.microsoft.com/office/webextensions/taskpanes/2010/11" xmlns:we="http://schemas.microsoft.com/office/webextensions/webextension/2010/11" xmlns:comp="http://schemas.openxmlformats.org/drawingml/2006/compatibility" xmlns:lc="http://schemas.openxmlformats.org/drawingml/2006/lockedCanvas">
+    <c:extLst xmlns:lc="http://schemas.openxmlformats.org/drawingml/2006/lockedCanvas" xmlns:comp="http://schemas.openxmlformats.org/drawingml/2006/compatibility" xmlns:we="http://schemas.microsoft.com/office/webextensions/webextension/2010/11" xmlns:wetp="http://schemas.microsoft.com/office/webextensions/taskpanes/2010/11" xmlns:w16cid="http://schemas.microsoft.com/office/word/2016/wordml/cid" xmlns:w16se="http://schemas.microsoft.com/office/word/2015/wordml/symex" xmlns:wps="http://schemas.microsoft.com/office/word/2010/wordprocessingShape" xmlns:b="http://schemas.openxmlformats.org/officeDocument/2006/bibliography" xmlns:odgm="http://opendope.org/SmartArt/DataHierarchy" xmlns:odi="http://opendope.org/components" xmlns:oda="http://opendope.org/answers" xmlns:odq="http://opendope.org/questions" xmlns:odc="http://opendope.org/conditions" xmlns:odx="http://opendope.org/xpaths" xmlns:cppr="http://schemas.microsoft.com/office/2006/coverPageProps" xmlns:pvml="urn:schemas-microsoft-com:office:powerpoint" xmlns:w10="urn:schemas-microsoft-com:office:word" xmlns:v="urn:schemas-microsoft-com:vml" xmlns:o="urn:schemas-microsoft-com:office:office" xmlns:xvml="urn:schemas-microsoft-com:office:excel" xmlns:dsp="http://schemas.microsoft.com/office/drawing/2008/diagram" xmlns:xdr="http://schemas.openxmlformats.org/drawingml/2006/spreadsheetDrawing" xmlns:pic="http://schemas.openxmlformats.org/drawingml/2006/picture" xmlns:dgm="http://schemas.openxmlformats.org/drawingml/2006/diagram" xmlns:c14="http://schemas.microsoft.com/office/drawing/2007/8/2/chart" xmlns:cdr="http://schemas.openxmlformats.org/drawingml/2006/chartDrawing" xmlns:wne="http://schemas.microsoft.com/office/word/2006/wordml" xmlns:sl="http://schemas.openxmlformats.org/schemaLibrary/2006/main" xmlns:mc="http://schemas.openxmlformats.org/markup-compatibility/2006" xmlns:wp14="http://schemas.microsoft.com/office/word/2010/wordprocessingDrawing" xmlns:wp="http://schemas.openxmlformats.org/drawingml/2006/wordprocessingDrawing" xmlns:m="http://schemas.openxmlformats.org/officeDocument/2006/math" xmlns:w14="http://schemas.microsoft.com/office/word/2010/wordml" xmlns:w15="http://schemas.microsoft.com/office/word/2012/wordml" xmlns:w="http://schemas.openxmlformats.org/wordprocessingml/2006/main">
       <c:ext xmlns:c16r3="http://schemas.microsoft.com/office/drawing/2017/03/chart" uri="{56B9EC1D-385E-4148-901F-78D8002777C0}">
         <c16r3:dataDisplayOptions16>
           <c16r3:dispNaAsBlank val="1"/>
@@ -2982,7 +2982,7 @@
                 </a:outerShdw>
               </a:effectLst>
             </c:spPr>
-            <c:extLst xmlns:w="http://schemas.openxmlformats.org/wordprocessingml/2006/main" xmlns:w15="http://schemas.microsoft.com/office/word/2012/wordml" xmlns:w14="http://schemas.microsoft.com/office/word/2010/wordml" xmlns:m="http://schemas.openxmlformats.org/officeDocument/2006/math" xmlns:wp="http://schemas.openxmlformats.org/drawingml/2006/wordprocessingDrawing" xmlns:wp14="http://schemas.microsoft.com/office/word/2010/wordprocessingDrawing" xmlns:mc="http://schemas.openxmlformats.org/markup-compatibility/2006" xmlns:sl="http://schemas.openxmlformats.org/schemaLibrary/2006/main" xmlns:wne="http://schemas.microsoft.com/office/word/2006/wordml" xmlns:cdr="http://schemas.openxmlformats.org/drawingml/2006/chartDrawing" xmlns:c14="http://schemas.microsoft.com/office/drawing/2007/8/2/chart" xmlns:dgm="http://schemas.openxmlformats.org/drawingml/2006/diagram" xmlns:pic="http://schemas.openxmlformats.org/drawingml/2006/picture" xmlns:xdr="http://schemas.openxmlformats.org/drawingml/2006/spreadsheetDrawing" xmlns:dsp="http://schemas.microsoft.com/office/drawing/2008/diagram" xmlns:xvml="urn:schemas-microsoft-com:office:excel" xmlns:o="urn:schemas-microsoft-com:office:office" xmlns:v="urn:schemas-microsoft-com:vml" xmlns:w10="urn:schemas-microsoft-com:office:word" xmlns:pvml="urn:schemas-microsoft-com:office:powerpoint" xmlns:cppr="http://schemas.microsoft.com/office/2006/coverPageProps" xmlns:odx="http://opendope.org/xpaths" xmlns:odc="http://opendope.org/conditions" xmlns:odq="http://opendope.org/questions" xmlns:oda="http://opendope.org/answers" xmlns:odi="http://opendope.org/components" xmlns:odgm="http://opendope.org/SmartArt/DataHierarchy" xmlns:b="http://schemas.openxmlformats.org/officeDocument/2006/bibliography" xmlns:wps="http://schemas.microsoft.com/office/word/2010/wordprocessingShape" xmlns:w16se="http://schemas.microsoft.com/office/word/2015/wordml/symex" xmlns:w16cid="http://schemas.microsoft.com/office/word/2016/wordml/cid" xmlns:wetp="http://schemas.microsoft.com/office/webextensions/taskpanes/2010/11" xmlns:we="http://schemas.microsoft.com/office/webextensions/webextension/2010/11" xmlns:comp="http://schemas.openxmlformats.org/drawingml/2006/compatibility" xmlns:lc="http://schemas.openxmlformats.org/drawingml/2006/lockedCanvas">
+            <c:extLst xmlns:lc="http://schemas.openxmlformats.org/drawingml/2006/lockedCanvas" xmlns:comp="http://schemas.openxmlformats.org/drawingml/2006/compatibility" xmlns:we="http://schemas.microsoft.com/office/webextensions/webextension/2010/11" xmlns:wetp="http://schemas.microsoft.com/office/webextensions/taskpanes/2010/11" xmlns:w16cid="http://schemas.microsoft.com/office/word/2016/wordml/cid" xmlns:w16se="http://schemas.microsoft.com/office/word/2015/wordml/symex" xmlns:wps="http://schemas.microsoft.com/office/word/2010/wordprocessingShape" xmlns:b="http://schemas.openxmlformats.org/officeDocument/2006/bibliography" xmlns:odgm="http://opendope.org/SmartArt/DataHierarchy" xmlns:odi="http://opendope.org/components" xmlns:oda="http://opendope.org/answers" xmlns:odq="http://opendope.org/questions" xmlns:odc="http://opendope.org/conditions" xmlns:odx="http://opendope.org/xpaths" xmlns:cppr="http://schemas.microsoft.com/office/2006/coverPageProps" xmlns:pvml="urn:schemas-microsoft-com:office:powerpoint" xmlns:w10="urn:schemas-microsoft-com:office:word" xmlns:v="urn:schemas-microsoft-com:vml" xmlns:o="urn:schemas-microsoft-com:office:office" xmlns:xvml="urn:schemas-microsoft-com:office:excel" xmlns:dsp="http://schemas.microsoft.com/office/drawing/2008/diagram" xmlns:xdr="http://schemas.openxmlformats.org/drawingml/2006/spreadsheetDrawing" xmlns:pic="http://schemas.openxmlformats.org/drawingml/2006/picture" xmlns:dgm="http://schemas.openxmlformats.org/drawingml/2006/diagram" xmlns:c14="http://schemas.microsoft.com/office/drawing/2007/8/2/chart" xmlns:cdr="http://schemas.openxmlformats.org/drawingml/2006/chartDrawing" xmlns:wne="http://schemas.microsoft.com/office/word/2006/wordml" xmlns:sl="http://schemas.openxmlformats.org/schemaLibrary/2006/main" xmlns:mc="http://schemas.openxmlformats.org/markup-compatibility/2006" xmlns:wp14="http://schemas.microsoft.com/office/word/2010/wordprocessingDrawing" xmlns:wp="http://schemas.openxmlformats.org/drawingml/2006/wordprocessingDrawing" xmlns:m="http://schemas.openxmlformats.org/officeDocument/2006/math" xmlns:w14="http://schemas.microsoft.com/office/word/2010/wordml" xmlns:w15="http://schemas.microsoft.com/office/word/2012/wordml" xmlns:w="http://schemas.openxmlformats.org/wordprocessingml/2006/main">
               <c:ext xmlns:c16="http://schemas.microsoft.com/office/drawing/2014/chart" uri="{C3380CC4-5D6E-409C-BE32-E72D297353CC}">
                 <c16:uniqueId val="{00000001-6147-E74A-AA7B-5531F0E4EE0C}"/>
               </c:ext>
@@ -3077,7 +3077,7 @@
               </c:numCache>
             </c:numRef>
           </c:val>
-          <c:extLst xmlns:w="http://schemas.openxmlformats.org/wordprocessingml/2006/main" xmlns:w15="http://schemas.microsoft.com/office/word/2012/wordml" xmlns:w14="http://schemas.microsoft.com/office/word/2010/wordml" xmlns:m="http://schemas.openxmlformats.org/officeDocument/2006/math" xmlns:wp="http://schemas.openxmlformats.org/drawingml/2006/wordprocessingDrawing" xmlns:wp14="http://schemas.microsoft.com/office/word/2010/wordprocessingDrawing" xmlns:mc="http://schemas.openxmlformats.org/markup-compatibility/2006" xmlns:sl="http://schemas.openxmlformats.org/schemaLibrary/2006/main" xmlns:wne="http://schemas.microsoft.com/office/word/2006/wordml" xmlns:cdr="http://schemas.openxmlformats.org/drawingml/2006/chartDrawing" xmlns:c14="http://schemas.microsoft.com/office/drawing/2007/8/2/chart" xmlns:dgm="http://schemas.openxmlformats.org/drawingml/2006/diagram" xmlns:pic="http://schemas.openxmlformats.org/drawingml/2006/picture" xmlns:xdr="http://schemas.openxmlformats.org/drawingml/2006/spreadsheetDrawing" xmlns:dsp="http://schemas.microsoft.com/office/drawing/2008/diagram" xmlns:xvml="urn:schemas-microsoft-com:office:excel" xmlns:o="urn:schemas-microsoft-com:office:office" xmlns:v="urn:schemas-microsoft-com:vml" xmlns:w10="urn:schemas-microsoft-com:office:word" xmlns:pvml="urn:schemas-microsoft-com:office:powerpoint" xmlns:cppr="http://schemas.microsoft.com/office/2006/coverPageProps" xmlns:odx="http://opendope.org/xpaths" xmlns:odc="http://opendope.org/conditions" xmlns:odq="http://opendope.org/questions" xmlns:oda="http://opendope.org/answers" xmlns:odi="http://opendope.org/components" xmlns:odgm="http://opendope.org/SmartArt/DataHierarchy" xmlns:b="http://schemas.openxmlformats.org/officeDocument/2006/bibliography" xmlns:wps="http://schemas.microsoft.com/office/word/2010/wordprocessingShape" xmlns:w16se="http://schemas.microsoft.com/office/word/2015/wordml/symex" xmlns:w16cid="http://schemas.microsoft.com/office/word/2016/wordml/cid" xmlns:wetp="http://schemas.microsoft.com/office/webextensions/taskpanes/2010/11" xmlns:we="http://schemas.microsoft.com/office/webextensions/webextension/2010/11" xmlns:comp="http://schemas.openxmlformats.org/drawingml/2006/compatibility" xmlns:lc="http://schemas.openxmlformats.org/drawingml/2006/lockedCanvas">
+          <c:extLst xmlns:lc="http://schemas.openxmlformats.org/drawingml/2006/lockedCanvas" xmlns:comp="http://schemas.openxmlformats.org/drawingml/2006/compatibility" xmlns:we="http://schemas.microsoft.com/office/webextensions/webextension/2010/11" xmlns:wetp="http://schemas.microsoft.com/office/webextensions/taskpanes/2010/11" xmlns:w16cid="http://schemas.microsoft.com/office/word/2016/wordml/cid" xmlns:w16se="http://schemas.microsoft.com/office/word/2015/wordml/symex" xmlns:wps="http://schemas.microsoft.com/office/word/2010/wordprocessingShape" xmlns:b="http://schemas.openxmlformats.org/officeDocument/2006/bibliography" xmlns:odgm="http://opendope.org/SmartArt/DataHierarchy" xmlns:odi="http://opendope.org/components" xmlns:oda="http://opendope.org/answers" xmlns:odq="http://opendope.org/questions" xmlns:odc="http://opendope.org/conditions" xmlns:odx="http://opendope.org/xpaths" xmlns:cppr="http://schemas.microsoft.com/office/2006/coverPageProps" xmlns:pvml="urn:schemas-microsoft-com:office:powerpoint" xmlns:w10="urn:schemas-microsoft-com:office:word" xmlns:v="urn:schemas-microsoft-com:vml" xmlns:o="urn:schemas-microsoft-com:office:office" xmlns:xvml="urn:schemas-microsoft-com:office:excel" xmlns:dsp="http://schemas.microsoft.com/office/drawing/2008/diagram" xmlns:xdr="http://schemas.openxmlformats.org/drawingml/2006/spreadsheetDrawing" xmlns:pic="http://schemas.openxmlformats.org/drawingml/2006/picture" xmlns:dgm="http://schemas.openxmlformats.org/drawingml/2006/diagram" xmlns:c14="http://schemas.microsoft.com/office/drawing/2007/8/2/chart" xmlns:cdr="http://schemas.openxmlformats.org/drawingml/2006/chartDrawing" xmlns:wne="http://schemas.microsoft.com/office/word/2006/wordml" xmlns:sl="http://schemas.openxmlformats.org/schemaLibrary/2006/main" xmlns:mc="http://schemas.openxmlformats.org/markup-compatibility/2006" xmlns:wp14="http://schemas.microsoft.com/office/word/2010/wordprocessingDrawing" xmlns:wp="http://schemas.openxmlformats.org/drawingml/2006/wordprocessingDrawing" xmlns:m="http://schemas.openxmlformats.org/officeDocument/2006/math" xmlns:w14="http://schemas.microsoft.com/office/word/2010/wordml" xmlns:w15="http://schemas.microsoft.com/office/word/2012/wordml" xmlns:w="http://schemas.openxmlformats.org/wordprocessingml/2006/main">
             <c:ext xmlns:c16="http://schemas.microsoft.com/office/drawing/2014/chart" uri="{C3380CC4-5D6E-409C-BE32-E72D297353CC}">
               <c16:uniqueId val="{00000002-6147-E74A-AA7B-5531F0E4EE0C}"/>
             </c:ext>
@@ -3688,7 +3688,7 @@
     <c:plotVisOnly val="1"/>
     <c:dispBlanksAs val="gap"/>
     <c:showDLblsOverMax val="0"/>
-    <c:extLst xmlns:w="http://schemas.openxmlformats.org/wordprocessingml/2006/main" xmlns:w15="http://schemas.microsoft.com/office/word/2012/wordml" xmlns:w14="http://schemas.microsoft.com/office/word/2010/wordml" xmlns:m="http://schemas.openxmlformats.org/officeDocument/2006/math" xmlns:wp="http://schemas.openxmlformats.org/drawingml/2006/wordprocessingDrawing" xmlns:wp14="http://schemas.microsoft.com/office/word/2010/wordprocessingDrawing" xmlns:mc="http://schemas.openxmlformats.org/markup-compatibility/2006" xmlns:sl="http://schemas.openxmlformats.org/schemaLibrary/2006/main" xmlns:wne="http://schemas.microsoft.com/office/word/2006/wordml" xmlns:cdr="http://schemas.openxmlformats.org/drawingml/2006/chartDrawing" xmlns:c14="http://schemas.microsoft.com/office/drawing/2007/8/2/chart" xmlns:dgm="http://schemas.openxmlformats.org/drawingml/2006/diagram" xmlns:pic="http://schemas.openxmlformats.org/drawingml/2006/picture" xmlns:xdr="http://schemas.openxmlformats.org/drawingml/2006/spreadsheetDrawing" xmlns:dsp="http://schemas.microsoft.com/office/drawing/2008/diagram" xmlns:xvml="urn:schemas-microsoft-com:office:excel" xmlns:o="urn:schemas-microsoft-com:office:office" xmlns:v="urn:schemas-microsoft-com:vml" xmlns:w10="urn:schemas-microsoft-com:office:word" xmlns:pvml="urn:schemas-microsoft-com:office:powerpoint" xmlns:cppr="http://schemas.microsoft.com/office/2006/coverPageProps" xmlns:odx="http://opendope.org/xpaths" xmlns:odc="http://opendope.org/conditions" xmlns:odq="http://opendope.org/questions" xmlns:oda="http://opendope.org/answers" xmlns:odi="http://opendope.org/components" xmlns:odgm="http://opendope.org/SmartArt/DataHierarchy" xmlns:b="http://schemas.openxmlformats.org/officeDocument/2006/bibliography" xmlns:wps="http://schemas.microsoft.com/office/word/2010/wordprocessingShape" xmlns:w16se="http://schemas.microsoft.com/office/word/2015/wordml/symex" xmlns:w16cid="http://schemas.microsoft.com/office/word/2016/wordml/cid" xmlns:wetp="http://schemas.microsoft.com/office/webextensions/taskpanes/2010/11" xmlns:we="http://schemas.microsoft.com/office/webextensions/webextension/2010/11" xmlns:comp="http://schemas.openxmlformats.org/drawingml/2006/compatibility" xmlns:lc="http://schemas.openxmlformats.org/drawingml/2006/lockedCanvas">
+    <c:extLst xmlns:lc="http://schemas.openxmlformats.org/drawingml/2006/lockedCanvas" xmlns:comp="http://schemas.openxmlformats.org/drawingml/2006/compatibility" xmlns:we="http://schemas.microsoft.com/office/webextensions/webextension/2010/11" xmlns:wetp="http://schemas.microsoft.com/office/webextensions/taskpanes/2010/11" xmlns:w16cid="http://schemas.microsoft.com/office/word/2016/wordml/cid" xmlns:w16se="http://schemas.microsoft.com/office/word/2015/wordml/symex" xmlns:wps="http://schemas.microsoft.com/office/word/2010/wordprocessingShape" xmlns:b="http://schemas.openxmlformats.org/officeDocument/2006/bibliography" xmlns:odgm="http://opendope.org/SmartArt/DataHierarchy" xmlns:odi="http://opendope.org/components" xmlns:oda="http://opendope.org/answers" xmlns:odq="http://opendope.org/questions" xmlns:odc="http://opendope.org/conditions" xmlns:odx="http://opendope.org/xpaths" xmlns:cppr="http://schemas.microsoft.com/office/2006/coverPageProps" xmlns:pvml="urn:schemas-microsoft-com:office:powerpoint" xmlns:w10="urn:schemas-microsoft-com:office:word" xmlns:v="urn:schemas-microsoft-com:vml" xmlns:o="urn:schemas-microsoft-com:office:office" xmlns:xvml="urn:schemas-microsoft-com:office:excel" xmlns:dsp="http://schemas.microsoft.com/office/drawing/2008/diagram" xmlns:xdr="http://schemas.openxmlformats.org/drawingml/2006/spreadsheetDrawing" xmlns:pic="http://schemas.openxmlformats.org/drawingml/2006/picture" xmlns:dgm="http://schemas.openxmlformats.org/drawingml/2006/diagram" xmlns:c14="http://schemas.microsoft.com/office/drawing/2007/8/2/chart" xmlns:cdr="http://schemas.openxmlformats.org/drawingml/2006/chartDrawing" xmlns:wne="http://schemas.microsoft.com/office/word/2006/wordml" xmlns:sl="http://schemas.openxmlformats.org/schemaLibrary/2006/main" xmlns:mc="http://schemas.openxmlformats.org/markup-compatibility/2006" xmlns:wp14="http://schemas.microsoft.com/office/word/2010/wordprocessingDrawing" xmlns:wp="http://schemas.openxmlformats.org/drawingml/2006/wordprocessingDrawing" xmlns:m="http://schemas.openxmlformats.org/officeDocument/2006/math" xmlns:w14="http://schemas.microsoft.com/office/word/2010/wordml" xmlns:w15="http://schemas.microsoft.com/office/word/2012/wordml" xmlns:w="http://schemas.openxmlformats.org/wordprocessingml/2006/main">
       <c:ext xmlns:c16r3="http://schemas.microsoft.com/office/drawing/2017/03/chart" uri="{56B9EC1D-385E-4148-901F-78D8002777C0}">
         <c16r3:dataDisplayOptions16>
           <c16r3:dispNaAsBlank val="1"/>
@@ -3790,7 +3790,7 @@
                 </a:outerShdw>
               </a:effectLst>
             </c:spPr>
-            <c:extLst xmlns:lc="http://schemas.openxmlformats.org/drawingml/2006/lockedCanvas" xmlns:comp="http://schemas.openxmlformats.org/drawingml/2006/compatibility" xmlns:we="http://schemas.microsoft.com/office/webextensions/webextension/2010/11" xmlns:wetp="http://schemas.microsoft.com/office/webextensions/taskpanes/2010/11" xmlns:w16cid="http://schemas.microsoft.com/office/word/2016/wordml/cid" xmlns:w16se="http://schemas.microsoft.com/office/word/2015/wordml/symex" xmlns:wps="http://schemas.microsoft.com/office/word/2010/wordprocessingShape" xmlns:b="http://schemas.openxmlformats.org/officeDocument/2006/bibliography" xmlns:odgm="http://opendope.org/SmartArt/DataHierarchy" xmlns:odi="http://opendope.org/components" xmlns:oda="http://opendope.org/answers" xmlns:odq="http://opendope.org/questions" xmlns:odc="http://opendope.org/conditions" xmlns:odx="http://opendope.org/xpaths" xmlns:cppr="http://schemas.microsoft.com/office/2006/coverPageProps" xmlns:pvml="urn:schemas-microsoft-com:office:powerpoint" xmlns:w10="urn:schemas-microsoft-com:office:word" xmlns:v="urn:schemas-microsoft-com:vml" xmlns:o="urn:schemas-microsoft-com:office:office" xmlns:xvml="urn:schemas-microsoft-com:office:excel" xmlns:dsp="http://schemas.microsoft.com/office/drawing/2008/diagram" xmlns:xdr="http://schemas.openxmlformats.org/drawingml/2006/spreadsheetDrawing" xmlns:pic="http://schemas.openxmlformats.org/drawingml/2006/picture" xmlns:dgm="http://schemas.openxmlformats.org/drawingml/2006/diagram" xmlns:c14="http://schemas.microsoft.com/office/drawing/2007/8/2/chart" xmlns:cdr="http://schemas.openxmlformats.org/drawingml/2006/chartDrawing" xmlns:wne="http://schemas.microsoft.com/office/word/2006/wordml" xmlns:sl="http://schemas.openxmlformats.org/schemaLibrary/2006/main" xmlns:mc="http://schemas.openxmlformats.org/markup-compatibility/2006" xmlns:wp14="http://schemas.microsoft.com/office/word/2010/wordprocessingDrawing" xmlns:wp="http://schemas.openxmlformats.org/drawingml/2006/wordprocessingDrawing" xmlns:m="http://schemas.openxmlformats.org/officeDocument/2006/math" xmlns:w14="http://schemas.microsoft.com/office/word/2010/wordml" xmlns:w15="http://schemas.microsoft.com/office/word/2012/wordml" xmlns:w="http://schemas.openxmlformats.org/wordprocessingml/2006/main">
+            <c:extLst xmlns:w="http://schemas.openxmlformats.org/wordprocessingml/2006/main" xmlns:w15="http://schemas.microsoft.com/office/word/2012/wordml" xmlns:w14="http://schemas.microsoft.com/office/word/2010/wordml" xmlns:m="http://schemas.openxmlformats.org/officeDocument/2006/math" xmlns:wp="http://schemas.openxmlformats.org/drawingml/2006/wordprocessingDrawing" xmlns:wp14="http://schemas.microsoft.com/office/word/2010/wordprocessingDrawing" xmlns:mc="http://schemas.openxmlformats.org/markup-compatibility/2006" xmlns:sl="http://schemas.openxmlformats.org/schemaLibrary/2006/main" xmlns:wne="http://schemas.microsoft.com/office/word/2006/wordml" xmlns:cdr="http://schemas.openxmlformats.org/drawingml/2006/chartDrawing" xmlns:c14="http://schemas.microsoft.com/office/drawing/2007/8/2/chart" xmlns:dgm="http://schemas.openxmlformats.org/drawingml/2006/diagram" xmlns:pic="http://schemas.openxmlformats.org/drawingml/2006/picture" xmlns:xdr="http://schemas.openxmlformats.org/drawingml/2006/spreadsheetDrawing" xmlns:dsp="http://schemas.microsoft.com/office/drawing/2008/diagram" xmlns:xvml="urn:schemas-microsoft-com:office:excel" xmlns:o="urn:schemas-microsoft-com:office:office" xmlns:v="urn:schemas-microsoft-com:vml" xmlns:w10="urn:schemas-microsoft-com:office:word" xmlns:pvml="urn:schemas-microsoft-com:office:powerpoint" xmlns:cppr="http://schemas.microsoft.com/office/2006/coverPageProps" xmlns:odx="http://opendope.org/xpaths" xmlns:odc="http://opendope.org/conditions" xmlns:odq="http://opendope.org/questions" xmlns:oda="http://opendope.org/answers" xmlns:odi="http://opendope.org/components" xmlns:odgm="http://opendope.org/SmartArt/DataHierarchy" xmlns:b="http://schemas.openxmlformats.org/officeDocument/2006/bibliography" xmlns:wps="http://schemas.microsoft.com/office/word/2010/wordprocessingShape" xmlns:w16se="http://schemas.microsoft.com/office/word/2015/wordml/symex" xmlns:w16cid="http://schemas.microsoft.com/office/word/2016/wordml/cid" xmlns:wetp="http://schemas.microsoft.com/office/webextensions/taskpanes/2010/11" xmlns:we="http://schemas.microsoft.com/office/webextensions/webextension/2010/11" xmlns:comp="http://schemas.openxmlformats.org/drawingml/2006/compatibility" xmlns:lc="http://schemas.openxmlformats.org/drawingml/2006/lockedCanvas">
               <c:ext xmlns:c16="http://schemas.microsoft.com/office/drawing/2014/chart" uri="{C3380CC4-5D6E-409C-BE32-E72D297353CC}">
                 <c16:uniqueId val="{00000001-6147-E74A-AA7B-5531F0E4EE0C}"/>
               </c:ext>
@@ -3885,7 +3885,7 @@
               </c:numCache>
             </c:numRef>
           </c:val>
-          <c:extLst xmlns:lc="http://schemas.openxmlformats.org/drawingml/2006/lockedCanvas" xmlns:comp="http://schemas.openxmlformats.org/drawingml/2006/compatibility" xmlns:we="http://schemas.microsoft.com/office/webextensions/webextension/2010/11" xmlns:wetp="http://schemas.microsoft.com/office/webextensions/taskpanes/2010/11" xmlns:w16cid="http://schemas.microsoft.com/office/word/2016/wordml/cid" xmlns:w16se="http://schemas.microsoft.com/office/word/2015/wordml/symex" xmlns:wps="http://schemas.microsoft.com/office/word/2010/wordprocessingShape" xmlns:b="http://schemas.openxmlformats.org/officeDocument/2006/bibliography" xmlns:odgm="http://opendope.org/SmartArt/DataHierarchy" xmlns:odi="http://opendope.org/components" xmlns:oda="http://opendope.org/answers" xmlns:odq="http://opendope.org/questions" xmlns:odc="http://opendope.org/conditions" xmlns:odx="http://opendope.org/xpaths" xmlns:cppr="http://schemas.microsoft.com/office/2006/coverPageProps" xmlns:pvml="urn:schemas-microsoft-com:office:powerpoint" xmlns:w10="urn:schemas-microsoft-com:office:word" xmlns:v="urn:schemas-microsoft-com:vml" xmlns:o="urn:schemas-microsoft-com:office:office" xmlns:xvml="urn:schemas-microsoft-com:office:excel" xmlns:dsp="http://schemas.microsoft.com/office/drawing/2008/diagram" xmlns:xdr="http://schemas.openxmlformats.org/drawingml/2006/spreadsheetDrawing" xmlns:pic="http://schemas.openxmlformats.org/drawingml/2006/picture" xmlns:dgm="http://schemas.openxmlformats.org/drawingml/2006/diagram" xmlns:c14="http://schemas.microsoft.com/office/drawing/2007/8/2/chart" xmlns:cdr="http://schemas.openxmlformats.org/drawingml/2006/chartDrawing" xmlns:wne="http://schemas.microsoft.com/office/word/2006/wordml" xmlns:sl="http://schemas.openxmlformats.org/schemaLibrary/2006/main" xmlns:mc="http://schemas.openxmlformats.org/markup-compatibility/2006" xmlns:wp14="http://schemas.microsoft.com/office/word/2010/wordprocessingDrawing" xmlns:wp="http://schemas.openxmlformats.org/drawingml/2006/wordprocessingDrawing" xmlns:m="http://schemas.openxmlformats.org/officeDocument/2006/math" xmlns:w14="http://schemas.microsoft.com/office/word/2010/wordml" xmlns:w15="http://schemas.microsoft.com/office/word/2012/wordml" xmlns:w="http://schemas.openxmlformats.org/wordprocessingml/2006/main">
+          <c:extLst xmlns:w="http://schemas.openxmlformats.org/wordprocessingml/2006/main" xmlns:w15="http://schemas.microsoft.com/office/word/2012/wordml" xmlns:w14="http://schemas.microsoft.com/office/word/2010/wordml" xmlns:m="http://schemas.openxmlformats.org/officeDocument/2006/math" xmlns:wp="http://schemas.openxmlformats.org/drawingml/2006/wordprocessingDrawing" xmlns:wp14="http://schemas.microsoft.com/office/word/2010/wordprocessingDrawing" xmlns:mc="http://schemas.openxmlformats.org/markup-compatibility/2006" xmlns:sl="http://schemas.openxmlformats.org/schemaLibrary/2006/main" xmlns:wne="http://schemas.microsoft.com/office/word/2006/wordml" xmlns:cdr="http://schemas.openxmlformats.org/drawingml/2006/chartDrawing" xmlns:c14="http://schemas.microsoft.com/office/drawing/2007/8/2/chart" xmlns:dgm="http://schemas.openxmlformats.org/drawingml/2006/diagram" xmlns:pic="http://schemas.openxmlformats.org/drawingml/2006/picture" xmlns:xdr="http://schemas.openxmlformats.org/drawingml/2006/spreadsheetDrawing" xmlns:dsp="http://schemas.microsoft.com/office/drawing/2008/diagram" xmlns:xvml="urn:schemas-microsoft-com:office:excel" xmlns:o="urn:schemas-microsoft-com:office:office" xmlns:v="urn:schemas-microsoft-com:vml" xmlns:w10="urn:schemas-microsoft-com:office:word" xmlns:pvml="urn:schemas-microsoft-com:office:powerpoint" xmlns:cppr="http://schemas.microsoft.com/office/2006/coverPageProps" xmlns:odx="http://opendope.org/xpaths" xmlns:odc="http://opendope.org/conditions" xmlns:odq="http://opendope.org/questions" xmlns:oda="http://opendope.org/answers" xmlns:odi="http://opendope.org/components" xmlns:odgm="http://opendope.org/SmartArt/DataHierarchy" xmlns:b="http://schemas.openxmlformats.org/officeDocument/2006/bibliography" xmlns:wps="http://schemas.microsoft.com/office/word/2010/wordprocessingShape" xmlns:w16se="http://schemas.microsoft.com/office/word/2015/wordml/symex" xmlns:w16cid="http://schemas.microsoft.com/office/word/2016/wordml/cid" xmlns:wetp="http://schemas.microsoft.com/office/webextensions/taskpanes/2010/11" xmlns:we="http://schemas.microsoft.com/office/webextensions/webextension/2010/11" xmlns:comp="http://schemas.openxmlformats.org/drawingml/2006/compatibility" xmlns:lc="http://schemas.openxmlformats.org/drawingml/2006/lockedCanvas">
             <c:ext xmlns:c16="http://schemas.microsoft.com/office/drawing/2014/chart" uri="{C3380CC4-5D6E-409C-BE32-E72D297353CC}">
               <c16:uniqueId val="{00000002-6147-E74A-AA7B-5531F0E4EE0C}"/>
             </c:ext>
@@ -4496,7 +4496,7 @@
     <c:plotVisOnly val="1"/>
     <c:dispBlanksAs val="gap"/>
     <c:showDLblsOverMax val="0"/>
-    <c:extLst xmlns:lc="http://schemas.openxmlformats.org/drawingml/2006/lockedCanvas" xmlns:comp="http://schemas.openxmlformats.org/drawingml/2006/compatibility" xmlns:we="http://schemas.microsoft.com/office/webextensions/webextension/2010/11" xmlns:wetp="http://schemas.microsoft.com/office/webextensions/taskpanes/2010/11" xmlns:w16cid="http://schemas.microsoft.com/office/word/2016/wordml/cid" xmlns:w16se="http://schemas.microsoft.com/office/word/2015/wordml/symex" xmlns:wps="http://schemas.microsoft.com/office/word/2010/wordprocessingShape" xmlns:b="http://schemas.openxmlformats.org/officeDocument/2006/bibliography" xmlns:odgm="http://opendope.org/SmartArt/DataHierarchy" xmlns:odi="http://opendope.org/components" xmlns:oda="http://opendope.org/answers" xmlns:odq="http://opendope.org/questions" xmlns:odc="http://opendope.org/conditions" xmlns:odx="http://opendope.org/xpaths" xmlns:cppr="http://schemas.microsoft.com/office/2006/coverPageProps" xmlns:pvml="urn:schemas-microsoft-com:office:powerpoint" xmlns:w10="urn:schemas-microsoft-com:office:word" xmlns:v="urn:schemas-microsoft-com:vml" xmlns:o="urn:schemas-microsoft-com:office:office" xmlns:xvml="urn:schemas-microsoft-com:office:excel" xmlns:dsp="http://schemas.microsoft.com/office/drawing/2008/diagram" xmlns:xdr="http://schemas.openxmlformats.org/drawingml/2006/spreadsheetDrawing" xmlns:pic="http://schemas.openxmlformats.org/drawingml/2006/picture" xmlns:dgm="http://schemas.openxmlformats.org/drawingml/2006/diagram" xmlns:c14="http://schemas.microsoft.com/office/drawing/2007/8/2/chart" xmlns:cdr="http://schemas.openxmlformats.org/drawingml/2006/chartDrawing" xmlns:wne="http://schemas.microsoft.com/office/word/2006/wordml" xmlns:sl="http://schemas.openxmlformats.org/schemaLibrary/2006/main" xmlns:mc="http://schemas.openxmlformats.org/markup-compatibility/2006" xmlns:wp14="http://schemas.microsoft.com/office/word/2010/wordprocessingDrawing" xmlns:wp="http://schemas.openxmlformats.org/drawingml/2006/wordprocessingDrawing" xmlns:m="http://schemas.openxmlformats.org/officeDocument/2006/math" xmlns:w14="http://schemas.microsoft.com/office/word/2010/wordml" xmlns:w15="http://schemas.microsoft.com/office/word/2012/wordml" xmlns:w="http://schemas.openxmlformats.org/wordprocessingml/2006/main">
+    <c:extLst xmlns:w="http://schemas.openxmlformats.org/wordprocessingml/2006/main" xmlns:w15="http://schemas.microsoft.com/office/word/2012/wordml" xmlns:w14="http://schemas.microsoft.com/office/word/2010/wordml" xmlns:m="http://schemas.openxmlformats.org/officeDocument/2006/math" xmlns:wp="http://schemas.openxmlformats.org/drawingml/2006/wordprocessingDrawing" xmlns:wp14="http://schemas.microsoft.com/office/word/2010/wordprocessingDrawing" xmlns:mc="http://schemas.openxmlformats.org/markup-compatibility/2006" xmlns:sl="http://schemas.openxmlformats.org/schemaLibrary/2006/main" xmlns:wne="http://schemas.microsoft.com/office/word/2006/wordml" xmlns:cdr="http://schemas.openxmlformats.org/drawingml/2006/chartDrawing" xmlns:c14="http://schemas.microsoft.com/office/drawing/2007/8/2/chart" xmlns:dgm="http://schemas.openxmlformats.org/drawingml/2006/diagram" xmlns:pic="http://schemas.openxmlformats.org/drawingml/2006/picture" xmlns:xdr="http://schemas.openxmlformats.org/drawingml/2006/spreadsheetDrawing" xmlns:dsp="http://schemas.microsoft.com/office/drawing/2008/diagram" xmlns:xvml="urn:schemas-microsoft-com:office:excel" xmlns:o="urn:schemas-microsoft-com:office:office" xmlns:v="urn:schemas-microsoft-com:vml" xmlns:w10="urn:schemas-microsoft-com:office:word" xmlns:pvml="urn:schemas-microsoft-com:office:powerpoint" xmlns:cppr="http://schemas.microsoft.com/office/2006/coverPageProps" xmlns:odx="http://opendope.org/xpaths" xmlns:odc="http://opendope.org/conditions" xmlns:odq="http://opendope.org/questions" xmlns:oda="http://opendope.org/answers" xmlns:odi="http://opendope.org/components" xmlns:odgm="http://opendope.org/SmartArt/DataHierarchy" xmlns:b="http://schemas.openxmlformats.org/officeDocument/2006/bibliography" xmlns:wps="http://schemas.microsoft.com/office/word/2010/wordprocessingShape" xmlns:w16se="http://schemas.microsoft.com/office/word/2015/wordml/symex" xmlns:w16cid="http://schemas.microsoft.com/office/word/2016/wordml/cid" xmlns:wetp="http://schemas.microsoft.com/office/webextensions/taskpanes/2010/11" xmlns:we="http://schemas.microsoft.com/office/webextensions/webextension/2010/11" xmlns:comp="http://schemas.openxmlformats.org/drawingml/2006/compatibility" xmlns:lc="http://schemas.openxmlformats.org/drawingml/2006/lockedCanvas">
       <c:ext xmlns:c16r3="http://schemas.microsoft.com/office/drawing/2017/03/chart" uri="{56B9EC1D-385E-4148-901F-78D8002777C0}">
         <c16r3:dataDisplayOptions16>
           <c16r3:dispNaAsBlank val="1"/>
@@ -4598,7 +4598,7 @@
                 </a:outerShdw>
               </a:effectLst>
             </c:spPr>
-            <c:extLst xmlns:lc="http://schemas.openxmlformats.org/drawingml/2006/lockedCanvas" xmlns:comp="http://schemas.openxmlformats.org/drawingml/2006/compatibility" xmlns:we="http://schemas.microsoft.com/office/webextensions/webextension/2010/11" xmlns:wetp="http://schemas.microsoft.com/office/webextensions/taskpanes/2010/11" xmlns:w16cid="http://schemas.microsoft.com/office/word/2016/wordml/cid" xmlns:w16se="http://schemas.microsoft.com/office/word/2015/wordml/symex" xmlns:wps="http://schemas.microsoft.com/office/word/2010/wordprocessingShape" xmlns:b="http://schemas.openxmlformats.org/officeDocument/2006/bibliography" xmlns:odgm="http://opendope.org/SmartArt/DataHierarchy" xmlns:odi="http://opendope.org/components" xmlns:oda="http://opendope.org/answers" xmlns:odq="http://opendope.org/questions" xmlns:odc="http://opendope.org/conditions" xmlns:odx="http://opendope.org/xpaths" xmlns:cppr="http://schemas.microsoft.com/office/2006/coverPageProps" xmlns:pvml="urn:schemas-microsoft-com:office:powerpoint" xmlns:w10="urn:schemas-microsoft-com:office:word" xmlns:v="urn:schemas-microsoft-com:vml" xmlns:o="urn:schemas-microsoft-com:office:office" xmlns:xvml="urn:schemas-microsoft-com:office:excel" xmlns:dsp="http://schemas.microsoft.com/office/drawing/2008/diagram" xmlns:xdr="http://schemas.openxmlformats.org/drawingml/2006/spreadsheetDrawing" xmlns:pic="http://schemas.openxmlformats.org/drawingml/2006/picture" xmlns:dgm="http://schemas.openxmlformats.org/drawingml/2006/diagram" xmlns:c14="http://schemas.microsoft.com/office/drawing/2007/8/2/chart" xmlns:cdr="http://schemas.openxmlformats.org/drawingml/2006/chartDrawing" xmlns:wne="http://schemas.microsoft.com/office/word/2006/wordml" xmlns:sl="http://schemas.openxmlformats.org/schemaLibrary/2006/main" xmlns:mc="http://schemas.openxmlformats.org/markup-compatibility/2006" xmlns:wp14="http://schemas.microsoft.com/office/word/2010/wordprocessingDrawing" xmlns:wp="http://schemas.openxmlformats.org/drawingml/2006/wordprocessingDrawing" xmlns:m="http://schemas.openxmlformats.org/officeDocument/2006/math" xmlns:w14="http://schemas.microsoft.com/office/word/2010/wordml" xmlns:w15="http://schemas.microsoft.com/office/word/2012/wordml" xmlns:w="http://schemas.openxmlformats.org/wordprocessingml/2006/main">
+            <c:extLst xmlns:w="http://schemas.openxmlformats.org/wordprocessingml/2006/main" xmlns:w15="http://schemas.microsoft.com/office/word/2012/wordml" xmlns:w14="http://schemas.microsoft.com/office/word/2010/wordml" xmlns:m="http://schemas.openxmlformats.org/officeDocument/2006/math" xmlns:wp="http://schemas.openxmlformats.org/drawingml/2006/wordprocessingDrawing" xmlns:wp14="http://schemas.microsoft.com/office/word/2010/wordprocessingDrawing" xmlns:mc="http://schemas.openxmlformats.org/markup-compatibility/2006" xmlns:sl="http://schemas.openxmlformats.org/schemaLibrary/2006/main" xmlns:wne="http://schemas.microsoft.com/office/word/2006/wordml" xmlns:cdr="http://schemas.openxmlformats.org/drawingml/2006/chartDrawing" xmlns:c14="http://schemas.microsoft.com/office/drawing/2007/8/2/chart" xmlns:dgm="http://schemas.openxmlformats.org/drawingml/2006/diagram" xmlns:pic="http://schemas.openxmlformats.org/drawingml/2006/picture" xmlns:xdr="http://schemas.openxmlformats.org/drawingml/2006/spreadsheetDrawing" xmlns:dsp="http://schemas.microsoft.com/office/drawing/2008/diagram" xmlns:xvml="urn:schemas-microsoft-com:office:excel" xmlns:o="urn:schemas-microsoft-com:office:office" xmlns:v="urn:schemas-microsoft-com:vml" xmlns:w10="urn:schemas-microsoft-com:office:word" xmlns:pvml="urn:schemas-microsoft-com:office:powerpoint" xmlns:cppr="http://schemas.microsoft.com/office/2006/coverPageProps" xmlns:odx="http://opendope.org/xpaths" xmlns:odc="http://opendope.org/conditions" xmlns:odq="http://opendope.org/questions" xmlns:oda="http://opendope.org/answers" xmlns:odi="http://opendope.org/components" xmlns:odgm="http://opendope.org/SmartArt/DataHierarchy" xmlns:b="http://schemas.openxmlformats.org/officeDocument/2006/bibliography" xmlns:wps="http://schemas.microsoft.com/office/word/2010/wordprocessingShape" xmlns:w16se="http://schemas.microsoft.com/office/word/2015/wordml/symex" xmlns:w16cid="http://schemas.microsoft.com/office/word/2016/wordml/cid" xmlns:wetp="http://schemas.microsoft.com/office/webextensions/taskpanes/2010/11" xmlns:we="http://schemas.microsoft.com/office/webextensions/webextension/2010/11" xmlns:comp="http://schemas.openxmlformats.org/drawingml/2006/compatibility" xmlns:lc="http://schemas.openxmlformats.org/drawingml/2006/lockedCanvas">
               <c:ext xmlns:c16="http://schemas.microsoft.com/office/drawing/2014/chart" uri="{C3380CC4-5D6E-409C-BE32-E72D297353CC}">
                 <c16:uniqueId val="{00000001-6147-E74A-AA7B-5531F0E4EE0C}"/>
               </c:ext>
@@ -4693,7 +4693,7 @@
               </c:numCache>
             </c:numRef>
           </c:val>
-          <c:extLst xmlns:lc="http://schemas.openxmlformats.org/drawingml/2006/lockedCanvas" xmlns:comp="http://schemas.openxmlformats.org/drawingml/2006/compatibility" xmlns:we="http://schemas.microsoft.com/office/webextensions/webextension/2010/11" xmlns:wetp="http://schemas.microsoft.com/office/webextensions/taskpanes/2010/11" xmlns:w16cid="http://schemas.microsoft.com/office/word/2016/wordml/cid" xmlns:w16se="http://schemas.microsoft.com/office/word/2015/wordml/symex" xmlns:wps="http://schemas.microsoft.com/office/word/2010/wordprocessingShape" xmlns:b="http://schemas.openxmlformats.org/officeDocument/2006/bibliography" xmlns:odgm="http://opendope.org/SmartArt/DataHierarchy" xmlns:odi="http://opendope.org/components" xmlns:oda="http://opendope.org/answers" xmlns:odq="http://opendope.org/questions" xmlns:odc="http://opendope.org/conditions" xmlns:odx="http://opendope.org/xpaths" xmlns:cppr="http://schemas.microsoft.com/office/2006/coverPageProps" xmlns:pvml="urn:schemas-microsoft-com:office:powerpoint" xmlns:w10="urn:schemas-microsoft-com:office:word" xmlns:v="urn:schemas-microsoft-com:vml" xmlns:o="urn:schemas-microsoft-com:office:office" xmlns:xvml="urn:schemas-microsoft-com:office:excel" xmlns:dsp="http://schemas.microsoft.com/office/drawing/2008/diagram" xmlns:xdr="http://schemas.openxmlformats.org/drawingml/2006/spreadsheetDrawing" xmlns:pic="http://schemas.openxmlformats.org/drawingml/2006/picture" xmlns:dgm="http://schemas.openxmlformats.org/drawingml/2006/diagram" xmlns:c14="http://schemas.microsoft.com/office/drawing/2007/8/2/chart" xmlns:cdr="http://schemas.openxmlformats.org/drawingml/2006/chartDrawing" xmlns:wne="http://schemas.microsoft.com/office/word/2006/wordml" xmlns:sl="http://schemas.openxmlformats.org/schemaLibrary/2006/main" xmlns:mc="http://schemas.openxmlformats.org/markup-compatibility/2006" xmlns:wp14="http://schemas.microsoft.com/office/word/2010/wordprocessingDrawing" xmlns:wp="http://schemas.openxmlformats.org/drawingml/2006/wordprocessingDrawing" xmlns:m="http://schemas.openxmlformats.org/officeDocument/2006/math" xmlns:w14="http://schemas.microsoft.com/office/word/2010/wordml" xmlns:w15="http://schemas.microsoft.com/office/word/2012/wordml" xmlns:w="http://schemas.openxmlformats.org/wordprocessingml/2006/main">
+          <c:extLst xmlns:w="http://schemas.openxmlformats.org/wordprocessingml/2006/main" xmlns:w15="http://schemas.microsoft.com/office/word/2012/wordml" xmlns:w14="http://schemas.microsoft.com/office/word/2010/wordml" xmlns:m="http://schemas.openxmlformats.org/officeDocument/2006/math" xmlns:wp="http://schemas.openxmlformats.org/drawingml/2006/wordprocessingDrawing" xmlns:wp14="http://schemas.microsoft.com/office/word/2010/wordprocessingDrawing" xmlns:mc="http://schemas.openxmlformats.org/markup-compatibility/2006" xmlns:sl="http://schemas.openxmlformats.org/schemaLibrary/2006/main" xmlns:wne="http://schemas.microsoft.com/office/word/2006/wordml" xmlns:cdr="http://schemas.openxmlformats.org/drawingml/2006/chartDrawing" xmlns:c14="http://schemas.microsoft.com/office/drawing/2007/8/2/chart" xmlns:dgm="http://schemas.openxmlformats.org/drawingml/2006/diagram" xmlns:pic="http://schemas.openxmlformats.org/drawingml/2006/picture" xmlns:xdr="http://schemas.openxmlformats.org/drawingml/2006/spreadsheetDrawing" xmlns:dsp="http://schemas.microsoft.com/office/drawing/2008/diagram" xmlns:xvml="urn:schemas-microsoft-com:office:excel" xmlns:o="urn:schemas-microsoft-com:office:office" xmlns:v="urn:schemas-microsoft-com:vml" xmlns:w10="urn:schemas-microsoft-com:office:word" xmlns:pvml="urn:schemas-microsoft-com:office:powerpoint" xmlns:cppr="http://schemas.microsoft.com/office/2006/coverPageProps" xmlns:odx="http://opendope.org/xpaths" xmlns:odc="http://opendope.org/conditions" xmlns:odq="http://opendope.org/questions" xmlns:oda="http://opendope.org/answers" xmlns:odi="http://opendope.org/components" xmlns:odgm="http://opendope.org/SmartArt/DataHierarchy" xmlns:b="http://schemas.openxmlformats.org/officeDocument/2006/bibliography" xmlns:wps="http://schemas.microsoft.com/office/word/2010/wordprocessingShape" xmlns:w16se="http://schemas.microsoft.com/office/word/2015/wordml/symex" xmlns:w16cid="http://schemas.microsoft.com/office/word/2016/wordml/cid" xmlns:wetp="http://schemas.microsoft.com/office/webextensions/taskpanes/2010/11" xmlns:we="http://schemas.microsoft.com/office/webextensions/webextension/2010/11" xmlns:comp="http://schemas.openxmlformats.org/drawingml/2006/compatibility" xmlns:lc="http://schemas.openxmlformats.org/drawingml/2006/lockedCanvas">
             <c:ext xmlns:c16="http://schemas.microsoft.com/office/drawing/2014/chart" uri="{C3380CC4-5D6E-409C-BE32-E72D297353CC}">
               <c16:uniqueId val="{00000002-6147-E74A-AA7B-5531F0E4EE0C}"/>
             </c:ext>
@@ -5304,7 +5304,7 @@
     <c:plotVisOnly val="1"/>
     <c:dispBlanksAs val="gap"/>
     <c:showDLblsOverMax val="0"/>
-    <c:extLst xmlns:lc="http://schemas.openxmlformats.org/drawingml/2006/lockedCanvas" xmlns:comp="http://schemas.openxmlformats.org/drawingml/2006/compatibility" xmlns:we="http://schemas.microsoft.com/office/webextensions/webextension/2010/11" xmlns:wetp="http://schemas.microsoft.com/office/webextensions/taskpanes/2010/11" xmlns:w16cid="http://schemas.microsoft.com/office/word/2016/wordml/cid" xmlns:w16se="http://schemas.microsoft.com/office/word/2015/wordml/symex" xmlns:wps="http://schemas.microsoft.com/office/word/2010/wordprocessingShape" xmlns:b="http://schemas.openxmlformats.org/officeDocument/2006/bibliography" xmlns:odgm="http://opendope.org/SmartArt/DataHierarchy" xmlns:odi="http://opendope.org/components" xmlns:oda="http://opendope.org/answers" xmlns:odq="http://opendope.org/questions" xmlns:odc="http://opendope.org/conditions" xmlns:odx="http://opendope.org/xpaths" xmlns:cppr="http://schemas.microsoft.com/office/2006/coverPageProps" xmlns:pvml="urn:schemas-microsoft-com:office:powerpoint" xmlns:w10="urn:schemas-microsoft-com:office:word" xmlns:v="urn:schemas-microsoft-com:vml" xmlns:o="urn:schemas-microsoft-com:office:office" xmlns:xvml="urn:schemas-microsoft-com:office:excel" xmlns:dsp="http://schemas.microsoft.com/office/drawing/2008/diagram" xmlns:xdr="http://schemas.openxmlformats.org/drawingml/2006/spreadsheetDrawing" xmlns:pic="http://schemas.openxmlformats.org/drawingml/2006/picture" xmlns:dgm="http://schemas.openxmlformats.org/drawingml/2006/diagram" xmlns:c14="http://schemas.microsoft.com/office/drawing/2007/8/2/chart" xmlns:cdr="http://schemas.openxmlformats.org/drawingml/2006/chartDrawing" xmlns:wne="http://schemas.microsoft.com/office/word/2006/wordml" xmlns:sl="http://schemas.openxmlformats.org/schemaLibrary/2006/main" xmlns:mc="http://schemas.openxmlformats.org/markup-compatibility/2006" xmlns:wp14="http://schemas.microsoft.com/office/word/2010/wordprocessingDrawing" xmlns:wp="http://schemas.openxmlformats.org/drawingml/2006/wordprocessingDrawing" xmlns:m="http://schemas.openxmlformats.org/officeDocument/2006/math" xmlns:w14="http://schemas.microsoft.com/office/word/2010/wordml" xmlns:w15="http://schemas.microsoft.com/office/word/2012/wordml" xmlns:w="http://schemas.openxmlformats.org/wordprocessingml/2006/main">
+    <c:extLst xmlns:w="http://schemas.openxmlformats.org/wordprocessingml/2006/main" xmlns:w15="http://schemas.microsoft.com/office/word/2012/wordml" xmlns:w14="http://schemas.microsoft.com/office/word/2010/wordml" xmlns:m="http://schemas.openxmlformats.org/officeDocument/2006/math" xmlns:wp="http://schemas.openxmlformats.org/drawingml/2006/wordprocessingDrawing" xmlns:wp14="http://schemas.microsoft.com/office/word/2010/wordprocessingDrawing" xmlns:mc="http://schemas.openxmlformats.org/markup-compatibility/2006" xmlns:sl="http://schemas.openxmlformats.org/schemaLibrary/2006/main" xmlns:wne="http://schemas.microsoft.com/office/word/2006/wordml" xmlns:cdr="http://schemas.openxmlformats.org/drawingml/2006/chartDrawing" xmlns:c14="http://schemas.microsoft.com/office/drawing/2007/8/2/chart" xmlns:dgm="http://schemas.openxmlformats.org/drawingml/2006/diagram" xmlns:pic="http://schemas.openxmlformats.org/drawingml/2006/picture" xmlns:xdr="http://schemas.openxmlformats.org/drawingml/2006/spreadsheetDrawing" xmlns:dsp="http://schemas.microsoft.com/office/drawing/2008/diagram" xmlns:xvml="urn:schemas-microsoft-com:office:excel" xmlns:o="urn:schemas-microsoft-com:office:office" xmlns:v="urn:schemas-microsoft-com:vml" xmlns:w10="urn:schemas-microsoft-com:office:word" xmlns:pvml="urn:schemas-microsoft-com:office:powerpoint" xmlns:cppr="http://schemas.microsoft.com/office/2006/coverPageProps" xmlns:odx="http://opendope.org/xpaths" xmlns:odc="http://opendope.org/conditions" xmlns:odq="http://opendope.org/questions" xmlns:oda="http://opendope.org/answers" xmlns:odi="http://opendope.org/components" xmlns:odgm="http://opendope.org/SmartArt/DataHierarchy" xmlns:b="http://schemas.openxmlformats.org/officeDocument/2006/bibliography" xmlns:wps="http://schemas.microsoft.com/office/word/2010/wordprocessingShape" xmlns:w16se="http://schemas.microsoft.com/office/word/2015/wordml/symex" xmlns:w16cid="http://schemas.microsoft.com/office/word/2016/wordml/cid" xmlns:wetp="http://schemas.microsoft.com/office/webextensions/taskpanes/2010/11" xmlns:we="http://schemas.microsoft.com/office/webextensions/webextension/2010/11" xmlns:comp="http://schemas.openxmlformats.org/drawingml/2006/compatibility" xmlns:lc="http://schemas.openxmlformats.org/drawingml/2006/lockedCanvas">
       <c:ext xmlns:c16r3="http://schemas.microsoft.com/office/drawing/2017/03/chart" uri="{56B9EC1D-385E-4148-901F-78D8002777C0}">
         <c16r3:dataDisplayOptions16>
           <c16r3:dispNaAsBlank val="1"/>
@@ -5406,7 +5406,7 @@
                 </a:outerShdw>
               </a:effectLst>
             </c:spPr>
-            <c:extLst xmlns:lc="http://schemas.openxmlformats.org/drawingml/2006/lockedCanvas" xmlns:comp="http://schemas.openxmlformats.org/drawingml/2006/compatibility" xmlns:we="http://schemas.microsoft.com/office/webextensions/webextension/2010/11" xmlns:wetp="http://schemas.microsoft.com/office/webextensions/taskpanes/2010/11" xmlns:w16cid="http://schemas.microsoft.com/office/word/2016/wordml/cid" xmlns:w16se="http://schemas.microsoft.com/office/word/2015/wordml/symex" xmlns:wps="http://schemas.microsoft.com/office/word/2010/wordprocessingShape" xmlns:b="http://schemas.openxmlformats.org/officeDocument/2006/bibliography" xmlns:odgm="http://opendope.org/SmartArt/DataHierarchy" xmlns:odi="http://opendope.org/components" xmlns:oda="http://opendope.org/answers" xmlns:odq="http://opendope.org/questions" xmlns:odc="http://opendope.org/conditions" xmlns:odx="http://opendope.org/xpaths" xmlns:cppr="http://schemas.microsoft.com/office/2006/coverPageProps" xmlns:pvml="urn:schemas-microsoft-com:office:powerpoint" xmlns:w10="urn:schemas-microsoft-com:office:word" xmlns:v="urn:schemas-microsoft-com:vml" xmlns:o="urn:schemas-microsoft-com:office:office" xmlns:xvml="urn:schemas-microsoft-com:office:excel" xmlns:dsp="http://schemas.microsoft.com/office/drawing/2008/diagram" xmlns:xdr="http://schemas.openxmlformats.org/drawingml/2006/spreadsheetDrawing" xmlns:pic="http://schemas.openxmlformats.org/drawingml/2006/picture" xmlns:dgm="http://schemas.openxmlformats.org/drawingml/2006/diagram" xmlns:c14="http://schemas.microsoft.com/office/drawing/2007/8/2/chart" xmlns:cdr="http://schemas.openxmlformats.org/drawingml/2006/chartDrawing" xmlns:wne="http://schemas.microsoft.com/office/word/2006/wordml" xmlns:sl="http://schemas.openxmlformats.org/schemaLibrary/2006/main" xmlns:mc="http://schemas.openxmlformats.org/markup-compatibility/2006" xmlns:wp14="http://schemas.microsoft.com/office/word/2010/wordprocessingDrawing" xmlns:wp="http://schemas.openxmlformats.org/drawingml/2006/wordprocessingDrawing" xmlns:m="http://schemas.openxmlformats.org/officeDocument/2006/math" xmlns:w14="http://schemas.microsoft.com/office/word/2010/wordml" xmlns:w15="http://schemas.microsoft.com/office/word/2012/wordml" xmlns:w="http://schemas.openxmlformats.org/wordprocessingml/2006/main">
+            <c:extLst xmlns:w="http://schemas.openxmlformats.org/wordprocessingml/2006/main" xmlns:w15="http://schemas.microsoft.com/office/word/2012/wordml" xmlns:w14="http://schemas.microsoft.com/office/word/2010/wordml" xmlns:m="http://schemas.openxmlformats.org/officeDocument/2006/math" xmlns:wp="http://schemas.openxmlformats.org/drawingml/2006/wordprocessingDrawing" xmlns:wp14="http://schemas.microsoft.com/office/word/2010/wordprocessingDrawing" xmlns:mc="http://schemas.openxmlformats.org/markup-compatibility/2006" xmlns:sl="http://schemas.openxmlformats.org/schemaLibrary/2006/main" xmlns:wne="http://schemas.microsoft.com/office/word/2006/wordml" xmlns:cdr="http://schemas.openxmlformats.org/drawingml/2006/chartDrawing" xmlns:c14="http://schemas.microsoft.com/office/drawing/2007/8/2/chart" xmlns:dgm="http://schemas.openxmlformats.org/drawingml/2006/diagram" xmlns:pic="http://schemas.openxmlformats.org/drawingml/2006/picture" xmlns:xdr="http://schemas.openxmlformats.org/drawingml/2006/spreadsheetDrawing" xmlns:dsp="http://schemas.microsoft.com/office/drawing/2008/diagram" xmlns:xvml="urn:schemas-microsoft-com:office:excel" xmlns:o="urn:schemas-microsoft-com:office:office" xmlns:v="urn:schemas-microsoft-com:vml" xmlns:w10="urn:schemas-microsoft-com:office:word" xmlns:pvml="urn:schemas-microsoft-com:office:powerpoint" xmlns:cppr="http://schemas.microsoft.com/office/2006/coverPageProps" xmlns:odx="http://opendope.org/xpaths" xmlns:odc="http://opendope.org/conditions" xmlns:odq="http://opendope.org/questions" xmlns:oda="http://opendope.org/answers" xmlns:odi="http://opendope.org/components" xmlns:odgm="http://opendope.org/SmartArt/DataHierarchy" xmlns:b="http://schemas.openxmlformats.org/officeDocument/2006/bibliography" xmlns:wps="http://schemas.microsoft.com/office/word/2010/wordprocessingShape" xmlns:w16se="http://schemas.microsoft.com/office/word/2015/wordml/symex" xmlns:w16cid="http://schemas.microsoft.com/office/word/2016/wordml/cid" xmlns:wetp="http://schemas.microsoft.com/office/webextensions/taskpanes/2010/11" xmlns:we="http://schemas.microsoft.com/office/webextensions/webextension/2010/11" xmlns:comp="http://schemas.openxmlformats.org/drawingml/2006/compatibility" xmlns:lc="http://schemas.openxmlformats.org/drawingml/2006/lockedCanvas">
               <c:ext xmlns:c16="http://schemas.microsoft.com/office/drawing/2014/chart" uri="{C3380CC4-5D6E-409C-BE32-E72D297353CC}">
                 <c16:uniqueId val="{00000001-6147-E74A-AA7B-5531F0E4EE0C}"/>
               </c:ext>
@@ -5501,7 +5501,7 @@
               </c:numCache>
             </c:numRef>
           </c:val>
-          <c:extLst xmlns:lc="http://schemas.openxmlformats.org/drawingml/2006/lockedCanvas" xmlns:comp="http://schemas.openxmlformats.org/drawingml/2006/compatibility" xmlns:we="http://schemas.microsoft.com/office/webextensions/webextension/2010/11" xmlns:wetp="http://schemas.microsoft.com/office/webextensions/taskpanes/2010/11" xmlns:w16cid="http://schemas.microsoft.com/office/word/2016/wordml/cid" xmlns:w16se="http://schemas.microsoft.com/office/word/2015/wordml/symex" xmlns:wps="http://schemas.microsoft.com/office/word/2010/wordprocessingShape" xmlns:b="http://schemas.openxmlformats.org/officeDocument/2006/bibliography" xmlns:odgm="http://opendope.org/SmartArt/DataHierarchy" xmlns:odi="http://opendope.org/components" xmlns:oda="http://opendope.org/answers" xmlns:odq="http://opendope.org/questions" xmlns:odc="http://opendope.org/conditions" xmlns:odx="http://opendope.org/xpaths" xmlns:cppr="http://schemas.microsoft.com/office/2006/coverPageProps" xmlns:pvml="urn:schemas-microsoft-com:office:powerpoint" xmlns:w10="urn:schemas-microsoft-com:office:word" xmlns:v="urn:schemas-microsoft-com:vml" xmlns:o="urn:schemas-microsoft-com:office:office" xmlns:xvml="urn:schemas-microsoft-com:office:excel" xmlns:dsp="http://schemas.microsoft.com/office/drawing/2008/diagram" xmlns:xdr="http://schemas.openxmlformats.org/drawingml/2006/spreadsheetDrawing" xmlns:pic="http://schemas.openxmlformats.org/drawingml/2006/picture" xmlns:dgm="http://schemas.openxmlformats.org/drawingml/2006/diagram" xmlns:c14="http://schemas.microsoft.com/office/drawing/2007/8/2/chart" xmlns:cdr="http://schemas.openxmlformats.org/drawingml/2006/chartDrawing" xmlns:wne="http://schemas.microsoft.com/office/word/2006/wordml" xmlns:sl="http://schemas.openxmlformats.org/schemaLibrary/2006/main" xmlns:mc="http://schemas.openxmlformats.org/markup-compatibility/2006" xmlns:wp14="http://schemas.microsoft.com/office/word/2010/wordprocessingDrawing" xmlns:wp="http://schemas.openxmlformats.org/drawingml/2006/wordprocessingDrawing" xmlns:m="http://schemas.openxmlformats.org/officeDocument/2006/math" xmlns:w14="http://schemas.microsoft.com/office/word/2010/wordml" xmlns:w15="http://schemas.microsoft.com/office/word/2012/wordml" xmlns:w="http://schemas.openxmlformats.org/wordprocessingml/2006/main">
+          <c:extLst xmlns:w="http://schemas.openxmlformats.org/wordprocessingml/2006/main" xmlns:w15="http://schemas.microsoft.com/office/word/2012/wordml" xmlns:w14="http://schemas.microsoft.com/office/word/2010/wordml" xmlns:m="http://schemas.openxmlformats.org/officeDocument/2006/math" xmlns:wp="http://schemas.openxmlformats.org/drawingml/2006/wordprocessingDrawing" xmlns:wp14="http://schemas.microsoft.com/office/word/2010/wordprocessingDrawing" xmlns:mc="http://schemas.openxmlformats.org/markup-compatibility/2006" xmlns:sl="http://schemas.openxmlformats.org/schemaLibrary/2006/main" xmlns:wne="http://schemas.microsoft.com/office/word/2006/wordml" xmlns:cdr="http://schemas.openxmlformats.org/drawingml/2006/chartDrawing" xmlns:c14="http://schemas.microsoft.com/office/drawing/2007/8/2/chart" xmlns:dgm="http://schemas.openxmlformats.org/drawingml/2006/diagram" xmlns:pic="http://schemas.openxmlformats.org/drawingml/2006/picture" xmlns:xdr="http://schemas.openxmlformats.org/drawingml/2006/spreadsheetDrawing" xmlns:dsp="http://schemas.microsoft.com/office/drawing/2008/diagram" xmlns:xvml="urn:schemas-microsoft-com:office:excel" xmlns:o="urn:schemas-microsoft-com:office:office" xmlns:v="urn:schemas-microsoft-com:vml" xmlns:w10="urn:schemas-microsoft-com:office:word" xmlns:pvml="urn:schemas-microsoft-com:office:powerpoint" xmlns:cppr="http://schemas.microsoft.com/office/2006/coverPageProps" xmlns:odx="http://opendope.org/xpaths" xmlns:odc="http://opendope.org/conditions" xmlns:odq="http://opendope.org/questions" xmlns:oda="http://opendope.org/answers" xmlns:odi="http://opendope.org/components" xmlns:odgm="http://opendope.org/SmartArt/DataHierarchy" xmlns:b="http://schemas.openxmlformats.org/officeDocument/2006/bibliography" xmlns:wps="http://schemas.microsoft.com/office/word/2010/wordprocessingShape" xmlns:w16se="http://schemas.microsoft.com/office/word/2015/wordml/symex" xmlns:w16cid="http://schemas.microsoft.com/office/word/2016/wordml/cid" xmlns:wetp="http://schemas.microsoft.com/office/webextensions/taskpanes/2010/11" xmlns:we="http://schemas.microsoft.com/office/webextensions/webextension/2010/11" xmlns:comp="http://schemas.openxmlformats.org/drawingml/2006/compatibility" xmlns:lc="http://schemas.openxmlformats.org/drawingml/2006/lockedCanvas">
             <c:ext xmlns:c16="http://schemas.microsoft.com/office/drawing/2014/chart" uri="{C3380CC4-5D6E-409C-BE32-E72D297353CC}">
               <c16:uniqueId val="{00000002-6147-E74A-AA7B-5531F0E4EE0C}"/>
             </c:ext>
@@ -6112,7 +6112,7 @@
     <c:plotVisOnly val="1"/>
     <c:dispBlanksAs val="gap"/>
     <c:showDLblsOverMax val="0"/>
-    <c:extLst xmlns:lc="http://schemas.openxmlformats.org/drawingml/2006/lockedCanvas" xmlns:comp="http://schemas.openxmlformats.org/drawingml/2006/compatibility" xmlns:we="http://schemas.microsoft.com/office/webextensions/webextension/2010/11" xmlns:wetp="http://schemas.microsoft.com/office/webextensions/taskpanes/2010/11" xmlns:w16cid="http://schemas.microsoft.com/office/word/2016/wordml/cid" xmlns:w16se="http://schemas.microsoft.com/office/word/2015/wordml/symex" xmlns:wps="http://schemas.microsoft.com/office/word/2010/wordprocessingShape" xmlns:b="http://schemas.openxmlformats.org/officeDocument/2006/bibliography" xmlns:odgm="http://opendope.org/SmartArt/DataHierarchy" xmlns:odi="http://opendope.org/components" xmlns:oda="http://opendope.org/answers" xmlns:odq="http://opendope.org/questions" xmlns:odc="http://opendope.org/conditions" xmlns:odx="http://opendope.org/xpaths" xmlns:cppr="http://schemas.microsoft.com/office/2006/coverPageProps" xmlns:pvml="urn:schemas-microsoft-com:office:powerpoint" xmlns:w10="urn:schemas-microsoft-com:office:word" xmlns:v="urn:schemas-microsoft-com:vml" xmlns:o="urn:schemas-microsoft-com:office:office" xmlns:xvml="urn:schemas-microsoft-com:office:excel" xmlns:dsp="http://schemas.microsoft.com/office/drawing/2008/diagram" xmlns:xdr="http://schemas.openxmlformats.org/drawingml/2006/spreadsheetDrawing" xmlns:pic="http://schemas.openxmlformats.org/drawingml/2006/picture" xmlns:dgm="http://schemas.openxmlformats.org/drawingml/2006/diagram" xmlns:c14="http://schemas.microsoft.com/office/drawing/2007/8/2/chart" xmlns:cdr="http://schemas.openxmlformats.org/drawingml/2006/chartDrawing" xmlns:wne="http://schemas.microsoft.com/office/word/2006/wordml" xmlns:sl="http://schemas.openxmlformats.org/schemaLibrary/2006/main" xmlns:mc="http://schemas.openxmlformats.org/markup-compatibility/2006" xmlns:wp14="http://schemas.microsoft.com/office/word/2010/wordprocessingDrawing" xmlns:wp="http://schemas.openxmlformats.org/drawingml/2006/wordprocessingDrawing" xmlns:m="http://schemas.openxmlformats.org/officeDocument/2006/math" xmlns:w14="http://schemas.microsoft.com/office/word/2010/wordml" xmlns:w15="http://schemas.microsoft.com/office/word/2012/wordml" xmlns:w="http://schemas.openxmlformats.org/wordprocessingml/2006/main">
+    <c:extLst xmlns:w="http://schemas.openxmlformats.org/wordprocessingml/2006/main" xmlns:w15="http://schemas.microsoft.com/office/word/2012/wordml" xmlns:w14="http://schemas.microsoft.com/office/word/2010/wordml" xmlns:m="http://schemas.openxmlformats.org/officeDocument/2006/math" xmlns:wp="http://schemas.openxmlformats.org/drawingml/2006/wordprocessingDrawing" xmlns:wp14="http://schemas.microsoft.com/office/word/2010/wordprocessingDrawing" xmlns:mc="http://schemas.openxmlformats.org/markup-compatibility/2006" xmlns:sl="http://schemas.openxmlformats.org/schemaLibrary/2006/main" xmlns:wne="http://schemas.microsoft.com/office/word/2006/wordml" xmlns:cdr="http://schemas.openxmlformats.org/drawingml/2006/chartDrawing" xmlns:c14="http://schemas.microsoft.com/office/drawing/2007/8/2/chart" xmlns:dgm="http://schemas.openxmlformats.org/drawingml/2006/diagram" xmlns:pic="http://schemas.openxmlformats.org/drawingml/2006/picture" xmlns:xdr="http://schemas.openxmlformats.org/drawingml/2006/spreadsheetDrawing" xmlns:dsp="http://schemas.microsoft.com/office/drawing/2008/diagram" xmlns:xvml="urn:schemas-microsoft-com:office:excel" xmlns:o="urn:schemas-microsoft-com:office:office" xmlns:v="urn:schemas-microsoft-com:vml" xmlns:w10="urn:schemas-microsoft-com:office:word" xmlns:pvml="urn:schemas-microsoft-com:office:powerpoint" xmlns:cppr="http://schemas.microsoft.com/office/2006/coverPageProps" xmlns:odx="http://opendope.org/xpaths" xmlns:odc="http://opendope.org/conditions" xmlns:odq="http://opendope.org/questions" xmlns:oda="http://opendope.org/answers" xmlns:odi="http://opendope.org/components" xmlns:odgm="http://opendope.org/SmartArt/DataHierarchy" xmlns:b="http://schemas.openxmlformats.org/officeDocument/2006/bibliography" xmlns:wps="http://schemas.microsoft.com/office/word/2010/wordprocessingShape" xmlns:w16se="http://schemas.microsoft.com/office/word/2015/wordml/symex" xmlns:w16cid="http://schemas.microsoft.com/office/word/2016/wordml/cid" xmlns:wetp="http://schemas.microsoft.com/office/webextensions/taskpanes/2010/11" xmlns:we="http://schemas.microsoft.com/office/webextensions/webextension/2010/11" xmlns:comp="http://schemas.openxmlformats.org/drawingml/2006/compatibility" xmlns:lc="http://schemas.openxmlformats.org/drawingml/2006/lockedCanvas">
       <c:ext xmlns:c16r3="http://schemas.microsoft.com/office/drawing/2017/03/chart" uri="{56B9EC1D-385E-4148-901F-78D8002777C0}">
         <c16r3:dataDisplayOptions16>
           <c16r3:dispNaAsBlank val="1"/>
@@ -10437,7 +10437,7 @@
           <a:p>
             <a:fld id="{C1255C68-584F-174D-BB81-51BF91708794}" type="datetimeFigureOut">
               <a:rPr lang="en-US" smtClean="0"/>
-              <a:t>8/23/25</a:t>
+              <a:t>8/24/25</a:t>
             </a:fld>
             <a:endParaRPr lang="en-US"/>
           </a:p>
@@ -10614,7 +10614,7 @@
           <a:p>
             <a:fld id="{A1EDAAC4-819D-C544-9EA1-C73624CFD70B}" type="datetimeFigureOut">
               <a:rPr lang="en-US" smtClean="0"/>
-              <a:t>8/23/25</a:t>
+              <a:t>8/24/25</a:t>
             </a:fld>
             <a:endParaRPr lang="en-US"/>
           </a:p>
@@ -49504,6 +49504,82 @@
           </a:p>
         </p:txBody>
       </p:sp>
+      <p:sp>
+        <p:nvSpPr>
+          <p:cNvPr id="49" name="Rounded Rectangle 48">
+            <a:extLst>
+              <a:ext uri="{FF2B5EF4-FFF2-40B4-BE49-F238E27FC236}">
+                <a16:creationId xmlns:a16="http://schemas.microsoft.com/office/drawing/2014/main" id="{CD49DD0C-66C3-9266-E636-A03AE7C9DFA7}"/>
+              </a:ext>
+            </a:extLst>
+          </p:cNvPr>
+          <p:cNvSpPr/>
+          <p:nvPr/>
+        </p:nvSpPr>
+        <p:spPr>
+          <a:xfrm>
+            <a:off x="207002" y="3495726"/>
+            <a:ext cx="11984997" cy="2575216"/>
+          </a:xfrm>
+          <a:prstGeom prst="roundRect">
+            <a:avLst>
+              <a:gd name="adj" fmla="val 7068"/>
+            </a:avLst>
+          </a:prstGeom>
+          <a:gradFill>
+            <a:gsLst>
+              <a:gs pos="0">
+                <a:schemeClr val="bg1"/>
+              </a:gs>
+              <a:gs pos="100000">
+                <a:schemeClr val="bg2"/>
+              </a:gs>
+            </a:gsLst>
+            <a:lin ang="2700000" scaled="0"/>
+          </a:gradFill>
+          <a:ln>
+            <a:noFill/>
+          </a:ln>
+          <a:effectLst>
+            <a:outerShdw blurRad="190500" dist="38100" dir="2700000" algn="tl" rotWithShape="0">
+              <a:prstClr val="black">
+                <a:alpha val="15000"/>
+              </a:prstClr>
+            </a:outerShdw>
+          </a:effectLst>
+        </p:spPr>
+        <p:style>
+          <a:lnRef idx="2">
+            <a:schemeClr val="accent1">
+              <a:shade val="50000"/>
+            </a:schemeClr>
+          </a:lnRef>
+          <a:fillRef idx="1">
+            <a:schemeClr val="accent1"/>
+          </a:fillRef>
+          <a:effectRef idx="0">
+            <a:schemeClr val="accent1"/>
+          </a:effectRef>
+          <a:fontRef idx="minor">
+            <a:schemeClr val="lt1"/>
+          </a:fontRef>
+        </p:style>
+        <p:txBody>
+          <a:bodyPr vert="vert270" lIns="0" tIns="73152" rIns="0" bIns="73152" rtlCol="0" anchor="t"/>
+          <a:lstStyle/>
+          <a:p>
+            <a:pPr algn="ctr"/>
+            <a:r>
+              <a:rPr lang="en-US" sz="1200" b="1" noProof="0" dirty="0">
+                <a:solidFill>
+                  <a:schemeClr val="accent1"/>
+                </a:solidFill>
+              </a:rPr>
+              <a:t>Open and resolved findings</a:t>
+            </a:r>
+          </a:p>
+        </p:txBody>
+      </p:sp>
       <p:pic>
         <p:nvPicPr>
           <p:cNvPr id="34" name="Graphic 33">
@@ -49532,7 +49608,7 @@
         </p:blipFill>
         <p:spPr>
           <a:xfrm>
-            <a:off x="11773775" y="6070942"/>
+            <a:off x="11773775" y="5803314"/>
             <a:ext cx="371130" cy="206558"/>
           </a:xfrm>
           <a:prstGeom prst="rect">
@@ -49554,8 +49630,8 @@
         </p:nvSpPr>
         <p:spPr>
           <a:xfrm flipH="1">
-            <a:off x="841767" y="3237334"/>
-            <a:ext cx="3086538" cy="3031905"/>
+            <a:off x="609944" y="3237334"/>
+            <a:ext cx="3612958" cy="2953323"/>
           </a:xfrm>
           <a:prstGeom prst="roundRect">
             <a:avLst>
@@ -49630,8 +49706,8 @@
         </p:nvSpPr>
         <p:spPr>
           <a:xfrm flipH="1">
-            <a:off x="4117074" y="3237334"/>
-            <a:ext cx="3086538" cy="3031905"/>
+            <a:off x="4373475" y="3237334"/>
+            <a:ext cx="3610810" cy="2953323"/>
           </a:xfrm>
           <a:prstGeom prst="roundRect">
             <a:avLst>
@@ -49706,8 +49782,8 @@
         </p:nvSpPr>
         <p:spPr>
           <a:xfrm flipH="1">
-            <a:off x="7392380" y="3237334"/>
-            <a:ext cx="3086538" cy="3031905"/>
+            <a:off x="8134857" y="3237334"/>
+            <a:ext cx="3610810" cy="2953323"/>
           </a:xfrm>
           <a:prstGeom prst="roundRect">
             <a:avLst>
@@ -49770,10 +49846,10 @@
       </p:sp>
       <p:sp>
         <p:nvSpPr>
-          <p:cNvPr id="49" name="Rounded Rectangle 48">
-            <a:extLst>
-              <a:ext uri="{FF2B5EF4-FFF2-40B4-BE49-F238E27FC236}">
-                <a16:creationId xmlns:a16="http://schemas.microsoft.com/office/drawing/2014/main" id="{CD49DD0C-66C3-9266-E636-A03AE7C9DFA7}"/>
+          <p:cNvPr id="4" name="Rectangle 3">
+            <a:extLst>
+              <a:ext uri="{FF2B5EF4-FFF2-40B4-BE49-F238E27FC236}">
+                <a16:creationId xmlns:a16="http://schemas.microsoft.com/office/drawing/2014/main" id="{0D5B4458-7A18-6975-596A-37B01EA5C4A6}"/>
               </a:ext>
             </a:extLst>
           </p:cNvPr>
@@ -49782,1560 +49858,8 @@
         </p:nvSpPr>
         <p:spPr>
           <a:xfrm>
-            <a:off x="207003" y="3495726"/>
-            <a:ext cx="11480030" cy="1314054"/>
-          </a:xfrm>
-          <a:prstGeom prst="roundRect">
-            <a:avLst>
-              <a:gd name="adj" fmla="val 7068"/>
-            </a:avLst>
-          </a:prstGeom>
-          <a:gradFill>
-            <a:gsLst>
-              <a:gs pos="0">
-                <a:schemeClr val="bg1"/>
-              </a:gs>
-              <a:gs pos="100000">
-                <a:schemeClr val="bg2"/>
-              </a:gs>
-            </a:gsLst>
-            <a:lin ang="2700000" scaled="0"/>
-          </a:gradFill>
-          <a:ln>
-            <a:noFill/>
-          </a:ln>
-          <a:effectLst>
-            <a:outerShdw blurRad="190500" dist="38100" dir="2700000" algn="tl" rotWithShape="0">
-              <a:prstClr val="black">
-                <a:alpha val="15000"/>
-              </a:prstClr>
-            </a:outerShdw>
-          </a:effectLst>
-        </p:spPr>
-        <p:style>
-          <a:lnRef idx="2">
-            <a:schemeClr val="accent1">
-              <a:shade val="50000"/>
-            </a:schemeClr>
-          </a:lnRef>
-          <a:fillRef idx="1">
-            <a:schemeClr val="accent1"/>
-          </a:fillRef>
-          <a:effectRef idx="0">
-            <a:schemeClr val="accent1"/>
-          </a:effectRef>
-          <a:fontRef idx="minor">
-            <a:schemeClr val="lt1"/>
-          </a:fontRef>
-        </p:style>
-        <p:txBody>
-          <a:bodyPr vert="vert270" lIns="0" tIns="73152" rIns="0" bIns="73152" rtlCol="0" anchor="t"/>
-          <a:lstStyle/>
-          <a:p>
-            <a:pPr algn="ctr"/>
-            <a:r>
-              <a:rPr lang="en-US" sz="1200" b="1" noProof="0" dirty="0">
-                <a:solidFill>
-                  <a:schemeClr val="accent1"/>
-                </a:solidFill>
-              </a:rPr>
-              <a:t>Open and resolved findings</a:t>
-            </a:r>
-          </a:p>
-        </p:txBody>
-      </p:sp>
-      <p:sp>
-        <p:nvSpPr>
-          <p:cNvPr id="50" name="Rounded Rectangle 49">
-            <a:extLst>
-              <a:ext uri="{FF2B5EF4-FFF2-40B4-BE49-F238E27FC236}">
-                <a16:creationId xmlns:a16="http://schemas.microsoft.com/office/drawing/2014/main" id="{9541F284-CD2B-8E13-4326-72177237DE8A}"/>
-              </a:ext>
-            </a:extLst>
-          </p:cNvPr>
-          <p:cNvSpPr/>
-          <p:nvPr/>
-        </p:nvSpPr>
-        <p:spPr>
-          <a:xfrm>
-            <a:off x="207003" y="4876643"/>
-            <a:ext cx="11480030" cy="1314054"/>
-          </a:xfrm>
-          <a:prstGeom prst="roundRect">
-            <a:avLst>
-              <a:gd name="adj" fmla="val 7068"/>
-            </a:avLst>
-          </a:prstGeom>
-          <a:gradFill>
-            <a:gsLst>
-              <a:gs pos="0">
-                <a:schemeClr val="bg1"/>
-              </a:gs>
-              <a:gs pos="100000">
-                <a:schemeClr val="bg2"/>
-              </a:gs>
-            </a:gsLst>
-            <a:lin ang="2700000" scaled="0"/>
-          </a:gradFill>
-          <a:ln>
-            <a:noFill/>
-          </a:ln>
-          <a:effectLst>
-            <a:outerShdw blurRad="190500" dist="38100" dir="2700000" algn="tl" rotWithShape="0">
-              <a:prstClr val="black">
-                <a:alpha val="15000"/>
-              </a:prstClr>
-            </a:outerShdw>
-          </a:effectLst>
-        </p:spPr>
-        <p:style>
-          <a:lnRef idx="2">
-            <a:schemeClr val="accent1">
-              <a:shade val="50000"/>
-            </a:schemeClr>
-          </a:lnRef>
-          <a:fillRef idx="1">
-            <a:schemeClr val="accent1"/>
-          </a:fillRef>
-          <a:effectRef idx="0">
-            <a:schemeClr val="accent1"/>
-          </a:effectRef>
-          <a:fontRef idx="minor">
-            <a:schemeClr val="lt1"/>
-          </a:fontRef>
-        </p:style>
-        <p:txBody>
-          <a:bodyPr vert="vert270" lIns="0" tIns="73152" rIns="0" bIns="73152" rtlCol="0" anchor="t"/>
-          <a:lstStyle/>
-          <a:p>
-            <a:pPr algn="ctr"/>
-            <a:r>
-              <a:rPr lang="en-US" sz="1200" b="1" noProof="0" dirty="0">
-                <a:solidFill>
-                  <a:schemeClr val="accent1"/>
-                </a:solidFill>
-              </a:rPr>
-              <a:t>Resolution time</a:t>
-            </a:r>
-          </a:p>
-        </p:txBody>
-      </p:sp>
-      <p:sp>
-        <p:nvSpPr>
-          <p:cNvPr id="57" name="TextBox 56">
-            <a:extLst>
-              <a:ext uri="{FF2B5EF4-FFF2-40B4-BE49-F238E27FC236}">
-                <a16:creationId xmlns:a16="http://schemas.microsoft.com/office/drawing/2014/main" id="{571CFFAB-EFDD-8C98-85AC-DBE00381AB5A}"/>
-              </a:ext>
-            </a:extLst>
-          </p:cNvPr>
-          <p:cNvSpPr txBox="1"/>
-          <p:nvPr/>
-        </p:nvSpPr>
-        <p:spPr>
-          <a:xfrm>
-            <a:off x="10685920" y="3914480"/>
-            <a:ext cx="856473" cy="223779"/>
-          </a:xfrm>
-          <a:prstGeom prst="rect">
-            <a:avLst/>
-          </a:prstGeom>
-          <a:noFill/>
-        </p:spPr>
-        <p:txBody>
-          <a:bodyPr wrap="none" lIns="90000" rtlCol="0" anchor="t">
-            <a:spAutoFit/>
-          </a:bodyPr>
-          <a:lstStyle/>
-          <a:p>
-            <a:pPr algn="l">
-              <a:lnSpc>
-                <a:spcPct val="113000"/>
-              </a:lnSpc>
-            </a:pPr>
-            <a:r>
-              <a:rPr lang="en-US" sz="800" dirty="0">
-                <a:solidFill>
-                  <a:schemeClr val="tx2"/>
-                </a:solidFill>
-              </a:rPr>
-              <a:t>Existing findings</a:t>
-            </a:r>
-          </a:p>
-        </p:txBody>
-      </p:sp>
-      <p:sp>
-        <p:nvSpPr>
-          <p:cNvPr id="58" name="TextBox 57">
-            <a:extLst>
-              <a:ext uri="{FF2B5EF4-FFF2-40B4-BE49-F238E27FC236}">
-                <a16:creationId xmlns:a16="http://schemas.microsoft.com/office/drawing/2014/main" id="{E49AE532-6CF4-ED36-78E9-50B68ABEFD32}"/>
-              </a:ext>
-            </a:extLst>
-          </p:cNvPr>
-          <p:cNvSpPr txBox="1"/>
-          <p:nvPr/>
-        </p:nvSpPr>
-        <p:spPr>
-          <a:xfrm>
-            <a:off x="10685920" y="4096769"/>
-            <a:ext cx="728233" cy="223779"/>
-          </a:xfrm>
-          <a:prstGeom prst="rect">
-            <a:avLst/>
-          </a:prstGeom>
-          <a:noFill/>
-        </p:spPr>
-        <p:txBody>
-          <a:bodyPr wrap="none" lIns="90000" rtlCol="0" anchor="t">
-            <a:spAutoFit/>
-          </a:bodyPr>
-          <a:lstStyle/>
-          <a:p>
-            <a:pPr algn="l">
-              <a:lnSpc>
-                <a:spcPct val="113000"/>
-              </a:lnSpc>
-            </a:pPr>
-            <a:r>
-              <a:rPr lang="en-US" sz="800" dirty="0">
-                <a:solidFill>
-                  <a:schemeClr val="tx2"/>
-                </a:solidFill>
-              </a:rPr>
-              <a:t>New findings</a:t>
-            </a:r>
-          </a:p>
-        </p:txBody>
-      </p:sp>
-      <p:sp>
-        <p:nvSpPr>
-          <p:cNvPr id="85" name="TextBox 84">
-            <a:extLst>
-              <a:ext uri="{FF2B5EF4-FFF2-40B4-BE49-F238E27FC236}">
-                <a16:creationId xmlns:a16="http://schemas.microsoft.com/office/drawing/2014/main" id="{5ABF7308-37F3-8EA2-975F-F6C558C139C2}"/>
-              </a:ext>
-            </a:extLst>
-          </p:cNvPr>
-          <p:cNvSpPr txBox="1"/>
-          <p:nvPr/>
-        </p:nvSpPr>
-        <p:spPr>
-          <a:xfrm>
-            <a:off x="10685920" y="4279058"/>
-            <a:ext cx="915785" cy="223779"/>
-          </a:xfrm>
-          <a:prstGeom prst="rect">
-            <a:avLst/>
-          </a:prstGeom>
-          <a:noFill/>
-        </p:spPr>
-        <p:txBody>
-          <a:bodyPr wrap="none" lIns="90000" rtlCol="0" anchor="t">
-            <a:spAutoFit/>
-          </a:bodyPr>
-          <a:lstStyle/>
-          <a:p>
-            <a:pPr algn="l">
-              <a:lnSpc>
-                <a:spcPct val="113000"/>
-              </a:lnSpc>
-            </a:pPr>
-            <a:r>
-              <a:rPr lang="en-US" sz="800" dirty="0">
-                <a:solidFill>
-                  <a:schemeClr val="tx2"/>
-                </a:solidFill>
-              </a:rPr>
-              <a:t>Resolved findings</a:t>
-            </a:r>
-          </a:p>
-        </p:txBody>
-      </p:sp>
-      <p:sp>
-        <p:nvSpPr>
-          <p:cNvPr id="86" name="TextBox 85">
-            <a:extLst>
-              <a:ext uri="{FF2B5EF4-FFF2-40B4-BE49-F238E27FC236}">
-                <a16:creationId xmlns:a16="http://schemas.microsoft.com/office/drawing/2014/main" id="{F66E8A60-AACC-3A37-E7C3-8E8EA1357414}"/>
-              </a:ext>
-            </a:extLst>
-          </p:cNvPr>
-          <p:cNvSpPr txBox="1"/>
-          <p:nvPr/>
-        </p:nvSpPr>
-        <p:spPr>
-          <a:xfrm>
-            <a:off x="10685920" y="5203409"/>
-            <a:ext cx="846855" cy="223779"/>
-          </a:xfrm>
-          <a:prstGeom prst="rect">
-            <a:avLst/>
-          </a:prstGeom>
-          <a:noFill/>
-        </p:spPr>
-        <p:txBody>
-          <a:bodyPr wrap="none" lIns="90000" rtlCol="0" anchor="t">
-            <a:spAutoFit/>
-          </a:bodyPr>
-          <a:lstStyle/>
-          <a:p>
-            <a:pPr algn="l">
-              <a:lnSpc>
-                <a:spcPct val="113000"/>
-              </a:lnSpc>
-            </a:pPr>
-            <a:r>
-              <a:rPr lang="en-US" sz="800" dirty="0">
-                <a:solidFill>
-                  <a:schemeClr val="tx2"/>
-                </a:solidFill>
-              </a:rPr>
-              <a:t>At most 30 days</a:t>
-            </a:r>
-          </a:p>
-        </p:txBody>
-      </p:sp>
-      <p:sp>
-        <p:nvSpPr>
-          <p:cNvPr id="87" name="TextBox 86">
-            <a:extLst>
-              <a:ext uri="{FF2B5EF4-FFF2-40B4-BE49-F238E27FC236}">
-                <a16:creationId xmlns:a16="http://schemas.microsoft.com/office/drawing/2014/main" id="{219DFB87-5463-8FF3-0A60-20E4C1163724}"/>
-              </a:ext>
-            </a:extLst>
-          </p:cNvPr>
-          <p:cNvSpPr txBox="1"/>
-          <p:nvPr/>
-        </p:nvSpPr>
-        <p:spPr>
-          <a:xfrm>
-            <a:off x="10685920" y="5385698"/>
-            <a:ext cx="684952" cy="223779"/>
-          </a:xfrm>
-          <a:prstGeom prst="rect">
-            <a:avLst/>
-          </a:prstGeom>
-          <a:noFill/>
-        </p:spPr>
-        <p:txBody>
-          <a:bodyPr wrap="none" lIns="90000" rtlCol="0" anchor="t">
-            <a:spAutoFit/>
-          </a:bodyPr>
-          <a:lstStyle/>
-          <a:p>
-            <a:pPr algn="l">
-              <a:lnSpc>
-                <a:spcPct val="113000"/>
-              </a:lnSpc>
-            </a:pPr>
-            <a:r>
-              <a:rPr lang="en-US" sz="800" dirty="0">
-                <a:solidFill>
-                  <a:schemeClr val="tx2"/>
-                </a:solidFill>
-              </a:rPr>
-              <a:t>30-180 days</a:t>
-            </a:r>
-          </a:p>
-        </p:txBody>
-      </p:sp>
-      <p:sp>
-        <p:nvSpPr>
-          <p:cNvPr id="88" name="TextBox 87">
-            <a:extLst>
-              <a:ext uri="{FF2B5EF4-FFF2-40B4-BE49-F238E27FC236}">
-                <a16:creationId xmlns:a16="http://schemas.microsoft.com/office/drawing/2014/main" id="{79099BC1-E198-5D17-B560-93946792D4F1}"/>
-              </a:ext>
-            </a:extLst>
-          </p:cNvPr>
-          <p:cNvSpPr txBox="1"/>
-          <p:nvPr/>
-        </p:nvSpPr>
-        <p:spPr>
-          <a:xfrm>
-            <a:off x="10685920" y="5567987"/>
-            <a:ext cx="736248" cy="223779"/>
-          </a:xfrm>
-          <a:prstGeom prst="rect">
-            <a:avLst/>
-          </a:prstGeom>
-          <a:noFill/>
-        </p:spPr>
-        <p:txBody>
-          <a:bodyPr wrap="none" lIns="90000" rtlCol="0" anchor="t">
-            <a:spAutoFit/>
-          </a:bodyPr>
-          <a:lstStyle/>
-          <a:p>
-            <a:pPr algn="l">
-              <a:lnSpc>
-                <a:spcPct val="113000"/>
-              </a:lnSpc>
-            </a:pPr>
-            <a:r>
-              <a:rPr lang="en-US" sz="800" dirty="0">
-                <a:solidFill>
-                  <a:schemeClr val="tx2"/>
-                </a:solidFill>
-              </a:rPr>
-              <a:t>180-365 days</a:t>
-            </a:r>
-          </a:p>
-        </p:txBody>
-      </p:sp>
-      <p:sp>
-        <p:nvSpPr>
-          <p:cNvPr id="89" name="TextBox 88">
-            <a:extLst>
-              <a:ext uri="{FF2B5EF4-FFF2-40B4-BE49-F238E27FC236}">
-                <a16:creationId xmlns:a16="http://schemas.microsoft.com/office/drawing/2014/main" id="{76D3C359-CD68-8B7A-9AD9-800D632925E5}"/>
-              </a:ext>
-            </a:extLst>
-          </p:cNvPr>
-          <p:cNvSpPr txBox="1"/>
-          <p:nvPr/>
-        </p:nvSpPr>
-        <p:spPr>
-          <a:xfrm>
-            <a:off x="10685920" y="5750276"/>
-            <a:ext cx="886931" cy="223779"/>
-          </a:xfrm>
-          <a:prstGeom prst="rect">
-            <a:avLst/>
-          </a:prstGeom>
-          <a:noFill/>
-        </p:spPr>
-        <p:txBody>
-          <a:bodyPr wrap="none" lIns="90000" rtlCol="0" anchor="t">
-            <a:spAutoFit/>
-          </a:bodyPr>
-          <a:lstStyle/>
-          <a:p>
-            <a:pPr algn="l">
-              <a:lnSpc>
-                <a:spcPct val="113000"/>
-              </a:lnSpc>
-            </a:pPr>
-            <a:r>
-              <a:rPr lang="en-US" sz="800" dirty="0">
-                <a:solidFill>
-                  <a:schemeClr val="tx2"/>
-                </a:solidFill>
-              </a:rPr>
-              <a:t>At least 365 days</a:t>
-            </a:r>
-          </a:p>
-        </p:txBody>
-      </p:sp>
-      <p:sp>
-        <p:nvSpPr>
-          <p:cNvPr id="90" name="Rounded Rectangle 89">
-            <a:extLst>
-              <a:ext uri="{FF2B5EF4-FFF2-40B4-BE49-F238E27FC236}">
-                <a16:creationId xmlns:a16="http://schemas.microsoft.com/office/drawing/2014/main" id="{F0ACD575-00A0-9ADB-615A-2516E8D62FE6}"/>
-              </a:ext>
-            </a:extLst>
-          </p:cNvPr>
-          <p:cNvSpPr/>
-          <p:nvPr/>
-        </p:nvSpPr>
-        <p:spPr>
-          <a:xfrm>
-            <a:off x="10555012" y="5277286"/>
-            <a:ext cx="168322" cy="91833"/>
-          </a:xfrm>
-          <a:prstGeom prst="roundRect">
-            <a:avLst/>
-          </a:prstGeom>
-          <a:solidFill>
-            <a:srgbClr val="C6CD60"/>
-          </a:solidFill>
-          <a:ln>
-            <a:noFill/>
-          </a:ln>
-        </p:spPr>
-        <p:style>
-          <a:lnRef idx="2">
-            <a:schemeClr val="accent1">
-              <a:shade val="50000"/>
-            </a:schemeClr>
-          </a:lnRef>
-          <a:fillRef idx="1">
-            <a:schemeClr val="accent1"/>
-          </a:fillRef>
-          <a:effectRef idx="0">
-            <a:schemeClr val="accent1"/>
-          </a:effectRef>
-          <a:fontRef idx="minor">
-            <a:schemeClr val="lt1"/>
-          </a:fontRef>
-        </p:style>
-        <p:txBody>
-          <a:bodyPr lIns="108000" tIns="72000" rIns="108000" bIns="72000" rtlCol="0" anchor="ctr"/>
-          <a:lstStyle/>
-          <a:p>
-            <a:pPr algn="ctr"/>
-            <a:endParaRPr lang="en-US" sz="1600" dirty="0" err="1">
-              <a:solidFill>
-                <a:schemeClr val="bg1"/>
-              </a:solidFill>
-            </a:endParaRPr>
-          </a:p>
-        </p:txBody>
-      </p:sp>
-      <p:sp>
-        <p:nvSpPr>
-          <p:cNvPr id="91" name="Rounded Rectangle 90">
-            <a:extLst>
-              <a:ext uri="{FF2B5EF4-FFF2-40B4-BE49-F238E27FC236}">
-                <a16:creationId xmlns:a16="http://schemas.microsoft.com/office/drawing/2014/main" id="{BD5B81D3-8D2C-5BA1-AD33-C5B66FA98BDE}"/>
-              </a:ext>
-            </a:extLst>
-          </p:cNvPr>
-          <p:cNvSpPr/>
-          <p:nvPr/>
-        </p:nvSpPr>
-        <p:spPr>
-          <a:xfrm>
-            <a:off x="10555012" y="5458208"/>
-            <a:ext cx="168322" cy="91833"/>
-          </a:xfrm>
-          <a:prstGeom prst="roundRect">
-            <a:avLst/>
-          </a:prstGeom>
-          <a:solidFill>
-            <a:srgbClr val="C8BED7"/>
-          </a:solidFill>
-          <a:ln>
-            <a:noFill/>
-          </a:ln>
-        </p:spPr>
-        <p:style>
-          <a:lnRef idx="2">
-            <a:schemeClr val="accent1">
-              <a:shade val="50000"/>
-            </a:schemeClr>
-          </a:lnRef>
-          <a:fillRef idx="1">
-            <a:schemeClr val="accent1"/>
-          </a:fillRef>
-          <a:effectRef idx="0">
-            <a:schemeClr val="accent1"/>
-          </a:effectRef>
-          <a:fontRef idx="minor">
-            <a:schemeClr val="lt1"/>
-          </a:fontRef>
-        </p:style>
-        <p:txBody>
-          <a:bodyPr lIns="108000" tIns="72000" rIns="108000" bIns="72000" rtlCol="0" anchor="ctr"/>
-          <a:lstStyle/>
-          <a:p>
-            <a:pPr algn="ctr"/>
-            <a:endParaRPr lang="en-US" sz="1600" dirty="0" err="1">
-              <a:solidFill>
-                <a:schemeClr val="bg1"/>
-              </a:solidFill>
-            </a:endParaRPr>
-          </a:p>
-        </p:txBody>
-      </p:sp>
-      <p:sp>
-        <p:nvSpPr>
-          <p:cNvPr id="92" name="Rounded Rectangle 91">
-            <a:extLst>
-              <a:ext uri="{FF2B5EF4-FFF2-40B4-BE49-F238E27FC236}">
-                <a16:creationId xmlns:a16="http://schemas.microsoft.com/office/drawing/2014/main" id="{C1406FCC-71DD-1FDC-A2A4-7B7F1E4B91FC}"/>
-              </a:ext>
-            </a:extLst>
-          </p:cNvPr>
-          <p:cNvSpPr/>
-          <p:nvPr/>
-        </p:nvSpPr>
-        <p:spPr>
-          <a:xfrm>
-            <a:off x="10555012" y="5639130"/>
-            <a:ext cx="168322" cy="91833"/>
-          </a:xfrm>
-          <a:prstGeom prst="roundRect">
-            <a:avLst/>
-          </a:prstGeom>
-          <a:solidFill>
-            <a:srgbClr val="A694BE"/>
-          </a:solidFill>
-          <a:ln>
-            <a:noFill/>
-          </a:ln>
-        </p:spPr>
-        <p:style>
-          <a:lnRef idx="2">
-            <a:schemeClr val="accent1">
-              <a:shade val="50000"/>
-            </a:schemeClr>
-          </a:lnRef>
-          <a:fillRef idx="1">
-            <a:schemeClr val="accent1"/>
-          </a:fillRef>
-          <a:effectRef idx="0">
-            <a:schemeClr val="accent1"/>
-          </a:effectRef>
-          <a:fontRef idx="minor">
-            <a:schemeClr val="lt1"/>
-          </a:fontRef>
-        </p:style>
-        <p:txBody>
-          <a:bodyPr lIns="108000" tIns="72000" rIns="108000" bIns="72000" rtlCol="0" anchor="ctr"/>
-          <a:lstStyle/>
-          <a:p>
-            <a:pPr algn="ctr"/>
-            <a:endParaRPr lang="en-US" sz="1600" dirty="0" err="1">
-              <a:solidFill>
-                <a:schemeClr val="bg1"/>
-              </a:solidFill>
-            </a:endParaRPr>
-          </a:p>
-        </p:txBody>
-      </p:sp>
-      <p:sp>
-        <p:nvSpPr>
-          <p:cNvPr id="93" name="Rounded Rectangle 92">
-            <a:extLst>
-              <a:ext uri="{FF2B5EF4-FFF2-40B4-BE49-F238E27FC236}">
-                <a16:creationId xmlns:a16="http://schemas.microsoft.com/office/drawing/2014/main" id="{C88CBBCA-EDC1-BFE3-5202-969B344A3C5E}"/>
-              </a:ext>
-            </a:extLst>
-          </p:cNvPr>
-          <p:cNvSpPr/>
-          <p:nvPr/>
-        </p:nvSpPr>
-        <p:spPr>
-          <a:xfrm>
-            <a:off x="10555012" y="5820051"/>
-            <a:ext cx="168322" cy="91833"/>
-          </a:xfrm>
-          <a:prstGeom prst="roundRect">
-            <a:avLst/>
-          </a:prstGeom>
-          <a:solidFill>
-            <a:srgbClr val="836BA5"/>
-          </a:solidFill>
-          <a:ln>
-            <a:noFill/>
-          </a:ln>
-        </p:spPr>
-        <p:style>
-          <a:lnRef idx="2">
-            <a:schemeClr val="accent1">
-              <a:shade val="50000"/>
-            </a:schemeClr>
-          </a:lnRef>
-          <a:fillRef idx="1">
-            <a:schemeClr val="accent1"/>
-          </a:fillRef>
-          <a:effectRef idx="0">
-            <a:schemeClr val="accent1"/>
-          </a:effectRef>
-          <a:fontRef idx="minor">
-            <a:schemeClr val="lt1"/>
-          </a:fontRef>
-        </p:style>
-        <p:txBody>
-          <a:bodyPr lIns="108000" tIns="72000" rIns="108000" bIns="72000" rtlCol="0" anchor="ctr"/>
-          <a:lstStyle/>
-          <a:p>
-            <a:pPr algn="ctr"/>
-            <a:endParaRPr lang="en-US" sz="1600" dirty="0" err="1">
-              <a:solidFill>
-                <a:schemeClr val="bg1"/>
-              </a:solidFill>
-            </a:endParaRPr>
-          </a:p>
-        </p:txBody>
-      </p:sp>
-      <p:sp>
-        <p:nvSpPr>
-          <p:cNvPr id="94" name="Rounded Rectangle 93">
-            <a:extLst>
-              <a:ext uri="{FF2B5EF4-FFF2-40B4-BE49-F238E27FC236}">
-                <a16:creationId xmlns:a16="http://schemas.microsoft.com/office/drawing/2014/main" id="{B5B03021-B0E1-D3DF-666F-604DCD5CD0D4}"/>
-              </a:ext>
-            </a:extLst>
-          </p:cNvPr>
-          <p:cNvSpPr/>
-          <p:nvPr/>
-        </p:nvSpPr>
-        <p:spPr>
-          <a:xfrm>
-            <a:off x="10555012" y="3982475"/>
-            <a:ext cx="168322" cy="91833"/>
-          </a:xfrm>
-          <a:prstGeom prst="roundRect">
-            <a:avLst/>
-          </a:prstGeom>
-          <a:solidFill>
-            <a:srgbClr val="334E68"/>
-          </a:solidFill>
-          <a:ln>
-            <a:noFill/>
-          </a:ln>
-        </p:spPr>
-        <p:style>
-          <a:lnRef idx="2">
-            <a:schemeClr val="accent1">
-              <a:shade val="50000"/>
-            </a:schemeClr>
-          </a:lnRef>
-          <a:fillRef idx="1">
-            <a:schemeClr val="accent1"/>
-          </a:fillRef>
-          <a:effectRef idx="0">
-            <a:schemeClr val="accent1"/>
-          </a:effectRef>
-          <a:fontRef idx="minor">
-            <a:schemeClr val="lt1"/>
-          </a:fontRef>
-        </p:style>
-        <p:txBody>
-          <a:bodyPr lIns="108000" tIns="72000" rIns="108000" bIns="72000" rtlCol="0" anchor="ctr"/>
-          <a:lstStyle/>
-          <a:p>
-            <a:pPr algn="ctr"/>
-            <a:endParaRPr lang="en-US" sz="1600" dirty="0" err="1">
-              <a:solidFill>
-                <a:schemeClr val="bg1"/>
-              </a:solidFill>
-            </a:endParaRPr>
-          </a:p>
-        </p:txBody>
-      </p:sp>
-      <p:sp>
-        <p:nvSpPr>
-          <p:cNvPr id="95" name="Rounded Rectangle 94">
-            <a:extLst>
-              <a:ext uri="{FF2B5EF4-FFF2-40B4-BE49-F238E27FC236}">
-                <a16:creationId xmlns:a16="http://schemas.microsoft.com/office/drawing/2014/main" id="{7732D24F-0C97-A5E3-5BE3-86EB1DD5A459}"/>
-              </a:ext>
-            </a:extLst>
-          </p:cNvPr>
-          <p:cNvSpPr/>
-          <p:nvPr/>
-        </p:nvSpPr>
-        <p:spPr>
-          <a:xfrm>
-            <a:off x="10555012" y="4165683"/>
-            <a:ext cx="168322" cy="91833"/>
-          </a:xfrm>
-          <a:prstGeom prst="roundRect">
-            <a:avLst/>
-          </a:prstGeom>
-          <a:solidFill>
-            <a:srgbClr val="9DAAB7"/>
-          </a:solidFill>
-          <a:ln>
-            <a:noFill/>
-          </a:ln>
-        </p:spPr>
-        <p:style>
-          <a:lnRef idx="2">
-            <a:schemeClr val="accent1">
-              <a:shade val="50000"/>
-            </a:schemeClr>
-          </a:lnRef>
-          <a:fillRef idx="1">
-            <a:schemeClr val="accent1"/>
-          </a:fillRef>
-          <a:effectRef idx="0">
-            <a:schemeClr val="accent1"/>
-          </a:effectRef>
-          <a:fontRef idx="minor">
-            <a:schemeClr val="lt1"/>
-          </a:fontRef>
-        </p:style>
-        <p:txBody>
-          <a:bodyPr lIns="108000" tIns="72000" rIns="108000" bIns="72000" rtlCol="0" anchor="ctr"/>
-          <a:lstStyle/>
-          <a:p>
-            <a:pPr algn="ctr"/>
-            <a:endParaRPr lang="en-US" sz="1600" dirty="0" err="1">
-              <a:solidFill>
-                <a:schemeClr val="bg1"/>
-              </a:solidFill>
-            </a:endParaRPr>
-          </a:p>
-        </p:txBody>
-      </p:sp>
-      <p:sp>
-        <p:nvSpPr>
-          <p:cNvPr id="96" name="Rounded Rectangle 95">
-            <a:extLst>
-              <a:ext uri="{FF2B5EF4-FFF2-40B4-BE49-F238E27FC236}">
-                <a16:creationId xmlns:a16="http://schemas.microsoft.com/office/drawing/2014/main" id="{664468DD-F725-773E-BAB7-98DCF200E9F7}"/>
-              </a:ext>
-            </a:extLst>
-          </p:cNvPr>
-          <p:cNvSpPr/>
-          <p:nvPr/>
-        </p:nvSpPr>
-        <p:spPr>
-          <a:xfrm>
-            <a:off x="10555012" y="4348891"/>
-            <a:ext cx="168322" cy="91833"/>
-          </a:xfrm>
-          <a:prstGeom prst="roundRect">
-            <a:avLst/>
-          </a:prstGeom>
-          <a:solidFill>
-            <a:srgbClr val="C6CD60"/>
-          </a:solidFill>
-          <a:ln>
-            <a:noFill/>
-          </a:ln>
-        </p:spPr>
-        <p:style>
-          <a:lnRef idx="2">
-            <a:schemeClr val="accent1">
-              <a:shade val="50000"/>
-            </a:schemeClr>
-          </a:lnRef>
-          <a:fillRef idx="1">
-            <a:schemeClr val="accent1"/>
-          </a:fillRef>
-          <a:effectRef idx="0">
-            <a:schemeClr val="accent1"/>
-          </a:effectRef>
-          <a:fontRef idx="minor">
-            <a:schemeClr val="lt1"/>
-          </a:fontRef>
-        </p:style>
-        <p:txBody>
-          <a:bodyPr lIns="108000" tIns="72000" rIns="108000" bIns="72000" rtlCol="0" anchor="ctr"/>
-          <a:lstStyle/>
-          <a:p>
-            <a:pPr algn="ctr"/>
-            <a:endParaRPr lang="en-US" sz="1600" dirty="0" err="1">
-              <a:solidFill>
-                <a:schemeClr val="bg1"/>
-              </a:solidFill>
-            </a:endParaRPr>
-          </a:p>
-        </p:txBody>
-      </p:sp>
-      <p:sp>
-        <p:nvSpPr>
-          <p:cNvPr id="4" name="TextBox 3">
-            <a:extLst>
-              <a:ext uri="{FF2B5EF4-FFF2-40B4-BE49-F238E27FC236}">
-                <a16:creationId xmlns:a16="http://schemas.microsoft.com/office/drawing/2014/main" id="{69D0D5CB-F67C-03CB-84F5-8ADF2D529748}"/>
-              </a:ext>
-            </a:extLst>
-          </p:cNvPr>
-          <p:cNvSpPr txBox="1"/>
-          <p:nvPr/>
-        </p:nvSpPr>
-        <p:spPr>
-          <a:xfrm>
-            <a:off x="3847211" y="6948976"/>
-            <a:ext cx="1125778" cy="223844"/>
-          </a:xfrm>
-          <a:prstGeom prst="rect">
-            <a:avLst/>
-          </a:prstGeom>
-          <a:noFill/>
-        </p:spPr>
-        <p:txBody>
-          <a:bodyPr wrap="none" lIns="90000" rtlCol="0" anchor="t">
-            <a:spAutoFit/>
-          </a:bodyPr>
-          <a:lstStyle/>
-          <a:p>
-            <a:pPr algn="l">
-              <a:lnSpc>
-                <a:spcPct val="113000"/>
-              </a:lnSpc>
-            </a:pPr>
-            <a:r>
-              <a:rPr lang="en-US" sz="800" dirty="0">
-                <a:solidFill>
-                  <a:schemeClr val="tx2"/>
-                </a:solidFill>
-              </a:rPr>
-              <a:t>New findings (2D6BFF)</a:t>
-            </a:r>
-          </a:p>
-        </p:txBody>
-      </p:sp>
-      <p:sp>
-        <p:nvSpPr>
-          <p:cNvPr id="5" name="TextBox 4">
-            <a:extLst>
-              <a:ext uri="{FF2B5EF4-FFF2-40B4-BE49-F238E27FC236}">
-                <a16:creationId xmlns:a16="http://schemas.microsoft.com/office/drawing/2014/main" id="{ABFB516C-5A42-1576-24CA-C03D1717DE69}"/>
-              </a:ext>
-            </a:extLst>
-          </p:cNvPr>
-          <p:cNvSpPr txBox="1"/>
-          <p:nvPr/>
-        </p:nvSpPr>
-        <p:spPr>
-          <a:xfrm>
-            <a:off x="3847211" y="7131265"/>
-            <a:ext cx="1258827" cy="223844"/>
-          </a:xfrm>
-          <a:prstGeom prst="rect">
-            <a:avLst/>
-          </a:prstGeom>
-          <a:noFill/>
-        </p:spPr>
-        <p:txBody>
-          <a:bodyPr wrap="none" lIns="90000" rtlCol="0" anchor="t">
-            <a:spAutoFit/>
-          </a:bodyPr>
-          <a:lstStyle/>
-          <a:p>
-            <a:pPr algn="l">
-              <a:lnSpc>
-                <a:spcPct val="113000"/>
-              </a:lnSpc>
-            </a:pPr>
-            <a:r>
-              <a:rPr lang="en-US" sz="800" dirty="0">
-                <a:solidFill>
-                  <a:schemeClr val="tx2"/>
-                </a:solidFill>
-              </a:rPr>
-              <a:t>Existing findings (B8C3FA)</a:t>
-            </a:r>
-          </a:p>
-        </p:txBody>
-      </p:sp>
-      <p:sp>
-        <p:nvSpPr>
-          <p:cNvPr id="9" name="TextBox 8">
-            <a:extLst>
-              <a:ext uri="{FF2B5EF4-FFF2-40B4-BE49-F238E27FC236}">
-                <a16:creationId xmlns:a16="http://schemas.microsoft.com/office/drawing/2014/main" id="{336EDEA9-04DF-E723-1F5B-FACCD40A8CF2}"/>
-              </a:ext>
-            </a:extLst>
-          </p:cNvPr>
-          <p:cNvSpPr txBox="1"/>
-          <p:nvPr/>
-        </p:nvSpPr>
-        <p:spPr>
-          <a:xfrm>
-            <a:off x="3847211" y="7313554"/>
-            <a:ext cx="1308520" cy="223844"/>
-          </a:xfrm>
-          <a:prstGeom prst="rect">
-            <a:avLst/>
-          </a:prstGeom>
-          <a:noFill/>
-        </p:spPr>
-        <p:txBody>
-          <a:bodyPr wrap="none" lIns="90000" rtlCol="0" anchor="t">
-            <a:spAutoFit/>
-          </a:bodyPr>
-          <a:lstStyle/>
-          <a:p>
-            <a:pPr algn="l">
-              <a:lnSpc>
-                <a:spcPct val="113000"/>
-              </a:lnSpc>
-            </a:pPr>
-            <a:r>
-              <a:rPr lang="en-US" sz="800" dirty="0">
-                <a:solidFill>
-                  <a:schemeClr val="tx2"/>
-                </a:solidFill>
-              </a:rPr>
-              <a:t>Resolved findings (E9C343)</a:t>
-            </a:r>
-          </a:p>
-        </p:txBody>
-      </p:sp>
-      <p:sp>
-        <p:nvSpPr>
-          <p:cNvPr id="10" name="Rounded Rectangle 9">
-            <a:extLst>
-              <a:ext uri="{FF2B5EF4-FFF2-40B4-BE49-F238E27FC236}">
-                <a16:creationId xmlns:a16="http://schemas.microsoft.com/office/drawing/2014/main" id="{B824A3D6-404E-6681-8BD2-1FB97DED7179}"/>
-              </a:ext>
-            </a:extLst>
-          </p:cNvPr>
-          <p:cNvSpPr/>
-          <p:nvPr/>
-        </p:nvSpPr>
-        <p:spPr>
-          <a:xfrm>
-            <a:off x="3716303" y="7016971"/>
-            <a:ext cx="168322" cy="91833"/>
-          </a:xfrm>
-          <a:prstGeom prst="roundRect">
-            <a:avLst/>
-          </a:prstGeom>
-          <a:solidFill>
-            <a:srgbClr val="2D6BFF"/>
-          </a:solidFill>
-          <a:ln>
-            <a:noFill/>
-          </a:ln>
-        </p:spPr>
-        <p:style>
-          <a:lnRef idx="2">
-            <a:schemeClr val="accent1">
-              <a:shade val="50000"/>
-            </a:schemeClr>
-          </a:lnRef>
-          <a:fillRef idx="1">
-            <a:schemeClr val="accent1"/>
-          </a:fillRef>
-          <a:effectRef idx="0">
-            <a:schemeClr val="accent1"/>
-          </a:effectRef>
-          <a:fontRef idx="minor">
-            <a:schemeClr val="lt1"/>
-          </a:fontRef>
-        </p:style>
-        <p:txBody>
-          <a:bodyPr lIns="108000" tIns="72000" rIns="108000" bIns="72000" rtlCol="0" anchor="ctr"/>
-          <a:lstStyle/>
-          <a:p>
-            <a:pPr algn="ctr"/>
-            <a:endParaRPr lang="en-US" sz="1600" dirty="0" err="1">
-              <a:solidFill>
-                <a:schemeClr val="bg1"/>
-              </a:solidFill>
-            </a:endParaRPr>
-          </a:p>
-        </p:txBody>
-      </p:sp>
-      <p:sp>
-        <p:nvSpPr>
-          <p:cNvPr id="11" name="Rounded Rectangle 10">
-            <a:extLst>
-              <a:ext uri="{FF2B5EF4-FFF2-40B4-BE49-F238E27FC236}">
-                <a16:creationId xmlns:a16="http://schemas.microsoft.com/office/drawing/2014/main" id="{E5D8105E-4BD3-946A-3386-67F8816B5245}"/>
-              </a:ext>
-            </a:extLst>
-          </p:cNvPr>
-          <p:cNvSpPr/>
-          <p:nvPr/>
-        </p:nvSpPr>
-        <p:spPr>
-          <a:xfrm>
-            <a:off x="3716303" y="7200179"/>
-            <a:ext cx="168322" cy="91833"/>
-          </a:xfrm>
-          <a:prstGeom prst="roundRect">
-            <a:avLst/>
-          </a:prstGeom>
-          <a:solidFill>
-            <a:srgbClr val="B6C4FF"/>
-          </a:solidFill>
-          <a:ln>
-            <a:noFill/>
-          </a:ln>
-        </p:spPr>
-        <p:style>
-          <a:lnRef idx="2">
-            <a:schemeClr val="accent1">
-              <a:shade val="50000"/>
-            </a:schemeClr>
-          </a:lnRef>
-          <a:fillRef idx="1">
-            <a:schemeClr val="accent1"/>
-          </a:fillRef>
-          <a:effectRef idx="0">
-            <a:schemeClr val="accent1"/>
-          </a:effectRef>
-          <a:fontRef idx="minor">
-            <a:schemeClr val="lt1"/>
-          </a:fontRef>
-        </p:style>
-        <p:txBody>
-          <a:bodyPr lIns="108000" tIns="72000" rIns="108000" bIns="72000" rtlCol="0" anchor="ctr"/>
-          <a:lstStyle/>
-          <a:p>
-            <a:pPr algn="ctr"/>
-            <a:endParaRPr lang="en-US" sz="1600" dirty="0" err="1">
-              <a:solidFill>
-                <a:schemeClr val="bg1"/>
-              </a:solidFill>
-            </a:endParaRPr>
-          </a:p>
-        </p:txBody>
-      </p:sp>
-      <p:sp>
-        <p:nvSpPr>
-          <p:cNvPr id="12" name="Rounded Rectangle 11">
-            <a:extLst>
-              <a:ext uri="{FF2B5EF4-FFF2-40B4-BE49-F238E27FC236}">
-                <a16:creationId xmlns:a16="http://schemas.microsoft.com/office/drawing/2014/main" id="{F708B75B-A95C-C433-F392-F80FA8AED1D8}"/>
-              </a:ext>
-            </a:extLst>
-          </p:cNvPr>
-          <p:cNvSpPr/>
-          <p:nvPr/>
-        </p:nvSpPr>
-        <p:spPr>
-          <a:xfrm>
-            <a:off x="3716303" y="7383387"/>
-            <a:ext cx="168322" cy="91833"/>
-          </a:xfrm>
-          <a:prstGeom prst="roundRect">
-            <a:avLst/>
-          </a:prstGeom>
-          <a:solidFill>
-            <a:srgbClr val="F1C109"/>
-          </a:solidFill>
-          <a:ln>
-            <a:noFill/>
-          </a:ln>
-        </p:spPr>
-        <p:style>
-          <a:lnRef idx="2">
-            <a:schemeClr val="accent1">
-              <a:shade val="50000"/>
-            </a:schemeClr>
-          </a:lnRef>
-          <a:fillRef idx="1">
-            <a:schemeClr val="accent1"/>
-          </a:fillRef>
-          <a:effectRef idx="0">
-            <a:schemeClr val="accent1"/>
-          </a:effectRef>
-          <a:fontRef idx="minor">
-            <a:schemeClr val="lt1"/>
-          </a:fontRef>
-        </p:style>
-        <p:txBody>
-          <a:bodyPr lIns="108000" tIns="72000" rIns="108000" bIns="72000" rtlCol="0" anchor="ctr"/>
-          <a:lstStyle/>
-          <a:p>
-            <a:pPr algn="ctr"/>
-            <a:endParaRPr lang="en-US" sz="1600" dirty="0" err="1">
-              <a:solidFill>
-                <a:schemeClr val="bg1"/>
-              </a:solidFill>
-            </a:endParaRPr>
-          </a:p>
-        </p:txBody>
-      </p:sp>
-      <p:sp>
-        <p:nvSpPr>
-          <p:cNvPr id="13" name="TextBox 12">
-            <a:extLst>
-              <a:ext uri="{FF2B5EF4-FFF2-40B4-BE49-F238E27FC236}">
-                <a16:creationId xmlns:a16="http://schemas.microsoft.com/office/drawing/2014/main" id="{EDD86F90-B83C-95D2-0263-C0960F4176D9}"/>
-              </a:ext>
-            </a:extLst>
-          </p:cNvPr>
-          <p:cNvSpPr txBox="1"/>
-          <p:nvPr/>
-        </p:nvSpPr>
-        <p:spPr>
-          <a:xfrm>
-            <a:off x="6355405" y="6948976"/>
-            <a:ext cx="1645151" cy="223844"/>
-          </a:xfrm>
-          <a:prstGeom prst="rect">
-            <a:avLst/>
-          </a:prstGeom>
-          <a:noFill/>
-        </p:spPr>
-        <p:txBody>
-          <a:bodyPr wrap="none" lIns="90000" rtlCol="0" anchor="t">
-            <a:spAutoFit/>
-          </a:bodyPr>
-          <a:lstStyle/>
-          <a:p>
-            <a:pPr>
-              <a:lnSpc>
-                <a:spcPct val="113000"/>
-              </a:lnSpc>
-            </a:pPr>
-            <a:r>
-              <a:rPr lang="en-US" sz="800" dirty="0">
-                <a:solidFill>
-                  <a:schemeClr val="tx2"/>
-                </a:solidFill>
-              </a:rPr>
-              <a:t>At most 7 / 14 / 30 /  days (2D6BFF)</a:t>
-            </a:r>
-          </a:p>
-        </p:txBody>
-      </p:sp>
-      <p:sp>
-        <p:nvSpPr>
-          <p:cNvPr id="14" name="TextBox 13">
-            <a:extLst>
-              <a:ext uri="{FF2B5EF4-FFF2-40B4-BE49-F238E27FC236}">
-                <a16:creationId xmlns:a16="http://schemas.microsoft.com/office/drawing/2014/main" id="{F934EFB9-5610-46A8-02BF-DD91B6F97E06}"/>
-              </a:ext>
-            </a:extLst>
-          </p:cNvPr>
-          <p:cNvSpPr txBox="1"/>
-          <p:nvPr/>
-        </p:nvSpPr>
-        <p:spPr>
-          <a:xfrm>
-            <a:off x="6355405" y="7131265"/>
-            <a:ext cx="1670799" cy="223844"/>
-          </a:xfrm>
-          <a:prstGeom prst="rect">
-            <a:avLst/>
-          </a:prstGeom>
-          <a:noFill/>
-        </p:spPr>
-        <p:txBody>
-          <a:bodyPr wrap="none" lIns="90000" rtlCol="0" anchor="t">
-            <a:spAutoFit/>
-          </a:bodyPr>
-          <a:lstStyle/>
-          <a:p>
-            <a:pPr algn="l">
-              <a:lnSpc>
-                <a:spcPct val="113000"/>
-              </a:lnSpc>
-            </a:pPr>
-            <a:r>
-              <a:rPr lang="en-US" sz="800" dirty="0">
-                <a:solidFill>
-                  <a:schemeClr val="tx2"/>
-                </a:solidFill>
-              </a:rPr>
-              <a:t>7-14 / 14-30 / 30-180 days (E9C343)</a:t>
-            </a:r>
-          </a:p>
-        </p:txBody>
-      </p:sp>
-      <p:sp>
-        <p:nvSpPr>
-          <p:cNvPr id="15" name="TextBox 14">
-            <a:extLst>
-              <a:ext uri="{FF2B5EF4-FFF2-40B4-BE49-F238E27FC236}">
-                <a16:creationId xmlns:a16="http://schemas.microsoft.com/office/drawing/2014/main" id="{02ED2BEC-6CE3-1F2A-CDC3-36BB37E09BD1}"/>
-              </a:ext>
-            </a:extLst>
-          </p:cNvPr>
-          <p:cNvSpPr txBox="1"/>
-          <p:nvPr/>
-        </p:nvSpPr>
-        <p:spPr>
-          <a:xfrm>
-            <a:off x="6355405" y="7313554"/>
-            <a:ext cx="1834305" cy="223844"/>
-          </a:xfrm>
-          <a:prstGeom prst="rect">
-            <a:avLst/>
-          </a:prstGeom>
-          <a:noFill/>
-        </p:spPr>
-        <p:txBody>
-          <a:bodyPr wrap="none" lIns="90000" rtlCol="0" anchor="t">
-            <a:spAutoFit/>
-          </a:bodyPr>
-          <a:lstStyle/>
-          <a:p>
-            <a:pPr algn="l">
-              <a:lnSpc>
-                <a:spcPct val="113000"/>
-              </a:lnSpc>
-            </a:pPr>
-            <a:r>
-              <a:rPr lang="en-US" sz="800" dirty="0">
-                <a:solidFill>
-                  <a:schemeClr val="tx2"/>
-                </a:solidFill>
-              </a:rPr>
-              <a:t>14-30 / 30-180 / 180-365 days (C9A837)</a:t>
-            </a:r>
-          </a:p>
-        </p:txBody>
-      </p:sp>
-      <p:sp>
-        <p:nvSpPr>
-          <p:cNvPr id="16" name="TextBox 15">
-            <a:extLst>
-              <a:ext uri="{FF2B5EF4-FFF2-40B4-BE49-F238E27FC236}">
-                <a16:creationId xmlns:a16="http://schemas.microsoft.com/office/drawing/2014/main" id="{18540858-2D95-20D2-168F-EB118164412E}"/>
-              </a:ext>
-            </a:extLst>
-          </p:cNvPr>
-          <p:cNvSpPr txBox="1"/>
-          <p:nvPr/>
-        </p:nvSpPr>
-        <p:spPr>
-          <a:xfrm>
-            <a:off x="6355405" y="7495843"/>
-            <a:ext cx="1739728" cy="223844"/>
-          </a:xfrm>
-          <a:prstGeom prst="rect">
-            <a:avLst/>
-          </a:prstGeom>
-          <a:noFill/>
-        </p:spPr>
-        <p:txBody>
-          <a:bodyPr wrap="none" lIns="90000" rtlCol="0" anchor="t">
-            <a:spAutoFit/>
-          </a:bodyPr>
-          <a:lstStyle/>
-          <a:p>
-            <a:pPr>
-              <a:lnSpc>
-                <a:spcPct val="113000"/>
-              </a:lnSpc>
-            </a:pPr>
-            <a:r>
-              <a:rPr lang="en-US" sz="800" dirty="0">
-                <a:solidFill>
-                  <a:schemeClr val="tx2"/>
-                </a:solidFill>
-              </a:rPr>
-              <a:t>At least 30 / 180 / 365 days (AB8D2D)</a:t>
-            </a:r>
-          </a:p>
-        </p:txBody>
-      </p:sp>
-      <p:sp>
-        <p:nvSpPr>
-          <p:cNvPr id="18" name="Rounded Rectangle 17">
-            <a:extLst>
-              <a:ext uri="{FF2B5EF4-FFF2-40B4-BE49-F238E27FC236}">
-                <a16:creationId xmlns:a16="http://schemas.microsoft.com/office/drawing/2014/main" id="{04E8A7ED-0584-2528-F05E-FBF4834260FD}"/>
-              </a:ext>
-            </a:extLst>
-          </p:cNvPr>
-          <p:cNvSpPr/>
-          <p:nvPr/>
-        </p:nvSpPr>
-        <p:spPr>
-          <a:xfrm>
-            <a:off x="6224497" y="7022853"/>
-            <a:ext cx="168322" cy="91833"/>
-          </a:xfrm>
-          <a:prstGeom prst="roundRect">
-            <a:avLst/>
-          </a:prstGeom>
-          <a:solidFill>
-            <a:srgbClr val="2F6BFE"/>
-          </a:solidFill>
-          <a:ln>
-            <a:noFill/>
-          </a:ln>
-        </p:spPr>
-        <p:style>
-          <a:lnRef idx="2">
-            <a:schemeClr val="accent1">
-              <a:shade val="50000"/>
-            </a:schemeClr>
-          </a:lnRef>
-          <a:fillRef idx="1">
-            <a:schemeClr val="accent1"/>
-          </a:fillRef>
-          <a:effectRef idx="0">
-            <a:schemeClr val="accent1"/>
-          </a:effectRef>
-          <a:fontRef idx="minor">
-            <a:schemeClr val="lt1"/>
-          </a:fontRef>
-        </p:style>
-        <p:txBody>
-          <a:bodyPr lIns="108000" tIns="72000" rIns="108000" bIns="72000" rtlCol="0" anchor="ctr"/>
-          <a:lstStyle/>
-          <a:p>
-            <a:pPr algn="ctr"/>
-            <a:endParaRPr lang="en-US" sz="1600" dirty="0" err="1">
-              <a:solidFill>
-                <a:schemeClr val="bg1"/>
-              </a:solidFill>
-            </a:endParaRPr>
-          </a:p>
-        </p:txBody>
-      </p:sp>
-      <p:sp>
-        <p:nvSpPr>
-          <p:cNvPr id="19" name="Rounded Rectangle 18">
-            <a:extLst>
-              <a:ext uri="{FF2B5EF4-FFF2-40B4-BE49-F238E27FC236}">
-                <a16:creationId xmlns:a16="http://schemas.microsoft.com/office/drawing/2014/main" id="{F57996B4-400A-1707-6FAF-47CE0D1132CE}"/>
-              </a:ext>
-            </a:extLst>
-          </p:cNvPr>
-          <p:cNvSpPr/>
-          <p:nvPr/>
-        </p:nvSpPr>
-        <p:spPr>
-          <a:xfrm>
-            <a:off x="6224497" y="7203775"/>
-            <a:ext cx="168322" cy="91833"/>
-          </a:xfrm>
-          <a:prstGeom prst="roundRect">
-            <a:avLst/>
-          </a:prstGeom>
-          <a:solidFill>
-            <a:srgbClr val="E9C343"/>
-          </a:solidFill>
-          <a:ln>
-            <a:noFill/>
-          </a:ln>
-        </p:spPr>
-        <p:style>
-          <a:lnRef idx="2">
-            <a:schemeClr val="accent1">
-              <a:shade val="50000"/>
-            </a:schemeClr>
-          </a:lnRef>
-          <a:fillRef idx="1">
-            <a:schemeClr val="accent1"/>
-          </a:fillRef>
-          <a:effectRef idx="0">
-            <a:schemeClr val="accent1"/>
-          </a:effectRef>
-          <a:fontRef idx="minor">
-            <a:schemeClr val="lt1"/>
-          </a:fontRef>
-        </p:style>
-        <p:txBody>
-          <a:bodyPr lIns="108000" tIns="72000" rIns="108000" bIns="72000" rtlCol="0" anchor="ctr"/>
-          <a:lstStyle/>
-          <a:p>
-            <a:pPr algn="ctr"/>
-            <a:endParaRPr lang="en-US" sz="1600" dirty="0" err="1">
-              <a:solidFill>
-                <a:schemeClr val="bg1"/>
-              </a:solidFill>
-            </a:endParaRPr>
-          </a:p>
-        </p:txBody>
-      </p:sp>
-      <p:sp>
-        <p:nvSpPr>
-          <p:cNvPr id="20" name="Rounded Rectangle 19">
-            <a:extLst>
-              <a:ext uri="{FF2B5EF4-FFF2-40B4-BE49-F238E27FC236}">
-                <a16:creationId xmlns:a16="http://schemas.microsoft.com/office/drawing/2014/main" id="{D51F3CF7-5C41-A6BD-B496-E231C2433787}"/>
-              </a:ext>
-            </a:extLst>
-          </p:cNvPr>
-          <p:cNvSpPr/>
-          <p:nvPr/>
-        </p:nvSpPr>
-        <p:spPr>
-          <a:xfrm>
-            <a:off x="6224497" y="7384697"/>
-            <a:ext cx="168322" cy="91833"/>
-          </a:xfrm>
-          <a:prstGeom prst="roundRect">
-            <a:avLst/>
-          </a:prstGeom>
-          <a:solidFill>
-            <a:srgbClr val="D0A700"/>
-          </a:solidFill>
-          <a:ln>
-            <a:noFill/>
-          </a:ln>
-        </p:spPr>
-        <p:style>
-          <a:lnRef idx="2">
-            <a:schemeClr val="accent1">
-              <a:shade val="50000"/>
-            </a:schemeClr>
-          </a:lnRef>
-          <a:fillRef idx="1">
-            <a:schemeClr val="accent1"/>
-          </a:fillRef>
-          <a:effectRef idx="0">
-            <a:schemeClr val="accent1"/>
-          </a:effectRef>
-          <a:fontRef idx="minor">
-            <a:schemeClr val="lt1"/>
-          </a:fontRef>
-        </p:style>
-        <p:txBody>
-          <a:bodyPr lIns="108000" tIns="72000" rIns="108000" bIns="72000" rtlCol="0" anchor="ctr"/>
-          <a:lstStyle/>
-          <a:p>
-            <a:pPr algn="ctr"/>
-            <a:endParaRPr lang="en-US" sz="1600" dirty="0" err="1">
-              <a:solidFill>
-                <a:schemeClr val="bg1"/>
-              </a:solidFill>
-            </a:endParaRPr>
-          </a:p>
-        </p:txBody>
-      </p:sp>
-      <p:sp>
-        <p:nvSpPr>
-          <p:cNvPr id="21" name="Rounded Rectangle 20">
-            <a:extLst>
-              <a:ext uri="{FF2B5EF4-FFF2-40B4-BE49-F238E27FC236}">
-                <a16:creationId xmlns:a16="http://schemas.microsoft.com/office/drawing/2014/main" id="{AD0A3B9C-2E25-9487-B93D-6859968E49CD}"/>
-              </a:ext>
-            </a:extLst>
-          </p:cNvPr>
-          <p:cNvSpPr/>
-          <p:nvPr/>
-        </p:nvSpPr>
-        <p:spPr>
-          <a:xfrm>
-            <a:off x="6224497" y="7565618"/>
-            <a:ext cx="168322" cy="91833"/>
-          </a:xfrm>
-          <a:prstGeom prst="roundRect">
-            <a:avLst/>
-          </a:prstGeom>
-          <a:solidFill>
-            <a:srgbClr val="B18C00"/>
-          </a:solidFill>
-          <a:ln>
-            <a:noFill/>
-          </a:ln>
-        </p:spPr>
-        <p:style>
-          <a:lnRef idx="2">
-            <a:schemeClr val="accent1">
-              <a:shade val="50000"/>
-            </a:schemeClr>
-          </a:lnRef>
-          <a:fillRef idx="1">
-            <a:schemeClr val="accent1"/>
-          </a:fillRef>
-          <a:effectRef idx="0">
-            <a:schemeClr val="accent1"/>
-          </a:effectRef>
-          <a:fontRef idx="minor">
-            <a:schemeClr val="lt1"/>
-          </a:fontRef>
-        </p:style>
-        <p:txBody>
-          <a:bodyPr lIns="108000" tIns="72000" rIns="108000" bIns="72000" rtlCol="0" anchor="ctr"/>
-          <a:lstStyle/>
-          <a:p>
-            <a:pPr algn="ctr"/>
-            <a:endParaRPr lang="en-US" sz="1600" dirty="0" err="1">
-              <a:solidFill>
-                <a:schemeClr val="bg1"/>
-              </a:solidFill>
-            </a:endParaRPr>
-          </a:p>
-        </p:txBody>
-      </p:sp>
-      <p:sp>
-        <p:nvSpPr>
-          <p:cNvPr id="2" name="Rectangle 1">
-            <a:extLst>
-              <a:ext uri="{FF2B5EF4-FFF2-40B4-BE49-F238E27FC236}">
-                <a16:creationId xmlns:a16="http://schemas.microsoft.com/office/drawing/2014/main" id="{2738C682-48A6-D670-7903-E8184035BEC7}"/>
-              </a:ext>
-            </a:extLst>
-          </p:cNvPr>
-          <p:cNvSpPr/>
-          <p:nvPr/>
-        </p:nvSpPr>
-        <p:spPr>
-          <a:xfrm>
-            <a:off x="926285" y="3569394"/>
-            <a:ext cx="6149934" cy="2501548"/>
+            <a:off x="766866" y="3612456"/>
+            <a:ext cx="3299114" cy="2341757"/>
           </a:xfrm>
           <a:prstGeom prst="rect">
             <a:avLst/>
@@ -51374,7 +49898,135 @@
                   <a:schemeClr val="bg1"/>
                 </a:solidFill>
               </a:rPr>
-              <a:t>PORTFOLIO_PERIOD_SECURITY_DASHBOARD_FINDINGS</a:t>
+              <a:t>PORTFOLIO_PERIOD_SECURITY_DASHBOARD_CRITICAL_FINDINGS</a:t>
+            </a:r>
+            <a:endParaRPr lang="en-US" sz="1600" dirty="0">
+              <a:solidFill>
+                <a:schemeClr val="bg1"/>
+              </a:solidFill>
+            </a:endParaRPr>
+          </a:p>
+        </p:txBody>
+      </p:sp>
+      <p:sp>
+        <p:nvSpPr>
+          <p:cNvPr id="5" name="Rectangle 4">
+            <a:extLst>
+              <a:ext uri="{FF2B5EF4-FFF2-40B4-BE49-F238E27FC236}">
+                <a16:creationId xmlns:a16="http://schemas.microsoft.com/office/drawing/2014/main" id="{F1F42F13-AC84-E68B-5231-2D1D16BF93F2}"/>
+              </a:ext>
+            </a:extLst>
+          </p:cNvPr>
+          <p:cNvSpPr/>
+          <p:nvPr/>
+        </p:nvSpPr>
+        <p:spPr>
+          <a:xfrm>
+            <a:off x="4529323" y="3612456"/>
+            <a:ext cx="3299114" cy="2341757"/>
+          </a:xfrm>
+          <a:prstGeom prst="rect">
+            <a:avLst/>
+          </a:prstGeom>
+          <a:solidFill>
+            <a:srgbClr val="F0089F"/>
+          </a:solidFill>
+          <a:ln>
+            <a:noFill/>
+          </a:ln>
+        </p:spPr>
+        <p:style>
+          <a:lnRef idx="2">
+            <a:schemeClr val="accent1">
+              <a:shade val="50000"/>
+            </a:schemeClr>
+          </a:lnRef>
+          <a:fillRef idx="1">
+            <a:schemeClr val="accent1"/>
+          </a:fillRef>
+          <a:effectRef idx="0">
+            <a:schemeClr val="accent1"/>
+          </a:effectRef>
+          <a:fontRef idx="minor">
+            <a:schemeClr val="lt1"/>
+          </a:fontRef>
+        </p:style>
+        <p:txBody>
+          <a:bodyPr lIns="108000" tIns="72000" rIns="108000" bIns="72000" rtlCol="0" anchor="ctr"/>
+          <a:lstStyle/>
+          <a:p>
+            <a:pPr algn="ctr"/>
+            <a:r>
+              <a:rPr lang="en-US" sz="1600" dirty="0" err="1">
+                <a:solidFill>
+                  <a:schemeClr val="bg1"/>
+                </a:solidFill>
+              </a:rPr>
+              <a:t>PORTFOLIO_PERIOD_SECURITY_DASHBOARD_HIGH_FINDINGS</a:t>
+            </a:r>
+            <a:endParaRPr lang="en-US" sz="1600" dirty="0">
+              <a:solidFill>
+                <a:schemeClr val="bg1"/>
+              </a:solidFill>
+            </a:endParaRPr>
+          </a:p>
+        </p:txBody>
+      </p:sp>
+      <p:sp>
+        <p:nvSpPr>
+          <p:cNvPr id="9" name="Rectangle 8">
+            <a:extLst>
+              <a:ext uri="{FF2B5EF4-FFF2-40B4-BE49-F238E27FC236}">
+                <a16:creationId xmlns:a16="http://schemas.microsoft.com/office/drawing/2014/main" id="{30258737-222F-2C4D-7BF4-52200E9C6818}"/>
+              </a:ext>
+            </a:extLst>
+          </p:cNvPr>
+          <p:cNvSpPr/>
+          <p:nvPr/>
+        </p:nvSpPr>
+        <p:spPr>
+          <a:xfrm>
+            <a:off x="8290705" y="3612456"/>
+            <a:ext cx="3299114" cy="2341757"/>
+          </a:xfrm>
+          <a:prstGeom prst="rect">
+            <a:avLst/>
+          </a:prstGeom>
+          <a:solidFill>
+            <a:srgbClr val="F0089F"/>
+          </a:solidFill>
+          <a:ln>
+            <a:noFill/>
+          </a:ln>
+        </p:spPr>
+        <p:style>
+          <a:lnRef idx="2">
+            <a:schemeClr val="accent1">
+              <a:shade val="50000"/>
+            </a:schemeClr>
+          </a:lnRef>
+          <a:fillRef idx="1">
+            <a:schemeClr val="accent1"/>
+          </a:fillRef>
+          <a:effectRef idx="0">
+            <a:schemeClr val="accent1"/>
+          </a:effectRef>
+          <a:fontRef idx="minor">
+            <a:schemeClr val="lt1"/>
+          </a:fontRef>
+        </p:style>
+        <p:txBody>
+          <a:bodyPr lIns="108000" tIns="72000" rIns="108000" bIns="72000" rtlCol="0" anchor="ctr"/>
+          <a:lstStyle/>
+          <a:p>
+            <a:pPr algn="ctr"/>
+            <a:r>
+              <a:rPr lang="en-US" sz="1600" dirty="0" err="1">
+                <a:solidFill>
+                  <a:schemeClr val="bg1"/>
+                </a:solidFill>
+              </a:rPr>
+              <a:t>PORTFOLIO_PERIOD_SECURITY_DASHBOARD_MEDIUM_FINDINGS</a:t>
             </a:r>
             <a:endParaRPr lang="en-US" sz="1600" dirty="0">
               <a:solidFill>
@@ -51387,7 +50039,7 @@
     </p:spTree>
     <p:extLst>
       <p:ext uri="{BB962C8B-B14F-4D97-AF65-F5344CB8AC3E}">
-        <p14:creationId xmlns:p14="http://schemas.microsoft.com/office/powerpoint/2010/main" val="3904381800"/>
+        <p14:creationId xmlns:p14="http://schemas.microsoft.com/office/powerpoint/2010/main" val="2697964643"/>
       </p:ext>
     </p:extLst>
   </p:cSld>
@@ -57599,15 +56251,6 @@
 </file>
 
 <file path=customXml/item2.xml><?xml version="1.0" encoding="utf-8"?>
-<?mso-contentType ?>
-<FormTemplates xmlns="http://schemas.microsoft.com/sharepoint/v3/contenttype/forms">
-  <Display>DocumentLibraryForm</Display>
-  <Edit>DocumentLibraryForm</Edit>
-  <New>DocumentLibraryForm</New>
-</FormTemplates>
-</file>
-
-<file path=customXml/item3.xml><?xml version="1.0" encoding="utf-8"?>
 <ct:contentTypeSchema xmlns:ct="http://schemas.microsoft.com/office/2006/metadata/contentType" xmlns:ma="http://schemas.microsoft.com/office/2006/metadata/properties/metaAttributes" ct:_="" ma:_="" ma:contentTypeName="Document" ma:contentTypeID="0x010100398B4EB28540854BB4092730D7F67224" ma:contentTypeVersion="13" ma:contentTypeDescription="Create a new document." ma:contentTypeScope="" ma:versionID="07d6997c7358ecc3b6f0d78039f1ac55">
   <xsd:schema xmlns:xsd="http://www.w3.org/2001/XMLSchema" xmlns:xs="http://www.w3.org/2001/XMLSchema" xmlns:p="http://schemas.microsoft.com/office/2006/metadata/properties" xmlns:ns2="fa937df2-abe2-4d38-b5f4-c228acba3827" xmlns:ns3="bc8ba18a-4a58-4ad2-bfc0-6516af8e7dc2" targetNamespace="http://schemas.microsoft.com/office/2006/metadata/properties" ma:root="true" ma:fieldsID="a7d20d2c9a349b6838acf4b79389f2fd" ns2:_="" ns3:_="">
     <xsd:import namespace="fa937df2-abe2-4d38-b5f4-c228acba3827"/>
@@ -57830,6 +56473,15 @@
 </ct:contentTypeSchema>
 </file>
 
+<file path=customXml/item3.xml><?xml version="1.0" encoding="utf-8"?>
+<?mso-contentType ?>
+<FormTemplates xmlns="http://schemas.microsoft.com/sharepoint/v3/contenttype/forms">
+  <Display>DocumentLibraryForm</Display>
+  <Edit>DocumentLibraryForm</Edit>
+  <New>DocumentLibraryForm</New>
+</FormTemplates>
+</file>
+
 <file path=customXml/itemProps1.xml><?xml version="1.0" encoding="utf-8"?>
 <ds:datastoreItem xmlns:ds="http://schemas.openxmlformats.org/officeDocument/2006/customXml" ds:itemID="{4B629362-CF15-4610-8FAC-A8E699942233}">
   <ds:schemaRefs>
@@ -57848,14 +56500,6 @@
 </file>
 
 <file path=customXml/itemProps2.xml><?xml version="1.0" encoding="utf-8"?>
-<ds:datastoreItem xmlns:ds="http://schemas.openxmlformats.org/officeDocument/2006/customXml" ds:itemID="{570928F0-D7CA-4732-B7F3-1F945720D0AA}">
-  <ds:schemaRefs>
-    <ds:schemaRef ds:uri="http://schemas.microsoft.com/sharepoint/v3/contenttype/forms"/>
-  </ds:schemaRefs>
-</ds:datastoreItem>
-</file>
-
-<file path=customXml/itemProps3.xml><?xml version="1.0" encoding="utf-8"?>
 <ds:datastoreItem xmlns:ds="http://schemas.openxmlformats.org/officeDocument/2006/customXml" ds:itemID="{06E6923A-C221-4753-B75B-BA213EEB7564}">
   <ds:schemaRefs>
     <ds:schemaRef ds:uri="bc8ba18a-4a58-4ad2-bfc0-6516af8e7dc2"/>
@@ -57872,4 +56516,12 @@
     <ds:schemaRef ds:uri="http://www.w3.org/2001/XMLSchema"/>
   </ds:schemaRefs>
 </ds:datastoreItem>
+</file>
+
+<file path=customXml/itemProps3.xml><?xml version="1.0" encoding="utf-8"?>
+<ds:datastoreItem xmlns:ds="http://schemas.openxmlformats.org/officeDocument/2006/customXml" ds:itemID="{570928F0-D7CA-4732-B7F3-1F945720D0AA}">
+  <ds:schemaRefs>
+    <ds:schemaRef ds:uri="http://schemas.microsoft.com/sharepoint/v3/contenttype/forms"/>
+  </ds:schemaRefs>
+</ds:datastoreItem>
 </file>
</xml_diff>

<commit_message>
Add security resolution times slide
</commit_message>
<xml_diff>
--- a/src/report_generator/presets/templates/portfolio-overview.pptx
+++ b/src/report_generator/presets/templates/portfolio-overview.pptx
@@ -5,10 +5,10 @@
     <p:sldMasterId id="2147483648" r:id="rId4"/>
   </p:sldMasterIdLst>
   <p:notesMasterIdLst>
-    <p:notesMasterId r:id="rId25"/>
+    <p:notesMasterId r:id="rId26"/>
   </p:notesMasterIdLst>
   <p:handoutMasterIdLst>
-    <p:handoutMasterId r:id="rId26"/>
+    <p:handoutMasterId r:id="rId27"/>
   </p:handoutMasterIdLst>
   <p:sldIdLst>
     <p:sldId id="561" r:id="rId5"/>
@@ -29,8 +29,9 @@
     <p:sldId id="10727" r:id="rId20"/>
     <p:sldId id="10726" r:id="rId21"/>
     <p:sldId id="10731" r:id="rId22"/>
-    <p:sldId id="10723" r:id="rId23"/>
-    <p:sldId id="597" r:id="rId24"/>
+    <p:sldId id="10732" r:id="rId23"/>
+    <p:sldId id="10723" r:id="rId24"/>
+    <p:sldId id="597" r:id="rId25"/>
   </p:sldIdLst>
   <p:sldSz cx="12192000" cy="6858000"/>
   <p:notesSz cx="6858000" cy="9144000"/>
@@ -48727,7 +48728,19 @@
                   <a:schemeClr val="accent3"/>
                 </a:solidFill>
               </a:rPr>
-              <a:t>SECURITY</a:t>
+              <a:t>SECURITY </a:t>
+            </a:r>
+            <a:r>
+              <a:rPr lang="en-US" dirty="0"/>
+              <a:t>– </a:t>
+            </a:r>
+            <a:r>
+              <a:rPr lang="en-US" dirty="0">
+                <a:solidFill>
+                  <a:schemeClr val="accent3"/>
+                </a:solidFill>
+              </a:rPr>
+              <a:t>FINDINGS TREND</a:t>
             </a:r>
           </a:p>
         </p:txBody>
@@ -50057,7 +50070,7 @@
         <p:cNvPr id="1" name="">
           <a:extLst>
             <a:ext uri="{FF2B5EF4-FFF2-40B4-BE49-F238E27FC236}">
-              <a16:creationId xmlns:a16="http://schemas.microsoft.com/office/drawing/2014/main" id="{2A447711-2F95-8D02-EF61-9DFDAFBAAE27}"/>
+              <a16:creationId xmlns:a16="http://schemas.microsoft.com/office/drawing/2014/main" id="{97008932-67FE-3479-AEE1-B79D9C3C59C1}"/>
             </a:ext>
           </a:extLst>
         </p:cNvPr>
@@ -50077,7 +50090,7 @@
           <p:cNvPr id="17" name="Rectangle 16">
             <a:extLst>
               <a:ext uri="{FF2B5EF4-FFF2-40B4-BE49-F238E27FC236}">
-                <a16:creationId xmlns:a16="http://schemas.microsoft.com/office/drawing/2014/main" id="{ED508E6A-8D1D-AB1F-259E-339FCAE0BA97}"/>
+                <a16:creationId xmlns:a16="http://schemas.microsoft.com/office/drawing/2014/main" id="{ABDCAA79-36DA-0C0E-7EC3-23BEA35C7716}"/>
               </a:ext>
             </a:extLst>
           </p:cNvPr>
@@ -50147,7 +50160,7 @@
           <p:cNvPr id="3" name="Slide Number Placeholder 2">
             <a:extLst>
               <a:ext uri="{FF2B5EF4-FFF2-40B4-BE49-F238E27FC236}">
-                <a16:creationId xmlns:a16="http://schemas.microsoft.com/office/drawing/2014/main" id="{B67F47A6-2E30-A3A2-1FA6-ADC44FB6A75A}"/>
+                <a16:creationId xmlns:a16="http://schemas.microsoft.com/office/drawing/2014/main" id="{99741DF7-A2F7-DE2C-4980-7DA07FA9D51E}"/>
               </a:ext>
             </a:extLst>
           </p:cNvPr>
@@ -50167,6 +50180,1720 @@
               <a:rPr lang="en-US" smtClean="0"/>
               <a:pPr/>
               <a:t>19</a:t>
+            </a:fld>
+            <a:endParaRPr lang="en-US"/>
+          </a:p>
+        </p:txBody>
+      </p:sp>
+      <p:sp>
+        <p:nvSpPr>
+          <p:cNvPr id="7" name="Text Placeholder 6">
+            <a:extLst>
+              <a:ext uri="{FF2B5EF4-FFF2-40B4-BE49-F238E27FC236}">
+                <a16:creationId xmlns:a16="http://schemas.microsoft.com/office/drawing/2014/main" id="{6F4D386A-EB7E-8B9F-F213-5AAB72238BEB}"/>
+              </a:ext>
+            </a:extLst>
+          </p:cNvPr>
+          <p:cNvSpPr>
+            <a:spLocks noGrp="1"/>
+          </p:cNvSpPr>
+          <p:nvPr>
+            <p:ph type="body" sz="quarter" idx="12"/>
+          </p:nvPr>
+        </p:nvSpPr>
+        <p:spPr/>
+        <p:txBody>
+          <a:bodyPr/>
+          <a:lstStyle/>
+          <a:p>
+            <a:r>
+              <a:rPr lang="en-US" dirty="0"/>
+              <a:t>Findings – </a:t>
+            </a:r>
+            <a:r>
+              <a:rPr lang="en-US" dirty="0">
+                <a:solidFill>
+                  <a:schemeClr val="accent3"/>
+                </a:solidFill>
+              </a:rPr>
+              <a:t>SECURITY </a:t>
+            </a:r>
+            <a:r>
+              <a:rPr lang="en-US"/>
+              <a:t>– </a:t>
+            </a:r>
+            <a:r>
+              <a:rPr lang="en-US">
+                <a:solidFill>
+                  <a:schemeClr val="accent3"/>
+                </a:solidFill>
+              </a:rPr>
+              <a:t>RESOLUTION TIMES</a:t>
+            </a:r>
+            <a:endParaRPr lang="en-US" dirty="0">
+              <a:solidFill>
+                <a:schemeClr val="accent3"/>
+              </a:solidFill>
+            </a:endParaRPr>
+          </a:p>
+        </p:txBody>
+      </p:sp>
+      <p:sp>
+        <p:nvSpPr>
+          <p:cNvPr id="6" name="Title 5">
+            <a:extLst>
+              <a:ext uri="{FF2B5EF4-FFF2-40B4-BE49-F238E27FC236}">
+                <a16:creationId xmlns:a16="http://schemas.microsoft.com/office/drawing/2014/main" id="{0CB3DF4B-7F1B-6565-0112-AF77D9AE5E9E}"/>
+              </a:ext>
+            </a:extLst>
+          </p:cNvPr>
+          <p:cNvSpPr>
+            <a:spLocks noGrp="1"/>
+          </p:cNvSpPr>
+          <p:nvPr>
+            <p:ph type="title"/>
+          </p:nvPr>
+        </p:nvSpPr>
+        <p:spPr/>
+        <p:txBody>
+          <a:bodyPr/>
+          <a:lstStyle/>
+          <a:p>
+            <a:r>
+              <a:rPr lang="en-US" noProof="0" dirty="0"/>
+              <a:t>@@</a:t>
+            </a:r>
+          </a:p>
+        </p:txBody>
+      </p:sp>
+      <p:sp>
+        <p:nvSpPr>
+          <p:cNvPr id="8" name="Content Placeholder 7">
+            <a:extLst>
+              <a:ext uri="{FF2B5EF4-FFF2-40B4-BE49-F238E27FC236}">
+                <a16:creationId xmlns:a16="http://schemas.microsoft.com/office/drawing/2014/main" id="{0AA92ECD-1BDA-FBEF-7C64-ECD0BA7B4BA3}"/>
+              </a:ext>
+            </a:extLst>
+          </p:cNvPr>
+          <p:cNvSpPr>
+            <a:spLocks noGrp="1"/>
+          </p:cNvSpPr>
+          <p:nvPr>
+            <p:ph sz="quarter" idx="13"/>
+          </p:nvPr>
+        </p:nvSpPr>
+        <p:spPr>
+          <a:xfrm>
+            <a:off x="514800" y="1368000"/>
+            <a:ext cx="11232000" cy="1658842"/>
+          </a:xfrm>
+        </p:spPr>
+        <p:txBody>
+          <a:bodyPr anchor="ctr"/>
+          <a:lstStyle/>
+          <a:p>
+            <a:pPr marL="0" indent="0">
+              <a:buNone/>
+            </a:pPr>
+            <a:r>
+              <a:rPr lang="en-US" sz="1400" noProof="0" dirty="0"/>
+              <a:t>@@</a:t>
+            </a:r>
+            <a:endParaRPr lang="en-US" sz="1200" noProof="0" dirty="0"/>
+          </a:p>
+        </p:txBody>
+      </p:sp>
+      <p:sp>
+        <p:nvSpPr>
+          <p:cNvPr id="28" name="TextBox 27">
+            <a:extLst>
+              <a:ext uri="{FF2B5EF4-FFF2-40B4-BE49-F238E27FC236}">
+                <a16:creationId xmlns:a16="http://schemas.microsoft.com/office/drawing/2014/main" id="{6F7F77EA-7E26-BE49-1757-A4CD9A5566EB}"/>
+              </a:ext>
+            </a:extLst>
+          </p:cNvPr>
+          <p:cNvSpPr txBox="1"/>
+          <p:nvPr/>
+        </p:nvSpPr>
+        <p:spPr>
+          <a:xfrm>
+            <a:off x="-1221448" y="4419492"/>
+            <a:ext cx="628847" cy="633443"/>
+          </a:xfrm>
+          <a:prstGeom prst="rect">
+            <a:avLst/>
+          </a:prstGeom>
+          <a:noFill/>
+        </p:spPr>
+        <p:txBody>
+          <a:bodyPr wrap="none" lIns="90000" rtlCol="0" anchor="t">
+            <a:spAutoFit/>
+          </a:bodyPr>
+          <a:lstStyle/>
+          <a:p>
+            <a:pPr algn="l">
+              <a:lnSpc>
+                <a:spcPct val="113000"/>
+              </a:lnSpc>
+            </a:pPr>
+            <a:r>
+              <a:rPr lang="en-US" sz="1600" dirty="0">
+                <a:solidFill>
+                  <a:schemeClr val="tx2"/>
+                </a:solidFill>
+              </a:rPr>
+              <a:t>3.12”</a:t>
+            </a:r>
+          </a:p>
+          <a:p>
+            <a:pPr algn="l">
+              <a:lnSpc>
+                <a:spcPct val="113000"/>
+              </a:lnSpc>
+            </a:pPr>
+            <a:r>
+              <a:rPr lang="en-US" sz="1600" dirty="0">
+                <a:solidFill>
+                  <a:schemeClr val="tx2"/>
+                </a:solidFill>
+              </a:rPr>
+              <a:t>9.57"</a:t>
+            </a:r>
+          </a:p>
+        </p:txBody>
+      </p:sp>
+      <p:sp>
+        <p:nvSpPr>
+          <p:cNvPr id="60" name="Triangle 59">
+            <a:extLst>
+              <a:ext uri="{FF2B5EF4-FFF2-40B4-BE49-F238E27FC236}">
+                <a16:creationId xmlns:a16="http://schemas.microsoft.com/office/drawing/2014/main" id="{0E164206-2345-E6D1-3746-641DBCAA683B}"/>
+              </a:ext>
+            </a:extLst>
+          </p:cNvPr>
+          <p:cNvSpPr/>
+          <p:nvPr/>
+        </p:nvSpPr>
+        <p:spPr>
+          <a:xfrm rot="5400000">
+            <a:off x="11223517" y="97630"/>
+            <a:ext cx="113704" cy="91353"/>
+          </a:xfrm>
+          <a:prstGeom prst="triangle">
+            <a:avLst/>
+          </a:prstGeom>
+          <a:solidFill>
+            <a:schemeClr val="tx2"/>
+          </a:solidFill>
+          <a:ln>
+            <a:noFill/>
+          </a:ln>
+        </p:spPr>
+        <p:style>
+          <a:lnRef idx="2">
+            <a:schemeClr val="accent1">
+              <a:shade val="50000"/>
+            </a:schemeClr>
+          </a:lnRef>
+          <a:fillRef idx="1">
+            <a:schemeClr val="accent1"/>
+          </a:fillRef>
+          <a:effectRef idx="0">
+            <a:schemeClr val="accent1"/>
+          </a:effectRef>
+          <a:fontRef idx="minor">
+            <a:schemeClr val="lt1"/>
+          </a:fontRef>
+        </p:style>
+        <p:txBody>
+          <a:bodyPr lIns="108000" tIns="72000" rIns="108000" bIns="72000" rtlCol="0" anchor="ctr"/>
+          <a:lstStyle/>
+          <a:p>
+            <a:pPr algn="ctr"/>
+            <a:endParaRPr lang="en-US" sz="1600">
+              <a:solidFill>
+                <a:schemeClr val="bg1"/>
+              </a:solidFill>
+            </a:endParaRPr>
+          </a:p>
+        </p:txBody>
+      </p:sp>
+      <p:pic>
+        <p:nvPicPr>
+          <p:cNvPr id="61" name="Picture 60">
+            <a:extLst>
+              <a:ext uri="{FF2B5EF4-FFF2-40B4-BE49-F238E27FC236}">
+                <a16:creationId xmlns:a16="http://schemas.microsoft.com/office/drawing/2014/main" id="{6786EE57-08F8-578E-A94E-4382E2E675E1}"/>
+              </a:ext>
+            </a:extLst>
+          </p:cNvPr>
+          <p:cNvPicPr>
+            <a:picLocks noChangeAspect="1"/>
+          </p:cNvPicPr>
+          <p:nvPr/>
+        </p:nvPicPr>
+        <p:blipFill>
+          <a:blip r:embed="rId2"/>
+          <a:stretch>
+            <a:fillRect/>
+          </a:stretch>
+        </p:blipFill>
+        <p:spPr>
+          <a:xfrm>
+            <a:off x="10267839" y="52613"/>
+            <a:ext cx="203103" cy="172639"/>
+          </a:xfrm>
+          <a:prstGeom prst="rect">
+            <a:avLst/>
+          </a:prstGeom>
+        </p:spPr>
+      </p:pic>
+      <p:sp>
+        <p:nvSpPr>
+          <p:cNvPr id="62" name="TextBox 61">
+            <a:extLst>
+              <a:ext uri="{FF2B5EF4-FFF2-40B4-BE49-F238E27FC236}">
+                <a16:creationId xmlns:a16="http://schemas.microsoft.com/office/drawing/2014/main" id="{9DD3010D-284B-FFE8-00DA-5B6B519F38C7}"/>
+              </a:ext>
+            </a:extLst>
+          </p:cNvPr>
+          <p:cNvSpPr txBox="1"/>
+          <p:nvPr/>
+        </p:nvSpPr>
+        <p:spPr>
+          <a:xfrm>
+            <a:off x="9145068" y="10898"/>
+            <a:ext cx="2110021" cy="264816"/>
+          </a:xfrm>
+          <a:prstGeom prst="rect">
+            <a:avLst/>
+          </a:prstGeom>
+          <a:noFill/>
+        </p:spPr>
+        <p:txBody>
+          <a:bodyPr wrap="none" lIns="90000" rtlCol="0" anchor="t">
+            <a:spAutoFit/>
+          </a:bodyPr>
+          <a:lstStyle/>
+          <a:p>
+            <a:pPr algn="r">
+              <a:lnSpc>
+                <a:spcPct val="113000"/>
+              </a:lnSpc>
+            </a:pPr>
+            <a:r>
+              <a:rPr lang="nl-NL" sz="1050" b="1" dirty="0" err="1">
+                <a:solidFill>
+                  <a:schemeClr val="bg1">
+                    <a:lumMod val="75000"/>
+                  </a:schemeClr>
+                </a:solidFill>
+              </a:rPr>
+              <a:t>PORTFOLIO_PERIOD_START_DATE</a:t>
+            </a:r>
+            <a:endParaRPr lang="nl-NL" sz="1050" b="1" dirty="0">
+              <a:solidFill>
+                <a:schemeClr val="bg1">
+                  <a:lumMod val="75000"/>
+                </a:schemeClr>
+              </a:solidFill>
+            </a:endParaRPr>
+          </a:p>
+        </p:txBody>
+      </p:sp>
+      <p:sp>
+        <p:nvSpPr>
+          <p:cNvPr id="63" name="TextBox 62">
+            <a:extLst>
+              <a:ext uri="{FF2B5EF4-FFF2-40B4-BE49-F238E27FC236}">
+                <a16:creationId xmlns:a16="http://schemas.microsoft.com/office/drawing/2014/main" id="{AAF65DDF-8D18-FC3B-861E-407B8366FA77}"/>
+              </a:ext>
+            </a:extLst>
+          </p:cNvPr>
+          <p:cNvSpPr txBox="1"/>
+          <p:nvPr/>
+        </p:nvSpPr>
+        <p:spPr>
+          <a:xfrm>
+            <a:off x="11305651" y="10898"/>
+            <a:ext cx="1993003" cy="264816"/>
+          </a:xfrm>
+          <a:prstGeom prst="rect">
+            <a:avLst/>
+          </a:prstGeom>
+          <a:noFill/>
+        </p:spPr>
+        <p:txBody>
+          <a:bodyPr wrap="none" lIns="90000" rtlCol="0" anchor="t">
+            <a:spAutoFit/>
+          </a:bodyPr>
+          <a:lstStyle/>
+          <a:p>
+            <a:pPr>
+              <a:lnSpc>
+                <a:spcPct val="113000"/>
+              </a:lnSpc>
+            </a:pPr>
+            <a:r>
+              <a:rPr lang="nl-NL" sz="1050" b="1" dirty="0" err="1">
+                <a:solidFill>
+                  <a:schemeClr val="tx2"/>
+                </a:solidFill>
+              </a:rPr>
+              <a:t>PORTFOLIO_PERIOD_END_DATE</a:t>
+            </a:r>
+            <a:endParaRPr lang="nl-NL" sz="1050" b="1" dirty="0">
+              <a:solidFill>
+                <a:schemeClr val="tx2"/>
+              </a:solidFill>
+            </a:endParaRPr>
+          </a:p>
+        </p:txBody>
+      </p:sp>
+      <p:grpSp>
+        <p:nvGrpSpPr>
+          <p:cNvPr id="64" name="Group 63">
+            <a:extLst>
+              <a:ext uri="{FF2B5EF4-FFF2-40B4-BE49-F238E27FC236}">
+                <a16:creationId xmlns:a16="http://schemas.microsoft.com/office/drawing/2014/main" id="{C15C3881-1CF2-F1D2-4215-9BE451E8DB22}"/>
+              </a:ext>
+            </a:extLst>
+          </p:cNvPr>
+          <p:cNvGrpSpPr>
+            <a:grpSpLocks noChangeAspect="1"/>
+          </p:cNvGrpSpPr>
+          <p:nvPr/>
+        </p:nvGrpSpPr>
+        <p:grpSpPr>
+          <a:xfrm>
+            <a:off x="-392105" y="2517185"/>
+            <a:ext cx="98115" cy="92576"/>
+            <a:chOff x="-331054" y="2564812"/>
+            <a:chExt cx="141517" cy="133528"/>
+          </a:xfrm>
+          <a:solidFill>
+            <a:srgbClr val="57C968"/>
+          </a:solidFill>
+        </p:grpSpPr>
+        <p:sp>
+          <p:nvSpPr>
+            <p:cNvPr id="65" name="Freeform 64">
+              <a:extLst>
+                <a:ext uri="{FF2B5EF4-FFF2-40B4-BE49-F238E27FC236}">
+                  <a16:creationId xmlns:a16="http://schemas.microsoft.com/office/drawing/2014/main" id="{0301DAEA-569B-4BFD-ADCC-7840C9E2C91C}"/>
+                </a:ext>
+              </a:extLst>
+            </p:cNvPr>
+            <p:cNvSpPr/>
+            <p:nvPr/>
+          </p:nvSpPr>
+          <p:spPr>
+            <a:xfrm>
+              <a:off x="-331054" y="2564812"/>
+              <a:ext cx="141517" cy="82436"/>
+            </a:xfrm>
+            <a:custGeom>
+              <a:avLst/>
+              <a:gdLst>
+                <a:gd name="connsiteX0" fmla="*/ 70759 w 141517"/>
+                <a:gd name="connsiteY0" fmla="*/ 0 h 82436"/>
+                <a:gd name="connsiteX1" fmla="*/ 141517 w 141517"/>
+                <a:gd name="connsiteY1" fmla="*/ 82436 h 82436"/>
+                <a:gd name="connsiteX2" fmla="*/ 111805 w 141517"/>
+                <a:gd name="connsiteY2" fmla="*/ 82436 h 82436"/>
+                <a:gd name="connsiteX3" fmla="*/ 70759 w 141517"/>
+                <a:gd name="connsiteY3" fmla="*/ 34616 h 82436"/>
+                <a:gd name="connsiteX4" fmla="*/ 29713 w 141517"/>
+                <a:gd name="connsiteY4" fmla="*/ 82436 h 82436"/>
+                <a:gd name="connsiteX5" fmla="*/ 0 w 141517"/>
+                <a:gd name="connsiteY5" fmla="*/ 82436 h 82436"/>
+              </a:gdLst>
+              <a:ahLst/>
+              <a:cxnLst>
+                <a:cxn ang="0">
+                  <a:pos x="connsiteX0" y="connsiteY0"/>
+                </a:cxn>
+                <a:cxn ang="0">
+                  <a:pos x="connsiteX1" y="connsiteY1"/>
+                </a:cxn>
+                <a:cxn ang="0">
+                  <a:pos x="connsiteX2" y="connsiteY2"/>
+                </a:cxn>
+                <a:cxn ang="0">
+                  <a:pos x="connsiteX3" y="connsiteY3"/>
+                </a:cxn>
+                <a:cxn ang="0">
+                  <a:pos x="connsiteX4" y="connsiteY4"/>
+                </a:cxn>
+                <a:cxn ang="0">
+                  <a:pos x="connsiteX5" y="connsiteY5"/>
+                </a:cxn>
+              </a:cxnLst>
+              <a:rect l="l" t="t" r="r" b="b"/>
+              <a:pathLst>
+                <a:path w="141517" h="82436">
+                  <a:moveTo>
+                    <a:pt x="70759" y="0"/>
+                  </a:moveTo>
+                  <a:lnTo>
+                    <a:pt x="141517" y="82436"/>
+                  </a:lnTo>
+                  <a:lnTo>
+                    <a:pt x="111805" y="82436"/>
+                  </a:lnTo>
+                  <a:lnTo>
+                    <a:pt x="70759" y="34616"/>
+                  </a:lnTo>
+                  <a:lnTo>
+                    <a:pt x="29713" y="82436"/>
+                  </a:lnTo>
+                  <a:lnTo>
+                    <a:pt x="0" y="82436"/>
+                  </a:lnTo>
+                  <a:close/>
+                </a:path>
+              </a:pathLst>
+            </a:custGeom>
+            <a:grpFill/>
+            <a:ln>
+              <a:noFill/>
+            </a:ln>
+          </p:spPr>
+          <p:style>
+            <a:lnRef idx="2">
+              <a:schemeClr val="accent1">
+                <a:shade val="50000"/>
+              </a:schemeClr>
+            </a:lnRef>
+            <a:fillRef idx="1">
+              <a:schemeClr val="accent1"/>
+            </a:fillRef>
+            <a:effectRef idx="0">
+              <a:schemeClr val="accent1"/>
+            </a:effectRef>
+            <a:fontRef idx="minor">
+              <a:schemeClr val="lt1"/>
+            </a:fontRef>
+          </p:style>
+          <p:txBody>
+            <a:bodyPr wrap="square" lIns="108000" tIns="72000" rIns="108000" bIns="72000" rtlCol="0" anchor="ctr">
+              <a:noAutofit/>
+            </a:bodyPr>
+            <a:lstStyle/>
+            <a:p>
+              <a:pPr algn="ctr"/>
+              <a:endParaRPr lang="en-US" sz="1600" err="1">
+                <a:solidFill>
+                  <a:schemeClr val="bg1"/>
+                </a:solidFill>
+              </a:endParaRPr>
+            </a:p>
+          </p:txBody>
+        </p:sp>
+        <p:sp>
+          <p:nvSpPr>
+            <p:cNvPr id="66" name="Triangle 65">
+              <a:extLst>
+                <a:ext uri="{FF2B5EF4-FFF2-40B4-BE49-F238E27FC236}">
+                  <a16:creationId xmlns:a16="http://schemas.microsoft.com/office/drawing/2014/main" id="{BF2D4EA4-AC1B-DA7D-2EDB-28604D9FA58C}"/>
+                </a:ext>
+              </a:extLst>
+            </p:cNvPr>
+            <p:cNvSpPr/>
+            <p:nvPr/>
+          </p:nvSpPr>
+          <p:spPr>
+            <a:xfrm>
+              <a:off x="-331054" y="2615904"/>
+              <a:ext cx="141517" cy="82436"/>
+            </a:xfrm>
+            <a:prstGeom prst="triangle">
+              <a:avLst/>
+            </a:prstGeom>
+            <a:grpFill/>
+            <a:ln>
+              <a:noFill/>
+            </a:ln>
+          </p:spPr>
+          <p:style>
+            <a:lnRef idx="2">
+              <a:schemeClr val="accent1">
+                <a:shade val="50000"/>
+              </a:schemeClr>
+            </a:lnRef>
+            <a:fillRef idx="1">
+              <a:schemeClr val="accent1"/>
+            </a:fillRef>
+            <a:effectRef idx="0">
+              <a:schemeClr val="accent1"/>
+            </a:effectRef>
+            <a:fontRef idx="minor">
+              <a:schemeClr val="lt1"/>
+            </a:fontRef>
+          </p:style>
+          <p:txBody>
+            <a:bodyPr lIns="108000" tIns="72000" rIns="108000" bIns="72000" rtlCol="0" anchor="ctr"/>
+            <a:lstStyle/>
+            <a:p>
+              <a:pPr algn="ctr"/>
+              <a:endParaRPr lang="en-US" sz="1600" err="1">
+                <a:solidFill>
+                  <a:schemeClr val="bg1"/>
+                </a:solidFill>
+              </a:endParaRPr>
+            </a:p>
+          </p:txBody>
+        </p:sp>
+      </p:grpSp>
+      <p:grpSp>
+        <p:nvGrpSpPr>
+          <p:cNvPr id="67" name="Group 66">
+            <a:extLst>
+              <a:ext uri="{FF2B5EF4-FFF2-40B4-BE49-F238E27FC236}">
+                <a16:creationId xmlns:a16="http://schemas.microsoft.com/office/drawing/2014/main" id="{A5B5F588-AE14-1A44-72CB-7290D2B83CA1}"/>
+              </a:ext>
+            </a:extLst>
+          </p:cNvPr>
+          <p:cNvGrpSpPr>
+            <a:grpSpLocks noChangeAspect="1"/>
+          </p:cNvGrpSpPr>
+          <p:nvPr/>
+        </p:nvGrpSpPr>
+        <p:grpSpPr>
+          <a:xfrm rot="10800000">
+            <a:off x="-392106" y="2948284"/>
+            <a:ext cx="98115" cy="92576"/>
+            <a:chOff x="-331054" y="2564812"/>
+            <a:chExt cx="141517" cy="133528"/>
+          </a:xfrm>
+          <a:solidFill>
+            <a:srgbClr val="FFC000"/>
+          </a:solidFill>
+        </p:grpSpPr>
+        <p:sp>
+          <p:nvSpPr>
+            <p:cNvPr id="68" name="Freeform 67">
+              <a:extLst>
+                <a:ext uri="{FF2B5EF4-FFF2-40B4-BE49-F238E27FC236}">
+                  <a16:creationId xmlns:a16="http://schemas.microsoft.com/office/drawing/2014/main" id="{64C617FB-D78D-A196-6ADD-360D8179B451}"/>
+                </a:ext>
+              </a:extLst>
+            </p:cNvPr>
+            <p:cNvSpPr/>
+            <p:nvPr/>
+          </p:nvSpPr>
+          <p:spPr>
+            <a:xfrm>
+              <a:off x="-331054" y="2564812"/>
+              <a:ext cx="141517" cy="82436"/>
+            </a:xfrm>
+            <a:custGeom>
+              <a:avLst/>
+              <a:gdLst>
+                <a:gd name="connsiteX0" fmla="*/ 70759 w 141517"/>
+                <a:gd name="connsiteY0" fmla="*/ 0 h 82436"/>
+                <a:gd name="connsiteX1" fmla="*/ 141517 w 141517"/>
+                <a:gd name="connsiteY1" fmla="*/ 82436 h 82436"/>
+                <a:gd name="connsiteX2" fmla="*/ 111805 w 141517"/>
+                <a:gd name="connsiteY2" fmla="*/ 82436 h 82436"/>
+                <a:gd name="connsiteX3" fmla="*/ 70759 w 141517"/>
+                <a:gd name="connsiteY3" fmla="*/ 34616 h 82436"/>
+                <a:gd name="connsiteX4" fmla="*/ 29713 w 141517"/>
+                <a:gd name="connsiteY4" fmla="*/ 82436 h 82436"/>
+                <a:gd name="connsiteX5" fmla="*/ 0 w 141517"/>
+                <a:gd name="connsiteY5" fmla="*/ 82436 h 82436"/>
+              </a:gdLst>
+              <a:ahLst/>
+              <a:cxnLst>
+                <a:cxn ang="0">
+                  <a:pos x="connsiteX0" y="connsiteY0"/>
+                </a:cxn>
+                <a:cxn ang="0">
+                  <a:pos x="connsiteX1" y="connsiteY1"/>
+                </a:cxn>
+                <a:cxn ang="0">
+                  <a:pos x="connsiteX2" y="connsiteY2"/>
+                </a:cxn>
+                <a:cxn ang="0">
+                  <a:pos x="connsiteX3" y="connsiteY3"/>
+                </a:cxn>
+                <a:cxn ang="0">
+                  <a:pos x="connsiteX4" y="connsiteY4"/>
+                </a:cxn>
+                <a:cxn ang="0">
+                  <a:pos x="connsiteX5" y="connsiteY5"/>
+                </a:cxn>
+              </a:cxnLst>
+              <a:rect l="l" t="t" r="r" b="b"/>
+              <a:pathLst>
+                <a:path w="141517" h="82436">
+                  <a:moveTo>
+                    <a:pt x="70759" y="0"/>
+                  </a:moveTo>
+                  <a:lnTo>
+                    <a:pt x="141517" y="82436"/>
+                  </a:lnTo>
+                  <a:lnTo>
+                    <a:pt x="111805" y="82436"/>
+                  </a:lnTo>
+                  <a:lnTo>
+                    <a:pt x="70759" y="34616"/>
+                  </a:lnTo>
+                  <a:lnTo>
+                    <a:pt x="29713" y="82436"/>
+                  </a:lnTo>
+                  <a:lnTo>
+                    <a:pt x="0" y="82436"/>
+                  </a:lnTo>
+                  <a:close/>
+                </a:path>
+              </a:pathLst>
+            </a:custGeom>
+            <a:grpFill/>
+            <a:ln>
+              <a:noFill/>
+            </a:ln>
+          </p:spPr>
+          <p:style>
+            <a:lnRef idx="2">
+              <a:schemeClr val="accent1">
+                <a:shade val="50000"/>
+              </a:schemeClr>
+            </a:lnRef>
+            <a:fillRef idx="1">
+              <a:schemeClr val="accent1"/>
+            </a:fillRef>
+            <a:effectRef idx="0">
+              <a:schemeClr val="accent1"/>
+            </a:effectRef>
+            <a:fontRef idx="minor">
+              <a:schemeClr val="lt1"/>
+            </a:fontRef>
+          </p:style>
+          <p:txBody>
+            <a:bodyPr wrap="square" lIns="108000" tIns="72000" rIns="108000" bIns="72000" rtlCol="0" anchor="ctr">
+              <a:noAutofit/>
+            </a:bodyPr>
+            <a:lstStyle/>
+            <a:p>
+              <a:pPr algn="ctr"/>
+              <a:endParaRPr lang="en-US" sz="1600" err="1">
+                <a:solidFill>
+                  <a:schemeClr val="bg1"/>
+                </a:solidFill>
+              </a:endParaRPr>
+            </a:p>
+          </p:txBody>
+        </p:sp>
+        <p:sp>
+          <p:nvSpPr>
+            <p:cNvPr id="69" name="Triangle 68">
+              <a:extLst>
+                <a:ext uri="{FF2B5EF4-FFF2-40B4-BE49-F238E27FC236}">
+                  <a16:creationId xmlns:a16="http://schemas.microsoft.com/office/drawing/2014/main" id="{3663B325-18F9-3426-D584-BA9F7DB8CABE}"/>
+                </a:ext>
+              </a:extLst>
+            </p:cNvPr>
+            <p:cNvSpPr/>
+            <p:nvPr/>
+          </p:nvSpPr>
+          <p:spPr>
+            <a:xfrm>
+              <a:off x="-331054" y="2615904"/>
+              <a:ext cx="141517" cy="82436"/>
+            </a:xfrm>
+            <a:prstGeom prst="triangle">
+              <a:avLst/>
+            </a:prstGeom>
+            <a:grpFill/>
+            <a:ln>
+              <a:noFill/>
+            </a:ln>
+          </p:spPr>
+          <p:style>
+            <a:lnRef idx="2">
+              <a:schemeClr val="accent1">
+                <a:shade val="50000"/>
+              </a:schemeClr>
+            </a:lnRef>
+            <a:fillRef idx="1">
+              <a:schemeClr val="accent1"/>
+            </a:fillRef>
+            <a:effectRef idx="0">
+              <a:schemeClr val="accent1"/>
+            </a:effectRef>
+            <a:fontRef idx="minor">
+              <a:schemeClr val="lt1"/>
+            </a:fontRef>
+          </p:style>
+          <p:txBody>
+            <a:bodyPr lIns="108000" tIns="72000" rIns="108000" bIns="72000" rtlCol="0" anchor="ctr"/>
+            <a:lstStyle/>
+            <a:p>
+              <a:pPr algn="ctr"/>
+              <a:endParaRPr lang="en-US" sz="1600" err="1">
+                <a:solidFill>
+                  <a:schemeClr val="bg1"/>
+                </a:solidFill>
+              </a:endParaRPr>
+            </a:p>
+          </p:txBody>
+        </p:sp>
+      </p:grpSp>
+      <p:sp>
+        <p:nvSpPr>
+          <p:cNvPr id="32" name="Rectangle 31">
+            <a:extLst>
+              <a:ext uri="{FF2B5EF4-FFF2-40B4-BE49-F238E27FC236}">
+                <a16:creationId xmlns:a16="http://schemas.microsoft.com/office/drawing/2014/main" id="{B04A86CB-042C-A526-AA66-032348B7C9D9}"/>
+              </a:ext>
+            </a:extLst>
+          </p:cNvPr>
+          <p:cNvSpPr/>
+          <p:nvPr/>
+        </p:nvSpPr>
+        <p:spPr>
+          <a:xfrm>
+            <a:off x="1" y="3154680"/>
+            <a:ext cx="12191999" cy="3163320"/>
+          </a:xfrm>
+          <a:prstGeom prst="rect">
+            <a:avLst/>
+          </a:prstGeom>
+          <a:gradFill>
+            <a:gsLst>
+              <a:gs pos="0">
+                <a:schemeClr val="bg1"/>
+              </a:gs>
+              <a:gs pos="100000">
+                <a:schemeClr val="bg2"/>
+              </a:gs>
+            </a:gsLst>
+            <a:lin ang="2700000" scaled="0"/>
+          </a:gradFill>
+          <a:ln>
+            <a:noFill/>
+          </a:ln>
+          <a:effectLst>
+            <a:outerShdw blurRad="190500" dist="38100" dir="2700000" algn="tl" rotWithShape="0">
+              <a:prstClr val="black">
+                <a:alpha val="15000"/>
+              </a:prstClr>
+            </a:outerShdw>
+          </a:effectLst>
+        </p:spPr>
+        <p:style>
+          <a:lnRef idx="2">
+            <a:schemeClr val="accent1">
+              <a:shade val="50000"/>
+            </a:schemeClr>
+          </a:lnRef>
+          <a:fillRef idx="1">
+            <a:schemeClr val="accent1"/>
+          </a:fillRef>
+          <a:effectRef idx="0">
+            <a:schemeClr val="accent1"/>
+          </a:effectRef>
+          <a:fontRef idx="minor">
+            <a:schemeClr val="lt1"/>
+          </a:fontRef>
+        </p:style>
+        <p:txBody>
+          <a:bodyPr lIns="731520" tIns="72000" rIns="108000" bIns="72000" rtlCol="0" anchor="ctr"/>
+          <a:lstStyle/>
+          <a:p>
+            <a:endParaRPr lang="nl-NL" sz="1200" b="1" noProof="0" dirty="0">
+              <a:solidFill>
+                <a:schemeClr val="accent1"/>
+              </a:solidFill>
+            </a:endParaRPr>
+          </a:p>
+        </p:txBody>
+      </p:sp>
+      <p:sp>
+        <p:nvSpPr>
+          <p:cNvPr id="49" name="Rounded Rectangle 48">
+            <a:extLst>
+              <a:ext uri="{FF2B5EF4-FFF2-40B4-BE49-F238E27FC236}">
+                <a16:creationId xmlns:a16="http://schemas.microsoft.com/office/drawing/2014/main" id="{CD49DD0C-66C3-9266-E636-A03AE7C9DFA7}"/>
+              </a:ext>
+            </a:extLst>
+          </p:cNvPr>
+          <p:cNvSpPr/>
+          <p:nvPr/>
+        </p:nvSpPr>
+        <p:spPr>
+          <a:xfrm>
+            <a:off x="207002" y="3495726"/>
+            <a:ext cx="11984997" cy="2575216"/>
+          </a:xfrm>
+          <a:prstGeom prst="roundRect">
+            <a:avLst>
+              <a:gd name="adj" fmla="val 7068"/>
+            </a:avLst>
+          </a:prstGeom>
+          <a:gradFill>
+            <a:gsLst>
+              <a:gs pos="0">
+                <a:schemeClr val="bg1"/>
+              </a:gs>
+              <a:gs pos="100000">
+                <a:schemeClr val="bg2"/>
+              </a:gs>
+            </a:gsLst>
+            <a:lin ang="2700000" scaled="0"/>
+          </a:gradFill>
+          <a:ln>
+            <a:noFill/>
+          </a:ln>
+          <a:effectLst>
+            <a:outerShdw blurRad="190500" dist="38100" dir="2700000" algn="tl" rotWithShape="0">
+              <a:prstClr val="black">
+                <a:alpha val="15000"/>
+              </a:prstClr>
+            </a:outerShdw>
+          </a:effectLst>
+        </p:spPr>
+        <p:style>
+          <a:lnRef idx="2">
+            <a:schemeClr val="accent1">
+              <a:shade val="50000"/>
+            </a:schemeClr>
+          </a:lnRef>
+          <a:fillRef idx="1">
+            <a:schemeClr val="accent1"/>
+          </a:fillRef>
+          <a:effectRef idx="0">
+            <a:schemeClr val="accent1"/>
+          </a:effectRef>
+          <a:fontRef idx="minor">
+            <a:schemeClr val="lt1"/>
+          </a:fontRef>
+        </p:style>
+        <p:txBody>
+          <a:bodyPr vert="vert270" lIns="0" tIns="73152" rIns="0" bIns="73152" rtlCol="0" anchor="t"/>
+          <a:lstStyle/>
+          <a:p>
+            <a:pPr algn="ctr"/>
+            <a:r>
+              <a:rPr lang="en-US" sz="1200" b="1" noProof="0" dirty="0">
+                <a:solidFill>
+                  <a:schemeClr val="accent1"/>
+                </a:solidFill>
+              </a:rPr>
+              <a:t>Open and resolved findings</a:t>
+            </a:r>
+          </a:p>
+        </p:txBody>
+      </p:sp>
+      <p:pic>
+        <p:nvPicPr>
+          <p:cNvPr id="34" name="Graphic 33">
+            <a:extLst>
+              <a:ext uri="{FF2B5EF4-FFF2-40B4-BE49-F238E27FC236}">
+                <a16:creationId xmlns:a16="http://schemas.microsoft.com/office/drawing/2014/main" id="{B102D423-A941-90C8-5743-AA30ED2966A7}"/>
+              </a:ext>
+            </a:extLst>
+          </p:cNvPr>
+          <p:cNvPicPr>
+            <a:picLocks noChangeAspect="1"/>
+          </p:cNvPicPr>
+          <p:nvPr/>
+        </p:nvPicPr>
+        <p:blipFill>
+          <a:blip r:embed="rId3">
+            <a:extLst>
+              <a:ext uri="{96DAC541-7B7A-43D3-8B79-37D633B846F1}">
+                <asvg:svgBlip xmlns:asvg="http://schemas.microsoft.com/office/drawing/2016/SVG/main" r:embed="rId4"/>
+              </a:ext>
+            </a:extLst>
+          </a:blip>
+          <a:stretch>
+            <a:fillRect/>
+          </a:stretch>
+        </p:blipFill>
+        <p:spPr>
+          <a:xfrm>
+            <a:off x="11773775" y="5803314"/>
+            <a:ext cx="371130" cy="206558"/>
+          </a:xfrm>
+          <a:prstGeom prst="rect">
+            <a:avLst/>
+          </a:prstGeom>
+        </p:spPr>
+      </p:pic>
+      <p:sp>
+        <p:nvSpPr>
+          <p:cNvPr id="46" name="Rounded Rectangle 45">
+            <a:extLst>
+              <a:ext uri="{FF2B5EF4-FFF2-40B4-BE49-F238E27FC236}">
+                <a16:creationId xmlns:a16="http://schemas.microsoft.com/office/drawing/2014/main" id="{67C0D00E-17C9-7B3E-1EE5-6A1653E68281}"/>
+              </a:ext>
+            </a:extLst>
+          </p:cNvPr>
+          <p:cNvSpPr/>
+          <p:nvPr/>
+        </p:nvSpPr>
+        <p:spPr>
+          <a:xfrm flipH="1">
+            <a:off x="609944" y="3237334"/>
+            <a:ext cx="3612958" cy="2953323"/>
+          </a:xfrm>
+          <a:prstGeom prst="roundRect">
+            <a:avLst>
+              <a:gd name="adj" fmla="val 3988"/>
+            </a:avLst>
+          </a:prstGeom>
+          <a:gradFill>
+            <a:gsLst>
+              <a:gs pos="0">
+                <a:schemeClr val="bg1"/>
+              </a:gs>
+              <a:gs pos="100000">
+                <a:schemeClr val="bg2"/>
+              </a:gs>
+            </a:gsLst>
+            <a:lin ang="2700000" scaled="0"/>
+          </a:gradFill>
+          <a:ln>
+            <a:noFill/>
+          </a:ln>
+          <a:effectLst>
+            <a:outerShdw blurRad="190500" dist="38100" dir="2700000" algn="tl" rotWithShape="0">
+              <a:prstClr val="black">
+                <a:alpha val="15000"/>
+              </a:prstClr>
+            </a:outerShdw>
+          </a:effectLst>
+        </p:spPr>
+        <p:style>
+          <a:lnRef idx="2">
+            <a:schemeClr val="accent1">
+              <a:shade val="50000"/>
+            </a:schemeClr>
+          </a:lnRef>
+          <a:fillRef idx="1">
+            <a:schemeClr val="accent1"/>
+          </a:fillRef>
+          <a:effectRef idx="0">
+            <a:schemeClr val="accent1"/>
+          </a:effectRef>
+          <a:fontRef idx="minor">
+            <a:schemeClr val="lt1"/>
+          </a:fontRef>
+        </p:style>
+        <p:txBody>
+          <a:bodyPr lIns="73152" tIns="0" rIns="73152" bIns="0" rtlCol="0" anchor="t"/>
+          <a:lstStyle/>
+          <a:p>
+            <a:pPr algn="ctr"/>
+            <a:r>
+              <a:rPr lang="nl-NL" sz="1200" b="1" noProof="0" dirty="0">
+                <a:solidFill>
+                  <a:srgbClr val="910714"/>
+                </a:solidFill>
+              </a:rPr>
+              <a:t>Critical</a:t>
+            </a:r>
+          </a:p>
+        </p:txBody>
+      </p:sp>
+      <p:sp>
+        <p:nvSpPr>
+          <p:cNvPr id="47" name="Rounded Rectangle 46">
+            <a:extLst>
+              <a:ext uri="{FF2B5EF4-FFF2-40B4-BE49-F238E27FC236}">
+                <a16:creationId xmlns:a16="http://schemas.microsoft.com/office/drawing/2014/main" id="{687937C5-61E6-B270-981B-2D0C53A4713E}"/>
+              </a:ext>
+            </a:extLst>
+          </p:cNvPr>
+          <p:cNvSpPr/>
+          <p:nvPr/>
+        </p:nvSpPr>
+        <p:spPr>
+          <a:xfrm flipH="1">
+            <a:off x="4373475" y="3237334"/>
+            <a:ext cx="3610810" cy="2953323"/>
+          </a:xfrm>
+          <a:prstGeom prst="roundRect">
+            <a:avLst>
+              <a:gd name="adj" fmla="val 3987"/>
+            </a:avLst>
+          </a:prstGeom>
+          <a:gradFill>
+            <a:gsLst>
+              <a:gs pos="0">
+                <a:schemeClr val="bg1"/>
+              </a:gs>
+              <a:gs pos="100000">
+                <a:schemeClr val="bg2"/>
+              </a:gs>
+            </a:gsLst>
+            <a:lin ang="2700000" scaled="0"/>
+          </a:gradFill>
+          <a:ln>
+            <a:noFill/>
+          </a:ln>
+          <a:effectLst>
+            <a:outerShdw blurRad="190500" dist="38100" dir="2700000" algn="tl" rotWithShape="0">
+              <a:prstClr val="black">
+                <a:alpha val="15000"/>
+              </a:prstClr>
+            </a:outerShdw>
+          </a:effectLst>
+        </p:spPr>
+        <p:style>
+          <a:lnRef idx="2">
+            <a:schemeClr val="accent1">
+              <a:shade val="50000"/>
+            </a:schemeClr>
+          </a:lnRef>
+          <a:fillRef idx="1">
+            <a:schemeClr val="accent1"/>
+          </a:fillRef>
+          <a:effectRef idx="0">
+            <a:schemeClr val="accent1"/>
+          </a:effectRef>
+          <a:fontRef idx="minor">
+            <a:schemeClr val="lt1"/>
+          </a:fontRef>
+        </p:style>
+        <p:txBody>
+          <a:bodyPr lIns="73152" tIns="0" rIns="73152" bIns="0" rtlCol="0" anchor="t"/>
+          <a:lstStyle/>
+          <a:p>
+            <a:pPr algn="ctr"/>
+            <a:r>
+              <a:rPr lang="nl-NL" sz="1200" b="1" noProof="0" dirty="0">
+                <a:solidFill>
+                  <a:srgbClr val="DB4A3D"/>
+                </a:solidFill>
+              </a:rPr>
+              <a:t>High</a:t>
+            </a:r>
+          </a:p>
+        </p:txBody>
+      </p:sp>
+      <p:sp>
+        <p:nvSpPr>
+          <p:cNvPr id="48" name="Rounded Rectangle 47">
+            <a:extLst>
+              <a:ext uri="{FF2B5EF4-FFF2-40B4-BE49-F238E27FC236}">
+                <a16:creationId xmlns:a16="http://schemas.microsoft.com/office/drawing/2014/main" id="{425C641F-B66E-DC80-C38D-822A10B95814}"/>
+              </a:ext>
+            </a:extLst>
+          </p:cNvPr>
+          <p:cNvSpPr/>
+          <p:nvPr/>
+        </p:nvSpPr>
+        <p:spPr>
+          <a:xfrm flipH="1">
+            <a:off x="8134857" y="3237334"/>
+            <a:ext cx="3610810" cy="2953323"/>
+          </a:xfrm>
+          <a:prstGeom prst="roundRect">
+            <a:avLst>
+              <a:gd name="adj" fmla="val 3837"/>
+            </a:avLst>
+          </a:prstGeom>
+          <a:gradFill>
+            <a:gsLst>
+              <a:gs pos="0">
+                <a:schemeClr val="bg1"/>
+              </a:gs>
+              <a:gs pos="100000">
+                <a:schemeClr val="bg2"/>
+              </a:gs>
+            </a:gsLst>
+            <a:lin ang="2700000" scaled="0"/>
+          </a:gradFill>
+          <a:ln>
+            <a:noFill/>
+          </a:ln>
+          <a:effectLst>
+            <a:outerShdw blurRad="190500" dist="38100" dir="2700000" algn="tl" rotWithShape="0">
+              <a:prstClr val="black">
+                <a:alpha val="15000"/>
+              </a:prstClr>
+            </a:outerShdw>
+          </a:effectLst>
+        </p:spPr>
+        <p:style>
+          <a:lnRef idx="2">
+            <a:schemeClr val="accent1">
+              <a:shade val="50000"/>
+            </a:schemeClr>
+          </a:lnRef>
+          <a:fillRef idx="1">
+            <a:schemeClr val="accent1"/>
+          </a:fillRef>
+          <a:effectRef idx="0">
+            <a:schemeClr val="accent1"/>
+          </a:effectRef>
+          <a:fontRef idx="minor">
+            <a:schemeClr val="lt1"/>
+          </a:fontRef>
+        </p:style>
+        <p:txBody>
+          <a:bodyPr lIns="73152" tIns="0" rIns="73152" bIns="0" rtlCol="0" anchor="t"/>
+          <a:lstStyle/>
+          <a:p>
+            <a:pPr algn="ctr"/>
+            <a:r>
+              <a:rPr lang="nl-NL" sz="1200" b="1" noProof="0" dirty="0">
+                <a:solidFill>
+                  <a:srgbClr val="F09819"/>
+                </a:solidFill>
+              </a:rPr>
+              <a:t>Medium</a:t>
+            </a:r>
+          </a:p>
+        </p:txBody>
+      </p:sp>
+      <p:sp>
+        <p:nvSpPr>
+          <p:cNvPr id="4" name="Rectangle 3">
+            <a:extLst>
+              <a:ext uri="{FF2B5EF4-FFF2-40B4-BE49-F238E27FC236}">
+                <a16:creationId xmlns:a16="http://schemas.microsoft.com/office/drawing/2014/main" id="{0D5B4458-7A18-6975-596A-37B01EA5C4A6}"/>
+              </a:ext>
+            </a:extLst>
+          </p:cNvPr>
+          <p:cNvSpPr/>
+          <p:nvPr/>
+        </p:nvSpPr>
+        <p:spPr>
+          <a:xfrm>
+            <a:off x="766866" y="3612456"/>
+            <a:ext cx="3299114" cy="2341757"/>
+          </a:xfrm>
+          <a:prstGeom prst="rect">
+            <a:avLst/>
+          </a:prstGeom>
+          <a:solidFill>
+            <a:srgbClr val="F0089F"/>
+          </a:solidFill>
+          <a:ln>
+            <a:noFill/>
+          </a:ln>
+        </p:spPr>
+        <p:style>
+          <a:lnRef idx="2">
+            <a:schemeClr val="accent1">
+              <a:shade val="50000"/>
+            </a:schemeClr>
+          </a:lnRef>
+          <a:fillRef idx="1">
+            <a:schemeClr val="accent1"/>
+          </a:fillRef>
+          <a:effectRef idx="0">
+            <a:schemeClr val="accent1"/>
+          </a:effectRef>
+          <a:fontRef idx="minor">
+            <a:schemeClr val="lt1"/>
+          </a:fontRef>
+        </p:style>
+        <p:txBody>
+          <a:bodyPr lIns="108000" tIns="72000" rIns="108000" bIns="72000" rtlCol="0" anchor="ctr"/>
+          <a:lstStyle/>
+          <a:p>
+            <a:pPr algn="ctr"/>
+            <a:r>
+              <a:rPr lang="en-US" sz="1600" dirty="0" err="1">
+                <a:solidFill>
+                  <a:schemeClr val="bg1"/>
+                </a:solidFill>
+              </a:rPr>
+              <a:t>PORTFOLIO_PERIOD_SECURITY_DASHBOARD_CRITICAL_RESOLUTION_TIMES</a:t>
+            </a:r>
+            <a:endParaRPr lang="en-US" sz="1600" dirty="0">
+              <a:solidFill>
+                <a:schemeClr val="bg1"/>
+              </a:solidFill>
+            </a:endParaRPr>
+          </a:p>
+        </p:txBody>
+      </p:sp>
+      <p:sp>
+        <p:nvSpPr>
+          <p:cNvPr id="5" name="Rectangle 4">
+            <a:extLst>
+              <a:ext uri="{FF2B5EF4-FFF2-40B4-BE49-F238E27FC236}">
+                <a16:creationId xmlns:a16="http://schemas.microsoft.com/office/drawing/2014/main" id="{F1F42F13-AC84-E68B-5231-2D1D16BF93F2}"/>
+              </a:ext>
+            </a:extLst>
+          </p:cNvPr>
+          <p:cNvSpPr/>
+          <p:nvPr/>
+        </p:nvSpPr>
+        <p:spPr>
+          <a:xfrm>
+            <a:off x="4529323" y="3612456"/>
+            <a:ext cx="3299114" cy="2341757"/>
+          </a:xfrm>
+          <a:prstGeom prst="rect">
+            <a:avLst/>
+          </a:prstGeom>
+          <a:solidFill>
+            <a:srgbClr val="F0089F"/>
+          </a:solidFill>
+          <a:ln>
+            <a:noFill/>
+          </a:ln>
+        </p:spPr>
+        <p:style>
+          <a:lnRef idx="2">
+            <a:schemeClr val="accent1">
+              <a:shade val="50000"/>
+            </a:schemeClr>
+          </a:lnRef>
+          <a:fillRef idx="1">
+            <a:schemeClr val="accent1"/>
+          </a:fillRef>
+          <a:effectRef idx="0">
+            <a:schemeClr val="accent1"/>
+          </a:effectRef>
+          <a:fontRef idx="minor">
+            <a:schemeClr val="lt1"/>
+          </a:fontRef>
+        </p:style>
+        <p:txBody>
+          <a:bodyPr lIns="108000" tIns="72000" rIns="108000" bIns="72000" rtlCol="0" anchor="ctr"/>
+          <a:lstStyle/>
+          <a:p>
+            <a:pPr algn="ctr"/>
+            <a:r>
+              <a:rPr lang="en-US" sz="1600" dirty="0" err="1">
+                <a:solidFill>
+                  <a:schemeClr val="bg1"/>
+                </a:solidFill>
+              </a:rPr>
+              <a:t>PORTFOLIO_PERIOD_SECURITY_DASHBOARD_HIGH_RESOLUTION_TIMES</a:t>
+            </a:r>
+            <a:endParaRPr lang="en-US" sz="1600" dirty="0">
+              <a:solidFill>
+                <a:schemeClr val="bg1"/>
+              </a:solidFill>
+            </a:endParaRPr>
+          </a:p>
+        </p:txBody>
+      </p:sp>
+      <p:sp>
+        <p:nvSpPr>
+          <p:cNvPr id="9" name="Rectangle 8">
+            <a:extLst>
+              <a:ext uri="{FF2B5EF4-FFF2-40B4-BE49-F238E27FC236}">
+                <a16:creationId xmlns:a16="http://schemas.microsoft.com/office/drawing/2014/main" id="{30258737-222F-2C4D-7BF4-52200E9C6818}"/>
+              </a:ext>
+            </a:extLst>
+          </p:cNvPr>
+          <p:cNvSpPr/>
+          <p:nvPr/>
+        </p:nvSpPr>
+        <p:spPr>
+          <a:xfrm>
+            <a:off x="8290705" y="3612456"/>
+            <a:ext cx="3299114" cy="2341757"/>
+          </a:xfrm>
+          <a:prstGeom prst="rect">
+            <a:avLst/>
+          </a:prstGeom>
+          <a:solidFill>
+            <a:srgbClr val="F0089F"/>
+          </a:solidFill>
+          <a:ln>
+            <a:noFill/>
+          </a:ln>
+        </p:spPr>
+        <p:style>
+          <a:lnRef idx="2">
+            <a:schemeClr val="accent1">
+              <a:shade val="50000"/>
+            </a:schemeClr>
+          </a:lnRef>
+          <a:fillRef idx="1">
+            <a:schemeClr val="accent1"/>
+          </a:fillRef>
+          <a:effectRef idx="0">
+            <a:schemeClr val="accent1"/>
+          </a:effectRef>
+          <a:fontRef idx="minor">
+            <a:schemeClr val="lt1"/>
+          </a:fontRef>
+        </p:style>
+        <p:txBody>
+          <a:bodyPr lIns="108000" tIns="72000" rIns="108000" bIns="72000" rtlCol="0" anchor="ctr"/>
+          <a:lstStyle/>
+          <a:p>
+            <a:pPr algn="ctr"/>
+            <a:r>
+              <a:rPr lang="en-US" sz="1600">
+                <a:solidFill>
+                  <a:schemeClr val="bg1"/>
+                </a:solidFill>
+              </a:rPr>
+              <a:t>PORTFOLIO_PERIOD_SECURITY_DASHBOARD_MEDIUM_RESOLUTION_TIMES</a:t>
+            </a:r>
+            <a:endParaRPr lang="en-US" sz="1600" dirty="0">
+              <a:solidFill>
+                <a:schemeClr val="bg1"/>
+              </a:solidFill>
+            </a:endParaRPr>
+          </a:p>
+        </p:txBody>
+      </p:sp>
+    </p:spTree>
+    <p:extLst>
+      <p:ext uri="{BB962C8B-B14F-4D97-AF65-F5344CB8AC3E}">
+        <p14:creationId xmlns:p14="http://schemas.microsoft.com/office/powerpoint/2010/main" val="4279907893"/>
+      </p:ext>
+    </p:extLst>
+  </p:cSld>
+  <p:clrMapOvr>
+    <a:masterClrMapping/>
+  </p:clrMapOvr>
+</p:sld>
+</file>
+
+<file path=ppt/slides/slide2.xml><?xml version="1.0" encoding="utf-8"?>
+<p:sld xmlns:a="http://schemas.openxmlformats.org/drawingml/2006/main" xmlns:r="http://schemas.openxmlformats.org/officeDocument/2006/relationships" xmlns:p="http://schemas.openxmlformats.org/presentationml/2006/main">
+  <p:cSld>
+    <p:spTree>
+      <p:nvGrpSpPr>
+        <p:cNvPr id="1" name="">
+          <a:extLst>
+            <a:ext uri="{FF2B5EF4-FFF2-40B4-BE49-F238E27FC236}">
+              <a16:creationId xmlns:a16="http://schemas.microsoft.com/office/drawing/2014/main" id="{B0CA42B1-79CC-1E21-4639-E7E670166532}"/>
+            </a:ext>
+          </a:extLst>
+        </p:cNvPr>
+        <p:cNvGrpSpPr/>
+        <p:nvPr/>
+      </p:nvGrpSpPr>
+      <p:grpSpPr>
+        <a:xfrm>
+          <a:off x="0" y="0"/>
+          <a:ext cx="0" cy="0"/>
+          <a:chOff x="0" y="0"/>
+          <a:chExt cx="0" cy="0"/>
+        </a:xfrm>
+      </p:grpSpPr>
+      <p:sp>
+        <p:nvSpPr>
+          <p:cNvPr id="2" name="Slide Number Placeholder 1">
+            <a:extLst>
+              <a:ext uri="{FF2B5EF4-FFF2-40B4-BE49-F238E27FC236}">
+                <a16:creationId xmlns:a16="http://schemas.microsoft.com/office/drawing/2014/main" id="{6FFC30FB-D319-2C0A-9F37-22FDBE06E510}"/>
+              </a:ext>
+            </a:extLst>
+          </p:cNvPr>
+          <p:cNvSpPr>
+            <a:spLocks noGrp="1"/>
+          </p:cNvSpPr>
+          <p:nvPr>
+            <p:ph type="sldNum" sz="quarter" idx="4"/>
+          </p:nvPr>
+        </p:nvSpPr>
+        <p:spPr/>
+        <p:txBody>
+          <a:bodyPr/>
+          <a:lstStyle/>
+          <a:p>
+            <a:fld id="{E242BD21-9B61-2246-BCB1-4BE5E1BEBE1C}" type="slidenum">
+              <a:rPr lang="en-US" smtClean="0"/>
+              <a:pPr/>
+              <a:t>2</a:t>
+            </a:fld>
+            <a:endParaRPr lang="en-US"/>
+          </a:p>
+        </p:txBody>
+      </p:sp>
+      <p:sp>
+        <p:nvSpPr>
+          <p:cNvPr id="3" name="Text Placeholder 2">
+            <a:extLst>
+              <a:ext uri="{FF2B5EF4-FFF2-40B4-BE49-F238E27FC236}">
+                <a16:creationId xmlns:a16="http://schemas.microsoft.com/office/drawing/2014/main" id="{52208AD9-F8A2-F7B2-D9F1-70BCDD12FBB8}"/>
+              </a:ext>
+            </a:extLst>
+          </p:cNvPr>
+          <p:cNvSpPr>
+            <a:spLocks noGrp="1"/>
+          </p:cNvSpPr>
+          <p:nvPr>
+            <p:ph type="body" sz="quarter" idx="12"/>
+          </p:nvPr>
+        </p:nvSpPr>
+        <p:spPr/>
+        <p:txBody>
+          <a:bodyPr/>
+          <a:lstStyle/>
+          <a:p>
+            <a:endParaRPr lang="en-US"/>
+          </a:p>
+        </p:txBody>
+      </p:sp>
+      <p:sp>
+        <p:nvSpPr>
+          <p:cNvPr id="4" name="Title 3">
+            <a:extLst>
+              <a:ext uri="{FF2B5EF4-FFF2-40B4-BE49-F238E27FC236}">
+                <a16:creationId xmlns:a16="http://schemas.microsoft.com/office/drawing/2014/main" id="{5717DAB3-373D-DCEC-7681-4A145CDFE5A3}"/>
+              </a:ext>
+            </a:extLst>
+          </p:cNvPr>
+          <p:cNvSpPr>
+            <a:spLocks noGrp="1"/>
+          </p:cNvSpPr>
+          <p:nvPr>
+            <p:ph type="title"/>
+          </p:nvPr>
+        </p:nvSpPr>
+        <p:spPr/>
+        <p:txBody>
+          <a:bodyPr/>
+          <a:lstStyle/>
+          <a:p>
+            <a:endParaRPr lang="en-US"/>
+          </a:p>
+        </p:txBody>
+      </p:sp>
+      <p:sp>
+        <p:nvSpPr>
+          <p:cNvPr id="5" name="Content Placeholder 4">
+            <a:extLst>
+              <a:ext uri="{FF2B5EF4-FFF2-40B4-BE49-F238E27FC236}">
+                <a16:creationId xmlns:a16="http://schemas.microsoft.com/office/drawing/2014/main" id="{DDA4B2A8-B773-91AF-217C-D5EE6ACFCD36}"/>
+              </a:ext>
+            </a:extLst>
+          </p:cNvPr>
+          <p:cNvSpPr>
+            <a:spLocks noGrp="1"/>
+          </p:cNvSpPr>
+          <p:nvPr>
+            <p:ph sz="quarter" idx="13"/>
+          </p:nvPr>
+        </p:nvSpPr>
+        <p:spPr/>
+        <p:txBody>
+          <a:bodyPr/>
+          <a:lstStyle/>
+          <a:p>
+            <a:pPr marL="0" indent="0" algn="ctr">
+              <a:buNone/>
+            </a:pPr>
+            <a:endParaRPr lang="en-US" sz="3200" b="1" dirty="0"/>
+          </a:p>
+          <a:p>
+            <a:pPr marL="0" indent="0" algn="ctr">
+              <a:buNone/>
+            </a:pPr>
+            <a:endParaRPr lang="en-US" sz="3200" b="1" dirty="0"/>
+          </a:p>
+          <a:p>
+            <a:pPr marL="0" indent="0" algn="ctr">
+              <a:buNone/>
+            </a:pPr>
+            <a:endParaRPr lang="en-US" sz="3200" b="1" dirty="0"/>
+          </a:p>
+          <a:p>
+            <a:pPr marL="0" indent="0" algn="ctr">
+              <a:buNone/>
+            </a:pPr>
+            <a:r>
+              <a:rPr lang="en-US" sz="3200" b="1" dirty="0"/>
+              <a:t>OBJECTIVES</a:t>
+            </a:r>
+          </a:p>
+        </p:txBody>
+      </p:sp>
+      <p:sp>
+        <p:nvSpPr>
+          <p:cNvPr id="6" name="Rectangle 5">
+            <a:extLst>
+              <a:ext uri="{FF2B5EF4-FFF2-40B4-BE49-F238E27FC236}">
+                <a16:creationId xmlns:a16="http://schemas.microsoft.com/office/drawing/2014/main" id="{E01EFB6F-BDEE-5ED9-3CD5-ECFE541AE10E}"/>
+              </a:ext>
+            </a:extLst>
+          </p:cNvPr>
+          <p:cNvSpPr/>
+          <p:nvPr/>
+        </p:nvSpPr>
+        <p:spPr>
+          <a:xfrm>
+            <a:off x="1371600" y="0"/>
+            <a:ext cx="10820400" cy="1186249"/>
+          </a:xfrm>
+          <a:prstGeom prst="rect">
+            <a:avLst/>
+          </a:prstGeom>
+          <a:solidFill>
+            <a:schemeClr val="tx2"/>
+          </a:solidFill>
+          <a:ln>
+            <a:noFill/>
+          </a:ln>
+        </p:spPr>
+        <p:style>
+          <a:lnRef idx="2">
+            <a:schemeClr val="accent1">
+              <a:shade val="50000"/>
+            </a:schemeClr>
+          </a:lnRef>
+          <a:fillRef idx="1">
+            <a:schemeClr val="accent1"/>
+          </a:fillRef>
+          <a:effectRef idx="0">
+            <a:schemeClr val="accent1"/>
+          </a:effectRef>
+          <a:fontRef idx="minor">
+            <a:schemeClr val="lt1"/>
+          </a:fontRef>
+        </p:style>
+        <p:txBody>
+          <a:bodyPr lIns="108000" tIns="72000" rIns="108000" bIns="72000" rtlCol="0" anchor="ctr"/>
+          <a:lstStyle/>
+          <a:p>
+            <a:pPr algn="ctr"/>
+            <a:endParaRPr lang="en-US" sz="1600" dirty="0" err="1">
+              <a:solidFill>
+                <a:schemeClr val="bg1"/>
+              </a:solidFill>
+            </a:endParaRPr>
+          </a:p>
+        </p:txBody>
+      </p:sp>
+    </p:spTree>
+    <p:extLst>
+      <p:ext uri="{BB962C8B-B14F-4D97-AF65-F5344CB8AC3E}">
+        <p14:creationId xmlns:p14="http://schemas.microsoft.com/office/powerpoint/2010/main" val="1721077860"/>
+      </p:ext>
+    </p:extLst>
+  </p:cSld>
+  <p:clrMapOvr>
+    <a:masterClrMapping/>
+  </p:clrMapOvr>
+</p:sld>
+</file>
+
+<file path=ppt/slides/slide20.xml><?xml version="1.0" encoding="utf-8"?>
+<p:sld xmlns:a="http://schemas.openxmlformats.org/drawingml/2006/main" xmlns:r="http://schemas.openxmlformats.org/officeDocument/2006/relationships" xmlns:p="http://schemas.openxmlformats.org/presentationml/2006/main">
+  <p:cSld>
+    <p:spTree>
+      <p:nvGrpSpPr>
+        <p:cNvPr id="1" name="">
+          <a:extLst>
+            <a:ext uri="{FF2B5EF4-FFF2-40B4-BE49-F238E27FC236}">
+              <a16:creationId xmlns:a16="http://schemas.microsoft.com/office/drawing/2014/main" id="{2A447711-2F95-8D02-EF61-9DFDAFBAAE27}"/>
+            </a:ext>
+          </a:extLst>
+        </p:cNvPr>
+        <p:cNvGrpSpPr/>
+        <p:nvPr/>
+      </p:nvGrpSpPr>
+      <p:grpSpPr>
+        <a:xfrm>
+          <a:off x="0" y="0"/>
+          <a:ext cx="0" cy="0"/>
+          <a:chOff x="0" y="0"/>
+          <a:chExt cx="0" cy="0"/>
+        </a:xfrm>
+      </p:grpSpPr>
+      <p:sp>
+        <p:nvSpPr>
+          <p:cNvPr id="17" name="Rectangle 16">
+            <a:extLst>
+              <a:ext uri="{FF2B5EF4-FFF2-40B4-BE49-F238E27FC236}">
+                <a16:creationId xmlns:a16="http://schemas.microsoft.com/office/drawing/2014/main" id="{ED508E6A-8D1D-AB1F-259E-339FCAE0BA97}"/>
+              </a:ext>
+            </a:extLst>
+          </p:cNvPr>
+          <p:cNvSpPr/>
+          <p:nvPr/>
+        </p:nvSpPr>
+        <p:spPr>
+          <a:xfrm flipH="1">
+            <a:off x="0" y="1368000"/>
+            <a:ext cx="12192000" cy="1658842"/>
+          </a:xfrm>
+          <a:prstGeom prst="rect">
+            <a:avLst/>
+          </a:prstGeom>
+          <a:gradFill>
+            <a:gsLst>
+              <a:gs pos="0">
+                <a:schemeClr val="bg1"/>
+              </a:gs>
+              <a:gs pos="100000">
+                <a:schemeClr val="bg2"/>
+              </a:gs>
+            </a:gsLst>
+            <a:lin ang="2700000" scaled="0"/>
+          </a:gradFill>
+          <a:ln>
+            <a:noFill/>
+          </a:ln>
+          <a:effectLst>
+            <a:outerShdw blurRad="190500" dist="38100" dir="2700000" algn="tl" rotWithShape="0">
+              <a:prstClr val="black">
+                <a:alpha val="15000"/>
+              </a:prstClr>
+            </a:outerShdw>
+          </a:effectLst>
+        </p:spPr>
+        <p:style>
+          <a:lnRef idx="2">
+            <a:schemeClr val="accent1">
+              <a:shade val="50000"/>
+            </a:schemeClr>
+          </a:lnRef>
+          <a:fillRef idx="1">
+            <a:schemeClr val="accent1"/>
+          </a:fillRef>
+          <a:effectRef idx="0">
+            <a:schemeClr val="accent1"/>
+          </a:effectRef>
+          <a:fontRef idx="minor">
+            <a:schemeClr val="lt1"/>
+          </a:fontRef>
+        </p:style>
+        <p:txBody>
+          <a:bodyPr lIns="731520" tIns="72000" rIns="108000" bIns="72000" rtlCol="0" anchor="ctr"/>
+          <a:lstStyle/>
+          <a:p>
+            <a:endParaRPr lang="nl-NL" sz="1200" b="1" noProof="0" dirty="0">
+              <a:solidFill>
+                <a:schemeClr val="accent1"/>
+              </a:solidFill>
+            </a:endParaRPr>
+          </a:p>
+        </p:txBody>
+      </p:sp>
+      <p:sp>
+        <p:nvSpPr>
+          <p:cNvPr id="3" name="Slide Number Placeholder 2">
+            <a:extLst>
+              <a:ext uri="{FF2B5EF4-FFF2-40B4-BE49-F238E27FC236}">
+                <a16:creationId xmlns:a16="http://schemas.microsoft.com/office/drawing/2014/main" id="{B67F47A6-2E30-A3A2-1FA6-ADC44FB6A75A}"/>
+              </a:ext>
+            </a:extLst>
+          </p:cNvPr>
+          <p:cNvSpPr>
+            <a:spLocks noGrp="1"/>
+          </p:cNvSpPr>
+          <p:nvPr>
+            <p:ph type="sldNum" sz="quarter" idx="4"/>
+          </p:nvPr>
+        </p:nvSpPr>
+        <p:spPr/>
+        <p:txBody>
+          <a:bodyPr/>
+          <a:lstStyle/>
+          <a:p>
+            <a:fld id="{E242BD21-9B61-2246-BCB1-4BE5E1BEBE1C}" type="slidenum">
+              <a:rPr lang="en-US" smtClean="0"/>
+              <a:pPr/>
+              <a:t>20</a:t>
             </a:fld>
             <a:endParaRPr lang="en-US"/>
           </a:p>
@@ -52824,228 +54551,7 @@
 </p:sld>
 </file>
 
-<file path=ppt/slides/slide2.xml><?xml version="1.0" encoding="utf-8"?>
-<p:sld xmlns:a="http://schemas.openxmlformats.org/drawingml/2006/main" xmlns:r="http://schemas.openxmlformats.org/officeDocument/2006/relationships" xmlns:p="http://schemas.openxmlformats.org/presentationml/2006/main">
-  <p:cSld>
-    <p:spTree>
-      <p:nvGrpSpPr>
-        <p:cNvPr id="1" name="">
-          <a:extLst>
-            <a:ext uri="{FF2B5EF4-FFF2-40B4-BE49-F238E27FC236}">
-              <a16:creationId xmlns:a16="http://schemas.microsoft.com/office/drawing/2014/main" id="{B0CA42B1-79CC-1E21-4639-E7E670166532}"/>
-            </a:ext>
-          </a:extLst>
-        </p:cNvPr>
-        <p:cNvGrpSpPr/>
-        <p:nvPr/>
-      </p:nvGrpSpPr>
-      <p:grpSpPr>
-        <a:xfrm>
-          <a:off x="0" y="0"/>
-          <a:ext cx="0" cy="0"/>
-          <a:chOff x="0" y="0"/>
-          <a:chExt cx="0" cy="0"/>
-        </a:xfrm>
-      </p:grpSpPr>
-      <p:sp>
-        <p:nvSpPr>
-          <p:cNvPr id="2" name="Slide Number Placeholder 1">
-            <a:extLst>
-              <a:ext uri="{FF2B5EF4-FFF2-40B4-BE49-F238E27FC236}">
-                <a16:creationId xmlns:a16="http://schemas.microsoft.com/office/drawing/2014/main" id="{6FFC30FB-D319-2C0A-9F37-22FDBE06E510}"/>
-              </a:ext>
-            </a:extLst>
-          </p:cNvPr>
-          <p:cNvSpPr>
-            <a:spLocks noGrp="1"/>
-          </p:cNvSpPr>
-          <p:nvPr>
-            <p:ph type="sldNum" sz="quarter" idx="4"/>
-          </p:nvPr>
-        </p:nvSpPr>
-        <p:spPr/>
-        <p:txBody>
-          <a:bodyPr/>
-          <a:lstStyle/>
-          <a:p>
-            <a:fld id="{E242BD21-9B61-2246-BCB1-4BE5E1BEBE1C}" type="slidenum">
-              <a:rPr lang="en-US" smtClean="0"/>
-              <a:pPr/>
-              <a:t>2</a:t>
-            </a:fld>
-            <a:endParaRPr lang="en-US"/>
-          </a:p>
-        </p:txBody>
-      </p:sp>
-      <p:sp>
-        <p:nvSpPr>
-          <p:cNvPr id="3" name="Text Placeholder 2">
-            <a:extLst>
-              <a:ext uri="{FF2B5EF4-FFF2-40B4-BE49-F238E27FC236}">
-                <a16:creationId xmlns:a16="http://schemas.microsoft.com/office/drawing/2014/main" id="{52208AD9-F8A2-F7B2-D9F1-70BCDD12FBB8}"/>
-              </a:ext>
-            </a:extLst>
-          </p:cNvPr>
-          <p:cNvSpPr>
-            <a:spLocks noGrp="1"/>
-          </p:cNvSpPr>
-          <p:nvPr>
-            <p:ph type="body" sz="quarter" idx="12"/>
-          </p:nvPr>
-        </p:nvSpPr>
-        <p:spPr/>
-        <p:txBody>
-          <a:bodyPr/>
-          <a:lstStyle/>
-          <a:p>
-            <a:endParaRPr lang="en-US"/>
-          </a:p>
-        </p:txBody>
-      </p:sp>
-      <p:sp>
-        <p:nvSpPr>
-          <p:cNvPr id="4" name="Title 3">
-            <a:extLst>
-              <a:ext uri="{FF2B5EF4-FFF2-40B4-BE49-F238E27FC236}">
-                <a16:creationId xmlns:a16="http://schemas.microsoft.com/office/drawing/2014/main" id="{5717DAB3-373D-DCEC-7681-4A145CDFE5A3}"/>
-              </a:ext>
-            </a:extLst>
-          </p:cNvPr>
-          <p:cNvSpPr>
-            <a:spLocks noGrp="1"/>
-          </p:cNvSpPr>
-          <p:nvPr>
-            <p:ph type="title"/>
-          </p:nvPr>
-        </p:nvSpPr>
-        <p:spPr/>
-        <p:txBody>
-          <a:bodyPr/>
-          <a:lstStyle/>
-          <a:p>
-            <a:endParaRPr lang="en-US"/>
-          </a:p>
-        </p:txBody>
-      </p:sp>
-      <p:sp>
-        <p:nvSpPr>
-          <p:cNvPr id="5" name="Content Placeholder 4">
-            <a:extLst>
-              <a:ext uri="{FF2B5EF4-FFF2-40B4-BE49-F238E27FC236}">
-                <a16:creationId xmlns:a16="http://schemas.microsoft.com/office/drawing/2014/main" id="{DDA4B2A8-B773-91AF-217C-D5EE6ACFCD36}"/>
-              </a:ext>
-            </a:extLst>
-          </p:cNvPr>
-          <p:cNvSpPr>
-            <a:spLocks noGrp="1"/>
-          </p:cNvSpPr>
-          <p:nvPr>
-            <p:ph sz="quarter" idx="13"/>
-          </p:nvPr>
-        </p:nvSpPr>
-        <p:spPr/>
-        <p:txBody>
-          <a:bodyPr/>
-          <a:lstStyle/>
-          <a:p>
-            <a:pPr marL="0" indent="0" algn="ctr">
-              <a:buNone/>
-            </a:pPr>
-            <a:endParaRPr lang="en-US" sz="3200" b="1" dirty="0"/>
-          </a:p>
-          <a:p>
-            <a:pPr marL="0" indent="0" algn="ctr">
-              <a:buNone/>
-            </a:pPr>
-            <a:endParaRPr lang="en-US" sz="3200" b="1" dirty="0"/>
-          </a:p>
-          <a:p>
-            <a:pPr marL="0" indent="0" algn="ctr">
-              <a:buNone/>
-            </a:pPr>
-            <a:endParaRPr lang="en-US" sz="3200" b="1" dirty="0"/>
-          </a:p>
-          <a:p>
-            <a:pPr marL="0" indent="0" algn="ctr">
-              <a:buNone/>
-            </a:pPr>
-            <a:r>
-              <a:rPr lang="en-US" sz="3200" b="1" dirty="0"/>
-              <a:t>OBJECTIVES</a:t>
-            </a:r>
-          </a:p>
-        </p:txBody>
-      </p:sp>
-      <p:sp>
-        <p:nvSpPr>
-          <p:cNvPr id="6" name="Rectangle 5">
-            <a:extLst>
-              <a:ext uri="{FF2B5EF4-FFF2-40B4-BE49-F238E27FC236}">
-                <a16:creationId xmlns:a16="http://schemas.microsoft.com/office/drawing/2014/main" id="{E01EFB6F-BDEE-5ED9-3CD5-ECFE541AE10E}"/>
-              </a:ext>
-            </a:extLst>
-          </p:cNvPr>
-          <p:cNvSpPr/>
-          <p:nvPr/>
-        </p:nvSpPr>
-        <p:spPr>
-          <a:xfrm>
-            <a:off x="1371600" y="0"/>
-            <a:ext cx="10820400" cy="1186249"/>
-          </a:xfrm>
-          <a:prstGeom prst="rect">
-            <a:avLst/>
-          </a:prstGeom>
-          <a:solidFill>
-            <a:schemeClr val="tx2"/>
-          </a:solidFill>
-          <a:ln>
-            <a:noFill/>
-          </a:ln>
-        </p:spPr>
-        <p:style>
-          <a:lnRef idx="2">
-            <a:schemeClr val="accent1">
-              <a:shade val="50000"/>
-            </a:schemeClr>
-          </a:lnRef>
-          <a:fillRef idx="1">
-            <a:schemeClr val="accent1"/>
-          </a:fillRef>
-          <a:effectRef idx="0">
-            <a:schemeClr val="accent1"/>
-          </a:effectRef>
-          <a:fontRef idx="minor">
-            <a:schemeClr val="lt1"/>
-          </a:fontRef>
-        </p:style>
-        <p:txBody>
-          <a:bodyPr lIns="108000" tIns="72000" rIns="108000" bIns="72000" rtlCol="0" anchor="ctr"/>
-          <a:lstStyle/>
-          <a:p>
-            <a:pPr algn="ctr"/>
-            <a:endParaRPr lang="en-US" sz="1600" dirty="0" err="1">
-              <a:solidFill>
-                <a:schemeClr val="bg1"/>
-              </a:solidFill>
-            </a:endParaRPr>
-          </a:p>
-        </p:txBody>
-      </p:sp>
-    </p:spTree>
-    <p:extLst>
-      <p:ext uri="{BB962C8B-B14F-4D97-AF65-F5344CB8AC3E}">
-        <p14:creationId xmlns:p14="http://schemas.microsoft.com/office/powerpoint/2010/main" val="1721077860"/>
-      </p:ext>
-    </p:extLst>
-  </p:cSld>
-  <p:clrMapOvr>
-    <a:masterClrMapping/>
-  </p:clrMapOvr>
-</p:sld>
-</file>
-
-<file path=ppt/slides/slide20.xml><?xml version="1.0" encoding="utf-8"?>
+<file path=ppt/slides/slide21.xml><?xml version="1.0" encoding="utf-8"?>
 <p:sld xmlns:a="http://schemas.openxmlformats.org/drawingml/2006/main" xmlns:r="http://schemas.openxmlformats.org/officeDocument/2006/relationships" xmlns:p="http://schemas.openxmlformats.org/presentationml/2006/main">
   <p:cSld>
     <p:spTree>
@@ -56240,17 +57746,6 @@
 </file>
 
 <file path=customXml/item1.xml><?xml version="1.0" encoding="utf-8"?>
-<p:properties xmlns:p="http://schemas.microsoft.com/office/2006/metadata/properties" xmlns:xsi="http://www.w3.org/2001/XMLSchema-instance" xmlns:pc="http://schemas.microsoft.com/office/infopath/2007/PartnerControls">
-  <documentManagement>
-    <lcf76f155ced4ddcb4097134ff3c332f xmlns="fa937df2-abe2-4d38-b5f4-c228acba3827">
-      <Terms xmlns="http://schemas.microsoft.com/office/infopath/2007/PartnerControls"/>
-    </lcf76f155ced4ddcb4097134ff3c332f>
-    <TaxCatchAll xmlns="bc8ba18a-4a58-4ad2-bfc0-6516af8e7dc2" xsi:nil="true"/>
-  </documentManagement>
-</p:properties>
-</file>
-
-<file path=customXml/item2.xml><?xml version="1.0" encoding="utf-8"?>
 <ct:contentTypeSchema xmlns:ct="http://schemas.microsoft.com/office/2006/metadata/contentType" xmlns:ma="http://schemas.microsoft.com/office/2006/metadata/properties/metaAttributes" ct:_="" ma:_="" ma:contentTypeName="Document" ma:contentTypeID="0x010100398B4EB28540854BB4092730D7F67224" ma:contentTypeVersion="13" ma:contentTypeDescription="Create a new document." ma:contentTypeScope="" ma:versionID="07d6997c7358ecc3b6f0d78039f1ac55">
   <xsd:schema xmlns:xsd="http://www.w3.org/2001/XMLSchema" xmlns:xs="http://www.w3.org/2001/XMLSchema" xmlns:p="http://schemas.microsoft.com/office/2006/metadata/properties" xmlns:ns2="fa937df2-abe2-4d38-b5f4-c228acba3827" xmlns:ns3="bc8ba18a-4a58-4ad2-bfc0-6516af8e7dc2" targetNamespace="http://schemas.microsoft.com/office/2006/metadata/properties" ma:root="true" ma:fieldsID="a7d20d2c9a349b6838acf4b79389f2fd" ns2:_="" ns3:_="">
     <xsd:import namespace="fa937df2-abe2-4d38-b5f4-c228acba3827"/>
@@ -56473,7 +57968,7 @@
 </ct:contentTypeSchema>
 </file>
 
-<file path=customXml/item3.xml><?xml version="1.0" encoding="utf-8"?>
+<file path=customXml/item2.xml><?xml version="1.0" encoding="utf-8"?>
 <?mso-contentType ?>
 <FormTemplates xmlns="http://schemas.microsoft.com/sharepoint/v3/contenttype/forms">
   <Display>DocumentLibraryForm</Display>
@@ -56482,24 +57977,18 @@
 </FormTemplates>
 </file>
 
-<file path=customXml/itemProps1.xml><?xml version="1.0" encoding="utf-8"?>
-<ds:datastoreItem xmlns:ds="http://schemas.openxmlformats.org/officeDocument/2006/customXml" ds:itemID="{4B629362-CF15-4610-8FAC-A8E699942233}">
-  <ds:schemaRefs>
-    <ds:schemaRef ds:uri="http://schemas.microsoft.com/office/2006/documentManagement/types"/>
-    <ds:schemaRef ds:uri="http://purl.org/dc/elements/1.1/"/>
-    <ds:schemaRef ds:uri="bc8ba18a-4a58-4ad2-bfc0-6516af8e7dc2"/>
-    <ds:schemaRef ds:uri="http://purl.org/dc/terms/"/>
-    <ds:schemaRef ds:uri="http://www.w3.org/XML/1998/namespace"/>
-    <ds:schemaRef ds:uri="http://schemas.microsoft.com/office/2006/metadata/properties"/>
-    <ds:schemaRef ds:uri="http://schemas.microsoft.com/office/infopath/2007/PartnerControls"/>
-    <ds:schemaRef ds:uri="http://schemas.openxmlformats.org/package/2006/metadata/core-properties"/>
-    <ds:schemaRef ds:uri="fa937df2-abe2-4d38-b5f4-c228acba3827"/>
-    <ds:schemaRef ds:uri="http://purl.org/dc/dcmitype/"/>
-  </ds:schemaRefs>
-</ds:datastoreItem>
+<file path=customXml/item3.xml><?xml version="1.0" encoding="utf-8"?>
+<p:properties xmlns:p="http://schemas.microsoft.com/office/2006/metadata/properties" xmlns:xsi="http://www.w3.org/2001/XMLSchema-instance" xmlns:pc="http://schemas.microsoft.com/office/infopath/2007/PartnerControls">
+  <documentManagement>
+    <lcf76f155ced4ddcb4097134ff3c332f xmlns="fa937df2-abe2-4d38-b5f4-c228acba3827">
+      <Terms xmlns="http://schemas.microsoft.com/office/infopath/2007/PartnerControls"/>
+    </lcf76f155ced4ddcb4097134ff3c332f>
+    <TaxCatchAll xmlns="bc8ba18a-4a58-4ad2-bfc0-6516af8e7dc2" xsi:nil="true"/>
+  </documentManagement>
+</p:properties>
 </file>
 
-<file path=customXml/itemProps2.xml><?xml version="1.0" encoding="utf-8"?>
+<file path=customXml/itemProps1.xml><?xml version="1.0" encoding="utf-8"?>
 <ds:datastoreItem xmlns:ds="http://schemas.openxmlformats.org/officeDocument/2006/customXml" ds:itemID="{06E6923A-C221-4753-B75B-BA213EEB7564}">
   <ds:schemaRefs>
     <ds:schemaRef ds:uri="bc8ba18a-4a58-4ad2-bfc0-6516af8e7dc2"/>
@@ -56518,10 +58007,27 @@
 </ds:datastoreItem>
 </file>
 
-<file path=customXml/itemProps3.xml><?xml version="1.0" encoding="utf-8"?>
+<file path=customXml/itemProps2.xml><?xml version="1.0" encoding="utf-8"?>
 <ds:datastoreItem xmlns:ds="http://schemas.openxmlformats.org/officeDocument/2006/customXml" ds:itemID="{570928F0-D7CA-4732-B7F3-1F945720D0AA}">
   <ds:schemaRefs>
     <ds:schemaRef ds:uri="http://schemas.microsoft.com/sharepoint/v3/contenttype/forms"/>
   </ds:schemaRefs>
 </ds:datastoreItem>
+</file>
+
+<file path=customXml/itemProps3.xml><?xml version="1.0" encoding="utf-8"?>
+<ds:datastoreItem xmlns:ds="http://schemas.openxmlformats.org/officeDocument/2006/customXml" ds:itemID="{4B629362-CF15-4610-8FAC-A8E699942233}">
+  <ds:schemaRefs>
+    <ds:schemaRef ds:uri="http://schemas.microsoft.com/office/2006/documentManagement/types"/>
+    <ds:schemaRef ds:uri="http://purl.org/dc/elements/1.1/"/>
+    <ds:schemaRef ds:uri="bc8ba18a-4a58-4ad2-bfc0-6516af8e7dc2"/>
+    <ds:schemaRef ds:uri="http://purl.org/dc/terms/"/>
+    <ds:schemaRef ds:uri="http://www.w3.org/XML/1998/namespace"/>
+    <ds:schemaRef ds:uri="http://schemas.microsoft.com/office/2006/metadata/properties"/>
+    <ds:schemaRef ds:uri="http://schemas.microsoft.com/office/infopath/2007/PartnerControls"/>
+    <ds:schemaRef ds:uri="http://schemas.openxmlformats.org/package/2006/metadata/core-properties"/>
+    <ds:schemaRef ds:uri="fa937df2-abe2-4d38-b5f4-c228acba3827"/>
+    <ds:schemaRef ds:uri="http://purl.org/dc/dcmitype/"/>
+  </ds:schemaRefs>
+</ds:datastoreItem>
 </file>
</xml_diff>

<commit_message>
Adding team and division filters
</commit_message>
<xml_diff>
--- a/src/report_generator/presets/templates/portfolio-overview.pptx
+++ b/src/report_generator/presets/templates/portfolio-overview.pptx
@@ -129,6 +129,11 @@
       </a:defRPr>
     </a:lvl9pPr>
   </p:defaultTextStyle>
+  <p:extLst>
+    <p:ext uri="{EFAFB233-063F-42B5-8137-9DF3F51BA10A}">
+      <p15:sldGuideLst xmlns:p15="http://schemas.microsoft.com/office/powerpoint/2012/main"/>
+    </p:ext>
+  </p:extLst>
 </p:presentation>
 </file>
 
@@ -203,7 +208,7 @@
                 </a:outerShdw>
               </a:effectLst>
             </c:spPr>
-            <c:extLst xmlns:w="http://schemas.openxmlformats.org/wordprocessingml/2006/main" xmlns:w15="http://schemas.microsoft.com/office/word/2012/wordml" xmlns:w14="http://schemas.microsoft.com/office/word/2010/wordml" xmlns:m="http://schemas.openxmlformats.org/officeDocument/2006/math" xmlns:wp="http://schemas.openxmlformats.org/drawingml/2006/wordprocessingDrawing" xmlns:wp14="http://schemas.microsoft.com/office/word/2010/wordprocessingDrawing" xmlns:mc="http://schemas.openxmlformats.org/markup-compatibility/2006" xmlns:sl="http://schemas.openxmlformats.org/schemaLibrary/2006/main" xmlns:wne="http://schemas.microsoft.com/office/word/2006/wordml" xmlns:cdr="http://schemas.openxmlformats.org/drawingml/2006/chartDrawing" xmlns:c14="http://schemas.microsoft.com/office/drawing/2007/8/2/chart" xmlns:dgm="http://schemas.openxmlformats.org/drawingml/2006/diagram" xmlns:pic="http://schemas.openxmlformats.org/drawingml/2006/picture" xmlns:xdr="http://schemas.openxmlformats.org/drawingml/2006/spreadsheetDrawing" xmlns:dsp="http://schemas.microsoft.com/office/drawing/2008/diagram" xmlns:xvml="urn:schemas-microsoft-com:office:excel" xmlns:o="urn:schemas-microsoft-com:office:office" xmlns:v="urn:schemas-microsoft-com:vml" xmlns:w10="urn:schemas-microsoft-com:office:word" xmlns:pvml="urn:schemas-microsoft-com:office:powerpoint" xmlns:cppr="http://schemas.microsoft.com/office/2006/coverPageProps" xmlns:odx="http://opendope.org/xpaths" xmlns:odc="http://opendope.org/conditions" xmlns:odq="http://opendope.org/questions" xmlns:oda="http://opendope.org/answers" xmlns:odi="http://opendope.org/components" xmlns:odgm="http://opendope.org/SmartArt/DataHierarchy" xmlns:b="http://schemas.openxmlformats.org/officeDocument/2006/bibliography" xmlns:wps="http://schemas.microsoft.com/office/word/2010/wordprocessingShape" xmlns:w16se="http://schemas.microsoft.com/office/word/2015/wordml/symex" xmlns:w16cid="http://schemas.microsoft.com/office/word/2016/wordml/cid" xmlns:wetp="http://schemas.microsoft.com/office/webextensions/taskpanes/2010/11" xmlns:we="http://schemas.microsoft.com/office/webextensions/webextension/2010/11" xmlns:comp="http://schemas.openxmlformats.org/drawingml/2006/compatibility" xmlns:lc="http://schemas.openxmlformats.org/drawingml/2006/lockedCanvas">
+            <c:extLst xmlns:lc="http://schemas.openxmlformats.org/drawingml/2006/lockedCanvas" xmlns:comp="http://schemas.openxmlformats.org/drawingml/2006/compatibility" xmlns:we="http://schemas.microsoft.com/office/webextensions/webextension/2010/11" xmlns:wetp="http://schemas.microsoft.com/office/webextensions/taskpanes/2010/11" xmlns:w16cid="http://schemas.microsoft.com/office/word/2016/wordml/cid" xmlns:w16se="http://schemas.microsoft.com/office/word/2015/wordml/symex" xmlns:wps="http://schemas.microsoft.com/office/word/2010/wordprocessingShape" xmlns:b="http://schemas.openxmlformats.org/officeDocument/2006/bibliography" xmlns:odgm="http://opendope.org/SmartArt/DataHierarchy" xmlns:odi="http://opendope.org/components" xmlns:oda="http://opendope.org/answers" xmlns:odq="http://opendope.org/questions" xmlns:odc="http://opendope.org/conditions" xmlns:odx="http://opendope.org/xpaths" xmlns:cppr="http://schemas.microsoft.com/office/2006/coverPageProps" xmlns:pvml="urn:schemas-microsoft-com:office:powerpoint" xmlns:w10="urn:schemas-microsoft-com:office:word" xmlns:v="urn:schemas-microsoft-com:vml" xmlns:o="urn:schemas-microsoft-com:office:office" xmlns:xvml="urn:schemas-microsoft-com:office:excel" xmlns:dsp="http://schemas.microsoft.com/office/drawing/2008/diagram" xmlns:xdr="http://schemas.openxmlformats.org/drawingml/2006/spreadsheetDrawing" xmlns:pic="http://schemas.openxmlformats.org/drawingml/2006/picture" xmlns:dgm="http://schemas.openxmlformats.org/drawingml/2006/diagram" xmlns:c14="http://schemas.microsoft.com/office/drawing/2007/8/2/chart" xmlns:cdr="http://schemas.openxmlformats.org/drawingml/2006/chartDrawing" xmlns:wne="http://schemas.microsoft.com/office/word/2006/wordml" xmlns:sl="http://schemas.openxmlformats.org/schemaLibrary/2006/main" xmlns:mc="http://schemas.openxmlformats.org/markup-compatibility/2006" xmlns:wp14="http://schemas.microsoft.com/office/word/2010/wordprocessingDrawing" xmlns:wp="http://schemas.openxmlformats.org/drawingml/2006/wordprocessingDrawing" xmlns:m="http://schemas.openxmlformats.org/officeDocument/2006/math" xmlns:w14="http://schemas.microsoft.com/office/word/2010/wordml" xmlns:w15="http://schemas.microsoft.com/office/word/2012/wordml" xmlns:w="http://schemas.openxmlformats.org/wordprocessingml/2006/main">
               <c:ext xmlns:c16="http://schemas.microsoft.com/office/drawing/2014/chart" uri="{C3380CC4-5D6E-409C-BE32-E72D297353CC}">
                 <c16:uniqueId val="{00000001-6147-E74A-AA7B-5531F0E4EE0C}"/>
               </c:ext>
@@ -232,7 +237,7 @@
               </c:numCache>
             </c:numRef>
           </c:val>
-          <c:extLst xmlns:w="http://schemas.openxmlformats.org/wordprocessingml/2006/main" xmlns:w15="http://schemas.microsoft.com/office/word/2012/wordml" xmlns:w14="http://schemas.microsoft.com/office/word/2010/wordml" xmlns:m="http://schemas.openxmlformats.org/officeDocument/2006/math" xmlns:wp="http://schemas.openxmlformats.org/drawingml/2006/wordprocessingDrawing" xmlns:wp14="http://schemas.microsoft.com/office/word/2010/wordprocessingDrawing" xmlns:mc="http://schemas.openxmlformats.org/markup-compatibility/2006" xmlns:sl="http://schemas.openxmlformats.org/schemaLibrary/2006/main" xmlns:wne="http://schemas.microsoft.com/office/word/2006/wordml" xmlns:cdr="http://schemas.openxmlformats.org/drawingml/2006/chartDrawing" xmlns:c14="http://schemas.microsoft.com/office/drawing/2007/8/2/chart" xmlns:dgm="http://schemas.openxmlformats.org/drawingml/2006/diagram" xmlns:pic="http://schemas.openxmlformats.org/drawingml/2006/picture" xmlns:xdr="http://schemas.openxmlformats.org/drawingml/2006/spreadsheetDrawing" xmlns:dsp="http://schemas.microsoft.com/office/drawing/2008/diagram" xmlns:xvml="urn:schemas-microsoft-com:office:excel" xmlns:o="urn:schemas-microsoft-com:office:office" xmlns:v="urn:schemas-microsoft-com:vml" xmlns:w10="urn:schemas-microsoft-com:office:word" xmlns:pvml="urn:schemas-microsoft-com:office:powerpoint" xmlns:cppr="http://schemas.microsoft.com/office/2006/coverPageProps" xmlns:odx="http://opendope.org/xpaths" xmlns:odc="http://opendope.org/conditions" xmlns:odq="http://opendope.org/questions" xmlns:oda="http://opendope.org/answers" xmlns:odi="http://opendope.org/components" xmlns:odgm="http://opendope.org/SmartArt/DataHierarchy" xmlns:b="http://schemas.openxmlformats.org/officeDocument/2006/bibliography" xmlns:wps="http://schemas.microsoft.com/office/word/2010/wordprocessingShape" xmlns:w16se="http://schemas.microsoft.com/office/word/2015/wordml/symex" xmlns:w16cid="http://schemas.microsoft.com/office/word/2016/wordml/cid" xmlns:wetp="http://schemas.microsoft.com/office/webextensions/taskpanes/2010/11" xmlns:we="http://schemas.microsoft.com/office/webextensions/webextension/2010/11" xmlns:comp="http://schemas.openxmlformats.org/drawingml/2006/compatibility" xmlns:lc="http://schemas.openxmlformats.org/drawingml/2006/lockedCanvas">
+          <c:extLst xmlns:lc="http://schemas.openxmlformats.org/drawingml/2006/lockedCanvas" xmlns:comp="http://schemas.openxmlformats.org/drawingml/2006/compatibility" xmlns:we="http://schemas.microsoft.com/office/webextensions/webextension/2010/11" xmlns:wetp="http://schemas.microsoft.com/office/webextensions/taskpanes/2010/11" xmlns:w16cid="http://schemas.microsoft.com/office/word/2016/wordml/cid" xmlns:w16se="http://schemas.microsoft.com/office/word/2015/wordml/symex" xmlns:wps="http://schemas.microsoft.com/office/word/2010/wordprocessingShape" xmlns:b="http://schemas.openxmlformats.org/officeDocument/2006/bibliography" xmlns:odgm="http://opendope.org/SmartArt/DataHierarchy" xmlns:odi="http://opendope.org/components" xmlns:oda="http://opendope.org/answers" xmlns:odq="http://opendope.org/questions" xmlns:odc="http://opendope.org/conditions" xmlns:odx="http://opendope.org/xpaths" xmlns:cppr="http://schemas.microsoft.com/office/2006/coverPageProps" xmlns:pvml="urn:schemas-microsoft-com:office:powerpoint" xmlns:w10="urn:schemas-microsoft-com:office:word" xmlns:v="urn:schemas-microsoft-com:vml" xmlns:o="urn:schemas-microsoft-com:office:office" xmlns:xvml="urn:schemas-microsoft-com:office:excel" xmlns:dsp="http://schemas.microsoft.com/office/drawing/2008/diagram" xmlns:xdr="http://schemas.openxmlformats.org/drawingml/2006/spreadsheetDrawing" xmlns:pic="http://schemas.openxmlformats.org/drawingml/2006/picture" xmlns:dgm="http://schemas.openxmlformats.org/drawingml/2006/diagram" xmlns:c14="http://schemas.microsoft.com/office/drawing/2007/8/2/chart" xmlns:cdr="http://schemas.openxmlformats.org/drawingml/2006/chartDrawing" xmlns:wne="http://schemas.microsoft.com/office/word/2006/wordml" xmlns:sl="http://schemas.openxmlformats.org/schemaLibrary/2006/main" xmlns:mc="http://schemas.openxmlformats.org/markup-compatibility/2006" xmlns:wp14="http://schemas.microsoft.com/office/word/2010/wordprocessingDrawing" xmlns:wp="http://schemas.openxmlformats.org/drawingml/2006/wordprocessingDrawing" xmlns:m="http://schemas.openxmlformats.org/officeDocument/2006/math" xmlns:w14="http://schemas.microsoft.com/office/word/2010/wordml" xmlns:w15="http://schemas.microsoft.com/office/word/2012/wordml" xmlns:w="http://schemas.openxmlformats.org/wordprocessingml/2006/main">
             <c:ext xmlns:c16="http://schemas.microsoft.com/office/drawing/2014/chart" uri="{C3380CC4-5D6E-409C-BE32-E72D297353CC}">
               <c16:uniqueId val="{00000002-6147-E74A-AA7B-5531F0E4EE0C}"/>
             </c:ext>
@@ -549,7 +554,7 @@
     <c:plotVisOnly val="1"/>
     <c:dispBlanksAs val="gap"/>
     <c:showDLblsOverMax val="0"/>
-    <c:extLst xmlns:w="http://schemas.openxmlformats.org/wordprocessingml/2006/main" xmlns:w15="http://schemas.microsoft.com/office/word/2012/wordml" xmlns:w14="http://schemas.microsoft.com/office/word/2010/wordml" xmlns:m="http://schemas.openxmlformats.org/officeDocument/2006/math" xmlns:wp="http://schemas.openxmlformats.org/drawingml/2006/wordprocessingDrawing" xmlns:wp14="http://schemas.microsoft.com/office/word/2010/wordprocessingDrawing" xmlns:mc="http://schemas.openxmlformats.org/markup-compatibility/2006" xmlns:sl="http://schemas.openxmlformats.org/schemaLibrary/2006/main" xmlns:wne="http://schemas.microsoft.com/office/word/2006/wordml" xmlns:cdr="http://schemas.openxmlformats.org/drawingml/2006/chartDrawing" xmlns:c14="http://schemas.microsoft.com/office/drawing/2007/8/2/chart" xmlns:dgm="http://schemas.openxmlformats.org/drawingml/2006/diagram" xmlns:pic="http://schemas.openxmlformats.org/drawingml/2006/picture" xmlns:xdr="http://schemas.openxmlformats.org/drawingml/2006/spreadsheetDrawing" xmlns:dsp="http://schemas.microsoft.com/office/drawing/2008/diagram" xmlns:xvml="urn:schemas-microsoft-com:office:excel" xmlns:o="urn:schemas-microsoft-com:office:office" xmlns:v="urn:schemas-microsoft-com:vml" xmlns:w10="urn:schemas-microsoft-com:office:word" xmlns:pvml="urn:schemas-microsoft-com:office:powerpoint" xmlns:cppr="http://schemas.microsoft.com/office/2006/coverPageProps" xmlns:odx="http://opendope.org/xpaths" xmlns:odc="http://opendope.org/conditions" xmlns:odq="http://opendope.org/questions" xmlns:oda="http://opendope.org/answers" xmlns:odi="http://opendope.org/components" xmlns:odgm="http://opendope.org/SmartArt/DataHierarchy" xmlns:b="http://schemas.openxmlformats.org/officeDocument/2006/bibliography" xmlns:wps="http://schemas.microsoft.com/office/word/2010/wordprocessingShape" xmlns:w16se="http://schemas.microsoft.com/office/word/2015/wordml/symex" xmlns:w16cid="http://schemas.microsoft.com/office/word/2016/wordml/cid" xmlns:wetp="http://schemas.microsoft.com/office/webextensions/taskpanes/2010/11" xmlns:we="http://schemas.microsoft.com/office/webextensions/webextension/2010/11" xmlns:comp="http://schemas.openxmlformats.org/drawingml/2006/compatibility" xmlns:lc="http://schemas.openxmlformats.org/drawingml/2006/lockedCanvas">
+    <c:extLst xmlns:lc="http://schemas.openxmlformats.org/drawingml/2006/lockedCanvas" xmlns:comp="http://schemas.openxmlformats.org/drawingml/2006/compatibility" xmlns:we="http://schemas.microsoft.com/office/webextensions/webextension/2010/11" xmlns:wetp="http://schemas.microsoft.com/office/webextensions/taskpanes/2010/11" xmlns:w16cid="http://schemas.microsoft.com/office/word/2016/wordml/cid" xmlns:w16se="http://schemas.microsoft.com/office/word/2015/wordml/symex" xmlns:wps="http://schemas.microsoft.com/office/word/2010/wordprocessingShape" xmlns:b="http://schemas.openxmlformats.org/officeDocument/2006/bibliography" xmlns:odgm="http://opendope.org/SmartArt/DataHierarchy" xmlns:odi="http://opendope.org/components" xmlns:oda="http://opendope.org/answers" xmlns:odq="http://opendope.org/questions" xmlns:odc="http://opendope.org/conditions" xmlns:odx="http://opendope.org/xpaths" xmlns:cppr="http://schemas.microsoft.com/office/2006/coverPageProps" xmlns:pvml="urn:schemas-microsoft-com:office:powerpoint" xmlns:w10="urn:schemas-microsoft-com:office:word" xmlns:v="urn:schemas-microsoft-com:vml" xmlns:o="urn:schemas-microsoft-com:office:office" xmlns:xvml="urn:schemas-microsoft-com:office:excel" xmlns:dsp="http://schemas.microsoft.com/office/drawing/2008/diagram" xmlns:xdr="http://schemas.openxmlformats.org/drawingml/2006/spreadsheetDrawing" xmlns:pic="http://schemas.openxmlformats.org/drawingml/2006/picture" xmlns:dgm="http://schemas.openxmlformats.org/drawingml/2006/diagram" xmlns:c14="http://schemas.microsoft.com/office/drawing/2007/8/2/chart" xmlns:cdr="http://schemas.openxmlformats.org/drawingml/2006/chartDrawing" xmlns:wne="http://schemas.microsoft.com/office/word/2006/wordml" xmlns:sl="http://schemas.openxmlformats.org/schemaLibrary/2006/main" xmlns:mc="http://schemas.openxmlformats.org/markup-compatibility/2006" xmlns:wp14="http://schemas.microsoft.com/office/word/2010/wordprocessingDrawing" xmlns:wp="http://schemas.openxmlformats.org/drawingml/2006/wordprocessingDrawing" xmlns:m="http://schemas.openxmlformats.org/officeDocument/2006/math" xmlns:w14="http://schemas.microsoft.com/office/word/2010/wordml" xmlns:w15="http://schemas.microsoft.com/office/word/2012/wordml" xmlns:w="http://schemas.openxmlformats.org/wordprocessingml/2006/main">
       <c:ext xmlns:c16r3="http://schemas.microsoft.com/office/drawing/2017/03/chart" uri="{56B9EC1D-385E-4148-901F-78D8002777C0}">
         <c16r3:dataDisplayOptions16>
           <c16r3:dispNaAsBlank val="1"/>
@@ -651,7 +656,7 @@
                 </a:outerShdw>
               </a:effectLst>
             </c:spPr>
-            <c:extLst xmlns:lc="http://schemas.openxmlformats.org/drawingml/2006/lockedCanvas" xmlns:comp="http://schemas.openxmlformats.org/drawingml/2006/compatibility" xmlns:we="http://schemas.microsoft.com/office/webextensions/webextension/2010/11" xmlns:wetp="http://schemas.microsoft.com/office/webextensions/taskpanes/2010/11" xmlns:w16cid="http://schemas.microsoft.com/office/word/2016/wordml/cid" xmlns:w16se="http://schemas.microsoft.com/office/word/2015/wordml/symex" xmlns:wps="http://schemas.microsoft.com/office/word/2010/wordprocessingShape" xmlns:b="http://schemas.openxmlformats.org/officeDocument/2006/bibliography" xmlns:odgm="http://opendope.org/SmartArt/DataHierarchy" xmlns:odi="http://opendope.org/components" xmlns:oda="http://opendope.org/answers" xmlns:odq="http://opendope.org/questions" xmlns:odc="http://opendope.org/conditions" xmlns:odx="http://opendope.org/xpaths" xmlns:cppr="http://schemas.microsoft.com/office/2006/coverPageProps" xmlns:pvml="urn:schemas-microsoft-com:office:powerpoint" xmlns:w10="urn:schemas-microsoft-com:office:word" xmlns:v="urn:schemas-microsoft-com:vml" xmlns:o="urn:schemas-microsoft-com:office:office" xmlns:xvml="urn:schemas-microsoft-com:office:excel" xmlns:dsp="http://schemas.microsoft.com/office/drawing/2008/diagram" xmlns:xdr="http://schemas.openxmlformats.org/drawingml/2006/spreadsheetDrawing" xmlns:pic="http://schemas.openxmlformats.org/drawingml/2006/picture" xmlns:dgm="http://schemas.openxmlformats.org/drawingml/2006/diagram" xmlns:c14="http://schemas.microsoft.com/office/drawing/2007/8/2/chart" xmlns:cdr="http://schemas.openxmlformats.org/drawingml/2006/chartDrawing" xmlns:wne="http://schemas.microsoft.com/office/word/2006/wordml" xmlns:sl="http://schemas.openxmlformats.org/schemaLibrary/2006/main" xmlns:mc="http://schemas.openxmlformats.org/markup-compatibility/2006" xmlns:wp14="http://schemas.microsoft.com/office/word/2010/wordprocessingDrawing" xmlns:wp="http://schemas.openxmlformats.org/drawingml/2006/wordprocessingDrawing" xmlns:m="http://schemas.openxmlformats.org/officeDocument/2006/math" xmlns:w14="http://schemas.microsoft.com/office/word/2010/wordml" xmlns:w15="http://schemas.microsoft.com/office/word/2012/wordml" xmlns:w="http://schemas.openxmlformats.org/wordprocessingml/2006/main">
+            <c:extLst xmlns:w="http://schemas.openxmlformats.org/wordprocessingml/2006/main" xmlns:w15="http://schemas.microsoft.com/office/word/2012/wordml" xmlns:w14="http://schemas.microsoft.com/office/word/2010/wordml" xmlns:m="http://schemas.openxmlformats.org/officeDocument/2006/math" xmlns:wp="http://schemas.openxmlformats.org/drawingml/2006/wordprocessingDrawing" xmlns:wp14="http://schemas.microsoft.com/office/word/2010/wordprocessingDrawing" xmlns:mc="http://schemas.openxmlformats.org/markup-compatibility/2006" xmlns:sl="http://schemas.openxmlformats.org/schemaLibrary/2006/main" xmlns:wne="http://schemas.microsoft.com/office/word/2006/wordml" xmlns:cdr="http://schemas.openxmlformats.org/drawingml/2006/chartDrawing" xmlns:c14="http://schemas.microsoft.com/office/drawing/2007/8/2/chart" xmlns:dgm="http://schemas.openxmlformats.org/drawingml/2006/diagram" xmlns:pic="http://schemas.openxmlformats.org/drawingml/2006/picture" xmlns:xdr="http://schemas.openxmlformats.org/drawingml/2006/spreadsheetDrawing" xmlns:dsp="http://schemas.microsoft.com/office/drawing/2008/diagram" xmlns:xvml="urn:schemas-microsoft-com:office:excel" xmlns:o="urn:schemas-microsoft-com:office:office" xmlns:v="urn:schemas-microsoft-com:vml" xmlns:w10="urn:schemas-microsoft-com:office:word" xmlns:pvml="urn:schemas-microsoft-com:office:powerpoint" xmlns:cppr="http://schemas.microsoft.com/office/2006/coverPageProps" xmlns:odx="http://opendope.org/xpaths" xmlns:odc="http://opendope.org/conditions" xmlns:odq="http://opendope.org/questions" xmlns:oda="http://opendope.org/answers" xmlns:odi="http://opendope.org/components" xmlns:odgm="http://opendope.org/SmartArt/DataHierarchy" xmlns:b="http://schemas.openxmlformats.org/officeDocument/2006/bibliography" xmlns:wps="http://schemas.microsoft.com/office/word/2010/wordprocessingShape" xmlns:w16se="http://schemas.microsoft.com/office/word/2015/wordml/symex" xmlns:w16cid="http://schemas.microsoft.com/office/word/2016/wordml/cid" xmlns:wetp="http://schemas.microsoft.com/office/webextensions/taskpanes/2010/11" xmlns:we="http://schemas.microsoft.com/office/webextensions/webextension/2010/11" xmlns:comp="http://schemas.openxmlformats.org/drawingml/2006/compatibility" xmlns:lc="http://schemas.openxmlformats.org/drawingml/2006/lockedCanvas">
               <c:ext xmlns:c16="http://schemas.microsoft.com/office/drawing/2014/chart" uri="{C3380CC4-5D6E-409C-BE32-E72D297353CC}">
                 <c16:uniqueId val="{00000001-6147-E74A-AA7B-5531F0E4EE0C}"/>
               </c:ext>
@@ -734,7 +739,7 @@
               </c:numCache>
             </c:numRef>
           </c:val>
-          <c:extLst xmlns:lc="http://schemas.openxmlformats.org/drawingml/2006/lockedCanvas" xmlns:comp="http://schemas.openxmlformats.org/drawingml/2006/compatibility" xmlns:we="http://schemas.microsoft.com/office/webextensions/webextension/2010/11" xmlns:wetp="http://schemas.microsoft.com/office/webextensions/taskpanes/2010/11" xmlns:w16cid="http://schemas.microsoft.com/office/word/2016/wordml/cid" xmlns:w16se="http://schemas.microsoft.com/office/word/2015/wordml/symex" xmlns:wps="http://schemas.microsoft.com/office/word/2010/wordprocessingShape" xmlns:b="http://schemas.openxmlformats.org/officeDocument/2006/bibliography" xmlns:odgm="http://opendope.org/SmartArt/DataHierarchy" xmlns:odi="http://opendope.org/components" xmlns:oda="http://opendope.org/answers" xmlns:odq="http://opendope.org/questions" xmlns:odc="http://opendope.org/conditions" xmlns:odx="http://opendope.org/xpaths" xmlns:cppr="http://schemas.microsoft.com/office/2006/coverPageProps" xmlns:pvml="urn:schemas-microsoft-com:office:powerpoint" xmlns:w10="urn:schemas-microsoft-com:office:word" xmlns:v="urn:schemas-microsoft-com:vml" xmlns:o="urn:schemas-microsoft-com:office:office" xmlns:xvml="urn:schemas-microsoft-com:office:excel" xmlns:dsp="http://schemas.microsoft.com/office/drawing/2008/diagram" xmlns:xdr="http://schemas.openxmlformats.org/drawingml/2006/spreadsheetDrawing" xmlns:pic="http://schemas.openxmlformats.org/drawingml/2006/picture" xmlns:dgm="http://schemas.openxmlformats.org/drawingml/2006/diagram" xmlns:c14="http://schemas.microsoft.com/office/drawing/2007/8/2/chart" xmlns:cdr="http://schemas.openxmlformats.org/drawingml/2006/chartDrawing" xmlns:wne="http://schemas.microsoft.com/office/word/2006/wordml" xmlns:sl="http://schemas.openxmlformats.org/schemaLibrary/2006/main" xmlns:mc="http://schemas.openxmlformats.org/markup-compatibility/2006" xmlns:wp14="http://schemas.microsoft.com/office/word/2010/wordprocessingDrawing" xmlns:wp="http://schemas.openxmlformats.org/drawingml/2006/wordprocessingDrawing" xmlns:m="http://schemas.openxmlformats.org/officeDocument/2006/math" xmlns:w14="http://schemas.microsoft.com/office/word/2010/wordml" xmlns:w15="http://schemas.microsoft.com/office/word/2012/wordml" xmlns:w="http://schemas.openxmlformats.org/wordprocessingml/2006/main">
+          <c:extLst xmlns:w="http://schemas.openxmlformats.org/wordprocessingml/2006/main" xmlns:w15="http://schemas.microsoft.com/office/word/2012/wordml" xmlns:w14="http://schemas.microsoft.com/office/word/2010/wordml" xmlns:m="http://schemas.openxmlformats.org/officeDocument/2006/math" xmlns:wp="http://schemas.openxmlformats.org/drawingml/2006/wordprocessingDrawing" xmlns:wp14="http://schemas.microsoft.com/office/word/2010/wordprocessingDrawing" xmlns:mc="http://schemas.openxmlformats.org/markup-compatibility/2006" xmlns:sl="http://schemas.openxmlformats.org/schemaLibrary/2006/main" xmlns:wne="http://schemas.microsoft.com/office/word/2006/wordml" xmlns:cdr="http://schemas.openxmlformats.org/drawingml/2006/chartDrawing" xmlns:c14="http://schemas.microsoft.com/office/drawing/2007/8/2/chart" xmlns:dgm="http://schemas.openxmlformats.org/drawingml/2006/diagram" xmlns:pic="http://schemas.openxmlformats.org/drawingml/2006/picture" xmlns:xdr="http://schemas.openxmlformats.org/drawingml/2006/spreadsheetDrawing" xmlns:dsp="http://schemas.microsoft.com/office/drawing/2008/diagram" xmlns:xvml="urn:schemas-microsoft-com:office:excel" xmlns:o="urn:schemas-microsoft-com:office:office" xmlns:v="urn:schemas-microsoft-com:vml" xmlns:w10="urn:schemas-microsoft-com:office:word" xmlns:pvml="urn:schemas-microsoft-com:office:powerpoint" xmlns:cppr="http://schemas.microsoft.com/office/2006/coverPageProps" xmlns:odx="http://opendope.org/xpaths" xmlns:odc="http://opendope.org/conditions" xmlns:odq="http://opendope.org/questions" xmlns:oda="http://opendope.org/answers" xmlns:odi="http://opendope.org/components" xmlns:odgm="http://opendope.org/SmartArt/DataHierarchy" xmlns:b="http://schemas.openxmlformats.org/officeDocument/2006/bibliography" xmlns:wps="http://schemas.microsoft.com/office/word/2010/wordprocessingShape" xmlns:w16se="http://schemas.microsoft.com/office/word/2015/wordml/symex" xmlns:w16cid="http://schemas.microsoft.com/office/word/2016/wordml/cid" xmlns:wetp="http://schemas.microsoft.com/office/webextensions/taskpanes/2010/11" xmlns:we="http://schemas.microsoft.com/office/webextensions/webextension/2010/11" xmlns:comp="http://schemas.openxmlformats.org/drawingml/2006/compatibility" xmlns:lc="http://schemas.openxmlformats.org/drawingml/2006/lockedCanvas">
             <c:ext xmlns:c16="http://schemas.microsoft.com/office/drawing/2014/chart" uri="{C3380CC4-5D6E-409C-BE32-E72D297353CC}">
               <c16:uniqueId val="{00000002-6147-E74A-AA7B-5531F0E4EE0C}"/>
             </c:ext>
@@ -1297,7 +1302,7 @@
     <c:plotVisOnly val="1"/>
     <c:dispBlanksAs val="gap"/>
     <c:showDLblsOverMax val="0"/>
-    <c:extLst xmlns:lc="http://schemas.openxmlformats.org/drawingml/2006/lockedCanvas" xmlns:comp="http://schemas.openxmlformats.org/drawingml/2006/compatibility" xmlns:we="http://schemas.microsoft.com/office/webextensions/webextension/2010/11" xmlns:wetp="http://schemas.microsoft.com/office/webextensions/taskpanes/2010/11" xmlns:w16cid="http://schemas.microsoft.com/office/word/2016/wordml/cid" xmlns:w16se="http://schemas.microsoft.com/office/word/2015/wordml/symex" xmlns:wps="http://schemas.microsoft.com/office/word/2010/wordprocessingShape" xmlns:b="http://schemas.openxmlformats.org/officeDocument/2006/bibliography" xmlns:odgm="http://opendope.org/SmartArt/DataHierarchy" xmlns:odi="http://opendope.org/components" xmlns:oda="http://opendope.org/answers" xmlns:odq="http://opendope.org/questions" xmlns:odc="http://opendope.org/conditions" xmlns:odx="http://opendope.org/xpaths" xmlns:cppr="http://schemas.microsoft.com/office/2006/coverPageProps" xmlns:pvml="urn:schemas-microsoft-com:office:powerpoint" xmlns:w10="urn:schemas-microsoft-com:office:word" xmlns:v="urn:schemas-microsoft-com:vml" xmlns:o="urn:schemas-microsoft-com:office:office" xmlns:xvml="urn:schemas-microsoft-com:office:excel" xmlns:dsp="http://schemas.microsoft.com/office/drawing/2008/diagram" xmlns:xdr="http://schemas.openxmlformats.org/drawingml/2006/spreadsheetDrawing" xmlns:pic="http://schemas.openxmlformats.org/drawingml/2006/picture" xmlns:dgm="http://schemas.openxmlformats.org/drawingml/2006/diagram" xmlns:c14="http://schemas.microsoft.com/office/drawing/2007/8/2/chart" xmlns:cdr="http://schemas.openxmlformats.org/drawingml/2006/chartDrawing" xmlns:wne="http://schemas.microsoft.com/office/word/2006/wordml" xmlns:sl="http://schemas.openxmlformats.org/schemaLibrary/2006/main" xmlns:mc="http://schemas.openxmlformats.org/markup-compatibility/2006" xmlns:wp14="http://schemas.microsoft.com/office/word/2010/wordprocessingDrawing" xmlns:wp="http://schemas.openxmlformats.org/drawingml/2006/wordprocessingDrawing" xmlns:m="http://schemas.openxmlformats.org/officeDocument/2006/math" xmlns:w14="http://schemas.microsoft.com/office/word/2010/wordml" xmlns:w15="http://schemas.microsoft.com/office/word/2012/wordml" xmlns:w="http://schemas.openxmlformats.org/wordprocessingml/2006/main">
+    <c:extLst xmlns:w="http://schemas.openxmlformats.org/wordprocessingml/2006/main" xmlns:w15="http://schemas.microsoft.com/office/word/2012/wordml" xmlns:w14="http://schemas.microsoft.com/office/word/2010/wordml" xmlns:m="http://schemas.openxmlformats.org/officeDocument/2006/math" xmlns:wp="http://schemas.openxmlformats.org/drawingml/2006/wordprocessingDrawing" xmlns:wp14="http://schemas.microsoft.com/office/word/2010/wordprocessingDrawing" xmlns:mc="http://schemas.openxmlformats.org/markup-compatibility/2006" xmlns:sl="http://schemas.openxmlformats.org/schemaLibrary/2006/main" xmlns:wne="http://schemas.microsoft.com/office/word/2006/wordml" xmlns:cdr="http://schemas.openxmlformats.org/drawingml/2006/chartDrawing" xmlns:c14="http://schemas.microsoft.com/office/drawing/2007/8/2/chart" xmlns:dgm="http://schemas.openxmlformats.org/drawingml/2006/diagram" xmlns:pic="http://schemas.openxmlformats.org/drawingml/2006/picture" xmlns:xdr="http://schemas.openxmlformats.org/drawingml/2006/spreadsheetDrawing" xmlns:dsp="http://schemas.microsoft.com/office/drawing/2008/diagram" xmlns:xvml="urn:schemas-microsoft-com:office:excel" xmlns:o="urn:schemas-microsoft-com:office:office" xmlns:v="urn:schemas-microsoft-com:vml" xmlns:w10="urn:schemas-microsoft-com:office:word" xmlns:pvml="urn:schemas-microsoft-com:office:powerpoint" xmlns:cppr="http://schemas.microsoft.com/office/2006/coverPageProps" xmlns:odx="http://opendope.org/xpaths" xmlns:odc="http://opendope.org/conditions" xmlns:odq="http://opendope.org/questions" xmlns:oda="http://opendope.org/answers" xmlns:odi="http://opendope.org/components" xmlns:odgm="http://opendope.org/SmartArt/DataHierarchy" xmlns:b="http://schemas.openxmlformats.org/officeDocument/2006/bibliography" xmlns:wps="http://schemas.microsoft.com/office/word/2010/wordprocessingShape" xmlns:w16se="http://schemas.microsoft.com/office/word/2015/wordml/symex" xmlns:w16cid="http://schemas.microsoft.com/office/word/2016/wordml/cid" xmlns:wetp="http://schemas.microsoft.com/office/webextensions/taskpanes/2010/11" xmlns:we="http://schemas.microsoft.com/office/webextensions/webextension/2010/11" xmlns:comp="http://schemas.openxmlformats.org/drawingml/2006/compatibility" xmlns:lc="http://schemas.openxmlformats.org/drawingml/2006/lockedCanvas">
       <c:ext xmlns:c16r3="http://schemas.microsoft.com/office/drawing/2017/03/chart" uri="{56B9EC1D-385E-4148-901F-78D8002777C0}">
         <c16r3:dataDisplayOptions16>
           <c16r3:dispNaAsBlank val="1"/>
@@ -1399,7 +1404,7 @@
                 </a:outerShdw>
               </a:effectLst>
             </c:spPr>
-            <c:extLst xmlns:w="http://schemas.openxmlformats.org/wordprocessingml/2006/main" xmlns:w15="http://schemas.microsoft.com/office/word/2012/wordml" xmlns:w14="http://schemas.microsoft.com/office/word/2010/wordml" xmlns:m="http://schemas.openxmlformats.org/officeDocument/2006/math" xmlns:wp="http://schemas.openxmlformats.org/drawingml/2006/wordprocessingDrawing" xmlns:wp14="http://schemas.microsoft.com/office/word/2010/wordprocessingDrawing" xmlns:mc="http://schemas.openxmlformats.org/markup-compatibility/2006" xmlns:sl="http://schemas.openxmlformats.org/schemaLibrary/2006/main" xmlns:wne="http://schemas.microsoft.com/office/word/2006/wordml" xmlns:cdr="http://schemas.openxmlformats.org/drawingml/2006/chartDrawing" xmlns:c14="http://schemas.microsoft.com/office/drawing/2007/8/2/chart" xmlns:dgm="http://schemas.openxmlformats.org/drawingml/2006/diagram" xmlns:pic="http://schemas.openxmlformats.org/drawingml/2006/picture" xmlns:xdr="http://schemas.openxmlformats.org/drawingml/2006/spreadsheetDrawing" xmlns:dsp="http://schemas.microsoft.com/office/drawing/2008/diagram" xmlns:xvml="urn:schemas-microsoft-com:office:excel" xmlns:o="urn:schemas-microsoft-com:office:office" xmlns:v="urn:schemas-microsoft-com:vml" xmlns:w10="urn:schemas-microsoft-com:office:word" xmlns:pvml="urn:schemas-microsoft-com:office:powerpoint" xmlns:cppr="http://schemas.microsoft.com/office/2006/coverPageProps" xmlns:odx="http://opendope.org/xpaths" xmlns:odc="http://opendope.org/conditions" xmlns:odq="http://opendope.org/questions" xmlns:oda="http://opendope.org/answers" xmlns:odi="http://opendope.org/components" xmlns:odgm="http://opendope.org/SmartArt/DataHierarchy" xmlns:b="http://schemas.openxmlformats.org/officeDocument/2006/bibliography" xmlns:wps="http://schemas.microsoft.com/office/word/2010/wordprocessingShape" xmlns:w16se="http://schemas.microsoft.com/office/word/2015/wordml/symex" xmlns:w16cid="http://schemas.microsoft.com/office/word/2016/wordml/cid" xmlns:wetp="http://schemas.microsoft.com/office/webextensions/taskpanes/2010/11" xmlns:we="http://schemas.microsoft.com/office/webextensions/webextension/2010/11" xmlns:comp="http://schemas.openxmlformats.org/drawingml/2006/compatibility" xmlns:lc="http://schemas.openxmlformats.org/drawingml/2006/lockedCanvas">
+            <c:extLst xmlns:lc="http://schemas.openxmlformats.org/drawingml/2006/lockedCanvas" xmlns:comp="http://schemas.openxmlformats.org/drawingml/2006/compatibility" xmlns:we="http://schemas.microsoft.com/office/webextensions/webextension/2010/11" xmlns:wetp="http://schemas.microsoft.com/office/webextensions/taskpanes/2010/11" xmlns:w16cid="http://schemas.microsoft.com/office/word/2016/wordml/cid" xmlns:w16se="http://schemas.microsoft.com/office/word/2015/wordml/symex" xmlns:wps="http://schemas.microsoft.com/office/word/2010/wordprocessingShape" xmlns:b="http://schemas.openxmlformats.org/officeDocument/2006/bibliography" xmlns:odgm="http://opendope.org/SmartArt/DataHierarchy" xmlns:odi="http://opendope.org/components" xmlns:oda="http://opendope.org/answers" xmlns:odq="http://opendope.org/questions" xmlns:odc="http://opendope.org/conditions" xmlns:odx="http://opendope.org/xpaths" xmlns:cppr="http://schemas.microsoft.com/office/2006/coverPageProps" xmlns:pvml="urn:schemas-microsoft-com:office:powerpoint" xmlns:w10="urn:schemas-microsoft-com:office:word" xmlns:v="urn:schemas-microsoft-com:vml" xmlns:o="urn:schemas-microsoft-com:office:office" xmlns:xvml="urn:schemas-microsoft-com:office:excel" xmlns:dsp="http://schemas.microsoft.com/office/drawing/2008/diagram" xmlns:xdr="http://schemas.openxmlformats.org/drawingml/2006/spreadsheetDrawing" xmlns:pic="http://schemas.openxmlformats.org/drawingml/2006/picture" xmlns:dgm="http://schemas.openxmlformats.org/drawingml/2006/diagram" xmlns:c14="http://schemas.microsoft.com/office/drawing/2007/8/2/chart" xmlns:cdr="http://schemas.openxmlformats.org/drawingml/2006/chartDrawing" xmlns:wne="http://schemas.microsoft.com/office/word/2006/wordml" xmlns:sl="http://schemas.openxmlformats.org/schemaLibrary/2006/main" xmlns:mc="http://schemas.openxmlformats.org/markup-compatibility/2006" xmlns:wp14="http://schemas.microsoft.com/office/word/2010/wordprocessingDrawing" xmlns:wp="http://schemas.openxmlformats.org/drawingml/2006/wordprocessingDrawing" xmlns:m="http://schemas.openxmlformats.org/officeDocument/2006/math" xmlns:w14="http://schemas.microsoft.com/office/word/2010/wordml" xmlns:w15="http://schemas.microsoft.com/office/word/2012/wordml" xmlns:w="http://schemas.openxmlformats.org/wordprocessingml/2006/main">
               <c:ext xmlns:c16="http://schemas.microsoft.com/office/drawing/2014/chart" uri="{C3380CC4-5D6E-409C-BE32-E72D297353CC}">
                 <c16:uniqueId val="{00000001-6147-E74A-AA7B-5531F0E4EE0C}"/>
               </c:ext>
@@ -1482,7 +1487,7 @@
               </c:numCache>
             </c:numRef>
           </c:val>
-          <c:extLst xmlns:w="http://schemas.openxmlformats.org/wordprocessingml/2006/main" xmlns:w15="http://schemas.microsoft.com/office/word/2012/wordml" xmlns:w14="http://schemas.microsoft.com/office/word/2010/wordml" xmlns:m="http://schemas.openxmlformats.org/officeDocument/2006/math" xmlns:wp="http://schemas.openxmlformats.org/drawingml/2006/wordprocessingDrawing" xmlns:wp14="http://schemas.microsoft.com/office/word/2010/wordprocessingDrawing" xmlns:mc="http://schemas.openxmlformats.org/markup-compatibility/2006" xmlns:sl="http://schemas.openxmlformats.org/schemaLibrary/2006/main" xmlns:wne="http://schemas.microsoft.com/office/word/2006/wordml" xmlns:cdr="http://schemas.openxmlformats.org/drawingml/2006/chartDrawing" xmlns:c14="http://schemas.microsoft.com/office/drawing/2007/8/2/chart" xmlns:dgm="http://schemas.openxmlformats.org/drawingml/2006/diagram" xmlns:pic="http://schemas.openxmlformats.org/drawingml/2006/picture" xmlns:xdr="http://schemas.openxmlformats.org/drawingml/2006/spreadsheetDrawing" xmlns:dsp="http://schemas.microsoft.com/office/drawing/2008/diagram" xmlns:xvml="urn:schemas-microsoft-com:office:excel" xmlns:o="urn:schemas-microsoft-com:office:office" xmlns:v="urn:schemas-microsoft-com:vml" xmlns:w10="urn:schemas-microsoft-com:office:word" xmlns:pvml="urn:schemas-microsoft-com:office:powerpoint" xmlns:cppr="http://schemas.microsoft.com/office/2006/coverPageProps" xmlns:odx="http://opendope.org/xpaths" xmlns:odc="http://opendope.org/conditions" xmlns:odq="http://opendope.org/questions" xmlns:oda="http://opendope.org/answers" xmlns:odi="http://opendope.org/components" xmlns:odgm="http://opendope.org/SmartArt/DataHierarchy" xmlns:b="http://schemas.openxmlformats.org/officeDocument/2006/bibliography" xmlns:wps="http://schemas.microsoft.com/office/word/2010/wordprocessingShape" xmlns:w16se="http://schemas.microsoft.com/office/word/2015/wordml/symex" xmlns:w16cid="http://schemas.microsoft.com/office/word/2016/wordml/cid" xmlns:wetp="http://schemas.microsoft.com/office/webextensions/taskpanes/2010/11" xmlns:we="http://schemas.microsoft.com/office/webextensions/webextension/2010/11" xmlns:comp="http://schemas.openxmlformats.org/drawingml/2006/compatibility" xmlns:lc="http://schemas.openxmlformats.org/drawingml/2006/lockedCanvas">
+          <c:extLst xmlns:lc="http://schemas.openxmlformats.org/drawingml/2006/lockedCanvas" xmlns:comp="http://schemas.openxmlformats.org/drawingml/2006/compatibility" xmlns:we="http://schemas.microsoft.com/office/webextensions/webextension/2010/11" xmlns:wetp="http://schemas.microsoft.com/office/webextensions/taskpanes/2010/11" xmlns:w16cid="http://schemas.microsoft.com/office/word/2016/wordml/cid" xmlns:w16se="http://schemas.microsoft.com/office/word/2015/wordml/symex" xmlns:wps="http://schemas.microsoft.com/office/word/2010/wordprocessingShape" xmlns:b="http://schemas.openxmlformats.org/officeDocument/2006/bibliography" xmlns:odgm="http://opendope.org/SmartArt/DataHierarchy" xmlns:odi="http://opendope.org/components" xmlns:oda="http://opendope.org/answers" xmlns:odq="http://opendope.org/questions" xmlns:odc="http://opendope.org/conditions" xmlns:odx="http://opendope.org/xpaths" xmlns:cppr="http://schemas.microsoft.com/office/2006/coverPageProps" xmlns:pvml="urn:schemas-microsoft-com:office:powerpoint" xmlns:w10="urn:schemas-microsoft-com:office:word" xmlns:v="urn:schemas-microsoft-com:vml" xmlns:o="urn:schemas-microsoft-com:office:office" xmlns:xvml="urn:schemas-microsoft-com:office:excel" xmlns:dsp="http://schemas.microsoft.com/office/drawing/2008/diagram" xmlns:xdr="http://schemas.openxmlformats.org/drawingml/2006/spreadsheetDrawing" xmlns:pic="http://schemas.openxmlformats.org/drawingml/2006/picture" xmlns:dgm="http://schemas.openxmlformats.org/drawingml/2006/diagram" xmlns:c14="http://schemas.microsoft.com/office/drawing/2007/8/2/chart" xmlns:cdr="http://schemas.openxmlformats.org/drawingml/2006/chartDrawing" xmlns:wne="http://schemas.microsoft.com/office/word/2006/wordml" xmlns:sl="http://schemas.openxmlformats.org/schemaLibrary/2006/main" xmlns:mc="http://schemas.openxmlformats.org/markup-compatibility/2006" xmlns:wp14="http://schemas.microsoft.com/office/word/2010/wordprocessingDrawing" xmlns:wp="http://schemas.openxmlformats.org/drawingml/2006/wordprocessingDrawing" xmlns:m="http://schemas.openxmlformats.org/officeDocument/2006/math" xmlns:w14="http://schemas.microsoft.com/office/word/2010/wordml" xmlns:w15="http://schemas.microsoft.com/office/word/2012/wordml" xmlns:w="http://schemas.openxmlformats.org/wordprocessingml/2006/main">
             <c:ext xmlns:c16="http://schemas.microsoft.com/office/drawing/2014/chart" uri="{C3380CC4-5D6E-409C-BE32-E72D297353CC}">
               <c16:uniqueId val="{00000002-6147-E74A-AA7B-5531F0E4EE0C}"/>
             </c:ext>
@@ -2045,7 +2050,7 @@
     <c:plotVisOnly val="1"/>
     <c:dispBlanksAs val="gap"/>
     <c:showDLblsOverMax val="0"/>
-    <c:extLst xmlns:w="http://schemas.openxmlformats.org/wordprocessingml/2006/main" xmlns:w15="http://schemas.microsoft.com/office/word/2012/wordml" xmlns:w14="http://schemas.microsoft.com/office/word/2010/wordml" xmlns:m="http://schemas.openxmlformats.org/officeDocument/2006/math" xmlns:wp="http://schemas.openxmlformats.org/drawingml/2006/wordprocessingDrawing" xmlns:wp14="http://schemas.microsoft.com/office/word/2010/wordprocessingDrawing" xmlns:mc="http://schemas.openxmlformats.org/markup-compatibility/2006" xmlns:sl="http://schemas.openxmlformats.org/schemaLibrary/2006/main" xmlns:wne="http://schemas.microsoft.com/office/word/2006/wordml" xmlns:cdr="http://schemas.openxmlformats.org/drawingml/2006/chartDrawing" xmlns:c14="http://schemas.microsoft.com/office/drawing/2007/8/2/chart" xmlns:dgm="http://schemas.openxmlformats.org/drawingml/2006/diagram" xmlns:pic="http://schemas.openxmlformats.org/drawingml/2006/picture" xmlns:xdr="http://schemas.openxmlformats.org/drawingml/2006/spreadsheetDrawing" xmlns:dsp="http://schemas.microsoft.com/office/drawing/2008/diagram" xmlns:xvml="urn:schemas-microsoft-com:office:excel" xmlns:o="urn:schemas-microsoft-com:office:office" xmlns:v="urn:schemas-microsoft-com:vml" xmlns:w10="urn:schemas-microsoft-com:office:word" xmlns:pvml="urn:schemas-microsoft-com:office:powerpoint" xmlns:cppr="http://schemas.microsoft.com/office/2006/coverPageProps" xmlns:odx="http://opendope.org/xpaths" xmlns:odc="http://opendope.org/conditions" xmlns:odq="http://opendope.org/questions" xmlns:oda="http://opendope.org/answers" xmlns:odi="http://opendope.org/components" xmlns:odgm="http://opendope.org/SmartArt/DataHierarchy" xmlns:b="http://schemas.openxmlformats.org/officeDocument/2006/bibliography" xmlns:wps="http://schemas.microsoft.com/office/word/2010/wordprocessingShape" xmlns:w16se="http://schemas.microsoft.com/office/word/2015/wordml/symex" xmlns:w16cid="http://schemas.microsoft.com/office/word/2016/wordml/cid" xmlns:wetp="http://schemas.microsoft.com/office/webextensions/taskpanes/2010/11" xmlns:we="http://schemas.microsoft.com/office/webextensions/webextension/2010/11" xmlns:comp="http://schemas.openxmlformats.org/drawingml/2006/compatibility" xmlns:lc="http://schemas.openxmlformats.org/drawingml/2006/lockedCanvas">
+    <c:extLst xmlns:lc="http://schemas.openxmlformats.org/drawingml/2006/lockedCanvas" xmlns:comp="http://schemas.openxmlformats.org/drawingml/2006/compatibility" xmlns:we="http://schemas.microsoft.com/office/webextensions/webextension/2010/11" xmlns:wetp="http://schemas.microsoft.com/office/webextensions/taskpanes/2010/11" xmlns:w16cid="http://schemas.microsoft.com/office/word/2016/wordml/cid" xmlns:w16se="http://schemas.microsoft.com/office/word/2015/wordml/symex" xmlns:wps="http://schemas.microsoft.com/office/word/2010/wordprocessingShape" xmlns:b="http://schemas.openxmlformats.org/officeDocument/2006/bibliography" xmlns:odgm="http://opendope.org/SmartArt/DataHierarchy" xmlns:odi="http://opendope.org/components" xmlns:oda="http://opendope.org/answers" xmlns:odq="http://opendope.org/questions" xmlns:odc="http://opendope.org/conditions" xmlns:odx="http://opendope.org/xpaths" xmlns:cppr="http://schemas.microsoft.com/office/2006/coverPageProps" xmlns:pvml="urn:schemas-microsoft-com:office:powerpoint" xmlns:w10="urn:schemas-microsoft-com:office:word" xmlns:v="urn:schemas-microsoft-com:vml" xmlns:o="urn:schemas-microsoft-com:office:office" xmlns:xvml="urn:schemas-microsoft-com:office:excel" xmlns:dsp="http://schemas.microsoft.com/office/drawing/2008/diagram" xmlns:xdr="http://schemas.openxmlformats.org/drawingml/2006/spreadsheetDrawing" xmlns:pic="http://schemas.openxmlformats.org/drawingml/2006/picture" xmlns:dgm="http://schemas.openxmlformats.org/drawingml/2006/diagram" xmlns:c14="http://schemas.microsoft.com/office/drawing/2007/8/2/chart" xmlns:cdr="http://schemas.openxmlformats.org/drawingml/2006/chartDrawing" xmlns:wne="http://schemas.microsoft.com/office/word/2006/wordml" xmlns:sl="http://schemas.openxmlformats.org/schemaLibrary/2006/main" xmlns:mc="http://schemas.openxmlformats.org/markup-compatibility/2006" xmlns:wp14="http://schemas.microsoft.com/office/word/2010/wordprocessingDrawing" xmlns:wp="http://schemas.openxmlformats.org/drawingml/2006/wordprocessingDrawing" xmlns:m="http://schemas.openxmlformats.org/officeDocument/2006/math" xmlns:w14="http://schemas.microsoft.com/office/word/2010/wordml" xmlns:w15="http://schemas.microsoft.com/office/word/2012/wordml" xmlns:w="http://schemas.openxmlformats.org/wordprocessingml/2006/main">
       <c:ext xmlns:c16r3="http://schemas.microsoft.com/office/drawing/2017/03/chart" uri="{56B9EC1D-385E-4148-901F-78D8002777C0}">
         <c16r3:dataDisplayOptions16>
           <c16r3:dispNaAsBlank val="1"/>
@@ -2147,7 +2152,7 @@
                 </a:outerShdw>
               </a:effectLst>
             </c:spPr>
-            <c:extLst xmlns:lc="http://schemas.openxmlformats.org/drawingml/2006/lockedCanvas" xmlns:comp="http://schemas.openxmlformats.org/drawingml/2006/compatibility" xmlns:we="http://schemas.microsoft.com/office/webextensions/webextension/2010/11" xmlns:wetp="http://schemas.microsoft.com/office/webextensions/taskpanes/2010/11" xmlns:w16cid="http://schemas.microsoft.com/office/word/2016/wordml/cid" xmlns:w16se="http://schemas.microsoft.com/office/word/2015/wordml/symex" xmlns:wps="http://schemas.microsoft.com/office/word/2010/wordprocessingShape" xmlns:b="http://schemas.openxmlformats.org/officeDocument/2006/bibliography" xmlns:odgm="http://opendope.org/SmartArt/DataHierarchy" xmlns:odi="http://opendope.org/components" xmlns:oda="http://opendope.org/answers" xmlns:odq="http://opendope.org/questions" xmlns:odc="http://opendope.org/conditions" xmlns:odx="http://opendope.org/xpaths" xmlns:cppr="http://schemas.microsoft.com/office/2006/coverPageProps" xmlns:pvml="urn:schemas-microsoft-com:office:powerpoint" xmlns:w10="urn:schemas-microsoft-com:office:word" xmlns:v="urn:schemas-microsoft-com:vml" xmlns:o="urn:schemas-microsoft-com:office:office" xmlns:xvml="urn:schemas-microsoft-com:office:excel" xmlns:dsp="http://schemas.microsoft.com/office/drawing/2008/diagram" xmlns:xdr="http://schemas.openxmlformats.org/drawingml/2006/spreadsheetDrawing" xmlns:pic="http://schemas.openxmlformats.org/drawingml/2006/picture" xmlns:dgm="http://schemas.openxmlformats.org/drawingml/2006/diagram" xmlns:c14="http://schemas.microsoft.com/office/drawing/2007/8/2/chart" xmlns:cdr="http://schemas.openxmlformats.org/drawingml/2006/chartDrawing" xmlns:wne="http://schemas.microsoft.com/office/word/2006/wordml" xmlns:sl="http://schemas.openxmlformats.org/schemaLibrary/2006/main" xmlns:mc="http://schemas.openxmlformats.org/markup-compatibility/2006" xmlns:wp14="http://schemas.microsoft.com/office/word/2010/wordprocessingDrawing" xmlns:wp="http://schemas.openxmlformats.org/drawingml/2006/wordprocessingDrawing" xmlns:m="http://schemas.openxmlformats.org/officeDocument/2006/math" xmlns:w14="http://schemas.microsoft.com/office/word/2010/wordml" xmlns:w15="http://schemas.microsoft.com/office/word/2012/wordml" xmlns:w="http://schemas.openxmlformats.org/wordprocessingml/2006/main">
+            <c:extLst xmlns:w="http://schemas.openxmlformats.org/wordprocessingml/2006/main" xmlns:w15="http://schemas.microsoft.com/office/word/2012/wordml" xmlns:w14="http://schemas.microsoft.com/office/word/2010/wordml" xmlns:m="http://schemas.openxmlformats.org/officeDocument/2006/math" xmlns:wp="http://schemas.openxmlformats.org/drawingml/2006/wordprocessingDrawing" xmlns:wp14="http://schemas.microsoft.com/office/word/2010/wordprocessingDrawing" xmlns:mc="http://schemas.openxmlformats.org/markup-compatibility/2006" xmlns:sl="http://schemas.openxmlformats.org/schemaLibrary/2006/main" xmlns:wne="http://schemas.microsoft.com/office/word/2006/wordml" xmlns:cdr="http://schemas.openxmlformats.org/drawingml/2006/chartDrawing" xmlns:c14="http://schemas.microsoft.com/office/drawing/2007/8/2/chart" xmlns:dgm="http://schemas.openxmlformats.org/drawingml/2006/diagram" xmlns:pic="http://schemas.openxmlformats.org/drawingml/2006/picture" xmlns:xdr="http://schemas.openxmlformats.org/drawingml/2006/spreadsheetDrawing" xmlns:dsp="http://schemas.microsoft.com/office/drawing/2008/diagram" xmlns:xvml="urn:schemas-microsoft-com:office:excel" xmlns:o="urn:schemas-microsoft-com:office:office" xmlns:v="urn:schemas-microsoft-com:vml" xmlns:w10="urn:schemas-microsoft-com:office:word" xmlns:pvml="urn:schemas-microsoft-com:office:powerpoint" xmlns:cppr="http://schemas.microsoft.com/office/2006/coverPageProps" xmlns:odx="http://opendope.org/xpaths" xmlns:odc="http://opendope.org/conditions" xmlns:odq="http://opendope.org/questions" xmlns:oda="http://opendope.org/answers" xmlns:odi="http://opendope.org/components" xmlns:odgm="http://opendope.org/SmartArt/DataHierarchy" xmlns:b="http://schemas.openxmlformats.org/officeDocument/2006/bibliography" xmlns:wps="http://schemas.microsoft.com/office/word/2010/wordprocessingShape" xmlns:w16se="http://schemas.microsoft.com/office/word/2015/wordml/symex" xmlns:w16cid="http://schemas.microsoft.com/office/word/2016/wordml/cid" xmlns:wetp="http://schemas.microsoft.com/office/webextensions/taskpanes/2010/11" xmlns:we="http://schemas.microsoft.com/office/webextensions/webextension/2010/11" xmlns:comp="http://schemas.openxmlformats.org/drawingml/2006/compatibility" xmlns:lc="http://schemas.openxmlformats.org/drawingml/2006/lockedCanvas">
               <c:ext xmlns:c16="http://schemas.microsoft.com/office/drawing/2014/chart" uri="{C3380CC4-5D6E-409C-BE32-E72D297353CC}">
                 <c16:uniqueId val="{00000001-6147-E74A-AA7B-5531F0E4EE0C}"/>
               </c:ext>
@@ -2242,7 +2247,7 @@
               </c:numCache>
             </c:numRef>
           </c:val>
-          <c:extLst xmlns:lc="http://schemas.openxmlformats.org/drawingml/2006/lockedCanvas" xmlns:comp="http://schemas.openxmlformats.org/drawingml/2006/compatibility" xmlns:we="http://schemas.microsoft.com/office/webextensions/webextension/2010/11" xmlns:wetp="http://schemas.microsoft.com/office/webextensions/taskpanes/2010/11" xmlns:w16cid="http://schemas.microsoft.com/office/word/2016/wordml/cid" xmlns:w16se="http://schemas.microsoft.com/office/word/2015/wordml/symex" xmlns:wps="http://schemas.microsoft.com/office/word/2010/wordprocessingShape" xmlns:b="http://schemas.openxmlformats.org/officeDocument/2006/bibliography" xmlns:odgm="http://opendope.org/SmartArt/DataHierarchy" xmlns:odi="http://opendope.org/components" xmlns:oda="http://opendope.org/answers" xmlns:odq="http://opendope.org/questions" xmlns:odc="http://opendope.org/conditions" xmlns:odx="http://opendope.org/xpaths" xmlns:cppr="http://schemas.microsoft.com/office/2006/coverPageProps" xmlns:pvml="urn:schemas-microsoft-com:office:powerpoint" xmlns:w10="urn:schemas-microsoft-com:office:word" xmlns:v="urn:schemas-microsoft-com:vml" xmlns:o="urn:schemas-microsoft-com:office:office" xmlns:xvml="urn:schemas-microsoft-com:office:excel" xmlns:dsp="http://schemas.microsoft.com/office/drawing/2008/diagram" xmlns:xdr="http://schemas.openxmlformats.org/drawingml/2006/spreadsheetDrawing" xmlns:pic="http://schemas.openxmlformats.org/drawingml/2006/picture" xmlns:dgm="http://schemas.openxmlformats.org/drawingml/2006/diagram" xmlns:c14="http://schemas.microsoft.com/office/drawing/2007/8/2/chart" xmlns:cdr="http://schemas.openxmlformats.org/drawingml/2006/chartDrawing" xmlns:wne="http://schemas.microsoft.com/office/word/2006/wordml" xmlns:sl="http://schemas.openxmlformats.org/schemaLibrary/2006/main" xmlns:mc="http://schemas.openxmlformats.org/markup-compatibility/2006" xmlns:wp14="http://schemas.microsoft.com/office/word/2010/wordprocessingDrawing" xmlns:wp="http://schemas.openxmlformats.org/drawingml/2006/wordprocessingDrawing" xmlns:m="http://schemas.openxmlformats.org/officeDocument/2006/math" xmlns:w14="http://schemas.microsoft.com/office/word/2010/wordml" xmlns:w15="http://schemas.microsoft.com/office/word/2012/wordml" xmlns:w="http://schemas.openxmlformats.org/wordprocessingml/2006/main">
+          <c:extLst xmlns:w="http://schemas.openxmlformats.org/wordprocessingml/2006/main" xmlns:w15="http://schemas.microsoft.com/office/word/2012/wordml" xmlns:w14="http://schemas.microsoft.com/office/word/2010/wordml" xmlns:m="http://schemas.openxmlformats.org/officeDocument/2006/math" xmlns:wp="http://schemas.openxmlformats.org/drawingml/2006/wordprocessingDrawing" xmlns:wp14="http://schemas.microsoft.com/office/word/2010/wordprocessingDrawing" xmlns:mc="http://schemas.openxmlformats.org/markup-compatibility/2006" xmlns:sl="http://schemas.openxmlformats.org/schemaLibrary/2006/main" xmlns:wne="http://schemas.microsoft.com/office/word/2006/wordml" xmlns:cdr="http://schemas.openxmlformats.org/drawingml/2006/chartDrawing" xmlns:c14="http://schemas.microsoft.com/office/drawing/2007/8/2/chart" xmlns:dgm="http://schemas.openxmlformats.org/drawingml/2006/diagram" xmlns:pic="http://schemas.openxmlformats.org/drawingml/2006/picture" xmlns:xdr="http://schemas.openxmlformats.org/drawingml/2006/spreadsheetDrawing" xmlns:dsp="http://schemas.microsoft.com/office/drawing/2008/diagram" xmlns:xvml="urn:schemas-microsoft-com:office:excel" xmlns:o="urn:schemas-microsoft-com:office:office" xmlns:v="urn:schemas-microsoft-com:vml" xmlns:w10="urn:schemas-microsoft-com:office:word" xmlns:pvml="urn:schemas-microsoft-com:office:powerpoint" xmlns:cppr="http://schemas.microsoft.com/office/2006/coverPageProps" xmlns:odx="http://opendope.org/xpaths" xmlns:odc="http://opendope.org/conditions" xmlns:odq="http://opendope.org/questions" xmlns:oda="http://opendope.org/answers" xmlns:odi="http://opendope.org/components" xmlns:odgm="http://opendope.org/SmartArt/DataHierarchy" xmlns:b="http://schemas.openxmlformats.org/officeDocument/2006/bibliography" xmlns:wps="http://schemas.microsoft.com/office/word/2010/wordprocessingShape" xmlns:w16se="http://schemas.microsoft.com/office/word/2015/wordml/symex" xmlns:w16cid="http://schemas.microsoft.com/office/word/2016/wordml/cid" xmlns:wetp="http://schemas.microsoft.com/office/webextensions/taskpanes/2010/11" xmlns:we="http://schemas.microsoft.com/office/webextensions/webextension/2010/11" xmlns:comp="http://schemas.openxmlformats.org/drawingml/2006/compatibility" xmlns:lc="http://schemas.openxmlformats.org/drawingml/2006/lockedCanvas">
             <c:ext xmlns:c16="http://schemas.microsoft.com/office/drawing/2014/chart" uri="{C3380CC4-5D6E-409C-BE32-E72D297353CC}">
               <c16:uniqueId val="{00000002-6147-E74A-AA7B-5531F0E4EE0C}"/>
             </c:ext>
@@ -2853,7 +2858,7 @@
     <c:plotVisOnly val="1"/>
     <c:dispBlanksAs val="gap"/>
     <c:showDLblsOverMax val="0"/>
-    <c:extLst xmlns:lc="http://schemas.openxmlformats.org/drawingml/2006/lockedCanvas" xmlns:comp="http://schemas.openxmlformats.org/drawingml/2006/compatibility" xmlns:we="http://schemas.microsoft.com/office/webextensions/webextension/2010/11" xmlns:wetp="http://schemas.microsoft.com/office/webextensions/taskpanes/2010/11" xmlns:w16cid="http://schemas.microsoft.com/office/word/2016/wordml/cid" xmlns:w16se="http://schemas.microsoft.com/office/word/2015/wordml/symex" xmlns:wps="http://schemas.microsoft.com/office/word/2010/wordprocessingShape" xmlns:b="http://schemas.openxmlformats.org/officeDocument/2006/bibliography" xmlns:odgm="http://opendope.org/SmartArt/DataHierarchy" xmlns:odi="http://opendope.org/components" xmlns:oda="http://opendope.org/answers" xmlns:odq="http://opendope.org/questions" xmlns:odc="http://opendope.org/conditions" xmlns:odx="http://opendope.org/xpaths" xmlns:cppr="http://schemas.microsoft.com/office/2006/coverPageProps" xmlns:pvml="urn:schemas-microsoft-com:office:powerpoint" xmlns:w10="urn:schemas-microsoft-com:office:word" xmlns:v="urn:schemas-microsoft-com:vml" xmlns:o="urn:schemas-microsoft-com:office:office" xmlns:xvml="urn:schemas-microsoft-com:office:excel" xmlns:dsp="http://schemas.microsoft.com/office/drawing/2008/diagram" xmlns:xdr="http://schemas.openxmlformats.org/drawingml/2006/spreadsheetDrawing" xmlns:pic="http://schemas.openxmlformats.org/drawingml/2006/picture" xmlns:dgm="http://schemas.openxmlformats.org/drawingml/2006/diagram" xmlns:c14="http://schemas.microsoft.com/office/drawing/2007/8/2/chart" xmlns:cdr="http://schemas.openxmlformats.org/drawingml/2006/chartDrawing" xmlns:wne="http://schemas.microsoft.com/office/word/2006/wordml" xmlns:sl="http://schemas.openxmlformats.org/schemaLibrary/2006/main" xmlns:mc="http://schemas.openxmlformats.org/markup-compatibility/2006" xmlns:wp14="http://schemas.microsoft.com/office/word/2010/wordprocessingDrawing" xmlns:wp="http://schemas.openxmlformats.org/drawingml/2006/wordprocessingDrawing" xmlns:m="http://schemas.openxmlformats.org/officeDocument/2006/math" xmlns:w14="http://schemas.microsoft.com/office/word/2010/wordml" xmlns:w15="http://schemas.microsoft.com/office/word/2012/wordml" xmlns:w="http://schemas.openxmlformats.org/wordprocessingml/2006/main">
+    <c:extLst xmlns:w="http://schemas.openxmlformats.org/wordprocessingml/2006/main" xmlns:w15="http://schemas.microsoft.com/office/word/2012/wordml" xmlns:w14="http://schemas.microsoft.com/office/word/2010/wordml" xmlns:m="http://schemas.openxmlformats.org/officeDocument/2006/math" xmlns:wp="http://schemas.openxmlformats.org/drawingml/2006/wordprocessingDrawing" xmlns:wp14="http://schemas.microsoft.com/office/word/2010/wordprocessingDrawing" xmlns:mc="http://schemas.openxmlformats.org/markup-compatibility/2006" xmlns:sl="http://schemas.openxmlformats.org/schemaLibrary/2006/main" xmlns:wne="http://schemas.microsoft.com/office/word/2006/wordml" xmlns:cdr="http://schemas.openxmlformats.org/drawingml/2006/chartDrawing" xmlns:c14="http://schemas.microsoft.com/office/drawing/2007/8/2/chart" xmlns:dgm="http://schemas.openxmlformats.org/drawingml/2006/diagram" xmlns:pic="http://schemas.openxmlformats.org/drawingml/2006/picture" xmlns:xdr="http://schemas.openxmlformats.org/drawingml/2006/spreadsheetDrawing" xmlns:dsp="http://schemas.microsoft.com/office/drawing/2008/diagram" xmlns:xvml="urn:schemas-microsoft-com:office:excel" xmlns:o="urn:schemas-microsoft-com:office:office" xmlns:v="urn:schemas-microsoft-com:vml" xmlns:w10="urn:schemas-microsoft-com:office:word" xmlns:pvml="urn:schemas-microsoft-com:office:powerpoint" xmlns:cppr="http://schemas.microsoft.com/office/2006/coverPageProps" xmlns:odx="http://opendope.org/xpaths" xmlns:odc="http://opendope.org/conditions" xmlns:odq="http://opendope.org/questions" xmlns:oda="http://opendope.org/answers" xmlns:odi="http://opendope.org/components" xmlns:odgm="http://opendope.org/SmartArt/DataHierarchy" xmlns:b="http://schemas.openxmlformats.org/officeDocument/2006/bibliography" xmlns:wps="http://schemas.microsoft.com/office/word/2010/wordprocessingShape" xmlns:w16se="http://schemas.microsoft.com/office/word/2015/wordml/symex" xmlns:w16cid="http://schemas.microsoft.com/office/word/2016/wordml/cid" xmlns:wetp="http://schemas.microsoft.com/office/webextensions/taskpanes/2010/11" xmlns:we="http://schemas.microsoft.com/office/webextensions/webextension/2010/11" xmlns:comp="http://schemas.openxmlformats.org/drawingml/2006/compatibility" xmlns:lc="http://schemas.openxmlformats.org/drawingml/2006/lockedCanvas">
       <c:ext xmlns:c16r3="http://schemas.microsoft.com/office/drawing/2017/03/chart" uri="{56B9EC1D-385E-4148-901F-78D8002777C0}">
         <c16r3:dataDisplayOptions16>
           <c16r3:dispNaAsBlank val="1"/>
@@ -2955,7 +2960,7 @@
                 </a:outerShdw>
               </a:effectLst>
             </c:spPr>
-            <c:extLst xmlns:lc="http://schemas.openxmlformats.org/drawingml/2006/lockedCanvas" xmlns:comp="http://schemas.openxmlformats.org/drawingml/2006/compatibility" xmlns:we="http://schemas.microsoft.com/office/webextensions/webextension/2010/11" xmlns:wetp="http://schemas.microsoft.com/office/webextensions/taskpanes/2010/11" xmlns:w16cid="http://schemas.microsoft.com/office/word/2016/wordml/cid" xmlns:w16se="http://schemas.microsoft.com/office/word/2015/wordml/symex" xmlns:wps="http://schemas.microsoft.com/office/word/2010/wordprocessingShape" xmlns:b="http://schemas.openxmlformats.org/officeDocument/2006/bibliography" xmlns:odgm="http://opendope.org/SmartArt/DataHierarchy" xmlns:odi="http://opendope.org/components" xmlns:oda="http://opendope.org/answers" xmlns:odq="http://opendope.org/questions" xmlns:odc="http://opendope.org/conditions" xmlns:odx="http://opendope.org/xpaths" xmlns:cppr="http://schemas.microsoft.com/office/2006/coverPageProps" xmlns:pvml="urn:schemas-microsoft-com:office:powerpoint" xmlns:w10="urn:schemas-microsoft-com:office:word" xmlns:v="urn:schemas-microsoft-com:vml" xmlns:o="urn:schemas-microsoft-com:office:office" xmlns:xvml="urn:schemas-microsoft-com:office:excel" xmlns:dsp="http://schemas.microsoft.com/office/drawing/2008/diagram" xmlns:xdr="http://schemas.openxmlformats.org/drawingml/2006/spreadsheetDrawing" xmlns:pic="http://schemas.openxmlformats.org/drawingml/2006/picture" xmlns:dgm="http://schemas.openxmlformats.org/drawingml/2006/diagram" xmlns:c14="http://schemas.microsoft.com/office/drawing/2007/8/2/chart" xmlns:cdr="http://schemas.openxmlformats.org/drawingml/2006/chartDrawing" xmlns:wne="http://schemas.microsoft.com/office/word/2006/wordml" xmlns:sl="http://schemas.openxmlformats.org/schemaLibrary/2006/main" xmlns:mc="http://schemas.openxmlformats.org/markup-compatibility/2006" xmlns:wp14="http://schemas.microsoft.com/office/word/2010/wordprocessingDrawing" xmlns:wp="http://schemas.openxmlformats.org/drawingml/2006/wordprocessingDrawing" xmlns:m="http://schemas.openxmlformats.org/officeDocument/2006/math" xmlns:w14="http://schemas.microsoft.com/office/word/2010/wordml" xmlns:w15="http://schemas.microsoft.com/office/word/2012/wordml" xmlns:w="http://schemas.openxmlformats.org/wordprocessingml/2006/main">
+            <c:extLst xmlns:w="http://schemas.openxmlformats.org/wordprocessingml/2006/main" xmlns:w15="http://schemas.microsoft.com/office/word/2012/wordml" xmlns:w14="http://schemas.microsoft.com/office/word/2010/wordml" xmlns:m="http://schemas.openxmlformats.org/officeDocument/2006/math" xmlns:wp="http://schemas.openxmlformats.org/drawingml/2006/wordprocessingDrawing" xmlns:wp14="http://schemas.microsoft.com/office/word/2010/wordprocessingDrawing" xmlns:mc="http://schemas.openxmlformats.org/markup-compatibility/2006" xmlns:sl="http://schemas.openxmlformats.org/schemaLibrary/2006/main" xmlns:wne="http://schemas.microsoft.com/office/word/2006/wordml" xmlns:cdr="http://schemas.openxmlformats.org/drawingml/2006/chartDrawing" xmlns:c14="http://schemas.microsoft.com/office/drawing/2007/8/2/chart" xmlns:dgm="http://schemas.openxmlformats.org/drawingml/2006/diagram" xmlns:pic="http://schemas.openxmlformats.org/drawingml/2006/picture" xmlns:xdr="http://schemas.openxmlformats.org/drawingml/2006/spreadsheetDrawing" xmlns:dsp="http://schemas.microsoft.com/office/drawing/2008/diagram" xmlns:xvml="urn:schemas-microsoft-com:office:excel" xmlns:o="urn:schemas-microsoft-com:office:office" xmlns:v="urn:schemas-microsoft-com:vml" xmlns:w10="urn:schemas-microsoft-com:office:word" xmlns:pvml="urn:schemas-microsoft-com:office:powerpoint" xmlns:cppr="http://schemas.microsoft.com/office/2006/coverPageProps" xmlns:odx="http://opendope.org/xpaths" xmlns:odc="http://opendope.org/conditions" xmlns:odq="http://opendope.org/questions" xmlns:oda="http://opendope.org/answers" xmlns:odi="http://opendope.org/components" xmlns:odgm="http://opendope.org/SmartArt/DataHierarchy" xmlns:b="http://schemas.openxmlformats.org/officeDocument/2006/bibliography" xmlns:wps="http://schemas.microsoft.com/office/word/2010/wordprocessingShape" xmlns:w16se="http://schemas.microsoft.com/office/word/2015/wordml/symex" xmlns:w16cid="http://schemas.microsoft.com/office/word/2016/wordml/cid" xmlns:wetp="http://schemas.microsoft.com/office/webextensions/taskpanes/2010/11" xmlns:we="http://schemas.microsoft.com/office/webextensions/webextension/2010/11" xmlns:comp="http://schemas.openxmlformats.org/drawingml/2006/compatibility" xmlns:lc="http://schemas.openxmlformats.org/drawingml/2006/lockedCanvas">
               <c:ext xmlns:c16="http://schemas.microsoft.com/office/drawing/2014/chart" uri="{C3380CC4-5D6E-409C-BE32-E72D297353CC}">
                 <c16:uniqueId val="{00000001-6147-E74A-AA7B-5531F0E4EE0C}"/>
               </c:ext>
@@ -3050,7 +3055,7 @@
               </c:numCache>
             </c:numRef>
           </c:val>
-          <c:extLst xmlns:lc="http://schemas.openxmlformats.org/drawingml/2006/lockedCanvas" xmlns:comp="http://schemas.openxmlformats.org/drawingml/2006/compatibility" xmlns:we="http://schemas.microsoft.com/office/webextensions/webextension/2010/11" xmlns:wetp="http://schemas.microsoft.com/office/webextensions/taskpanes/2010/11" xmlns:w16cid="http://schemas.microsoft.com/office/word/2016/wordml/cid" xmlns:w16se="http://schemas.microsoft.com/office/word/2015/wordml/symex" xmlns:wps="http://schemas.microsoft.com/office/word/2010/wordprocessingShape" xmlns:b="http://schemas.openxmlformats.org/officeDocument/2006/bibliography" xmlns:odgm="http://opendope.org/SmartArt/DataHierarchy" xmlns:odi="http://opendope.org/components" xmlns:oda="http://opendope.org/answers" xmlns:odq="http://opendope.org/questions" xmlns:odc="http://opendope.org/conditions" xmlns:odx="http://opendope.org/xpaths" xmlns:cppr="http://schemas.microsoft.com/office/2006/coverPageProps" xmlns:pvml="urn:schemas-microsoft-com:office:powerpoint" xmlns:w10="urn:schemas-microsoft-com:office:word" xmlns:v="urn:schemas-microsoft-com:vml" xmlns:o="urn:schemas-microsoft-com:office:office" xmlns:xvml="urn:schemas-microsoft-com:office:excel" xmlns:dsp="http://schemas.microsoft.com/office/drawing/2008/diagram" xmlns:xdr="http://schemas.openxmlformats.org/drawingml/2006/spreadsheetDrawing" xmlns:pic="http://schemas.openxmlformats.org/drawingml/2006/picture" xmlns:dgm="http://schemas.openxmlformats.org/drawingml/2006/diagram" xmlns:c14="http://schemas.microsoft.com/office/drawing/2007/8/2/chart" xmlns:cdr="http://schemas.openxmlformats.org/drawingml/2006/chartDrawing" xmlns:wne="http://schemas.microsoft.com/office/word/2006/wordml" xmlns:sl="http://schemas.openxmlformats.org/schemaLibrary/2006/main" xmlns:mc="http://schemas.openxmlformats.org/markup-compatibility/2006" xmlns:wp14="http://schemas.microsoft.com/office/word/2010/wordprocessingDrawing" xmlns:wp="http://schemas.openxmlformats.org/drawingml/2006/wordprocessingDrawing" xmlns:m="http://schemas.openxmlformats.org/officeDocument/2006/math" xmlns:w14="http://schemas.microsoft.com/office/word/2010/wordml" xmlns:w15="http://schemas.microsoft.com/office/word/2012/wordml" xmlns:w="http://schemas.openxmlformats.org/wordprocessingml/2006/main">
+          <c:extLst xmlns:w="http://schemas.openxmlformats.org/wordprocessingml/2006/main" xmlns:w15="http://schemas.microsoft.com/office/word/2012/wordml" xmlns:w14="http://schemas.microsoft.com/office/word/2010/wordml" xmlns:m="http://schemas.openxmlformats.org/officeDocument/2006/math" xmlns:wp="http://schemas.openxmlformats.org/drawingml/2006/wordprocessingDrawing" xmlns:wp14="http://schemas.microsoft.com/office/word/2010/wordprocessingDrawing" xmlns:mc="http://schemas.openxmlformats.org/markup-compatibility/2006" xmlns:sl="http://schemas.openxmlformats.org/schemaLibrary/2006/main" xmlns:wne="http://schemas.microsoft.com/office/word/2006/wordml" xmlns:cdr="http://schemas.openxmlformats.org/drawingml/2006/chartDrawing" xmlns:c14="http://schemas.microsoft.com/office/drawing/2007/8/2/chart" xmlns:dgm="http://schemas.openxmlformats.org/drawingml/2006/diagram" xmlns:pic="http://schemas.openxmlformats.org/drawingml/2006/picture" xmlns:xdr="http://schemas.openxmlformats.org/drawingml/2006/spreadsheetDrawing" xmlns:dsp="http://schemas.microsoft.com/office/drawing/2008/diagram" xmlns:xvml="urn:schemas-microsoft-com:office:excel" xmlns:o="urn:schemas-microsoft-com:office:office" xmlns:v="urn:schemas-microsoft-com:vml" xmlns:w10="urn:schemas-microsoft-com:office:word" xmlns:pvml="urn:schemas-microsoft-com:office:powerpoint" xmlns:cppr="http://schemas.microsoft.com/office/2006/coverPageProps" xmlns:odx="http://opendope.org/xpaths" xmlns:odc="http://opendope.org/conditions" xmlns:odq="http://opendope.org/questions" xmlns:oda="http://opendope.org/answers" xmlns:odi="http://opendope.org/components" xmlns:odgm="http://opendope.org/SmartArt/DataHierarchy" xmlns:b="http://schemas.openxmlformats.org/officeDocument/2006/bibliography" xmlns:wps="http://schemas.microsoft.com/office/word/2010/wordprocessingShape" xmlns:w16se="http://schemas.microsoft.com/office/word/2015/wordml/symex" xmlns:w16cid="http://schemas.microsoft.com/office/word/2016/wordml/cid" xmlns:wetp="http://schemas.microsoft.com/office/webextensions/taskpanes/2010/11" xmlns:we="http://schemas.microsoft.com/office/webextensions/webextension/2010/11" xmlns:comp="http://schemas.openxmlformats.org/drawingml/2006/compatibility" xmlns:lc="http://schemas.openxmlformats.org/drawingml/2006/lockedCanvas">
             <c:ext xmlns:c16="http://schemas.microsoft.com/office/drawing/2014/chart" uri="{C3380CC4-5D6E-409C-BE32-E72D297353CC}">
               <c16:uniqueId val="{00000002-6147-E74A-AA7B-5531F0E4EE0C}"/>
             </c:ext>
@@ -3661,7 +3666,7 @@
     <c:plotVisOnly val="1"/>
     <c:dispBlanksAs val="gap"/>
     <c:showDLblsOverMax val="0"/>
-    <c:extLst xmlns:lc="http://schemas.openxmlformats.org/drawingml/2006/lockedCanvas" xmlns:comp="http://schemas.openxmlformats.org/drawingml/2006/compatibility" xmlns:we="http://schemas.microsoft.com/office/webextensions/webextension/2010/11" xmlns:wetp="http://schemas.microsoft.com/office/webextensions/taskpanes/2010/11" xmlns:w16cid="http://schemas.microsoft.com/office/word/2016/wordml/cid" xmlns:w16se="http://schemas.microsoft.com/office/word/2015/wordml/symex" xmlns:wps="http://schemas.microsoft.com/office/word/2010/wordprocessingShape" xmlns:b="http://schemas.openxmlformats.org/officeDocument/2006/bibliography" xmlns:odgm="http://opendope.org/SmartArt/DataHierarchy" xmlns:odi="http://opendope.org/components" xmlns:oda="http://opendope.org/answers" xmlns:odq="http://opendope.org/questions" xmlns:odc="http://opendope.org/conditions" xmlns:odx="http://opendope.org/xpaths" xmlns:cppr="http://schemas.microsoft.com/office/2006/coverPageProps" xmlns:pvml="urn:schemas-microsoft-com:office:powerpoint" xmlns:w10="urn:schemas-microsoft-com:office:word" xmlns:v="urn:schemas-microsoft-com:vml" xmlns:o="urn:schemas-microsoft-com:office:office" xmlns:xvml="urn:schemas-microsoft-com:office:excel" xmlns:dsp="http://schemas.microsoft.com/office/drawing/2008/diagram" xmlns:xdr="http://schemas.openxmlformats.org/drawingml/2006/spreadsheetDrawing" xmlns:pic="http://schemas.openxmlformats.org/drawingml/2006/picture" xmlns:dgm="http://schemas.openxmlformats.org/drawingml/2006/diagram" xmlns:c14="http://schemas.microsoft.com/office/drawing/2007/8/2/chart" xmlns:cdr="http://schemas.openxmlformats.org/drawingml/2006/chartDrawing" xmlns:wne="http://schemas.microsoft.com/office/word/2006/wordml" xmlns:sl="http://schemas.openxmlformats.org/schemaLibrary/2006/main" xmlns:mc="http://schemas.openxmlformats.org/markup-compatibility/2006" xmlns:wp14="http://schemas.microsoft.com/office/word/2010/wordprocessingDrawing" xmlns:wp="http://schemas.openxmlformats.org/drawingml/2006/wordprocessingDrawing" xmlns:m="http://schemas.openxmlformats.org/officeDocument/2006/math" xmlns:w14="http://schemas.microsoft.com/office/word/2010/wordml" xmlns:w15="http://schemas.microsoft.com/office/word/2012/wordml" xmlns:w="http://schemas.openxmlformats.org/wordprocessingml/2006/main">
+    <c:extLst xmlns:w="http://schemas.openxmlformats.org/wordprocessingml/2006/main" xmlns:w15="http://schemas.microsoft.com/office/word/2012/wordml" xmlns:w14="http://schemas.microsoft.com/office/word/2010/wordml" xmlns:m="http://schemas.openxmlformats.org/officeDocument/2006/math" xmlns:wp="http://schemas.openxmlformats.org/drawingml/2006/wordprocessingDrawing" xmlns:wp14="http://schemas.microsoft.com/office/word/2010/wordprocessingDrawing" xmlns:mc="http://schemas.openxmlformats.org/markup-compatibility/2006" xmlns:sl="http://schemas.openxmlformats.org/schemaLibrary/2006/main" xmlns:wne="http://schemas.microsoft.com/office/word/2006/wordml" xmlns:cdr="http://schemas.openxmlformats.org/drawingml/2006/chartDrawing" xmlns:c14="http://schemas.microsoft.com/office/drawing/2007/8/2/chart" xmlns:dgm="http://schemas.openxmlformats.org/drawingml/2006/diagram" xmlns:pic="http://schemas.openxmlformats.org/drawingml/2006/picture" xmlns:xdr="http://schemas.openxmlformats.org/drawingml/2006/spreadsheetDrawing" xmlns:dsp="http://schemas.microsoft.com/office/drawing/2008/diagram" xmlns:xvml="urn:schemas-microsoft-com:office:excel" xmlns:o="urn:schemas-microsoft-com:office:office" xmlns:v="urn:schemas-microsoft-com:vml" xmlns:w10="urn:schemas-microsoft-com:office:word" xmlns:pvml="urn:schemas-microsoft-com:office:powerpoint" xmlns:cppr="http://schemas.microsoft.com/office/2006/coverPageProps" xmlns:odx="http://opendope.org/xpaths" xmlns:odc="http://opendope.org/conditions" xmlns:odq="http://opendope.org/questions" xmlns:oda="http://opendope.org/answers" xmlns:odi="http://opendope.org/components" xmlns:odgm="http://opendope.org/SmartArt/DataHierarchy" xmlns:b="http://schemas.openxmlformats.org/officeDocument/2006/bibliography" xmlns:wps="http://schemas.microsoft.com/office/word/2010/wordprocessingShape" xmlns:w16se="http://schemas.microsoft.com/office/word/2015/wordml/symex" xmlns:w16cid="http://schemas.microsoft.com/office/word/2016/wordml/cid" xmlns:wetp="http://schemas.microsoft.com/office/webextensions/taskpanes/2010/11" xmlns:we="http://schemas.microsoft.com/office/webextensions/webextension/2010/11" xmlns:comp="http://schemas.openxmlformats.org/drawingml/2006/compatibility" xmlns:lc="http://schemas.openxmlformats.org/drawingml/2006/lockedCanvas">
       <c:ext xmlns:c16r3="http://schemas.microsoft.com/office/drawing/2017/03/chart" uri="{56B9EC1D-385E-4148-901F-78D8002777C0}">
         <c16r3:dataDisplayOptions16>
           <c16r3:dispNaAsBlank val="1"/>
@@ -3763,7 +3768,7 @@
                 </a:outerShdw>
               </a:effectLst>
             </c:spPr>
-            <c:extLst xmlns:w="http://schemas.openxmlformats.org/wordprocessingml/2006/main" xmlns:w15="http://schemas.microsoft.com/office/word/2012/wordml" xmlns:w14="http://schemas.microsoft.com/office/word/2010/wordml" xmlns:m="http://schemas.openxmlformats.org/officeDocument/2006/math" xmlns:wp="http://schemas.openxmlformats.org/drawingml/2006/wordprocessingDrawing" xmlns:wp14="http://schemas.microsoft.com/office/word/2010/wordprocessingDrawing" xmlns:mc="http://schemas.openxmlformats.org/markup-compatibility/2006" xmlns:sl="http://schemas.openxmlformats.org/schemaLibrary/2006/main" xmlns:wne="http://schemas.microsoft.com/office/word/2006/wordml" xmlns:cdr="http://schemas.openxmlformats.org/drawingml/2006/chartDrawing" xmlns:c14="http://schemas.microsoft.com/office/drawing/2007/8/2/chart" xmlns:dgm="http://schemas.openxmlformats.org/drawingml/2006/diagram" xmlns:pic="http://schemas.openxmlformats.org/drawingml/2006/picture" xmlns:xdr="http://schemas.openxmlformats.org/drawingml/2006/spreadsheetDrawing" xmlns:dsp="http://schemas.microsoft.com/office/drawing/2008/diagram" xmlns:xvml="urn:schemas-microsoft-com:office:excel" xmlns:o="urn:schemas-microsoft-com:office:office" xmlns:v="urn:schemas-microsoft-com:vml" xmlns:w10="urn:schemas-microsoft-com:office:word" xmlns:pvml="urn:schemas-microsoft-com:office:powerpoint" xmlns:cppr="http://schemas.microsoft.com/office/2006/coverPageProps" xmlns:odx="http://opendope.org/xpaths" xmlns:odc="http://opendope.org/conditions" xmlns:odq="http://opendope.org/questions" xmlns:oda="http://opendope.org/answers" xmlns:odi="http://opendope.org/components" xmlns:odgm="http://opendope.org/SmartArt/DataHierarchy" xmlns:b="http://schemas.openxmlformats.org/officeDocument/2006/bibliography" xmlns:wps="http://schemas.microsoft.com/office/word/2010/wordprocessingShape" xmlns:w16se="http://schemas.microsoft.com/office/word/2015/wordml/symex" xmlns:w16cid="http://schemas.microsoft.com/office/word/2016/wordml/cid" xmlns:wetp="http://schemas.microsoft.com/office/webextensions/taskpanes/2010/11" xmlns:we="http://schemas.microsoft.com/office/webextensions/webextension/2010/11" xmlns:comp="http://schemas.openxmlformats.org/drawingml/2006/compatibility" xmlns:lc="http://schemas.openxmlformats.org/drawingml/2006/lockedCanvas">
+            <c:extLst xmlns:lc="http://schemas.openxmlformats.org/drawingml/2006/lockedCanvas" xmlns:comp="http://schemas.openxmlformats.org/drawingml/2006/compatibility" xmlns:we="http://schemas.microsoft.com/office/webextensions/webextension/2010/11" xmlns:wetp="http://schemas.microsoft.com/office/webextensions/taskpanes/2010/11" xmlns:w16cid="http://schemas.microsoft.com/office/word/2016/wordml/cid" xmlns:w16se="http://schemas.microsoft.com/office/word/2015/wordml/symex" xmlns:wps="http://schemas.microsoft.com/office/word/2010/wordprocessingShape" xmlns:b="http://schemas.openxmlformats.org/officeDocument/2006/bibliography" xmlns:odgm="http://opendope.org/SmartArt/DataHierarchy" xmlns:odi="http://opendope.org/components" xmlns:oda="http://opendope.org/answers" xmlns:odq="http://opendope.org/questions" xmlns:odc="http://opendope.org/conditions" xmlns:odx="http://opendope.org/xpaths" xmlns:cppr="http://schemas.microsoft.com/office/2006/coverPageProps" xmlns:pvml="urn:schemas-microsoft-com:office:powerpoint" xmlns:w10="urn:schemas-microsoft-com:office:word" xmlns:v="urn:schemas-microsoft-com:vml" xmlns:o="urn:schemas-microsoft-com:office:office" xmlns:xvml="urn:schemas-microsoft-com:office:excel" xmlns:dsp="http://schemas.microsoft.com/office/drawing/2008/diagram" xmlns:xdr="http://schemas.openxmlformats.org/drawingml/2006/spreadsheetDrawing" xmlns:pic="http://schemas.openxmlformats.org/drawingml/2006/picture" xmlns:dgm="http://schemas.openxmlformats.org/drawingml/2006/diagram" xmlns:c14="http://schemas.microsoft.com/office/drawing/2007/8/2/chart" xmlns:cdr="http://schemas.openxmlformats.org/drawingml/2006/chartDrawing" xmlns:wne="http://schemas.microsoft.com/office/word/2006/wordml" xmlns:sl="http://schemas.openxmlformats.org/schemaLibrary/2006/main" xmlns:mc="http://schemas.openxmlformats.org/markup-compatibility/2006" xmlns:wp14="http://schemas.microsoft.com/office/word/2010/wordprocessingDrawing" xmlns:wp="http://schemas.openxmlformats.org/drawingml/2006/wordprocessingDrawing" xmlns:m="http://schemas.openxmlformats.org/officeDocument/2006/math" xmlns:w14="http://schemas.microsoft.com/office/word/2010/wordml" xmlns:w15="http://schemas.microsoft.com/office/word/2012/wordml" xmlns:w="http://schemas.openxmlformats.org/wordprocessingml/2006/main">
               <c:ext xmlns:c16="http://schemas.microsoft.com/office/drawing/2014/chart" uri="{C3380CC4-5D6E-409C-BE32-E72D297353CC}">
                 <c16:uniqueId val="{00000001-6147-E74A-AA7B-5531F0E4EE0C}"/>
               </c:ext>
@@ -3858,7 +3863,7 @@
               </c:numCache>
             </c:numRef>
           </c:val>
-          <c:extLst xmlns:w="http://schemas.openxmlformats.org/wordprocessingml/2006/main" xmlns:w15="http://schemas.microsoft.com/office/word/2012/wordml" xmlns:w14="http://schemas.microsoft.com/office/word/2010/wordml" xmlns:m="http://schemas.openxmlformats.org/officeDocument/2006/math" xmlns:wp="http://schemas.openxmlformats.org/drawingml/2006/wordprocessingDrawing" xmlns:wp14="http://schemas.microsoft.com/office/word/2010/wordprocessingDrawing" xmlns:mc="http://schemas.openxmlformats.org/markup-compatibility/2006" xmlns:sl="http://schemas.openxmlformats.org/schemaLibrary/2006/main" xmlns:wne="http://schemas.microsoft.com/office/word/2006/wordml" xmlns:cdr="http://schemas.openxmlformats.org/drawingml/2006/chartDrawing" xmlns:c14="http://schemas.microsoft.com/office/drawing/2007/8/2/chart" xmlns:dgm="http://schemas.openxmlformats.org/drawingml/2006/diagram" xmlns:pic="http://schemas.openxmlformats.org/drawingml/2006/picture" xmlns:xdr="http://schemas.openxmlformats.org/drawingml/2006/spreadsheetDrawing" xmlns:dsp="http://schemas.microsoft.com/office/drawing/2008/diagram" xmlns:xvml="urn:schemas-microsoft-com:office:excel" xmlns:o="urn:schemas-microsoft-com:office:office" xmlns:v="urn:schemas-microsoft-com:vml" xmlns:w10="urn:schemas-microsoft-com:office:word" xmlns:pvml="urn:schemas-microsoft-com:office:powerpoint" xmlns:cppr="http://schemas.microsoft.com/office/2006/coverPageProps" xmlns:odx="http://opendope.org/xpaths" xmlns:odc="http://opendope.org/conditions" xmlns:odq="http://opendope.org/questions" xmlns:oda="http://opendope.org/answers" xmlns:odi="http://opendope.org/components" xmlns:odgm="http://opendope.org/SmartArt/DataHierarchy" xmlns:b="http://schemas.openxmlformats.org/officeDocument/2006/bibliography" xmlns:wps="http://schemas.microsoft.com/office/word/2010/wordprocessingShape" xmlns:w16se="http://schemas.microsoft.com/office/word/2015/wordml/symex" xmlns:w16cid="http://schemas.microsoft.com/office/word/2016/wordml/cid" xmlns:wetp="http://schemas.microsoft.com/office/webextensions/taskpanes/2010/11" xmlns:we="http://schemas.microsoft.com/office/webextensions/webextension/2010/11" xmlns:comp="http://schemas.openxmlformats.org/drawingml/2006/compatibility" xmlns:lc="http://schemas.openxmlformats.org/drawingml/2006/lockedCanvas">
+          <c:extLst xmlns:lc="http://schemas.openxmlformats.org/drawingml/2006/lockedCanvas" xmlns:comp="http://schemas.openxmlformats.org/drawingml/2006/compatibility" xmlns:we="http://schemas.microsoft.com/office/webextensions/webextension/2010/11" xmlns:wetp="http://schemas.microsoft.com/office/webextensions/taskpanes/2010/11" xmlns:w16cid="http://schemas.microsoft.com/office/word/2016/wordml/cid" xmlns:w16se="http://schemas.microsoft.com/office/word/2015/wordml/symex" xmlns:wps="http://schemas.microsoft.com/office/word/2010/wordprocessingShape" xmlns:b="http://schemas.openxmlformats.org/officeDocument/2006/bibliography" xmlns:odgm="http://opendope.org/SmartArt/DataHierarchy" xmlns:odi="http://opendope.org/components" xmlns:oda="http://opendope.org/answers" xmlns:odq="http://opendope.org/questions" xmlns:odc="http://opendope.org/conditions" xmlns:odx="http://opendope.org/xpaths" xmlns:cppr="http://schemas.microsoft.com/office/2006/coverPageProps" xmlns:pvml="urn:schemas-microsoft-com:office:powerpoint" xmlns:w10="urn:schemas-microsoft-com:office:word" xmlns:v="urn:schemas-microsoft-com:vml" xmlns:o="urn:schemas-microsoft-com:office:office" xmlns:xvml="urn:schemas-microsoft-com:office:excel" xmlns:dsp="http://schemas.microsoft.com/office/drawing/2008/diagram" xmlns:xdr="http://schemas.openxmlformats.org/drawingml/2006/spreadsheetDrawing" xmlns:pic="http://schemas.openxmlformats.org/drawingml/2006/picture" xmlns:dgm="http://schemas.openxmlformats.org/drawingml/2006/diagram" xmlns:c14="http://schemas.microsoft.com/office/drawing/2007/8/2/chart" xmlns:cdr="http://schemas.openxmlformats.org/drawingml/2006/chartDrawing" xmlns:wne="http://schemas.microsoft.com/office/word/2006/wordml" xmlns:sl="http://schemas.openxmlformats.org/schemaLibrary/2006/main" xmlns:mc="http://schemas.openxmlformats.org/markup-compatibility/2006" xmlns:wp14="http://schemas.microsoft.com/office/word/2010/wordprocessingDrawing" xmlns:wp="http://schemas.openxmlformats.org/drawingml/2006/wordprocessingDrawing" xmlns:m="http://schemas.openxmlformats.org/officeDocument/2006/math" xmlns:w14="http://schemas.microsoft.com/office/word/2010/wordml" xmlns:w15="http://schemas.microsoft.com/office/word/2012/wordml" xmlns:w="http://schemas.openxmlformats.org/wordprocessingml/2006/main">
             <c:ext xmlns:c16="http://schemas.microsoft.com/office/drawing/2014/chart" uri="{C3380CC4-5D6E-409C-BE32-E72D297353CC}">
               <c16:uniqueId val="{00000002-6147-E74A-AA7B-5531F0E4EE0C}"/>
             </c:ext>
@@ -4469,7 +4474,7 @@
     <c:plotVisOnly val="1"/>
     <c:dispBlanksAs val="gap"/>
     <c:showDLblsOverMax val="0"/>
-    <c:extLst xmlns:w="http://schemas.openxmlformats.org/wordprocessingml/2006/main" xmlns:w15="http://schemas.microsoft.com/office/word/2012/wordml" xmlns:w14="http://schemas.microsoft.com/office/word/2010/wordml" xmlns:m="http://schemas.openxmlformats.org/officeDocument/2006/math" xmlns:wp="http://schemas.openxmlformats.org/drawingml/2006/wordprocessingDrawing" xmlns:wp14="http://schemas.microsoft.com/office/word/2010/wordprocessingDrawing" xmlns:mc="http://schemas.openxmlformats.org/markup-compatibility/2006" xmlns:sl="http://schemas.openxmlformats.org/schemaLibrary/2006/main" xmlns:wne="http://schemas.microsoft.com/office/word/2006/wordml" xmlns:cdr="http://schemas.openxmlformats.org/drawingml/2006/chartDrawing" xmlns:c14="http://schemas.microsoft.com/office/drawing/2007/8/2/chart" xmlns:dgm="http://schemas.openxmlformats.org/drawingml/2006/diagram" xmlns:pic="http://schemas.openxmlformats.org/drawingml/2006/picture" xmlns:xdr="http://schemas.openxmlformats.org/drawingml/2006/spreadsheetDrawing" xmlns:dsp="http://schemas.microsoft.com/office/drawing/2008/diagram" xmlns:xvml="urn:schemas-microsoft-com:office:excel" xmlns:o="urn:schemas-microsoft-com:office:office" xmlns:v="urn:schemas-microsoft-com:vml" xmlns:w10="urn:schemas-microsoft-com:office:word" xmlns:pvml="urn:schemas-microsoft-com:office:powerpoint" xmlns:cppr="http://schemas.microsoft.com/office/2006/coverPageProps" xmlns:odx="http://opendope.org/xpaths" xmlns:odc="http://opendope.org/conditions" xmlns:odq="http://opendope.org/questions" xmlns:oda="http://opendope.org/answers" xmlns:odi="http://opendope.org/components" xmlns:odgm="http://opendope.org/SmartArt/DataHierarchy" xmlns:b="http://schemas.openxmlformats.org/officeDocument/2006/bibliography" xmlns:wps="http://schemas.microsoft.com/office/word/2010/wordprocessingShape" xmlns:w16se="http://schemas.microsoft.com/office/word/2015/wordml/symex" xmlns:w16cid="http://schemas.microsoft.com/office/word/2016/wordml/cid" xmlns:wetp="http://schemas.microsoft.com/office/webextensions/taskpanes/2010/11" xmlns:we="http://schemas.microsoft.com/office/webextensions/webextension/2010/11" xmlns:comp="http://schemas.openxmlformats.org/drawingml/2006/compatibility" xmlns:lc="http://schemas.openxmlformats.org/drawingml/2006/lockedCanvas">
+    <c:extLst xmlns:lc="http://schemas.openxmlformats.org/drawingml/2006/lockedCanvas" xmlns:comp="http://schemas.openxmlformats.org/drawingml/2006/compatibility" xmlns:we="http://schemas.microsoft.com/office/webextensions/webextension/2010/11" xmlns:wetp="http://schemas.microsoft.com/office/webextensions/taskpanes/2010/11" xmlns:w16cid="http://schemas.microsoft.com/office/word/2016/wordml/cid" xmlns:w16se="http://schemas.microsoft.com/office/word/2015/wordml/symex" xmlns:wps="http://schemas.microsoft.com/office/word/2010/wordprocessingShape" xmlns:b="http://schemas.openxmlformats.org/officeDocument/2006/bibliography" xmlns:odgm="http://opendope.org/SmartArt/DataHierarchy" xmlns:odi="http://opendope.org/components" xmlns:oda="http://opendope.org/answers" xmlns:odq="http://opendope.org/questions" xmlns:odc="http://opendope.org/conditions" xmlns:odx="http://opendope.org/xpaths" xmlns:cppr="http://schemas.microsoft.com/office/2006/coverPageProps" xmlns:pvml="urn:schemas-microsoft-com:office:powerpoint" xmlns:w10="urn:schemas-microsoft-com:office:word" xmlns:v="urn:schemas-microsoft-com:vml" xmlns:o="urn:schemas-microsoft-com:office:office" xmlns:xvml="urn:schemas-microsoft-com:office:excel" xmlns:dsp="http://schemas.microsoft.com/office/drawing/2008/diagram" xmlns:xdr="http://schemas.openxmlformats.org/drawingml/2006/spreadsheetDrawing" xmlns:pic="http://schemas.openxmlformats.org/drawingml/2006/picture" xmlns:dgm="http://schemas.openxmlformats.org/drawingml/2006/diagram" xmlns:c14="http://schemas.microsoft.com/office/drawing/2007/8/2/chart" xmlns:cdr="http://schemas.openxmlformats.org/drawingml/2006/chartDrawing" xmlns:wne="http://schemas.microsoft.com/office/word/2006/wordml" xmlns:sl="http://schemas.openxmlformats.org/schemaLibrary/2006/main" xmlns:mc="http://schemas.openxmlformats.org/markup-compatibility/2006" xmlns:wp14="http://schemas.microsoft.com/office/word/2010/wordprocessingDrawing" xmlns:wp="http://schemas.openxmlformats.org/drawingml/2006/wordprocessingDrawing" xmlns:m="http://schemas.openxmlformats.org/officeDocument/2006/math" xmlns:w14="http://schemas.microsoft.com/office/word/2010/wordml" xmlns:w15="http://schemas.microsoft.com/office/word/2012/wordml" xmlns:w="http://schemas.openxmlformats.org/wordprocessingml/2006/main">
       <c:ext xmlns:c16r3="http://schemas.microsoft.com/office/drawing/2017/03/chart" uri="{56B9EC1D-385E-4148-901F-78D8002777C0}">
         <c16r3:dataDisplayOptions16>
           <c16r3:dispNaAsBlank val="1"/>
@@ -4571,7 +4576,7 @@
                 </a:outerShdw>
               </a:effectLst>
             </c:spPr>
-            <c:extLst xmlns:w="http://schemas.openxmlformats.org/wordprocessingml/2006/main" xmlns:w15="http://schemas.microsoft.com/office/word/2012/wordml" xmlns:w14="http://schemas.microsoft.com/office/word/2010/wordml" xmlns:m="http://schemas.openxmlformats.org/officeDocument/2006/math" xmlns:wp="http://schemas.openxmlformats.org/drawingml/2006/wordprocessingDrawing" xmlns:wp14="http://schemas.microsoft.com/office/word/2010/wordprocessingDrawing" xmlns:mc="http://schemas.openxmlformats.org/markup-compatibility/2006" xmlns:sl="http://schemas.openxmlformats.org/schemaLibrary/2006/main" xmlns:wne="http://schemas.microsoft.com/office/word/2006/wordml" xmlns:cdr="http://schemas.openxmlformats.org/drawingml/2006/chartDrawing" xmlns:c14="http://schemas.microsoft.com/office/drawing/2007/8/2/chart" xmlns:dgm="http://schemas.openxmlformats.org/drawingml/2006/diagram" xmlns:pic="http://schemas.openxmlformats.org/drawingml/2006/picture" xmlns:xdr="http://schemas.openxmlformats.org/drawingml/2006/spreadsheetDrawing" xmlns:dsp="http://schemas.microsoft.com/office/drawing/2008/diagram" xmlns:xvml="urn:schemas-microsoft-com:office:excel" xmlns:o="urn:schemas-microsoft-com:office:office" xmlns:v="urn:schemas-microsoft-com:vml" xmlns:w10="urn:schemas-microsoft-com:office:word" xmlns:pvml="urn:schemas-microsoft-com:office:powerpoint" xmlns:cppr="http://schemas.microsoft.com/office/2006/coverPageProps" xmlns:odx="http://opendope.org/xpaths" xmlns:odc="http://opendope.org/conditions" xmlns:odq="http://opendope.org/questions" xmlns:oda="http://opendope.org/answers" xmlns:odi="http://opendope.org/components" xmlns:odgm="http://opendope.org/SmartArt/DataHierarchy" xmlns:b="http://schemas.openxmlformats.org/officeDocument/2006/bibliography" xmlns:wps="http://schemas.microsoft.com/office/word/2010/wordprocessingShape" xmlns:w16se="http://schemas.microsoft.com/office/word/2015/wordml/symex" xmlns:w16cid="http://schemas.microsoft.com/office/word/2016/wordml/cid" xmlns:wetp="http://schemas.microsoft.com/office/webextensions/taskpanes/2010/11" xmlns:we="http://schemas.microsoft.com/office/webextensions/webextension/2010/11" xmlns:comp="http://schemas.openxmlformats.org/drawingml/2006/compatibility" xmlns:lc="http://schemas.openxmlformats.org/drawingml/2006/lockedCanvas">
+            <c:extLst xmlns:lc="http://schemas.openxmlformats.org/drawingml/2006/lockedCanvas" xmlns:comp="http://schemas.openxmlformats.org/drawingml/2006/compatibility" xmlns:we="http://schemas.microsoft.com/office/webextensions/webextension/2010/11" xmlns:wetp="http://schemas.microsoft.com/office/webextensions/taskpanes/2010/11" xmlns:w16cid="http://schemas.microsoft.com/office/word/2016/wordml/cid" xmlns:w16se="http://schemas.microsoft.com/office/word/2015/wordml/symex" xmlns:wps="http://schemas.microsoft.com/office/word/2010/wordprocessingShape" xmlns:b="http://schemas.openxmlformats.org/officeDocument/2006/bibliography" xmlns:odgm="http://opendope.org/SmartArt/DataHierarchy" xmlns:odi="http://opendope.org/components" xmlns:oda="http://opendope.org/answers" xmlns:odq="http://opendope.org/questions" xmlns:odc="http://opendope.org/conditions" xmlns:odx="http://opendope.org/xpaths" xmlns:cppr="http://schemas.microsoft.com/office/2006/coverPageProps" xmlns:pvml="urn:schemas-microsoft-com:office:powerpoint" xmlns:w10="urn:schemas-microsoft-com:office:word" xmlns:v="urn:schemas-microsoft-com:vml" xmlns:o="urn:schemas-microsoft-com:office:office" xmlns:xvml="urn:schemas-microsoft-com:office:excel" xmlns:dsp="http://schemas.microsoft.com/office/drawing/2008/diagram" xmlns:xdr="http://schemas.openxmlformats.org/drawingml/2006/spreadsheetDrawing" xmlns:pic="http://schemas.openxmlformats.org/drawingml/2006/picture" xmlns:dgm="http://schemas.openxmlformats.org/drawingml/2006/diagram" xmlns:c14="http://schemas.microsoft.com/office/drawing/2007/8/2/chart" xmlns:cdr="http://schemas.openxmlformats.org/drawingml/2006/chartDrawing" xmlns:wne="http://schemas.microsoft.com/office/word/2006/wordml" xmlns:sl="http://schemas.openxmlformats.org/schemaLibrary/2006/main" xmlns:mc="http://schemas.openxmlformats.org/markup-compatibility/2006" xmlns:wp14="http://schemas.microsoft.com/office/word/2010/wordprocessingDrawing" xmlns:wp="http://schemas.openxmlformats.org/drawingml/2006/wordprocessingDrawing" xmlns:m="http://schemas.openxmlformats.org/officeDocument/2006/math" xmlns:w14="http://schemas.microsoft.com/office/word/2010/wordml" xmlns:w15="http://schemas.microsoft.com/office/word/2012/wordml" xmlns:w="http://schemas.openxmlformats.org/wordprocessingml/2006/main">
               <c:ext xmlns:c16="http://schemas.microsoft.com/office/drawing/2014/chart" uri="{C3380CC4-5D6E-409C-BE32-E72D297353CC}">
                 <c16:uniqueId val="{00000001-6147-E74A-AA7B-5531F0E4EE0C}"/>
               </c:ext>
@@ -4666,7 +4671,7 @@
               </c:numCache>
             </c:numRef>
           </c:val>
-          <c:extLst xmlns:w="http://schemas.openxmlformats.org/wordprocessingml/2006/main" xmlns:w15="http://schemas.microsoft.com/office/word/2012/wordml" xmlns:w14="http://schemas.microsoft.com/office/word/2010/wordml" xmlns:m="http://schemas.openxmlformats.org/officeDocument/2006/math" xmlns:wp="http://schemas.openxmlformats.org/drawingml/2006/wordprocessingDrawing" xmlns:wp14="http://schemas.microsoft.com/office/word/2010/wordprocessingDrawing" xmlns:mc="http://schemas.openxmlformats.org/markup-compatibility/2006" xmlns:sl="http://schemas.openxmlformats.org/schemaLibrary/2006/main" xmlns:wne="http://schemas.microsoft.com/office/word/2006/wordml" xmlns:cdr="http://schemas.openxmlformats.org/drawingml/2006/chartDrawing" xmlns:c14="http://schemas.microsoft.com/office/drawing/2007/8/2/chart" xmlns:dgm="http://schemas.openxmlformats.org/drawingml/2006/diagram" xmlns:pic="http://schemas.openxmlformats.org/drawingml/2006/picture" xmlns:xdr="http://schemas.openxmlformats.org/drawingml/2006/spreadsheetDrawing" xmlns:dsp="http://schemas.microsoft.com/office/drawing/2008/diagram" xmlns:xvml="urn:schemas-microsoft-com:office:excel" xmlns:o="urn:schemas-microsoft-com:office:office" xmlns:v="urn:schemas-microsoft-com:vml" xmlns:w10="urn:schemas-microsoft-com:office:word" xmlns:pvml="urn:schemas-microsoft-com:office:powerpoint" xmlns:cppr="http://schemas.microsoft.com/office/2006/coverPageProps" xmlns:odx="http://opendope.org/xpaths" xmlns:odc="http://opendope.org/conditions" xmlns:odq="http://opendope.org/questions" xmlns:oda="http://opendope.org/answers" xmlns:odi="http://opendope.org/components" xmlns:odgm="http://opendope.org/SmartArt/DataHierarchy" xmlns:b="http://schemas.openxmlformats.org/officeDocument/2006/bibliography" xmlns:wps="http://schemas.microsoft.com/office/word/2010/wordprocessingShape" xmlns:w16se="http://schemas.microsoft.com/office/word/2015/wordml/symex" xmlns:w16cid="http://schemas.microsoft.com/office/word/2016/wordml/cid" xmlns:wetp="http://schemas.microsoft.com/office/webextensions/taskpanes/2010/11" xmlns:we="http://schemas.microsoft.com/office/webextensions/webextension/2010/11" xmlns:comp="http://schemas.openxmlformats.org/drawingml/2006/compatibility" xmlns:lc="http://schemas.openxmlformats.org/drawingml/2006/lockedCanvas">
+          <c:extLst xmlns:lc="http://schemas.openxmlformats.org/drawingml/2006/lockedCanvas" xmlns:comp="http://schemas.openxmlformats.org/drawingml/2006/compatibility" xmlns:we="http://schemas.microsoft.com/office/webextensions/webextension/2010/11" xmlns:wetp="http://schemas.microsoft.com/office/webextensions/taskpanes/2010/11" xmlns:w16cid="http://schemas.microsoft.com/office/word/2016/wordml/cid" xmlns:w16se="http://schemas.microsoft.com/office/word/2015/wordml/symex" xmlns:wps="http://schemas.microsoft.com/office/word/2010/wordprocessingShape" xmlns:b="http://schemas.openxmlformats.org/officeDocument/2006/bibliography" xmlns:odgm="http://opendope.org/SmartArt/DataHierarchy" xmlns:odi="http://opendope.org/components" xmlns:oda="http://opendope.org/answers" xmlns:odq="http://opendope.org/questions" xmlns:odc="http://opendope.org/conditions" xmlns:odx="http://opendope.org/xpaths" xmlns:cppr="http://schemas.microsoft.com/office/2006/coverPageProps" xmlns:pvml="urn:schemas-microsoft-com:office:powerpoint" xmlns:w10="urn:schemas-microsoft-com:office:word" xmlns:v="urn:schemas-microsoft-com:vml" xmlns:o="urn:schemas-microsoft-com:office:office" xmlns:xvml="urn:schemas-microsoft-com:office:excel" xmlns:dsp="http://schemas.microsoft.com/office/drawing/2008/diagram" xmlns:xdr="http://schemas.openxmlformats.org/drawingml/2006/spreadsheetDrawing" xmlns:pic="http://schemas.openxmlformats.org/drawingml/2006/picture" xmlns:dgm="http://schemas.openxmlformats.org/drawingml/2006/diagram" xmlns:c14="http://schemas.microsoft.com/office/drawing/2007/8/2/chart" xmlns:cdr="http://schemas.openxmlformats.org/drawingml/2006/chartDrawing" xmlns:wne="http://schemas.microsoft.com/office/word/2006/wordml" xmlns:sl="http://schemas.openxmlformats.org/schemaLibrary/2006/main" xmlns:mc="http://schemas.openxmlformats.org/markup-compatibility/2006" xmlns:wp14="http://schemas.microsoft.com/office/word/2010/wordprocessingDrawing" xmlns:wp="http://schemas.openxmlformats.org/drawingml/2006/wordprocessingDrawing" xmlns:m="http://schemas.openxmlformats.org/officeDocument/2006/math" xmlns:w14="http://schemas.microsoft.com/office/word/2010/wordml" xmlns:w15="http://schemas.microsoft.com/office/word/2012/wordml" xmlns:w="http://schemas.openxmlformats.org/wordprocessingml/2006/main">
             <c:ext xmlns:c16="http://schemas.microsoft.com/office/drawing/2014/chart" uri="{C3380CC4-5D6E-409C-BE32-E72D297353CC}">
               <c16:uniqueId val="{00000002-6147-E74A-AA7B-5531F0E4EE0C}"/>
             </c:ext>
@@ -5277,7 +5282,7 @@
     <c:plotVisOnly val="1"/>
     <c:dispBlanksAs val="gap"/>
     <c:showDLblsOverMax val="0"/>
-    <c:extLst xmlns:w="http://schemas.openxmlformats.org/wordprocessingml/2006/main" xmlns:w15="http://schemas.microsoft.com/office/word/2012/wordml" xmlns:w14="http://schemas.microsoft.com/office/word/2010/wordml" xmlns:m="http://schemas.openxmlformats.org/officeDocument/2006/math" xmlns:wp="http://schemas.openxmlformats.org/drawingml/2006/wordprocessingDrawing" xmlns:wp14="http://schemas.microsoft.com/office/word/2010/wordprocessingDrawing" xmlns:mc="http://schemas.openxmlformats.org/markup-compatibility/2006" xmlns:sl="http://schemas.openxmlformats.org/schemaLibrary/2006/main" xmlns:wne="http://schemas.microsoft.com/office/word/2006/wordml" xmlns:cdr="http://schemas.openxmlformats.org/drawingml/2006/chartDrawing" xmlns:c14="http://schemas.microsoft.com/office/drawing/2007/8/2/chart" xmlns:dgm="http://schemas.openxmlformats.org/drawingml/2006/diagram" xmlns:pic="http://schemas.openxmlformats.org/drawingml/2006/picture" xmlns:xdr="http://schemas.openxmlformats.org/drawingml/2006/spreadsheetDrawing" xmlns:dsp="http://schemas.microsoft.com/office/drawing/2008/diagram" xmlns:xvml="urn:schemas-microsoft-com:office:excel" xmlns:o="urn:schemas-microsoft-com:office:office" xmlns:v="urn:schemas-microsoft-com:vml" xmlns:w10="urn:schemas-microsoft-com:office:word" xmlns:pvml="urn:schemas-microsoft-com:office:powerpoint" xmlns:cppr="http://schemas.microsoft.com/office/2006/coverPageProps" xmlns:odx="http://opendope.org/xpaths" xmlns:odc="http://opendope.org/conditions" xmlns:odq="http://opendope.org/questions" xmlns:oda="http://opendope.org/answers" xmlns:odi="http://opendope.org/components" xmlns:odgm="http://opendope.org/SmartArt/DataHierarchy" xmlns:b="http://schemas.openxmlformats.org/officeDocument/2006/bibliography" xmlns:wps="http://schemas.microsoft.com/office/word/2010/wordprocessingShape" xmlns:w16se="http://schemas.microsoft.com/office/word/2015/wordml/symex" xmlns:w16cid="http://schemas.microsoft.com/office/word/2016/wordml/cid" xmlns:wetp="http://schemas.microsoft.com/office/webextensions/taskpanes/2010/11" xmlns:we="http://schemas.microsoft.com/office/webextensions/webextension/2010/11" xmlns:comp="http://schemas.openxmlformats.org/drawingml/2006/compatibility" xmlns:lc="http://schemas.openxmlformats.org/drawingml/2006/lockedCanvas">
+    <c:extLst xmlns:lc="http://schemas.openxmlformats.org/drawingml/2006/lockedCanvas" xmlns:comp="http://schemas.openxmlformats.org/drawingml/2006/compatibility" xmlns:we="http://schemas.microsoft.com/office/webextensions/webextension/2010/11" xmlns:wetp="http://schemas.microsoft.com/office/webextensions/taskpanes/2010/11" xmlns:w16cid="http://schemas.microsoft.com/office/word/2016/wordml/cid" xmlns:w16se="http://schemas.microsoft.com/office/word/2015/wordml/symex" xmlns:wps="http://schemas.microsoft.com/office/word/2010/wordprocessingShape" xmlns:b="http://schemas.openxmlformats.org/officeDocument/2006/bibliography" xmlns:odgm="http://opendope.org/SmartArt/DataHierarchy" xmlns:odi="http://opendope.org/components" xmlns:oda="http://opendope.org/answers" xmlns:odq="http://opendope.org/questions" xmlns:odc="http://opendope.org/conditions" xmlns:odx="http://opendope.org/xpaths" xmlns:cppr="http://schemas.microsoft.com/office/2006/coverPageProps" xmlns:pvml="urn:schemas-microsoft-com:office:powerpoint" xmlns:w10="urn:schemas-microsoft-com:office:word" xmlns:v="urn:schemas-microsoft-com:vml" xmlns:o="urn:schemas-microsoft-com:office:office" xmlns:xvml="urn:schemas-microsoft-com:office:excel" xmlns:dsp="http://schemas.microsoft.com/office/drawing/2008/diagram" xmlns:xdr="http://schemas.openxmlformats.org/drawingml/2006/spreadsheetDrawing" xmlns:pic="http://schemas.openxmlformats.org/drawingml/2006/picture" xmlns:dgm="http://schemas.openxmlformats.org/drawingml/2006/diagram" xmlns:c14="http://schemas.microsoft.com/office/drawing/2007/8/2/chart" xmlns:cdr="http://schemas.openxmlformats.org/drawingml/2006/chartDrawing" xmlns:wne="http://schemas.microsoft.com/office/word/2006/wordml" xmlns:sl="http://schemas.openxmlformats.org/schemaLibrary/2006/main" xmlns:mc="http://schemas.openxmlformats.org/markup-compatibility/2006" xmlns:wp14="http://schemas.microsoft.com/office/word/2010/wordprocessingDrawing" xmlns:wp="http://schemas.openxmlformats.org/drawingml/2006/wordprocessingDrawing" xmlns:m="http://schemas.openxmlformats.org/officeDocument/2006/math" xmlns:w14="http://schemas.microsoft.com/office/word/2010/wordml" xmlns:w15="http://schemas.microsoft.com/office/word/2012/wordml" xmlns:w="http://schemas.openxmlformats.org/wordprocessingml/2006/main">
       <c:ext xmlns:c16r3="http://schemas.microsoft.com/office/drawing/2017/03/chart" uri="{56B9EC1D-385E-4148-901F-78D8002777C0}">
         <c16r3:dataDisplayOptions16>
           <c16r3:dispNaAsBlank val="1"/>
@@ -5379,7 +5384,7 @@
                 </a:outerShdw>
               </a:effectLst>
             </c:spPr>
-            <c:extLst xmlns:w="http://schemas.openxmlformats.org/wordprocessingml/2006/main" xmlns:w15="http://schemas.microsoft.com/office/word/2012/wordml" xmlns:w14="http://schemas.microsoft.com/office/word/2010/wordml" xmlns:m="http://schemas.openxmlformats.org/officeDocument/2006/math" xmlns:wp="http://schemas.openxmlformats.org/drawingml/2006/wordprocessingDrawing" xmlns:wp14="http://schemas.microsoft.com/office/word/2010/wordprocessingDrawing" xmlns:mc="http://schemas.openxmlformats.org/markup-compatibility/2006" xmlns:sl="http://schemas.openxmlformats.org/schemaLibrary/2006/main" xmlns:wne="http://schemas.microsoft.com/office/word/2006/wordml" xmlns:cdr="http://schemas.openxmlformats.org/drawingml/2006/chartDrawing" xmlns:c14="http://schemas.microsoft.com/office/drawing/2007/8/2/chart" xmlns:dgm="http://schemas.openxmlformats.org/drawingml/2006/diagram" xmlns:pic="http://schemas.openxmlformats.org/drawingml/2006/picture" xmlns:xdr="http://schemas.openxmlformats.org/drawingml/2006/spreadsheetDrawing" xmlns:dsp="http://schemas.microsoft.com/office/drawing/2008/diagram" xmlns:xvml="urn:schemas-microsoft-com:office:excel" xmlns:o="urn:schemas-microsoft-com:office:office" xmlns:v="urn:schemas-microsoft-com:vml" xmlns:w10="urn:schemas-microsoft-com:office:word" xmlns:pvml="urn:schemas-microsoft-com:office:powerpoint" xmlns:cppr="http://schemas.microsoft.com/office/2006/coverPageProps" xmlns:odx="http://opendope.org/xpaths" xmlns:odc="http://opendope.org/conditions" xmlns:odq="http://opendope.org/questions" xmlns:oda="http://opendope.org/answers" xmlns:odi="http://opendope.org/components" xmlns:odgm="http://opendope.org/SmartArt/DataHierarchy" xmlns:b="http://schemas.openxmlformats.org/officeDocument/2006/bibliography" xmlns:wps="http://schemas.microsoft.com/office/word/2010/wordprocessingShape" xmlns:w16se="http://schemas.microsoft.com/office/word/2015/wordml/symex" xmlns:w16cid="http://schemas.microsoft.com/office/word/2016/wordml/cid" xmlns:wetp="http://schemas.microsoft.com/office/webextensions/taskpanes/2010/11" xmlns:we="http://schemas.microsoft.com/office/webextensions/webextension/2010/11" xmlns:comp="http://schemas.openxmlformats.org/drawingml/2006/compatibility" xmlns:lc="http://schemas.openxmlformats.org/drawingml/2006/lockedCanvas">
+            <c:extLst xmlns:lc="http://schemas.openxmlformats.org/drawingml/2006/lockedCanvas" xmlns:comp="http://schemas.openxmlformats.org/drawingml/2006/compatibility" xmlns:we="http://schemas.microsoft.com/office/webextensions/webextension/2010/11" xmlns:wetp="http://schemas.microsoft.com/office/webextensions/taskpanes/2010/11" xmlns:w16cid="http://schemas.microsoft.com/office/word/2016/wordml/cid" xmlns:w16se="http://schemas.microsoft.com/office/word/2015/wordml/symex" xmlns:wps="http://schemas.microsoft.com/office/word/2010/wordprocessingShape" xmlns:b="http://schemas.openxmlformats.org/officeDocument/2006/bibliography" xmlns:odgm="http://opendope.org/SmartArt/DataHierarchy" xmlns:odi="http://opendope.org/components" xmlns:oda="http://opendope.org/answers" xmlns:odq="http://opendope.org/questions" xmlns:odc="http://opendope.org/conditions" xmlns:odx="http://opendope.org/xpaths" xmlns:cppr="http://schemas.microsoft.com/office/2006/coverPageProps" xmlns:pvml="urn:schemas-microsoft-com:office:powerpoint" xmlns:w10="urn:schemas-microsoft-com:office:word" xmlns:v="urn:schemas-microsoft-com:vml" xmlns:o="urn:schemas-microsoft-com:office:office" xmlns:xvml="urn:schemas-microsoft-com:office:excel" xmlns:dsp="http://schemas.microsoft.com/office/drawing/2008/diagram" xmlns:xdr="http://schemas.openxmlformats.org/drawingml/2006/spreadsheetDrawing" xmlns:pic="http://schemas.openxmlformats.org/drawingml/2006/picture" xmlns:dgm="http://schemas.openxmlformats.org/drawingml/2006/diagram" xmlns:c14="http://schemas.microsoft.com/office/drawing/2007/8/2/chart" xmlns:cdr="http://schemas.openxmlformats.org/drawingml/2006/chartDrawing" xmlns:wne="http://schemas.microsoft.com/office/word/2006/wordml" xmlns:sl="http://schemas.openxmlformats.org/schemaLibrary/2006/main" xmlns:mc="http://schemas.openxmlformats.org/markup-compatibility/2006" xmlns:wp14="http://schemas.microsoft.com/office/word/2010/wordprocessingDrawing" xmlns:wp="http://schemas.openxmlformats.org/drawingml/2006/wordprocessingDrawing" xmlns:m="http://schemas.openxmlformats.org/officeDocument/2006/math" xmlns:w14="http://schemas.microsoft.com/office/word/2010/wordml" xmlns:w15="http://schemas.microsoft.com/office/word/2012/wordml" xmlns:w="http://schemas.openxmlformats.org/wordprocessingml/2006/main">
               <c:ext xmlns:c16="http://schemas.microsoft.com/office/drawing/2014/chart" uri="{C3380CC4-5D6E-409C-BE32-E72D297353CC}">
                 <c16:uniqueId val="{00000001-6147-E74A-AA7B-5531F0E4EE0C}"/>
               </c:ext>
@@ -5474,7 +5479,7 @@
               </c:numCache>
             </c:numRef>
           </c:val>
-          <c:extLst xmlns:w="http://schemas.openxmlformats.org/wordprocessingml/2006/main" xmlns:w15="http://schemas.microsoft.com/office/word/2012/wordml" xmlns:w14="http://schemas.microsoft.com/office/word/2010/wordml" xmlns:m="http://schemas.openxmlformats.org/officeDocument/2006/math" xmlns:wp="http://schemas.openxmlformats.org/drawingml/2006/wordprocessingDrawing" xmlns:wp14="http://schemas.microsoft.com/office/word/2010/wordprocessingDrawing" xmlns:mc="http://schemas.openxmlformats.org/markup-compatibility/2006" xmlns:sl="http://schemas.openxmlformats.org/schemaLibrary/2006/main" xmlns:wne="http://schemas.microsoft.com/office/word/2006/wordml" xmlns:cdr="http://schemas.openxmlformats.org/drawingml/2006/chartDrawing" xmlns:c14="http://schemas.microsoft.com/office/drawing/2007/8/2/chart" xmlns:dgm="http://schemas.openxmlformats.org/drawingml/2006/diagram" xmlns:pic="http://schemas.openxmlformats.org/drawingml/2006/picture" xmlns:xdr="http://schemas.openxmlformats.org/drawingml/2006/spreadsheetDrawing" xmlns:dsp="http://schemas.microsoft.com/office/drawing/2008/diagram" xmlns:xvml="urn:schemas-microsoft-com:office:excel" xmlns:o="urn:schemas-microsoft-com:office:office" xmlns:v="urn:schemas-microsoft-com:vml" xmlns:w10="urn:schemas-microsoft-com:office:word" xmlns:pvml="urn:schemas-microsoft-com:office:powerpoint" xmlns:cppr="http://schemas.microsoft.com/office/2006/coverPageProps" xmlns:odx="http://opendope.org/xpaths" xmlns:odc="http://opendope.org/conditions" xmlns:odq="http://opendope.org/questions" xmlns:oda="http://opendope.org/answers" xmlns:odi="http://opendope.org/components" xmlns:odgm="http://opendope.org/SmartArt/DataHierarchy" xmlns:b="http://schemas.openxmlformats.org/officeDocument/2006/bibliography" xmlns:wps="http://schemas.microsoft.com/office/word/2010/wordprocessingShape" xmlns:w16se="http://schemas.microsoft.com/office/word/2015/wordml/symex" xmlns:w16cid="http://schemas.microsoft.com/office/word/2016/wordml/cid" xmlns:wetp="http://schemas.microsoft.com/office/webextensions/taskpanes/2010/11" xmlns:we="http://schemas.microsoft.com/office/webextensions/webextension/2010/11" xmlns:comp="http://schemas.openxmlformats.org/drawingml/2006/compatibility" xmlns:lc="http://schemas.openxmlformats.org/drawingml/2006/lockedCanvas">
+          <c:extLst xmlns:lc="http://schemas.openxmlformats.org/drawingml/2006/lockedCanvas" xmlns:comp="http://schemas.openxmlformats.org/drawingml/2006/compatibility" xmlns:we="http://schemas.microsoft.com/office/webextensions/webextension/2010/11" xmlns:wetp="http://schemas.microsoft.com/office/webextensions/taskpanes/2010/11" xmlns:w16cid="http://schemas.microsoft.com/office/word/2016/wordml/cid" xmlns:w16se="http://schemas.microsoft.com/office/word/2015/wordml/symex" xmlns:wps="http://schemas.microsoft.com/office/word/2010/wordprocessingShape" xmlns:b="http://schemas.openxmlformats.org/officeDocument/2006/bibliography" xmlns:odgm="http://opendope.org/SmartArt/DataHierarchy" xmlns:odi="http://opendope.org/components" xmlns:oda="http://opendope.org/answers" xmlns:odq="http://opendope.org/questions" xmlns:odc="http://opendope.org/conditions" xmlns:odx="http://opendope.org/xpaths" xmlns:cppr="http://schemas.microsoft.com/office/2006/coverPageProps" xmlns:pvml="urn:schemas-microsoft-com:office:powerpoint" xmlns:w10="urn:schemas-microsoft-com:office:word" xmlns:v="urn:schemas-microsoft-com:vml" xmlns:o="urn:schemas-microsoft-com:office:office" xmlns:xvml="urn:schemas-microsoft-com:office:excel" xmlns:dsp="http://schemas.microsoft.com/office/drawing/2008/diagram" xmlns:xdr="http://schemas.openxmlformats.org/drawingml/2006/spreadsheetDrawing" xmlns:pic="http://schemas.openxmlformats.org/drawingml/2006/picture" xmlns:dgm="http://schemas.openxmlformats.org/drawingml/2006/diagram" xmlns:c14="http://schemas.microsoft.com/office/drawing/2007/8/2/chart" xmlns:cdr="http://schemas.openxmlformats.org/drawingml/2006/chartDrawing" xmlns:wne="http://schemas.microsoft.com/office/word/2006/wordml" xmlns:sl="http://schemas.openxmlformats.org/schemaLibrary/2006/main" xmlns:mc="http://schemas.openxmlformats.org/markup-compatibility/2006" xmlns:wp14="http://schemas.microsoft.com/office/word/2010/wordprocessingDrawing" xmlns:wp="http://schemas.openxmlformats.org/drawingml/2006/wordprocessingDrawing" xmlns:m="http://schemas.openxmlformats.org/officeDocument/2006/math" xmlns:w14="http://schemas.microsoft.com/office/word/2010/wordml" xmlns:w15="http://schemas.microsoft.com/office/word/2012/wordml" xmlns:w="http://schemas.openxmlformats.org/wordprocessingml/2006/main">
             <c:ext xmlns:c16="http://schemas.microsoft.com/office/drawing/2014/chart" uri="{C3380CC4-5D6E-409C-BE32-E72D297353CC}">
               <c16:uniqueId val="{00000002-6147-E74A-AA7B-5531F0E4EE0C}"/>
             </c:ext>
@@ -6085,7 +6090,7 @@
     <c:plotVisOnly val="1"/>
     <c:dispBlanksAs val="gap"/>
     <c:showDLblsOverMax val="0"/>
-    <c:extLst xmlns:w="http://schemas.openxmlformats.org/wordprocessingml/2006/main" xmlns:w15="http://schemas.microsoft.com/office/word/2012/wordml" xmlns:w14="http://schemas.microsoft.com/office/word/2010/wordml" xmlns:m="http://schemas.openxmlformats.org/officeDocument/2006/math" xmlns:wp="http://schemas.openxmlformats.org/drawingml/2006/wordprocessingDrawing" xmlns:wp14="http://schemas.microsoft.com/office/word/2010/wordprocessingDrawing" xmlns:mc="http://schemas.openxmlformats.org/markup-compatibility/2006" xmlns:sl="http://schemas.openxmlformats.org/schemaLibrary/2006/main" xmlns:wne="http://schemas.microsoft.com/office/word/2006/wordml" xmlns:cdr="http://schemas.openxmlformats.org/drawingml/2006/chartDrawing" xmlns:c14="http://schemas.microsoft.com/office/drawing/2007/8/2/chart" xmlns:dgm="http://schemas.openxmlformats.org/drawingml/2006/diagram" xmlns:pic="http://schemas.openxmlformats.org/drawingml/2006/picture" xmlns:xdr="http://schemas.openxmlformats.org/drawingml/2006/spreadsheetDrawing" xmlns:dsp="http://schemas.microsoft.com/office/drawing/2008/diagram" xmlns:xvml="urn:schemas-microsoft-com:office:excel" xmlns:o="urn:schemas-microsoft-com:office:office" xmlns:v="urn:schemas-microsoft-com:vml" xmlns:w10="urn:schemas-microsoft-com:office:word" xmlns:pvml="urn:schemas-microsoft-com:office:powerpoint" xmlns:cppr="http://schemas.microsoft.com/office/2006/coverPageProps" xmlns:odx="http://opendope.org/xpaths" xmlns:odc="http://opendope.org/conditions" xmlns:odq="http://opendope.org/questions" xmlns:oda="http://opendope.org/answers" xmlns:odi="http://opendope.org/components" xmlns:odgm="http://opendope.org/SmartArt/DataHierarchy" xmlns:b="http://schemas.openxmlformats.org/officeDocument/2006/bibliography" xmlns:wps="http://schemas.microsoft.com/office/word/2010/wordprocessingShape" xmlns:w16se="http://schemas.microsoft.com/office/word/2015/wordml/symex" xmlns:w16cid="http://schemas.microsoft.com/office/word/2016/wordml/cid" xmlns:wetp="http://schemas.microsoft.com/office/webextensions/taskpanes/2010/11" xmlns:we="http://schemas.microsoft.com/office/webextensions/webextension/2010/11" xmlns:comp="http://schemas.openxmlformats.org/drawingml/2006/compatibility" xmlns:lc="http://schemas.openxmlformats.org/drawingml/2006/lockedCanvas">
+    <c:extLst xmlns:lc="http://schemas.openxmlformats.org/drawingml/2006/lockedCanvas" xmlns:comp="http://schemas.openxmlformats.org/drawingml/2006/compatibility" xmlns:we="http://schemas.microsoft.com/office/webextensions/webextension/2010/11" xmlns:wetp="http://schemas.microsoft.com/office/webextensions/taskpanes/2010/11" xmlns:w16cid="http://schemas.microsoft.com/office/word/2016/wordml/cid" xmlns:w16se="http://schemas.microsoft.com/office/word/2015/wordml/symex" xmlns:wps="http://schemas.microsoft.com/office/word/2010/wordprocessingShape" xmlns:b="http://schemas.openxmlformats.org/officeDocument/2006/bibliography" xmlns:odgm="http://opendope.org/SmartArt/DataHierarchy" xmlns:odi="http://opendope.org/components" xmlns:oda="http://opendope.org/answers" xmlns:odq="http://opendope.org/questions" xmlns:odc="http://opendope.org/conditions" xmlns:odx="http://opendope.org/xpaths" xmlns:cppr="http://schemas.microsoft.com/office/2006/coverPageProps" xmlns:pvml="urn:schemas-microsoft-com:office:powerpoint" xmlns:w10="urn:schemas-microsoft-com:office:word" xmlns:v="urn:schemas-microsoft-com:vml" xmlns:o="urn:schemas-microsoft-com:office:office" xmlns:xvml="urn:schemas-microsoft-com:office:excel" xmlns:dsp="http://schemas.microsoft.com/office/drawing/2008/diagram" xmlns:xdr="http://schemas.openxmlformats.org/drawingml/2006/spreadsheetDrawing" xmlns:pic="http://schemas.openxmlformats.org/drawingml/2006/picture" xmlns:dgm="http://schemas.openxmlformats.org/drawingml/2006/diagram" xmlns:c14="http://schemas.microsoft.com/office/drawing/2007/8/2/chart" xmlns:cdr="http://schemas.openxmlformats.org/drawingml/2006/chartDrawing" xmlns:wne="http://schemas.microsoft.com/office/word/2006/wordml" xmlns:sl="http://schemas.openxmlformats.org/schemaLibrary/2006/main" xmlns:mc="http://schemas.openxmlformats.org/markup-compatibility/2006" xmlns:wp14="http://schemas.microsoft.com/office/word/2010/wordprocessingDrawing" xmlns:wp="http://schemas.openxmlformats.org/drawingml/2006/wordprocessingDrawing" xmlns:m="http://schemas.openxmlformats.org/officeDocument/2006/math" xmlns:w14="http://schemas.microsoft.com/office/word/2010/wordml" xmlns:w15="http://schemas.microsoft.com/office/word/2012/wordml" xmlns:w="http://schemas.openxmlformats.org/wordprocessingml/2006/main">
       <c:ext xmlns:c16r3="http://schemas.microsoft.com/office/drawing/2017/03/chart" uri="{56B9EC1D-385E-4148-901F-78D8002777C0}">
         <c16r3:dataDisplayOptions16>
           <c16r3:dispNaAsBlank val="1"/>
@@ -10398,7 +10403,7 @@
           <a:p>
             <a:fld id="{D672B8B4-E227-994A-A2C0-477E986EF4F1}" type="datetimeFigureOut">
               <a:rPr lang="nl-NL" smtClean="0"/>
-              <a:t>21-10-2025</a:t>
+              <a:t>29-10-2025</a:t>
             </a:fld>
             <a:endParaRPr lang="nl-NL"/>
           </a:p>
@@ -12663,7 +12668,7 @@
           <a:p>
             <a:fld id="{542F8156-3D1B-1047-9A3D-372BE84AD46C}" type="datetimeFigureOut">
               <a:rPr lang="nl-NL" smtClean="0"/>
-              <a:t>21-10-2025</a:t>
+              <a:t>29-10-2025</a:t>
             </a:fld>
             <a:endParaRPr lang="nl-NL"/>
           </a:p>
@@ -12863,7 +12868,7 @@
           <a:p>
             <a:fld id="{542F8156-3D1B-1047-9A3D-372BE84AD46C}" type="datetimeFigureOut">
               <a:rPr lang="nl-NL" smtClean="0"/>
-              <a:t>21-10-2025</a:t>
+              <a:t>29-10-2025</a:t>
             </a:fld>
             <a:endParaRPr lang="nl-NL"/>
           </a:p>
@@ -13073,7 +13078,7 @@
           <a:p>
             <a:fld id="{542F8156-3D1B-1047-9A3D-372BE84AD46C}" type="datetimeFigureOut">
               <a:rPr lang="nl-NL" smtClean="0"/>
-              <a:t>21-10-2025</a:t>
+              <a:t>29-10-2025</a:t>
             </a:fld>
             <a:endParaRPr lang="nl-NL"/>
           </a:p>
@@ -13998,7 +14003,7 @@
           <a:p>
             <a:fld id="{542F8156-3D1B-1047-9A3D-372BE84AD46C}" type="datetimeFigureOut">
               <a:rPr lang="nl-NL" smtClean="0"/>
-              <a:t>21-10-2025</a:t>
+              <a:t>29-10-2025</a:t>
             </a:fld>
             <a:endParaRPr lang="nl-NL"/>
           </a:p>
@@ -14274,7 +14279,7 @@
           <a:p>
             <a:fld id="{542F8156-3D1B-1047-9A3D-372BE84AD46C}" type="datetimeFigureOut">
               <a:rPr lang="nl-NL" smtClean="0"/>
-              <a:t>21-10-2025</a:t>
+              <a:t>29-10-2025</a:t>
             </a:fld>
             <a:endParaRPr lang="nl-NL"/>
           </a:p>
@@ -14542,7 +14547,7 @@
           <a:p>
             <a:fld id="{542F8156-3D1B-1047-9A3D-372BE84AD46C}" type="datetimeFigureOut">
               <a:rPr lang="nl-NL" smtClean="0"/>
-              <a:t>21-10-2025</a:t>
+              <a:t>29-10-2025</a:t>
             </a:fld>
             <a:endParaRPr lang="nl-NL"/>
           </a:p>
@@ -14957,7 +14962,7 @@
           <a:p>
             <a:fld id="{542F8156-3D1B-1047-9A3D-372BE84AD46C}" type="datetimeFigureOut">
               <a:rPr lang="nl-NL" smtClean="0"/>
-              <a:t>21-10-2025</a:t>
+              <a:t>29-10-2025</a:t>
             </a:fld>
             <a:endParaRPr lang="nl-NL"/>
           </a:p>
@@ -15099,7 +15104,7 @@
           <a:p>
             <a:fld id="{542F8156-3D1B-1047-9A3D-372BE84AD46C}" type="datetimeFigureOut">
               <a:rPr lang="nl-NL" smtClean="0"/>
-              <a:t>21-10-2025</a:t>
+              <a:t>29-10-2025</a:t>
             </a:fld>
             <a:endParaRPr lang="nl-NL"/>
           </a:p>
@@ -15212,7 +15217,7 @@
           <a:p>
             <a:fld id="{542F8156-3D1B-1047-9A3D-372BE84AD46C}" type="datetimeFigureOut">
               <a:rPr lang="nl-NL" smtClean="0"/>
-              <a:t>21-10-2025</a:t>
+              <a:t>29-10-2025</a:t>
             </a:fld>
             <a:endParaRPr lang="nl-NL"/>
           </a:p>
@@ -15525,7 +15530,7 @@
           <a:p>
             <a:fld id="{542F8156-3D1B-1047-9A3D-372BE84AD46C}" type="datetimeFigureOut">
               <a:rPr lang="nl-NL" smtClean="0"/>
-              <a:t>21-10-2025</a:t>
+              <a:t>29-10-2025</a:t>
             </a:fld>
             <a:endParaRPr lang="nl-NL"/>
           </a:p>
@@ -15814,7 +15819,7 @@
           <a:p>
             <a:fld id="{542F8156-3D1B-1047-9A3D-372BE84AD46C}" type="datetimeFigureOut">
               <a:rPr lang="nl-NL" smtClean="0"/>
-              <a:t>21-10-2025</a:t>
+              <a:t>29-10-2025</a:t>
             </a:fld>
             <a:endParaRPr lang="nl-NL"/>
           </a:p>
@@ -16057,7 +16062,7 @@
           <a:p>
             <a:fld id="{542F8156-3D1B-1047-9A3D-372BE84AD46C}" type="datetimeFigureOut">
               <a:rPr lang="nl-NL" smtClean="0"/>
-              <a:t>21-10-2025</a:t>
+              <a:t>29-10-2025</a:t>
             </a:fld>
             <a:endParaRPr lang="nl-NL"/>
           </a:p>
@@ -25107,7 +25112,31 @@
                   <a:schemeClr val="bg1"/>
                 </a:solidFill>
               </a:rPr>
-              <a:t>PORTFOLIO_PERIOD_SECURITY_DASHBOARD_MEDIUM_RESOLUTION_TIMES</a:t>
+              <a:t>PORTFOLIO_PERIOD_SECURITY_</a:t>
+            </a:r>
+            <a:r>
+              <a:rPr lang="en-US" sz="1600" err="1">
+                <a:solidFill>
+                  <a:schemeClr val="bg1"/>
+                </a:solidFill>
+              </a:rPr>
+              <a:t>DASHBOARD</a:t>
+            </a:r>
+            <a:r>
+              <a:rPr lang="en-US" sz="1600">
+                <a:solidFill>
+                  <a:schemeClr val="bg1"/>
+                </a:solidFill>
+              </a:rPr>
+              <a:t>_HIGH_</a:t>
+            </a:r>
+            <a:r>
+              <a:rPr lang="en-US" sz="1600" dirty="0" err="1">
+                <a:solidFill>
+                  <a:schemeClr val="bg1"/>
+                </a:solidFill>
+              </a:rPr>
+              <a:t>RESOLUTION_TIMES</a:t>
             </a:r>
             <a:endParaRPr lang="en-US" sz="1600" dirty="0">
               <a:solidFill>

</xml_diff>

<commit_message>
Intermediary update regarding bar charts
</commit_message>
<xml_diff>
--- a/src/report_generator/presets/templates/portfolio-overview.pptx
+++ b/src/report_generator/presets/templates/portfolio-overview.pptx
@@ -129,6 +129,11 @@
       </a:defRPr>
     </a:lvl9pPr>
   </p:defaultTextStyle>
+  <p:extLst>
+    <p:ext uri="{EFAFB233-063F-42B5-8137-9DF3F51BA10A}">
+      <p15:sldGuideLst xmlns:p15="http://schemas.microsoft.com/office/powerpoint/2012/main"/>
+    </p:ext>
+  </p:extLst>
 </p:presentation>
 </file>
 
@@ -203,7 +208,7 @@
                 </a:outerShdw>
               </a:effectLst>
             </c:spPr>
-            <c:extLst xmlns:w="http://schemas.openxmlformats.org/wordprocessingml/2006/main" xmlns:w15="http://schemas.microsoft.com/office/word/2012/wordml" xmlns:w14="http://schemas.microsoft.com/office/word/2010/wordml" xmlns:m="http://schemas.openxmlformats.org/officeDocument/2006/math" xmlns:wp="http://schemas.openxmlformats.org/drawingml/2006/wordprocessingDrawing" xmlns:wp14="http://schemas.microsoft.com/office/word/2010/wordprocessingDrawing" xmlns:mc="http://schemas.openxmlformats.org/markup-compatibility/2006" xmlns:sl="http://schemas.openxmlformats.org/schemaLibrary/2006/main" xmlns:wne="http://schemas.microsoft.com/office/word/2006/wordml" xmlns:cdr="http://schemas.openxmlformats.org/drawingml/2006/chartDrawing" xmlns:c14="http://schemas.microsoft.com/office/drawing/2007/8/2/chart" xmlns:dgm="http://schemas.openxmlformats.org/drawingml/2006/diagram" xmlns:pic="http://schemas.openxmlformats.org/drawingml/2006/picture" xmlns:xdr="http://schemas.openxmlformats.org/drawingml/2006/spreadsheetDrawing" xmlns:dsp="http://schemas.microsoft.com/office/drawing/2008/diagram" xmlns:xvml="urn:schemas-microsoft-com:office:excel" xmlns:o="urn:schemas-microsoft-com:office:office" xmlns:v="urn:schemas-microsoft-com:vml" xmlns:w10="urn:schemas-microsoft-com:office:word" xmlns:pvml="urn:schemas-microsoft-com:office:powerpoint" xmlns:cppr="http://schemas.microsoft.com/office/2006/coverPageProps" xmlns:odx="http://opendope.org/xpaths" xmlns:odc="http://opendope.org/conditions" xmlns:odq="http://opendope.org/questions" xmlns:oda="http://opendope.org/answers" xmlns:odi="http://opendope.org/components" xmlns:odgm="http://opendope.org/SmartArt/DataHierarchy" xmlns:b="http://schemas.openxmlformats.org/officeDocument/2006/bibliography" xmlns:wps="http://schemas.microsoft.com/office/word/2010/wordprocessingShape" xmlns:w16se="http://schemas.microsoft.com/office/word/2015/wordml/symex" xmlns:w16cid="http://schemas.microsoft.com/office/word/2016/wordml/cid" xmlns:wetp="http://schemas.microsoft.com/office/webextensions/taskpanes/2010/11" xmlns:we="http://schemas.microsoft.com/office/webextensions/webextension/2010/11" xmlns:comp="http://schemas.openxmlformats.org/drawingml/2006/compatibility" xmlns:lc="http://schemas.openxmlformats.org/drawingml/2006/lockedCanvas">
+            <c:extLst xmlns:lc="http://schemas.openxmlformats.org/drawingml/2006/lockedCanvas" xmlns:comp="http://schemas.openxmlformats.org/drawingml/2006/compatibility" xmlns:we="http://schemas.microsoft.com/office/webextensions/webextension/2010/11" xmlns:wetp="http://schemas.microsoft.com/office/webextensions/taskpanes/2010/11" xmlns:w16cid="http://schemas.microsoft.com/office/word/2016/wordml/cid" xmlns:w16se="http://schemas.microsoft.com/office/word/2015/wordml/symex" xmlns:wps="http://schemas.microsoft.com/office/word/2010/wordprocessingShape" xmlns:b="http://schemas.openxmlformats.org/officeDocument/2006/bibliography" xmlns:odgm="http://opendope.org/SmartArt/DataHierarchy" xmlns:odi="http://opendope.org/components" xmlns:oda="http://opendope.org/answers" xmlns:odq="http://opendope.org/questions" xmlns:odc="http://opendope.org/conditions" xmlns:odx="http://opendope.org/xpaths" xmlns:cppr="http://schemas.microsoft.com/office/2006/coverPageProps" xmlns:pvml="urn:schemas-microsoft-com:office:powerpoint" xmlns:w10="urn:schemas-microsoft-com:office:word" xmlns:v="urn:schemas-microsoft-com:vml" xmlns:o="urn:schemas-microsoft-com:office:office" xmlns:xvml="urn:schemas-microsoft-com:office:excel" xmlns:dsp="http://schemas.microsoft.com/office/drawing/2008/diagram" xmlns:xdr="http://schemas.openxmlformats.org/drawingml/2006/spreadsheetDrawing" xmlns:pic="http://schemas.openxmlformats.org/drawingml/2006/picture" xmlns:dgm="http://schemas.openxmlformats.org/drawingml/2006/diagram" xmlns:c14="http://schemas.microsoft.com/office/drawing/2007/8/2/chart" xmlns:cdr="http://schemas.openxmlformats.org/drawingml/2006/chartDrawing" xmlns:wne="http://schemas.microsoft.com/office/word/2006/wordml" xmlns:sl="http://schemas.openxmlformats.org/schemaLibrary/2006/main" xmlns:mc="http://schemas.openxmlformats.org/markup-compatibility/2006" xmlns:wp14="http://schemas.microsoft.com/office/word/2010/wordprocessingDrawing" xmlns:wp="http://schemas.openxmlformats.org/drawingml/2006/wordprocessingDrawing" xmlns:m="http://schemas.openxmlformats.org/officeDocument/2006/math" xmlns:w14="http://schemas.microsoft.com/office/word/2010/wordml" xmlns:w15="http://schemas.microsoft.com/office/word/2012/wordml" xmlns:w="http://schemas.openxmlformats.org/wordprocessingml/2006/main">
               <c:ext xmlns:c16="http://schemas.microsoft.com/office/drawing/2014/chart" uri="{C3380CC4-5D6E-409C-BE32-E72D297353CC}">
                 <c16:uniqueId val="{00000001-6147-E74A-AA7B-5531F0E4EE0C}"/>
               </c:ext>
@@ -232,7 +237,7 @@
               </c:numCache>
             </c:numRef>
           </c:val>
-          <c:extLst xmlns:w="http://schemas.openxmlformats.org/wordprocessingml/2006/main" xmlns:w15="http://schemas.microsoft.com/office/word/2012/wordml" xmlns:w14="http://schemas.microsoft.com/office/word/2010/wordml" xmlns:m="http://schemas.openxmlformats.org/officeDocument/2006/math" xmlns:wp="http://schemas.openxmlformats.org/drawingml/2006/wordprocessingDrawing" xmlns:wp14="http://schemas.microsoft.com/office/word/2010/wordprocessingDrawing" xmlns:mc="http://schemas.openxmlformats.org/markup-compatibility/2006" xmlns:sl="http://schemas.openxmlformats.org/schemaLibrary/2006/main" xmlns:wne="http://schemas.microsoft.com/office/word/2006/wordml" xmlns:cdr="http://schemas.openxmlformats.org/drawingml/2006/chartDrawing" xmlns:c14="http://schemas.microsoft.com/office/drawing/2007/8/2/chart" xmlns:dgm="http://schemas.openxmlformats.org/drawingml/2006/diagram" xmlns:pic="http://schemas.openxmlformats.org/drawingml/2006/picture" xmlns:xdr="http://schemas.openxmlformats.org/drawingml/2006/spreadsheetDrawing" xmlns:dsp="http://schemas.microsoft.com/office/drawing/2008/diagram" xmlns:xvml="urn:schemas-microsoft-com:office:excel" xmlns:o="urn:schemas-microsoft-com:office:office" xmlns:v="urn:schemas-microsoft-com:vml" xmlns:w10="urn:schemas-microsoft-com:office:word" xmlns:pvml="urn:schemas-microsoft-com:office:powerpoint" xmlns:cppr="http://schemas.microsoft.com/office/2006/coverPageProps" xmlns:odx="http://opendope.org/xpaths" xmlns:odc="http://opendope.org/conditions" xmlns:odq="http://opendope.org/questions" xmlns:oda="http://opendope.org/answers" xmlns:odi="http://opendope.org/components" xmlns:odgm="http://opendope.org/SmartArt/DataHierarchy" xmlns:b="http://schemas.openxmlformats.org/officeDocument/2006/bibliography" xmlns:wps="http://schemas.microsoft.com/office/word/2010/wordprocessingShape" xmlns:w16se="http://schemas.microsoft.com/office/word/2015/wordml/symex" xmlns:w16cid="http://schemas.microsoft.com/office/word/2016/wordml/cid" xmlns:wetp="http://schemas.microsoft.com/office/webextensions/taskpanes/2010/11" xmlns:we="http://schemas.microsoft.com/office/webextensions/webextension/2010/11" xmlns:comp="http://schemas.openxmlformats.org/drawingml/2006/compatibility" xmlns:lc="http://schemas.openxmlformats.org/drawingml/2006/lockedCanvas">
+          <c:extLst xmlns:lc="http://schemas.openxmlformats.org/drawingml/2006/lockedCanvas" xmlns:comp="http://schemas.openxmlformats.org/drawingml/2006/compatibility" xmlns:we="http://schemas.microsoft.com/office/webextensions/webextension/2010/11" xmlns:wetp="http://schemas.microsoft.com/office/webextensions/taskpanes/2010/11" xmlns:w16cid="http://schemas.microsoft.com/office/word/2016/wordml/cid" xmlns:w16se="http://schemas.microsoft.com/office/word/2015/wordml/symex" xmlns:wps="http://schemas.microsoft.com/office/word/2010/wordprocessingShape" xmlns:b="http://schemas.openxmlformats.org/officeDocument/2006/bibliography" xmlns:odgm="http://opendope.org/SmartArt/DataHierarchy" xmlns:odi="http://opendope.org/components" xmlns:oda="http://opendope.org/answers" xmlns:odq="http://opendope.org/questions" xmlns:odc="http://opendope.org/conditions" xmlns:odx="http://opendope.org/xpaths" xmlns:cppr="http://schemas.microsoft.com/office/2006/coverPageProps" xmlns:pvml="urn:schemas-microsoft-com:office:powerpoint" xmlns:w10="urn:schemas-microsoft-com:office:word" xmlns:v="urn:schemas-microsoft-com:vml" xmlns:o="urn:schemas-microsoft-com:office:office" xmlns:xvml="urn:schemas-microsoft-com:office:excel" xmlns:dsp="http://schemas.microsoft.com/office/drawing/2008/diagram" xmlns:xdr="http://schemas.openxmlformats.org/drawingml/2006/spreadsheetDrawing" xmlns:pic="http://schemas.openxmlformats.org/drawingml/2006/picture" xmlns:dgm="http://schemas.openxmlformats.org/drawingml/2006/diagram" xmlns:c14="http://schemas.microsoft.com/office/drawing/2007/8/2/chart" xmlns:cdr="http://schemas.openxmlformats.org/drawingml/2006/chartDrawing" xmlns:wne="http://schemas.microsoft.com/office/word/2006/wordml" xmlns:sl="http://schemas.openxmlformats.org/schemaLibrary/2006/main" xmlns:mc="http://schemas.openxmlformats.org/markup-compatibility/2006" xmlns:wp14="http://schemas.microsoft.com/office/word/2010/wordprocessingDrawing" xmlns:wp="http://schemas.openxmlformats.org/drawingml/2006/wordprocessingDrawing" xmlns:m="http://schemas.openxmlformats.org/officeDocument/2006/math" xmlns:w14="http://schemas.microsoft.com/office/word/2010/wordml" xmlns:w15="http://schemas.microsoft.com/office/word/2012/wordml" xmlns:w="http://schemas.openxmlformats.org/wordprocessingml/2006/main">
             <c:ext xmlns:c16="http://schemas.microsoft.com/office/drawing/2014/chart" uri="{C3380CC4-5D6E-409C-BE32-E72D297353CC}">
               <c16:uniqueId val="{00000002-6147-E74A-AA7B-5531F0E4EE0C}"/>
             </c:ext>
@@ -549,7 +554,7 @@
     <c:plotVisOnly val="1"/>
     <c:dispBlanksAs val="gap"/>
     <c:showDLblsOverMax val="0"/>
-    <c:extLst xmlns:w="http://schemas.openxmlformats.org/wordprocessingml/2006/main" xmlns:w15="http://schemas.microsoft.com/office/word/2012/wordml" xmlns:w14="http://schemas.microsoft.com/office/word/2010/wordml" xmlns:m="http://schemas.openxmlformats.org/officeDocument/2006/math" xmlns:wp="http://schemas.openxmlformats.org/drawingml/2006/wordprocessingDrawing" xmlns:wp14="http://schemas.microsoft.com/office/word/2010/wordprocessingDrawing" xmlns:mc="http://schemas.openxmlformats.org/markup-compatibility/2006" xmlns:sl="http://schemas.openxmlformats.org/schemaLibrary/2006/main" xmlns:wne="http://schemas.microsoft.com/office/word/2006/wordml" xmlns:cdr="http://schemas.openxmlformats.org/drawingml/2006/chartDrawing" xmlns:c14="http://schemas.microsoft.com/office/drawing/2007/8/2/chart" xmlns:dgm="http://schemas.openxmlformats.org/drawingml/2006/diagram" xmlns:pic="http://schemas.openxmlformats.org/drawingml/2006/picture" xmlns:xdr="http://schemas.openxmlformats.org/drawingml/2006/spreadsheetDrawing" xmlns:dsp="http://schemas.microsoft.com/office/drawing/2008/diagram" xmlns:xvml="urn:schemas-microsoft-com:office:excel" xmlns:o="urn:schemas-microsoft-com:office:office" xmlns:v="urn:schemas-microsoft-com:vml" xmlns:w10="urn:schemas-microsoft-com:office:word" xmlns:pvml="urn:schemas-microsoft-com:office:powerpoint" xmlns:cppr="http://schemas.microsoft.com/office/2006/coverPageProps" xmlns:odx="http://opendope.org/xpaths" xmlns:odc="http://opendope.org/conditions" xmlns:odq="http://opendope.org/questions" xmlns:oda="http://opendope.org/answers" xmlns:odi="http://opendope.org/components" xmlns:odgm="http://opendope.org/SmartArt/DataHierarchy" xmlns:b="http://schemas.openxmlformats.org/officeDocument/2006/bibliography" xmlns:wps="http://schemas.microsoft.com/office/word/2010/wordprocessingShape" xmlns:w16se="http://schemas.microsoft.com/office/word/2015/wordml/symex" xmlns:w16cid="http://schemas.microsoft.com/office/word/2016/wordml/cid" xmlns:wetp="http://schemas.microsoft.com/office/webextensions/taskpanes/2010/11" xmlns:we="http://schemas.microsoft.com/office/webextensions/webextension/2010/11" xmlns:comp="http://schemas.openxmlformats.org/drawingml/2006/compatibility" xmlns:lc="http://schemas.openxmlformats.org/drawingml/2006/lockedCanvas">
+    <c:extLst xmlns:lc="http://schemas.openxmlformats.org/drawingml/2006/lockedCanvas" xmlns:comp="http://schemas.openxmlformats.org/drawingml/2006/compatibility" xmlns:we="http://schemas.microsoft.com/office/webextensions/webextension/2010/11" xmlns:wetp="http://schemas.microsoft.com/office/webextensions/taskpanes/2010/11" xmlns:w16cid="http://schemas.microsoft.com/office/word/2016/wordml/cid" xmlns:w16se="http://schemas.microsoft.com/office/word/2015/wordml/symex" xmlns:wps="http://schemas.microsoft.com/office/word/2010/wordprocessingShape" xmlns:b="http://schemas.openxmlformats.org/officeDocument/2006/bibliography" xmlns:odgm="http://opendope.org/SmartArt/DataHierarchy" xmlns:odi="http://opendope.org/components" xmlns:oda="http://opendope.org/answers" xmlns:odq="http://opendope.org/questions" xmlns:odc="http://opendope.org/conditions" xmlns:odx="http://opendope.org/xpaths" xmlns:cppr="http://schemas.microsoft.com/office/2006/coverPageProps" xmlns:pvml="urn:schemas-microsoft-com:office:powerpoint" xmlns:w10="urn:schemas-microsoft-com:office:word" xmlns:v="urn:schemas-microsoft-com:vml" xmlns:o="urn:schemas-microsoft-com:office:office" xmlns:xvml="urn:schemas-microsoft-com:office:excel" xmlns:dsp="http://schemas.microsoft.com/office/drawing/2008/diagram" xmlns:xdr="http://schemas.openxmlformats.org/drawingml/2006/spreadsheetDrawing" xmlns:pic="http://schemas.openxmlformats.org/drawingml/2006/picture" xmlns:dgm="http://schemas.openxmlformats.org/drawingml/2006/diagram" xmlns:c14="http://schemas.microsoft.com/office/drawing/2007/8/2/chart" xmlns:cdr="http://schemas.openxmlformats.org/drawingml/2006/chartDrawing" xmlns:wne="http://schemas.microsoft.com/office/word/2006/wordml" xmlns:sl="http://schemas.openxmlformats.org/schemaLibrary/2006/main" xmlns:mc="http://schemas.openxmlformats.org/markup-compatibility/2006" xmlns:wp14="http://schemas.microsoft.com/office/word/2010/wordprocessingDrawing" xmlns:wp="http://schemas.openxmlformats.org/drawingml/2006/wordprocessingDrawing" xmlns:m="http://schemas.openxmlformats.org/officeDocument/2006/math" xmlns:w14="http://schemas.microsoft.com/office/word/2010/wordml" xmlns:w15="http://schemas.microsoft.com/office/word/2012/wordml" xmlns:w="http://schemas.openxmlformats.org/wordprocessingml/2006/main">
       <c:ext xmlns:c16r3="http://schemas.microsoft.com/office/drawing/2017/03/chart" uri="{56B9EC1D-385E-4148-901F-78D8002777C0}">
         <c16r3:dataDisplayOptions16>
           <c16r3:dispNaAsBlank val="1"/>
@@ -651,7 +656,7 @@
                 </a:outerShdw>
               </a:effectLst>
             </c:spPr>
-            <c:extLst xmlns:lc="http://schemas.openxmlformats.org/drawingml/2006/lockedCanvas" xmlns:comp="http://schemas.openxmlformats.org/drawingml/2006/compatibility" xmlns:we="http://schemas.microsoft.com/office/webextensions/webextension/2010/11" xmlns:wetp="http://schemas.microsoft.com/office/webextensions/taskpanes/2010/11" xmlns:w16cid="http://schemas.microsoft.com/office/word/2016/wordml/cid" xmlns:w16se="http://schemas.microsoft.com/office/word/2015/wordml/symex" xmlns:wps="http://schemas.microsoft.com/office/word/2010/wordprocessingShape" xmlns:b="http://schemas.openxmlformats.org/officeDocument/2006/bibliography" xmlns:odgm="http://opendope.org/SmartArt/DataHierarchy" xmlns:odi="http://opendope.org/components" xmlns:oda="http://opendope.org/answers" xmlns:odq="http://opendope.org/questions" xmlns:odc="http://opendope.org/conditions" xmlns:odx="http://opendope.org/xpaths" xmlns:cppr="http://schemas.microsoft.com/office/2006/coverPageProps" xmlns:pvml="urn:schemas-microsoft-com:office:powerpoint" xmlns:w10="urn:schemas-microsoft-com:office:word" xmlns:v="urn:schemas-microsoft-com:vml" xmlns:o="urn:schemas-microsoft-com:office:office" xmlns:xvml="urn:schemas-microsoft-com:office:excel" xmlns:dsp="http://schemas.microsoft.com/office/drawing/2008/diagram" xmlns:xdr="http://schemas.openxmlformats.org/drawingml/2006/spreadsheetDrawing" xmlns:pic="http://schemas.openxmlformats.org/drawingml/2006/picture" xmlns:dgm="http://schemas.openxmlformats.org/drawingml/2006/diagram" xmlns:c14="http://schemas.microsoft.com/office/drawing/2007/8/2/chart" xmlns:cdr="http://schemas.openxmlformats.org/drawingml/2006/chartDrawing" xmlns:wne="http://schemas.microsoft.com/office/word/2006/wordml" xmlns:sl="http://schemas.openxmlformats.org/schemaLibrary/2006/main" xmlns:mc="http://schemas.openxmlformats.org/markup-compatibility/2006" xmlns:wp14="http://schemas.microsoft.com/office/word/2010/wordprocessingDrawing" xmlns:wp="http://schemas.openxmlformats.org/drawingml/2006/wordprocessingDrawing" xmlns:m="http://schemas.openxmlformats.org/officeDocument/2006/math" xmlns:w14="http://schemas.microsoft.com/office/word/2010/wordml" xmlns:w15="http://schemas.microsoft.com/office/word/2012/wordml" xmlns:w="http://schemas.openxmlformats.org/wordprocessingml/2006/main">
+            <c:extLst xmlns:w="http://schemas.openxmlformats.org/wordprocessingml/2006/main" xmlns:w15="http://schemas.microsoft.com/office/word/2012/wordml" xmlns:w14="http://schemas.microsoft.com/office/word/2010/wordml" xmlns:m="http://schemas.openxmlformats.org/officeDocument/2006/math" xmlns:wp="http://schemas.openxmlformats.org/drawingml/2006/wordprocessingDrawing" xmlns:wp14="http://schemas.microsoft.com/office/word/2010/wordprocessingDrawing" xmlns:mc="http://schemas.openxmlformats.org/markup-compatibility/2006" xmlns:sl="http://schemas.openxmlformats.org/schemaLibrary/2006/main" xmlns:wne="http://schemas.microsoft.com/office/word/2006/wordml" xmlns:cdr="http://schemas.openxmlformats.org/drawingml/2006/chartDrawing" xmlns:c14="http://schemas.microsoft.com/office/drawing/2007/8/2/chart" xmlns:dgm="http://schemas.openxmlformats.org/drawingml/2006/diagram" xmlns:pic="http://schemas.openxmlformats.org/drawingml/2006/picture" xmlns:xdr="http://schemas.openxmlformats.org/drawingml/2006/spreadsheetDrawing" xmlns:dsp="http://schemas.microsoft.com/office/drawing/2008/diagram" xmlns:xvml="urn:schemas-microsoft-com:office:excel" xmlns:o="urn:schemas-microsoft-com:office:office" xmlns:v="urn:schemas-microsoft-com:vml" xmlns:w10="urn:schemas-microsoft-com:office:word" xmlns:pvml="urn:schemas-microsoft-com:office:powerpoint" xmlns:cppr="http://schemas.microsoft.com/office/2006/coverPageProps" xmlns:odx="http://opendope.org/xpaths" xmlns:odc="http://opendope.org/conditions" xmlns:odq="http://opendope.org/questions" xmlns:oda="http://opendope.org/answers" xmlns:odi="http://opendope.org/components" xmlns:odgm="http://opendope.org/SmartArt/DataHierarchy" xmlns:b="http://schemas.openxmlformats.org/officeDocument/2006/bibliography" xmlns:wps="http://schemas.microsoft.com/office/word/2010/wordprocessingShape" xmlns:w16se="http://schemas.microsoft.com/office/word/2015/wordml/symex" xmlns:w16cid="http://schemas.microsoft.com/office/word/2016/wordml/cid" xmlns:wetp="http://schemas.microsoft.com/office/webextensions/taskpanes/2010/11" xmlns:we="http://schemas.microsoft.com/office/webextensions/webextension/2010/11" xmlns:comp="http://schemas.openxmlformats.org/drawingml/2006/compatibility" xmlns:lc="http://schemas.openxmlformats.org/drawingml/2006/lockedCanvas">
               <c:ext xmlns:c16="http://schemas.microsoft.com/office/drawing/2014/chart" uri="{C3380CC4-5D6E-409C-BE32-E72D297353CC}">
                 <c16:uniqueId val="{00000001-6147-E74A-AA7B-5531F0E4EE0C}"/>
               </c:ext>
@@ -734,7 +739,7 @@
               </c:numCache>
             </c:numRef>
           </c:val>
-          <c:extLst xmlns:lc="http://schemas.openxmlformats.org/drawingml/2006/lockedCanvas" xmlns:comp="http://schemas.openxmlformats.org/drawingml/2006/compatibility" xmlns:we="http://schemas.microsoft.com/office/webextensions/webextension/2010/11" xmlns:wetp="http://schemas.microsoft.com/office/webextensions/taskpanes/2010/11" xmlns:w16cid="http://schemas.microsoft.com/office/word/2016/wordml/cid" xmlns:w16se="http://schemas.microsoft.com/office/word/2015/wordml/symex" xmlns:wps="http://schemas.microsoft.com/office/word/2010/wordprocessingShape" xmlns:b="http://schemas.openxmlformats.org/officeDocument/2006/bibliography" xmlns:odgm="http://opendope.org/SmartArt/DataHierarchy" xmlns:odi="http://opendope.org/components" xmlns:oda="http://opendope.org/answers" xmlns:odq="http://opendope.org/questions" xmlns:odc="http://opendope.org/conditions" xmlns:odx="http://opendope.org/xpaths" xmlns:cppr="http://schemas.microsoft.com/office/2006/coverPageProps" xmlns:pvml="urn:schemas-microsoft-com:office:powerpoint" xmlns:w10="urn:schemas-microsoft-com:office:word" xmlns:v="urn:schemas-microsoft-com:vml" xmlns:o="urn:schemas-microsoft-com:office:office" xmlns:xvml="urn:schemas-microsoft-com:office:excel" xmlns:dsp="http://schemas.microsoft.com/office/drawing/2008/diagram" xmlns:xdr="http://schemas.openxmlformats.org/drawingml/2006/spreadsheetDrawing" xmlns:pic="http://schemas.openxmlformats.org/drawingml/2006/picture" xmlns:dgm="http://schemas.openxmlformats.org/drawingml/2006/diagram" xmlns:c14="http://schemas.microsoft.com/office/drawing/2007/8/2/chart" xmlns:cdr="http://schemas.openxmlformats.org/drawingml/2006/chartDrawing" xmlns:wne="http://schemas.microsoft.com/office/word/2006/wordml" xmlns:sl="http://schemas.openxmlformats.org/schemaLibrary/2006/main" xmlns:mc="http://schemas.openxmlformats.org/markup-compatibility/2006" xmlns:wp14="http://schemas.microsoft.com/office/word/2010/wordprocessingDrawing" xmlns:wp="http://schemas.openxmlformats.org/drawingml/2006/wordprocessingDrawing" xmlns:m="http://schemas.openxmlformats.org/officeDocument/2006/math" xmlns:w14="http://schemas.microsoft.com/office/word/2010/wordml" xmlns:w15="http://schemas.microsoft.com/office/word/2012/wordml" xmlns:w="http://schemas.openxmlformats.org/wordprocessingml/2006/main">
+          <c:extLst xmlns:w="http://schemas.openxmlformats.org/wordprocessingml/2006/main" xmlns:w15="http://schemas.microsoft.com/office/word/2012/wordml" xmlns:w14="http://schemas.microsoft.com/office/word/2010/wordml" xmlns:m="http://schemas.openxmlformats.org/officeDocument/2006/math" xmlns:wp="http://schemas.openxmlformats.org/drawingml/2006/wordprocessingDrawing" xmlns:wp14="http://schemas.microsoft.com/office/word/2010/wordprocessingDrawing" xmlns:mc="http://schemas.openxmlformats.org/markup-compatibility/2006" xmlns:sl="http://schemas.openxmlformats.org/schemaLibrary/2006/main" xmlns:wne="http://schemas.microsoft.com/office/word/2006/wordml" xmlns:cdr="http://schemas.openxmlformats.org/drawingml/2006/chartDrawing" xmlns:c14="http://schemas.microsoft.com/office/drawing/2007/8/2/chart" xmlns:dgm="http://schemas.openxmlformats.org/drawingml/2006/diagram" xmlns:pic="http://schemas.openxmlformats.org/drawingml/2006/picture" xmlns:xdr="http://schemas.openxmlformats.org/drawingml/2006/spreadsheetDrawing" xmlns:dsp="http://schemas.microsoft.com/office/drawing/2008/diagram" xmlns:xvml="urn:schemas-microsoft-com:office:excel" xmlns:o="urn:schemas-microsoft-com:office:office" xmlns:v="urn:schemas-microsoft-com:vml" xmlns:w10="urn:schemas-microsoft-com:office:word" xmlns:pvml="urn:schemas-microsoft-com:office:powerpoint" xmlns:cppr="http://schemas.microsoft.com/office/2006/coverPageProps" xmlns:odx="http://opendope.org/xpaths" xmlns:odc="http://opendope.org/conditions" xmlns:odq="http://opendope.org/questions" xmlns:oda="http://opendope.org/answers" xmlns:odi="http://opendope.org/components" xmlns:odgm="http://opendope.org/SmartArt/DataHierarchy" xmlns:b="http://schemas.openxmlformats.org/officeDocument/2006/bibliography" xmlns:wps="http://schemas.microsoft.com/office/word/2010/wordprocessingShape" xmlns:w16se="http://schemas.microsoft.com/office/word/2015/wordml/symex" xmlns:w16cid="http://schemas.microsoft.com/office/word/2016/wordml/cid" xmlns:wetp="http://schemas.microsoft.com/office/webextensions/taskpanes/2010/11" xmlns:we="http://schemas.microsoft.com/office/webextensions/webextension/2010/11" xmlns:comp="http://schemas.openxmlformats.org/drawingml/2006/compatibility" xmlns:lc="http://schemas.openxmlformats.org/drawingml/2006/lockedCanvas">
             <c:ext xmlns:c16="http://schemas.microsoft.com/office/drawing/2014/chart" uri="{C3380CC4-5D6E-409C-BE32-E72D297353CC}">
               <c16:uniqueId val="{00000002-6147-E74A-AA7B-5531F0E4EE0C}"/>
             </c:ext>
@@ -1297,7 +1302,7 @@
     <c:plotVisOnly val="1"/>
     <c:dispBlanksAs val="gap"/>
     <c:showDLblsOverMax val="0"/>
-    <c:extLst xmlns:lc="http://schemas.openxmlformats.org/drawingml/2006/lockedCanvas" xmlns:comp="http://schemas.openxmlformats.org/drawingml/2006/compatibility" xmlns:we="http://schemas.microsoft.com/office/webextensions/webextension/2010/11" xmlns:wetp="http://schemas.microsoft.com/office/webextensions/taskpanes/2010/11" xmlns:w16cid="http://schemas.microsoft.com/office/word/2016/wordml/cid" xmlns:w16se="http://schemas.microsoft.com/office/word/2015/wordml/symex" xmlns:wps="http://schemas.microsoft.com/office/word/2010/wordprocessingShape" xmlns:b="http://schemas.openxmlformats.org/officeDocument/2006/bibliography" xmlns:odgm="http://opendope.org/SmartArt/DataHierarchy" xmlns:odi="http://opendope.org/components" xmlns:oda="http://opendope.org/answers" xmlns:odq="http://opendope.org/questions" xmlns:odc="http://opendope.org/conditions" xmlns:odx="http://opendope.org/xpaths" xmlns:cppr="http://schemas.microsoft.com/office/2006/coverPageProps" xmlns:pvml="urn:schemas-microsoft-com:office:powerpoint" xmlns:w10="urn:schemas-microsoft-com:office:word" xmlns:v="urn:schemas-microsoft-com:vml" xmlns:o="urn:schemas-microsoft-com:office:office" xmlns:xvml="urn:schemas-microsoft-com:office:excel" xmlns:dsp="http://schemas.microsoft.com/office/drawing/2008/diagram" xmlns:xdr="http://schemas.openxmlformats.org/drawingml/2006/spreadsheetDrawing" xmlns:pic="http://schemas.openxmlformats.org/drawingml/2006/picture" xmlns:dgm="http://schemas.openxmlformats.org/drawingml/2006/diagram" xmlns:c14="http://schemas.microsoft.com/office/drawing/2007/8/2/chart" xmlns:cdr="http://schemas.openxmlformats.org/drawingml/2006/chartDrawing" xmlns:wne="http://schemas.microsoft.com/office/word/2006/wordml" xmlns:sl="http://schemas.openxmlformats.org/schemaLibrary/2006/main" xmlns:mc="http://schemas.openxmlformats.org/markup-compatibility/2006" xmlns:wp14="http://schemas.microsoft.com/office/word/2010/wordprocessingDrawing" xmlns:wp="http://schemas.openxmlformats.org/drawingml/2006/wordprocessingDrawing" xmlns:m="http://schemas.openxmlformats.org/officeDocument/2006/math" xmlns:w14="http://schemas.microsoft.com/office/word/2010/wordml" xmlns:w15="http://schemas.microsoft.com/office/word/2012/wordml" xmlns:w="http://schemas.openxmlformats.org/wordprocessingml/2006/main">
+    <c:extLst xmlns:w="http://schemas.openxmlformats.org/wordprocessingml/2006/main" xmlns:w15="http://schemas.microsoft.com/office/word/2012/wordml" xmlns:w14="http://schemas.microsoft.com/office/word/2010/wordml" xmlns:m="http://schemas.openxmlformats.org/officeDocument/2006/math" xmlns:wp="http://schemas.openxmlformats.org/drawingml/2006/wordprocessingDrawing" xmlns:wp14="http://schemas.microsoft.com/office/word/2010/wordprocessingDrawing" xmlns:mc="http://schemas.openxmlformats.org/markup-compatibility/2006" xmlns:sl="http://schemas.openxmlformats.org/schemaLibrary/2006/main" xmlns:wne="http://schemas.microsoft.com/office/word/2006/wordml" xmlns:cdr="http://schemas.openxmlformats.org/drawingml/2006/chartDrawing" xmlns:c14="http://schemas.microsoft.com/office/drawing/2007/8/2/chart" xmlns:dgm="http://schemas.openxmlformats.org/drawingml/2006/diagram" xmlns:pic="http://schemas.openxmlformats.org/drawingml/2006/picture" xmlns:xdr="http://schemas.openxmlformats.org/drawingml/2006/spreadsheetDrawing" xmlns:dsp="http://schemas.microsoft.com/office/drawing/2008/diagram" xmlns:xvml="urn:schemas-microsoft-com:office:excel" xmlns:o="urn:schemas-microsoft-com:office:office" xmlns:v="urn:schemas-microsoft-com:vml" xmlns:w10="urn:schemas-microsoft-com:office:word" xmlns:pvml="urn:schemas-microsoft-com:office:powerpoint" xmlns:cppr="http://schemas.microsoft.com/office/2006/coverPageProps" xmlns:odx="http://opendope.org/xpaths" xmlns:odc="http://opendope.org/conditions" xmlns:odq="http://opendope.org/questions" xmlns:oda="http://opendope.org/answers" xmlns:odi="http://opendope.org/components" xmlns:odgm="http://opendope.org/SmartArt/DataHierarchy" xmlns:b="http://schemas.openxmlformats.org/officeDocument/2006/bibliography" xmlns:wps="http://schemas.microsoft.com/office/word/2010/wordprocessingShape" xmlns:w16se="http://schemas.microsoft.com/office/word/2015/wordml/symex" xmlns:w16cid="http://schemas.microsoft.com/office/word/2016/wordml/cid" xmlns:wetp="http://schemas.microsoft.com/office/webextensions/taskpanes/2010/11" xmlns:we="http://schemas.microsoft.com/office/webextensions/webextension/2010/11" xmlns:comp="http://schemas.openxmlformats.org/drawingml/2006/compatibility" xmlns:lc="http://schemas.openxmlformats.org/drawingml/2006/lockedCanvas">
       <c:ext xmlns:c16r3="http://schemas.microsoft.com/office/drawing/2017/03/chart" uri="{56B9EC1D-385E-4148-901F-78D8002777C0}">
         <c16r3:dataDisplayOptions16>
           <c16r3:dispNaAsBlank val="1"/>
@@ -1399,7 +1404,7 @@
                 </a:outerShdw>
               </a:effectLst>
             </c:spPr>
-            <c:extLst xmlns:w="http://schemas.openxmlformats.org/wordprocessingml/2006/main" xmlns:w15="http://schemas.microsoft.com/office/word/2012/wordml" xmlns:w14="http://schemas.microsoft.com/office/word/2010/wordml" xmlns:m="http://schemas.openxmlformats.org/officeDocument/2006/math" xmlns:wp="http://schemas.openxmlformats.org/drawingml/2006/wordprocessingDrawing" xmlns:wp14="http://schemas.microsoft.com/office/word/2010/wordprocessingDrawing" xmlns:mc="http://schemas.openxmlformats.org/markup-compatibility/2006" xmlns:sl="http://schemas.openxmlformats.org/schemaLibrary/2006/main" xmlns:wne="http://schemas.microsoft.com/office/word/2006/wordml" xmlns:cdr="http://schemas.openxmlformats.org/drawingml/2006/chartDrawing" xmlns:c14="http://schemas.microsoft.com/office/drawing/2007/8/2/chart" xmlns:dgm="http://schemas.openxmlformats.org/drawingml/2006/diagram" xmlns:pic="http://schemas.openxmlformats.org/drawingml/2006/picture" xmlns:xdr="http://schemas.openxmlformats.org/drawingml/2006/spreadsheetDrawing" xmlns:dsp="http://schemas.microsoft.com/office/drawing/2008/diagram" xmlns:xvml="urn:schemas-microsoft-com:office:excel" xmlns:o="urn:schemas-microsoft-com:office:office" xmlns:v="urn:schemas-microsoft-com:vml" xmlns:w10="urn:schemas-microsoft-com:office:word" xmlns:pvml="urn:schemas-microsoft-com:office:powerpoint" xmlns:cppr="http://schemas.microsoft.com/office/2006/coverPageProps" xmlns:odx="http://opendope.org/xpaths" xmlns:odc="http://opendope.org/conditions" xmlns:odq="http://opendope.org/questions" xmlns:oda="http://opendope.org/answers" xmlns:odi="http://opendope.org/components" xmlns:odgm="http://opendope.org/SmartArt/DataHierarchy" xmlns:b="http://schemas.openxmlformats.org/officeDocument/2006/bibliography" xmlns:wps="http://schemas.microsoft.com/office/word/2010/wordprocessingShape" xmlns:w16se="http://schemas.microsoft.com/office/word/2015/wordml/symex" xmlns:w16cid="http://schemas.microsoft.com/office/word/2016/wordml/cid" xmlns:wetp="http://schemas.microsoft.com/office/webextensions/taskpanes/2010/11" xmlns:we="http://schemas.microsoft.com/office/webextensions/webextension/2010/11" xmlns:comp="http://schemas.openxmlformats.org/drawingml/2006/compatibility" xmlns:lc="http://schemas.openxmlformats.org/drawingml/2006/lockedCanvas">
+            <c:extLst xmlns:lc="http://schemas.openxmlformats.org/drawingml/2006/lockedCanvas" xmlns:comp="http://schemas.openxmlformats.org/drawingml/2006/compatibility" xmlns:we="http://schemas.microsoft.com/office/webextensions/webextension/2010/11" xmlns:wetp="http://schemas.microsoft.com/office/webextensions/taskpanes/2010/11" xmlns:w16cid="http://schemas.microsoft.com/office/word/2016/wordml/cid" xmlns:w16se="http://schemas.microsoft.com/office/word/2015/wordml/symex" xmlns:wps="http://schemas.microsoft.com/office/word/2010/wordprocessingShape" xmlns:b="http://schemas.openxmlformats.org/officeDocument/2006/bibliography" xmlns:odgm="http://opendope.org/SmartArt/DataHierarchy" xmlns:odi="http://opendope.org/components" xmlns:oda="http://opendope.org/answers" xmlns:odq="http://opendope.org/questions" xmlns:odc="http://opendope.org/conditions" xmlns:odx="http://opendope.org/xpaths" xmlns:cppr="http://schemas.microsoft.com/office/2006/coverPageProps" xmlns:pvml="urn:schemas-microsoft-com:office:powerpoint" xmlns:w10="urn:schemas-microsoft-com:office:word" xmlns:v="urn:schemas-microsoft-com:vml" xmlns:o="urn:schemas-microsoft-com:office:office" xmlns:xvml="urn:schemas-microsoft-com:office:excel" xmlns:dsp="http://schemas.microsoft.com/office/drawing/2008/diagram" xmlns:xdr="http://schemas.openxmlformats.org/drawingml/2006/spreadsheetDrawing" xmlns:pic="http://schemas.openxmlformats.org/drawingml/2006/picture" xmlns:dgm="http://schemas.openxmlformats.org/drawingml/2006/diagram" xmlns:c14="http://schemas.microsoft.com/office/drawing/2007/8/2/chart" xmlns:cdr="http://schemas.openxmlformats.org/drawingml/2006/chartDrawing" xmlns:wne="http://schemas.microsoft.com/office/word/2006/wordml" xmlns:sl="http://schemas.openxmlformats.org/schemaLibrary/2006/main" xmlns:mc="http://schemas.openxmlformats.org/markup-compatibility/2006" xmlns:wp14="http://schemas.microsoft.com/office/word/2010/wordprocessingDrawing" xmlns:wp="http://schemas.openxmlformats.org/drawingml/2006/wordprocessingDrawing" xmlns:m="http://schemas.openxmlformats.org/officeDocument/2006/math" xmlns:w14="http://schemas.microsoft.com/office/word/2010/wordml" xmlns:w15="http://schemas.microsoft.com/office/word/2012/wordml" xmlns:w="http://schemas.openxmlformats.org/wordprocessingml/2006/main">
               <c:ext xmlns:c16="http://schemas.microsoft.com/office/drawing/2014/chart" uri="{C3380CC4-5D6E-409C-BE32-E72D297353CC}">
                 <c16:uniqueId val="{00000001-6147-E74A-AA7B-5531F0E4EE0C}"/>
               </c:ext>
@@ -1482,7 +1487,7 @@
               </c:numCache>
             </c:numRef>
           </c:val>
-          <c:extLst xmlns:w="http://schemas.openxmlformats.org/wordprocessingml/2006/main" xmlns:w15="http://schemas.microsoft.com/office/word/2012/wordml" xmlns:w14="http://schemas.microsoft.com/office/word/2010/wordml" xmlns:m="http://schemas.openxmlformats.org/officeDocument/2006/math" xmlns:wp="http://schemas.openxmlformats.org/drawingml/2006/wordprocessingDrawing" xmlns:wp14="http://schemas.microsoft.com/office/word/2010/wordprocessingDrawing" xmlns:mc="http://schemas.openxmlformats.org/markup-compatibility/2006" xmlns:sl="http://schemas.openxmlformats.org/schemaLibrary/2006/main" xmlns:wne="http://schemas.microsoft.com/office/word/2006/wordml" xmlns:cdr="http://schemas.openxmlformats.org/drawingml/2006/chartDrawing" xmlns:c14="http://schemas.microsoft.com/office/drawing/2007/8/2/chart" xmlns:dgm="http://schemas.openxmlformats.org/drawingml/2006/diagram" xmlns:pic="http://schemas.openxmlformats.org/drawingml/2006/picture" xmlns:xdr="http://schemas.openxmlformats.org/drawingml/2006/spreadsheetDrawing" xmlns:dsp="http://schemas.microsoft.com/office/drawing/2008/diagram" xmlns:xvml="urn:schemas-microsoft-com:office:excel" xmlns:o="urn:schemas-microsoft-com:office:office" xmlns:v="urn:schemas-microsoft-com:vml" xmlns:w10="urn:schemas-microsoft-com:office:word" xmlns:pvml="urn:schemas-microsoft-com:office:powerpoint" xmlns:cppr="http://schemas.microsoft.com/office/2006/coverPageProps" xmlns:odx="http://opendope.org/xpaths" xmlns:odc="http://opendope.org/conditions" xmlns:odq="http://opendope.org/questions" xmlns:oda="http://opendope.org/answers" xmlns:odi="http://opendope.org/components" xmlns:odgm="http://opendope.org/SmartArt/DataHierarchy" xmlns:b="http://schemas.openxmlformats.org/officeDocument/2006/bibliography" xmlns:wps="http://schemas.microsoft.com/office/word/2010/wordprocessingShape" xmlns:w16se="http://schemas.microsoft.com/office/word/2015/wordml/symex" xmlns:w16cid="http://schemas.microsoft.com/office/word/2016/wordml/cid" xmlns:wetp="http://schemas.microsoft.com/office/webextensions/taskpanes/2010/11" xmlns:we="http://schemas.microsoft.com/office/webextensions/webextension/2010/11" xmlns:comp="http://schemas.openxmlformats.org/drawingml/2006/compatibility" xmlns:lc="http://schemas.openxmlformats.org/drawingml/2006/lockedCanvas">
+          <c:extLst xmlns:lc="http://schemas.openxmlformats.org/drawingml/2006/lockedCanvas" xmlns:comp="http://schemas.openxmlformats.org/drawingml/2006/compatibility" xmlns:we="http://schemas.microsoft.com/office/webextensions/webextension/2010/11" xmlns:wetp="http://schemas.microsoft.com/office/webextensions/taskpanes/2010/11" xmlns:w16cid="http://schemas.microsoft.com/office/word/2016/wordml/cid" xmlns:w16se="http://schemas.microsoft.com/office/word/2015/wordml/symex" xmlns:wps="http://schemas.microsoft.com/office/word/2010/wordprocessingShape" xmlns:b="http://schemas.openxmlformats.org/officeDocument/2006/bibliography" xmlns:odgm="http://opendope.org/SmartArt/DataHierarchy" xmlns:odi="http://opendope.org/components" xmlns:oda="http://opendope.org/answers" xmlns:odq="http://opendope.org/questions" xmlns:odc="http://opendope.org/conditions" xmlns:odx="http://opendope.org/xpaths" xmlns:cppr="http://schemas.microsoft.com/office/2006/coverPageProps" xmlns:pvml="urn:schemas-microsoft-com:office:powerpoint" xmlns:w10="urn:schemas-microsoft-com:office:word" xmlns:v="urn:schemas-microsoft-com:vml" xmlns:o="urn:schemas-microsoft-com:office:office" xmlns:xvml="urn:schemas-microsoft-com:office:excel" xmlns:dsp="http://schemas.microsoft.com/office/drawing/2008/diagram" xmlns:xdr="http://schemas.openxmlformats.org/drawingml/2006/spreadsheetDrawing" xmlns:pic="http://schemas.openxmlformats.org/drawingml/2006/picture" xmlns:dgm="http://schemas.openxmlformats.org/drawingml/2006/diagram" xmlns:c14="http://schemas.microsoft.com/office/drawing/2007/8/2/chart" xmlns:cdr="http://schemas.openxmlformats.org/drawingml/2006/chartDrawing" xmlns:wne="http://schemas.microsoft.com/office/word/2006/wordml" xmlns:sl="http://schemas.openxmlformats.org/schemaLibrary/2006/main" xmlns:mc="http://schemas.openxmlformats.org/markup-compatibility/2006" xmlns:wp14="http://schemas.microsoft.com/office/word/2010/wordprocessingDrawing" xmlns:wp="http://schemas.openxmlformats.org/drawingml/2006/wordprocessingDrawing" xmlns:m="http://schemas.openxmlformats.org/officeDocument/2006/math" xmlns:w14="http://schemas.microsoft.com/office/word/2010/wordml" xmlns:w15="http://schemas.microsoft.com/office/word/2012/wordml" xmlns:w="http://schemas.openxmlformats.org/wordprocessingml/2006/main">
             <c:ext xmlns:c16="http://schemas.microsoft.com/office/drawing/2014/chart" uri="{C3380CC4-5D6E-409C-BE32-E72D297353CC}">
               <c16:uniqueId val="{00000002-6147-E74A-AA7B-5531F0E4EE0C}"/>
             </c:ext>
@@ -2045,7 +2050,7 @@
     <c:plotVisOnly val="1"/>
     <c:dispBlanksAs val="gap"/>
     <c:showDLblsOverMax val="0"/>
-    <c:extLst xmlns:w="http://schemas.openxmlformats.org/wordprocessingml/2006/main" xmlns:w15="http://schemas.microsoft.com/office/word/2012/wordml" xmlns:w14="http://schemas.microsoft.com/office/word/2010/wordml" xmlns:m="http://schemas.openxmlformats.org/officeDocument/2006/math" xmlns:wp="http://schemas.openxmlformats.org/drawingml/2006/wordprocessingDrawing" xmlns:wp14="http://schemas.microsoft.com/office/word/2010/wordprocessingDrawing" xmlns:mc="http://schemas.openxmlformats.org/markup-compatibility/2006" xmlns:sl="http://schemas.openxmlformats.org/schemaLibrary/2006/main" xmlns:wne="http://schemas.microsoft.com/office/word/2006/wordml" xmlns:cdr="http://schemas.openxmlformats.org/drawingml/2006/chartDrawing" xmlns:c14="http://schemas.microsoft.com/office/drawing/2007/8/2/chart" xmlns:dgm="http://schemas.openxmlformats.org/drawingml/2006/diagram" xmlns:pic="http://schemas.openxmlformats.org/drawingml/2006/picture" xmlns:xdr="http://schemas.openxmlformats.org/drawingml/2006/spreadsheetDrawing" xmlns:dsp="http://schemas.microsoft.com/office/drawing/2008/diagram" xmlns:xvml="urn:schemas-microsoft-com:office:excel" xmlns:o="urn:schemas-microsoft-com:office:office" xmlns:v="urn:schemas-microsoft-com:vml" xmlns:w10="urn:schemas-microsoft-com:office:word" xmlns:pvml="urn:schemas-microsoft-com:office:powerpoint" xmlns:cppr="http://schemas.microsoft.com/office/2006/coverPageProps" xmlns:odx="http://opendope.org/xpaths" xmlns:odc="http://opendope.org/conditions" xmlns:odq="http://opendope.org/questions" xmlns:oda="http://opendope.org/answers" xmlns:odi="http://opendope.org/components" xmlns:odgm="http://opendope.org/SmartArt/DataHierarchy" xmlns:b="http://schemas.openxmlformats.org/officeDocument/2006/bibliography" xmlns:wps="http://schemas.microsoft.com/office/word/2010/wordprocessingShape" xmlns:w16se="http://schemas.microsoft.com/office/word/2015/wordml/symex" xmlns:w16cid="http://schemas.microsoft.com/office/word/2016/wordml/cid" xmlns:wetp="http://schemas.microsoft.com/office/webextensions/taskpanes/2010/11" xmlns:we="http://schemas.microsoft.com/office/webextensions/webextension/2010/11" xmlns:comp="http://schemas.openxmlformats.org/drawingml/2006/compatibility" xmlns:lc="http://schemas.openxmlformats.org/drawingml/2006/lockedCanvas">
+    <c:extLst xmlns:lc="http://schemas.openxmlformats.org/drawingml/2006/lockedCanvas" xmlns:comp="http://schemas.openxmlformats.org/drawingml/2006/compatibility" xmlns:we="http://schemas.microsoft.com/office/webextensions/webextension/2010/11" xmlns:wetp="http://schemas.microsoft.com/office/webextensions/taskpanes/2010/11" xmlns:w16cid="http://schemas.microsoft.com/office/word/2016/wordml/cid" xmlns:w16se="http://schemas.microsoft.com/office/word/2015/wordml/symex" xmlns:wps="http://schemas.microsoft.com/office/word/2010/wordprocessingShape" xmlns:b="http://schemas.openxmlformats.org/officeDocument/2006/bibliography" xmlns:odgm="http://opendope.org/SmartArt/DataHierarchy" xmlns:odi="http://opendope.org/components" xmlns:oda="http://opendope.org/answers" xmlns:odq="http://opendope.org/questions" xmlns:odc="http://opendope.org/conditions" xmlns:odx="http://opendope.org/xpaths" xmlns:cppr="http://schemas.microsoft.com/office/2006/coverPageProps" xmlns:pvml="urn:schemas-microsoft-com:office:powerpoint" xmlns:w10="urn:schemas-microsoft-com:office:word" xmlns:v="urn:schemas-microsoft-com:vml" xmlns:o="urn:schemas-microsoft-com:office:office" xmlns:xvml="urn:schemas-microsoft-com:office:excel" xmlns:dsp="http://schemas.microsoft.com/office/drawing/2008/diagram" xmlns:xdr="http://schemas.openxmlformats.org/drawingml/2006/spreadsheetDrawing" xmlns:pic="http://schemas.openxmlformats.org/drawingml/2006/picture" xmlns:dgm="http://schemas.openxmlformats.org/drawingml/2006/diagram" xmlns:c14="http://schemas.microsoft.com/office/drawing/2007/8/2/chart" xmlns:cdr="http://schemas.openxmlformats.org/drawingml/2006/chartDrawing" xmlns:wne="http://schemas.microsoft.com/office/word/2006/wordml" xmlns:sl="http://schemas.openxmlformats.org/schemaLibrary/2006/main" xmlns:mc="http://schemas.openxmlformats.org/markup-compatibility/2006" xmlns:wp14="http://schemas.microsoft.com/office/word/2010/wordprocessingDrawing" xmlns:wp="http://schemas.openxmlformats.org/drawingml/2006/wordprocessingDrawing" xmlns:m="http://schemas.openxmlformats.org/officeDocument/2006/math" xmlns:w14="http://schemas.microsoft.com/office/word/2010/wordml" xmlns:w15="http://schemas.microsoft.com/office/word/2012/wordml" xmlns:w="http://schemas.openxmlformats.org/wordprocessingml/2006/main">
       <c:ext xmlns:c16r3="http://schemas.microsoft.com/office/drawing/2017/03/chart" uri="{56B9EC1D-385E-4148-901F-78D8002777C0}">
         <c16r3:dataDisplayOptions16>
           <c16r3:dispNaAsBlank val="1"/>
@@ -2147,7 +2152,7 @@
                 </a:outerShdw>
               </a:effectLst>
             </c:spPr>
-            <c:extLst xmlns:lc="http://schemas.openxmlformats.org/drawingml/2006/lockedCanvas" xmlns:comp="http://schemas.openxmlformats.org/drawingml/2006/compatibility" xmlns:we="http://schemas.microsoft.com/office/webextensions/webextension/2010/11" xmlns:wetp="http://schemas.microsoft.com/office/webextensions/taskpanes/2010/11" xmlns:w16cid="http://schemas.microsoft.com/office/word/2016/wordml/cid" xmlns:w16se="http://schemas.microsoft.com/office/word/2015/wordml/symex" xmlns:wps="http://schemas.microsoft.com/office/word/2010/wordprocessingShape" xmlns:b="http://schemas.openxmlformats.org/officeDocument/2006/bibliography" xmlns:odgm="http://opendope.org/SmartArt/DataHierarchy" xmlns:odi="http://opendope.org/components" xmlns:oda="http://opendope.org/answers" xmlns:odq="http://opendope.org/questions" xmlns:odc="http://opendope.org/conditions" xmlns:odx="http://opendope.org/xpaths" xmlns:cppr="http://schemas.microsoft.com/office/2006/coverPageProps" xmlns:pvml="urn:schemas-microsoft-com:office:powerpoint" xmlns:w10="urn:schemas-microsoft-com:office:word" xmlns:v="urn:schemas-microsoft-com:vml" xmlns:o="urn:schemas-microsoft-com:office:office" xmlns:xvml="urn:schemas-microsoft-com:office:excel" xmlns:dsp="http://schemas.microsoft.com/office/drawing/2008/diagram" xmlns:xdr="http://schemas.openxmlformats.org/drawingml/2006/spreadsheetDrawing" xmlns:pic="http://schemas.openxmlformats.org/drawingml/2006/picture" xmlns:dgm="http://schemas.openxmlformats.org/drawingml/2006/diagram" xmlns:c14="http://schemas.microsoft.com/office/drawing/2007/8/2/chart" xmlns:cdr="http://schemas.openxmlformats.org/drawingml/2006/chartDrawing" xmlns:wne="http://schemas.microsoft.com/office/word/2006/wordml" xmlns:sl="http://schemas.openxmlformats.org/schemaLibrary/2006/main" xmlns:mc="http://schemas.openxmlformats.org/markup-compatibility/2006" xmlns:wp14="http://schemas.microsoft.com/office/word/2010/wordprocessingDrawing" xmlns:wp="http://schemas.openxmlformats.org/drawingml/2006/wordprocessingDrawing" xmlns:m="http://schemas.openxmlformats.org/officeDocument/2006/math" xmlns:w14="http://schemas.microsoft.com/office/word/2010/wordml" xmlns:w15="http://schemas.microsoft.com/office/word/2012/wordml" xmlns:w="http://schemas.openxmlformats.org/wordprocessingml/2006/main">
+            <c:extLst xmlns:w="http://schemas.openxmlformats.org/wordprocessingml/2006/main" xmlns:w15="http://schemas.microsoft.com/office/word/2012/wordml" xmlns:w14="http://schemas.microsoft.com/office/word/2010/wordml" xmlns:m="http://schemas.openxmlformats.org/officeDocument/2006/math" xmlns:wp="http://schemas.openxmlformats.org/drawingml/2006/wordprocessingDrawing" xmlns:wp14="http://schemas.microsoft.com/office/word/2010/wordprocessingDrawing" xmlns:mc="http://schemas.openxmlformats.org/markup-compatibility/2006" xmlns:sl="http://schemas.openxmlformats.org/schemaLibrary/2006/main" xmlns:wne="http://schemas.microsoft.com/office/word/2006/wordml" xmlns:cdr="http://schemas.openxmlformats.org/drawingml/2006/chartDrawing" xmlns:c14="http://schemas.microsoft.com/office/drawing/2007/8/2/chart" xmlns:dgm="http://schemas.openxmlformats.org/drawingml/2006/diagram" xmlns:pic="http://schemas.openxmlformats.org/drawingml/2006/picture" xmlns:xdr="http://schemas.openxmlformats.org/drawingml/2006/spreadsheetDrawing" xmlns:dsp="http://schemas.microsoft.com/office/drawing/2008/diagram" xmlns:xvml="urn:schemas-microsoft-com:office:excel" xmlns:o="urn:schemas-microsoft-com:office:office" xmlns:v="urn:schemas-microsoft-com:vml" xmlns:w10="urn:schemas-microsoft-com:office:word" xmlns:pvml="urn:schemas-microsoft-com:office:powerpoint" xmlns:cppr="http://schemas.microsoft.com/office/2006/coverPageProps" xmlns:odx="http://opendope.org/xpaths" xmlns:odc="http://opendope.org/conditions" xmlns:odq="http://opendope.org/questions" xmlns:oda="http://opendope.org/answers" xmlns:odi="http://opendope.org/components" xmlns:odgm="http://opendope.org/SmartArt/DataHierarchy" xmlns:b="http://schemas.openxmlformats.org/officeDocument/2006/bibliography" xmlns:wps="http://schemas.microsoft.com/office/word/2010/wordprocessingShape" xmlns:w16se="http://schemas.microsoft.com/office/word/2015/wordml/symex" xmlns:w16cid="http://schemas.microsoft.com/office/word/2016/wordml/cid" xmlns:wetp="http://schemas.microsoft.com/office/webextensions/taskpanes/2010/11" xmlns:we="http://schemas.microsoft.com/office/webextensions/webextension/2010/11" xmlns:comp="http://schemas.openxmlformats.org/drawingml/2006/compatibility" xmlns:lc="http://schemas.openxmlformats.org/drawingml/2006/lockedCanvas">
               <c:ext xmlns:c16="http://schemas.microsoft.com/office/drawing/2014/chart" uri="{C3380CC4-5D6E-409C-BE32-E72D297353CC}">
                 <c16:uniqueId val="{00000001-6147-E74A-AA7B-5531F0E4EE0C}"/>
               </c:ext>
@@ -2242,7 +2247,7 @@
               </c:numCache>
             </c:numRef>
           </c:val>
-          <c:extLst xmlns:lc="http://schemas.openxmlformats.org/drawingml/2006/lockedCanvas" xmlns:comp="http://schemas.openxmlformats.org/drawingml/2006/compatibility" xmlns:we="http://schemas.microsoft.com/office/webextensions/webextension/2010/11" xmlns:wetp="http://schemas.microsoft.com/office/webextensions/taskpanes/2010/11" xmlns:w16cid="http://schemas.microsoft.com/office/word/2016/wordml/cid" xmlns:w16se="http://schemas.microsoft.com/office/word/2015/wordml/symex" xmlns:wps="http://schemas.microsoft.com/office/word/2010/wordprocessingShape" xmlns:b="http://schemas.openxmlformats.org/officeDocument/2006/bibliography" xmlns:odgm="http://opendope.org/SmartArt/DataHierarchy" xmlns:odi="http://opendope.org/components" xmlns:oda="http://opendope.org/answers" xmlns:odq="http://opendope.org/questions" xmlns:odc="http://opendope.org/conditions" xmlns:odx="http://opendope.org/xpaths" xmlns:cppr="http://schemas.microsoft.com/office/2006/coverPageProps" xmlns:pvml="urn:schemas-microsoft-com:office:powerpoint" xmlns:w10="urn:schemas-microsoft-com:office:word" xmlns:v="urn:schemas-microsoft-com:vml" xmlns:o="urn:schemas-microsoft-com:office:office" xmlns:xvml="urn:schemas-microsoft-com:office:excel" xmlns:dsp="http://schemas.microsoft.com/office/drawing/2008/diagram" xmlns:xdr="http://schemas.openxmlformats.org/drawingml/2006/spreadsheetDrawing" xmlns:pic="http://schemas.openxmlformats.org/drawingml/2006/picture" xmlns:dgm="http://schemas.openxmlformats.org/drawingml/2006/diagram" xmlns:c14="http://schemas.microsoft.com/office/drawing/2007/8/2/chart" xmlns:cdr="http://schemas.openxmlformats.org/drawingml/2006/chartDrawing" xmlns:wne="http://schemas.microsoft.com/office/word/2006/wordml" xmlns:sl="http://schemas.openxmlformats.org/schemaLibrary/2006/main" xmlns:mc="http://schemas.openxmlformats.org/markup-compatibility/2006" xmlns:wp14="http://schemas.microsoft.com/office/word/2010/wordprocessingDrawing" xmlns:wp="http://schemas.openxmlformats.org/drawingml/2006/wordprocessingDrawing" xmlns:m="http://schemas.openxmlformats.org/officeDocument/2006/math" xmlns:w14="http://schemas.microsoft.com/office/word/2010/wordml" xmlns:w15="http://schemas.microsoft.com/office/word/2012/wordml" xmlns:w="http://schemas.openxmlformats.org/wordprocessingml/2006/main">
+          <c:extLst xmlns:w="http://schemas.openxmlformats.org/wordprocessingml/2006/main" xmlns:w15="http://schemas.microsoft.com/office/word/2012/wordml" xmlns:w14="http://schemas.microsoft.com/office/word/2010/wordml" xmlns:m="http://schemas.openxmlformats.org/officeDocument/2006/math" xmlns:wp="http://schemas.openxmlformats.org/drawingml/2006/wordprocessingDrawing" xmlns:wp14="http://schemas.microsoft.com/office/word/2010/wordprocessingDrawing" xmlns:mc="http://schemas.openxmlformats.org/markup-compatibility/2006" xmlns:sl="http://schemas.openxmlformats.org/schemaLibrary/2006/main" xmlns:wne="http://schemas.microsoft.com/office/word/2006/wordml" xmlns:cdr="http://schemas.openxmlformats.org/drawingml/2006/chartDrawing" xmlns:c14="http://schemas.microsoft.com/office/drawing/2007/8/2/chart" xmlns:dgm="http://schemas.openxmlformats.org/drawingml/2006/diagram" xmlns:pic="http://schemas.openxmlformats.org/drawingml/2006/picture" xmlns:xdr="http://schemas.openxmlformats.org/drawingml/2006/spreadsheetDrawing" xmlns:dsp="http://schemas.microsoft.com/office/drawing/2008/diagram" xmlns:xvml="urn:schemas-microsoft-com:office:excel" xmlns:o="urn:schemas-microsoft-com:office:office" xmlns:v="urn:schemas-microsoft-com:vml" xmlns:w10="urn:schemas-microsoft-com:office:word" xmlns:pvml="urn:schemas-microsoft-com:office:powerpoint" xmlns:cppr="http://schemas.microsoft.com/office/2006/coverPageProps" xmlns:odx="http://opendope.org/xpaths" xmlns:odc="http://opendope.org/conditions" xmlns:odq="http://opendope.org/questions" xmlns:oda="http://opendope.org/answers" xmlns:odi="http://opendope.org/components" xmlns:odgm="http://opendope.org/SmartArt/DataHierarchy" xmlns:b="http://schemas.openxmlformats.org/officeDocument/2006/bibliography" xmlns:wps="http://schemas.microsoft.com/office/word/2010/wordprocessingShape" xmlns:w16se="http://schemas.microsoft.com/office/word/2015/wordml/symex" xmlns:w16cid="http://schemas.microsoft.com/office/word/2016/wordml/cid" xmlns:wetp="http://schemas.microsoft.com/office/webextensions/taskpanes/2010/11" xmlns:we="http://schemas.microsoft.com/office/webextensions/webextension/2010/11" xmlns:comp="http://schemas.openxmlformats.org/drawingml/2006/compatibility" xmlns:lc="http://schemas.openxmlformats.org/drawingml/2006/lockedCanvas">
             <c:ext xmlns:c16="http://schemas.microsoft.com/office/drawing/2014/chart" uri="{C3380CC4-5D6E-409C-BE32-E72D297353CC}">
               <c16:uniqueId val="{00000002-6147-E74A-AA7B-5531F0E4EE0C}"/>
             </c:ext>
@@ -2853,7 +2858,7 @@
     <c:plotVisOnly val="1"/>
     <c:dispBlanksAs val="gap"/>
     <c:showDLblsOverMax val="0"/>
-    <c:extLst xmlns:lc="http://schemas.openxmlformats.org/drawingml/2006/lockedCanvas" xmlns:comp="http://schemas.openxmlformats.org/drawingml/2006/compatibility" xmlns:we="http://schemas.microsoft.com/office/webextensions/webextension/2010/11" xmlns:wetp="http://schemas.microsoft.com/office/webextensions/taskpanes/2010/11" xmlns:w16cid="http://schemas.microsoft.com/office/word/2016/wordml/cid" xmlns:w16se="http://schemas.microsoft.com/office/word/2015/wordml/symex" xmlns:wps="http://schemas.microsoft.com/office/word/2010/wordprocessingShape" xmlns:b="http://schemas.openxmlformats.org/officeDocument/2006/bibliography" xmlns:odgm="http://opendope.org/SmartArt/DataHierarchy" xmlns:odi="http://opendope.org/components" xmlns:oda="http://opendope.org/answers" xmlns:odq="http://opendope.org/questions" xmlns:odc="http://opendope.org/conditions" xmlns:odx="http://opendope.org/xpaths" xmlns:cppr="http://schemas.microsoft.com/office/2006/coverPageProps" xmlns:pvml="urn:schemas-microsoft-com:office:powerpoint" xmlns:w10="urn:schemas-microsoft-com:office:word" xmlns:v="urn:schemas-microsoft-com:vml" xmlns:o="urn:schemas-microsoft-com:office:office" xmlns:xvml="urn:schemas-microsoft-com:office:excel" xmlns:dsp="http://schemas.microsoft.com/office/drawing/2008/diagram" xmlns:xdr="http://schemas.openxmlformats.org/drawingml/2006/spreadsheetDrawing" xmlns:pic="http://schemas.openxmlformats.org/drawingml/2006/picture" xmlns:dgm="http://schemas.openxmlformats.org/drawingml/2006/diagram" xmlns:c14="http://schemas.microsoft.com/office/drawing/2007/8/2/chart" xmlns:cdr="http://schemas.openxmlformats.org/drawingml/2006/chartDrawing" xmlns:wne="http://schemas.microsoft.com/office/word/2006/wordml" xmlns:sl="http://schemas.openxmlformats.org/schemaLibrary/2006/main" xmlns:mc="http://schemas.openxmlformats.org/markup-compatibility/2006" xmlns:wp14="http://schemas.microsoft.com/office/word/2010/wordprocessingDrawing" xmlns:wp="http://schemas.openxmlformats.org/drawingml/2006/wordprocessingDrawing" xmlns:m="http://schemas.openxmlformats.org/officeDocument/2006/math" xmlns:w14="http://schemas.microsoft.com/office/word/2010/wordml" xmlns:w15="http://schemas.microsoft.com/office/word/2012/wordml" xmlns:w="http://schemas.openxmlformats.org/wordprocessingml/2006/main">
+    <c:extLst xmlns:w="http://schemas.openxmlformats.org/wordprocessingml/2006/main" xmlns:w15="http://schemas.microsoft.com/office/word/2012/wordml" xmlns:w14="http://schemas.microsoft.com/office/word/2010/wordml" xmlns:m="http://schemas.openxmlformats.org/officeDocument/2006/math" xmlns:wp="http://schemas.openxmlformats.org/drawingml/2006/wordprocessingDrawing" xmlns:wp14="http://schemas.microsoft.com/office/word/2010/wordprocessingDrawing" xmlns:mc="http://schemas.openxmlformats.org/markup-compatibility/2006" xmlns:sl="http://schemas.openxmlformats.org/schemaLibrary/2006/main" xmlns:wne="http://schemas.microsoft.com/office/word/2006/wordml" xmlns:cdr="http://schemas.openxmlformats.org/drawingml/2006/chartDrawing" xmlns:c14="http://schemas.microsoft.com/office/drawing/2007/8/2/chart" xmlns:dgm="http://schemas.openxmlformats.org/drawingml/2006/diagram" xmlns:pic="http://schemas.openxmlformats.org/drawingml/2006/picture" xmlns:xdr="http://schemas.openxmlformats.org/drawingml/2006/spreadsheetDrawing" xmlns:dsp="http://schemas.microsoft.com/office/drawing/2008/diagram" xmlns:xvml="urn:schemas-microsoft-com:office:excel" xmlns:o="urn:schemas-microsoft-com:office:office" xmlns:v="urn:schemas-microsoft-com:vml" xmlns:w10="urn:schemas-microsoft-com:office:word" xmlns:pvml="urn:schemas-microsoft-com:office:powerpoint" xmlns:cppr="http://schemas.microsoft.com/office/2006/coverPageProps" xmlns:odx="http://opendope.org/xpaths" xmlns:odc="http://opendope.org/conditions" xmlns:odq="http://opendope.org/questions" xmlns:oda="http://opendope.org/answers" xmlns:odi="http://opendope.org/components" xmlns:odgm="http://opendope.org/SmartArt/DataHierarchy" xmlns:b="http://schemas.openxmlformats.org/officeDocument/2006/bibliography" xmlns:wps="http://schemas.microsoft.com/office/word/2010/wordprocessingShape" xmlns:w16se="http://schemas.microsoft.com/office/word/2015/wordml/symex" xmlns:w16cid="http://schemas.microsoft.com/office/word/2016/wordml/cid" xmlns:wetp="http://schemas.microsoft.com/office/webextensions/taskpanes/2010/11" xmlns:we="http://schemas.microsoft.com/office/webextensions/webextension/2010/11" xmlns:comp="http://schemas.openxmlformats.org/drawingml/2006/compatibility" xmlns:lc="http://schemas.openxmlformats.org/drawingml/2006/lockedCanvas">
       <c:ext xmlns:c16r3="http://schemas.microsoft.com/office/drawing/2017/03/chart" uri="{56B9EC1D-385E-4148-901F-78D8002777C0}">
         <c16r3:dataDisplayOptions16>
           <c16r3:dispNaAsBlank val="1"/>
@@ -2955,7 +2960,7 @@
                 </a:outerShdw>
               </a:effectLst>
             </c:spPr>
-            <c:extLst xmlns:lc="http://schemas.openxmlformats.org/drawingml/2006/lockedCanvas" xmlns:comp="http://schemas.openxmlformats.org/drawingml/2006/compatibility" xmlns:we="http://schemas.microsoft.com/office/webextensions/webextension/2010/11" xmlns:wetp="http://schemas.microsoft.com/office/webextensions/taskpanes/2010/11" xmlns:w16cid="http://schemas.microsoft.com/office/word/2016/wordml/cid" xmlns:w16se="http://schemas.microsoft.com/office/word/2015/wordml/symex" xmlns:wps="http://schemas.microsoft.com/office/word/2010/wordprocessingShape" xmlns:b="http://schemas.openxmlformats.org/officeDocument/2006/bibliography" xmlns:odgm="http://opendope.org/SmartArt/DataHierarchy" xmlns:odi="http://opendope.org/components" xmlns:oda="http://opendope.org/answers" xmlns:odq="http://opendope.org/questions" xmlns:odc="http://opendope.org/conditions" xmlns:odx="http://opendope.org/xpaths" xmlns:cppr="http://schemas.microsoft.com/office/2006/coverPageProps" xmlns:pvml="urn:schemas-microsoft-com:office:powerpoint" xmlns:w10="urn:schemas-microsoft-com:office:word" xmlns:v="urn:schemas-microsoft-com:vml" xmlns:o="urn:schemas-microsoft-com:office:office" xmlns:xvml="urn:schemas-microsoft-com:office:excel" xmlns:dsp="http://schemas.microsoft.com/office/drawing/2008/diagram" xmlns:xdr="http://schemas.openxmlformats.org/drawingml/2006/spreadsheetDrawing" xmlns:pic="http://schemas.openxmlformats.org/drawingml/2006/picture" xmlns:dgm="http://schemas.openxmlformats.org/drawingml/2006/diagram" xmlns:c14="http://schemas.microsoft.com/office/drawing/2007/8/2/chart" xmlns:cdr="http://schemas.openxmlformats.org/drawingml/2006/chartDrawing" xmlns:wne="http://schemas.microsoft.com/office/word/2006/wordml" xmlns:sl="http://schemas.openxmlformats.org/schemaLibrary/2006/main" xmlns:mc="http://schemas.openxmlformats.org/markup-compatibility/2006" xmlns:wp14="http://schemas.microsoft.com/office/word/2010/wordprocessingDrawing" xmlns:wp="http://schemas.openxmlformats.org/drawingml/2006/wordprocessingDrawing" xmlns:m="http://schemas.openxmlformats.org/officeDocument/2006/math" xmlns:w14="http://schemas.microsoft.com/office/word/2010/wordml" xmlns:w15="http://schemas.microsoft.com/office/word/2012/wordml" xmlns:w="http://schemas.openxmlformats.org/wordprocessingml/2006/main">
+            <c:extLst xmlns:w="http://schemas.openxmlformats.org/wordprocessingml/2006/main" xmlns:w15="http://schemas.microsoft.com/office/word/2012/wordml" xmlns:w14="http://schemas.microsoft.com/office/word/2010/wordml" xmlns:m="http://schemas.openxmlformats.org/officeDocument/2006/math" xmlns:wp="http://schemas.openxmlformats.org/drawingml/2006/wordprocessingDrawing" xmlns:wp14="http://schemas.microsoft.com/office/word/2010/wordprocessingDrawing" xmlns:mc="http://schemas.openxmlformats.org/markup-compatibility/2006" xmlns:sl="http://schemas.openxmlformats.org/schemaLibrary/2006/main" xmlns:wne="http://schemas.microsoft.com/office/word/2006/wordml" xmlns:cdr="http://schemas.openxmlformats.org/drawingml/2006/chartDrawing" xmlns:c14="http://schemas.microsoft.com/office/drawing/2007/8/2/chart" xmlns:dgm="http://schemas.openxmlformats.org/drawingml/2006/diagram" xmlns:pic="http://schemas.openxmlformats.org/drawingml/2006/picture" xmlns:xdr="http://schemas.openxmlformats.org/drawingml/2006/spreadsheetDrawing" xmlns:dsp="http://schemas.microsoft.com/office/drawing/2008/diagram" xmlns:xvml="urn:schemas-microsoft-com:office:excel" xmlns:o="urn:schemas-microsoft-com:office:office" xmlns:v="urn:schemas-microsoft-com:vml" xmlns:w10="urn:schemas-microsoft-com:office:word" xmlns:pvml="urn:schemas-microsoft-com:office:powerpoint" xmlns:cppr="http://schemas.microsoft.com/office/2006/coverPageProps" xmlns:odx="http://opendope.org/xpaths" xmlns:odc="http://opendope.org/conditions" xmlns:odq="http://opendope.org/questions" xmlns:oda="http://opendope.org/answers" xmlns:odi="http://opendope.org/components" xmlns:odgm="http://opendope.org/SmartArt/DataHierarchy" xmlns:b="http://schemas.openxmlformats.org/officeDocument/2006/bibliography" xmlns:wps="http://schemas.microsoft.com/office/word/2010/wordprocessingShape" xmlns:w16se="http://schemas.microsoft.com/office/word/2015/wordml/symex" xmlns:w16cid="http://schemas.microsoft.com/office/word/2016/wordml/cid" xmlns:wetp="http://schemas.microsoft.com/office/webextensions/taskpanes/2010/11" xmlns:we="http://schemas.microsoft.com/office/webextensions/webextension/2010/11" xmlns:comp="http://schemas.openxmlformats.org/drawingml/2006/compatibility" xmlns:lc="http://schemas.openxmlformats.org/drawingml/2006/lockedCanvas">
               <c:ext xmlns:c16="http://schemas.microsoft.com/office/drawing/2014/chart" uri="{C3380CC4-5D6E-409C-BE32-E72D297353CC}">
                 <c16:uniqueId val="{00000001-6147-E74A-AA7B-5531F0E4EE0C}"/>
               </c:ext>
@@ -3050,7 +3055,7 @@
               </c:numCache>
             </c:numRef>
           </c:val>
-          <c:extLst xmlns:lc="http://schemas.openxmlformats.org/drawingml/2006/lockedCanvas" xmlns:comp="http://schemas.openxmlformats.org/drawingml/2006/compatibility" xmlns:we="http://schemas.microsoft.com/office/webextensions/webextension/2010/11" xmlns:wetp="http://schemas.microsoft.com/office/webextensions/taskpanes/2010/11" xmlns:w16cid="http://schemas.microsoft.com/office/word/2016/wordml/cid" xmlns:w16se="http://schemas.microsoft.com/office/word/2015/wordml/symex" xmlns:wps="http://schemas.microsoft.com/office/word/2010/wordprocessingShape" xmlns:b="http://schemas.openxmlformats.org/officeDocument/2006/bibliography" xmlns:odgm="http://opendope.org/SmartArt/DataHierarchy" xmlns:odi="http://opendope.org/components" xmlns:oda="http://opendope.org/answers" xmlns:odq="http://opendope.org/questions" xmlns:odc="http://opendope.org/conditions" xmlns:odx="http://opendope.org/xpaths" xmlns:cppr="http://schemas.microsoft.com/office/2006/coverPageProps" xmlns:pvml="urn:schemas-microsoft-com:office:powerpoint" xmlns:w10="urn:schemas-microsoft-com:office:word" xmlns:v="urn:schemas-microsoft-com:vml" xmlns:o="urn:schemas-microsoft-com:office:office" xmlns:xvml="urn:schemas-microsoft-com:office:excel" xmlns:dsp="http://schemas.microsoft.com/office/drawing/2008/diagram" xmlns:xdr="http://schemas.openxmlformats.org/drawingml/2006/spreadsheetDrawing" xmlns:pic="http://schemas.openxmlformats.org/drawingml/2006/picture" xmlns:dgm="http://schemas.openxmlformats.org/drawingml/2006/diagram" xmlns:c14="http://schemas.microsoft.com/office/drawing/2007/8/2/chart" xmlns:cdr="http://schemas.openxmlformats.org/drawingml/2006/chartDrawing" xmlns:wne="http://schemas.microsoft.com/office/word/2006/wordml" xmlns:sl="http://schemas.openxmlformats.org/schemaLibrary/2006/main" xmlns:mc="http://schemas.openxmlformats.org/markup-compatibility/2006" xmlns:wp14="http://schemas.microsoft.com/office/word/2010/wordprocessingDrawing" xmlns:wp="http://schemas.openxmlformats.org/drawingml/2006/wordprocessingDrawing" xmlns:m="http://schemas.openxmlformats.org/officeDocument/2006/math" xmlns:w14="http://schemas.microsoft.com/office/word/2010/wordml" xmlns:w15="http://schemas.microsoft.com/office/word/2012/wordml" xmlns:w="http://schemas.openxmlformats.org/wordprocessingml/2006/main">
+          <c:extLst xmlns:w="http://schemas.openxmlformats.org/wordprocessingml/2006/main" xmlns:w15="http://schemas.microsoft.com/office/word/2012/wordml" xmlns:w14="http://schemas.microsoft.com/office/word/2010/wordml" xmlns:m="http://schemas.openxmlformats.org/officeDocument/2006/math" xmlns:wp="http://schemas.openxmlformats.org/drawingml/2006/wordprocessingDrawing" xmlns:wp14="http://schemas.microsoft.com/office/word/2010/wordprocessingDrawing" xmlns:mc="http://schemas.openxmlformats.org/markup-compatibility/2006" xmlns:sl="http://schemas.openxmlformats.org/schemaLibrary/2006/main" xmlns:wne="http://schemas.microsoft.com/office/word/2006/wordml" xmlns:cdr="http://schemas.openxmlformats.org/drawingml/2006/chartDrawing" xmlns:c14="http://schemas.microsoft.com/office/drawing/2007/8/2/chart" xmlns:dgm="http://schemas.openxmlformats.org/drawingml/2006/diagram" xmlns:pic="http://schemas.openxmlformats.org/drawingml/2006/picture" xmlns:xdr="http://schemas.openxmlformats.org/drawingml/2006/spreadsheetDrawing" xmlns:dsp="http://schemas.microsoft.com/office/drawing/2008/diagram" xmlns:xvml="urn:schemas-microsoft-com:office:excel" xmlns:o="urn:schemas-microsoft-com:office:office" xmlns:v="urn:schemas-microsoft-com:vml" xmlns:w10="urn:schemas-microsoft-com:office:word" xmlns:pvml="urn:schemas-microsoft-com:office:powerpoint" xmlns:cppr="http://schemas.microsoft.com/office/2006/coverPageProps" xmlns:odx="http://opendope.org/xpaths" xmlns:odc="http://opendope.org/conditions" xmlns:odq="http://opendope.org/questions" xmlns:oda="http://opendope.org/answers" xmlns:odi="http://opendope.org/components" xmlns:odgm="http://opendope.org/SmartArt/DataHierarchy" xmlns:b="http://schemas.openxmlformats.org/officeDocument/2006/bibliography" xmlns:wps="http://schemas.microsoft.com/office/word/2010/wordprocessingShape" xmlns:w16se="http://schemas.microsoft.com/office/word/2015/wordml/symex" xmlns:w16cid="http://schemas.microsoft.com/office/word/2016/wordml/cid" xmlns:wetp="http://schemas.microsoft.com/office/webextensions/taskpanes/2010/11" xmlns:we="http://schemas.microsoft.com/office/webextensions/webextension/2010/11" xmlns:comp="http://schemas.openxmlformats.org/drawingml/2006/compatibility" xmlns:lc="http://schemas.openxmlformats.org/drawingml/2006/lockedCanvas">
             <c:ext xmlns:c16="http://schemas.microsoft.com/office/drawing/2014/chart" uri="{C3380CC4-5D6E-409C-BE32-E72D297353CC}">
               <c16:uniqueId val="{00000002-6147-E74A-AA7B-5531F0E4EE0C}"/>
             </c:ext>
@@ -3661,7 +3666,7 @@
     <c:plotVisOnly val="1"/>
     <c:dispBlanksAs val="gap"/>
     <c:showDLblsOverMax val="0"/>
-    <c:extLst xmlns:lc="http://schemas.openxmlformats.org/drawingml/2006/lockedCanvas" xmlns:comp="http://schemas.openxmlformats.org/drawingml/2006/compatibility" xmlns:we="http://schemas.microsoft.com/office/webextensions/webextension/2010/11" xmlns:wetp="http://schemas.microsoft.com/office/webextensions/taskpanes/2010/11" xmlns:w16cid="http://schemas.microsoft.com/office/word/2016/wordml/cid" xmlns:w16se="http://schemas.microsoft.com/office/word/2015/wordml/symex" xmlns:wps="http://schemas.microsoft.com/office/word/2010/wordprocessingShape" xmlns:b="http://schemas.openxmlformats.org/officeDocument/2006/bibliography" xmlns:odgm="http://opendope.org/SmartArt/DataHierarchy" xmlns:odi="http://opendope.org/components" xmlns:oda="http://opendope.org/answers" xmlns:odq="http://opendope.org/questions" xmlns:odc="http://opendope.org/conditions" xmlns:odx="http://opendope.org/xpaths" xmlns:cppr="http://schemas.microsoft.com/office/2006/coverPageProps" xmlns:pvml="urn:schemas-microsoft-com:office:powerpoint" xmlns:w10="urn:schemas-microsoft-com:office:word" xmlns:v="urn:schemas-microsoft-com:vml" xmlns:o="urn:schemas-microsoft-com:office:office" xmlns:xvml="urn:schemas-microsoft-com:office:excel" xmlns:dsp="http://schemas.microsoft.com/office/drawing/2008/diagram" xmlns:xdr="http://schemas.openxmlformats.org/drawingml/2006/spreadsheetDrawing" xmlns:pic="http://schemas.openxmlformats.org/drawingml/2006/picture" xmlns:dgm="http://schemas.openxmlformats.org/drawingml/2006/diagram" xmlns:c14="http://schemas.microsoft.com/office/drawing/2007/8/2/chart" xmlns:cdr="http://schemas.openxmlformats.org/drawingml/2006/chartDrawing" xmlns:wne="http://schemas.microsoft.com/office/word/2006/wordml" xmlns:sl="http://schemas.openxmlformats.org/schemaLibrary/2006/main" xmlns:mc="http://schemas.openxmlformats.org/markup-compatibility/2006" xmlns:wp14="http://schemas.microsoft.com/office/word/2010/wordprocessingDrawing" xmlns:wp="http://schemas.openxmlformats.org/drawingml/2006/wordprocessingDrawing" xmlns:m="http://schemas.openxmlformats.org/officeDocument/2006/math" xmlns:w14="http://schemas.microsoft.com/office/word/2010/wordml" xmlns:w15="http://schemas.microsoft.com/office/word/2012/wordml" xmlns:w="http://schemas.openxmlformats.org/wordprocessingml/2006/main">
+    <c:extLst xmlns:w="http://schemas.openxmlformats.org/wordprocessingml/2006/main" xmlns:w15="http://schemas.microsoft.com/office/word/2012/wordml" xmlns:w14="http://schemas.microsoft.com/office/word/2010/wordml" xmlns:m="http://schemas.openxmlformats.org/officeDocument/2006/math" xmlns:wp="http://schemas.openxmlformats.org/drawingml/2006/wordprocessingDrawing" xmlns:wp14="http://schemas.microsoft.com/office/word/2010/wordprocessingDrawing" xmlns:mc="http://schemas.openxmlformats.org/markup-compatibility/2006" xmlns:sl="http://schemas.openxmlformats.org/schemaLibrary/2006/main" xmlns:wne="http://schemas.microsoft.com/office/word/2006/wordml" xmlns:cdr="http://schemas.openxmlformats.org/drawingml/2006/chartDrawing" xmlns:c14="http://schemas.microsoft.com/office/drawing/2007/8/2/chart" xmlns:dgm="http://schemas.openxmlformats.org/drawingml/2006/diagram" xmlns:pic="http://schemas.openxmlformats.org/drawingml/2006/picture" xmlns:xdr="http://schemas.openxmlformats.org/drawingml/2006/spreadsheetDrawing" xmlns:dsp="http://schemas.microsoft.com/office/drawing/2008/diagram" xmlns:xvml="urn:schemas-microsoft-com:office:excel" xmlns:o="urn:schemas-microsoft-com:office:office" xmlns:v="urn:schemas-microsoft-com:vml" xmlns:w10="urn:schemas-microsoft-com:office:word" xmlns:pvml="urn:schemas-microsoft-com:office:powerpoint" xmlns:cppr="http://schemas.microsoft.com/office/2006/coverPageProps" xmlns:odx="http://opendope.org/xpaths" xmlns:odc="http://opendope.org/conditions" xmlns:odq="http://opendope.org/questions" xmlns:oda="http://opendope.org/answers" xmlns:odi="http://opendope.org/components" xmlns:odgm="http://opendope.org/SmartArt/DataHierarchy" xmlns:b="http://schemas.openxmlformats.org/officeDocument/2006/bibliography" xmlns:wps="http://schemas.microsoft.com/office/word/2010/wordprocessingShape" xmlns:w16se="http://schemas.microsoft.com/office/word/2015/wordml/symex" xmlns:w16cid="http://schemas.microsoft.com/office/word/2016/wordml/cid" xmlns:wetp="http://schemas.microsoft.com/office/webextensions/taskpanes/2010/11" xmlns:we="http://schemas.microsoft.com/office/webextensions/webextension/2010/11" xmlns:comp="http://schemas.openxmlformats.org/drawingml/2006/compatibility" xmlns:lc="http://schemas.openxmlformats.org/drawingml/2006/lockedCanvas">
       <c:ext xmlns:c16r3="http://schemas.microsoft.com/office/drawing/2017/03/chart" uri="{56B9EC1D-385E-4148-901F-78D8002777C0}">
         <c16r3:dataDisplayOptions16>
           <c16r3:dispNaAsBlank val="1"/>
@@ -3763,7 +3768,7 @@
                 </a:outerShdw>
               </a:effectLst>
             </c:spPr>
-            <c:extLst xmlns:w="http://schemas.openxmlformats.org/wordprocessingml/2006/main" xmlns:w15="http://schemas.microsoft.com/office/word/2012/wordml" xmlns:w14="http://schemas.microsoft.com/office/word/2010/wordml" xmlns:m="http://schemas.openxmlformats.org/officeDocument/2006/math" xmlns:wp="http://schemas.openxmlformats.org/drawingml/2006/wordprocessingDrawing" xmlns:wp14="http://schemas.microsoft.com/office/word/2010/wordprocessingDrawing" xmlns:mc="http://schemas.openxmlformats.org/markup-compatibility/2006" xmlns:sl="http://schemas.openxmlformats.org/schemaLibrary/2006/main" xmlns:wne="http://schemas.microsoft.com/office/word/2006/wordml" xmlns:cdr="http://schemas.openxmlformats.org/drawingml/2006/chartDrawing" xmlns:c14="http://schemas.microsoft.com/office/drawing/2007/8/2/chart" xmlns:dgm="http://schemas.openxmlformats.org/drawingml/2006/diagram" xmlns:pic="http://schemas.openxmlformats.org/drawingml/2006/picture" xmlns:xdr="http://schemas.openxmlformats.org/drawingml/2006/spreadsheetDrawing" xmlns:dsp="http://schemas.microsoft.com/office/drawing/2008/diagram" xmlns:xvml="urn:schemas-microsoft-com:office:excel" xmlns:o="urn:schemas-microsoft-com:office:office" xmlns:v="urn:schemas-microsoft-com:vml" xmlns:w10="urn:schemas-microsoft-com:office:word" xmlns:pvml="urn:schemas-microsoft-com:office:powerpoint" xmlns:cppr="http://schemas.microsoft.com/office/2006/coverPageProps" xmlns:odx="http://opendope.org/xpaths" xmlns:odc="http://opendope.org/conditions" xmlns:odq="http://opendope.org/questions" xmlns:oda="http://opendope.org/answers" xmlns:odi="http://opendope.org/components" xmlns:odgm="http://opendope.org/SmartArt/DataHierarchy" xmlns:b="http://schemas.openxmlformats.org/officeDocument/2006/bibliography" xmlns:wps="http://schemas.microsoft.com/office/word/2010/wordprocessingShape" xmlns:w16se="http://schemas.microsoft.com/office/word/2015/wordml/symex" xmlns:w16cid="http://schemas.microsoft.com/office/word/2016/wordml/cid" xmlns:wetp="http://schemas.microsoft.com/office/webextensions/taskpanes/2010/11" xmlns:we="http://schemas.microsoft.com/office/webextensions/webextension/2010/11" xmlns:comp="http://schemas.openxmlformats.org/drawingml/2006/compatibility" xmlns:lc="http://schemas.openxmlformats.org/drawingml/2006/lockedCanvas">
+            <c:extLst xmlns:lc="http://schemas.openxmlformats.org/drawingml/2006/lockedCanvas" xmlns:comp="http://schemas.openxmlformats.org/drawingml/2006/compatibility" xmlns:we="http://schemas.microsoft.com/office/webextensions/webextension/2010/11" xmlns:wetp="http://schemas.microsoft.com/office/webextensions/taskpanes/2010/11" xmlns:w16cid="http://schemas.microsoft.com/office/word/2016/wordml/cid" xmlns:w16se="http://schemas.microsoft.com/office/word/2015/wordml/symex" xmlns:wps="http://schemas.microsoft.com/office/word/2010/wordprocessingShape" xmlns:b="http://schemas.openxmlformats.org/officeDocument/2006/bibliography" xmlns:odgm="http://opendope.org/SmartArt/DataHierarchy" xmlns:odi="http://opendope.org/components" xmlns:oda="http://opendope.org/answers" xmlns:odq="http://opendope.org/questions" xmlns:odc="http://opendope.org/conditions" xmlns:odx="http://opendope.org/xpaths" xmlns:cppr="http://schemas.microsoft.com/office/2006/coverPageProps" xmlns:pvml="urn:schemas-microsoft-com:office:powerpoint" xmlns:w10="urn:schemas-microsoft-com:office:word" xmlns:v="urn:schemas-microsoft-com:vml" xmlns:o="urn:schemas-microsoft-com:office:office" xmlns:xvml="urn:schemas-microsoft-com:office:excel" xmlns:dsp="http://schemas.microsoft.com/office/drawing/2008/diagram" xmlns:xdr="http://schemas.openxmlformats.org/drawingml/2006/spreadsheetDrawing" xmlns:pic="http://schemas.openxmlformats.org/drawingml/2006/picture" xmlns:dgm="http://schemas.openxmlformats.org/drawingml/2006/diagram" xmlns:c14="http://schemas.microsoft.com/office/drawing/2007/8/2/chart" xmlns:cdr="http://schemas.openxmlformats.org/drawingml/2006/chartDrawing" xmlns:wne="http://schemas.microsoft.com/office/word/2006/wordml" xmlns:sl="http://schemas.openxmlformats.org/schemaLibrary/2006/main" xmlns:mc="http://schemas.openxmlformats.org/markup-compatibility/2006" xmlns:wp14="http://schemas.microsoft.com/office/word/2010/wordprocessingDrawing" xmlns:wp="http://schemas.openxmlformats.org/drawingml/2006/wordprocessingDrawing" xmlns:m="http://schemas.openxmlformats.org/officeDocument/2006/math" xmlns:w14="http://schemas.microsoft.com/office/word/2010/wordml" xmlns:w15="http://schemas.microsoft.com/office/word/2012/wordml" xmlns:w="http://schemas.openxmlformats.org/wordprocessingml/2006/main">
               <c:ext xmlns:c16="http://schemas.microsoft.com/office/drawing/2014/chart" uri="{C3380CC4-5D6E-409C-BE32-E72D297353CC}">
                 <c16:uniqueId val="{00000001-6147-E74A-AA7B-5531F0E4EE0C}"/>
               </c:ext>
@@ -3858,7 +3863,7 @@
               </c:numCache>
             </c:numRef>
           </c:val>
-          <c:extLst xmlns:w="http://schemas.openxmlformats.org/wordprocessingml/2006/main" xmlns:w15="http://schemas.microsoft.com/office/word/2012/wordml" xmlns:w14="http://schemas.microsoft.com/office/word/2010/wordml" xmlns:m="http://schemas.openxmlformats.org/officeDocument/2006/math" xmlns:wp="http://schemas.openxmlformats.org/drawingml/2006/wordprocessingDrawing" xmlns:wp14="http://schemas.microsoft.com/office/word/2010/wordprocessingDrawing" xmlns:mc="http://schemas.openxmlformats.org/markup-compatibility/2006" xmlns:sl="http://schemas.openxmlformats.org/schemaLibrary/2006/main" xmlns:wne="http://schemas.microsoft.com/office/word/2006/wordml" xmlns:cdr="http://schemas.openxmlformats.org/drawingml/2006/chartDrawing" xmlns:c14="http://schemas.microsoft.com/office/drawing/2007/8/2/chart" xmlns:dgm="http://schemas.openxmlformats.org/drawingml/2006/diagram" xmlns:pic="http://schemas.openxmlformats.org/drawingml/2006/picture" xmlns:xdr="http://schemas.openxmlformats.org/drawingml/2006/spreadsheetDrawing" xmlns:dsp="http://schemas.microsoft.com/office/drawing/2008/diagram" xmlns:xvml="urn:schemas-microsoft-com:office:excel" xmlns:o="urn:schemas-microsoft-com:office:office" xmlns:v="urn:schemas-microsoft-com:vml" xmlns:w10="urn:schemas-microsoft-com:office:word" xmlns:pvml="urn:schemas-microsoft-com:office:powerpoint" xmlns:cppr="http://schemas.microsoft.com/office/2006/coverPageProps" xmlns:odx="http://opendope.org/xpaths" xmlns:odc="http://opendope.org/conditions" xmlns:odq="http://opendope.org/questions" xmlns:oda="http://opendope.org/answers" xmlns:odi="http://opendope.org/components" xmlns:odgm="http://opendope.org/SmartArt/DataHierarchy" xmlns:b="http://schemas.openxmlformats.org/officeDocument/2006/bibliography" xmlns:wps="http://schemas.microsoft.com/office/word/2010/wordprocessingShape" xmlns:w16se="http://schemas.microsoft.com/office/word/2015/wordml/symex" xmlns:w16cid="http://schemas.microsoft.com/office/word/2016/wordml/cid" xmlns:wetp="http://schemas.microsoft.com/office/webextensions/taskpanes/2010/11" xmlns:we="http://schemas.microsoft.com/office/webextensions/webextension/2010/11" xmlns:comp="http://schemas.openxmlformats.org/drawingml/2006/compatibility" xmlns:lc="http://schemas.openxmlformats.org/drawingml/2006/lockedCanvas">
+          <c:extLst xmlns:lc="http://schemas.openxmlformats.org/drawingml/2006/lockedCanvas" xmlns:comp="http://schemas.openxmlformats.org/drawingml/2006/compatibility" xmlns:we="http://schemas.microsoft.com/office/webextensions/webextension/2010/11" xmlns:wetp="http://schemas.microsoft.com/office/webextensions/taskpanes/2010/11" xmlns:w16cid="http://schemas.microsoft.com/office/word/2016/wordml/cid" xmlns:w16se="http://schemas.microsoft.com/office/word/2015/wordml/symex" xmlns:wps="http://schemas.microsoft.com/office/word/2010/wordprocessingShape" xmlns:b="http://schemas.openxmlformats.org/officeDocument/2006/bibliography" xmlns:odgm="http://opendope.org/SmartArt/DataHierarchy" xmlns:odi="http://opendope.org/components" xmlns:oda="http://opendope.org/answers" xmlns:odq="http://opendope.org/questions" xmlns:odc="http://opendope.org/conditions" xmlns:odx="http://opendope.org/xpaths" xmlns:cppr="http://schemas.microsoft.com/office/2006/coverPageProps" xmlns:pvml="urn:schemas-microsoft-com:office:powerpoint" xmlns:w10="urn:schemas-microsoft-com:office:word" xmlns:v="urn:schemas-microsoft-com:vml" xmlns:o="urn:schemas-microsoft-com:office:office" xmlns:xvml="urn:schemas-microsoft-com:office:excel" xmlns:dsp="http://schemas.microsoft.com/office/drawing/2008/diagram" xmlns:xdr="http://schemas.openxmlformats.org/drawingml/2006/spreadsheetDrawing" xmlns:pic="http://schemas.openxmlformats.org/drawingml/2006/picture" xmlns:dgm="http://schemas.openxmlformats.org/drawingml/2006/diagram" xmlns:c14="http://schemas.microsoft.com/office/drawing/2007/8/2/chart" xmlns:cdr="http://schemas.openxmlformats.org/drawingml/2006/chartDrawing" xmlns:wne="http://schemas.microsoft.com/office/word/2006/wordml" xmlns:sl="http://schemas.openxmlformats.org/schemaLibrary/2006/main" xmlns:mc="http://schemas.openxmlformats.org/markup-compatibility/2006" xmlns:wp14="http://schemas.microsoft.com/office/word/2010/wordprocessingDrawing" xmlns:wp="http://schemas.openxmlformats.org/drawingml/2006/wordprocessingDrawing" xmlns:m="http://schemas.openxmlformats.org/officeDocument/2006/math" xmlns:w14="http://schemas.microsoft.com/office/word/2010/wordml" xmlns:w15="http://schemas.microsoft.com/office/word/2012/wordml" xmlns:w="http://schemas.openxmlformats.org/wordprocessingml/2006/main">
             <c:ext xmlns:c16="http://schemas.microsoft.com/office/drawing/2014/chart" uri="{C3380CC4-5D6E-409C-BE32-E72D297353CC}">
               <c16:uniqueId val="{00000002-6147-E74A-AA7B-5531F0E4EE0C}"/>
             </c:ext>
@@ -4469,7 +4474,7 @@
     <c:plotVisOnly val="1"/>
     <c:dispBlanksAs val="gap"/>
     <c:showDLblsOverMax val="0"/>
-    <c:extLst xmlns:w="http://schemas.openxmlformats.org/wordprocessingml/2006/main" xmlns:w15="http://schemas.microsoft.com/office/word/2012/wordml" xmlns:w14="http://schemas.microsoft.com/office/word/2010/wordml" xmlns:m="http://schemas.openxmlformats.org/officeDocument/2006/math" xmlns:wp="http://schemas.openxmlformats.org/drawingml/2006/wordprocessingDrawing" xmlns:wp14="http://schemas.microsoft.com/office/word/2010/wordprocessingDrawing" xmlns:mc="http://schemas.openxmlformats.org/markup-compatibility/2006" xmlns:sl="http://schemas.openxmlformats.org/schemaLibrary/2006/main" xmlns:wne="http://schemas.microsoft.com/office/word/2006/wordml" xmlns:cdr="http://schemas.openxmlformats.org/drawingml/2006/chartDrawing" xmlns:c14="http://schemas.microsoft.com/office/drawing/2007/8/2/chart" xmlns:dgm="http://schemas.openxmlformats.org/drawingml/2006/diagram" xmlns:pic="http://schemas.openxmlformats.org/drawingml/2006/picture" xmlns:xdr="http://schemas.openxmlformats.org/drawingml/2006/spreadsheetDrawing" xmlns:dsp="http://schemas.microsoft.com/office/drawing/2008/diagram" xmlns:xvml="urn:schemas-microsoft-com:office:excel" xmlns:o="urn:schemas-microsoft-com:office:office" xmlns:v="urn:schemas-microsoft-com:vml" xmlns:w10="urn:schemas-microsoft-com:office:word" xmlns:pvml="urn:schemas-microsoft-com:office:powerpoint" xmlns:cppr="http://schemas.microsoft.com/office/2006/coverPageProps" xmlns:odx="http://opendope.org/xpaths" xmlns:odc="http://opendope.org/conditions" xmlns:odq="http://opendope.org/questions" xmlns:oda="http://opendope.org/answers" xmlns:odi="http://opendope.org/components" xmlns:odgm="http://opendope.org/SmartArt/DataHierarchy" xmlns:b="http://schemas.openxmlformats.org/officeDocument/2006/bibliography" xmlns:wps="http://schemas.microsoft.com/office/word/2010/wordprocessingShape" xmlns:w16se="http://schemas.microsoft.com/office/word/2015/wordml/symex" xmlns:w16cid="http://schemas.microsoft.com/office/word/2016/wordml/cid" xmlns:wetp="http://schemas.microsoft.com/office/webextensions/taskpanes/2010/11" xmlns:we="http://schemas.microsoft.com/office/webextensions/webextension/2010/11" xmlns:comp="http://schemas.openxmlformats.org/drawingml/2006/compatibility" xmlns:lc="http://schemas.openxmlformats.org/drawingml/2006/lockedCanvas">
+    <c:extLst xmlns:lc="http://schemas.openxmlformats.org/drawingml/2006/lockedCanvas" xmlns:comp="http://schemas.openxmlformats.org/drawingml/2006/compatibility" xmlns:we="http://schemas.microsoft.com/office/webextensions/webextension/2010/11" xmlns:wetp="http://schemas.microsoft.com/office/webextensions/taskpanes/2010/11" xmlns:w16cid="http://schemas.microsoft.com/office/word/2016/wordml/cid" xmlns:w16se="http://schemas.microsoft.com/office/word/2015/wordml/symex" xmlns:wps="http://schemas.microsoft.com/office/word/2010/wordprocessingShape" xmlns:b="http://schemas.openxmlformats.org/officeDocument/2006/bibliography" xmlns:odgm="http://opendope.org/SmartArt/DataHierarchy" xmlns:odi="http://opendope.org/components" xmlns:oda="http://opendope.org/answers" xmlns:odq="http://opendope.org/questions" xmlns:odc="http://opendope.org/conditions" xmlns:odx="http://opendope.org/xpaths" xmlns:cppr="http://schemas.microsoft.com/office/2006/coverPageProps" xmlns:pvml="urn:schemas-microsoft-com:office:powerpoint" xmlns:w10="urn:schemas-microsoft-com:office:word" xmlns:v="urn:schemas-microsoft-com:vml" xmlns:o="urn:schemas-microsoft-com:office:office" xmlns:xvml="urn:schemas-microsoft-com:office:excel" xmlns:dsp="http://schemas.microsoft.com/office/drawing/2008/diagram" xmlns:xdr="http://schemas.openxmlformats.org/drawingml/2006/spreadsheetDrawing" xmlns:pic="http://schemas.openxmlformats.org/drawingml/2006/picture" xmlns:dgm="http://schemas.openxmlformats.org/drawingml/2006/diagram" xmlns:c14="http://schemas.microsoft.com/office/drawing/2007/8/2/chart" xmlns:cdr="http://schemas.openxmlformats.org/drawingml/2006/chartDrawing" xmlns:wne="http://schemas.microsoft.com/office/word/2006/wordml" xmlns:sl="http://schemas.openxmlformats.org/schemaLibrary/2006/main" xmlns:mc="http://schemas.openxmlformats.org/markup-compatibility/2006" xmlns:wp14="http://schemas.microsoft.com/office/word/2010/wordprocessingDrawing" xmlns:wp="http://schemas.openxmlformats.org/drawingml/2006/wordprocessingDrawing" xmlns:m="http://schemas.openxmlformats.org/officeDocument/2006/math" xmlns:w14="http://schemas.microsoft.com/office/word/2010/wordml" xmlns:w15="http://schemas.microsoft.com/office/word/2012/wordml" xmlns:w="http://schemas.openxmlformats.org/wordprocessingml/2006/main">
       <c:ext xmlns:c16r3="http://schemas.microsoft.com/office/drawing/2017/03/chart" uri="{56B9EC1D-385E-4148-901F-78D8002777C0}">
         <c16r3:dataDisplayOptions16>
           <c16r3:dispNaAsBlank val="1"/>
@@ -4571,7 +4576,7 @@
                 </a:outerShdw>
               </a:effectLst>
             </c:spPr>
-            <c:extLst xmlns:w="http://schemas.openxmlformats.org/wordprocessingml/2006/main" xmlns:w15="http://schemas.microsoft.com/office/word/2012/wordml" xmlns:w14="http://schemas.microsoft.com/office/word/2010/wordml" xmlns:m="http://schemas.openxmlformats.org/officeDocument/2006/math" xmlns:wp="http://schemas.openxmlformats.org/drawingml/2006/wordprocessingDrawing" xmlns:wp14="http://schemas.microsoft.com/office/word/2010/wordprocessingDrawing" xmlns:mc="http://schemas.openxmlformats.org/markup-compatibility/2006" xmlns:sl="http://schemas.openxmlformats.org/schemaLibrary/2006/main" xmlns:wne="http://schemas.microsoft.com/office/word/2006/wordml" xmlns:cdr="http://schemas.openxmlformats.org/drawingml/2006/chartDrawing" xmlns:c14="http://schemas.microsoft.com/office/drawing/2007/8/2/chart" xmlns:dgm="http://schemas.openxmlformats.org/drawingml/2006/diagram" xmlns:pic="http://schemas.openxmlformats.org/drawingml/2006/picture" xmlns:xdr="http://schemas.openxmlformats.org/drawingml/2006/spreadsheetDrawing" xmlns:dsp="http://schemas.microsoft.com/office/drawing/2008/diagram" xmlns:xvml="urn:schemas-microsoft-com:office:excel" xmlns:o="urn:schemas-microsoft-com:office:office" xmlns:v="urn:schemas-microsoft-com:vml" xmlns:w10="urn:schemas-microsoft-com:office:word" xmlns:pvml="urn:schemas-microsoft-com:office:powerpoint" xmlns:cppr="http://schemas.microsoft.com/office/2006/coverPageProps" xmlns:odx="http://opendope.org/xpaths" xmlns:odc="http://opendope.org/conditions" xmlns:odq="http://opendope.org/questions" xmlns:oda="http://opendope.org/answers" xmlns:odi="http://opendope.org/components" xmlns:odgm="http://opendope.org/SmartArt/DataHierarchy" xmlns:b="http://schemas.openxmlformats.org/officeDocument/2006/bibliography" xmlns:wps="http://schemas.microsoft.com/office/word/2010/wordprocessingShape" xmlns:w16se="http://schemas.microsoft.com/office/word/2015/wordml/symex" xmlns:w16cid="http://schemas.microsoft.com/office/word/2016/wordml/cid" xmlns:wetp="http://schemas.microsoft.com/office/webextensions/taskpanes/2010/11" xmlns:we="http://schemas.microsoft.com/office/webextensions/webextension/2010/11" xmlns:comp="http://schemas.openxmlformats.org/drawingml/2006/compatibility" xmlns:lc="http://schemas.openxmlformats.org/drawingml/2006/lockedCanvas">
+            <c:extLst xmlns:lc="http://schemas.openxmlformats.org/drawingml/2006/lockedCanvas" xmlns:comp="http://schemas.openxmlformats.org/drawingml/2006/compatibility" xmlns:we="http://schemas.microsoft.com/office/webextensions/webextension/2010/11" xmlns:wetp="http://schemas.microsoft.com/office/webextensions/taskpanes/2010/11" xmlns:w16cid="http://schemas.microsoft.com/office/word/2016/wordml/cid" xmlns:w16se="http://schemas.microsoft.com/office/word/2015/wordml/symex" xmlns:wps="http://schemas.microsoft.com/office/word/2010/wordprocessingShape" xmlns:b="http://schemas.openxmlformats.org/officeDocument/2006/bibliography" xmlns:odgm="http://opendope.org/SmartArt/DataHierarchy" xmlns:odi="http://opendope.org/components" xmlns:oda="http://opendope.org/answers" xmlns:odq="http://opendope.org/questions" xmlns:odc="http://opendope.org/conditions" xmlns:odx="http://opendope.org/xpaths" xmlns:cppr="http://schemas.microsoft.com/office/2006/coverPageProps" xmlns:pvml="urn:schemas-microsoft-com:office:powerpoint" xmlns:w10="urn:schemas-microsoft-com:office:word" xmlns:v="urn:schemas-microsoft-com:vml" xmlns:o="urn:schemas-microsoft-com:office:office" xmlns:xvml="urn:schemas-microsoft-com:office:excel" xmlns:dsp="http://schemas.microsoft.com/office/drawing/2008/diagram" xmlns:xdr="http://schemas.openxmlformats.org/drawingml/2006/spreadsheetDrawing" xmlns:pic="http://schemas.openxmlformats.org/drawingml/2006/picture" xmlns:dgm="http://schemas.openxmlformats.org/drawingml/2006/diagram" xmlns:c14="http://schemas.microsoft.com/office/drawing/2007/8/2/chart" xmlns:cdr="http://schemas.openxmlformats.org/drawingml/2006/chartDrawing" xmlns:wne="http://schemas.microsoft.com/office/word/2006/wordml" xmlns:sl="http://schemas.openxmlformats.org/schemaLibrary/2006/main" xmlns:mc="http://schemas.openxmlformats.org/markup-compatibility/2006" xmlns:wp14="http://schemas.microsoft.com/office/word/2010/wordprocessingDrawing" xmlns:wp="http://schemas.openxmlformats.org/drawingml/2006/wordprocessingDrawing" xmlns:m="http://schemas.openxmlformats.org/officeDocument/2006/math" xmlns:w14="http://schemas.microsoft.com/office/word/2010/wordml" xmlns:w15="http://schemas.microsoft.com/office/word/2012/wordml" xmlns:w="http://schemas.openxmlformats.org/wordprocessingml/2006/main">
               <c:ext xmlns:c16="http://schemas.microsoft.com/office/drawing/2014/chart" uri="{C3380CC4-5D6E-409C-BE32-E72D297353CC}">
                 <c16:uniqueId val="{00000001-6147-E74A-AA7B-5531F0E4EE0C}"/>
               </c:ext>
@@ -4666,7 +4671,7 @@
               </c:numCache>
             </c:numRef>
           </c:val>
-          <c:extLst xmlns:w="http://schemas.openxmlformats.org/wordprocessingml/2006/main" xmlns:w15="http://schemas.microsoft.com/office/word/2012/wordml" xmlns:w14="http://schemas.microsoft.com/office/word/2010/wordml" xmlns:m="http://schemas.openxmlformats.org/officeDocument/2006/math" xmlns:wp="http://schemas.openxmlformats.org/drawingml/2006/wordprocessingDrawing" xmlns:wp14="http://schemas.microsoft.com/office/word/2010/wordprocessingDrawing" xmlns:mc="http://schemas.openxmlformats.org/markup-compatibility/2006" xmlns:sl="http://schemas.openxmlformats.org/schemaLibrary/2006/main" xmlns:wne="http://schemas.microsoft.com/office/word/2006/wordml" xmlns:cdr="http://schemas.openxmlformats.org/drawingml/2006/chartDrawing" xmlns:c14="http://schemas.microsoft.com/office/drawing/2007/8/2/chart" xmlns:dgm="http://schemas.openxmlformats.org/drawingml/2006/diagram" xmlns:pic="http://schemas.openxmlformats.org/drawingml/2006/picture" xmlns:xdr="http://schemas.openxmlformats.org/drawingml/2006/spreadsheetDrawing" xmlns:dsp="http://schemas.microsoft.com/office/drawing/2008/diagram" xmlns:xvml="urn:schemas-microsoft-com:office:excel" xmlns:o="urn:schemas-microsoft-com:office:office" xmlns:v="urn:schemas-microsoft-com:vml" xmlns:w10="urn:schemas-microsoft-com:office:word" xmlns:pvml="urn:schemas-microsoft-com:office:powerpoint" xmlns:cppr="http://schemas.microsoft.com/office/2006/coverPageProps" xmlns:odx="http://opendope.org/xpaths" xmlns:odc="http://opendope.org/conditions" xmlns:odq="http://opendope.org/questions" xmlns:oda="http://opendope.org/answers" xmlns:odi="http://opendope.org/components" xmlns:odgm="http://opendope.org/SmartArt/DataHierarchy" xmlns:b="http://schemas.openxmlformats.org/officeDocument/2006/bibliography" xmlns:wps="http://schemas.microsoft.com/office/word/2010/wordprocessingShape" xmlns:w16se="http://schemas.microsoft.com/office/word/2015/wordml/symex" xmlns:w16cid="http://schemas.microsoft.com/office/word/2016/wordml/cid" xmlns:wetp="http://schemas.microsoft.com/office/webextensions/taskpanes/2010/11" xmlns:we="http://schemas.microsoft.com/office/webextensions/webextension/2010/11" xmlns:comp="http://schemas.openxmlformats.org/drawingml/2006/compatibility" xmlns:lc="http://schemas.openxmlformats.org/drawingml/2006/lockedCanvas">
+          <c:extLst xmlns:lc="http://schemas.openxmlformats.org/drawingml/2006/lockedCanvas" xmlns:comp="http://schemas.openxmlformats.org/drawingml/2006/compatibility" xmlns:we="http://schemas.microsoft.com/office/webextensions/webextension/2010/11" xmlns:wetp="http://schemas.microsoft.com/office/webextensions/taskpanes/2010/11" xmlns:w16cid="http://schemas.microsoft.com/office/word/2016/wordml/cid" xmlns:w16se="http://schemas.microsoft.com/office/word/2015/wordml/symex" xmlns:wps="http://schemas.microsoft.com/office/word/2010/wordprocessingShape" xmlns:b="http://schemas.openxmlformats.org/officeDocument/2006/bibliography" xmlns:odgm="http://opendope.org/SmartArt/DataHierarchy" xmlns:odi="http://opendope.org/components" xmlns:oda="http://opendope.org/answers" xmlns:odq="http://opendope.org/questions" xmlns:odc="http://opendope.org/conditions" xmlns:odx="http://opendope.org/xpaths" xmlns:cppr="http://schemas.microsoft.com/office/2006/coverPageProps" xmlns:pvml="urn:schemas-microsoft-com:office:powerpoint" xmlns:w10="urn:schemas-microsoft-com:office:word" xmlns:v="urn:schemas-microsoft-com:vml" xmlns:o="urn:schemas-microsoft-com:office:office" xmlns:xvml="urn:schemas-microsoft-com:office:excel" xmlns:dsp="http://schemas.microsoft.com/office/drawing/2008/diagram" xmlns:xdr="http://schemas.openxmlformats.org/drawingml/2006/spreadsheetDrawing" xmlns:pic="http://schemas.openxmlformats.org/drawingml/2006/picture" xmlns:dgm="http://schemas.openxmlformats.org/drawingml/2006/diagram" xmlns:c14="http://schemas.microsoft.com/office/drawing/2007/8/2/chart" xmlns:cdr="http://schemas.openxmlformats.org/drawingml/2006/chartDrawing" xmlns:wne="http://schemas.microsoft.com/office/word/2006/wordml" xmlns:sl="http://schemas.openxmlformats.org/schemaLibrary/2006/main" xmlns:mc="http://schemas.openxmlformats.org/markup-compatibility/2006" xmlns:wp14="http://schemas.microsoft.com/office/word/2010/wordprocessingDrawing" xmlns:wp="http://schemas.openxmlformats.org/drawingml/2006/wordprocessingDrawing" xmlns:m="http://schemas.openxmlformats.org/officeDocument/2006/math" xmlns:w14="http://schemas.microsoft.com/office/word/2010/wordml" xmlns:w15="http://schemas.microsoft.com/office/word/2012/wordml" xmlns:w="http://schemas.openxmlformats.org/wordprocessingml/2006/main">
             <c:ext xmlns:c16="http://schemas.microsoft.com/office/drawing/2014/chart" uri="{C3380CC4-5D6E-409C-BE32-E72D297353CC}">
               <c16:uniqueId val="{00000002-6147-E74A-AA7B-5531F0E4EE0C}"/>
             </c:ext>
@@ -5277,7 +5282,7 @@
     <c:plotVisOnly val="1"/>
     <c:dispBlanksAs val="gap"/>
     <c:showDLblsOverMax val="0"/>
-    <c:extLst xmlns:w="http://schemas.openxmlformats.org/wordprocessingml/2006/main" xmlns:w15="http://schemas.microsoft.com/office/word/2012/wordml" xmlns:w14="http://schemas.microsoft.com/office/word/2010/wordml" xmlns:m="http://schemas.openxmlformats.org/officeDocument/2006/math" xmlns:wp="http://schemas.openxmlformats.org/drawingml/2006/wordprocessingDrawing" xmlns:wp14="http://schemas.microsoft.com/office/word/2010/wordprocessingDrawing" xmlns:mc="http://schemas.openxmlformats.org/markup-compatibility/2006" xmlns:sl="http://schemas.openxmlformats.org/schemaLibrary/2006/main" xmlns:wne="http://schemas.microsoft.com/office/word/2006/wordml" xmlns:cdr="http://schemas.openxmlformats.org/drawingml/2006/chartDrawing" xmlns:c14="http://schemas.microsoft.com/office/drawing/2007/8/2/chart" xmlns:dgm="http://schemas.openxmlformats.org/drawingml/2006/diagram" xmlns:pic="http://schemas.openxmlformats.org/drawingml/2006/picture" xmlns:xdr="http://schemas.openxmlformats.org/drawingml/2006/spreadsheetDrawing" xmlns:dsp="http://schemas.microsoft.com/office/drawing/2008/diagram" xmlns:xvml="urn:schemas-microsoft-com:office:excel" xmlns:o="urn:schemas-microsoft-com:office:office" xmlns:v="urn:schemas-microsoft-com:vml" xmlns:w10="urn:schemas-microsoft-com:office:word" xmlns:pvml="urn:schemas-microsoft-com:office:powerpoint" xmlns:cppr="http://schemas.microsoft.com/office/2006/coverPageProps" xmlns:odx="http://opendope.org/xpaths" xmlns:odc="http://opendope.org/conditions" xmlns:odq="http://opendope.org/questions" xmlns:oda="http://opendope.org/answers" xmlns:odi="http://opendope.org/components" xmlns:odgm="http://opendope.org/SmartArt/DataHierarchy" xmlns:b="http://schemas.openxmlformats.org/officeDocument/2006/bibliography" xmlns:wps="http://schemas.microsoft.com/office/word/2010/wordprocessingShape" xmlns:w16se="http://schemas.microsoft.com/office/word/2015/wordml/symex" xmlns:w16cid="http://schemas.microsoft.com/office/word/2016/wordml/cid" xmlns:wetp="http://schemas.microsoft.com/office/webextensions/taskpanes/2010/11" xmlns:we="http://schemas.microsoft.com/office/webextensions/webextension/2010/11" xmlns:comp="http://schemas.openxmlformats.org/drawingml/2006/compatibility" xmlns:lc="http://schemas.openxmlformats.org/drawingml/2006/lockedCanvas">
+    <c:extLst xmlns:lc="http://schemas.openxmlformats.org/drawingml/2006/lockedCanvas" xmlns:comp="http://schemas.openxmlformats.org/drawingml/2006/compatibility" xmlns:we="http://schemas.microsoft.com/office/webextensions/webextension/2010/11" xmlns:wetp="http://schemas.microsoft.com/office/webextensions/taskpanes/2010/11" xmlns:w16cid="http://schemas.microsoft.com/office/word/2016/wordml/cid" xmlns:w16se="http://schemas.microsoft.com/office/word/2015/wordml/symex" xmlns:wps="http://schemas.microsoft.com/office/word/2010/wordprocessingShape" xmlns:b="http://schemas.openxmlformats.org/officeDocument/2006/bibliography" xmlns:odgm="http://opendope.org/SmartArt/DataHierarchy" xmlns:odi="http://opendope.org/components" xmlns:oda="http://opendope.org/answers" xmlns:odq="http://opendope.org/questions" xmlns:odc="http://opendope.org/conditions" xmlns:odx="http://opendope.org/xpaths" xmlns:cppr="http://schemas.microsoft.com/office/2006/coverPageProps" xmlns:pvml="urn:schemas-microsoft-com:office:powerpoint" xmlns:w10="urn:schemas-microsoft-com:office:word" xmlns:v="urn:schemas-microsoft-com:vml" xmlns:o="urn:schemas-microsoft-com:office:office" xmlns:xvml="urn:schemas-microsoft-com:office:excel" xmlns:dsp="http://schemas.microsoft.com/office/drawing/2008/diagram" xmlns:xdr="http://schemas.openxmlformats.org/drawingml/2006/spreadsheetDrawing" xmlns:pic="http://schemas.openxmlformats.org/drawingml/2006/picture" xmlns:dgm="http://schemas.openxmlformats.org/drawingml/2006/diagram" xmlns:c14="http://schemas.microsoft.com/office/drawing/2007/8/2/chart" xmlns:cdr="http://schemas.openxmlformats.org/drawingml/2006/chartDrawing" xmlns:wne="http://schemas.microsoft.com/office/word/2006/wordml" xmlns:sl="http://schemas.openxmlformats.org/schemaLibrary/2006/main" xmlns:mc="http://schemas.openxmlformats.org/markup-compatibility/2006" xmlns:wp14="http://schemas.microsoft.com/office/word/2010/wordprocessingDrawing" xmlns:wp="http://schemas.openxmlformats.org/drawingml/2006/wordprocessingDrawing" xmlns:m="http://schemas.openxmlformats.org/officeDocument/2006/math" xmlns:w14="http://schemas.microsoft.com/office/word/2010/wordml" xmlns:w15="http://schemas.microsoft.com/office/word/2012/wordml" xmlns:w="http://schemas.openxmlformats.org/wordprocessingml/2006/main">
       <c:ext xmlns:c16r3="http://schemas.microsoft.com/office/drawing/2017/03/chart" uri="{56B9EC1D-385E-4148-901F-78D8002777C0}">
         <c16r3:dataDisplayOptions16>
           <c16r3:dispNaAsBlank val="1"/>
@@ -5379,7 +5384,7 @@
                 </a:outerShdw>
               </a:effectLst>
             </c:spPr>
-            <c:extLst xmlns:w="http://schemas.openxmlformats.org/wordprocessingml/2006/main" xmlns:w15="http://schemas.microsoft.com/office/word/2012/wordml" xmlns:w14="http://schemas.microsoft.com/office/word/2010/wordml" xmlns:m="http://schemas.openxmlformats.org/officeDocument/2006/math" xmlns:wp="http://schemas.openxmlformats.org/drawingml/2006/wordprocessingDrawing" xmlns:wp14="http://schemas.microsoft.com/office/word/2010/wordprocessingDrawing" xmlns:mc="http://schemas.openxmlformats.org/markup-compatibility/2006" xmlns:sl="http://schemas.openxmlformats.org/schemaLibrary/2006/main" xmlns:wne="http://schemas.microsoft.com/office/word/2006/wordml" xmlns:cdr="http://schemas.openxmlformats.org/drawingml/2006/chartDrawing" xmlns:c14="http://schemas.microsoft.com/office/drawing/2007/8/2/chart" xmlns:dgm="http://schemas.openxmlformats.org/drawingml/2006/diagram" xmlns:pic="http://schemas.openxmlformats.org/drawingml/2006/picture" xmlns:xdr="http://schemas.openxmlformats.org/drawingml/2006/spreadsheetDrawing" xmlns:dsp="http://schemas.microsoft.com/office/drawing/2008/diagram" xmlns:xvml="urn:schemas-microsoft-com:office:excel" xmlns:o="urn:schemas-microsoft-com:office:office" xmlns:v="urn:schemas-microsoft-com:vml" xmlns:w10="urn:schemas-microsoft-com:office:word" xmlns:pvml="urn:schemas-microsoft-com:office:powerpoint" xmlns:cppr="http://schemas.microsoft.com/office/2006/coverPageProps" xmlns:odx="http://opendope.org/xpaths" xmlns:odc="http://opendope.org/conditions" xmlns:odq="http://opendope.org/questions" xmlns:oda="http://opendope.org/answers" xmlns:odi="http://opendope.org/components" xmlns:odgm="http://opendope.org/SmartArt/DataHierarchy" xmlns:b="http://schemas.openxmlformats.org/officeDocument/2006/bibliography" xmlns:wps="http://schemas.microsoft.com/office/word/2010/wordprocessingShape" xmlns:w16se="http://schemas.microsoft.com/office/word/2015/wordml/symex" xmlns:w16cid="http://schemas.microsoft.com/office/word/2016/wordml/cid" xmlns:wetp="http://schemas.microsoft.com/office/webextensions/taskpanes/2010/11" xmlns:we="http://schemas.microsoft.com/office/webextensions/webextension/2010/11" xmlns:comp="http://schemas.openxmlformats.org/drawingml/2006/compatibility" xmlns:lc="http://schemas.openxmlformats.org/drawingml/2006/lockedCanvas">
+            <c:extLst xmlns:lc="http://schemas.openxmlformats.org/drawingml/2006/lockedCanvas" xmlns:comp="http://schemas.openxmlformats.org/drawingml/2006/compatibility" xmlns:we="http://schemas.microsoft.com/office/webextensions/webextension/2010/11" xmlns:wetp="http://schemas.microsoft.com/office/webextensions/taskpanes/2010/11" xmlns:w16cid="http://schemas.microsoft.com/office/word/2016/wordml/cid" xmlns:w16se="http://schemas.microsoft.com/office/word/2015/wordml/symex" xmlns:wps="http://schemas.microsoft.com/office/word/2010/wordprocessingShape" xmlns:b="http://schemas.openxmlformats.org/officeDocument/2006/bibliography" xmlns:odgm="http://opendope.org/SmartArt/DataHierarchy" xmlns:odi="http://opendope.org/components" xmlns:oda="http://opendope.org/answers" xmlns:odq="http://opendope.org/questions" xmlns:odc="http://opendope.org/conditions" xmlns:odx="http://opendope.org/xpaths" xmlns:cppr="http://schemas.microsoft.com/office/2006/coverPageProps" xmlns:pvml="urn:schemas-microsoft-com:office:powerpoint" xmlns:w10="urn:schemas-microsoft-com:office:word" xmlns:v="urn:schemas-microsoft-com:vml" xmlns:o="urn:schemas-microsoft-com:office:office" xmlns:xvml="urn:schemas-microsoft-com:office:excel" xmlns:dsp="http://schemas.microsoft.com/office/drawing/2008/diagram" xmlns:xdr="http://schemas.openxmlformats.org/drawingml/2006/spreadsheetDrawing" xmlns:pic="http://schemas.openxmlformats.org/drawingml/2006/picture" xmlns:dgm="http://schemas.openxmlformats.org/drawingml/2006/diagram" xmlns:c14="http://schemas.microsoft.com/office/drawing/2007/8/2/chart" xmlns:cdr="http://schemas.openxmlformats.org/drawingml/2006/chartDrawing" xmlns:wne="http://schemas.microsoft.com/office/word/2006/wordml" xmlns:sl="http://schemas.openxmlformats.org/schemaLibrary/2006/main" xmlns:mc="http://schemas.openxmlformats.org/markup-compatibility/2006" xmlns:wp14="http://schemas.microsoft.com/office/word/2010/wordprocessingDrawing" xmlns:wp="http://schemas.openxmlformats.org/drawingml/2006/wordprocessingDrawing" xmlns:m="http://schemas.openxmlformats.org/officeDocument/2006/math" xmlns:w14="http://schemas.microsoft.com/office/word/2010/wordml" xmlns:w15="http://schemas.microsoft.com/office/word/2012/wordml" xmlns:w="http://schemas.openxmlformats.org/wordprocessingml/2006/main">
               <c:ext xmlns:c16="http://schemas.microsoft.com/office/drawing/2014/chart" uri="{C3380CC4-5D6E-409C-BE32-E72D297353CC}">
                 <c16:uniqueId val="{00000001-6147-E74A-AA7B-5531F0E4EE0C}"/>
               </c:ext>
@@ -5474,7 +5479,7 @@
               </c:numCache>
             </c:numRef>
           </c:val>
-          <c:extLst xmlns:w="http://schemas.openxmlformats.org/wordprocessingml/2006/main" xmlns:w15="http://schemas.microsoft.com/office/word/2012/wordml" xmlns:w14="http://schemas.microsoft.com/office/word/2010/wordml" xmlns:m="http://schemas.openxmlformats.org/officeDocument/2006/math" xmlns:wp="http://schemas.openxmlformats.org/drawingml/2006/wordprocessingDrawing" xmlns:wp14="http://schemas.microsoft.com/office/word/2010/wordprocessingDrawing" xmlns:mc="http://schemas.openxmlformats.org/markup-compatibility/2006" xmlns:sl="http://schemas.openxmlformats.org/schemaLibrary/2006/main" xmlns:wne="http://schemas.microsoft.com/office/word/2006/wordml" xmlns:cdr="http://schemas.openxmlformats.org/drawingml/2006/chartDrawing" xmlns:c14="http://schemas.microsoft.com/office/drawing/2007/8/2/chart" xmlns:dgm="http://schemas.openxmlformats.org/drawingml/2006/diagram" xmlns:pic="http://schemas.openxmlformats.org/drawingml/2006/picture" xmlns:xdr="http://schemas.openxmlformats.org/drawingml/2006/spreadsheetDrawing" xmlns:dsp="http://schemas.microsoft.com/office/drawing/2008/diagram" xmlns:xvml="urn:schemas-microsoft-com:office:excel" xmlns:o="urn:schemas-microsoft-com:office:office" xmlns:v="urn:schemas-microsoft-com:vml" xmlns:w10="urn:schemas-microsoft-com:office:word" xmlns:pvml="urn:schemas-microsoft-com:office:powerpoint" xmlns:cppr="http://schemas.microsoft.com/office/2006/coverPageProps" xmlns:odx="http://opendope.org/xpaths" xmlns:odc="http://opendope.org/conditions" xmlns:odq="http://opendope.org/questions" xmlns:oda="http://opendope.org/answers" xmlns:odi="http://opendope.org/components" xmlns:odgm="http://opendope.org/SmartArt/DataHierarchy" xmlns:b="http://schemas.openxmlformats.org/officeDocument/2006/bibliography" xmlns:wps="http://schemas.microsoft.com/office/word/2010/wordprocessingShape" xmlns:w16se="http://schemas.microsoft.com/office/word/2015/wordml/symex" xmlns:w16cid="http://schemas.microsoft.com/office/word/2016/wordml/cid" xmlns:wetp="http://schemas.microsoft.com/office/webextensions/taskpanes/2010/11" xmlns:we="http://schemas.microsoft.com/office/webextensions/webextension/2010/11" xmlns:comp="http://schemas.openxmlformats.org/drawingml/2006/compatibility" xmlns:lc="http://schemas.openxmlformats.org/drawingml/2006/lockedCanvas">
+          <c:extLst xmlns:lc="http://schemas.openxmlformats.org/drawingml/2006/lockedCanvas" xmlns:comp="http://schemas.openxmlformats.org/drawingml/2006/compatibility" xmlns:we="http://schemas.microsoft.com/office/webextensions/webextension/2010/11" xmlns:wetp="http://schemas.microsoft.com/office/webextensions/taskpanes/2010/11" xmlns:w16cid="http://schemas.microsoft.com/office/word/2016/wordml/cid" xmlns:w16se="http://schemas.microsoft.com/office/word/2015/wordml/symex" xmlns:wps="http://schemas.microsoft.com/office/word/2010/wordprocessingShape" xmlns:b="http://schemas.openxmlformats.org/officeDocument/2006/bibliography" xmlns:odgm="http://opendope.org/SmartArt/DataHierarchy" xmlns:odi="http://opendope.org/components" xmlns:oda="http://opendope.org/answers" xmlns:odq="http://opendope.org/questions" xmlns:odc="http://opendope.org/conditions" xmlns:odx="http://opendope.org/xpaths" xmlns:cppr="http://schemas.microsoft.com/office/2006/coverPageProps" xmlns:pvml="urn:schemas-microsoft-com:office:powerpoint" xmlns:w10="urn:schemas-microsoft-com:office:word" xmlns:v="urn:schemas-microsoft-com:vml" xmlns:o="urn:schemas-microsoft-com:office:office" xmlns:xvml="urn:schemas-microsoft-com:office:excel" xmlns:dsp="http://schemas.microsoft.com/office/drawing/2008/diagram" xmlns:xdr="http://schemas.openxmlformats.org/drawingml/2006/spreadsheetDrawing" xmlns:pic="http://schemas.openxmlformats.org/drawingml/2006/picture" xmlns:dgm="http://schemas.openxmlformats.org/drawingml/2006/diagram" xmlns:c14="http://schemas.microsoft.com/office/drawing/2007/8/2/chart" xmlns:cdr="http://schemas.openxmlformats.org/drawingml/2006/chartDrawing" xmlns:wne="http://schemas.microsoft.com/office/word/2006/wordml" xmlns:sl="http://schemas.openxmlformats.org/schemaLibrary/2006/main" xmlns:mc="http://schemas.openxmlformats.org/markup-compatibility/2006" xmlns:wp14="http://schemas.microsoft.com/office/word/2010/wordprocessingDrawing" xmlns:wp="http://schemas.openxmlformats.org/drawingml/2006/wordprocessingDrawing" xmlns:m="http://schemas.openxmlformats.org/officeDocument/2006/math" xmlns:w14="http://schemas.microsoft.com/office/word/2010/wordml" xmlns:w15="http://schemas.microsoft.com/office/word/2012/wordml" xmlns:w="http://schemas.openxmlformats.org/wordprocessingml/2006/main">
             <c:ext xmlns:c16="http://schemas.microsoft.com/office/drawing/2014/chart" uri="{C3380CC4-5D6E-409C-BE32-E72D297353CC}">
               <c16:uniqueId val="{00000002-6147-E74A-AA7B-5531F0E4EE0C}"/>
             </c:ext>
@@ -6085,7 +6090,7 @@
     <c:plotVisOnly val="1"/>
     <c:dispBlanksAs val="gap"/>
     <c:showDLblsOverMax val="0"/>
-    <c:extLst xmlns:w="http://schemas.openxmlformats.org/wordprocessingml/2006/main" xmlns:w15="http://schemas.microsoft.com/office/word/2012/wordml" xmlns:w14="http://schemas.microsoft.com/office/word/2010/wordml" xmlns:m="http://schemas.openxmlformats.org/officeDocument/2006/math" xmlns:wp="http://schemas.openxmlformats.org/drawingml/2006/wordprocessingDrawing" xmlns:wp14="http://schemas.microsoft.com/office/word/2010/wordprocessingDrawing" xmlns:mc="http://schemas.openxmlformats.org/markup-compatibility/2006" xmlns:sl="http://schemas.openxmlformats.org/schemaLibrary/2006/main" xmlns:wne="http://schemas.microsoft.com/office/word/2006/wordml" xmlns:cdr="http://schemas.openxmlformats.org/drawingml/2006/chartDrawing" xmlns:c14="http://schemas.microsoft.com/office/drawing/2007/8/2/chart" xmlns:dgm="http://schemas.openxmlformats.org/drawingml/2006/diagram" xmlns:pic="http://schemas.openxmlformats.org/drawingml/2006/picture" xmlns:xdr="http://schemas.openxmlformats.org/drawingml/2006/spreadsheetDrawing" xmlns:dsp="http://schemas.microsoft.com/office/drawing/2008/diagram" xmlns:xvml="urn:schemas-microsoft-com:office:excel" xmlns:o="urn:schemas-microsoft-com:office:office" xmlns:v="urn:schemas-microsoft-com:vml" xmlns:w10="urn:schemas-microsoft-com:office:word" xmlns:pvml="urn:schemas-microsoft-com:office:powerpoint" xmlns:cppr="http://schemas.microsoft.com/office/2006/coverPageProps" xmlns:odx="http://opendope.org/xpaths" xmlns:odc="http://opendope.org/conditions" xmlns:odq="http://opendope.org/questions" xmlns:oda="http://opendope.org/answers" xmlns:odi="http://opendope.org/components" xmlns:odgm="http://opendope.org/SmartArt/DataHierarchy" xmlns:b="http://schemas.openxmlformats.org/officeDocument/2006/bibliography" xmlns:wps="http://schemas.microsoft.com/office/word/2010/wordprocessingShape" xmlns:w16se="http://schemas.microsoft.com/office/word/2015/wordml/symex" xmlns:w16cid="http://schemas.microsoft.com/office/word/2016/wordml/cid" xmlns:wetp="http://schemas.microsoft.com/office/webextensions/taskpanes/2010/11" xmlns:we="http://schemas.microsoft.com/office/webextensions/webextension/2010/11" xmlns:comp="http://schemas.openxmlformats.org/drawingml/2006/compatibility" xmlns:lc="http://schemas.openxmlformats.org/drawingml/2006/lockedCanvas">
+    <c:extLst xmlns:lc="http://schemas.openxmlformats.org/drawingml/2006/lockedCanvas" xmlns:comp="http://schemas.openxmlformats.org/drawingml/2006/compatibility" xmlns:we="http://schemas.microsoft.com/office/webextensions/webextension/2010/11" xmlns:wetp="http://schemas.microsoft.com/office/webextensions/taskpanes/2010/11" xmlns:w16cid="http://schemas.microsoft.com/office/word/2016/wordml/cid" xmlns:w16se="http://schemas.microsoft.com/office/word/2015/wordml/symex" xmlns:wps="http://schemas.microsoft.com/office/word/2010/wordprocessingShape" xmlns:b="http://schemas.openxmlformats.org/officeDocument/2006/bibliography" xmlns:odgm="http://opendope.org/SmartArt/DataHierarchy" xmlns:odi="http://opendope.org/components" xmlns:oda="http://opendope.org/answers" xmlns:odq="http://opendope.org/questions" xmlns:odc="http://opendope.org/conditions" xmlns:odx="http://opendope.org/xpaths" xmlns:cppr="http://schemas.microsoft.com/office/2006/coverPageProps" xmlns:pvml="urn:schemas-microsoft-com:office:powerpoint" xmlns:w10="urn:schemas-microsoft-com:office:word" xmlns:v="urn:schemas-microsoft-com:vml" xmlns:o="urn:schemas-microsoft-com:office:office" xmlns:xvml="urn:schemas-microsoft-com:office:excel" xmlns:dsp="http://schemas.microsoft.com/office/drawing/2008/diagram" xmlns:xdr="http://schemas.openxmlformats.org/drawingml/2006/spreadsheetDrawing" xmlns:pic="http://schemas.openxmlformats.org/drawingml/2006/picture" xmlns:dgm="http://schemas.openxmlformats.org/drawingml/2006/diagram" xmlns:c14="http://schemas.microsoft.com/office/drawing/2007/8/2/chart" xmlns:cdr="http://schemas.openxmlformats.org/drawingml/2006/chartDrawing" xmlns:wne="http://schemas.microsoft.com/office/word/2006/wordml" xmlns:sl="http://schemas.openxmlformats.org/schemaLibrary/2006/main" xmlns:mc="http://schemas.openxmlformats.org/markup-compatibility/2006" xmlns:wp14="http://schemas.microsoft.com/office/word/2010/wordprocessingDrawing" xmlns:wp="http://schemas.openxmlformats.org/drawingml/2006/wordprocessingDrawing" xmlns:m="http://schemas.openxmlformats.org/officeDocument/2006/math" xmlns:w14="http://schemas.microsoft.com/office/word/2010/wordml" xmlns:w15="http://schemas.microsoft.com/office/word/2012/wordml" xmlns:w="http://schemas.openxmlformats.org/wordprocessingml/2006/main">
       <c:ext xmlns:c16r3="http://schemas.microsoft.com/office/drawing/2017/03/chart" uri="{56B9EC1D-385E-4148-901F-78D8002777C0}">
         <c16r3:dataDisplayOptions16>
           <c16r3:dispNaAsBlank val="1"/>
@@ -10398,7 +10403,7 @@
           <a:p>
             <a:fld id="{D672B8B4-E227-994A-A2C0-477E986EF4F1}" type="datetimeFigureOut">
               <a:rPr lang="nl-NL" smtClean="0"/>
-              <a:t>21-10-2025</a:t>
+              <a:t>08-11-2025</a:t>
             </a:fld>
             <a:endParaRPr lang="nl-NL"/>
           </a:p>
@@ -12663,7 +12668,7 @@
           <a:p>
             <a:fld id="{542F8156-3D1B-1047-9A3D-372BE84AD46C}" type="datetimeFigureOut">
               <a:rPr lang="nl-NL" smtClean="0"/>
-              <a:t>21-10-2025</a:t>
+              <a:t>08-11-2025</a:t>
             </a:fld>
             <a:endParaRPr lang="nl-NL"/>
           </a:p>
@@ -12863,7 +12868,7 @@
           <a:p>
             <a:fld id="{542F8156-3D1B-1047-9A3D-372BE84AD46C}" type="datetimeFigureOut">
               <a:rPr lang="nl-NL" smtClean="0"/>
-              <a:t>21-10-2025</a:t>
+              <a:t>08-11-2025</a:t>
             </a:fld>
             <a:endParaRPr lang="nl-NL"/>
           </a:p>
@@ -13073,7 +13078,7 @@
           <a:p>
             <a:fld id="{542F8156-3D1B-1047-9A3D-372BE84AD46C}" type="datetimeFigureOut">
               <a:rPr lang="nl-NL" smtClean="0"/>
-              <a:t>21-10-2025</a:t>
+              <a:t>08-11-2025</a:t>
             </a:fld>
             <a:endParaRPr lang="nl-NL"/>
           </a:p>
@@ -13998,7 +14003,7 @@
           <a:p>
             <a:fld id="{542F8156-3D1B-1047-9A3D-372BE84AD46C}" type="datetimeFigureOut">
               <a:rPr lang="nl-NL" smtClean="0"/>
-              <a:t>21-10-2025</a:t>
+              <a:t>08-11-2025</a:t>
             </a:fld>
             <a:endParaRPr lang="nl-NL"/>
           </a:p>
@@ -14274,7 +14279,7 @@
           <a:p>
             <a:fld id="{542F8156-3D1B-1047-9A3D-372BE84AD46C}" type="datetimeFigureOut">
               <a:rPr lang="nl-NL" smtClean="0"/>
-              <a:t>21-10-2025</a:t>
+              <a:t>08-11-2025</a:t>
             </a:fld>
             <a:endParaRPr lang="nl-NL"/>
           </a:p>
@@ -14542,7 +14547,7 @@
           <a:p>
             <a:fld id="{542F8156-3D1B-1047-9A3D-372BE84AD46C}" type="datetimeFigureOut">
               <a:rPr lang="nl-NL" smtClean="0"/>
-              <a:t>21-10-2025</a:t>
+              <a:t>08-11-2025</a:t>
             </a:fld>
             <a:endParaRPr lang="nl-NL"/>
           </a:p>
@@ -14957,7 +14962,7 @@
           <a:p>
             <a:fld id="{542F8156-3D1B-1047-9A3D-372BE84AD46C}" type="datetimeFigureOut">
               <a:rPr lang="nl-NL" smtClean="0"/>
-              <a:t>21-10-2025</a:t>
+              <a:t>08-11-2025</a:t>
             </a:fld>
             <a:endParaRPr lang="nl-NL"/>
           </a:p>
@@ -15099,7 +15104,7 @@
           <a:p>
             <a:fld id="{542F8156-3D1B-1047-9A3D-372BE84AD46C}" type="datetimeFigureOut">
               <a:rPr lang="nl-NL" smtClean="0"/>
-              <a:t>21-10-2025</a:t>
+              <a:t>08-11-2025</a:t>
             </a:fld>
             <a:endParaRPr lang="nl-NL"/>
           </a:p>
@@ -15212,7 +15217,7 @@
           <a:p>
             <a:fld id="{542F8156-3D1B-1047-9A3D-372BE84AD46C}" type="datetimeFigureOut">
               <a:rPr lang="nl-NL" smtClean="0"/>
-              <a:t>21-10-2025</a:t>
+              <a:t>08-11-2025</a:t>
             </a:fld>
             <a:endParaRPr lang="nl-NL"/>
           </a:p>
@@ -15525,7 +15530,7 @@
           <a:p>
             <a:fld id="{542F8156-3D1B-1047-9A3D-372BE84AD46C}" type="datetimeFigureOut">
               <a:rPr lang="nl-NL" smtClean="0"/>
-              <a:t>21-10-2025</a:t>
+              <a:t>08-11-2025</a:t>
             </a:fld>
             <a:endParaRPr lang="nl-NL"/>
           </a:p>
@@ -15814,7 +15819,7 @@
           <a:p>
             <a:fld id="{542F8156-3D1B-1047-9A3D-372BE84AD46C}" type="datetimeFigureOut">
               <a:rPr lang="nl-NL" smtClean="0"/>
-              <a:t>21-10-2025</a:t>
+              <a:t>08-11-2025</a:t>
             </a:fld>
             <a:endParaRPr lang="nl-NL"/>
           </a:p>
@@ -16057,7 +16062,7 @@
           <a:p>
             <a:fld id="{542F8156-3D1B-1047-9A3D-372BE84AD46C}" type="datetimeFigureOut">
               <a:rPr lang="nl-NL" smtClean="0"/>
-              <a:t>21-10-2025</a:t>
+              <a:t>08-11-2025</a:t>
             </a:fld>
             <a:endParaRPr lang="nl-NL"/>
           </a:p>
@@ -25107,7 +25112,31 @@
                   <a:schemeClr val="bg1"/>
                 </a:solidFill>
               </a:rPr>
-              <a:t>PORTFOLIO_PERIOD_SECURITY_DASHBOARD_MEDIUM_RESOLUTION_TIMES</a:t>
+              <a:t>PORTFOLIO_PERIOD_SECURITY_</a:t>
+            </a:r>
+            <a:r>
+              <a:rPr lang="en-US" sz="1600" err="1">
+                <a:solidFill>
+                  <a:schemeClr val="bg1"/>
+                </a:solidFill>
+              </a:rPr>
+              <a:t>DASHBOARD</a:t>
+            </a:r>
+            <a:r>
+              <a:rPr lang="en-US" sz="1600">
+                <a:solidFill>
+                  <a:schemeClr val="bg1"/>
+                </a:solidFill>
+              </a:rPr>
+              <a:t>_HIGH_</a:t>
+            </a:r>
+            <a:r>
+              <a:rPr lang="en-US" sz="1600" dirty="0" err="1">
+                <a:solidFill>
+                  <a:schemeClr val="bg1"/>
+                </a:solidFill>
+              </a:rPr>
+              <a:t>RESOLUTION_TIMES</a:t>
             </a:r>
             <a:endParaRPr lang="en-US" sz="1600" dirty="0">
               <a:solidFill>

</xml_diff>

<commit_message>
Update template with new placeholders
</commit_message>
<xml_diff>
--- a/src/report_generator/presets/templates/portfolio-overview.pptx
+++ b/src/report_generator/presets/templates/portfolio-overview.pptx
@@ -208,7 +208,7 @@
                 </a:outerShdw>
               </a:effectLst>
             </c:spPr>
-            <c:extLst xmlns:lc="http://schemas.openxmlformats.org/drawingml/2006/lockedCanvas" xmlns:comp="http://schemas.openxmlformats.org/drawingml/2006/compatibility" xmlns:we="http://schemas.microsoft.com/office/webextensions/webextension/2010/11" xmlns:wetp="http://schemas.microsoft.com/office/webextensions/taskpanes/2010/11" xmlns:w16cid="http://schemas.microsoft.com/office/word/2016/wordml/cid" xmlns:w16se="http://schemas.microsoft.com/office/word/2015/wordml/symex" xmlns:wps="http://schemas.microsoft.com/office/word/2010/wordprocessingShape" xmlns:b="http://schemas.openxmlformats.org/officeDocument/2006/bibliography" xmlns:odgm="http://opendope.org/SmartArt/DataHierarchy" xmlns:odi="http://opendope.org/components" xmlns:oda="http://opendope.org/answers" xmlns:odq="http://opendope.org/questions" xmlns:odc="http://opendope.org/conditions" xmlns:odx="http://opendope.org/xpaths" xmlns:cppr="http://schemas.microsoft.com/office/2006/coverPageProps" xmlns:pvml="urn:schemas-microsoft-com:office:powerpoint" xmlns:w10="urn:schemas-microsoft-com:office:word" xmlns:v="urn:schemas-microsoft-com:vml" xmlns:o="urn:schemas-microsoft-com:office:office" xmlns:xvml="urn:schemas-microsoft-com:office:excel" xmlns:dsp="http://schemas.microsoft.com/office/drawing/2008/diagram" xmlns:xdr="http://schemas.openxmlformats.org/drawingml/2006/spreadsheetDrawing" xmlns:pic="http://schemas.openxmlformats.org/drawingml/2006/picture" xmlns:dgm="http://schemas.openxmlformats.org/drawingml/2006/diagram" xmlns:c14="http://schemas.microsoft.com/office/drawing/2007/8/2/chart" xmlns:cdr="http://schemas.openxmlformats.org/drawingml/2006/chartDrawing" xmlns:wne="http://schemas.microsoft.com/office/word/2006/wordml" xmlns:sl="http://schemas.openxmlformats.org/schemaLibrary/2006/main" xmlns:mc="http://schemas.openxmlformats.org/markup-compatibility/2006" xmlns:wp14="http://schemas.microsoft.com/office/word/2010/wordprocessingDrawing" xmlns:wp="http://schemas.openxmlformats.org/drawingml/2006/wordprocessingDrawing" xmlns:m="http://schemas.openxmlformats.org/officeDocument/2006/math" xmlns:w14="http://schemas.microsoft.com/office/word/2010/wordml" xmlns:w15="http://schemas.microsoft.com/office/word/2012/wordml" xmlns:w="http://schemas.openxmlformats.org/wordprocessingml/2006/main">
+            <c:extLst xmlns:w="http://schemas.openxmlformats.org/wordprocessingml/2006/main" xmlns:w15="http://schemas.microsoft.com/office/word/2012/wordml" xmlns:w14="http://schemas.microsoft.com/office/word/2010/wordml" xmlns:m="http://schemas.openxmlformats.org/officeDocument/2006/math" xmlns:wp="http://schemas.openxmlformats.org/drawingml/2006/wordprocessingDrawing" xmlns:wp14="http://schemas.microsoft.com/office/word/2010/wordprocessingDrawing" xmlns:mc="http://schemas.openxmlformats.org/markup-compatibility/2006" xmlns:sl="http://schemas.openxmlformats.org/schemaLibrary/2006/main" xmlns:wne="http://schemas.microsoft.com/office/word/2006/wordml" xmlns:cdr="http://schemas.openxmlformats.org/drawingml/2006/chartDrawing" xmlns:c14="http://schemas.microsoft.com/office/drawing/2007/8/2/chart" xmlns:dgm="http://schemas.openxmlformats.org/drawingml/2006/diagram" xmlns:pic="http://schemas.openxmlformats.org/drawingml/2006/picture" xmlns:xdr="http://schemas.openxmlformats.org/drawingml/2006/spreadsheetDrawing" xmlns:dsp="http://schemas.microsoft.com/office/drawing/2008/diagram" xmlns:xvml="urn:schemas-microsoft-com:office:excel" xmlns:o="urn:schemas-microsoft-com:office:office" xmlns:v="urn:schemas-microsoft-com:vml" xmlns:w10="urn:schemas-microsoft-com:office:word" xmlns:pvml="urn:schemas-microsoft-com:office:powerpoint" xmlns:cppr="http://schemas.microsoft.com/office/2006/coverPageProps" xmlns:odx="http://opendope.org/xpaths" xmlns:odc="http://opendope.org/conditions" xmlns:odq="http://opendope.org/questions" xmlns:oda="http://opendope.org/answers" xmlns:odi="http://opendope.org/components" xmlns:odgm="http://opendope.org/SmartArt/DataHierarchy" xmlns:b="http://schemas.openxmlformats.org/officeDocument/2006/bibliography" xmlns:wps="http://schemas.microsoft.com/office/word/2010/wordprocessingShape" xmlns:w16se="http://schemas.microsoft.com/office/word/2015/wordml/symex" xmlns:w16cid="http://schemas.microsoft.com/office/word/2016/wordml/cid" xmlns:wetp="http://schemas.microsoft.com/office/webextensions/taskpanes/2010/11" xmlns:we="http://schemas.microsoft.com/office/webextensions/webextension/2010/11" xmlns:comp="http://schemas.openxmlformats.org/drawingml/2006/compatibility" xmlns:lc="http://schemas.openxmlformats.org/drawingml/2006/lockedCanvas">
               <c:ext xmlns:c16="http://schemas.microsoft.com/office/drawing/2014/chart" uri="{C3380CC4-5D6E-409C-BE32-E72D297353CC}">
                 <c16:uniqueId val="{00000001-6147-E74A-AA7B-5531F0E4EE0C}"/>
               </c:ext>
@@ -237,7 +237,7 @@
               </c:numCache>
             </c:numRef>
           </c:val>
-          <c:extLst xmlns:lc="http://schemas.openxmlformats.org/drawingml/2006/lockedCanvas" xmlns:comp="http://schemas.openxmlformats.org/drawingml/2006/compatibility" xmlns:we="http://schemas.microsoft.com/office/webextensions/webextension/2010/11" xmlns:wetp="http://schemas.microsoft.com/office/webextensions/taskpanes/2010/11" xmlns:w16cid="http://schemas.microsoft.com/office/word/2016/wordml/cid" xmlns:w16se="http://schemas.microsoft.com/office/word/2015/wordml/symex" xmlns:wps="http://schemas.microsoft.com/office/word/2010/wordprocessingShape" xmlns:b="http://schemas.openxmlformats.org/officeDocument/2006/bibliography" xmlns:odgm="http://opendope.org/SmartArt/DataHierarchy" xmlns:odi="http://opendope.org/components" xmlns:oda="http://opendope.org/answers" xmlns:odq="http://opendope.org/questions" xmlns:odc="http://opendope.org/conditions" xmlns:odx="http://opendope.org/xpaths" xmlns:cppr="http://schemas.microsoft.com/office/2006/coverPageProps" xmlns:pvml="urn:schemas-microsoft-com:office:powerpoint" xmlns:w10="urn:schemas-microsoft-com:office:word" xmlns:v="urn:schemas-microsoft-com:vml" xmlns:o="urn:schemas-microsoft-com:office:office" xmlns:xvml="urn:schemas-microsoft-com:office:excel" xmlns:dsp="http://schemas.microsoft.com/office/drawing/2008/diagram" xmlns:xdr="http://schemas.openxmlformats.org/drawingml/2006/spreadsheetDrawing" xmlns:pic="http://schemas.openxmlformats.org/drawingml/2006/picture" xmlns:dgm="http://schemas.openxmlformats.org/drawingml/2006/diagram" xmlns:c14="http://schemas.microsoft.com/office/drawing/2007/8/2/chart" xmlns:cdr="http://schemas.openxmlformats.org/drawingml/2006/chartDrawing" xmlns:wne="http://schemas.microsoft.com/office/word/2006/wordml" xmlns:sl="http://schemas.openxmlformats.org/schemaLibrary/2006/main" xmlns:mc="http://schemas.openxmlformats.org/markup-compatibility/2006" xmlns:wp14="http://schemas.microsoft.com/office/word/2010/wordprocessingDrawing" xmlns:wp="http://schemas.openxmlformats.org/drawingml/2006/wordprocessingDrawing" xmlns:m="http://schemas.openxmlformats.org/officeDocument/2006/math" xmlns:w14="http://schemas.microsoft.com/office/word/2010/wordml" xmlns:w15="http://schemas.microsoft.com/office/word/2012/wordml" xmlns:w="http://schemas.openxmlformats.org/wordprocessingml/2006/main">
+          <c:extLst xmlns:w="http://schemas.openxmlformats.org/wordprocessingml/2006/main" xmlns:w15="http://schemas.microsoft.com/office/word/2012/wordml" xmlns:w14="http://schemas.microsoft.com/office/word/2010/wordml" xmlns:m="http://schemas.openxmlformats.org/officeDocument/2006/math" xmlns:wp="http://schemas.openxmlformats.org/drawingml/2006/wordprocessingDrawing" xmlns:wp14="http://schemas.microsoft.com/office/word/2010/wordprocessingDrawing" xmlns:mc="http://schemas.openxmlformats.org/markup-compatibility/2006" xmlns:sl="http://schemas.openxmlformats.org/schemaLibrary/2006/main" xmlns:wne="http://schemas.microsoft.com/office/word/2006/wordml" xmlns:cdr="http://schemas.openxmlformats.org/drawingml/2006/chartDrawing" xmlns:c14="http://schemas.microsoft.com/office/drawing/2007/8/2/chart" xmlns:dgm="http://schemas.openxmlformats.org/drawingml/2006/diagram" xmlns:pic="http://schemas.openxmlformats.org/drawingml/2006/picture" xmlns:xdr="http://schemas.openxmlformats.org/drawingml/2006/spreadsheetDrawing" xmlns:dsp="http://schemas.microsoft.com/office/drawing/2008/diagram" xmlns:xvml="urn:schemas-microsoft-com:office:excel" xmlns:o="urn:schemas-microsoft-com:office:office" xmlns:v="urn:schemas-microsoft-com:vml" xmlns:w10="urn:schemas-microsoft-com:office:word" xmlns:pvml="urn:schemas-microsoft-com:office:powerpoint" xmlns:cppr="http://schemas.microsoft.com/office/2006/coverPageProps" xmlns:odx="http://opendope.org/xpaths" xmlns:odc="http://opendope.org/conditions" xmlns:odq="http://opendope.org/questions" xmlns:oda="http://opendope.org/answers" xmlns:odi="http://opendope.org/components" xmlns:odgm="http://opendope.org/SmartArt/DataHierarchy" xmlns:b="http://schemas.openxmlformats.org/officeDocument/2006/bibliography" xmlns:wps="http://schemas.microsoft.com/office/word/2010/wordprocessingShape" xmlns:w16se="http://schemas.microsoft.com/office/word/2015/wordml/symex" xmlns:w16cid="http://schemas.microsoft.com/office/word/2016/wordml/cid" xmlns:wetp="http://schemas.microsoft.com/office/webextensions/taskpanes/2010/11" xmlns:we="http://schemas.microsoft.com/office/webextensions/webextension/2010/11" xmlns:comp="http://schemas.openxmlformats.org/drawingml/2006/compatibility" xmlns:lc="http://schemas.openxmlformats.org/drawingml/2006/lockedCanvas">
             <c:ext xmlns:c16="http://schemas.microsoft.com/office/drawing/2014/chart" uri="{C3380CC4-5D6E-409C-BE32-E72D297353CC}">
               <c16:uniqueId val="{00000002-6147-E74A-AA7B-5531F0E4EE0C}"/>
             </c:ext>
@@ -554,7 +554,7 @@
     <c:plotVisOnly val="1"/>
     <c:dispBlanksAs val="gap"/>
     <c:showDLblsOverMax val="0"/>
-    <c:extLst xmlns:lc="http://schemas.openxmlformats.org/drawingml/2006/lockedCanvas" xmlns:comp="http://schemas.openxmlformats.org/drawingml/2006/compatibility" xmlns:we="http://schemas.microsoft.com/office/webextensions/webextension/2010/11" xmlns:wetp="http://schemas.microsoft.com/office/webextensions/taskpanes/2010/11" xmlns:w16cid="http://schemas.microsoft.com/office/word/2016/wordml/cid" xmlns:w16se="http://schemas.microsoft.com/office/word/2015/wordml/symex" xmlns:wps="http://schemas.microsoft.com/office/word/2010/wordprocessingShape" xmlns:b="http://schemas.openxmlformats.org/officeDocument/2006/bibliography" xmlns:odgm="http://opendope.org/SmartArt/DataHierarchy" xmlns:odi="http://opendope.org/components" xmlns:oda="http://opendope.org/answers" xmlns:odq="http://opendope.org/questions" xmlns:odc="http://opendope.org/conditions" xmlns:odx="http://opendope.org/xpaths" xmlns:cppr="http://schemas.microsoft.com/office/2006/coverPageProps" xmlns:pvml="urn:schemas-microsoft-com:office:powerpoint" xmlns:w10="urn:schemas-microsoft-com:office:word" xmlns:v="urn:schemas-microsoft-com:vml" xmlns:o="urn:schemas-microsoft-com:office:office" xmlns:xvml="urn:schemas-microsoft-com:office:excel" xmlns:dsp="http://schemas.microsoft.com/office/drawing/2008/diagram" xmlns:xdr="http://schemas.openxmlformats.org/drawingml/2006/spreadsheetDrawing" xmlns:pic="http://schemas.openxmlformats.org/drawingml/2006/picture" xmlns:dgm="http://schemas.openxmlformats.org/drawingml/2006/diagram" xmlns:c14="http://schemas.microsoft.com/office/drawing/2007/8/2/chart" xmlns:cdr="http://schemas.openxmlformats.org/drawingml/2006/chartDrawing" xmlns:wne="http://schemas.microsoft.com/office/word/2006/wordml" xmlns:sl="http://schemas.openxmlformats.org/schemaLibrary/2006/main" xmlns:mc="http://schemas.openxmlformats.org/markup-compatibility/2006" xmlns:wp14="http://schemas.microsoft.com/office/word/2010/wordprocessingDrawing" xmlns:wp="http://schemas.openxmlformats.org/drawingml/2006/wordprocessingDrawing" xmlns:m="http://schemas.openxmlformats.org/officeDocument/2006/math" xmlns:w14="http://schemas.microsoft.com/office/word/2010/wordml" xmlns:w15="http://schemas.microsoft.com/office/word/2012/wordml" xmlns:w="http://schemas.openxmlformats.org/wordprocessingml/2006/main">
+    <c:extLst xmlns:w="http://schemas.openxmlformats.org/wordprocessingml/2006/main" xmlns:w15="http://schemas.microsoft.com/office/word/2012/wordml" xmlns:w14="http://schemas.microsoft.com/office/word/2010/wordml" xmlns:m="http://schemas.openxmlformats.org/officeDocument/2006/math" xmlns:wp="http://schemas.openxmlformats.org/drawingml/2006/wordprocessingDrawing" xmlns:wp14="http://schemas.microsoft.com/office/word/2010/wordprocessingDrawing" xmlns:mc="http://schemas.openxmlformats.org/markup-compatibility/2006" xmlns:sl="http://schemas.openxmlformats.org/schemaLibrary/2006/main" xmlns:wne="http://schemas.microsoft.com/office/word/2006/wordml" xmlns:cdr="http://schemas.openxmlformats.org/drawingml/2006/chartDrawing" xmlns:c14="http://schemas.microsoft.com/office/drawing/2007/8/2/chart" xmlns:dgm="http://schemas.openxmlformats.org/drawingml/2006/diagram" xmlns:pic="http://schemas.openxmlformats.org/drawingml/2006/picture" xmlns:xdr="http://schemas.openxmlformats.org/drawingml/2006/spreadsheetDrawing" xmlns:dsp="http://schemas.microsoft.com/office/drawing/2008/diagram" xmlns:xvml="urn:schemas-microsoft-com:office:excel" xmlns:o="urn:schemas-microsoft-com:office:office" xmlns:v="urn:schemas-microsoft-com:vml" xmlns:w10="urn:schemas-microsoft-com:office:word" xmlns:pvml="urn:schemas-microsoft-com:office:powerpoint" xmlns:cppr="http://schemas.microsoft.com/office/2006/coverPageProps" xmlns:odx="http://opendope.org/xpaths" xmlns:odc="http://opendope.org/conditions" xmlns:odq="http://opendope.org/questions" xmlns:oda="http://opendope.org/answers" xmlns:odi="http://opendope.org/components" xmlns:odgm="http://opendope.org/SmartArt/DataHierarchy" xmlns:b="http://schemas.openxmlformats.org/officeDocument/2006/bibliography" xmlns:wps="http://schemas.microsoft.com/office/word/2010/wordprocessingShape" xmlns:w16se="http://schemas.microsoft.com/office/word/2015/wordml/symex" xmlns:w16cid="http://schemas.microsoft.com/office/word/2016/wordml/cid" xmlns:wetp="http://schemas.microsoft.com/office/webextensions/taskpanes/2010/11" xmlns:we="http://schemas.microsoft.com/office/webextensions/webextension/2010/11" xmlns:comp="http://schemas.openxmlformats.org/drawingml/2006/compatibility" xmlns:lc="http://schemas.openxmlformats.org/drawingml/2006/lockedCanvas">
       <c:ext xmlns:c16r3="http://schemas.microsoft.com/office/drawing/2017/03/chart" uri="{56B9EC1D-385E-4148-901F-78D8002777C0}">
         <c16r3:dataDisplayOptions16>
           <c16r3:dispNaAsBlank val="1"/>
@@ -656,7 +656,7 @@
                 </a:outerShdw>
               </a:effectLst>
             </c:spPr>
-            <c:extLst xmlns:w="http://schemas.openxmlformats.org/wordprocessingml/2006/main" xmlns:w15="http://schemas.microsoft.com/office/word/2012/wordml" xmlns:w14="http://schemas.microsoft.com/office/word/2010/wordml" xmlns:m="http://schemas.openxmlformats.org/officeDocument/2006/math" xmlns:wp="http://schemas.openxmlformats.org/drawingml/2006/wordprocessingDrawing" xmlns:wp14="http://schemas.microsoft.com/office/word/2010/wordprocessingDrawing" xmlns:mc="http://schemas.openxmlformats.org/markup-compatibility/2006" xmlns:sl="http://schemas.openxmlformats.org/schemaLibrary/2006/main" xmlns:wne="http://schemas.microsoft.com/office/word/2006/wordml" xmlns:cdr="http://schemas.openxmlformats.org/drawingml/2006/chartDrawing" xmlns:c14="http://schemas.microsoft.com/office/drawing/2007/8/2/chart" xmlns:dgm="http://schemas.openxmlformats.org/drawingml/2006/diagram" xmlns:pic="http://schemas.openxmlformats.org/drawingml/2006/picture" xmlns:xdr="http://schemas.openxmlformats.org/drawingml/2006/spreadsheetDrawing" xmlns:dsp="http://schemas.microsoft.com/office/drawing/2008/diagram" xmlns:xvml="urn:schemas-microsoft-com:office:excel" xmlns:o="urn:schemas-microsoft-com:office:office" xmlns:v="urn:schemas-microsoft-com:vml" xmlns:w10="urn:schemas-microsoft-com:office:word" xmlns:pvml="urn:schemas-microsoft-com:office:powerpoint" xmlns:cppr="http://schemas.microsoft.com/office/2006/coverPageProps" xmlns:odx="http://opendope.org/xpaths" xmlns:odc="http://opendope.org/conditions" xmlns:odq="http://opendope.org/questions" xmlns:oda="http://opendope.org/answers" xmlns:odi="http://opendope.org/components" xmlns:odgm="http://opendope.org/SmartArt/DataHierarchy" xmlns:b="http://schemas.openxmlformats.org/officeDocument/2006/bibliography" xmlns:wps="http://schemas.microsoft.com/office/word/2010/wordprocessingShape" xmlns:w16se="http://schemas.microsoft.com/office/word/2015/wordml/symex" xmlns:w16cid="http://schemas.microsoft.com/office/word/2016/wordml/cid" xmlns:wetp="http://schemas.microsoft.com/office/webextensions/taskpanes/2010/11" xmlns:we="http://schemas.microsoft.com/office/webextensions/webextension/2010/11" xmlns:comp="http://schemas.openxmlformats.org/drawingml/2006/compatibility" xmlns:lc="http://schemas.openxmlformats.org/drawingml/2006/lockedCanvas">
+            <c:extLst xmlns:lc="http://schemas.openxmlformats.org/drawingml/2006/lockedCanvas" xmlns:comp="http://schemas.openxmlformats.org/drawingml/2006/compatibility" xmlns:we="http://schemas.microsoft.com/office/webextensions/webextension/2010/11" xmlns:wetp="http://schemas.microsoft.com/office/webextensions/taskpanes/2010/11" xmlns:w16cid="http://schemas.microsoft.com/office/word/2016/wordml/cid" xmlns:w16se="http://schemas.microsoft.com/office/word/2015/wordml/symex" xmlns:wps="http://schemas.microsoft.com/office/word/2010/wordprocessingShape" xmlns:b="http://schemas.openxmlformats.org/officeDocument/2006/bibliography" xmlns:odgm="http://opendope.org/SmartArt/DataHierarchy" xmlns:odi="http://opendope.org/components" xmlns:oda="http://opendope.org/answers" xmlns:odq="http://opendope.org/questions" xmlns:odc="http://opendope.org/conditions" xmlns:odx="http://opendope.org/xpaths" xmlns:cppr="http://schemas.microsoft.com/office/2006/coverPageProps" xmlns:pvml="urn:schemas-microsoft-com:office:powerpoint" xmlns:w10="urn:schemas-microsoft-com:office:word" xmlns:v="urn:schemas-microsoft-com:vml" xmlns:o="urn:schemas-microsoft-com:office:office" xmlns:xvml="urn:schemas-microsoft-com:office:excel" xmlns:dsp="http://schemas.microsoft.com/office/drawing/2008/diagram" xmlns:xdr="http://schemas.openxmlformats.org/drawingml/2006/spreadsheetDrawing" xmlns:pic="http://schemas.openxmlformats.org/drawingml/2006/picture" xmlns:dgm="http://schemas.openxmlformats.org/drawingml/2006/diagram" xmlns:c14="http://schemas.microsoft.com/office/drawing/2007/8/2/chart" xmlns:cdr="http://schemas.openxmlformats.org/drawingml/2006/chartDrawing" xmlns:wne="http://schemas.microsoft.com/office/word/2006/wordml" xmlns:sl="http://schemas.openxmlformats.org/schemaLibrary/2006/main" xmlns:mc="http://schemas.openxmlformats.org/markup-compatibility/2006" xmlns:wp14="http://schemas.microsoft.com/office/word/2010/wordprocessingDrawing" xmlns:wp="http://schemas.openxmlformats.org/drawingml/2006/wordprocessingDrawing" xmlns:m="http://schemas.openxmlformats.org/officeDocument/2006/math" xmlns:w14="http://schemas.microsoft.com/office/word/2010/wordml" xmlns:w15="http://schemas.microsoft.com/office/word/2012/wordml" xmlns:w="http://schemas.openxmlformats.org/wordprocessingml/2006/main">
               <c:ext xmlns:c16="http://schemas.microsoft.com/office/drawing/2014/chart" uri="{C3380CC4-5D6E-409C-BE32-E72D297353CC}">
                 <c16:uniqueId val="{00000001-6147-E74A-AA7B-5531F0E4EE0C}"/>
               </c:ext>
@@ -739,7 +739,7 @@
               </c:numCache>
             </c:numRef>
           </c:val>
-          <c:extLst xmlns:w="http://schemas.openxmlformats.org/wordprocessingml/2006/main" xmlns:w15="http://schemas.microsoft.com/office/word/2012/wordml" xmlns:w14="http://schemas.microsoft.com/office/word/2010/wordml" xmlns:m="http://schemas.openxmlformats.org/officeDocument/2006/math" xmlns:wp="http://schemas.openxmlformats.org/drawingml/2006/wordprocessingDrawing" xmlns:wp14="http://schemas.microsoft.com/office/word/2010/wordprocessingDrawing" xmlns:mc="http://schemas.openxmlformats.org/markup-compatibility/2006" xmlns:sl="http://schemas.openxmlformats.org/schemaLibrary/2006/main" xmlns:wne="http://schemas.microsoft.com/office/word/2006/wordml" xmlns:cdr="http://schemas.openxmlformats.org/drawingml/2006/chartDrawing" xmlns:c14="http://schemas.microsoft.com/office/drawing/2007/8/2/chart" xmlns:dgm="http://schemas.openxmlformats.org/drawingml/2006/diagram" xmlns:pic="http://schemas.openxmlformats.org/drawingml/2006/picture" xmlns:xdr="http://schemas.openxmlformats.org/drawingml/2006/spreadsheetDrawing" xmlns:dsp="http://schemas.microsoft.com/office/drawing/2008/diagram" xmlns:xvml="urn:schemas-microsoft-com:office:excel" xmlns:o="urn:schemas-microsoft-com:office:office" xmlns:v="urn:schemas-microsoft-com:vml" xmlns:w10="urn:schemas-microsoft-com:office:word" xmlns:pvml="urn:schemas-microsoft-com:office:powerpoint" xmlns:cppr="http://schemas.microsoft.com/office/2006/coverPageProps" xmlns:odx="http://opendope.org/xpaths" xmlns:odc="http://opendope.org/conditions" xmlns:odq="http://opendope.org/questions" xmlns:oda="http://opendope.org/answers" xmlns:odi="http://opendope.org/components" xmlns:odgm="http://opendope.org/SmartArt/DataHierarchy" xmlns:b="http://schemas.openxmlformats.org/officeDocument/2006/bibliography" xmlns:wps="http://schemas.microsoft.com/office/word/2010/wordprocessingShape" xmlns:w16se="http://schemas.microsoft.com/office/word/2015/wordml/symex" xmlns:w16cid="http://schemas.microsoft.com/office/word/2016/wordml/cid" xmlns:wetp="http://schemas.microsoft.com/office/webextensions/taskpanes/2010/11" xmlns:we="http://schemas.microsoft.com/office/webextensions/webextension/2010/11" xmlns:comp="http://schemas.openxmlformats.org/drawingml/2006/compatibility" xmlns:lc="http://schemas.openxmlformats.org/drawingml/2006/lockedCanvas">
+          <c:extLst xmlns:lc="http://schemas.openxmlformats.org/drawingml/2006/lockedCanvas" xmlns:comp="http://schemas.openxmlformats.org/drawingml/2006/compatibility" xmlns:we="http://schemas.microsoft.com/office/webextensions/webextension/2010/11" xmlns:wetp="http://schemas.microsoft.com/office/webextensions/taskpanes/2010/11" xmlns:w16cid="http://schemas.microsoft.com/office/word/2016/wordml/cid" xmlns:w16se="http://schemas.microsoft.com/office/word/2015/wordml/symex" xmlns:wps="http://schemas.microsoft.com/office/word/2010/wordprocessingShape" xmlns:b="http://schemas.openxmlformats.org/officeDocument/2006/bibliography" xmlns:odgm="http://opendope.org/SmartArt/DataHierarchy" xmlns:odi="http://opendope.org/components" xmlns:oda="http://opendope.org/answers" xmlns:odq="http://opendope.org/questions" xmlns:odc="http://opendope.org/conditions" xmlns:odx="http://opendope.org/xpaths" xmlns:cppr="http://schemas.microsoft.com/office/2006/coverPageProps" xmlns:pvml="urn:schemas-microsoft-com:office:powerpoint" xmlns:w10="urn:schemas-microsoft-com:office:word" xmlns:v="urn:schemas-microsoft-com:vml" xmlns:o="urn:schemas-microsoft-com:office:office" xmlns:xvml="urn:schemas-microsoft-com:office:excel" xmlns:dsp="http://schemas.microsoft.com/office/drawing/2008/diagram" xmlns:xdr="http://schemas.openxmlformats.org/drawingml/2006/spreadsheetDrawing" xmlns:pic="http://schemas.openxmlformats.org/drawingml/2006/picture" xmlns:dgm="http://schemas.openxmlformats.org/drawingml/2006/diagram" xmlns:c14="http://schemas.microsoft.com/office/drawing/2007/8/2/chart" xmlns:cdr="http://schemas.openxmlformats.org/drawingml/2006/chartDrawing" xmlns:wne="http://schemas.microsoft.com/office/word/2006/wordml" xmlns:sl="http://schemas.openxmlformats.org/schemaLibrary/2006/main" xmlns:mc="http://schemas.openxmlformats.org/markup-compatibility/2006" xmlns:wp14="http://schemas.microsoft.com/office/word/2010/wordprocessingDrawing" xmlns:wp="http://schemas.openxmlformats.org/drawingml/2006/wordprocessingDrawing" xmlns:m="http://schemas.openxmlformats.org/officeDocument/2006/math" xmlns:w14="http://schemas.microsoft.com/office/word/2010/wordml" xmlns:w15="http://schemas.microsoft.com/office/word/2012/wordml" xmlns:w="http://schemas.openxmlformats.org/wordprocessingml/2006/main">
             <c:ext xmlns:c16="http://schemas.microsoft.com/office/drawing/2014/chart" uri="{C3380CC4-5D6E-409C-BE32-E72D297353CC}">
               <c16:uniqueId val="{00000002-6147-E74A-AA7B-5531F0E4EE0C}"/>
             </c:ext>
@@ -1302,7 +1302,7 @@
     <c:plotVisOnly val="1"/>
     <c:dispBlanksAs val="gap"/>
     <c:showDLblsOverMax val="0"/>
-    <c:extLst xmlns:w="http://schemas.openxmlformats.org/wordprocessingml/2006/main" xmlns:w15="http://schemas.microsoft.com/office/word/2012/wordml" xmlns:w14="http://schemas.microsoft.com/office/word/2010/wordml" xmlns:m="http://schemas.openxmlformats.org/officeDocument/2006/math" xmlns:wp="http://schemas.openxmlformats.org/drawingml/2006/wordprocessingDrawing" xmlns:wp14="http://schemas.microsoft.com/office/word/2010/wordprocessingDrawing" xmlns:mc="http://schemas.openxmlformats.org/markup-compatibility/2006" xmlns:sl="http://schemas.openxmlformats.org/schemaLibrary/2006/main" xmlns:wne="http://schemas.microsoft.com/office/word/2006/wordml" xmlns:cdr="http://schemas.openxmlformats.org/drawingml/2006/chartDrawing" xmlns:c14="http://schemas.microsoft.com/office/drawing/2007/8/2/chart" xmlns:dgm="http://schemas.openxmlformats.org/drawingml/2006/diagram" xmlns:pic="http://schemas.openxmlformats.org/drawingml/2006/picture" xmlns:xdr="http://schemas.openxmlformats.org/drawingml/2006/spreadsheetDrawing" xmlns:dsp="http://schemas.microsoft.com/office/drawing/2008/diagram" xmlns:xvml="urn:schemas-microsoft-com:office:excel" xmlns:o="urn:schemas-microsoft-com:office:office" xmlns:v="urn:schemas-microsoft-com:vml" xmlns:w10="urn:schemas-microsoft-com:office:word" xmlns:pvml="urn:schemas-microsoft-com:office:powerpoint" xmlns:cppr="http://schemas.microsoft.com/office/2006/coverPageProps" xmlns:odx="http://opendope.org/xpaths" xmlns:odc="http://opendope.org/conditions" xmlns:odq="http://opendope.org/questions" xmlns:oda="http://opendope.org/answers" xmlns:odi="http://opendope.org/components" xmlns:odgm="http://opendope.org/SmartArt/DataHierarchy" xmlns:b="http://schemas.openxmlformats.org/officeDocument/2006/bibliography" xmlns:wps="http://schemas.microsoft.com/office/word/2010/wordprocessingShape" xmlns:w16se="http://schemas.microsoft.com/office/word/2015/wordml/symex" xmlns:w16cid="http://schemas.microsoft.com/office/word/2016/wordml/cid" xmlns:wetp="http://schemas.microsoft.com/office/webextensions/taskpanes/2010/11" xmlns:we="http://schemas.microsoft.com/office/webextensions/webextension/2010/11" xmlns:comp="http://schemas.openxmlformats.org/drawingml/2006/compatibility" xmlns:lc="http://schemas.openxmlformats.org/drawingml/2006/lockedCanvas">
+    <c:extLst xmlns:lc="http://schemas.openxmlformats.org/drawingml/2006/lockedCanvas" xmlns:comp="http://schemas.openxmlformats.org/drawingml/2006/compatibility" xmlns:we="http://schemas.microsoft.com/office/webextensions/webextension/2010/11" xmlns:wetp="http://schemas.microsoft.com/office/webextensions/taskpanes/2010/11" xmlns:w16cid="http://schemas.microsoft.com/office/word/2016/wordml/cid" xmlns:w16se="http://schemas.microsoft.com/office/word/2015/wordml/symex" xmlns:wps="http://schemas.microsoft.com/office/word/2010/wordprocessingShape" xmlns:b="http://schemas.openxmlformats.org/officeDocument/2006/bibliography" xmlns:odgm="http://opendope.org/SmartArt/DataHierarchy" xmlns:odi="http://opendope.org/components" xmlns:oda="http://opendope.org/answers" xmlns:odq="http://opendope.org/questions" xmlns:odc="http://opendope.org/conditions" xmlns:odx="http://opendope.org/xpaths" xmlns:cppr="http://schemas.microsoft.com/office/2006/coverPageProps" xmlns:pvml="urn:schemas-microsoft-com:office:powerpoint" xmlns:w10="urn:schemas-microsoft-com:office:word" xmlns:v="urn:schemas-microsoft-com:vml" xmlns:o="urn:schemas-microsoft-com:office:office" xmlns:xvml="urn:schemas-microsoft-com:office:excel" xmlns:dsp="http://schemas.microsoft.com/office/drawing/2008/diagram" xmlns:xdr="http://schemas.openxmlformats.org/drawingml/2006/spreadsheetDrawing" xmlns:pic="http://schemas.openxmlformats.org/drawingml/2006/picture" xmlns:dgm="http://schemas.openxmlformats.org/drawingml/2006/diagram" xmlns:c14="http://schemas.microsoft.com/office/drawing/2007/8/2/chart" xmlns:cdr="http://schemas.openxmlformats.org/drawingml/2006/chartDrawing" xmlns:wne="http://schemas.microsoft.com/office/word/2006/wordml" xmlns:sl="http://schemas.openxmlformats.org/schemaLibrary/2006/main" xmlns:mc="http://schemas.openxmlformats.org/markup-compatibility/2006" xmlns:wp14="http://schemas.microsoft.com/office/word/2010/wordprocessingDrawing" xmlns:wp="http://schemas.openxmlformats.org/drawingml/2006/wordprocessingDrawing" xmlns:m="http://schemas.openxmlformats.org/officeDocument/2006/math" xmlns:w14="http://schemas.microsoft.com/office/word/2010/wordml" xmlns:w15="http://schemas.microsoft.com/office/word/2012/wordml" xmlns:w="http://schemas.openxmlformats.org/wordprocessingml/2006/main">
       <c:ext xmlns:c16r3="http://schemas.microsoft.com/office/drawing/2017/03/chart" uri="{56B9EC1D-385E-4148-901F-78D8002777C0}">
         <c16r3:dataDisplayOptions16>
           <c16r3:dispNaAsBlank val="1"/>
@@ -1404,7 +1404,7 @@
                 </a:outerShdw>
               </a:effectLst>
             </c:spPr>
-            <c:extLst xmlns:lc="http://schemas.openxmlformats.org/drawingml/2006/lockedCanvas" xmlns:comp="http://schemas.openxmlformats.org/drawingml/2006/compatibility" xmlns:we="http://schemas.microsoft.com/office/webextensions/webextension/2010/11" xmlns:wetp="http://schemas.microsoft.com/office/webextensions/taskpanes/2010/11" xmlns:w16cid="http://schemas.microsoft.com/office/word/2016/wordml/cid" xmlns:w16se="http://schemas.microsoft.com/office/word/2015/wordml/symex" xmlns:wps="http://schemas.microsoft.com/office/word/2010/wordprocessingShape" xmlns:b="http://schemas.openxmlformats.org/officeDocument/2006/bibliography" xmlns:odgm="http://opendope.org/SmartArt/DataHierarchy" xmlns:odi="http://opendope.org/components" xmlns:oda="http://opendope.org/answers" xmlns:odq="http://opendope.org/questions" xmlns:odc="http://opendope.org/conditions" xmlns:odx="http://opendope.org/xpaths" xmlns:cppr="http://schemas.microsoft.com/office/2006/coverPageProps" xmlns:pvml="urn:schemas-microsoft-com:office:powerpoint" xmlns:w10="urn:schemas-microsoft-com:office:word" xmlns:v="urn:schemas-microsoft-com:vml" xmlns:o="urn:schemas-microsoft-com:office:office" xmlns:xvml="urn:schemas-microsoft-com:office:excel" xmlns:dsp="http://schemas.microsoft.com/office/drawing/2008/diagram" xmlns:xdr="http://schemas.openxmlformats.org/drawingml/2006/spreadsheetDrawing" xmlns:pic="http://schemas.openxmlformats.org/drawingml/2006/picture" xmlns:dgm="http://schemas.openxmlformats.org/drawingml/2006/diagram" xmlns:c14="http://schemas.microsoft.com/office/drawing/2007/8/2/chart" xmlns:cdr="http://schemas.openxmlformats.org/drawingml/2006/chartDrawing" xmlns:wne="http://schemas.microsoft.com/office/word/2006/wordml" xmlns:sl="http://schemas.openxmlformats.org/schemaLibrary/2006/main" xmlns:mc="http://schemas.openxmlformats.org/markup-compatibility/2006" xmlns:wp14="http://schemas.microsoft.com/office/word/2010/wordprocessingDrawing" xmlns:wp="http://schemas.openxmlformats.org/drawingml/2006/wordprocessingDrawing" xmlns:m="http://schemas.openxmlformats.org/officeDocument/2006/math" xmlns:w14="http://schemas.microsoft.com/office/word/2010/wordml" xmlns:w15="http://schemas.microsoft.com/office/word/2012/wordml" xmlns:w="http://schemas.openxmlformats.org/wordprocessingml/2006/main">
+            <c:extLst xmlns:w="http://schemas.openxmlformats.org/wordprocessingml/2006/main" xmlns:w15="http://schemas.microsoft.com/office/word/2012/wordml" xmlns:w14="http://schemas.microsoft.com/office/word/2010/wordml" xmlns:m="http://schemas.openxmlformats.org/officeDocument/2006/math" xmlns:wp="http://schemas.openxmlformats.org/drawingml/2006/wordprocessingDrawing" xmlns:wp14="http://schemas.microsoft.com/office/word/2010/wordprocessingDrawing" xmlns:mc="http://schemas.openxmlformats.org/markup-compatibility/2006" xmlns:sl="http://schemas.openxmlformats.org/schemaLibrary/2006/main" xmlns:wne="http://schemas.microsoft.com/office/word/2006/wordml" xmlns:cdr="http://schemas.openxmlformats.org/drawingml/2006/chartDrawing" xmlns:c14="http://schemas.microsoft.com/office/drawing/2007/8/2/chart" xmlns:dgm="http://schemas.openxmlformats.org/drawingml/2006/diagram" xmlns:pic="http://schemas.openxmlformats.org/drawingml/2006/picture" xmlns:xdr="http://schemas.openxmlformats.org/drawingml/2006/spreadsheetDrawing" xmlns:dsp="http://schemas.microsoft.com/office/drawing/2008/diagram" xmlns:xvml="urn:schemas-microsoft-com:office:excel" xmlns:o="urn:schemas-microsoft-com:office:office" xmlns:v="urn:schemas-microsoft-com:vml" xmlns:w10="urn:schemas-microsoft-com:office:word" xmlns:pvml="urn:schemas-microsoft-com:office:powerpoint" xmlns:cppr="http://schemas.microsoft.com/office/2006/coverPageProps" xmlns:odx="http://opendope.org/xpaths" xmlns:odc="http://opendope.org/conditions" xmlns:odq="http://opendope.org/questions" xmlns:oda="http://opendope.org/answers" xmlns:odi="http://opendope.org/components" xmlns:odgm="http://opendope.org/SmartArt/DataHierarchy" xmlns:b="http://schemas.openxmlformats.org/officeDocument/2006/bibliography" xmlns:wps="http://schemas.microsoft.com/office/word/2010/wordprocessingShape" xmlns:w16se="http://schemas.microsoft.com/office/word/2015/wordml/symex" xmlns:w16cid="http://schemas.microsoft.com/office/word/2016/wordml/cid" xmlns:wetp="http://schemas.microsoft.com/office/webextensions/taskpanes/2010/11" xmlns:we="http://schemas.microsoft.com/office/webextensions/webextension/2010/11" xmlns:comp="http://schemas.openxmlformats.org/drawingml/2006/compatibility" xmlns:lc="http://schemas.openxmlformats.org/drawingml/2006/lockedCanvas">
               <c:ext xmlns:c16="http://schemas.microsoft.com/office/drawing/2014/chart" uri="{C3380CC4-5D6E-409C-BE32-E72D297353CC}">
                 <c16:uniqueId val="{00000001-6147-E74A-AA7B-5531F0E4EE0C}"/>
               </c:ext>
@@ -1487,7 +1487,7 @@
               </c:numCache>
             </c:numRef>
           </c:val>
-          <c:extLst xmlns:lc="http://schemas.openxmlformats.org/drawingml/2006/lockedCanvas" xmlns:comp="http://schemas.openxmlformats.org/drawingml/2006/compatibility" xmlns:we="http://schemas.microsoft.com/office/webextensions/webextension/2010/11" xmlns:wetp="http://schemas.microsoft.com/office/webextensions/taskpanes/2010/11" xmlns:w16cid="http://schemas.microsoft.com/office/word/2016/wordml/cid" xmlns:w16se="http://schemas.microsoft.com/office/word/2015/wordml/symex" xmlns:wps="http://schemas.microsoft.com/office/word/2010/wordprocessingShape" xmlns:b="http://schemas.openxmlformats.org/officeDocument/2006/bibliography" xmlns:odgm="http://opendope.org/SmartArt/DataHierarchy" xmlns:odi="http://opendope.org/components" xmlns:oda="http://opendope.org/answers" xmlns:odq="http://opendope.org/questions" xmlns:odc="http://opendope.org/conditions" xmlns:odx="http://opendope.org/xpaths" xmlns:cppr="http://schemas.microsoft.com/office/2006/coverPageProps" xmlns:pvml="urn:schemas-microsoft-com:office:powerpoint" xmlns:w10="urn:schemas-microsoft-com:office:word" xmlns:v="urn:schemas-microsoft-com:vml" xmlns:o="urn:schemas-microsoft-com:office:office" xmlns:xvml="urn:schemas-microsoft-com:office:excel" xmlns:dsp="http://schemas.microsoft.com/office/drawing/2008/diagram" xmlns:xdr="http://schemas.openxmlformats.org/drawingml/2006/spreadsheetDrawing" xmlns:pic="http://schemas.openxmlformats.org/drawingml/2006/picture" xmlns:dgm="http://schemas.openxmlformats.org/drawingml/2006/diagram" xmlns:c14="http://schemas.microsoft.com/office/drawing/2007/8/2/chart" xmlns:cdr="http://schemas.openxmlformats.org/drawingml/2006/chartDrawing" xmlns:wne="http://schemas.microsoft.com/office/word/2006/wordml" xmlns:sl="http://schemas.openxmlformats.org/schemaLibrary/2006/main" xmlns:mc="http://schemas.openxmlformats.org/markup-compatibility/2006" xmlns:wp14="http://schemas.microsoft.com/office/word/2010/wordprocessingDrawing" xmlns:wp="http://schemas.openxmlformats.org/drawingml/2006/wordprocessingDrawing" xmlns:m="http://schemas.openxmlformats.org/officeDocument/2006/math" xmlns:w14="http://schemas.microsoft.com/office/word/2010/wordml" xmlns:w15="http://schemas.microsoft.com/office/word/2012/wordml" xmlns:w="http://schemas.openxmlformats.org/wordprocessingml/2006/main">
+          <c:extLst xmlns:w="http://schemas.openxmlformats.org/wordprocessingml/2006/main" xmlns:w15="http://schemas.microsoft.com/office/word/2012/wordml" xmlns:w14="http://schemas.microsoft.com/office/word/2010/wordml" xmlns:m="http://schemas.openxmlformats.org/officeDocument/2006/math" xmlns:wp="http://schemas.openxmlformats.org/drawingml/2006/wordprocessingDrawing" xmlns:wp14="http://schemas.microsoft.com/office/word/2010/wordprocessingDrawing" xmlns:mc="http://schemas.openxmlformats.org/markup-compatibility/2006" xmlns:sl="http://schemas.openxmlformats.org/schemaLibrary/2006/main" xmlns:wne="http://schemas.microsoft.com/office/word/2006/wordml" xmlns:cdr="http://schemas.openxmlformats.org/drawingml/2006/chartDrawing" xmlns:c14="http://schemas.microsoft.com/office/drawing/2007/8/2/chart" xmlns:dgm="http://schemas.openxmlformats.org/drawingml/2006/diagram" xmlns:pic="http://schemas.openxmlformats.org/drawingml/2006/picture" xmlns:xdr="http://schemas.openxmlformats.org/drawingml/2006/spreadsheetDrawing" xmlns:dsp="http://schemas.microsoft.com/office/drawing/2008/diagram" xmlns:xvml="urn:schemas-microsoft-com:office:excel" xmlns:o="urn:schemas-microsoft-com:office:office" xmlns:v="urn:schemas-microsoft-com:vml" xmlns:w10="urn:schemas-microsoft-com:office:word" xmlns:pvml="urn:schemas-microsoft-com:office:powerpoint" xmlns:cppr="http://schemas.microsoft.com/office/2006/coverPageProps" xmlns:odx="http://opendope.org/xpaths" xmlns:odc="http://opendope.org/conditions" xmlns:odq="http://opendope.org/questions" xmlns:oda="http://opendope.org/answers" xmlns:odi="http://opendope.org/components" xmlns:odgm="http://opendope.org/SmartArt/DataHierarchy" xmlns:b="http://schemas.openxmlformats.org/officeDocument/2006/bibliography" xmlns:wps="http://schemas.microsoft.com/office/word/2010/wordprocessingShape" xmlns:w16se="http://schemas.microsoft.com/office/word/2015/wordml/symex" xmlns:w16cid="http://schemas.microsoft.com/office/word/2016/wordml/cid" xmlns:wetp="http://schemas.microsoft.com/office/webextensions/taskpanes/2010/11" xmlns:we="http://schemas.microsoft.com/office/webextensions/webextension/2010/11" xmlns:comp="http://schemas.openxmlformats.org/drawingml/2006/compatibility" xmlns:lc="http://schemas.openxmlformats.org/drawingml/2006/lockedCanvas">
             <c:ext xmlns:c16="http://schemas.microsoft.com/office/drawing/2014/chart" uri="{C3380CC4-5D6E-409C-BE32-E72D297353CC}">
               <c16:uniqueId val="{00000002-6147-E74A-AA7B-5531F0E4EE0C}"/>
             </c:ext>
@@ -2050,7 +2050,7 @@
     <c:plotVisOnly val="1"/>
     <c:dispBlanksAs val="gap"/>
     <c:showDLblsOverMax val="0"/>
-    <c:extLst xmlns:lc="http://schemas.openxmlformats.org/drawingml/2006/lockedCanvas" xmlns:comp="http://schemas.openxmlformats.org/drawingml/2006/compatibility" xmlns:we="http://schemas.microsoft.com/office/webextensions/webextension/2010/11" xmlns:wetp="http://schemas.microsoft.com/office/webextensions/taskpanes/2010/11" xmlns:w16cid="http://schemas.microsoft.com/office/word/2016/wordml/cid" xmlns:w16se="http://schemas.microsoft.com/office/word/2015/wordml/symex" xmlns:wps="http://schemas.microsoft.com/office/word/2010/wordprocessingShape" xmlns:b="http://schemas.openxmlformats.org/officeDocument/2006/bibliography" xmlns:odgm="http://opendope.org/SmartArt/DataHierarchy" xmlns:odi="http://opendope.org/components" xmlns:oda="http://opendope.org/answers" xmlns:odq="http://opendope.org/questions" xmlns:odc="http://opendope.org/conditions" xmlns:odx="http://opendope.org/xpaths" xmlns:cppr="http://schemas.microsoft.com/office/2006/coverPageProps" xmlns:pvml="urn:schemas-microsoft-com:office:powerpoint" xmlns:w10="urn:schemas-microsoft-com:office:word" xmlns:v="urn:schemas-microsoft-com:vml" xmlns:o="urn:schemas-microsoft-com:office:office" xmlns:xvml="urn:schemas-microsoft-com:office:excel" xmlns:dsp="http://schemas.microsoft.com/office/drawing/2008/diagram" xmlns:xdr="http://schemas.openxmlformats.org/drawingml/2006/spreadsheetDrawing" xmlns:pic="http://schemas.openxmlformats.org/drawingml/2006/picture" xmlns:dgm="http://schemas.openxmlformats.org/drawingml/2006/diagram" xmlns:c14="http://schemas.microsoft.com/office/drawing/2007/8/2/chart" xmlns:cdr="http://schemas.openxmlformats.org/drawingml/2006/chartDrawing" xmlns:wne="http://schemas.microsoft.com/office/word/2006/wordml" xmlns:sl="http://schemas.openxmlformats.org/schemaLibrary/2006/main" xmlns:mc="http://schemas.openxmlformats.org/markup-compatibility/2006" xmlns:wp14="http://schemas.microsoft.com/office/word/2010/wordprocessingDrawing" xmlns:wp="http://schemas.openxmlformats.org/drawingml/2006/wordprocessingDrawing" xmlns:m="http://schemas.openxmlformats.org/officeDocument/2006/math" xmlns:w14="http://schemas.microsoft.com/office/word/2010/wordml" xmlns:w15="http://schemas.microsoft.com/office/word/2012/wordml" xmlns:w="http://schemas.openxmlformats.org/wordprocessingml/2006/main">
+    <c:extLst xmlns:w="http://schemas.openxmlformats.org/wordprocessingml/2006/main" xmlns:w15="http://schemas.microsoft.com/office/word/2012/wordml" xmlns:w14="http://schemas.microsoft.com/office/word/2010/wordml" xmlns:m="http://schemas.openxmlformats.org/officeDocument/2006/math" xmlns:wp="http://schemas.openxmlformats.org/drawingml/2006/wordprocessingDrawing" xmlns:wp14="http://schemas.microsoft.com/office/word/2010/wordprocessingDrawing" xmlns:mc="http://schemas.openxmlformats.org/markup-compatibility/2006" xmlns:sl="http://schemas.openxmlformats.org/schemaLibrary/2006/main" xmlns:wne="http://schemas.microsoft.com/office/word/2006/wordml" xmlns:cdr="http://schemas.openxmlformats.org/drawingml/2006/chartDrawing" xmlns:c14="http://schemas.microsoft.com/office/drawing/2007/8/2/chart" xmlns:dgm="http://schemas.openxmlformats.org/drawingml/2006/diagram" xmlns:pic="http://schemas.openxmlformats.org/drawingml/2006/picture" xmlns:xdr="http://schemas.openxmlformats.org/drawingml/2006/spreadsheetDrawing" xmlns:dsp="http://schemas.microsoft.com/office/drawing/2008/diagram" xmlns:xvml="urn:schemas-microsoft-com:office:excel" xmlns:o="urn:schemas-microsoft-com:office:office" xmlns:v="urn:schemas-microsoft-com:vml" xmlns:w10="urn:schemas-microsoft-com:office:word" xmlns:pvml="urn:schemas-microsoft-com:office:powerpoint" xmlns:cppr="http://schemas.microsoft.com/office/2006/coverPageProps" xmlns:odx="http://opendope.org/xpaths" xmlns:odc="http://opendope.org/conditions" xmlns:odq="http://opendope.org/questions" xmlns:oda="http://opendope.org/answers" xmlns:odi="http://opendope.org/components" xmlns:odgm="http://opendope.org/SmartArt/DataHierarchy" xmlns:b="http://schemas.openxmlformats.org/officeDocument/2006/bibliography" xmlns:wps="http://schemas.microsoft.com/office/word/2010/wordprocessingShape" xmlns:w16se="http://schemas.microsoft.com/office/word/2015/wordml/symex" xmlns:w16cid="http://schemas.microsoft.com/office/word/2016/wordml/cid" xmlns:wetp="http://schemas.microsoft.com/office/webextensions/taskpanes/2010/11" xmlns:we="http://schemas.microsoft.com/office/webextensions/webextension/2010/11" xmlns:comp="http://schemas.openxmlformats.org/drawingml/2006/compatibility" xmlns:lc="http://schemas.openxmlformats.org/drawingml/2006/lockedCanvas">
       <c:ext xmlns:c16r3="http://schemas.microsoft.com/office/drawing/2017/03/chart" uri="{56B9EC1D-385E-4148-901F-78D8002777C0}">
         <c16r3:dataDisplayOptions16>
           <c16r3:dispNaAsBlank val="1"/>
@@ -2152,7 +2152,7 @@
                 </a:outerShdw>
               </a:effectLst>
             </c:spPr>
-            <c:extLst xmlns:w="http://schemas.openxmlformats.org/wordprocessingml/2006/main" xmlns:w15="http://schemas.microsoft.com/office/word/2012/wordml" xmlns:w14="http://schemas.microsoft.com/office/word/2010/wordml" xmlns:m="http://schemas.openxmlformats.org/officeDocument/2006/math" xmlns:wp="http://schemas.openxmlformats.org/drawingml/2006/wordprocessingDrawing" xmlns:wp14="http://schemas.microsoft.com/office/word/2010/wordprocessingDrawing" xmlns:mc="http://schemas.openxmlformats.org/markup-compatibility/2006" xmlns:sl="http://schemas.openxmlformats.org/schemaLibrary/2006/main" xmlns:wne="http://schemas.microsoft.com/office/word/2006/wordml" xmlns:cdr="http://schemas.openxmlformats.org/drawingml/2006/chartDrawing" xmlns:c14="http://schemas.microsoft.com/office/drawing/2007/8/2/chart" xmlns:dgm="http://schemas.openxmlformats.org/drawingml/2006/diagram" xmlns:pic="http://schemas.openxmlformats.org/drawingml/2006/picture" xmlns:xdr="http://schemas.openxmlformats.org/drawingml/2006/spreadsheetDrawing" xmlns:dsp="http://schemas.microsoft.com/office/drawing/2008/diagram" xmlns:xvml="urn:schemas-microsoft-com:office:excel" xmlns:o="urn:schemas-microsoft-com:office:office" xmlns:v="urn:schemas-microsoft-com:vml" xmlns:w10="urn:schemas-microsoft-com:office:word" xmlns:pvml="urn:schemas-microsoft-com:office:powerpoint" xmlns:cppr="http://schemas.microsoft.com/office/2006/coverPageProps" xmlns:odx="http://opendope.org/xpaths" xmlns:odc="http://opendope.org/conditions" xmlns:odq="http://opendope.org/questions" xmlns:oda="http://opendope.org/answers" xmlns:odi="http://opendope.org/components" xmlns:odgm="http://opendope.org/SmartArt/DataHierarchy" xmlns:b="http://schemas.openxmlformats.org/officeDocument/2006/bibliography" xmlns:wps="http://schemas.microsoft.com/office/word/2010/wordprocessingShape" xmlns:w16se="http://schemas.microsoft.com/office/word/2015/wordml/symex" xmlns:w16cid="http://schemas.microsoft.com/office/word/2016/wordml/cid" xmlns:wetp="http://schemas.microsoft.com/office/webextensions/taskpanes/2010/11" xmlns:we="http://schemas.microsoft.com/office/webextensions/webextension/2010/11" xmlns:comp="http://schemas.openxmlformats.org/drawingml/2006/compatibility" xmlns:lc="http://schemas.openxmlformats.org/drawingml/2006/lockedCanvas">
+            <c:extLst xmlns:lc="http://schemas.openxmlformats.org/drawingml/2006/lockedCanvas" xmlns:comp="http://schemas.openxmlformats.org/drawingml/2006/compatibility" xmlns:we="http://schemas.microsoft.com/office/webextensions/webextension/2010/11" xmlns:wetp="http://schemas.microsoft.com/office/webextensions/taskpanes/2010/11" xmlns:w16cid="http://schemas.microsoft.com/office/word/2016/wordml/cid" xmlns:w16se="http://schemas.microsoft.com/office/word/2015/wordml/symex" xmlns:wps="http://schemas.microsoft.com/office/word/2010/wordprocessingShape" xmlns:b="http://schemas.openxmlformats.org/officeDocument/2006/bibliography" xmlns:odgm="http://opendope.org/SmartArt/DataHierarchy" xmlns:odi="http://opendope.org/components" xmlns:oda="http://opendope.org/answers" xmlns:odq="http://opendope.org/questions" xmlns:odc="http://opendope.org/conditions" xmlns:odx="http://opendope.org/xpaths" xmlns:cppr="http://schemas.microsoft.com/office/2006/coverPageProps" xmlns:pvml="urn:schemas-microsoft-com:office:powerpoint" xmlns:w10="urn:schemas-microsoft-com:office:word" xmlns:v="urn:schemas-microsoft-com:vml" xmlns:o="urn:schemas-microsoft-com:office:office" xmlns:xvml="urn:schemas-microsoft-com:office:excel" xmlns:dsp="http://schemas.microsoft.com/office/drawing/2008/diagram" xmlns:xdr="http://schemas.openxmlformats.org/drawingml/2006/spreadsheetDrawing" xmlns:pic="http://schemas.openxmlformats.org/drawingml/2006/picture" xmlns:dgm="http://schemas.openxmlformats.org/drawingml/2006/diagram" xmlns:c14="http://schemas.microsoft.com/office/drawing/2007/8/2/chart" xmlns:cdr="http://schemas.openxmlformats.org/drawingml/2006/chartDrawing" xmlns:wne="http://schemas.microsoft.com/office/word/2006/wordml" xmlns:sl="http://schemas.openxmlformats.org/schemaLibrary/2006/main" xmlns:mc="http://schemas.openxmlformats.org/markup-compatibility/2006" xmlns:wp14="http://schemas.microsoft.com/office/word/2010/wordprocessingDrawing" xmlns:wp="http://schemas.openxmlformats.org/drawingml/2006/wordprocessingDrawing" xmlns:m="http://schemas.openxmlformats.org/officeDocument/2006/math" xmlns:w14="http://schemas.microsoft.com/office/word/2010/wordml" xmlns:w15="http://schemas.microsoft.com/office/word/2012/wordml" xmlns:w="http://schemas.openxmlformats.org/wordprocessingml/2006/main">
               <c:ext xmlns:c16="http://schemas.microsoft.com/office/drawing/2014/chart" uri="{C3380CC4-5D6E-409C-BE32-E72D297353CC}">
                 <c16:uniqueId val="{00000001-6147-E74A-AA7B-5531F0E4EE0C}"/>
               </c:ext>
@@ -2247,7 +2247,7 @@
               </c:numCache>
             </c:numRef>
           </c:val>
-          <c:extLst xmlns:w="http://schemas.openxmlformats.org/wordprocessingml/2006/main" xmlns:w15="http://schemas.microsoft.com/office/word/2012/wordml" xmlns:w14="http://schemas.microsoft.com/office/word/2010/wordml" xmlns:m="http://schemas.openxmlformats.org/officeDocument/2006/math" xmlns:wp="http://schemas.openxmlformats.org/drawingml/2006/wordprocessingDrawing" xmlns:wp14="http://schemas.microsoft.com/office/word/2010/wordprocessingDrawing" xmlns:mc="http://schemas.openxmlformats.org/markup-compatibility/2006" xmlns:sl="http://schemas.openxmlformats.org/schemaLibrary/2006/main" xmlns:wne="http://schemas.microsoft.com/office/word/2006/wordml" xmlns:cdr="http://schemas.openxmlformats.org/drawingml/2006/chartDrawing" xmlns:c14="http://schemas.microsoft.com/office/drawing/2007/8/2/chart" xmlns:dgm="http://schemas.openxmlformats.org/drawingml/2006/diagram" xmlns:pic="http://schemas.openxmlformats.org/drawingml/2006/picture" xmlns:xdr="http://schemas.openxmlformats.org/drawingml/2006/spreadsheetDrawing" xmlns:dsp="http://schemas.microsoft.com/office/drawing/2008/diagram" xmlns:xvml="urn:schemas-microsoft-com:office:excel" xmlns:o="urn:schemas-microsoft-com:office:office" xmlns:v="urn:schemas-microsoft-com:vml" xmlns:w10="urn:schemas-microsoft-com:office:word" xmlns:pvml="urn:schemas-microsoft-com:office:powerpoint" xmlns:cppr="http://schemas.microsoft.com/office/2006/coverPageProps" xmlns:odx="http://opendope.org/xpaths" xmlns:odc="http://opendope.org/conditions" xmlns:odq="http://opendope.org/questions" xmlns:oda="http://opendope.org/answers" xmlns:odi="http://opendope.org/components" xmlns:odgm="http://opendope.org/SmartArt/DataHierarchy" xmlns:b="http://schemas.openxmlformats.org/officeDocument/2006/bibliography" xmlns:wps="http://schemas.microsoft.com/office/word/2010/wordprocessingShape" xmlns:w16se="http://schemas.microsoft.com/office/word/2015/wordml/symex" xmlns:w16cid="http://schemas.microsoft.com/office/word/2016/wordml/cid" xmlns:wetp="http://schemas.microsoft.com/office/webextensions/taskpanes/2010/11" xmlns:we="http://schemas.microsoft.com/office/webextensions/webextension/2010/11" xmlns:comp="http://schemas.openxmlformats.org/drawingml/2006/compatibility" xmlns:lc="http://schemas.openxmlformats.org/drawingml/2006/lockedCanvas">
+          <c:extLst xmlns:lc="http://schemas.openxmlformats.org/drawingml/2006/lockedCanvas" xmlns:comp="http://schemas.openxmlformats.org/drawingml/2006/compatibility" xmlns:we="http://schemas.microsoft.com/office/webextensions/webextension/2010/11" xmlns:wetp="http://schemas.microsoft.com/office/webextensions/taskpanes/2010/11" xmlns:w16cid="http://schemas.microsoft.com/office/word/2016/wordml/cid" xmlns:w16se="http://schemas.microsoft.com/office/word/2015/wordml/symex" xmlns:wps="http://schemas.microsoft.com/office/word/2010/wordprocessingShape" xmlns:b="http://schemas.openxmlformats.org/officeDocument/2006/bibliography" xmlns:odgm="http://opendope.org/SmartArt/DataHierarchy" xmlns:odi="http://opendope.org/components" xmlns:oda="http://opendope.org/answers" xmlns:odq="http://opendope.org/questions" xmlns:odc="http://opendope.org/conditions" xmlns:odx="http://opendope.org/xpaths" xmlns:cppr="http://schemas.microsoft.com/office/2006/coverPageProps" xmlns:pvml="urn:schemas-microsoft-com:office:powerpoint" xmlns:w10="urn:schemas-microsoft-com:office:word" xmlns:v="urn:schemas-microsoft-com:vml" xmlns:o="urn:schemas-microsoft-com:office:office" xmlns:xvml="urn:schemas-microsoft-com:office:excel" xmlns:dsp="http://schemas.microsoft.com/office/drawing/2008/diagram" xmlns:xdr="http://schemas.openxmlformats.org/drawingml/2006/spreadsheetDrawing" xmlns:pic="http://schemas.openxmlformats.org/drawingml/2006/picture" xmlns:dgm="http://schemas.openxmlformats.org/drawingml/2006/diagram" xmlns:c14="http://schemas.microsoft.com/office/drawing/2007/8/2/chart" xmlns:cdr="http://schemas.openxmlformats.org/drawingml/2006/chartDrawing" xmlns:wne="http://schemas.microsoft.com/office/word/2006/wordml" xmlns:sl="http://schemas.openxmlformats.org/schemaLibrary/2006/main" xmlns:mc="http://schemas.openxmlformats.org/markup-compatibility/2006" xmlns:wp14="http://schemas.microsoft.com/office/word/2010/wordprocessingDrawing" xmlns:wp="http://schemas.openxmlformats.org/drawingml/2006/wordprocessingDrawing" xmlns:m="http://schemas.openxmlformats.org/officeDocument/2006/math" xmlns:w14="http://schemas.microsoft.com/office/word/2010/wordml" xmlns:w15="http://schemas.microsoft.com/office/word/2012/wordml" xmlns:w="http://schemas.openxmlformats.org/wordprocessingml/2006/main">
             <c:ext xmlns:c16="http://schemas.microsoft.com/office/drawing/2014/chart" uri="{C3380CC4-5D6E-409C-BE32-E72D297353CC}">
               <c16:uniqueId val="{00000002-6147-E74A-AA7B-5531F0E4EE0C}"/>
             </c:ext>
@@ -2858,7 +2858,7 @@
     <c:plotVisOnly val="1"/>
     <c:dispBlanksAs val="gap"/>
     <c:showDLblsOverMax val="0"/>
-    <c:extLst xmlns:w="http://schemas.openxmlformats.org/wordprocessingml/2006/main" xmlns:w15="http://schemas.microsoft.com/office/word/2012/wordml" xmlns:w14="http://schemas.microsoft.com/office/word/2010/wordml" xmlns:m="http://schemas.openxmlformats.org/officeDocument/2006/math" xmlns:wp="http://schemas.openxmlformats.org/drawingml/2006/wordprocessingDrawing" xmlns:wp14="http://schemas.microsoft.com/office/word/2010/wordprocessingDrawing" xmlns:mc="http://schemas.openxmlformats.org/markup-compatibility/2006" xmlns:sl="http://schemas.openxmlformats.org/schemaLibrary/2006/main" xmlns:wne="http://schemas.microsoft.com/office/word/2006/wordml" xmlns:cdr="http://schemas.openxmlformats.org/drawingml/2006/chartDrawing" xmlns:c14="http://schemas.microsoft.com/office/drawing/2007/8/2/chart" xmlns:dgm="http://schemas.openxmlformats.org/drawingml/2006/diagram" xmlns:pic="http://schemas.openxmlformats.org/drawingml/2006/picture" xmlns:xdr="http://schemas.openxmlformats.org/drawingml/2006/spreadsheetDrawing" xmlns:dsp="http://schemas.microsoft.com/office/drawing/2008/diagram" xmlns:xvml="urn:schemas-microsoft-com:office:excel" xmlns:o="urn:schemas-microsoft-com:office:office" xmlns:v="urn:schemas-microsoft-com:vml" xmlns:w10="urn:schemas-microsoft-com:office:word" xmlns:pvml="urn:schemas-microsoft-com:office:powerpoint" xmlns:cppr="http://schemas.microsoft.com/office/2006/coverPageProps" xmlns:odx="http://opendope.org/xpaths" xmlns:odc="http://opendope.org/conditions" xmlns:odq="http://opendope.org/questions" xmlns:oda="http://opendope.org/answers" xmlns:odi="http://opendope.org/components" xmlns:odgm="http://opendope.org/SmartArt/DataHierarchy" xmlns:b="http://schemas.openxmlformats.org/officeDocument/2006/bibliography" xmlns:wps="http://schemas.microsoft.com/office/word/2010/wordprocessingShape" xmlns:w16se="http://schemas.microsoft.com/office/word/2015/wordml/symex" xmlns:w16cid="http://schemas.microsoft.com/office/word/2016/wordml/cid" xmlns:wetp="http://schemas.microsoft.com/office/webextensions/taskpanes/2010/11" xmlns:we="http://schemas.microsoft.com/office/webextensions/webextension/2010/11" xmlns:comp="http://schemas.openxmlformats.org/drawingml/2006/compatibility" xmlns:lc="http://schemas.openxmlformats.org/drawingml/2006/lockedCanvas">
+    <c:extLst xmlns:lc="http://schemas.openxmlformats.org/drawingml/2006/lockedCanvas" xmlns:comp="http://schemas.openxmlformats.org/drawingml/2006/compatibility" xmlns:we="http://schemas.microsoft.com/office/webextensions/webextension/2010/11" xmlns:wetp="http://schemas.microsoft.com/office/webextensions/taskpanes/2010/11" xmlns:w16cid="http://schemas.microsoft.com/office/word/2016/wordml/cid" xmlns:w16se="http://schemas.microsoft.com/office/word/2015/wordml/symex" xmlns:wps="http://schemas.microsoft.com/office/word/2010/wordprocessingShape" xmlns:b="http://schemas.openxmlformats.org/officeDocument/2006/bibliography" xmlns:odgm="http://opendope.org/SmartArt/DataHierarchy" xmlns:odi="http://opendope.org/components" xmlns:oda="http://opendope.org/answers" xmlns:odq="http://opendope.org/questions" xmlns:odc="http://opendope.org/conditions" xmlns:odx="http://opendope.org/xpaths" xmlns:cppr="http://schemas.microsoft.com/office/2006/coverPageProps" xmlns:pvml="urn:schemas-microsoft-com:office:powerpoint" xmlns:w10="urn:schemas-microsoft-com:office:word" xmlns:v="urn:schemas-microsoft-com:vml" xmlns:o="urn:schemas-microsoft-com:office:office" xmlns:xvml="urn:schemas-microsoft-com:office:excel" xmlns:dsp="http://schemas.microsoft.com/office/drawing/2008/diagram" xmlns:xdr="http://schemas.openxmlformats.org/drawingml/2006/spreadsheetDrawing" xmlns:pic="http://schemas.openxmlformats.org/drawingml/2006/picture" xmlns:dgm="http://schemas.openxmlformats.org/drawingml/2006/diagram" xmlns:c14="http://schemas.microsoft.com/office/drawing/2007/8/2/chart" xmlns:cdr="http://schemas.openxmlformats.org/drawingml/2006/chartDrawing" xmlns:wne="http://schemas.microsoft.com/office/word/2006/wordml" xmlns:sl="http://schemas.openxmlformats.org/schemaLibrary/2006/main" xmlns:mc="http://schemas.openxmlformats.org/markup-compatibility/2006" xmlns:wp14="http://schemas.microsoft.com/office/word/2010/wordprocessingDrawing" xmlns:wp="http://schemas.openxmlformats.org/drawingml/2006/wordprocessingDrawing" xmlns:m="http://schemas.openxmlformats.org/officeDocument/2006/math" xmlns:w14="http://schemas.microsoft.com/office/word/2010/wordml" xmlns:w15="http://schemas.microsoft.com/office/word/2012/wordml" xmlns:w="http://schemas.openxmlformats.org/wordprocessingml/2006/main">
       <c:ext xmlns:c16r3="http://schemas.microsoft.com/office/drawing/2017/03/chart" uri="{56B9EC1D-385E-4148-901F-78D8002777C0}">
         <c16r3:dataDisplayOptions16>
           <c16r3:dispNaAsBlank val="1"/>
@@ -2960,7 +2960,7 @@
                 </a:outerShdw>
               </a:effectLst>
             </c:spPr>
-            <c:extLst xmlns:w="http://schemas.openxmlformats.org/wordprocessingml/2006/main" xmlns:w15="http://schemas.microsoft.com/office/word/2012/wordml" xmlns:w14="http://schemas.microsoft.com/office/word/2010/wordml" xmlns:m="http://schemas.openxmlformats.org/officeDocument/2006/math" xmlns:wp="http://schemas.openxmlformats.org/drawingml/2006/wordprocessingDrawing" xmlns:wp14="http://schemas.microsoft.com/office/word/2010/wordprocessingDrawing" xmlns:mc="http://schemas.openxmlformats.org/markup-compatibility/2006" xmlns:sl="http://schemas.openxmlformats.org/schemaLibrary/2006/main" xmlns:wne="http://schemas.microsoft.com/office/word/2006/wordml" xmlns:cdr="http://schemas.openxmlformats.org/drawingml/2006/chartDrawing" xmlns:c14="http://schemas.microsoft.com/office/drawing/2007/8/2/chart" xmlns:dgm="http://schemas.openxmlformats.org/drawingml/2006/diagram" xmlns:pic="http://schemas.openxmlformats.org/drawingml/2006/picture" xmlns:xdr="http://schemas.openxmlformats.org/drawingml/2006/spreadsheetDrawing" xmlns:dsp="http://schemas.microsoft.com/office/drawing/2008/diagram" xmlns:xvml="urn:schemas-microsoft-com:office:excel" xmlns:o="urn:schemas-microsoft-com:office:office" xmlns:v="urn:schemas-microsoft-com:vml" xmlns:w10="urn:schemas-microsoft-com:office:word" xmlns:pvml="urn:schemas-microsoft-com:office:powerpoint" xmlns:cppr="http://schemas.microsoft.com/office/2006/coverPageProps" xmlns:odx="http://opendope.org/xpaths" xmlns:odc="http://opendope.org/conditions" xmlns:odq="http://opendope.org/questions" xmlns:oda="http://opendope.org/answers" xmlns:odi="http://opendope.org/components" xmlns:odgm="http://opendope.org/SmartArt/DataHierarchy" xmlns:b="http://schemas.openxmlformats.org/officeDocument/2006/bibliography" xmlns:wps="http://schemas.microsoft.com/office/word/2010/wordprocessingShape" xmlns:w16se="http://schemas.microsoft.com/office/word/2015/wordml/symex" xmlns:w16cid="http://schemas.microsoft.com/office/word/2016/wordml/cid" xmlns:wetp="http://schemas.microsoft.com/office/webextensions/taskpanes/2010/11" xmlns:we="http://schemas.microsoft.com/office/webextensions/webextension/2010/11" xmlns:comp="http://schemas.openxmlformats.org/drawingml/2006/compatibility" xmlns:lc="http://schemas.openxmlformats.org/drawingml/2006/lockedCanvas">
+            <c:extLst xmlns:lc="http://schemas.openxmlformats.org/drawingml/2006/lockedCanvas" xmlns:comp="http://schemas.openxmlformats.org/drawingml/2006/compatibility" xmlns:we="http://schemas.microsoft.com/office/webextensions/webextension/2010/11" xmlns:wetp="http://schemas.microsoft.com/office/webextensions/taskpanes/2010/11" xmlns:w16cid="http://schemas.microsoft.com/office/word/2016/wordml/cid" xmlns:w16se="http://schemas.microsoft.com/office/word/2015/wordml/symex" xmlns:wps="http://schemas.microsoft.com/office/word/2010/wordprocessingShape" xmlns:b="http://schemas.openxmlformats.org/officeDocument/2006/bibliography" xmlns:odgm="http://opendope.org/SmartArt/DataHierarchy" xmlns:odi="http://opendope.org/components" xmlns:oda="http://opendope.org/answers" xmlns:odq="http://opendope.org/questions" xmlns:odc="http://opendope.org/conditions" xmlns:odx="http://opendope.org/xpaths" xmlns:cppr="http://schemas.microsoft.com/office/2006/coverPageProps" xmlns:pvml="urn:schemas-microsoft-com:office:powerpoint" xmlns:w10="urn:schemas-microsoft-com:office:word" xmlns:v="urn:schemas-microsoft-com:vml" xmlns:o="urn:schemas-microsoft-com:office:office" xmlns:xvml="urn:schemas-microsoft-com:office:excel" xmlns:dsp="http://schemas.microsoft.com/office/drawing/2008/diagram" xmlns:xdr="http://schemas.openxmlformats.org/drawingml/2006/spreadsheetDrawing" xmlns:pic="http://schemas.openxmlformats.org/drawingml/2006/picture" xmlns:dgm="http://schemas.openxmlformats.org/drawingml/2006/diagram" xmlns:c14="http://schemas.microsoft.com/office/drawing/2007/8/2/chart" xmlns:cdr="http://schemas.openxmlformats.org/drawingml/2006/chartDrawing" xmlns:wne="http://schemas.microsoft.com/office/word/2006/wordml" xmlns:sl="http://schemas.openxmlformats.org/schemaLibrary/2006/main" xmlns:mc="http://schemas.openxmlformats.org/markup-compatibility/2006" xmlns:wp14="http://schemas.microsoft.com/office/word/2010/wordprocessingDrawing" xmlns:wp="http://schemas.openxmlformats.org/drawingml/2006/wordprocessingDrawing" xmlns:m="http://schemas.openxmlformats.org/officeDocument/2006/math" xmlns:w14="http://schemas.microsoft.com/office/word/2010/wordml" xmlns:w15="http://schemas.microsoft.com/office/word/2012/wordml" xmlns:w="http://schemas.openxmlformats.org/wordprocessingml/2006/main">
               <c:ext xmlns:c16="http://schemas.microsoft.com/office/drawing/2014/chart" uri="{C3380CC4-5D6E-409C-BE32-E72D297353CC}">
                 <c16:uniqueId val="{00000001-6147-E74A-AA7B-5531F0E4EE0C}"/>
               </c:ext>
@@ -3055,7 +3055,7 @@
               </c:numCache>
             </c:numRef>
           </c:val>
-          <c:extLst xmlns:w="http://schemas.openxmlformats.org/wordprocessingml/2006/main" xmlns:w15="http://schemas.microsoft.com/office/word/2012/wordml" xmlns:w14="http://schemas.microsoft.com/office/word/2010/wordml" xmlns:m="http://schemas.openxmlformats.org/officeDocument/2006/math" xmlns:wp="http://schemas.openxmlformats.org/drawingml/2006/wordprocessingDrawing" xmlns:wp14="http://schemas.microsoft.com/office/word/2010/wordprocessingDrawing" xmlns:mc="http://schemas.openxmlformats.org/markup-compatibility/2006" xmlns:sl="http://schemas.openxmlformats.org/schemaLibrary/2006/main" xmlns:wne="http://schemas.microsoft.com/office/word/2006/wordml" xmlns:cdr="http://schemas.openxmlformats.org/drawingml/2006/chartDrawing" xmlns:c14="http://schemas.microsoft.com/office/drawing/2007/8/2/chart" xmlns:dgm="http://schemas.openxmlformats.org/drawingml/2006/diagram" xmlns:pic="http://schemas.openxmlformats.org/drawingml/2006/picture" xmlns:xdr="http://schemas.openxmlformats.org/drawingml/2006/spreadsheetDrawing" xmlns:dsp="http://schemas.microsoft.com/office/drawing/2008/diagram" xmlns:xvml="urn:schemas-microsoft-com:office:excel" xmlns:o="urn:schemas-microsoft-com:office:office" xmlns:v="urn:schemas-microsoft-com:vml" xmlns:w10="urn:schemas-microsoft-com:office:word" xmlns:pvml="urn:schemas-microsoft-com:office:powerpoint" xmlns:cppr="http://schemas.microsoft.com/office/2006/coverPageProps" xmlns:odx="http://opendope.org/xpaths" xmlns:odc="http://opendope.org/conditions" xmlns:odq="http://opendope.org/questions" xmlns:oda="http://opendope.org/answers" xmlns:odi="http://opendope.org/components" xmlns:odgm="http://opendope.org/SmartArt/DataHierarchy" xmlns:b="http://schemas.openxmlformats.org/officeDocument/2006/bibliography" xmlns:wps="http://schemas.microsoft.com/office/word/2010/wordprocessingShape" xmlns:w16se="http://schemas.microsoft.com/office/word/2015/wordml/symex" xmlns:w16cid="http://schemas.microsoft.com/office/word/2016/wordml/cid" xmlns:wetp="http://schemas.microsoft.com/office/webextensions/taskpanes/2010/11" xmlns:we="http://schemas.microsoft.com/office/webextensions/webextension/2010/11" xmlns:comp="http://schemas.openxmlformats.org/drawingml/2006/compatibility" xmlns:lc="http://schemas.openxmlformats.org/drawingml/2006/lockedCanvas">
+          <c:extLst xmlns:lc="http://schemas.openxmlformats.org/drawingml/2006/lockedCanvas" xmlns:comp="http://schemas.openxmlformats.org/drawingml/2006/compatibility" xmlns:we="http://schemas.microsoft.com/office/webextensions/webextension/2010/11" xmlns:wetp="http://schemas.microsoft.com/office/webextensions/taskpanes/2010/11" xmlns:w16cid="http://schemas.microsoft.com/office/word/2016/wordml/cid" xmlns:w16se="http://schemas.microsoft.com/office/word/2015/wordml/symex" xmlns:wps="http://schemas.microsoft.com/office/word/2010/wordprocessingShape" xmlns:b="http://schemas.openxmlformats.org/officeDocument/2006/bibliography" xmlns:odgm="http://opendope.org/SmartArt/DataHierarchy" xmlns:odi="http://opendope.org/components" xmlns:oda="http://opendope.org/answers" xmlns:odq="http://opendope.org/questions" xmlns:odc="http://opendope.org/conditions" xmlns:odx="http://opendope.org/xpaths" xmlns:cppr="http://schemas.microsoft.com/office/2006/coverPageProps" xmlns:pvml="urn:schemas-microsoft-com:office:powerpoint" xmlns:w10="urn:schemas-microsoft-com:office:word" xmlns:v="urn:schemas-microsoft-com:vml" xmlns:o="urn:schemas-microsoft-com:office:office" xmlns:xvml="urn:schemas-microsoft-com:office:excel" xmlns:dsp="http://schemas.microsoft.com/office/drawing/2008/diagram" xmlns:xdr="http://schemas.openxmlformats.org/drawingml/2006/spreadsheetDrawing" xmlns:pic="http://schemas.openxmlformats.org/drawingml/2006/picture" xmlns:dgm="http://schemas.openxmlformats.org/drawingml/2006/diagram" xmlns:c14="http://schemas.microsoft.com/office/drawing/2007/8/2/chart" xmlns:cdr="http://schemas.openxmlformats.org/drawingml/2006/chartDrawing" xmlns:wne="http://schemas.microsoft.com/office/word/2006/wordml" xmlns:sl="http://schemas.openxmlformats.org/schemaLibrary/2006/main" xmlns:mc="http://schemas.openxmlformats.org/markup-compatibility/2006" xmlns:wp14="http://schemas.microsoft.com/office/word/2010/wordprocessingDrawing" xmlns:wp="http://schemas.openxmlformats.org/drawingml/2006/wordprocessingDrawing" xmlns:m="http://schemas.openxmlformats.org/officeDocument/2006/math" xmlns:w14="http://schemas.microsoft.com/office/word/2010/wordml" xmlns:w15="http://schemas.microsoft.com/office/word/2012/wordml" xmlns:w="http://schemas.openxmlformats.org/wordprocessingml/2006/main">
             <c:ext xmlns:c16="http://schemas.microsoft.com/office/drawing/2014/chart" uri="{C3380CC4-5D6E-409C-BE32-E72D297353CC}">
               <c16:uniqueId val="{00000002-6147-E74A-AA7B-5531F0E4EE0C}"/>
             </c:ext>
@@ -3666,7 +3666,7 @@
     <c:plotVisOnly val="1"/>
     <c:dispBlanksAs val="gap"/>
     <c:showDLblsOverMax val="0"/>
-    <c:extLst xmlns:w="http://schemas.openxmlformats.org/wordprocessingml/2006/main" xmlns:w15="http://schemas.microsoft.com/office/word/2012/wordml" xmlns:w14="http://schemas.microsoft.com/office/word/2010/wordml" xmlns:m="http://schemas.openxmlformats.org/officeDocument/2006/math" xmlns:wp="http://schemas.openxmlformats.org/drawingml/2006/wordprocessingDrawing" xmlns:wp14="http://schemas.microsoft.com/office/word/2010/wordprocessingDrawing" xmlns:mc="http://schemas.openxmlformats.org/markup-compatibility/2006" xmlns:sl="http://schemas.openxmlformats.org/schemaLibrary/2006/main" xmlns:wne="http://schemas.microsoft.com/office/word/2006/wordml" xmlns:cdr="http://schemas.openxmlformats.org/drawingml/2006/chartDrawing" xmlns:c14="http://schemas.microsoft.com/office/drawing/2007/8/2/chart" xmlns:dgm="http://schemas.openxmlformats.org/drawingml/2006/diagram" xmlns:pic="http://schemas.openxmlformats.org/drawingml/2006/picture" xmlns:xdr="http://schemas.openxmlformats.org/drawingml/2006/spreadsheetDrawing" xmlns:dsp="http://schemas.microsoft.com/office/drawing/2008/diagram" xmlns:xvml="urn:schemas-microsoft-com:office:excel" xmlns:o="urn:schemas-microsoft-com:office:office" xmlns:v="urn:schemas-microsoft-com:vml" xmlns:w10="urn:schemas-microsoft-com:office:word" xmlns:pvml="urn:schemas-microsoft-com:office:powerpoint" xmlns:cppr="http://schemas.microsoft.com/office/2006/coverPageProps" xmlns:odx="http://opendope.org/xpaths" xmlns:odc="http://opendope.org/conditions" xmlns:odq="http://opendope.org/questions" xmlns:oda="http://opendope.org/answers" xmlns:odi="http://opendope.org/components" xmlns:odgm="http://opendope.org/SmartArt/DataHierarchy" xmlns:b="http://schemas.openxmlformats.org/officeDocument/2006/bibliography" xmlns:wps="http://schemas.microsoft.com/office/word/2010/wordprocessingShape" xmlns:w16se="http://schemas.microsoft.com/office/word/2015/wordml/symex" xmlns:w16cid="http://schemas.microsoft.com/office/word/2016/wordml/cid" xmlns:wetp="http://schemas.microsoft.com/office/webextensions/taskpanes/2010/11" xmlns:we="http://schemas.microsoft.com/office/webextensions/webextension/2010/11" xmlns:comp="http://schemas.openxmlformats.org/drawingml/2006/compatibility" xmlns:lc="http://schemas.openxmlformats.org/drawingml/2006/lockedCanvas">
+    <c:extLst xmlns:lc="http://schemas.openxmlformats.org/drawingml/2006/lockedCanvas" xmlns:comp="http://schemas.openxmlformats.org/drawingml/2006/compatibility" xmlns:we="http://schemas.microsoft.com/office/webextensions/webextension/2010/11" xmlns:wetp="http://schemas.microsoft.com/office/webextensions/taskpanes/2010/11" xmlns:w16cid="http://schemas.microsoft.com/office/word/2016/wordml/cid" xmlns:w16se="http://schemas.microsoft.com/office/word/2015/wordml/symex" xmlns:wps="http://schemas.microsoft.com/office/word/2010/wordprocessingShape" xmlns:b="http://schemas.openxmlformats.org/officeDocument/2006/bibliography" xmlns:odgm="http://opendope.org/SmartArt/DataHierarchy" xmlns:odi="http://opendope.org/components" xmlns:oda="http://opendope.org/answers" xmlns:odq="http://opendope.org/questions" xmlns:odc="http://opendope.org/conditions" xmlns:odx="http://opendope.org/xpaths" xmlns:cppr="http://schemas.microsoft.com/office/2006/coverPageProps" xmlns:pvml="urn:schemas-microsoft-com:office:powerpoint" xmlns:w10="urn:schemas-microsoft-com:office:word" xmlns:v="urn:schemas-microsoft-com:vml" xmlns:o="urn:schemas-microsoft-com:office:office" xmlns:xvml="urn:schemas-microsoft-com:office:excel" xmlns:dsp="http://schemas.microsoft.com/office/drawing/2008/diagram" xmlns:xdr="http://schemas.openxmlformats.org/drawingml/2006/spreadsheetDrawing" xmlns:pic="http://schemas.openxmlformats.org/drawingml/2006/picture" xmlns:dgm="http://schemas.openxmlformats.org/drawingml/2006/diagram" xmlns:c14="http://schemas.microsoft.com/office/drawing/2007/8/2/chart" xmlns:cdr="http://schemas.openxmlformats.org/drawingml/2006/chartDrawing" xmlns:wne="http://schemas.microsoft.com/office/word/2006/wordml" xmlns:sl="http://schemas.openxmlformats.org/schemaLibrary/2006/main" xmlns:mc="http://schemas.openxmlformats.org/markup-compatibility/2006" xmlns:wp14="http://schemas.microsoft.com/office/word/2010/wordprocessingDrawing" xmlns:wp="http://schemas.openxmlformats.org/drawingml/2006/wordprocessingDrawing" xmlns:m="http://schemas.openxmlformats.org/officeDocument/2006/math" xmlns:w14="http://schemas.microsoft.com/office/word/2010/wordml" xmlns:w15="http://schemas.microsoft.com/office/word/2012/wordml" xmlns:w="http://schemas.openxmlformats.org/wordprocessingml/2006/main">
       <c:ext xmlns:c16r3="http://schemas.microsoft.com/office/drawing/2017/03/chart" uri="{56B9EC1D-385E-4148-901F-78D8002777C0}">
         <c16r3:dataDisplayOptions16>
           <c16r3:dispNaAsBlank val="1"/>
@@ -3768,7 +3768,7 @@
                 </a:outerShdw>
               </a:effectLst>
             </c:spPr>
-            <c:extLst xmlns:lc="http://schemas.openxmlformats.org/drawingml/2006/lockedCanvas" xmlns:comp="http://schemas.openxmlformats.org/drawingml/2006/compatibility" xmlns:we="http://schemas.microsoft.com/office/webextensions/webextension/2010/11" xmlns:wetp="http://schemas.microsoft.com/office/webextensions/taskpanes/2010/11" xmlns:w16cid="http://schemas.microsoft.com/office/word/2016/wordml/cid" xmlns:w16se="http://schemas.microsoft.com/office/word/2015/wordml/symex" xmlns:wps="http://schemas.microsoft.com/office/word/2010/wordprocessingShape" xmlns:b="http://schemas.openxmlformats.org/officeDocument/2006/bibliography" xmlns:odgm="http://opendope.org/SmartArt/DataHierarchy" xmlns:odi="http://opendope.org/components" xmlns:oda="http://opendope.org/answers" xmlns:odq="http://opendope.org/questions" xmlns:odc="http://opendope.org/conditions" xmlns:odx="http://opendope.org/xpaths" xmlns:cppr="http://schemas.microsoft.com/office/2006/coverPageProps" xmlns:pvml="urn:schemas-microsoft-com:office:powerpoint" xmlns:w10="urn:schemas-microsoft-com:office:word" xmlns:v="urn:schemas-microsoft-com:vml" xmlns:o="urn:schemas-microsoft-com:office:office" xmlns:xvml="urn:schemas-microsoft-com:office:excel" xmlns:dsp="http://schemas.microsoft.com/office/drawing/2008/diagram" xmlns:xdr="http://schemas.openxmlformats.org/drawingml/2006/spreadsheetDrawing" xmlns:pic="http://schemas.openxmlformats.org/drawingml/2006/picture" xmlns:dgm="http://schemas.openxmlformats.org/drawingml/2006/diagram" xmlns:c14="http://schemas.microsoft.com/office/drawing/2007/8/2/chart" xmlns:cdr="http://schemas.openxmlformats.org/drawingml/2006/chartDrawing" xmlns:wne="http://schemas.microsoft.com/office/word/2006/wordml" xmlns:sl="http://schemas.openxmlformats.org/schemaLibrary/2006/main" xmlns:mc="http://schemas.openxmlformats.org/markup-compatibility/2006" xmlns:wp14="http://schemas.microsoft.com/office/word/2010/wordprocessingDrawing" xmlns:wp="http://schemas.openxmlformats.org/drawingml/2006/wordprocessingDrawing" xmlns:m="http://schemas.openxmlformats.org/officeDocument/2006/math" xmlns:w14="http://schemas.microsoft.com/office/word/2010/wordml" xmlns:w15="http://schemas.microsoft.com/office/word/2012/wordml" xmlns:w="http://schemas.openxmlformats.org/wordprocessingml/2006/main">
+            <c:extLst xmlns:w="http://schemas.openxmlformats.org/wordprocessingml/2006/main" xmlns:w15="http://schemas.microsoft.com/office/word/2012/wordml" xmlns:w14="http://schemas.microsoft.com/office/word/2010/wordml" xmlns:m="http://schemas.openxmlformats.org/officeDocument/2006/math" xmlns:wp="http://schemas.openxmlformats.org/drawingml/2006/wordprocessingDrawing" xmlns:wp14="http://schemas.microsoft.com/office/word/2010/wordprocessingDrawing" xmlns:mc="http://schemas.openxmlformats.org/markup-compatibility/2006" xmlns:sl="http://schemas.openxmlformats.org/schemaLibrary/2006/main" xmlns:wne="http://schemas.microsoft.com/office/word/2006/wordml" xmlns:cdr="http://schemas.openxmlformats.org/drawingml/2006/chartDrawing" xmlns:c14="http://schemas.microsoft.com/office/drawing/2007/8/2/chart" xmlns:dgm="http://schemas.openxmlformats.org/drawingml/2006/diagram" xmlns:pic="http://schemas.openxmlformats.org/drawingml/2006/picture" xmlns:xdr="http://schemas.openxmlformats.org/drawingml/2006/spreadsheetDrawing" xmlns:dsp="http://schemas.microsoft.com/office/drawing/2008/diagram" xmlns:xvml="urn:schemas-microsoft-com:office:excel" xmlns:o="urn:schemas-microsoft-com:office:office" xmlns:v="urn:schemas-microsoft-com:vml" xmlns:w10="urn:schemas-microsoft-com:office:word" xmlns:pvml="urn:schemas-microsoft-com:office:powerpoint" xmlns:cppr="http://schemas.microsoft.com/office/2006/coverPageProps" xmlns:odx="http://opendope.org/xpaths" xmlns:odc="http://opendope.org/conditions" xmlns:odq="http://opendope.org/questions" xmlns:oda="http://opendope.org/answers" xmlns:odi="http://opendope.org/components" xmlns:odgm="http://opendope.org/SmartArt/DataHierarchy" xmlns:b="http://schemas.openxmlformats.org/officeDocument/2006/bibliography" xmlns:wps="http://schemas.microsoft.com/office/word/2010/wordprocessingShape" xmlns:w16se="http://schemas.microsoft.com/office/word/2015/wordml/symex" xmlns:w16cid="http://schemas.microsoft.com/office/word/2016/wordml/cid" xmlns:wetp="http://schemas.microsoft.com/office/webextensions/taskpanes/2010/11" xmlns:we="http://schemas.microsoft.com/office/webextensions/webextension/2010/11" xmlns:comp="http://schemas.openxmlformats.org/drawingml/2006/compatibility" xmlns:lc="http://schemas.openxmlformats.org/drawingml/2006/lockedCanvas">
               <c:ext xmlns:c16="http://schemas.microsoft.com/office/drawing/2014/chart" uri="{C3380CC4-5D6E-409C-BE32-E72D297353CC}">
                 <c16:uniqueId val="{00000001-6147-E74A-AA7B-5531F0E4EE0C}"/>
               </c:ext>
@@ -3863,7 +3863,7 @@
               </c:numCache>
             </c:numRef>
           </c:val>
-          <c:extLst xmlns:lc="http://schemas.openxmlformats.org/drawingml/2006/lockedCanvas" xmlns:comp="http://schemas.openxmlformats.org/drawingml/2006/compatibility" xmlns:we="http://schemas.microsoft.com/office/webextensions/webextension/2010/11" xmlns:wetp="http://schemas.microsoft.com/office/webextensions/taskpanes/2010/11" xmlns:w16cid="http://schemas.microsoft.com/office/word/2016/wordml/cid" xmlns:w16se="http://schemas.microsoft.com/office/word/2015/wordml/symex" xmlns:wps="http://schemas.microsoft.com/office/word/2010/wordprocessingShape" xmlns:b="http://schemas.openxmlformats.org/officeDocument/2006/bibliography" xmlns:odgm="http://opendope.org/SmartArt/DataHierarchy" xmlns:odi="http://opendope.org/components" xmlns:oda="http://opendope.org/answers" xmlns:odq="http://opendope.org/questions" xmlns:odc="http://opendope.org/conditions" xmlns:odx="http://opendope.org/xpaths" xmlns:cppr="http://schemas.microsoft.com/office/2006/coverPageProps" xmlns:pvml="urn:schemas-microsoft-com:office:powerpoint" xmlns:w10="urn:schemas-microsoft-com:office:word" xmlns:v="urn:schemas-microsoft-com:vml" xmlns:o="urn:schemas-microsoft-com:office:office" xmlns:xvml="urn:schemas-microsoft-com:office:excel" xmlns:dsp="http://schemas.microsoft.com/office/drawing/2008/diagram" xmlns:xdr="http://schemas.openxmlformats.org/drawingml/2006/spreadsheetDrawing" xmlns:pic="http://schemas.openxmlformats.org/drawingml/2006/picture" xmlns:dgm="http://schemas.openxmlformats.org/drawingml/2006/diagram" xmlns:c14="http://schemas.microsoft.com/office/drawing/2007/8/2/chart" xmlns:cdr="http://schemas.openxmlformats.org/drawingml/2006/chartDrawing" xmlns:wne="http://schemas.microsoft.com/office/word/2006/wordml" xmlns:sl="http://schemas.openxmlformats.org/schemaLibrary/2006/main" xmlns:mc="http://schemas.openxmlformats.org/markup-compatibility/2006" xmlns:wp14="http://schemas.microsoft.com/office/word/2010/wordprocessingDrawing" xmlns:wp="http://schemas.openxmlformats.org/drawingml/2006/wordprocessingDrawing" xmlns:m="http://schemas.openxmlformats.org/officeDocument/2006/math" xmlns:w14="http://schemas.microsoft.com/office/word/2010/wordml" xmlns:w15="http://schemas.microsoft.com/office/word/2012/wordml" xmlns:w="http://schemas.openxmlformats.org/wordprocessingml/2006/main">
+          <c:extLst xmlns:w="http://schemas.openxmlformats.org/wordprocessingml/2006/main" xmlns:w15="http://schemas.microsoft.com/office/word/2012/wordml" xmlns:w14="http://schemas.microsoft.com/office/word/2010/wordml" xmlns:m="http://schemas.openxmlformats.org/officeDocument/2006/math" xmlns:wp="http://schemas.openxmlformats.org/drawingml/2006/wordprocessingDrawing" xmlns:wp14="http://schemas.microsoft.com/office/word/2010/wordprocessingDrawing" xmlns:mc="http://schemas.openxmlformats.org/markup-compatibility/2006" xmlns:sl="http://schemas.openxmlformats.org/schemaLibrary/2006/main" xmlns:wne="http://schemas.microsoft.com/office/word/2006/wordml" xmlns:cdr="http://schemas.openxmlformats.org/drawingml/2006/chartDrawing" xmlns:c14="http://schemas.microsoft.com/office/drawing/2007/8/2/chart" xmlns:dgm="http://schemas.openxmlformats.org/drawingml/2006/diagram" xmlns:pic="http://schemas.openxmlformats.org/drawingml/2006/picture" xmlns:xdr="http://schemas.openxmlformats.org/drawingml/2006/spreadsheetDrawing" xmlns:dsp="http://schemas.microsoft.com/office/drawing/2008/diagram" xmlns:xvml="urn:schemas-microsoft-com:office:excel" xmlns:o="urn:schemas-microsoft-com:office:office" xmlns:v="urn:schemas-microsoft-com:vml" xmlns:w10="urn:schemas-microsoft-com:office:word" xmlns:pvml="urn:schemas-microsoft-com:office:powerpoint" xmlns:cppr="http://schemas.microsoft.com/office/2006/coverPageProps" xmlns:odx="http://opendope.org/xpaths" xmlns:odc="http://opendope.org/conditions" xmlns:odq="http://opendope.org/questions" xmlns:oda="http://opendope.org/answers" xmlns:odi="http://opendope.org/components" xmlns:odgm="http://opendope.org/SmartArt/DataHierarchy" xmlns:b="http://schemas.openxmlformats.org/officeDocument/2006/bibliography" xmlns:wps="http://schemas.microsoft.com/office/word/2010/wordprocessingShape" xmlns:w16se="http://schemas.microsoft.com/office/word/2015/wordml/symex" xmlns:w16cid="http://schemas.microsoft.com/office/word/2016/wordml/cid" xmlns:wetp="http://schemas.microsoft.com/office/webextensions/taskpanes/2010/11" xmlns:we="http://schemas.microsoft.com/office/webextensions/webextension/2010/11" xmlns:comp="http://schemas.openxmlformats.org/drawingml/2006/compatibility" xmlns:lc="http://schemas.openxmlformats.org/drawingml/2006/lockedCanvas">
             <c:ext xmlns:c16="http://schemas.microsoft.com/office/drawing/2014/chart" uri="{C3380CC4-5D6E-409C-BE32-E72D297353CC}">
               <c16:uniqueId val="{00000002-6147-E74A-AA7B-5531F0E4EE0C}"/>
             </c:ext>
@@ -4474,7 +4474,7 @@
     <c:plotVisOnly val="1"/>
     <c:dispBlanksAs val="gap"/>
     <c:showDLblsOverMax val="0"/>
-    <c:extLst xmlns:lc="http://schemas.openxmlformats.org/drawingml/2006/lockedCanvas" xmlns:comp="http://schemas.openxmlformats.org/drawingml/2006/compatibility" xmlns:we="http://schemas.microsoft.com/office/webextensions/webextension/2010/11" xmlns:wetp="http://schemas.microsoft.com/office/webextensions/taskpanes/2010/11" xmlns:w16cid="http://schemas.microsoft.com/office/word/2016/wordml/cid" xmlns:w16se="http://schemas.microsoft.com/office/word/2015/wordml/symex" xmlns:wps="http://schemas.microsoft.com/office/word/2010/wordprocessingShape" xmlns:b="http://schemas.openxmlformats.org/officeDocument/2006/bibliography" xmlns:odgm="http://opendope.org/SmartArt/DataHierarchy" xmlns:odi="http://opendope.org/components" xmlns:oda="http://opendope.org/answers" xmlns:odq="http://opendope.org/questions" xmlns:odc="http://opendope.org/conditions" xmlns:odx="http://opendope.org/xpaths" xmlns:cppr="http://schemas.microsoft.com/office/2006/coverPageProps" xmlns:pvml="urn:schemas-microsoft-com:office:powerpoint" xmlns:w10="urn:schemas-microsoft-com:office:word" xmlns:v="urn:schemas-microsoft-com:vml" xmlns:o="urn:schemas-microsoft-com:office:office" xmlns:xvml="urn:schemas-microsoft-com:office:excel" xmlns:dsp="http://schemas.microsoft.com/office/drawing/2008/diagram" xmlns:xdr="http://schemas.openxmlformats.org/drawingml/2006/spreadsheetDrawing" xmlns:pic="http://schemas.openxmlformats.org/drawingml/2006/picture" xmlns:dgm="http://schemas.openxmlformats.org/drawingml/2006/diagram" xmlns:c14="http://schemas.microsoft.com/office/drawing/2007/8/2/chart" xmlns:cdr="http://schemas.openxmlformats.org/drawingml/2006/chartDrawing" xmlns:wne="http://schemas.microsoft.com/office/word/2006/wordml" xmlns:sl="http://schemas.openxmlformats.org/schemaLibrary/2006/main" xmlns:mc="http://schemas.openxmlformats.org/markup-compatibility/2006" xmlns:wp14="http://schemas.microsoft.com/office/word/2010/wordprocessingDrawing" xmlns:wp="http://schemas.openxmlformats.org/drawingml/2006/wordprocessingDrawing" xmlns:m="http://schemas.openxmlformats.org/officeDocument/2006/math" xmlns:w14="http://schemas.microsoft.com/office/word/2010/wordml" xmlns:w15="http://schemas.microsoft.com/office/word/2012/wordml" xmlns:w="http://schemas.openxmlformats.org/wordprocessingml/2006/main">
+    <c:extLst xmlns:w="http://schemas.openxmlformats.org/wordprocessingml/2006/main" xmlns:w15="http://schemas.microsoft.com/office/word/2012/wordml" xmlns:w14="http://schemas.microsoft.com/office/word/2010/wordml" xmlns:m="http://schemas.openxmlformats.org/officeDocument/2006/math" xmlns:wp="http://schemas.openxmlformats.org/drawingml/2006/wordprocessingDrawing" xmlns:wp14="http://schemas.microsoft.com/office/word/2010/wordprocessingDrawing" xmlns:mc="http://schemas.openxmlformats.org/markup-compatibility/2006" xmlns:sl="http://schemas.openxmlformats.org/schemaLibrary/2006/main" xmlns:wne="http://schemas.microsoft.com/office/word/2006/wordml" xmlns:cdr="http://schemas.openxmlformats.org/drawingml/2006/chartDrawing" xmlns:c14="http://schemas.microsoft.com/office/drawing/2007/8/2/chart" xmlns:dgm="http://schemas.openxmlformats.org/drawingml/2006/diagram" xmlns:pic="http://schemas.openxmlformats.org/drawingml/2006/picture" xmlns:xdr="http://schemas.openxmlformats.org/drawingml/2006/spreadsheetDrawing" xmlns:dsp="http://schemas.microsoft.com/office/drawing/2008/diagram" xmlns:xvml="urn:schemas-microsoft-com:office:excel" xmlns:o="urn:schemas-microsoft-com:office:office" xmlns:v="urn:schemas-microsoft-com:vml" xmlns:w10="urn:schemas-microsoft-com:office:word" xmlns:pvml="urn:schemas-microsoft-com:office:powerpoint" xmlns:cppr="http://schemas.microsoft.com/office/2006/coverPageProps" xmlns:odx="http://opendope.org/xpaths" xmlns:odc="http://opendope.org/conditions" xmlns:odq="http://opendope.org/questions" xmlns:oda="http://opendope.org/answers" xmlns:odi="http://opendope.org/components" xmlns:odgm="http://opendope.org/SmartArt/DataHierarchy" xmlns:b="http://schemas.openxmlformats.org/officeDocument/2006/bibliography" xmlns:wps="http://schemas.microsoft.com/office/word/2010/wordprocessingShape" xmlns:w16se="http://schemas.microsoft.com/office/word/2015/wordml/symex" xmlns:w16cid="http://schemas.microsoft.com/office/word/2016/wordml/cid" xmlns:wetp="http://schemas.microsoft.com/office/webextensions/taskpanes/2010/11" xmlns:we="http://schemas.microsoft.com/office/webextensions/webextension/2010/11" xmlns:comp="http://schemas.openxmlformats.org/drawingml/2006/compatibility" xmlns:lc="http://schemas.openxmlformats.org/drawingml/2006/lockedCanvas">
       <c:ext xmlns:c16r3="http://schemas.microsoft.com/office/drawing/2017/03/chart" uri="{56B9EC1D-385E-4148-901F-78D8002777C0}">
         <c16r3:dataDisplayOptions16>
           <c16r3:dispNaAsBlank val="1"/>
@@ -4576,7 +4576,7 @@
                 </a:outerShdw>
               </a:effectLst>
             </c:spPr>
-            <c:extLst xmlns:lc="http://schemas.openxmlformats.org/drawingml/2006/lockedCanvas" xmlns:comp="http://schemas.openxmlformats.org/drawingml/2006/compatibility" xmlns:we="http://schemas.microsoft.com/office/webextensions/webextension/2010/11" xmlns:wetp="http://schemas.microsoft.com/office/webextensions/taskpanes/2010/11" xmlns:w16cid="http://schemas.microsoft.com/office/word/2016/wordml/cid" xmlns:w16se="http://schemas.microsoft.com/office/word/2015/wordml/symex" xmlns:wps="http://schemas.microsoft.com/office/word/2010/wordprocessingShape" xmlns:b="http://schemas.openxmlformats.org/officeDocument/2006/bibliography" xmlns:odgm="http://opendope.org/SmartArt/DataHierarchy" xmlns:odi="http://opendope.org/components" xmlns:oda="http://opendope.org/answers" xmlns:odq="http://opendope.org/questions" xmlns:odc="http://opendope.org/conditions" xmlns:odx="http://opendope.org/xpaths" xmlns:cppr="http://schemas.microsoft.com/office/2006/coverPageProps" xmlns:pvml="urn:schemas-microsoft-com:office:powerpoint" xmlns:w10="urn:schemas-microsoft-com:office:word" xmlns:v="urn:schemas-microsoft-com:vml" xmlns:o="urn:schemas-microsoft-com:office:office" xmlns:xvml="urn:schemas-microsoft-com:office:excel" xmlns:dsp="http://schemas.microsoft.com/office/drawing/2008/diagram" xmlns:xdr="http://schemas.openxmlformats.org/drawingml/2006/spreadsheetDrawing" xmlns:pic="http://schemas.openxmlformats.org/drawingml/2006/picture" xmlns:dgm="http://schemas.openxmlformats.org/drawingml/2006/diagram" xmlns:c14="http://schemas.microsoft.com/office/drawing/2007/8/2/chart" xmlns:cdr="http://schemas.openxmlformats.org/drawingml/2006/chartDrawing" xmlns:wne="http://schemas.microsoft.com/office/word/2006/wordml" xmlns:sl="http://schemas.openxmlformats.org/schemaLibrary/2006/main" xmlns:mc="http://schemas.openxmlformats.org/markup-compatibility/2006" xmlns:wp14="http://schemas.microsoft.com/office/word/2010/wordprocessingDrawing" xmlns:wp="http://schemas.openxmlformats.org/drawingml/2006/wordprocessingDrawing" xmlns:m="http://schemas.openxmlformats.org/officeDocument/2006/math" xmlns:w14="http://schemas.microsoft.com/office/word/2010/wordml" xmlns:w15="http://schemas.microsoft.com/office/word/2012/wordml" xmlns:w="http://schemas.openxmlformats.org/wordprocessingml/2006/main">
+            <c:extLst xmlns:w="http://schemas.openxmlformats.org/wordprocessingml/2006/main" xmlns:w15="http://schemas.microsoft.com/office/word/2012/wordml" xmlns:w14="http://schemas.microsoft.com/office/word/2010/wordml" xmlns:m="http://schemas.openxmlformats.org/officeDocument/2006/math" xmlns:wp="http://schemas.openxmlformats.org/drawingml/2006/wordprocessingDrawing" xmlns:wp14="http://schemas.microsoft.com/office/word/2010/wordprocessingDrawing" xmlns:mc="http://schemas.openxmlformats.org/markup-compatibility/2006" xmlns:sl="http://schemas.openxmlformats.org/schemaLibrary/2006/main" xmlns:wne="http://schemas.microsoft.com/office/word/2006/wordml" xmlns:cdr="http://schemas.openxmlformats.org/drawingml/2006/chartDrawing" xmlns:c14="http://schemas.microsoft.com/office/drawing/2007/8/2/chart" xmlns:dgm="http://schemas.openxmlformats.org/drawingml/2006/diagram" xmlns:pic="http://schemas.openxmlformats.org/drawingml/2006/picture" xmlns:xdr="http://schemas.openxmlformats.org/drawingml/2006/spreadsheetDrawing" xmlns:dsp="http://schemas.microsoft.com/office/drawing/2008/diagram" xmlns:xvml="urn:schemas-microsoft-com:office:excel" xmlns:o="urn:schemas-microsoft-com:office:office" xmlns:v="urn:schemas-microsoft-com:vml" xmlns:w10="urn:schemas-microsoft-com:office:word" xmlns:pvml="urn:schemas-microsoft-com:office:powerpoint" xmlns:cppr="http://schemas.microsoft.com/office/2006/coverPageProps" xmlns:odx="http://opendope.org/xpaths" xmlns:odc="http://opendope.org/conditions" xmlns:odq="http://opendope.org/questions" xmlns:oda="http://opendope.org/answers" xmlns:odi="http://opendope.org/components" xmlns:odgm="http://opendope.org/SmartArt/DataHierarchy" xmlns:b="http://schemas.openxmlformats.org/officeDocument/2006/bibliography" xmlns:wps="http://schemas.microsoft.com/office/word/2010/wordprocessingShape" xmlns:w16se="http://schemas.microsoft.com/office/word/2015/wordml/symex" xmlns:w16cid="http://schemas.microsoft.com/office/word/2016/wordml/cid" xmlns:wetp="http://schemas.microsoft.com/office/webextensions/taskpanes/2010/11" xmlns:we="http://schemas.microsoft.com/office/webextensions/webextension/2010/11" xmlns:comp="http://schemas.openxmlformats.org/drawingml/2006/compatibility" xmlns:lc="http://schemas.openxmlformats.org/drawingml/2006/lockedCanvas">
               <c:ext xmlns:c16="http://schemas.microsoft.com/office/drawing/2014/chart" uri="{C3380CC4-5D6E-409C-BE32-E72D297353CC}">
                 <c16:uniqueId val="{00000001-6147-E74A-AA7B-5531F0E4EE0C}"/>
               </c:ext>
@@ -4671,7 +4671,7 @@
               </c:numCache>
             </c:numRef>
           </c:val>
-          <c:extLst xmlns:lc="http://schemas.openxmlformats.org/drawingml/2006/lockedCanvas" xmlns:comp="http://schemas.openxmlformats.org/drawingml/2006/compatibility" xmlns:we="http://schemas.microsoft.com/office/webextensions/webextension/2010/11" xmlns:wetp="http://schemas.microsoft.com/office/webextensions/taskpanes/2010/11" xmlns:w16cid="http://schemas.microsoft.com/office/word/2016/wordml/cid" xmlns:w16se="http://schemas.microsoft.com/office/word/2015/wordml/symex" xmlns:wps="http://schemas.microsoft.com/office/word/2010/wordprocessingShape" xmlns:b="http://schemas.openxmlformats.org/officeDocument/2006/bibliography" xmlns:odgm="http://opendope.org/SmartArt/DataHierarchy" xmlns:odi="http://opendope.org/components" xmlns:oda="http://opendope.org/answers" xmlns:odq="http://opendope.org/questions" xmlns:odc="http://opendope.org/conditions" xmlns:odx="http://opendope.org/xpaths" xmlns:cppr="http://schemas.microsoft.com/office/2006/coverPageProps" xmlns:pvml="urn:schemas-microsoft-com:office:powerpoint" xmlns:w10="urn:schemas-microsoft-com:office:word" xmlns:v="urn:schemas-microsoft-com:vml" xmlns:o="urn:schemas-microsoft-com:office:office" xmlns:xvml="urn:schemas-microsoft-com:office:excel" xmlns:dsp="http://schemas.microsoft.com/office/drawing/2008/diagram" xmlns:xdr="http://schemas.openxmlformats.org/drawingml/2006/spreadsheetDrawing" xmlns:pic="http://schemas.openxmlformats.org/drawingml/2006/picture" xmlns:dgm="http://schemas.openxmlformats.org/drawingml/2006/diagram" xmlns:c14="http://schemas.microsoft.com/office/drawing/2007/8/2/chart" xmlns:cdr="http://schemas.openxmlformats.org/drawingml/2006/chartDrawing" xmlns:wne="http://schemas.microsoft.com/office/word/2006/wordml" xmlns:sl="http://schemas.openxmlformats.org/schemaLibrary/2006/main" xmlns:mc="http://schemas.openxmlformats.org/markup-compatibility/2006" xmlns:wp14="http://schemas.microsoft.com/office/word/2010/wordprocessingDrawing" xmlns:wp="http://schemas.openxmlformats.org/drawingml/2006/wordprocessingDrawing" xmlns:m="http://schemas.openxmlformats.org/officeDocument/2006/math" xmlns:w14="http://schemas.microsoft.com/office/word/2010/wordml" xmlns:w15="http://schemas.microsoft.com/office/word/2012/wordml" xmlns:w="http://schemas.openxmlformats.org/wordprocessingml/2006/main">
+          <c:extLst xmlns:w="http://schemas.openxmlformats.org/wordprocessingml/2006/main" xmlns:w15="http://schemas.microsoft.com/office/word/2012/wordml" xmlns:w14="http://schemas.microsoft.com/office/word/2010/wordml" xmlns:m="http://schemas.openxmlformats.org/officeDocument/2006/math" xmlns:wp="http://schemas.openxmlformats.org/drawingml/2006/wordprocessingDrawing" xmlns:wp14="http://schemas.microsoft.com/office/word/2010/wordprocessingDrawing" xmlns:mc="http://schemas.openxmlformats.org/markup-compatibility/2006" xmlns:sl="http://schemas.openxmlformats.org/schemaLibrary/2006/main" xmlns:wne="http://schemas.microsoft.com/office/word/2006/wordml" xmlns:cdr="http://schemas.openxmlformats.org/drawingml/2006/chartDrawing" xmlns:c14="http://schemas.microsoft.com/office/drawing/2007/8/2/chart" xmlns:dgm="http://schemas.openxmlformats.org/drawingml/2006/diagram" xmlns:pic="http://schemas.openxmlformats.org/drawingml/2006/picture" xmlns:xdr="http://schemas.openxmlformats.org/drawingml/2006/spreadsheetDrawing" xmlns:dsp="http://schemas.microsoft.com/office/drawing/2008/diagram" xmlns:xvml="urn:schemas-microsoft-com:office:excel" xmlns:o="urn:schemas-microsoft-com:office:office" xmlns:v="urn:schemas-microsoft-com:vml" xmlns:w10="urn:schemas-microsoft-com:office:word" xmlns:pvml="urn:schemas-microsoft-com:office:powerpoint" xmlns:cppr="http://schemas.microsoft.com/office/2006/coverPageProps" xmlns:odx="http://opendope.org/xpaths" xmlns:odc="http://opendope.org/conditions" xmlns:odq="http://opendope.org/questions" xmlns:oda="http://opendope.org/answers" xmlns:odi="http://opendope.org/components" xmlns:odgm="http://opendope.org/SmartArt/DataHierarchy" xmlns:b="http://schemas.openxmlformats.org/officeDocument/2006/bibliography" xmlns:wps="http://schemas.microsoft.com/office/word/2010/wordprocessingShape" xmlns:w16se="http://schemas.microsoft.com/office/word/2015/wordml/symex" xmlns:w16cid="http://schemas.microsoft.com/office/word/2016/wordml/cid" xmlns:wetp="http://schemas.microsoft.com/office/webextensions/taskpanes/2010/11" xmlns:we="http://schemas.microsoft.com/office/webextensions/webextension/2010/11" xmlns:comp="http://schemas.openxmlformats.org/drawingml/2006/compatibility" xmlns:lc="http://schemas.openxmlformats.org/drawingml/2006/lockedCanvas">
             <c:ext xmlns:c16="http://schemas.microsoft.com/office/drawing/2014/chart" uri="{C3380CC4-5D6E-409C-BE32-E72D297353CC}">
               <c16:uniqueId val="{00000002-6147-E74A-AA7B-5531F0E4EE0C}"/>
             </c:ext>
@@ -5282,7 +5282,7 @@
     <c:plotVisOnly val="1"/>
     <c:dispBlanksAs val="gap"/>
     <c:showDLblsOverMax val="0"/>
-    <c:extLst xmlns:lc="http://schemas.openxmlformats.org/drawingml/2006/lockedCanvas" xmlns:comp="http://schemas.openxmlformats.org/drawingml/2006/compatibility" xmlns:we="http://schemas.microsoft.com/office/webextensions/webextension/2010/11" xmlns:wetp="http://schemas.microsoft.com/office/webextensions/taskpanes/2010/11" xmlns:w16cid="http://schemas.microsoft.com/office/word/2016/wordml/cid" xmlns:w16se="http://schemas.microsoft.com/office/word/2015/wordml/symex" xmlns:wps="http://schemas.microsoft.com/office/word/2010/wordprocessingShape" xmlns:b="http://schemas.openxmlformats.org/officeDocument/2006/bibliography" xmlns:odgm="http://opendope.org/SmartArt/DataHierarchy" xmlns:odi="http://opendope.org/components" xmlns:oda="http://opendope.org/answers" xmlns:odq="http://opendope.org/questions" xmlns:odc="http://opendope.org/conditions" xmlns:odx="http://opendope.org/xpaths" xmlns:cppr="http://schemas.microsoft.com/office/2006/coverPageProps" xmlns:pvml="urn:schemas-microsoft-com:office:powerpoint" xmlns:w10="urn:schemas-microsoft-com:office:word" xmlns:v="urn:schemas-microsoft-com:vml" xmlns:o="urn:schemas-microsoft-com:office:office" xmlns:xvml="urn:schemas-microsoft-com:office:excel" xmlns:dsp="http://schemas.microsoft.com/office/drawing/2008/diagram" xmlns:xdr="http://schemas.openxmlformats.org/drawingml/2006/spreadsheetDrawing" xmlns:pic="http://schemas.openxmlformats.org/drawingml/2006/picture" xmlns:dgm="http://schemas.openxmlformats.org/drawingml/2006/diagram" xmlns:c14="http://schemas.microsoft.com/office/drawing/2007/8/2/chart" xmlns:cdr="http://schemas.openxmlformats.org/drawingml/2006/chartDrawing" xmlns:wne="http://schemas.microsoft.com/office/word/2006/wordml" xmlns:sl="http://schemas.openxmlformats.org/schemaLibrary/2006/main" xmlns:mc="http://schemas.openxmlformats.org/markup-compatibility/2006" xmlns:wp14="http://schemas.microsoft.com/office/word/2010/wordprocessingDrawing" xmlns:wp="http://schemas.openxmlformats.org/drawingml/2006/wordprocessingDrawing" xmlns:m="http://schemas.openxmlformats.org/officeDocument/2006/math" xmlns:w14="http://schemas.microsoft.com/office/word/2010/wordml" xmlns:w15="http://schemas.microsoft.com/office/word/2012/wordml" xmlns:w="http://schemas.openxmlformats.org/wordprocessingml/2006/main">
+    <c:extLst xmlns:w="http://schemas.openxmlformats.org/wordprocessingml/2006/main" xmlns:w15="http://schemas.microsoft.com/office/word/2012/wordml" xmlns:w14="http://schemas.microsoft.com/office/word/2010/wordml" xmlns:m="http://schemas.openxmlformats.org/officeDocument/2006/math" xmlns:wp="http://schemas.openxmlformats.org/drawingml/2006/wordprocessingDrawing" xmlns:wp14="http://schemas.microsoft.com/office/word/2010/wordprocessingDrawing" xmlns:mc="http://schemas.openxmlformats.org/markup-compatibility/2006" xmlns:sl="http://schemas.openxmlformats.org/schemaLibrary/2006/main" xmlns:wne="http://schemas.microsoft.com/office/word/2006/wordml" xmlns:cdr="http://schemas.openxmlformats.org/drawingml/2006/chartDrawing" xmlns:c14="http://schemas.microsoft.com/office/drawing/2007/8/2/chart" xmlns:dgm="http://schemas.openxmlformats.org/drawingml/2006/diagram" xmlns:pic="http://schemas.openxmlformats.org/drawingml/2006/picture" xmlns:xdr="http://schemas.openxmlformats.org/drawingml/2006/spreadsheetDrawing" xmlns:dsp="http://schemas.microsoft.com/office/drawing/2008/diagram" xmlns:xvml="urn:schemas-microsoft-com:office:excel" xmlns:o="urn:schemas-microsoft-com:office:office" xmlns:v="urn:schemas-microsoft-com:vml" xmlns:w10="urn:schemas-microsoft-com:office:word" xmlns:pvml="urn:schemas-microsoft-com:office:powerpoint" xmlns:cppr="http://schemas.microsoft.com/office/2006/coverPageProps" xmlns:odx="http://opendope.org/xpaths" xmlns:odc="http://opendope.org/conditions" xmlns:odq="http://opendope.org/questions" xmlns:oda="http://opendope.org/answers" xmlns:odi="http://opendope.org/components" xmlns:odgm="http://opendope.org/SmartArt/DataHierarchy" xmlns:b="http://schemas.openxmlformats.org/officeDocument/2006/bibliography" xmlns:wps="http://schemas.microsoft.com/office/word/2010/wordprocessingShape" xmlns:w16se="http://schemas.microsoft.com/office/word/2015/wordml/symex" xmlns:w16cid="http://schemas.microsoft.com/office/word/2016/wordml/cid" xmlns:wetp="http://schemas.microsoft.com/office/webextensions/taskpanes/2010/11" xmlns:we="http://schemas.microsoft.com/office/webextensions/webextension/2010/11" xmlns:comp="http://schemas.openxmlformats.org/drawingml/2006/compatibility" xmlns:lc="http://schemas.openxmlformats.org/drawingml/2006/lockedCanvas">
       <c:ext xmlns:c16r3="http://schemas.microsoft.com/office/drawing/2017/03/chart" uri="{56B9EC1D-385E-4148-901F-78D8002777C0}">
         <c16r3:dataDisplayOptions16>
           <c16r3:dispNaAsBlank val="1"/>
@@ -5384,7 +5384,7 @@
                 </a:outerShdw>
               </a:effectLst>
             </c:spPr>
-            <c:extLst xmlns:lc="http://schemas.openxmlformats.org/drawingml/2006/lockedCanvas" xmlns:comp="http://schemas.openxmlformats.org/drawingml/2006/compatibility" xmlns:we="http://schemas.microsoft.com/office/webextensions/webextension/2010/11" xmlns:wetp="http://schemas.microsoft.com/office/webextensions/taskpanes/2010/11" xmlns:w16cid="http://schemas.microsoft.com/office/word/2016/wordml/cid" xmlns:w16se="http://schemas.microsoft.com/office/word/2015/wordml/symex" xmlns:wps="http://schemas.microsoft.com/office/word/2010/wordprocessingShape" xmlns:b="http://schemas.openxmlformats.org/officeDocument/2006/bibliography" xmlns:odgm="http://opendope.org/SmartArt/DataHierarchy" xmlns:odi="http://opendope.org/components" xmlns:oda="http://opendope.org/answers" xmlns:odq="http://opendope.org/questions" xmlns:odc="http://opendope.org/conditions" xmlns:odx="http://opendope.org/xpaths" xmlns:cppr="http://schemas.microsoft.com/office/2006/coverPageProps" xmlns:pvml="urn:schemas-microsoft-com:office:powerpoint" xmlns:w10="urn:schemas-microsoft-com:office:word" xmlns:v="urn:schemas-microsoft-com:vml" xmlns:o="urn:schemas-microsoft-com:office:office" xmlns:xvml="urn:schemas-microsoft-com:office:excel" xmlns:dsp="http://schemas.microsoft.com/office/drawing/2008/diagram" xmlns:xdr="http://schemas.openxmlformats.org/drawingml/2006/spreadsheetDrawing" xmlns:pic="http://schemas.openxmlformats.org/drawingml/2006/picture" xmlns:dgm="http://schemas.openxmlformats.org/drawingml/2006/diagram" xmlns:c14="http://schemas.microsoft.com/office/drawing/2007/8/2/chart" xmlns:cdr="http://schemas.openxmlformats.org/drawingml/2006/chartDrawing" xmlns:wne="http://schemas.microsoft.com/office/word/2006/wordml" xmlns:sl="http://schemas.openxmlformats.org/schemaLibrary/2006/main" xmlns:mc="http://schemas.openxmlformats.org/markup-compatibility/2006" xmlns:wp14="http://schemas.microsoft.com/office/word/2010/wordprocessingDrawing" xmlns:wp="http://schemas.openxmlformats.org/drawingml/2006/wordprocessingDrawing" xmlns:m="http://schemas.openxmlformats.org/officeDocument/2006/math" xmlns:w14="http://schemas.microsoft.com/office/word/2010/wordml" xmlns:w15="http://schemas.microsoft.com/office/word/2012/wordml" xmlns:w="http://schemas.openxmlformats.org/wordprocessingml/2006/main">
+            <c:extLst xmlns:w="http://schemas.openxmlformats.org/wordprocessingml/2006/main" xmlns:w15="http://schemas.microsoft.com/office/word/2012/wordml" xmlns:w14="http://schemas.microsoft.com/office/word/2010/wordml" xmlns:m="http://schemas.openxmlformats.org/officeDocument/2006/math" xmlns:wp="http://schemas.openxmlformats.org/drawingml/2006/wordprocessingDrawing" xmlns:wp14="http://schemas.microsoft.com/office/word/2010/wordprocessingDrawing" xmlns:mc="http://schemas.openxmlformats.org/markup-compatibility/2006" xmlns:sl="http://schemas.openxmlformats.org/schemaLibrary/2006/main" xmlns:wne="http://schemas.microsoft.com/office/word/2006/wordml" xmlns:cdr="http://schemas.openxmlformats.org/drawingml/2006/chartDrawing" xmlns:c14="http://schemas.microsoft.com/office/drawing/2007/8/2/chart" xmlns:dgm="http://schemas.openxmlformats.org/drawingml/2006/diagram" xmlns:pic="http://schemas.openxmlformats.org/drawingml/2006/picture" xmlns:xdr="http://schemas.openxmlformats.org/drawingml/2006/spreadsheetDrawing" xmlns:dsp="http://schemas.microsoft.com/office/drawing/2008/diagram" xmlns:xvml="urn:schemas-microsoft-com:office:excel" xmlns:o="urn:schemas-microsoft-com:office:office" xmlns:v="urn:schemas-microsoft-com:vml" xmlns:w10="urn:schemas-microsoft-com:office:word" xmlns:pvml="urn:schemas-microsoft-com:office:powerpoint" xmlns:cppr="http://schemas.microsoft.com/office/2006/coverPageProps" xmlns:odx="http://opendope.org/xpaths" xmlns:odc="http://opendope.org/conditions" xmlns:odq="http://opendope.org/questions" xmlns:oda="http://opendope.org/answers" xmlns:odi="http://opendope.org/components" xmlns:odgm="http://opendope.org/SmartArt/DataHierarchy" xmlns:b="http://schemas.openxmlformats.org/officeDocument/2006/bibliography" xmlns:wps="http://schemas.microsoft.com/office/word/2010/wordprocessingShape" xmlns:w16se="http://schemas.microsoft.com/office/word/2015/wordml/symex" xmlns:w16cid="http://schemas.microsoft.com/office/word/2016/wordml/cid" xmlns:wetp="http://schemas.microsoft.com/office/webextensions/taskpanes/2010/11" xmlns:we="http://schemas.microsoft.com/office/webextensions/webextension/2010/11" xmlns:comp="http://schemas.openxmlformats.org/drawingml/2006/compatibility" xmlns:lc="http://schemas.openxmlformats.org/drawingml/2006/lockedCanvas">
               <c:ext xmlns:c16="http://schemas.microsoft.com/office/drawing/2014/chart" uri="{C3380CC4-5D6E-409C-BE32-E72D297353CC}">
                 <c16:uniqueId val="{00000001-6147-E74A-AA7B-5531F0E4EE0C}"/>
               </c:ext>
@@ -5479,7 +5479,7 @@
               </c:numCache>
             </c:numRef>
           </c:val>
-          <c:extLst xmlns:lc="http://schemas.openxmlformats.org/drawingml/2006/lockedCanvas" xmlns:comp="http://schemas.openxmlformats.org/drawingml/2006/compatibility" xmlns:we="http://schemas.microsoft.com/office/webextensions/webextension/2010/11" xmlns:wetp="http://schemas.microsoft.com/office/webextensions/taskpanes/2010/11" xmlns:w16cid="http://schemas.microsoft.com/office/word/2016/wordml/cid" xmlns:w16se="http://schemas.microsoft.com/office/word/2015/wordml/symex" xmlns:wps="http://schemas.microsoft.com/office/word/2010/wordprocessingShape" xmlns:b="http://schemas.openxmlformats.org/officeDocument/2006/bibliography" xmlns:odgm="http://opendope.org/SmartArt/DataHierarchy" xmlns:odi="http://opendope.org/components" xmlns:oda="http://opendope.org/answers" xmlns:odq="http://opendope.org/questions" xmlns:odc="http://opendope.org/conditions" xmlns:odx="http://opendope.org/xpaths" xmlns:cppr="http://schemas.microsoft.com/office/2006/coverPageProps" xmlns:pvml="urn:schemas-microsoft-com:office:powerpoint" xmlns:w10="urn:schemas-microsoft-com:office:word" xmlns:v="urn:schemas-microsoft-com:vml" xmlns:o="urn:schemas-microsoft-com:office:office" xmlns:xvml="urn:schemas-microsoft-com:office:excel" xmlns:dsp="http://schemas.microsoft.com/office/drawing/2008/diagram" xmlns:xdr="http://schemas.openxmlformats.org/drawingml/2006/spreadsheetDrawing" xmlns:pic="http://schemas.openxmlformats.org/drawingml/2006/picture" xmlns:dgm="http://schemas.openxmlformats.org/drawingml/2006/diagram" xmlns:c14="http://schemas.microsoft.com/office/drawing/2007/8/2/chart" xmlns:cdr="http://schemas.openxmlformats.org/drawingml/2006/chartDrawing" xmlns:wne="http://schemas.microsoft.com/office/word/2006/wordml" xmlns:sl="http://schemas.openxmlformats.org/schemaLibrary/2006/main" xmlns:mc="http://schemas.openxmlformats.org/markup-compatibility/2006" xmlns:wp14="http://schemas.microsoft.com/office/word/2010/wordprocessingDrawing" xmlns:wp="http://schemas.openxmlformats.org/drawingml/2006/wordprocessingDrawing" xmlns:m="http://schemas.openxmlformats.org/officeDocument/2006/math" xmlns:w14="http://schemas.microsoft.com/office/word/2010/wordml" xmlns:w15="http://schemas.microsoft.com/office/word/2012/wordml" xmlns:w="http://schemas.openxmlformats.org/wordprocessingml/2006/main">
+          <c:extLst xmlns:w="http://schemas.openxmlformats.org/wordprocessingml/2006/main" xmlns:w15="http://schemas.microsoft.com/office/word/2012/wordml" xmlns:w14="http://schemas.microsoft.com/office/word/2010/wordml" xmlns:m="http://schemas.openxmlformats.org/officeDocument/2006/math" xmlns:wp="http://schemas.openxmlformats.org/drawingml/2006/wordprocessingDrawing" xmlns:wp14="http://schemas.microsoft.com/office/word/2010/wordprocessingDrawing" xmlns:mc="http://schemas.openxmlformats.org/markup-compatibility/2006" xmlns:sl="http://schemas.openxmlformats.org/schemaLibrary/2006/main" xmlns:wne="http://schemas.microsoft.com/office/word/2006/wordml" xmlns:cdr="http://schemas.openxmlformats.org/drawingml/2006/chartDrawing" xmlns:c14="http://schemas.microsoft.com/office/drawing/2007/8/2/chart" xmlns:dgm="http://schemas.openxmlformats.org/drawingml/2006/diagram" xmlns:pic="http://schemas.openxmlformats.org/drawingml/2006/picture" xmlns:xdr="http://schemas.openxmlformats.org/drawingml/2006/spreadsheetDrawing" xmlns:dsp="http://schemas.microsoft.com/office/drawing/2008/diagram" xmlns:xvml="urn:schemas-microsoft-com:office:excel" xmlns:o="urn:schemas-microsoft-com:office:office" xmlns:v="urn:schemas-microsoft-com:vml" xmlns:w10="urn:schemas-microsoft-com:office:word" xmlns:pvml="urn:schemas-microsoft-com:office:powerpoint" xmlns:cppr="http://schemas.microsoft.com/office/2006/coverPageProps" xmlns:odx="http://opendope.org/xpaths" xmlns:odc="http://opendope.org/conditions" xmlns:odq="http://opendope.org/questions" xmlns:oda="http://opendope.org/answers" xmlns:odi="http://opendope.org/components" xmlns:odgm="http://opendope.org/SmartArt/DataHierarchy" xmlns:b="http://schemas.openxmlformats.org/officeDocument/2006/bibliography" xmlns:wps="http://schemas.microsoft.com/office/word/2010/wordprocessingShape" xmlns:w16se="http://schemas.microsoft.com/office/word/2015/wordml/symex" xmlns:w16cid="http://schemas.microsoft.com/office/word/2016/wordml/cid" xmlns:wetp="http://schemas.microsoft.com/office/webextensions/taskpanes/2010/11" xmlns:we="http://schemas.microsoft.com/office/webextensions/webextension/2010/11" xmlns:comp="http://schemas.openxmlformats.org/drawingml/2006/compatibility" xmlns:lc="http://schemas.openxmlformats.org/drawingml/2006/lockedCanvas">
             <c:ext xmlns:c16="http://schemas.microsoft.com/office/drawing/2014/chart" uri="{C3380CC4-5D6E-409C-BE32-E72D297353CC}">
               <c16:uniqueId val="{00000002-6147-E74A-AA7B-5531F0E4EE0C}"/>
             </c:ext>
@@ -6090,7 +6090,7 @@
     <c:plotVisOnly val="1"/>
     <c:dispBlanksAs val="gap"/>
     <c:showDLblsOverMax val="0"/>
-    <c:extLst xmlns:lc="http://schemas.openxmlformats.org/drawingml/2006/lockedCanvas" xmlns:comp="http://schemas.openxmlformats.org/drawingml/2006/compatibility" xmlns:we="http://schemas.microsoft.com/office/webextensions/webextension/2010/11" xmlns:wetp="http://schemas.microsoft.com/office/webextensions/taskpanes/2010/11" xmlns:w16cid="http://schemas.microsoft.com/office/word/2016/wordml/cid" xmlns:w16se="http://schemas.microsoft.com/office/word/2015/wordml/symex" xmlns:wps="http://schemas.microsoft.com/office/word/2010/wordprocessingShape" xmlns:b="http://schemas.openxmlformats.org/officeDocument/2006/bibliography" xmlns:odgm="http://opendope.org/SmartArt/DataHierarchy" xmlns:odi="http://opendope.org/components" xmlns:oda="http://opendope.org/answers" xmlns:odq="http://opendope.org/questions" xmlns:odc="http://opendope.org/conditions" xmlns:odx="http://opendope.org/xpaths" xmlns:cppr="http://schemas.microsoft.com/office/2006/coverPageProps" xmlns:pvml="urn:schemas-microsoft-com:office:powerpoint" xmlns:w10="urn:schemas-microsoft-com:office:word" xmlns:v="urn:schemas-microsoft-com:vml" xmlns:o="urn:schemas-microsoft-com:office:office" xmlns:xvml="urn:schemas-microsoft-com:office:excel" xmlns:dsp="http://schemas.microsoft.com/office/drawing/2008/diagram" xmlns:xdr="http://schemas.openxmlformats.org/drawingml/2006/spreadsheetDrawing" xmlns:pic="http://schemas.openxmlformats.org/drawingml/2006/picture" xmlns:dgm="http://schemas.openxmlformats.org/drawingml/2006/diagram" xmlns:c14="http://schemas.microsoft.com/office/drawing/2007/8/2/chart" xmlns:cdr="http://schemas.openxmlformats.org/drawingml/2006/chartDrawing" xmlns:wne="http://schemas.microsoft.com/office/word/2006/wordml" xmlns:sl="http://schemas.openxmlformats.org/schemaLibrary/2006/main" xmlns:mc="http://schemas.openxmlformats.org/markup-compatibility/2006" xmlns:wp14="http://schemas.microsoft.com/office/word/2010/wordprocessingDrawing" xmlns:wp="http://schemas.openxmlformats.org/drawingml/2006/wordprocessingDrawing" xmlns:m="http://schemas.openxmlformats.org/officeDocument/2006/math" xmlns:w14="http://schemas.microsoft.com/office/word/2010/wordml" xmlns:w15="http://schemas.microsoft.com/office/word/2012/wordml" xmlns:w="http://schemas.openxmlformats.org/wordprocessingml/2006/main">
+    <c:extLst xmlns:w="http://schemas.openxmlformats.org/wordprocessingml/2006/main" xmlns:w15="http://schemas.microsoft.com/office/word/2012/wordml" xmlns:w14="http://schemas.microsoft.com/office/word/2010/wordml" xmlns:m="http://schemas.openxmlformats.org/officeDocument/2006/math" xmlns:wp="http://schemas.openxmlformats.org/drawingml/2006/wordprocessingDrawing" xmlns:wp14="http://schemas.microsoft.com/office/word/2010/wordprocessingDrawing" xmlns:mc="http://schemas.openxmlformats.org/markup-compatibility/2006" xmlns:sl="http://schemas.openxmlformats.org/schemaLibrary/2006/main" xmlns:wne="http://schemas.microsoft.com/office/word/2006/wordml" xmlns:cdr="http://schemas.openxmlformats.org/drawingml/2006/chartDrawing" xmlns:c14="http://schemas.microsoft.com/office/drawing/2007/8/2/chart" xmlns:dgm="http://schemas.openxmlformats.org/drawingml/2006/diagram" xmlns:pic="http://schemas.openxmlformats.org/drawingml/2006/picture" xmlns:xdr="http://schemas.openxmlformats.org/drawingml/2006/spreadsheetDrawing" xmlns:dsp="http://schemas.microsoft.com/office/drawing/2008/diagram" xmlns:xvml="urn:schemas-microsoft-com:office:excel" xmlns:o="urn:schemas-microsoft-com:office:office" xmlns:v="urn:schemas-microsoft-com:vml" xmlns:w10="urn:schemas-microsoft-com:office:word" xmlns:pvml="urn:schemas-microsoft-com:office:powerpoint" xmlns:cppr="http://schemas.microsoft.com/office/2006/coverPageProps" xmlns:odx="http://opendope.org/xpaths" xmlns:odc="http://opendope.org/conditions" xmlns:odq="http://opendope.org/questions" xmlns:oda="http://opendope.org/answers" xmlns:odi="http://opendope.org/components" xmlns:odgm="http://opendope.org/SmartArt/DataHierarchy" xmlns:b="http://schemas.openxmlformats.org/officeDocument/2006/bibliography" xmlns:wps="http://schemas.microsoft.com/office/word/2010/wordprocessingShape" xmlns:w16se="http://schemas.microsoft.com/office/word/2015/wordml/symex" xmlns:w16cid="http://schemas.microsoft.com/office/word/2016/wordml/cid" xmlns:wetp="http://schemas.microsoft.com/office/webextensions/taskpanes/2010/11" xmlns:we="http://schemas.microsoft.com/office/webextensions/webextension/2010/11" xmlns:comp="http://schemas.openxmlformats.org/drawingml/2006/compatibility" xmlns:lc="http://schemas.openxmlformats.org/drawingml/2006/lockedCanvas">
       <c:ext xmlns:c16r3="http://schemas.microsoft.com/office/drawing/2017/03/chart" uri="{56B9EC1D-385E-4148-901F-78D8002777C0}">
         <c16r3:dataDisplayOptions16>
           <c16r3:dispNaAsBlank val="1"/>
@@ -10403,7 +10403,7 @@
           <a:p>
             <a:fld id="{D672B8B4-E227-994A-A2C0-477E986EF4F1}" type="datetimeFigureOut">
               <a:rPr lang="nl-NL" smtClean="0"/>
-              <a:t>08-11-2025</a:t>
+              <a:t>03-12-2025</a:t>
             </a:fld>
             <a:endParaRPr lang="nl-NL"/>
           </a:p>
@@ -12668,7 +12668,7 @@
           <a:p>
             <a:fld id="{542F8156-3D1B-1047-9A3D-372BE84AD46C}" type="datetimeFigureOut">
               <a:rPr lang="nl-NL" smtClean="0"/>
-              <a:t>08-11-2025</a:t>
+              <a:t>03-12-2025</a:t>
             </a:fld>
             <a:endParaRPr lang="nl-NL"/>
           </a:p>
@@ -12868,7 +12868,7 @@
           <a:p>
             <a:fld id="{542F8156-3D1B-1047-9A3D-372BE84AD46C}" type="datetimeFigureOut">
               <a:rPr lang="nl-NL" smtClean="0"/>
-              <a:t>08-11-2025</a:t>
+              <a:t>03-12-2025</a:t>
             </a:fld>
             <a:endParaRPr lang="nl-NL"/>
           </a:p>
@@ -13078,7 +13078,7 @@
           <a:p>
             <a:fld id="{542F8156-3D1B-1047-9A3D-372BE84AD46C}" type="datetimeFigureOut">
               <a:rPr lang="nl-NL" smtClean="0"/>
-              <a:t>08-11-2025</a:t>
+              <a:t>03-12-2025</a:t>
             </a:fld>
             <a:endParaRPr lang="nl-NL"/>
           </a:p>
@@ -14003,7 +14003,7 @@
           <a:p>
             <a:fld id="{542F8156-3D1B-1047-9A3D-372BE84AD46C}" type="datetimeFigureOut">
               <a:rPr lang="nl-NL" smtClean="0"/>
-              <a:t>08-11-2025</a:t>
+              <a:t>03-12-2025</a:t>
             </a:fld>
             <a:endParaRPr lang="nl-NL"/>
           </a:p>
@@ -14279,7 +14279,7 @@
           <a:p>
             <a:fld id="{542F8156-3D1B-1047-9A3D-372BE84AD46C}" type="datetimeFigureOut">
               <a:rPr lang="nl-NL" smtClean="0"/>
-              <a:t>08-11-2025</a:t>
+              <a:t>03-12-2025</a:t>
             </a:fld>
             <a:endParaRPr lang="nl-NL"/>
           </a:p>
@@ -14547,7 +14547,7 @@
           <a:p>
             <a:fld id="{542F8156-3D1B-1047-9A3D-372BE84AD46C}" type="datetimeFigureOut">
               <a:rPr lang="nl-NL" smtClean="0"/>
-              <a:t>08-11-2025</a:t>
+              <a:t>03-12-2025</a:t>
             </a:fld>
             <a:endParaRPr lang="nl-NL"/>
           </a:p>
@@ -14962,7 +14962,7 @@
           <a:p>
             <a:fld id="{542F8156-3D1B-1047-9A3D-372BE84AD46C}" type="datetimeFigureOut">
               <a:rPr lang="nl-NL" smtClean="0"/>
-              <a:t>08-11-2025</a:t>
+              <a:t>03-12-2025</a:t>
             </a:fld>
             <a:endParaRPr lang="nl-NL"/>
           </a:p>
@@ -15104,7 +15104,7 @@
           <a:p>
             <a:fld id="{542F8156-3D1B-1047-9A3D-372BE84AD46C}" type="datetimeFigureOut">
               <a:rPr lang="nl-NL" smtClean="0"/>
-              <a:t>08-11-2025</a:t>
+              <a:t>03-12-2025</a:t>
             </a:fld>
             <a:endParaRPr lang="nl-NL"/>
           </a:p>
@@ -15217,7 +15217,7 @@
           <a:p>
             <a:fld id="{542F8156-3D1B-1047-9A3D-372BE84AD46C}" type="datetimeFigureOut">
               <a:rPr lang="nl-NL" smtClean="0"/>
-              <a:t>08-11-2025</a:t>
+              <a:t>03-12-2025</a:t>
             </a:fld>
             <a:endParaRPr lang="nl-NL"/>
           </a:p>
@@ -15530,7 +15530,7 @@
           <a:p>
             <a:fld id="{542F8156-3D1B-1047-9A3D-372BE84AD46C}" type="datetimeFigureOut">
               <a:rPr lang="nl-NL" smtClean="0"/>
-              <a:t>08-11-2025</a:t>
+              <a:t>03-12-2025</a:t>
             </a:fld>
             <a:endParaRPr lang="nl-NL"/>
           </a:p>
@@ -15819,7 +15819,7 @@
           <a:p>
             <a:fld id="{542F8156-3D1B-1047-9A3D-372BE84AD46C}" type="datetimeFigureOut">
               <a:rPr lang="nl-NL" smtClean="0"/>
-              <a:t>08-11-2025</a:t>
+              <a:t>03-12-2025</a:t>
             </a:fld>
             <a:endParaRPr lang="nl-NL"/>
           </a:p>
@@ -16062,7 +16062,7 @@
           <a:p>
             <a:fld id="{542F8156-3D1B-1047-9A3D-372BE84AD46C}" type="datetimeFigureOut">
               <a:rPr lang="nl-NL" smtClean="0"/>
-              <a:t>08-11-2025</a:t>
+              <a:t>03-12-2025</a:t>
             </a:fld>
             <a:endParaRPr lang="nl-NL"/>
           </a:p>
@@ -17629,7 +17629,7 @@
                   <a:schemeClr val="bg1"/>
                 </a:solidFill>
               </a:rPr>
-              <a:t>PORTFOLIO_PERIOD_MAINTAINABILITY</a:t>
+              <a:t>PORTFOLIO_PERIOD_MAINTAINABILITY_GROUPED_BY_TEAM</a:t>
             </a:r>
             <a:endParaRPr lang="en-US" sz="1600" dirty="0">
               <a:solidFill>
@@ -18560,7 +18560,7 @@
                   <a:schemeClr val="bg1"/>
                 </a:solidFill>
               </a:rPr>
-              <a:t>PORTFOLIO_PERIOD_MAINTAINABILITY_CHANGE</a:t>
+              <a:t>PORTFOLIO_PERIOD_MAINTAINABILITY_CHANGE_GROUPED_BY_TEAM</a:t>
             </a:r>
             <a:endParaRPr lang="en-US" sz="1600" dirty="0">
               <a:solidFill>
@@ -19946,18 +19946,13 @@
           <a:p>
             <a:pPr algn="ctr"/>
             <a:r>
-              <a:rPr lang="en-US" sz="1600" dirty="0" err="1">
+              <a:rPr lang="en-US" sz="1600" dirty="0">
                 <a:solidFill>
                   <a:schemeClr val="bg1"/>
                 </a:solidFill>
               </a:rPr>
-              <a:t>PORTFOLIO_PERIOD_MAINTAINABILITY_DELTA_QUALITY_NEW_CODE</a:t>
+              <a:t>PORTFOLIO_PERIOD_MAINTAINABILITY_DELTA_QUALITY_NEW_CODE_GROUPED_BY_TEAM</a:t>
             </a:r>
-            <a:endParaRPr lang="en-US" sz="1600" dirty="0">
-              <a:solidFill>
-                <a:schemeClr val="bg1"/>
-              </a:solidFill>
-            </a:endParaRPr>
           </a:p>
         </p:txBody>
       </p:sp>
@@ -20010,18 +20005,13 @@
           <a:p>
             <a:pPr algn="ctr"/>
             <a:r>
-              <a:rPr lang="en-US" sz="1600" dirty="0" err="1">
+              <a:rPr lang="en-US" sz="1600" dirty="0">
                 <a:solidFill>
                   <a:schemeClr val="bg1"/>
                 </a:solidFill>
               </a:rPr>
-              <a:t>PORTFOLIO_PERIOD_MAINTAINABILITY_DELTA_QUALITY_CHANGED_CODE</a:t>
+              <a:t>PORTFOLIO_PERIOD_MAINTAINABILITY_DELTA_QUALITY_CHANGED_CODE_GROUPED_BY_TEAM</a:t>
             </a:r>
-            <a:endParaRPr lang="en-US" sz="1600" dirty="0">
-              <a:solidFill>
-                <a:schemeClr val="bg1"/>
-              </a:solidFill>
-            </a:endParaRPr>
           </a:p>
         </p:txBody>
       </p:sp>
@@ -20079,7 +20069,7 @@
                   <a:schemeClr val="bg1"/>
                 </a:solidFill>
               </a:rPr>
-              <a:t>PORTFOLIO_PERIOD_MAINTAINABILITY_DELTA_QUALITY_NEW_AND_CHANGED_CODE</a:t>
+              <a:t>PORTFOLIO_PERIOD_MAINTAINABILITY_DELTA_QUALITY_NEW_AND_CHANGED_CODE_GROUPED_BY_TEAM</a:t>
             </a:r>
           </a:p>
         </p:txBody>
@@ -20486,7 +20476,7 @@
                   <a:schemeClr val="bg1"/>
                 </a:solidFill>
               </a:rPr>
-              <a:t>PORTFOLIO_PERIOD_VOLUME_CHANGE</a:t>
+              <a:t>PORTFOLIO_PERIOD_VOLUME_CHANGE_GROUPED_BY_TEAM</a:t>
             </a:r>
             <a:endParaRPr lang="en-US" sz="1600" dirty="0">
               <a:solidFill>
@@ -21196,7 +21186,7 @@
                   <a:schemeClr val="bg1"/>
                 </a:solidFill>
               </a:rPr>
-              <a:t>PORTFOLIO_PERIOD_ARCHITECTURE</a:t>
+              <a:t>PORTFOLIO_PERIOD_ARCHITECTURE_GROUPED_BY_TEAM</a:t>
             </a:r>
             <a:endParaRPr lang="en-US" sz="1600" dirty="0">
               <a:solidFill>
@@ -22134,12 +22124,12 @@
           <a:p>
             <a:pPr algn="ctr"/>
             <a:r>
-              <a:rPr lang="en-US" sz="1600">
+              <a:rPr lang="en-US" sz="1600" dirty="0" err="1">
                 <a:solidFill>
                   <a:schemeClr val="bg1"/>
                 </a:solidFill>
               </a:rPr>
-              <a:t>PORTFOLIO_PERIOD_OSH_RATINGS</a:t>
+              <a:t>PORTFOLIO_PERIOD_OSH_RATINGS_GROUPED_BY_TEAM</a:t>
             </a:r>
             <a:endParaRPr lang="en-US" sz="1600" dirty="0">
               <a:solidFill>
@@ -23082,7 +23072,7 @@
                   <a:schemeClr val="bg1"/>
                 </a:solidFill>
               </a:rPr>
-              <a:t>PORTFOLIO_PERIOD_SECURITY_RATINGS</a:t>
+              <a:t>PORTFOLIO_PERIOD_SECURITY_RATINGS_GROUPED_BY_TEAM</a:t>
             </a:r>
             <a:endParaRPr lang="en-US" sz="1600" dirty="0">
               <a:solidFill>
@@ -25522,7 +25512,7 @@
                   <a:schemeClr val="bg1"/>
                 </a:solidFill>
               </a:rPr>
-              <a:t>PORTFOLIO_PERIOD_TEST_CODE</a:t>
+              <a:t>PORTFOLIO_PERIOD_TEST_CODE_GROUPED_BY_TEAM</a:t>
             </a:r>
             <a:endParaRPr lang="en-US" sz="1600" dirty="0">
               <a:solidFill>
@@ -26470,7 +26460,23 @@
                   <a:schemeClr val="bg1"/>
                 </a:solidFill>
               </a:rPr>
-              <a:t>PORTFOLIO_PERIOD_TEST_CODE_CHANGE</a:t>
+              <a:t>PORTFOLIO_PERIOD_TEST_CODE_CHANGE_GROUPED_</a:t>
+            </a:r>
+            <a:r>
+              <a:rPr lang="en-US" sz="1600" err="1">
+                <a:solidFill>
+                  <a:schemeClr val="bg1"/>
+                </a:solidFill>
+              </a:rPr>
+              <a:t>BY</a:t>
+            </a:r>
+            <a:r>
+              <a:rPr lang="en-US" sz="1600">
+                <a:solidFill>
+                  <a:schemeClr val="bg1"/>
+                </a:solidFill>
+              </a:rPr>
+              <a:t>_TEAM</a:t>
             </a:r>
             <a:endParaRPr lang="en-US" sz="1600" dirty="0">
               <a:solidFill>

</xml_diff>

<commit_message>
change placeholder names and add descriptions
</commit_message>
<xml_diff>
--- a/src/report_generator/presets/templates/portfolio-overview.pptx
+++ b/src/report_generator/presets/templates/portfolio-overview.pptx
@@ -216,7 +216,7 @@
                 </a:outerShdw>
               </a:effectLst>
             </c:spPr>
-            <c:extLst xmlns:w="http://schemas.openxmlformats.org/wordprocessingml/2006/main" xmlns:w15="http://schemas.microsoft.com/office/word/2012/wordml" xmlns:w14="http://schemas.microsoft.com/office/word/2010/wordml" xmlns:m="http://schemas.openxmlformats.org/officeDocument/2006/math" xmlns:wp="http://schemas.openxmlformats.org/drawingml/2006/wordprocessingDrawing" xmlns:wp14="http://schemas.microsoft.com/office/word/2010/wordprocessingDrawing" xmlns:mc="http://schemas.openxmlformats.org/markup-compatibility/2006" xmlns:sl="http://schemas.openxmlformats.org/schemaLibrary/2006/main" xmlns:wne="http://schemas.microsoft.com/office/word/2006/wordml" xmlns:cdr="http://schemas.openxmlformats.org/drawingml/2006/chartDrawing" xmlns:c14="http://schemas.microsoft.com/office/drawing/2007/8/2/chart" xmlns:dgm="http://schemas.openxmlformats.org/drawingml/2006/diagram" xmlns:pic="http://schemas.openxmlformats.org/drawingml/2006/picture" xmlns:xdr="http://schemas.openxmlformats.org/drawingml/2006/spreadsheetDrawing" xmlns:dsp="http://schemas.microsoft.com/office/drawing/2008/diagram" xmlns:xvml="urn:schemas-microsoft-com:office:excel" xmlns:o="urn:schemas-microsoft-com:office:office" xmlns:v="urn:schemas-microsoft-com:vml" xmlns:w10="urn:schemas-microsoft-com:office:word" xmlns:pvml="urn:schemas-microsoft-com:office:powerpoint" xmlns:cppr="http://schemas.microsoft.com/office/2006/coverPageProps" xmlns:odx="http://opendope.org/xpaths" xmlns:odc="http://opendope.org/conditions" xmlns:odq="http://opendope.org/questions" xmlns:oda="http://opendope.org/answers" xmlns:odi="http://opendope.org/components" xmlns:odgm="http://opendope.org/SmartArt/DataHierarchy" xmlns:b="http://schemas.openxmlformats.org/officeDocument/2006/bibliography" xmlns:wps="http://schemas.microsoft.com/office/word/2010/wordprocessingShape" xmlns:w16se="http://schemas.microsoft.com/office/word/2015/wordml/symex" xmlns:w16cid="http://schemas.microsoft.com/office/word/2016/wordml/cid" xmlns:wetp="http://schemas.microsoft.com/office/webextensions/taskpanes/2010/11" xmlns:we="http://schemas.microsoft.com/office/webextensions/webextension/2010/11" xmlns:comp="http://schemas.openxmlformats.org/drawingml/2006/compatibility" xmlns:lc="http://schemas.openxmlformats.org/drawingml/2006/lockedCanvas">
+            <c:extLst xmlns:lc="http://schemas.openxmlformats.org/drawingml/2006/lockedCanvas" xmlns:comp="http://schemas.openxmlformats.org/drawingml/2006/compatibility" xmlns:we="http://schemas.microsoft.com/office/webextensions/webextension/2010/11" xmlns:wetp="http://schemas.microsoft.com/office/webextensions/taskpanes/2010/11" xmlns:w16cid="http://schemas.microsoft.com/office/word/2016/wordml/cid" xmlns:w16se="http://schemas.microsoft.com/office/word/2015/wordml/symex" xmlns:wps="http://schemas.microsoft.com/office/word/2010/wordprocessingShape" xmlns:b="http://schemas.openxmlformats.org/officeDocument/2006/bibliography" xmlns:odgm="http://opendope.org/SmartArt/DataHierarchy" xmlns:odi="http://opendope.org/components" xmlns:oda="http://opendope.org/answers" xmlns:odq="http://opendope.org/questions" xmlns:odc="http://opendope.org/conditions" xmlns:odx="http://opendope.org/xpaths" xmlns:cppr="http://schemas.microsoft.com/office/2006/coverPageProps" xmlns:pvml="urn:schemas-microsoft-com:office:powerpoint" xmlns:w10="urn:schemas-microsoft-com:office:word" xmlns:v="urn:schemas-microsoft-com:vml" xmlns:o="urn:schemas-microsoft-com:office:office" xmlns:xvml="urn:schemas-microsoft-com:office:excel" xmlns:dsp="http://schemas.microsoft.com/office/drawing/2008/diagram" xmlns:xdr="http://schemas.openxmlformats.org/drawingml/2006/spreadsheetDrawing" xmlns:pic="http://schemas.openxmlformats.org/drawingml/2006/picture" xmlns:dgm="http://schemas.openxmlformats.org/drawingml/2006/diagram" xmlns:c14="http://schemas.microsoft.com/office/drawing/2007/8/2/chart" xmlns:cdr="http://schemas.openxmlformats.org/drawingml/2006/chartDrawing" xmlns:wne="http://schemas.microsoft.com/office/word/2006/wordml" xmlns:sl="http://schemas.openxmlformats.org/schemaLibrary/2006/main" xmlns:mc="http://schemas.openxmlformats.org/markup-compatibility/2006" xmlns:wp14="http://schemas.microsoft.com/office/word/2010/wordprocessingDrawing" xmlns:wp="http://schemas.openxmlformats.org/drawingml/2006/wordprocessingDrawing" xmlns:m="http://schemas.openxmlformats.org/officeDocument/2006/math" xmlns:w14="http://schemas.microsoft.com/office/word/2010/wordml" xmlns:w15="http://schemas.microsoft.com/office/word/2012/wordml" xmlns:w="http://schemas.openxmlformats.org/wordprocessingml/2006/main">
               <c:ext xmlns:c16="http://schemas.microsoft.com/office/drawing/2014/chart" uri="{C3380CC4-5D6E-409C-BE32-E72D297353CC}">
                 <c16:uniqueId val="{00000001-6147-E74A-AA7B-5531F0E4EE0C}"/>
               </c:ext>
@@ -341,7 +341,7 @@
               </c:numCache>
             </c:numRef>
           </c:val>
-          <c:extLst xmlns:w="http://schemas.openxmlformats.org/wordprocessingml/2006/main" xmlns:w15="http://schemas.microsoft.com/office/word/2012/wordml" xmlns:w14="http://schemas.microsoft.com/office/word/2010/wordml" xmlns:m="http://schemas.openxmlformats.org/officeDocument/2006/math" xmlns:wp="http://schemas.openxmlformats.org/drawingml/2006/wordprocessingDrawing" xmlns:wp14="http://schemas.microsoft.com/office/word/2010/wordprocessingDrawing" xmlns:mc="http://schemas.openxmlformats.org/markup-compatibility/2006" xmlns:sl="http://schemas.openxmlformats.org/schemaLibrary/2006/main" xmlns:wne="http://schemas.microsoft.com/office/word/2006/wordml" xmlns:cdr="http://schemas.openxmlformats.org/drawingml/2006/chartDrawing" xmlns:c14="http://schemas.microsoft.com/office/drawing/2007/8/2/chart" xmlns:dgm="http://schemas.openxmlformats.org/drawingml/2006/diagram" xmlns:pic="http://schemas.openxmlformats.org/drawingml/2006/picture" xmlns:xdr="http://schemas.openxmlformats.org/drawingml/2006/spreadsheetDrawing" xmlns:dsp="http://schemas.microsoft.com/office/drawing/2008/diagram" xmlns:xvml="urn:schemas-microsoft-com:office:excel" xmlns:o="urn:schemas-microsoft-com:office:office" xmlns:v="urn:schemas-microsoft-com:vml" xmlns:w10="urn:schemas-microsoft-com:office:word" xmlns:pvml="urn:schemas-microsoft-com:office:powerpoint" xmlns:cppr="http://schemas.microsoft.com/office/2006/coverPageProps" xmlns:odx="http://opendope.org/xpaths" xmlns:odc="http://opendope.org/conditions" xmlns:odq="http://opendope.org/questions" xmlns:oda="http://opendope.org/answers" xmlns:odi="http://opendope.org/components" xmlns:odgm="http://opendope.org/SmartArt/DataHierarchy" xmlns:b="http://schemas.openxmlformats.org/officeDocument/2006/bibliography" xmlns:wps="http://schemas.microsoft.com/office/word/2010/wordprocessingShape" xmlns:w16se="http://schemas.microsoft.com/office/word/2015/wordml/symex" xmlns:w16cid="http://schemas.microsoft.com/office/word/2016/wordml/cid" xmlns:wetp="http://schemas.microsoft.com/office/webextensions/taskpanes/2010/11" xmlns:we="http://schemas.microsoft.com/office/webextensions/webextension/2010/11" xmlns:comp="http://schemas.openxmlformats.org/drawingml/2006/compatibility" xmlns:lc="http://schemas.openxmlformats.org/drawingml/2006/lockedCanvas">
+          <c:extLst xmlns:lc="http://schemas.openxmlformats.org/drawingml/2006/lockedCanvas" xmlns:comp="http://schemas.openxmlformats.org/drawingml/2006/compatibility" xmlns:we="http://schemas.microsoft.com/office/webextensions/webextension/2010/11" xmlns:wetp="http://schemas.microsoft.com/office/webextensions/taskpanes/2010/11" xmlns:w16cid="http://schemas.microsoft.com/office/word/2016/wordml/cid" xmlns:w16se="http://schemas.microsoft.com/office/word/2015/wordml/symex" xmlns:wps="http://schemas.microsoft.com/office/word/2010/wordprocessingShape" xmlns:b="http://schemas.openxmlformats.org/officeDocument/2006/bibliography" xmlns:odgm="http://opendope.org/SmartArt/DataHierarchy" xmlns:odi="http://opendope.org/components" xmlns:oda="http://opendope.org/answers" xmlns:odq="http://opendope.org/questions" xmlns:odc="http://opendope.org/conditions" xmlns:odx="http://opendope.org/xpaths" xmlns:cppr="http://schemas.microsoft.com/office/2006/coverPageProps" xmlns:pvml="urn:schemas-microsoft-com:office:powerpoint" xmlns:w10="urn:schemas-microsoft-com:office:word" xmlns:v="urn:schemas-microsoft-com:vml" xmlns:o="urn:schemas-microsoft-com:office:office" xmlns:xvml="urn:schemas-microsoft-com:office:excel" xmlns:dsp="http://schemas.microsoft.com/office/drawing/2008/diagram" xmlns:xdr="http://schemas.openxmlformats.org/drawingml/2006/spreadsheetDrawing" xmlns:pic="http://schemas.openxmlformats.org/drawingml/2006/picture" xmlns:dgm="http://schemas.openxmlformats.org/drawingml/2006/diagram" xmlns:c14="http://schemas.microsoft.com/office/drawing/2007/8/2/chart" xmlns:cdr="http://schemas.openxmlformats.org/drawingml/2006/chartDrawing" xmlns:wne="http://schemas.microsoft.com/office/word/2006/wordml" xmlns:sl="http://schemas.openxmlformats.org/schemaLibrary/2006/main" xmlns:mc="http://schemas.openxmlformats.org/markup-compatibility/2006" xmlns:wp14="http://schemas.microsoft.com/office/word/2010/wordprocessingDrawing" xmlns:wp="http://schemas.openxmlformats.org/drawingml/2006/wordprocessingDrawing" xmlns:m="http://schemas.openxmlformats.org/officeDocument/2006/math" xmlns:w14="http://schemas.microsoft.com/office/word/2010/wordml" xmlns:w15="http://schemas.microsoft.com/office/word/2012/wordml" xmlns:w="http://schemas.openxmlformats.org/wordprocessingml/2006/main">
             <c:ext xmlns:c16="http://schemas.microsoft.com/office/drawing/2014/chart" uri="{C3380CC4-5D6E-409C-BE32-E72D297353CC}">
               <c16:uniqueId val="{00000002-6147-E74A-AA7B-5531F0E4EE0C}"/>
             </c:ext>
@@ -799,7 +799,7 @@
     <c:plotVisOnly val="1"/>
     <c:dispBlanksAs val="gap"/>
     <c:showDLblsOverMax val="0"/>
-    <c:extLst xmlns:w="http://schemas.openxmlformats.org/wordprocessingml/2006/main" xmlns:w15="http://schemas.microsoft.com/office/word/2012/wordml" xmlns:w14="http://schemas.microsoft.com/office/word/2010/wordml" xmlns:m="http://schemas.openxmlformats.org/officeDocument/2006/math" xmlns:wp="http://schemas.openxmlformats.org/drawingml/2006/wordprocessingDrawing" xmlns:wp14="http://schemas.microsoft.com/office/word/2010/wordprocessingDrawing" xmlns:mc="http://schemas.openxmlformats.org/markup-compatibility/2006" xmlns:sl="http://schemas.openxmlformats.org/schemaLibrary/2006/main" xmlns:wne="http://schemas.microsoft.com/office/word/2006/wordml" xmlns:cdr="http://schemas.openxmlformats.org/drawingml/2006/chartDrawing" xmlns:c14="http://schemas.microsoft.com/office/drawing/2007/8/2/chart" xmlns:dgm="http://schemas.openxmlformats.org/drawingml/2006/diagram" xmlns:pic="http://schemas.openxmlformats.org/drawingml/2006/picture" xmlns:xdr="http://schemas.openxmlformats.org/drawingml/2006/spreadsheetDrawing" xmlns:dsp="http://schemas.microsoft.com/office/drawing/2008/diagram" xmlns:xvml="urn:schemas-microsoft-com:office:excel" xmlns:o="urn:schemas-microsoft-com:office:office" xmlns:v="urn:schemas-microsoft-com:vml" xmlns:w10="urn:schemas-microsoft-com:office:word" xmlns:pvml="urn:schemas-microsoft-com:office:powerpoint" xmlns:cppr="http://schemas.microsoft.com/office/2006/coverPageProps" xmlns:odx="http://opendope.org/xpaths" xmlns:odc="http://opendope.org/conditions" xmlns:odq="http://opendope.org/questions" xmlns:oda="http://opendope.org/answers" xmlns:odi="http://opendope.org/components" xmlns:odgm="http://opendope.org/SmartArt/DataHierarchy" xmlns:b="http://schemas.openxmlformats.org/officeDocument/2006/bibliography" xmlns:wps="http://schemas.microsoft.com/office/word/2010/wordprocessingShape" xmlns:w16se="http://schemas.microsoft.com/office/word/2015/wordml/symex" xmlns:w16cid="http://schemas.microsoft.com/office/word/2016/wordml/cid" xmlns:wetp="http://schemas.microsoft.com/office/webextensions/taskpanes/2010/11" xmlns:we="http://schemas.microsoft.com/office/webextensions/webextension/2010/11" xmlns:comp="http://schemas.openxmlformats.org/drawingml/2006/compatibility" xmlns:lc="http://schemas.openxmlformats.org/drawingml/2006/lockedCanvas">
+    <c:extLst xmlns:lc="http://schemas.openxmlformats.org/drawingml/2006/lockedCanvas" xmlns:comp="http://schemas.openxmlformats.org/drawingml/2006/compatibility" xmlns:we="http://schemas.microsoft.com/office/webextensions/webextension/2010/11" xmlns:wetp="http://schemas.microsoft.com/office/webextensions/taskpanes/2010/11" xmlns:w16cid="http://schemas.microsoft.com/office/word/2016/wordml/cid" xmlns:w16se="http://schemas.microsoft.com/office/word/2015/wordml/symex" xmlns:wps="http://schemas.microsoft.com/office/word/2010/wordprocessingShape" xmlns:b="http://schemas.openxmlformats.org/officeDocument/2006/bibliography" xmlns:odgm="http://opendope.org/SmartArt/DataHierarchy" xmlns:odi="http://opendope.org/components" xmlns:oda="http://opendope.org/answers" xmlns:odq="http://opendope.org/questions" xmlns:odc="http://opendope.org/conditions" xmlns:odx="http://opendope.org/xpaths" xmlns:cppr="http://schemas.microsoft.com/office/2006/coverPageProps" xmlns:pvml="urn:schemas-microsoft-com:office:powerpoint" xmlns:w10="urn:schemas-microsoft-com:office:word" xmlns:v="urn:schemas-microsoft-com:vml" xmlns:o="urn:schemas-microsoft-com:office:office" xmlns:xvml="urn:schemas-microsoft-com:office:excel" xmlns:dsp="http://schemas.microsoft.com/office/drawing/2008/diagram" xmlns:xdr="http://schemas.openxmlformats.org/drawingml/2006/spreadsheetDrawing" xmlns:pic="http://schemas.openxmlformats.org/drawingml/2006/picture" xmlns:dgm="http://schemas.openxmlformats.org/drawingml/2006/diagram" xmlns:c14="http://schemas.microsoft.com/office/drawing/2007/8/2/chart" xmlns:cdr="http://schemas.openxmlformats.org/drawingml/2006/chartDrawing" xmlns:wne="http://schemas.microsoft.com/office/word/2006/wordml" xmlns:sl="http://schemas.openxmlformats.org/schemaLibrary/2006/main" xmlns:mc="http://schemas.openxmlformats.org/markup-compatibility/2006" xmlns:wp14="http://schemas.microsoft.com/office/word/2010/wordprocessingDrawing" xmlns:wp="http://schemas.openxmlformats.org/drawingml/2006/wordprocessingDrawing" xmlns:m="http://schemas.openxmlformats.org/officeDocument/2006/math" xmlns:w14="http://schemas.microsoft.com/office/word/2010/wordml" xmlns:w15="http://schemas.microsoft.com/office/word/2012/wordml" xmlns:w="http://schemas.openxmlformats.org/wordprocessingml/2006/main">
       <c:ext xmlns:c16r3="http://schemas.microsoft.com/office/drawing/2017/03/chart" uri="{56B9EC1D-385E-4148-901F-78D8002777C0}">
         <c16r3:dataDisplayOptions16>
           <c16r3:dispNaAsBlank val="1"/>
@@ -901,7 +901,7 @@
                 </a:outerShdw>
               </a:effectLst>
             </c:spPr>
-            <c:extLst xmlns:lc="http://schemas.openxmlformats.org/drawingml/2006/lockedCanvas" xmlns:comp="http://schemas.openxmlformats.org/drawingml/2006/compatibility" xmlns:we="http://schemas.microsoft.com/office/webextensions/webextension/2010/11" xmlns:wetp="http://schemas.microsoft.com/office/webextensions/taskpanes/2010/11" xmlns:w16cid="http://schemas.microsoft.com/office/word/2016/wordml/cid" xmlns:w16se="http://schemas.microsoft.com/office/word/2015/wordml/symex" xmlns:wps="http://schemas.microsoft.com/office/word/2010/wordprocessingShape" xmlns:b="http://schemas.openxmlformats.org/officeDocument/2006/bibliography" xmlns:odgm="http://opendope.org/SmartArt/DataHierarchy" xmlns:odi="http://opendope.org/components" xmlns:oda="http://opendope.org/answers" xmlns:odq="http://opendope.org/questions" xmlns:odc="http://opendope.org/conditions" xmlns:odx="http://opendope.org/xpaths" xmlns:cppr="http://schemas.microsoft.com/office/2006/coverPageProps" xmlns:pvml="urn:schemas-microsoft-com:office:powerpoint" xmlns:w10="urn:schemas-microsoft-com:office:word" xmlns:v="urn:schemas-microsoft-com:vml" xmlns:o="urn:schemas-microsoft-com:office:office" xmlns:xvml="urn:schemas-microsoft-com:office:excel" xmlns:dsp="http://schemas.microsoft.com/office/drawing/2008/diagram" xmlns:xdr="http://schemas.openxmlformats.org/drawingml/2006/spreadsheetDrawing" xmlns:pic="http://schemas.openxmlformats.org/drawingml/2006/picture" xmlns:dgm="http://schemas.openxmlformats.org/drawingml/2006/diagram" xmlns:c14="http://schemas.microsoft.com/office/drawing/2007/8/2/chart" xmlns:cdr="http://schemas.openxmlformats.org/drawingml/2006/chartDrawing" xmlns:wne="http://schemas.microsoft.com/office/word/2006/wordml" xmlns:sl="http://schemas.openxmlformats.org/schemaLibrary/2006/main" xmlns:mc="http://schemas.openxmlformats.org/markup-compatibility/2006" xmlns:wp14="http://schemas.microsoft.com/office/word/2010/wordprocessingDrawing" xmlns:wp="http://schemas.openxmlformats.org/drawingml/2006/wordprocessingDrawing" xmlns:m="http://schemas.openxmlformats.org/officeDocument/2006/math" xmlns:w14="http://schemas.microsoft.com/office/word/2010/wordml" xmlns:w15="http://schemas.microsoft.com/office/word/2012/wordml" xmlns:w="http://schemas.openxmlformats.org/wordprocessingml/2006/main">
+            <c:extLst xmlns:w="http://schemas.openxmlformats.org/wordprocessingml/2006/main" xmlns:w15="http://schemas.microsoft.com/office/word/2012/wordml" xmlns:w14="http://schemas.microsoft.com/office/word/2010/wordml" xmlns:m="http://schemas.openxmlformats.org/officeDocument/2006/math" xmlns:wp="http://schemas.openxmlformats.org/drawingml/2006/wordprocessingDrawing" xmlns:wp14="http://schemas.microsoft.com/office/word/2010/wordprocessingDrawing" xmlns:mc="http://schemas.openxmlformats.org/markup-compatibility/2006" xmlns:sl="http://schemas.openxmlformats.org/schemaLibrary/2006/main" xmlns:wne="http://schemas.microsoft.com/office/word/2006/wordml" xmlns:cdr="http://schemas.openxmlformats.org/drawingml/2006/chartDrawing" xmlns:c14="http://schemas.microsoft.com/office/drawing/2007/8/2/chart" xmlns:dgm="http://schemas.openxmlformats.org/drawingml/2006/diagram" xmlns:pic="http://schemas.openxmlformats.org/drawingml/2006/picture" xmlns:xdr="http://schemas.openxmlformats.org/drawingml/2006/spreadsheetDrawing" xmlns:dsp="http://schemas.microsoft.com/office/drawing/2008/diagram" xmlns:xvml="urn:schemas-microsoft-com:office:excel" xmlns:o="urn:schemas-microsoft-com:office:office" xmlns:v="urn:schemas-microsoft-com:vml" xmlns:w10="urn:schemas-microsoft-com:office:word" xmlns:pvml="urn:schemas-microsoft-com:office:powerpoint" xmlns:cppr="http://schemas.microsoft.com/office/2006/coverPageProps" xmlns:odx="http://opendope.org/xpaths" xmlns:odc="http://opendope.org/conditions" xmlns:odq="http://opendope.org/questions" xmlns:oda="http://opendope.org/answers" xmlns:odi="http://opendope.org/components" xmlns:odgm="http://opendope.org/SmartArt/DataHierarchy" xmlns:b="http://schemas.openxmlformats.org/officeDocument/2006/bibliography" xmlns:wps="http://schemas.microsoft.com/office/word/2010/wordprocessingShape" xmlns:w16se="http://schemas.microsoft.com/office/word/2015/wordml/symex" xmlns:w16cid="http://schemas.microsoft.com/office/word/2016/wordml/cid" xmlns:wetp="http://schemas.microsoft.com/office/webextensions/taskpanes/2010/11" xmlns:we="http://schemas.microsoft.com/office/webextensions/webextension/2010/11" xmlns:comp="http://schemas.openxmlformats.org/drawingml/2006/compatibility" xmlns:lc="http://schemas.openxmlformats.org/drawingml/2006/lockedCanvas">
               <c:ext xmlns:c16="http://schemas.microsoft.com/office/drawing/2014/chart" uri="{C3380CC4-5D6E-409C-BE32-E72D297353CC}">
                 <c16:uniqueId val="{00000001-6147-E74A-AA7B-5531F0E4EE0C}"/>
               </c:ext>
@@ -984,7 +984,7 @@
               </c:numCache>
             </c:numRef>
           </c:val>
-          <c:extLst xmlns:lc="http://schemas.openxmlformats.org/drawingml/2006/lockedCanvas" xmlns:comp="http://schemas.openxmlformats.org/drawingml/2006/compatibility" xmlns:we="http://schemas.microsoft.com/office/webextensions/webextension/2010/11" xmlns:wetp="http://schemas.microsoft.com/office/webextensions/taskpanes/2010/11" xmlns:w16cid="http://schemas.microsoft.com/office/word/2016/wordml/cid" xmlns:w16se="http://schemas.microsoft.com/office/word/2015/wordml/symex" xmlns:wps="http://schemas.microsoft.com/office/word/2010/wordprocessingShape" xmlns:b="http://schemas.openxmlformats.org/officeDocument/2006/bibliography" xmlns:odgm="http://opendope.org/SmartArt/DataHierarchy" xmlns:odi="http://opendope.org/components" xmlns:oda="http://opendope.org/answers" xmlns:odq="http://opendope.org/questions" xmlns:odc="http://opendope.org/conditions" xmlns:odx="http://opendope.org/xpaths" xmlns:cppr="http://schemas.microsoft.com/office/2006/coverPageProps" xmlns:pvml="urn:schemas-microsoft-com:office:powerpoint" xmlns:w10="urn:schemas-microsoft-com:office:word" xmlns:v="urn:schemas-microsoft-com:vml" xmlns:o="urn:schemas-microsoft-com:office:office" xmlns:xvml="urn:schemas-microsoft-com:office:excel" xmlns:dsp="http://schemas.microsoft.com/office/drawing/2008/diagram" xmlns:xdr="http://schemas.openxmlformats.org/drawingml/2006/spreadsheetDrawing" xmlns:pic="http://schemas.openxmlformats.org/drawingml/2006/picture" xmlns:dgm="http://schemas.openxmlformats.org/drawingml/2006/diagram" xmlns:c14="http://schemas.microsoft.com/office/drawing/2007/8/2/chart" xmlns:cdr="http://schemas.openxmlformats.org/drawingml/2006/chartDrawing" xmlns:wne="http://schemas.microsoft.com/office/word/2006/wordml" xmlns:sl="http://schemas.openxmlformats.org/schemaLibrary/2006/main" xmlns:mc="http://schemas.openxmlformats.org/markup-compatibility/2006" xmlns:wp14="http://schemas.microsoft.com/office/word/2010/wordprocessingDrawing" xmlns:wp="http://schemas.openxmlformats.org/drawingml/2006/wordprocessingDrawing" xmlns:m="http://schemas.openxmlformats.org/officeDocument/2006/math" xmlns:w14="http://schemas.microsoft.com/office/word/2010/wordml" xmlns:w15="http://schemas.microsoft.com/office/word/2012/wordml" xmlns:w="http://schemas.openxmlformats.org/wordprocessingml/2006/main">
+          <c:extLst xmlns:w="http://schemas.openxmlformats.org/wordprocessingml/2006/main" xmlns:w15="http://schemas.microsoft.com/office/word/2012/wordml" xmlns:w14="http://schemas.microsoft.com/office/word/2010/wordml" xmlns:m="http://schemas.openxmlformats.org/officeDocument/2006/math" xmlns:wp="http://schemas.openxmlformats.org/drawingml/2006/wordprocessingDrawing" xmlns:wp14="http://schemas.microsoft.com/office/word/2010/wordprocessingDrawing" xmlns:mc="http://schemas.openxmlformats.org/markup-compatibility/2006" xmlns:sl="http://schemas.openxmlformats.org/schemaLibrary/2006/main" xmlns:wne="http://schemas.microsoft.com/office/word/2006/wordml" xmlns:cdr="http://schemas.openxmlformats.org/drawingml/2006/chartDrawing" xmlns:c14="http://schemas.microsoft.com/office/drawing/2007/8/2/chart" xmlns:dgm="http://schemas.openxmlformats.org/drawingml/2006/diagram" xmlns:pic="http://schemas.openxmlformats.org/drawingml/2006/picture" xmlns:xdr="http://schemas.openxmlformats.org/drawingml/2006/spreadsheetDrawing" xmlns:dsp="http://schemas.microsoft.com/office/drawing/2008/diagram" xmlns:xvml="urn:schemas-microsoft-com:office:excel" xmlns:o="urn:schemas-microsoft-com:office:office" xmlns:v="urn:schemas-microsoft-com:vml" xmlns:w10="urn:schemas-microsoft-com:office:word" xmlns:pvml="urn:schemas-microsoft-com:office:powerpoint" xmlns:cppr="http://schemas.microsoft.com/office/2006/coverPageProps" xmlns:odx="http://opendope.org/xpaths" xmlns:odc="http://opendope.org/conditions" xmlns:odq="http://opendope.org/questions" xmlns:oda="http://opendope.org/answers" xmlns:odi="http://opendope.org/components" xmlns:odgm="http://opendope.org/SmartArt/DataHierarchy" xmlns:b="http://schemas.openxmlformats.org/officeDocument/2006/bibliography" xmlns:wps="http://schemas.microsoft.com/office/word/2010/wordprocessingShape" xmlns:w16se="http://schemas.microsoft.com/office/word/2015/wordml/symex" xmlns:w16cid="http://schemas.microsoft.com/office/word/2016/wordml/cid" xmlns:wetp="http://schemas.microsoft.com/office/webextensions/taskpanes/2010/11" xmlns:we="http://schemas.microsoft.com/office/webextensions/webextension/2010/11" xmlns:comp="http://schemas.openxmlformats.org/drawingml/2006/compatibility" xmlns:lc="http://schemas.openxmlformats.org/drawingml/2006/lockedCanvas">
             <c:ext xmlns:c16="http://schemas.microsoft.com/office/drawing/2014/chart" uri="{C3380CC4-5D6E-409C-BE32-E72D297353CC}">
               <c16:uniqueId val="{00000002-6147-E74A-AA7B-5531F0E4EE0C}"/>
             </c:ext>
@@ -1547,6 +1547,814 @@
     <c:plotVisOnly val="1"/>
     <c:dispBlanksAs val="gap"/>
     <c:showDLblsOverMax val="0"/>
+    <c:extLst xmlns:w="http://schemas.openxmlformats.org/wordprocessingml/2006/main" xmlns:w15="http://schemas.microsoft.com/office/word/2012/wordml" xmlns:w14="http://schemas.microsoft.com/office/word/2010/wordml" xmlns:m="http://schemas.openxmlformats.org/officeDocument/2006/math" xmlns:wp="http://schemas.openxmlformats.org/drawingml/2006/wordprocessingDrawing" xmlns:wp14="http://schemas.microsoft.com/office/word/2010/wordprocessingDrawing" xmlns:mc="http://schemas.openxmlformats.org/markup-compatibility/2006" xmlns:sl="http://schemas.openxmlformats.org/schemaLibrary/2006/main" xmlns:wne="http://schemas.microsoft.com/office/word/2006/wordml" xmlns:cdr="http://schemas.openxmlformats.org/drawingml/2006/chartDrawing" xmlns:c14="http://schemas.microsoft.com/office/drawing/2007/8/2/chart" xmlns:dgm="http://schemas.openxmlformats.org/drawingml/2006/diagram" xmlns:pic="http://schemas.openxmlformats.org/drawingml/2006/picture" xmlns:xdr="http://schemas.openxmlformats.org/drawingml/2006/spreadsheetDrawing" xmlns:dsp="http://schemas.microsoft.com/office/drawing/2008/diagram" xmlns:xvml="urn:schemas-microsoft-com:office:excel" xmlns:o="urn:schemas-microsoft-com:office:office" xmlns:v="urn:schemas-microsoft-com:vml" xmlns:w10="urn:schemas-microsoft-com:office:word" xmlns:pvml="urn:schemas-microsoft-com:office:powerpoint" xmlns:cppr="http://schemas.microsoft.com/office/2006/coverPageProps" xmlns:odx="http://opendope.org/xpaths" xmlns:odc="http://opendope.org/conditions" xmlns:odq="http://opendope.org/questions" xmlns:oda="http://opendope.org/answers" xmlns:odi="http://opendope.org/components" xmlns:odgm="http://opendope.org/SmartArt/DataHierarchy" xmlns:b="http://schemas.openxmlformats.org/officeDocument/2006/bibliography" xmlns:wps="http://schemas.microsoft.com/office/word/2010/wordprocessingShape" xmlns:w16se="http://schemas.microsoft.com/office/word/2015/wordml/symex" xmlns:w16cid="http://schemas.microsoft.com/office/word/2016/wordml/cid" xmlns:wetp="http://schemas.microsoft.com/office/webextensions/taskpanes/2010/11" xmlns:we="http://schemas.microsoft.com/office/webextensions/webextension/2010/11" xmlns:comp="http://schemas.openxmlformats.org/drawingml/2006/compatibility" xmlns:lc="http://schemas.openxmlformats.org/drawingml/2006/lockedCanvas">
+      <c:ext xmlns:c16r3="http://schemas.microsoft.com/office/drawing/2017/03/chart" uri="{56B9EC1D-385E-4148-901F-78D8002777C0}">
+        <c16r3:dataDisplayOptions16>
+          <c16r3:dispNaAsBlank val="1"/>
+        </c16r3:dataDisplayOptions16>
+      </c:ext>
+    </c:extLst>
+  </c:chart>
+  <c:spPr>
+    <a:noFill/>
+    <a:ln>
+      <a:noFill/>
+    </a:ln>
+    <a:effectLst/>
+  </c:spPr>
+  <c:txPr>
+    <a:bodyPr/>
+    <a:lstStyle/>
+    <a:p>
+      <a:pPr>
+        <a:defRPr/>
+      </a:pPr>
+      <a:endParaRPr lang="en-NL"/>
+    </a:p>
+  </c:txPr>
+  <c:externalData r:id="rId3">
+    <c:autoUpdate val="0"/>
+  </c:externalData>
+</c:chartSpace>
+</file>
+
+<file path=ppt/charts/chart11.xml><?xml version="1.0" encoding="utf-8"?>
+<c:chartSpace xmlns:c="http://schemas.openxmlformats.org/drawingml/2006/chart" xmlns:a="http://schemas.openxmlformats.org/drawingml/2006/main" xmlns:r="http://schemas.openxmlformats.org/officeDocument/2006/relationships" xmlns:c16r2="http://schemas.microsoft.com/office/drawing/2015/06/chart">
+  <c:date1904 val="0"/>
+  <c:lang val="en-US"/>
+  <c:roundedCorners val="0"/>
+  <mc:AlternateContent xmlns:mc="http://schemas.openxmlformats.org/markup-compatibility/2006">
+    <mc:Choice xmlns:c14="http://schemas.microsoft.com/office/drawing/2007/8/2/chart" Requires="c14">
+      <c14:style val="104"/>
+    </mc:Choice>
+    <mc:Fallback>
+      <c:style val="4"/>
+    </mc:Fallback>
+  </mc:AlternateContent>
+  <c:chart>
+    <c:autoTitleDeleted val="1"/>
+    <c:plotArea>
+      <c:layout/>
+      <c:barChart>
+        <c:barDir val="col"/>
+        <c:grouping val="percentStacked"/>
+        <c:varyColors val="0"/>
+        <c:ser>
+          <c:idx val="0"/>
+          <c:order val="0"/>
+          <c:tx>
+            <c:strRef>
+              <c:f>Sheet1!$B$1</c:f>
+              <c:strCache>
+                <c:ptCount val="1"/>
+                <c:pt idx="0">
+                  <c:v>Objective met</c:v>
+                </c:pt>
+              </c:strCache>
+            </c:strRef>
+          </c:tx>
+          <c:spPr>
+            <a:solidFill>
+              <a:srgbClr val="0066FF"/>
+            </a:solidFill>
+            <a:ln w="19050">
+              <a:noFill/>
+            </a:ln>
+            <a:effectLst>
+              <a:outerShdw blurRad="241300" dist="38100" dir="2700000" algn="tl" rotWithShape="0">
+                <a:prstClr val="black">
+                  <a:alpha val="15000"/>
+                </a:prstClr>
+              </a:outerShdw>
+            </a:effectLst>
+          </c:spPr>
+          <c:invertIfNegative val="0"/>
+          <c:dPt>
+            <c:idx val="0"/>
+            <c:invertIfNegative val="0"/>
+            <c:bubble3D val="0"/>
+            <c:explosion val="6"/>
+            <c:spPr>
+              <a:solidFill>
+                <a:srgbClr val="0066FF"/>
+              </a:solidFill>
+              <a:ln w="19050">
+                <a:noFill/>
+              </a:ln>
+              <a:effectLst>
+                <a:outerShdw blurRad="241300" dist="38100" dir="2700000" algn="tl" rotWithShape="0">
+                  <a:prstClr val="black">
+                    <a:alpha val="15000"/>
+                  </a:prstClr>
+                </a:outerShdw>
+              </a:effectLst>
+            </c:spPr>
+            <c:extLst xmlns:lc="http://schemas.openxmlformats.org/drawingml/2006/lockedCanvas" xmlns:comp="http://schemas.openxmlformats.org/drawingml/2006/compatibility" xmlns:we="http://schemas.microsoft.com/office/webextensions/webextension/2010/11" xmlns:wetp="http://schemas.microsoft.com/office/webextensions/taskpanes/2010/11" xmlns:w16cid="http://schemas.microsoft.com/office/word/2016/wordml/cid" xmlns:w16se="http://schemas.microsoft.com/office/word/2015/wordml/symex" xmlns:wps="http://schemas.microsoft.com/office/word/2010/wordprocessingShape" xmlns:b="http://schemas.openxmlformats.org/officeDocument/2006/bibliography" xmlns:odgm="http://opendope.org/SmartArt/DataHierarchy" xmlns:odi="http://opendope.org/components" xmlns:oda="http://opendope.org/answers" xmlns:odq="http://opendope.org/questions" xmlns:odc="http://opendope.org/conditions" xmlns:odx="http://opendope.org/xpaths" xmlns:cppr="http://schemas.microsoft.com/office/2006/coverPageProps" xmlns:pvml="urn:schemas-microsoft-com:office:powerpoint" xmlns:w10="urn:schemas-microsoft-com:office:word" xmlns:v="urn:schemas-microsoft-com:vml" xmlns:o="urn:schemas-microsoft-com:office:office" xmlns:xvml="urn:schemas-microsoft-com:office:excel" xmlns:dsp="http://schemas.microsoft.com/office/drawing/2008/diagram" xmlns:xdr="http://schemas.openxmlformats.org/drawingml/2006/spreadsheetDrawing" xmlns:pic="http://schemas.openxmlformats.org/drawingml/2006/picture" xmlns:dgm="http://schemas.openxmlformats.org/drawingml/2006/diagram" xmlns:c14="http://schemas.microsoft.com/office/drawing/2007/8/2/chart" xmlns:cdr="http://schemas.openxmlformats.org/drawingml/2006/chartDrawing" xmlns:wne="http://schemas.microsoft.com/office/word/2006/wordml" xmlns:sl="http://schemas.openxmlformats.org/schemaLibrary/2006/main" xmlns:mc="http://schemas.openxmlformats.org/markup-compatibility/2006" xmlns:wp14="http://schemas.microsoft.com/office/word/2010/wordprocessingDrawing" xmlns:wp="http://schemas.openxmlformats.org/drawingml/2006/wordprocessingDrawing" xmlns:m="http://schemas.openxmlformats.org/officeDocument/2006/math" xmlns:w14="http://schemas.microsoft.com/office/word/2010/wordml" xmlns:w15="http://schemas.microsoft.com/office/word/2012/wordml" xmlns:w="http://schemas.openxmlformats.org/wordprocessingml/2006/main">
+              <c:ext xmlns:c16="http://schemas.microsoft.com/office/drawing/2014/chart" uri="{C3380CC4-5D6E-409C-BE32-E72D297353CC}">
+                <c16:uniqueId val="{00000001-6147-E74A-AA7B-5531F0E4EE0C}"/>
+              </c:ext>
+            </c:extLst>
+          </c:dPt>
+          <c:cat>
+            <c:strRef>
+              <c:f>Sheet1!$A$2:$A$13</c:f>
+              <c:strCache>
+                <c:ptCount val="12"/>
+                <c:pt idx="0">
+                  <c:v>Month 1</c:v>
+                </c:pt>
+                <c:pt idx="1">
+                  <c:v>Month 2</c:v>
+                </c:pt>
+                <c:pt idx="2">
+                  <c:v>Month 3</c:v>
+                </c:pt>
+                <c:pt idx="3">
+                  <c:v>Month 4</c:v>
+                </c:pt>
+                <c:pt idx="4">
+                  <c:v>Month 5</c:v>
+                </c:pt>
+                <c:pt idx="5">
+                  <c:v>Month 6</c:v>
+                </c:pt>
+                <c:pt idx="6">
+                  <c:v>Month 7</c:v>
+                </c:pt>
+                <c:pt idx="7">
+                  <c:v>Month 8</c:v>
+                </c:pt>
+                <c:pt idx="8">
+                  <c:v>Month 9</c:v>
+                </c:pt>
+                <c:pt idx="9">
+                  <c:v>Month 10</c:v>
+                </c:pt>
+                <c:pt idx="10">
+                  <c:v>Month 11</c:v>
+                </c:pt>
+                <c:pt idx="11">
+                  <c:v>Month 12</c:v>
+                </c:pt>
+              </c:strCache>
+            </c:strRef>
+          </c:cat>
+          <c:val>
+            <c:numRef>
+              <c:f>Sheet1!$B$2:$B$13</c:f>
+              <c:numCache>
+                <c:formatCode>0.0</c:formatCode>
+                <c:ptCount val="12"/>
+                <c:pt idx="0">
+                  <c:v>0.5</c:v>
+                </c:pt>
+                <c:pt idx="1">
+                  <c:v>0.5</c:v>
+                </c:pt>
+                <c:pt idx="2">
+                  <c:v>0.5</c:v>
+                </c:pt>
+                <c:pt idx="3">
+                  <c:v>0.5</c:v>
+                </c:pt>
+                <c:pt idx="4">
+                  <c:v>0.5</c:v>
+                </c:pt>
+                <c:pt idx="5">
+                  <c:v>0.5</c:v>
+                </c:pt>
+                <c:pt idx="6">
+                  <c:v>0.5</c:v>
+                </c:pt>
+                <c:pt idx="7">
+                  <c:v>0.5</c:v>
+                </c:pt>
+                <c:pt idx="8">
+                  <c:v>0.5</c:v>
+                </c:pt>
+                <c:pt idx="9">
+                  <c:v>0.5</c:v>
+                </c:pt>
+                <c:pt idx="10">
+                  <c:v>0.5</c:v>
+                </c:pt>
+                <c:pt idx="11">
+                  <c:v>0.5</c:v>
+                </c:pt>
+              </c:numCache>
+            </c:numRef>
+          </c:val>
+          <c:extLst xmlns:lc="http://schemas.openxmlformats.org/drawingml/2006/lockedCanvas" xmlns:comp="http://schemas.openxmlformats.org/drawingml/2006/compatibility" xmlns:we="http://schemas.microsoft.com/office/webextensions/webextension/2010/11" xmlns:wetp="http://schemas.microsoft.com/office/webextensions/taskpanes/2010/11" xmlns:w16cid="http://schemas.microsoft.com/office/word/2016/wordml/cid" xmlns:w16se="http://schemas.microsoft.com/office/word/2015/wordml/symex" xmlns:wps="http://schemas.microsoft.com/office/word/2010/wordprocessingShape" xmlns:b="http://schemas.openxmlformats.org/officeDocument/2006/bibliography" xmlns:odgm="http://opendope.org/SmartArt/DataHierarchy" xmlns:odi="http://opendope.org/components" xmlns:oda="http://opendope.org/answers" xmlns:odq="http://opendope.org/questions" xmlns:odc="http://opendope.org/conditions" xmlns:odx="http://opendope.org/xpaths" xmlns:cppr="http://schemas.microsoft.com/office/2006/coverPageProps" xmlns:pvml="urn:schemas-microsoft-com:office:powerpoint" xmlns:w10="urn:schemas-microsoft-com:office:word" xmlns:v="urn:schemas-microsoft-com:vml" xmlns:o="urn:schemas-microsoft-com:office:office" xmlns:xvml="urn:schemas-microsoft-com:office:excel" xmlns:dsp="http://schemas.microsoft.com/office/drawing/2008/diagram" xmlns:xdr="http://schemas.openxmlformats.org/drawingml/2006/spreadsheetDrawing" xmlns:pic="http://schemas.openxmlformats.org/drawingml/2006/picture" xmlns:dgm="http://schemas.openxmlformats.org/drawingml/2006/diagram" xmlns:c14="http://schemas.microsoft.com/office/drawing/2007/8/2/chart" xmlns:cdr="http://schemas.openxmlformats.org/drawingml/2006/chartDrawing" xmlns:wne="http://schemas.microsoft.com/office/word/2006/wordml" xmlns:sl="http://schemas.openxmlformats.org/schemaLibrary/2006/main" xmlns:mc="http://schemas.openxmlformats.org/markup-compatibility/2006" xmlns:wp14="http://schemas.microsoft.com/office/word/2010/wordprocessingDrawing" xmlns:wp="http://schemas.openxmlformats.org/drawingml/2006/wordprocessingDrawing" xmlns:m="http://schemas.openxmlformats.org/officeDocument/2006/math" xmlns:w14="http://schemas.microsoft.com/office/word/2010/wordml" xmlns:w15="http://schemas.microsoft.com/office/word/2012/wordml" xmlns:w="http://schemas.openxmlformats.org/wordprocessingml/2006/main">
+            <c:ext xmlns:c16="http://schemas.microsoft.com/office/drawing/2014/chart" uri="{C3380CC4-5D6E-409C-BE32-E72D297353CC}">
+              <c16:uniqueId val="{00000002-6147-E74A-AA7B-5531F0E4EE0C}"/>
+            </c:ext>
+          </c:extLst>
+        </c:ser>
+        <c:ser>
+          <c:idx val="1"/>
+          <c:order val="1"/>
+          <c:tx>
+            <c:strRef>
+              <c:f>Sheet1!$C$1</c:f>
+              <c:strCache>
+                <c:ptCount val="1"/>
+                <c:pt idx="0">
+                  <c:v>Improved</c:v>
+                </c:pt>
+              </c:strCache>
+            </c:strRef>
+          </c:tx>
+          <c:spPr>
+            <a:solidFill>
+              <a:srgbClr val="67E77F"/>
+            </a:solidFill>
+            <a:ln w="19050">
+              <a:noFill/>
+            </a:ln>
+            <a:effectLst/>
+          </c:spPr>
+          <c:invertIfNegative val="0"/>
+          <c:cat>
+            <c:strRef>
+              <c:f>Sheet1!$A$2:$A$13</c:f>
+              <c:strCache>
+                <c:ptCount val="12"/>
+                <c:pt idx="0">
+                  <c:v>Month 1</c:v>
+                </c:pt>
+                <c:pt idx="1">
+                  <c:v>Month 2</c:v>
+                </c:pt>
+                <c:pt idx="2">
+                  <c:v>Month 3</c:v>
+                </c:pt>
+                <c:pt idx="3">
+                  <c:v>Month 4</c:v>
+                </c:pt>
+                <c:pt idx="4">
+                  <c:v>Month 5</c:v>
+                </c:pt>
+                <c:pt idx="5">
+                  <c:v>Month 6</c:v>
+                </c:pt>
+                <c:pt idx="6">
+                  <c:v>Month 7</c:v>
+                </c:pt>
+                <c:pt idx="7">
+                  <c:v>Month 8</c:v>
+                </c:pt>
+                <c:pt idx="8">
+                  <c:v>Month 9</c:v>
+                </c:pt>
+                <c:pt idx="9">
+                  <c:v>Month 10</c:v>
+                </c:pt>
+                <c:pt idx="10">
+                  <c:v>Month 11</c:v>
+                </c:pt>
+                <c:pt idx="11">
+                  <c:v>Month 12</c:v>
+                </c:pt>
+              </c:strCache>
+            </c:strRef>
+          </c:cat>
+          <c:val>
+            <c:numRef>
+              <c:f>Sheet1!$C$2:$C$13</c:f>
+              <c:numCache>
+                <c:formatCode>0.0</c:formatCode>
+                <c:ptCount val="12"/>
+                <c:pt idx="0">
+                  <c:v>0.5</c:v>
+                </c:pt>
+                <c:pt idx="1">
+                  <c:v>0.5</c:v>
+                </c:pt>
+                <c:pt idx="2">
+                  <c:v>0.5</c:v>
+                </c:pt>
+                <c:pt idx="3">
+                  <c:v>0.5</c:v>
+                </c:pt>
+                <c:pt idx="4">
+                  <c:v>0.5</c:v>
+                </c:pt>
+                <c:pt idx="5">
+                  <c:v>0.5</c:v>
+                </c:pt>
+                <c:pt idx="6">
+                  <c:v>0.5</c:v>
+                </c:pt>
+                <c:pt idx="7">
+                  <c:v>0.5</c:v>
+                </c:pt>
+                <c:pt idx="8">
+                  <c:v>0.5</c:v>
+                </c:pt>
+                <c:pt idx="9">
+                  <c:v>0.5</c:v>
+                </c:pt>
+                <c:pt idx="10">
+                  <c:v>0.5</c:v>
+                </c:pt>
+                <c:pt idx="11">
+                  <c:v>0.5</c:v>
+                </c:pt>
+              </c:numCache>
+            </c:numRef>
+          </c:val>
+          <c:extLst>
+            <c:ext xmlns:c16="http://schemas.microsoft.com/office/drawing/2014/chart" uri="{C3380CC4-5D6E-409C-BE32-E72D297353CC}">
+              <c16:uniqueId val="{00000003-6147-E74A-AA7B-5531F0E4EE0C}"/>
+            </c:ext>
+          </c:extLst>
+        </c:ser>
+        <c:ser>
+          <c:idx val="2"/>
+          <c:order val="2"/>
+          <c:tx>
+            <c:strRef>
+              <c:f>Sheet1!$D$1</c:f>
+              <c:strCache>
+                <c:ptCount val="1"/>
+                <c:pt idx="0">
+                  <c:v>Unchanged</c:v>
+                </c:pt>
+              </c:strCache>
+            </c:strRef>
+          </c:tx>
+          <c:spPr>
+            <a:solidFill>
+              <a:srgbClr val="BFC4CF"/>
+            </a:solidFill>
+            <a:ln w="19050">
+              <a:noFill/>
+            </a:ln>
+            <a:effectLst/>
+          </c:spPr>
+          <c:invertIfNegative val="0"/>
+          <c:cat>
+            <c:strRef>
+              <c:f>Sheet1!$A$2:$A$13</c:f>
+              <c:strCache>
+                <c:ptCount val="12"/>
+                <c:pt idx="0">
+                  <c:v>Month 1</c:v>
+                </c:pt>
+                <c:pt idx="1">
+                  <c:v>Month 2</c:v>
+                </c:pt>
+                <c:pt idx="2">
+                  <c:v>Month 3</c:v>
+                </c:pt>
+                <c:pt idx="3">
+                  <c:v>Month 4</c:v>
+                </c:pt>
+                <c:pt idx="4">
+                  <c:v>Month 5</c:v>
+                </c:pt>
+                <c:pt idx="5">
+                  <c:v>Month 6</c:v>
+                </c:pt>
+                <c:pt idx="6">
+                  <c:v>Month 7</c:v>
+                </c:pt>
+                <c:pt idx="7">
+                  <c:v>Month 8</c:v>
+                </c:pt>
+                <c:pt idx="8">
+                  <c:v>Month 9</c:v>
+                </c:pt>
+                <c:pt idx="9">
+                  <c:v>Month 10</c:v>
+                </c:pt>
+                <c:pt idx="10">
+                  <c:v>Month 11</c:v>
+                </c:pt>
+                <c:pt idx="11">
+                  <c:v>Month 12</c:v>
+                </c:pt>
+              </c:strCache>
+            </c:strRef>
+          </c:cat>
+          <c:val>
+            <c:numRef>
+              <c:f>Sheet1!$D$2:$D$13</c:f>
+              <c:numCache>
+                <c:formatCode>General</c:formatCode>
+                <c:ptCount val="12"/>
+                <c:pt idx="0">
+                  <c:v>0.5</c:v>
+                </c:pt>
+                <c:pt idx="1">
+                  <c:v>0.5</c:v>
+                </c:pt>
+                <c:pt idx="2">
+                  <c:v>0.5</c:v>
+                </c:pt>
+                <c:pt idx="3">
+                  <c:v>0.5</c:v>
+                </c:pt>
+                <c:pt idx="4">
+                  <c:v>0.5</c:v>
+                </c:pt>
+                <c:pt idx="5">
+                  <c:v>0.5</c:v>
+                </c:pt>
+                <c:pt idx="6">
+                  <c:v>0.5</c:v>
+                </c:pt>
+                <c:pt idx="7">
+                  <c:v>0.5</c:v>
+                </c:pt>
+                <c:pt idx="8">
+                  <c:v>0.5</c:v>
+                </c:pt>
+                <c:pt idx="9">
+                  <c:v>0.5</c:v>
+                </c:pt>
+                <c:pt idx="10">
+                  <c:v>0.5</c:v>
+                </c:pt>
+                <c:pt idx="11">
+                  <c:v>0.5</c:v>
+                </c:pt>
+              </c:numCache>
+            </c:numRef>
+          </c:val>
+          <c:extLst>
+            <c:ext xmlns:c16="http://schemas.microsoft.com/office/drawing/2014/chart" uri="{C3380CC4-5D6E-409C-BE32-E72D297353CC}">
+              <c16:uniqueId val="{00000004-6147-E74A-AA7B-5531F0E4EE0C}"/>
+            </c:ext>
+          </c:extLst>
+        </c:ser>
+        <c:ser>
+          <c:idx val="3"/>
+          <c:order val="3"/>
+          <c:tx>
+            <c:strRef>
+              <c:f>Sheet1!$E$1</c:f>
+              <c:strCache>
+                <c:ptCount val="1"/>
+                <c:pt idx="0">
+                  <c:v>Worsened</c:v>
+                </c:pt>
+              </c:strCache>
+            </c:strRef>
+          </c:tx>
+          <c:spPr>
+            <a:solidFill>
+              <a:srgbClr val="F06241"/>
+            </a:solidFill>
+            <a:ln w="19050">
+              <a:noFill/>
+            </a:ln>
+            <a:effectLst/>
+          </c:spPr>
+          <c:invertIfNegative val="0"/>
+          <c:cat>
+            <c:strRef>
+              <c:f>Sheet1!$A$2:$A$13</c:f>
+              <c:strCache>
+                <c:ptCount val="12"/>
+                <c:pt idx="0">
+                  <c:v>Month 1</c:v>
+                </c:pt>
+                <c:pt idx="1">
+                  <c:v>Month 2</c:v>
+                </c:pt>
+                <c:pt idx="2">
+                  <c:v>Month 3</c:v>
+                </c:pt>
+                <c:pt idx="3">
+                  <c:v>Month 4</c:v>
+                </c:pt>
+                <c:pt idx="4">
+                  <c:v>Month 5</c:v>
+                </c:pt>
+                <c:pt idx="5">
+                  <c:v>Month 6</c:v>
+                </c:pt>
+                <c:pt idx="6">
+                  <c:v>Month 7</c:v>
+                </c:pt>
+                <c:pt idx="7">
+                  <c:v>Month 8</c:v>
+                </c:pt>
+                <c:pt idx="8">
+                  <c:v>Month 9</c:v>
+                </c:pt>
+                <c:pt idx="9">
+                  <c:v>Month 10</c:v>
+                </c:pt>
+                <c:pt idx="10">
+                  <c:v>Month 11</c:v>
+                </c:pt>
+                <c:pt idx="11">
+                  <c:v>Month 12</c:v>
+                </c:pt>
+              </c:strCache>
+            </c:strRef>
+          </c:cat>
+          <c:val>
+            <c:numRef>
+              <c:f>Sheet1!$E$2:$E$13</c:f>
+              <c:numCache>
+                <c:formatCode>General</c:formatCode>
+                <c:ptCount val="12"/>
+                <c:pt idx="0">
+                  <c:v>0.5</c:v>
+                </c:pt>
+                <c:pt idx="1">
+                  <c:v>0.5</c:v>
+                </c:pt>
+                <c:pt idx="2">
+                  <c:v>0.5</c:v>
+                </c:pt>
+                <c:pt idx="3">
+                  <c:v>0.5</c:v>
+                </c:pt>
+                <c:pt idx="4">
+                  <c:v>0.5</c:v>
+                </c:pt>
+                <c:pt idx="5">
+                  <c:v>0.5</c:v>
+                </c:pt>
+                <c:pt idx="6">
+                  <c:v>0.5</c:v>
+                </c:pt>
+                <c:pt idx="7">
+                  <c:v>0.5</c:v>
+                </c:pt>
+                <c:pt idx="8">
+                  <c:v>0.5</c:v>
+                </c:pt>
+                <c:pt idx="9">
+                  <c:v>0.5</c:v>
+                </c:pt>
+                <c:pt idx="10">
+                  <c:v>0.5</c:v>
+                </c:pt>
+                <c:pt idx="11">
+                  <c:v>0.5</c:v>
+                </c:pt>
+              </c:numCache>
+            </c:numRef>
+          </c:val>
+          <c:extLst>
+            <c:ext xmlns:c16="http://schemas.microsoft.com/office/drawing/2014/chart" uri="{C3380CC4-5D6E-409C-BE32-E72D297353CC}">
+              <c16:uniqueId val="{00000005-6147-E74A-AA7B-5531F0E4EE0C}"/>
+            </c:ext>
+          </c:extLst>
+        </c:ser>
+        <c:ser>
+          <c:idx val="4"/>
+          <c:order val="4"/>
+          <c:tx>
+            <c:strRef>
+              <c:f>Sheet1!$F$1</c:f>
+              <c:strCache>
+                <c:ptCount val="1"/>
+                <c:pt idx="0">
+                  <c:v>Unknown</c:v>
+                </c:pt>
+              </c:strCache>
+            </c:strRef>
+          </c:tx>
+          <c:spPr>
+            <a:solidFill>
+              <a:schemeClr val="bg1"/>
+            </a:solidFill>
+            <a:ln w="19050">
+              <a:solidFill>
+                <a:schemeClr val="lt1"/>
+              </a:solidFill>
+            </a:ln>
+            <a:effectLst/>
+          </c:spPr>
+          <c:invertIfNegative val="0"/>
+          <c:cat>
+            <c:strRef>
+              <c:f>Sheet1!$A$2:$A$13</c:f>
+              <c:strCache>
+                <c:ptCount val="12"/>
+                <c:pt idx="0">
+                  <c:v>Month 1</c:v>
+                </c:pt>
+                <c:pt idx="1">
+                  <c:v>Month 2</c:v>
+                </c:pt>
+                <c:pt idx="2">
+                  <c:v>Month 3</c:v>
+                </c:pt>
+                <c:pt idx="3">
+                  <c:v>Month 4</c:v>
+                </c:pt>
+                <c:pt idx="4">
+                  <c:v>Month 5</c:v>
+                </c:pt>
+                <c:pt idx="5">
+                  <c:v>Month 6</c:v>
+                </c:pt>
+                <c:pt idx="6">
+                  <c:v>Month 7</c:v>
+                </c:pt>
+                <c:pt idx="7">
+                  <c:v>Month 8</c:v>
+                </c:pt>
+                <c:pt idx="8">
+                  <c:v>Month 9</c:v>
+                </c:pt>
+                <c:pt idx="9">
+                  <c:v>Month 10</c:v>
+                </c:pt>
+                <c:pt idx="10">
+                  <c:v>Month 11</c:v>
+                </c:pt>
+                <c:pt idx="11">
+                  <c:v>Month 12</c:v>
+                </c:pt>
+              </c:strCache>
+            </c:strRef>
+          </c:cat>
+          <c:val>
+            <c:numRef>
+              <c:f>Sheet1!$F$2:$F$13</c:f>
+              <c:numCache>
+                <c:formatCode>General</c:formatCode>
+                <c:ptCount val="12"/>
+                <c:pt idx="0">
+                  <c:v>0.5</c:v>
+                </c:pt>
+                <c:pt idx="1">
+                  <c:v>0.5</c:v>
+                </c:pt>
+                <c:pt idx="2">
+                  <c:v>0.5</c:v>
+                </c:pt>
+                <c:pt idx="3">
+                  <c:v>0.5</c:v>
+                </c:pt>
+                <c:pt idx="4">
+                  <c:v>0.5</c:v>
+                </c:pt>
+                <c:pt idx="5">
+                  <c:v>0.5</c:v>
+                </c:pt>
+                <c:pt idx="6">
+                  <c:v>0.5</c:v>
+                </c:pt>
+                <c:pt idx="7">
+                  <c:v>0.5</c:v>
+                </c:pt>
+                <c:pt idx="8">
+                  <c:v>0.5</c:v>
+                </c:pt>
+                <c:pt idx="9">
+                  <c:v>0.5</c:v>
+                </c:pt>
+                <c:pt idx="10">
+                  <c:v>0.5</c:v>
+                </c:pt>
+                <c:pt idx="11">
+                  <c:v>0.5</c:v>
+                </c:pt>
+              </c:numCache>
+            </c:numRef>
+          </c:val>
+          <c:extLst>
+            <c:ext xmlns:c16="http://schemas.microsoft.com/office/drawing/2014/chart" uri="{C3380CC4-5D6E-409C-BE32-E72D297353CC}">
+              <c16:uniqueId val="{00000006-6147-E74A-AA7B-5531F0E4EE0C}"/>
+            </c:ext>
+          </c:extLst>
+        </c:ser>
+        <c:dLbls>
+          <c:showLegendKey val="0"/>
+          <c:showVal val="0"/>
+          <c:showCatName val="0"/>
+          <c:showSerName val="0"/>
+          <c:showPercent val="0"/>
+          <c:showBubbleSize val="0"/>
+        </c:dLbls>
+        <c:gapWidth val="20"/>
+        <c:overlap val="100"/>
+        <c:axId val="476387520"/>
+        <c:axId val="477616192"/>
+      </c:barChart>
+      <c:catAx>
+        <c:axId val="476387520"/>
+        <c:scaling>
+          <c:orientation val="minMax"/>
+        </c:scaling>
+        <c:delete val="0"/>
+        <c:axPos val="b"/>
+        <c:numFmt formatCode="General" sourceLinked="1"/>
+        <c:majorTickMark val="out"/>
+        <c:minorTickMark val="none"/>
+        <c:tickLblPos val="nextTo"/>
+        <c:spPr>
+          <a:noFill/>
+          <a:ln w="9525" cap="flat" cmpd="sng" algn="ctr">
+            <a:solidFill>
+              <a:schemeClr val="tx1">
+                <a:lumMod val="15000"/>
+                <a:lumOff val="85000"/>
+              </a:schemeClr>
+            </a:solidFill>
+            <a:round/>
+          </a:ln>
+          <a:effectLst/>
+        </c:spPr>
+        <c:txPr>
+          <a:bodyPr rot="-60000000" spcFirstLastPara="1" vertOverflow="ellipsis" vert="horz" wrap="square" anchor="ctr" anchorCtr="1"/>
+          <a:lstStyle/>
+          <a:p>
+            <a:pPr>
+              <a:defRPr sz="1400" b="0" i="0" u="none" strike="noStrike" kern="1200" baseline="0">
+                <a:solidFill>
+                  <a:schemeClr val="tx2"/>
+                </a:solidFill>
+                <a:latin typeface="+mn-lt"/>
+                <a:ea typeface="+mn-ea"/>
+                <a:cs typeface="+mn-cs"/>
+              </a:defRPr>
+            </a:pPr>
+            <a:endParaRPr lang="en-NL"/>
+          </a:p>
+        </c:txPr>
+        <c:crossAx val="477616192"/>
+        <c:crosses val="autoZero"/>
+        <c:auto val="1"/>
+        <c:lblAlgn val="ctr"/>
+        <c:lblOffset val="100"/>
+        <c:noMultiLvlLbl val="0"/>
+      </c:catAx>
+      <c:valAx>
+        <c:axId val="477616192"/>
+        <c:scaling>
+          <c:orientation val="minMax"/>
+        </c:scaling>
+        <c:delete val="0"/>
+        <c:axPos val="l"/>
+        <c:majorGridlines>
+          <c:spPr>
+            <a:ln w="9525" cap="flat" cmpd="sng" algn="ctr">
+              <a:solidFill>
+                <a:schemeClr val="tx1">
+                  <a:lumMod val="15000"/>
+                  <a:lumOff val="85000"/>
+                </a:schemeClr>
+              </a:solidFill>
+              <a:round/>
+            </a:ln>
+            <a:effectLst/>
+          </c:spPr>
+        </c:majorGridlines>
+        <c:numFmt formatCode="0%" sourceLinked="0"/>
+        <c:majorTickMark val="out"/>
+        <c:minorTickMark val="none"/>
+        <c:tickLblPos val="nextTo"/>
+        <c:spPr>
+          <a:noFill/>
+          <a:ln>
+            <a:noFill/>
+          </a:ln>
+          <a:effectLst/>
+        </c:spPr>
+        <c:txPr>
+          <a:bodyPr rot="-60000000" spcFirstLastPara="1" vertOverflow="ellipsis" vert="horz" wrap="square" anchor="ctr" anchorCtr="1"/>
+          <a:lstStyle/>
+          <a:p>
+            <a:pPr>
+              <a:defRPr sz="1197" b="0" i="0" u="none" strike="noStrike" kern="1200" baseline="0">
+                <a:solidFill>
+                  <a:schemeClr val="tx2"/>
+                </a:solidFill>
+                <a:latin typeface="+mn-lt"/>
+                <a:ea typeface="+mn-ea"/>
+                <a:cs typeface="+mn-cs"/>
+              </a:defRPr>
+            </a:pPr>
+            <a:endParaRPr lang="en-US"/>
+          </a:p>
+        </c:txPr>
+        <c:crossAx val="476387520"/>
+        <c:crosses val="autoZero"/>
+        <c:crossBetween val="between"/>
+      </c:valAx>
+      <c:spPr>
+        <a:solidFill>
+          <a:srgbClr val="F0F4F8"/>
+        </a:solidFill>
+        <a:ln>
+          <a:noFill/>
+        </a:ln>
+        <a:effectLst/>
+      </c:spPr>
+    </c:plotArea>
+    <c:plotVisOnly val="1"/>
+    <c:dispBlanksAs val="gap"/>
+    <c:showDLblsOverMax val="0"/>
     <c:extLst xmlns:lc="http://schemas.openxmlformats.org/drawingml/2006/lockedCanvas" xmlns:comp="http://schemas.openxmlformats.org/drawingml/2006/compatibility" xmlns:we="http://schemas.microsoft.com/office/webextensions/webextension/2010/11" xmlns:wetp="http://schemas.microsoft.com/office/webextensions/taskpanes/2010/11" xmlns:w16cid="http://schemas.microsoft.com/office/word/2016/wordml/cid" xmlns:w16se="http://schemas.microsoft.com/office/word/2015/wordml/symex" xmlns:wps="http://schemas.microsoft.com/office/word/2010/wordprocessingShape" xmlns:b="http://schemas.openxmlformats.org/officeDocument/2006/bibliography" xmlns:odgm="http://opendope.org/SmartArt/DataHierarchy" xmlns:odi="http://opendope.org/components" xmlns:oda="http://opendope.org/answers" xmlns:odq="http://opendope.org/questions" xmlns:odc="http://opendope.org/conditions" xmlns:odx="http://opendope.org/xpaths" xmlns:cppr="http://schemas.microsoft.com/office/2006/coverPageProps" xmlns:pvml="urn:schemas-microsoft-com:office:powerpoint" xmlns:w10="urn:schemas-microsoft-com:office:word" xmlns:v="urn:schemas-microsoft-com:vml" xmlns:o="urn:schemas-microsoft-com:office:office" xmlns:xvml="urn:schemas-microsoft-com:office:excel" xmlns:dsp="http://schemas.microsoft.com/office/drawing/2008/diagram" xmlns:xdr="http://schemas.openxmlformats.org/drawingml/2006/spreadsheetDrawing" xmlns:pic="http://schemas.openxmlformats.org/drawingml/2006/picture" xmlns:dgm="http://schemas.openxmlformats.org/drawingml/2006/diagram" xmlns:c14="http://schemas.microsoft.com/office/drawing/2007/8/2/chart" xmlns:cdr="http://schemas.openxmlformats.org/drawingml/2006/chartDrawing" xmlns:wne="http://schemas.microsoft.com/office/word/2006/wordml" xmlns:sl="http://schemas.openxmlformats.org/schemaLibrary/2006/main" xmlns:mc="http://schemas.openxmlformats.org/markup-compatibility/2006" xmlns:wp14="http://schemas.microsoft.com/office/word/2010/wordprocessingDrawing" xmlns:wp="http://schemas.openxmlformats.org/drawingml/2006/wordprocessingDrawing" xmlns:m="http://schemas.openxmlformats.org/officeDocument/2006/math" xmlns:w14="http://schemas.microsoft.com/office/word/2010/wordml" xmlns:w15="http://schemas.microsoft.com/office/word/2012/wordml" xmlns:w="http://schemas.openxmlformats.org/wordprocessingml/2006/main">
       <c:ext xmlns:c16r3="http://schemas.microsoft.com/office/drawing/2017/03/chart" uri="{56B9EC1D-385E-4148-901F-78D8002777C0}">
         <c16r3:dataDisplayOptions16>
@@ -1578,7 +2386,815 @@
 </c:chartSpace>
 </file>
 
-<file path=ppt/charts/chart11.xml><?xml version="1.0" encoding="utf-8"?>
+<file path=ppt/charts/chart12.xml><?xml version="1.0" encoding="utf-8"?>
+<c:chartSpace xmlns:c="http://schemas.openxmlformats.org/drawingml/2006/chart" xmlns:a="http://schemas.openxmlformats.org/drawingml/2006/main" xmlns:r="http://schemas.openxmlformats.org/officeDocument/2006/relationships" xmlns:c16r2="http://schemas.microsoft.com/office/drawing/2015/06/chart">
+  <c:date1904 val="0"/>
+  <c:lang val="en-US"/>
+  <c:roundedCorners val="0"/>
+  <mc:AlternateContent xmlns:mc="http://schemas.openxmlformats.org/markup-compatibility/2006">
+    <mc:Choice xmlns:c14="http://schemas.microsoft.com/office/drawing/2007/8/2/chart" Requires="c14">
+      <c14:style val="104"/>
+    </mc:Choice>
+    <mc:Fallback>
+      <c:style val="4"/>
+    </mc:Fallback>
+  </mc:AlternateContent>
+  <c:chart>
+    <c:autoTitleDeleted val="1"/>
+    <c:plotArea>
+      <c:layout/>
+      <c:barChart>
+        <c:barDir val="col"/>
+        <c:grouping val="percentStacked"/>
+        <c:varyColors val="0"/>
+        <c:ser>
+          <c:idx val="0"/>
+          <c:order val="0"/>
+          <c:tx>
+            <c:strRef>
+              <c:f>Sheet1!$B$1</c:f>
+              <c:strCache>
+                <c:ptCount val="1"/>
+                <c:pt idx="0">
+                  <c:v>Objective met</c:v>
+                </c:pt>
+              </c:strCache>
+            </c:strRef>
+          </c:tx>
+          <c:spPr>
+            <a:solidFill>
+              <a:srgbClr val="0066FF"/>
+            </a:solidFill>
+            <a:ln w="19050">
+              <a:noFill/>
+            </a:ln>
+            <a:effectLst>
+              <a:outerShdw blurRad="241300" dist="38100" dir="2700000" algn="tl" rotWithShape="0">
+                <a:prstClr val="black">
+                  <a:alpha val="15000"/>
+                </a:prstClr>
+              </a:outerShdw>
+            </a:effectLst>
+          </c:spPr>
+          <c:invertIfNegative val="0"/>
+          <c:dPt>
+            <c:idx val="0"/>
+            <c:invertIfNegative val="0"/>
+            <c:bubble3D val="0"/>
+            <c:explosion val="6"/>
+            <c:spPr>
+              <a:solidFill>
+                <a:srgbClr val="0066FF"/>
+              </a:solidFill>
+              <a:ln w="19050">
+                <a:noFill/>
+              </a:ln>
+              <a:effectLst>
+                <a:outerShdw blurRad="241300" dist="38100" dir="2700000" algn="tl" rotWithShape="0">
+                  <a:prstClr val="black">
+                    <a:alpha val="15000"/>
+                  </a:prstClr>
+                </a:outerShdw>
+              </a:effectLst>
+            </c:spPr>
+            <c:extLst xmlns:lc="http://schemas.openxmlformats.org/drawingml/2006/lockedCanvas" xmlns:comp="http://schemas.openxmlformats.org/drawingml/2006/compatibility" xmlns:we="http://schemas.microsoft.com/office/webextensions/webextension/2010/11" xmlns:wetp="http://schemas.microsoft.com/office/webextensions/taskpanes/2010/11" xmlns:w16cid="http://schemas.microsoft.com/office/word/2016/wordml/cid" xmlns:w16se="http://schemas.microsoft.com/office/word/2015/wordml/symex" xmlns:wps="http://schemas.microsoft.com/office/word/2010/wordprocessingShape" xmlns:b="http://schemas.openxmlformats.org/officeDocument/2006/bibliography" xmlns:odgm="http://opendope.org/SmartArt/DataHierarchy" xmlns:odi="http://opendope.org/components" xmlns:oda="http://opendope.org/answers" xmlns:odq="http://opendope.org/questions" xmlns:odc="http://opendope.org/conditions" xmlns:odx="http://opendope.org/xpaths" xmlns:cppr="http://schemas.microsoft.com/office/2006/coverPageProps" xmlns:pvml="urn:schemas-microsoft-com:office:powerpoint" xmlns:w10="urn:schemas-microsoft-com:office:word" xmlns:v="urn:schemas-microsoft-com:vml" xmlns:o="urn:schemas-microsoft-com:office:office" xmlns:xvml="urn:schemas-microsoft-com:office:excel" xmlns:dsp="http://schemas.microsoft.com/office/drawing/2008/diagram" xmlns:xdr="http://schemas.openxmlformats.org/drawingml/2006/spreadsheetDrawing" xmlns:pic="http://schemas.openxmlformats.org/drawingml/2006/picture" xmlns:dgm="http://schemas.openxmlformats.org/drawingml/2006/diagram" xmlns:c14="http://schemas.microsoft.com/office/drawing/2007/8/2/chart" xmlns:cdr="http://schemas.openxmlformats.org/drawingml/2006/chartDrawing" xmlns:wne="http://schemas.microsoft.com/office/word/2006/wordml" xmlns:sl="http://schemas.openxmlformats.org/schemaLibrary/2006/main" xmlns:mc="http://schemas.openxmlformats.org/markup-compatibility/2006" xmlns:wp14="http://schemas.microsoft.com/office/word/2010/wordprocessingDrawing" xmlns:wp="http://schemas.openxmlformats.org/drawingml/2006/wordprocessingDrawing" xmlns:m="http://schemas.openxmlformats.org/officeDocument/2006/math" xmlns:w14="http://schemas.microsoft.com/office/word/2010/wordml" xmlns:w15="http://schemas.microsoft.com/office/word/2012/wordml" xmlns:w="http://schemas.openxmlformats.org/wordprocessingml/2006/main">
+              <c:ext xmlns:c16="http://schemas.microsoft.com/office/drawing/2014/chart" uri="{C3380CC4-5D6E-409C-BE32-E72D297353CC}">
+                <c16:uniqueId val="{00000001-6147-E74A-AA7B-5531F0E4EE0C}"/>
+              </c:ext>
+            </c:extLst>
+          </c:dPt>
+          <c:cat>
+            <c:strRef>
+              <c:f>Sheet1!$A$2:$A$13</c:f>
+              <c:strCache>
+                <c:ptCount val="12"/>
+                <c:pt idx="0">
+                  <c:v>Month 1</c:v>
+                </c:pt>
+                <c:pt idx="1">
+                  <c:v>Month 2</c:v>
+                </c:pt>
+                <c:pt idx="2">
+                  <c:v>Month 3</c:v>
+                </c:pt>
+                <c:pt idx="3">
+                  <c:v>Month 4</c:v>
+                </c:pt>
+                <c:pt idx="4">
+                  <c:v>Month 5</c:v>
+                </c:pt>
+                <c:pt idx="5">
+                  <c:v>Month 6</c:v>
+                </c:pt>
+                <c:pt idx="6">
+                  <c:v>Month 7</c:v>
+                </c:pt>
+                <c:pt idx="7">
+                  <c:v>Month 8</c:v>
+                </c:pt>
+                <c:pt idx="8">
+                  <c:v>Month 9</c:v>
+                </c:pt>
+                <c:pt idx="9">
+                  <c:v>Month 10</c:v>
+                </c:pt>
+                <c:pt idx="10">
+                  <c:v>Month 11</c:v>
+                </c:pt>
+                <c:pt idx="11">
+                  <c:v>Month 12</c:v>
+                </c:pt>
+              </c:strCache>
+            </c:strRef>
+          </c:cat>
+          <c:val>
+            <c:numRef>
+              <c:f>Sheet1!$B$2:$B$13</c:f>
+              <c:numCache>
+                <c:formatCode>0.0</c:formatCode>
+                <c:ptCount val="12"/>
+                <c:pt idx="0">
+                  <c:v>0.5</c:v>
+                </c:pt>
+                <c:pt idx="1">
+                  <c:v>0.5</c:v>
+                </c:pt>
+                <c:pt idx="2">
+                  <c:v>0.5</c:v>
+                </c:pt>
+                <c:pt idx="3">
+                  <c:v>0.5</c:v>
+                </c:pt>
+                <c:pt idx="4">
+                  <c:v>0.5</c:v>
+                </c:pt>
+                <c:pt idx="5">
+                  <c:v>0.5</c:v>
+                </c:pt>
+                <c:pt idx="6">
+                  <c:v>0.5</c:v>
+                </c:pt>
+                <c:pt idx="7">
+                  <c:v>0.5</c:v>
+                </c:pt>
+                <c:pt idx="8">
+                  <c:v>0.5</c:v>
+                </c:pt>
+                <c:pt idx="9">
+                  <c:v>0.5</c:v>
+                </c:pt>
+                <c:pt idx="10">
+                  <c:v>0.5</c:v>
+                </c:pt>
+                <c:pt idx="11">
+                  <c:v>0.5</c:v>
+                </c:pt>
+              </c:numCache>
+            </c:numRef>
+          </c:val>
+          <c:extLst xmlns:lc="http://schemas.openxmlformats.org/drawingml/2006/lockedCanvas" xmlns:comp="http://schemas.openxmlformats.org/drawingml/2006/compatibility" xmlns:we="http://schemas.microsoft.com/office/webextensions/webextension/2010/11" xmlns:wetp="http://schemas.microsoft.com/office/webextensions/taskpanes/2010/11" xmlns:w16cid="http://schemas.microsoft.com/office/word/2016/wordml/cid" xmlns:w16se="http://schemas.microsoft.com/office/word/2015/wordml/symex" xmlns:wps="http://schemas.microsoft.com/office/word/2010/wordprocessingShape" xmlns:b="http://schemas.openxmlformats.org/officeDocument/2006/bibliography" xmlns:odgm="http://opendope.org/SmartArt/DataHierarchy" xmlns:odi="http://opendope.org/components" xmlns:oda="http://opendope.org/answers" xmlns:odq="http://opendope.org/questions" xmlns:odc="http://opendope.org/conditions" xmlns:odx="http://opendope.org/xpaths" xmlns:cppr="http://schemas.microsoft.com/office/2006/coverPageProps" xmlns:pvml="urn:schemas-microsoft-com:office:powerpoint" xmlns:w10="urn:schemas-microsoft-com:office:word" xmlns:v="urn:schemas-microsoft-com:vml" xmlns:o="urn:schemas-microsoft-com:office:office" xmlns:xvml="urn:schemas-microsoft-com:office:excel" xmlns:dsp="http://schemas.microsoft.com/office/drawing/2008/diagram" xmlns:xdr="http://schemas.openxmlformats.org/drawingml/2006/spreadsheetDrawing" xmlns:pic="http://schemas.openxmlformats.org/drawingml/2006/picture" xmlns:dgm="http://schemas.openxmlformats.org/drawingml/2006/diagram" xmlns:c14="http://schemas.microsoft.com/office/drawing/2007/8/2/chart" xmlns:cdr="http://schemas.openxmlformats.org/drawingml/2006/chartDrawing" xmlns:wne="http://schemas.microsoft.com/office/word/2006/wordml" xmlns:sl="http://schemas.openxmlformats.org/schemaLibrary/2006/main" xmlns:mc="http://schemas.openxmlformats.org/markup-compatibility/2006" xmlns:wp14="http://schemas.microsoft.com/office/word/2010/wordprocessingDrawing" xmlns:wp="http://schemas.openxmlformats.org/drawingml/2006/wordprocessingDrawing" xmlns:m="http://schemas.openxmlformats.org/officeDocument/2006/math" xmlns:w14="http://schemas.microsoft.com/office/word/2010/wordml" xmlns:w15="http://schemas.microsoft.com/office/word/2012/wordml" xmlns:w="http://schemas.openxmlformats.org/wordprocessingml/2006/main">
+            <c:ext xmlns:c16="http://schemas.microsoft.com/office/drawing/2014/chart" uri="{C3380CC4-5D6E-409C-BE32-E72D297353CC}">
+              <c16:uniqueId val="{00000002-6147-E74A-AA7B-5531F0E4EE0C}"/>
+            </c:ext>
+          </c:extLst>
+        </c:ser>
+        <c:ser>
+          <c:idx val="1"/>
+          <c:order val="1"/>
+          <c:tx>
+            <c:strRef>
+              <c:f>Sheet1!$C$1</c:f>
+              <c:strCache>
+                <c:ptCount val="1"/>
+                <c:pt idx="0">
+                  <c:v>Improved</c:v>
+                </c:pt>
+              </c:strCache>
+            </c:strRef>
+          </c:tx>
+          <c:spPr>
+            <a:solidFill>
+              <a:srgbClr val="67E77F"/>
+            </a:solidFill>
+            <a:ln w="19050">
+              <a:noFill/>
+            </a:ln>
+            <a:effectLst/>
+          </c:spPr>
+          <c:invertIfNegative val="0"/>
+          <c:cat>
+            <c:strRef>
+              <c:f>Sheet1!$A$2:$A$13</c:f>
+              <c:strCache>
+                <c:ptCount val="12"/>
+                <c:pt idx="0">
+                  <c:v>Month 1</c:v>
+                </c:pt>
+                <c:pt idx="1">
+                  <c:v>Month 2</c:v>
+                </c:pt>
+                <c:pt idx="2">
+                  <c:v>Month 3</c:v>
+                </c:pt>
+                <c:pt idx="3">
+                  <c:v>Month 4</c:v>
+                </c:pt>
+                <c:pt idx="4">
+                  <c:v>Month 5</c:v>
+                </c:pt>
+                <c:pt idx="5">
+                  <c:v>Month 6</c:v>
+                </c:pt>
+                <c:pt idx="6">
+                  <c:v>Month 7</c:v>
+                </c:pt>
+                <c:pt idx="7">
+                  <c:v>Month 8</c:v>
+                </c:pt>
+                <c:pt idx="8">
+                  <c:v>Month 9</c:v>
+                </c:pt>
+                <c:pt idx="9">
+                  <c:v>Month 10</c:v>
+                </c:pt>
+                <c:pt idx="10">
+                  <c:v>Month 11</c:v>
+                </c:pt>
+                <c:pt idx="11">
+                  <c:v>Month 12</c:v>
+                </c:pt>
+              </c:strCache>
+            </c:strRef>
+          </c:cat>
+          <c:val>
+            <c:numRef>
+              <c:f>Sheet1!$C$2:$C$13</c:f>
+              <c:numCache>
+                <c:formatCode>0.0</c:formatCode>
+                <c:ptCount val="12"/>
+                <c:pt idx="0">
+                  <c:v>0.5</c:v>
+                </c:pt>
+                <c:pt idx="1">
+                  <c:v>0.5</c:v>
+                </c:pt>
+                <c:pt idx="2">
+                  <c:v>0.5</c:v>
+                </c:pt>
+                <c:pt idx="3">
+                  <c:v>0.5</c:v>
+                </c:pt>
+                <c:pt idx="4">
+                  <c:v>0.5</c:v>
+                </c:pt>
+                <c:pt idx="5">
+                  <c:v>0.5</c:v>
+                </c:pt>
+                <c:pt idx="6">
+                  <c:v>0.5</c:v>
+                </c:pt>
+                <c:pt idx="7">
+                  <c:v>0.5</c:v>
+                </c:pt>
+                <c:pt idx="8">
+                  <c:v>0.5</c:v>
+                </c:pt>
+                <c:pt idx="9">
+                  <c:v>0.5</c:v>
+                </c:pt>
+                <c:pt idx="10">
+                  <c:v>0.5</c:v>
+                </c:pt>
+                <c:pt idx="11">
+                  <c:v>0.5</c:v>
+                </c:pt>
+              </c:numCache>
+            </c:numRef>
+          </c:val>
+          <c:extLst>
+            <c:ext xmlns:c16="http://schemas.microsoft.com/office/drawing/2014/chart" uri="{C3380CC4-5D6E-409C-BE32-E72D297353CC}">
+              <c16:uniqueId val="{00000003-6147-E74A-AA7B-5531F0E4EE0C}"/>
+            </c:ext>
+          </c:extLst>
+        </c:ser>
+        <c:ser>
+          <c:idx val="2"/>
+          <c:order val="2"/>
+          <c:tx>
+            <c:strRef>
+              <c:f>Sheet1!$D$1</c:f>
+              <c:strCache>
+                <c:ptCount val="1"/>
+                <c:pt idx="0">
+                  <c:v>Unchanged</c:v>
+                </c:pt>
+              </c:strCache>
+            </c:strRef>
+          </c:tx>
+          <c:spPr>
+            <a:solidFill>
+              <a:srgbClr val="BFC4CF"/>
+            </a:solidFill>
+            <a:ln w="19050">
+              <a:noFill/>
+            </a:ln>
+            <a:effectLst/>
+          </c:spPr>
+          <c:invertIfNegative val="0"/>
+          <c:cat>
+            <c:strRef>
+              <c:f>Sheet1!$A$2:$A$13</c:f>
+              <c:strCache>
+                <c:ptCount val="12"/>
+                <c:pt idx="0">
+                  <c:v>Month 1</c:v>
+                </c:pt>
+                <c:pt idx="1">
+                  <c:v>Month 2</c:v>
+                </c:pt>
+                <c:pt idx="2">
+                  <c:v>Month 3</c:v>
+                </c:pt>
+                <c:pt idx="3">
+                  <c:v>Month 4</c:v>
+                </c:pt>
+                <c:pt idx="4">
+                  <c:v>Month 5</c:v>
+                </c:pt>
+                <c:pt idx="5">
+                  <c:v>Month 6</c:v>
+                </c:pt>
+                <c:pt idx="6">
+                  <c:v>Month 7</c:v>
+                </c:pt>
+                <c:pt idx="7">
+                  <c:v>Month 8</c:v>
+                </c:pt>
+                <c:pt idx="8">
+                  <c:v>Month 9</c:v>
+                </c:pt>
+                <c:pt idx="9">
+                  <c:v>Month 10</c:v>
+                </c:pt>
+                <c:pt idx="10">
+                  <c:v>Month 11</c:v>
+                </c:pt>
+                <c:pt idx="11">
+                  <c:v>Month 12</c:v>
+                </c:pt>
+              </c:strCache>
+            </c:strRef>
+          </c:cat>
+          <c:val>
+            <c:numRef>
+              <c:f>Sheet1!$D$2:$D$13</c:f>
+              <c:numCache>
+                <c:formatCode>General</c:formatCode>
+                <c:ptCount val="12"/>
+                <c:pt idx="0">
+                  <c:v>0.5</c:v>
+                </c:pt>
+                <c:pt idx="1">
+                  <c:v>0.5</c:v>
+                </c:pt>
+                <c:pt idx="2">
+                  <c:v>0.5</c:v>
+                </c:pt>
+                <c:pt idx="3">
+                  <c:v>0.5</c:v>
+                </c:pt>
+                <c:pt idx="4">
+                  <c:v>0.5</c:v>
+                </c:pt>
+                <c:pt idx="5">
+                  <c:v>0.5</c:v>
+                </c:pt>
+                <c:pt idx="6">
+                  <c:v>0.5</c:v>
+                </c:pt>
+                <c:pt idx="7">
+                  <c:v>0.5</c:v>
+                </c:pt>
+                <c:pt idx="8">
+                  <c:v>0.5</c:v>
+                </c:pt>
+                <c:pt idx="9">
+                  <c:v>0.5</c:v>
+                </c:pt>
+                <c:pt idx="10">
+                  <c:v>0.5</c:v>
+                </c:pt>
+                <c:pt idx="11">
+                  <c:v>0.5</c:v>
+                </c:pt>
+              </c:numCache>
+            </c:numRef>
+          </c:val>
+          <c:extLst>
+            <c:ext xmlns:c16="http://schemas.microsoft.com/office/drawing/2014/chart" uri="{C3380CC4-5D6E-409C-BE32-E72D297353CC}">
+              <c16:uniqueId val="{00000004-6147-E74A-AA7B-5531F0E4EE0C}"/>
+            </c:ext>
+          </c:extLst>
+        </c:ser>
+        <c:ser>
+          <c:idx val="3"/>
+          <c:order val="3"/>
+          <c:tx>
+            <c:strRef>
+              <c:f>Sheet1!$E$1</c:f>
+              <c:strCache>
+                <c:ptCount val="1"/>
+                <c:pt idx="0">
+                  <c:v>Worsened</c:v>
+                </c:pt>
+              </c:strCache>
+            </c:strRef>
+          </c:tx>
+          <c:spPr>
+            <a:solidFill>
+              <a:srgbClr val="F06241"/>
+            </a:solidFill>
+            <a:ln w="19050">
+              <a:noFill/>
+            </a:ln>
+            <a:effectLst/>
+          </c:spPr>
+          <c:invertIfNegative val="0"/>
+          <c:cat>
+            <c:strRef>
+              <c:f>Sheet1!$A$2:$A$13</c:f>
+              <c:strCache>
+                <c:ptCount val="12"/>
+                <c:pt idx="0">
+                  <c:v>Month 1</c:v>
+                </c:pt>
+                <c:pt idx="1">
+                  <c:v>Month 2</c:v>
+                </c:pt>
+                <c:pt idx="2">
+                  <c:v>Month 3</c:v>
+                </c:pt>
+                <c:pt idx="3">
+                  <c:v>Month 4</c:v>
+                </c:pt>
+                <c:pt idx="4">
+                  <c:v>Month 5</c:v>
+                </c:pt>
+                <c:pt idx="5">
+                  <c:v>Month 6</c:v>
+                </c:pt>
+                <c:pt idx="6">
+                  <c:v>Month 7</c:v>
+                </c:pt>
+                <c:pt idx="7">
+                  <c:v>Month 8</c:v>
+                </c:pt>
+                <c:pt idx="8">
+                  <c:v>Month 9</c:v>
+                </c:pt>
+                <c:pt idx="9">
+                  <c:v>Month 10</c:v>
+                </c:pt>
+                <c:pt idx="10">
+                  <c:v>Month 11</c:v>
+                </c:pt>
+                <c:pt idx="11">
+                  <c:v>Month 12</c:v>
+                </c:pt>
+              </c:strCache>
+            </c:strRef>
+          </c:cat>
+          <c:val>
+            <c:numRef>
+              <c:f>Sheet1!$E$2:$E$13</c:f>
+              <c:numCache>
+                <c:formatCode>General</c:formatCode>
+                <c:ptCount val="12"/>
+                <c:pt idx="0">
+                  <c:v>0.5</c:v>
+                </c:pt>
+                <c:pt idx="1">
+                  <c:v>0.5</c:v>
+                </c:pt>
+                <c:pt idx="2">
+                  <c:v>0.5</c:v>
+                </c:pt>
+                <c:pt idx="3">
+                  <c:v>0.5</c:v>
+                </c:pt>
+                <c:pt idx="4">
+                  <c:v>0.5</c:v>
+                </c:pt>
+                <c:pt idx="5">
+                  <c:v>0.5</c:v>
+                </c:pt>
+                <c:pt idx="6">
+                  <c:v>0.5</c:v>
+                </c:pt>
+                <c:pt idx="7">
+                  <c:v>0.5</c:v>
+                </c:pt>
+                <c:pt idx="8">
+                  <c:v>0.5</c:v>
+                </c:pt>
+                <c:pt idx="9">
+                  <c:v>0.5</c:v>
+                </c:pt>
+                <c:pt idx="10">
+                  <c:v>0.5</c:v>
+                </c:pt>
+                <c:pt idx="11">
+                  <c:v>0.5</c:v>
+                </c:pt>
+              </c:numCache>
+            </c:numRef>
+          </c:val>
+          <c:extLst>
+            <c:ext xmlns:c16="http://schemas.microsoft.com/office/drawing/2014/chart" uri="{C3380CC4-5D6E-409C-BE32-E72D297353CC}">
+              <c16:uniqueId val="{00000005-6147-E74A-AA7B-5531F0E4EE0C}"/>
+            </c:ext>
+          </c:extLst>
+        </c:ser>
+        <c:ser>
+          <c:idx val="4"/>
+          <c:order val="4"/>
+          <c:tx>
+            <c:strRef>
+              <c:f>Sheet1!$F$1</c:f>
+              <c:strCache>
+                <c:ptCount val="1"/>
+                <c:pt idx="0">
+                  <c:v>Unknown</c:v>
+                </c:pt>
+              </c:strCache>
+            </c:strRef>
+          </c:tx>
+          <c:spPr>
+            <a:solidFill>
+              <a:schemeClr val="bg1"/>
+            </a:solidFill>
+            <a:ln w="19050">
+              <a:solidFill>
+                <a:schemeClr val="lt1"/>
+              </a:solidFill>
+            </a:ln>
+            <a:effectLst/>
+          </c:spPr>
+          <c:invertIfNegative val="0"/>
+          <c:cat>
+            <c:strRef>
+              <c:f>Sheet1!$A$2:$A$13</c:f>
+              <c:strCache>
+                <c:ptCount val="12"/>
+                <c:pt idx="0">
+                  <c:v>Month 1</c:v>
+                </c:pt>
+                <c:pt idx="1">
+                  <c:v>Month 2</c:v>
+                </c:pt>
+                <c:pt idx="2">
+                  <c:v>Month 3</c:v>
+                </c:pt>
+                <c:pt idx="3">
+                  <c:v>Month 4</c:v>
+                </c:pt>
+                <c:pt idx="4">
+                  <c:v>Month 5</c:v>
+                </c:pt>
+                <c:pt idx="5">
+                  <c:v>Month 6</c:v>
+                </c:pt>
+                <c:pt idx="6">
+                  <c:v>Month 7</c:v>
+                </c:pt>
+                <c:pt idx="7">
+                  <c:v>Month 8</c:v>
+                </c:pt>
+                <c:pt idx="8">
+                  <c:v>Month 9</c:v>
+                </c:pt>
+                <c:pt idx="9">
+                  <c:v>Month 10</c:v>
+                </c:pt>
+                <c:pt idx="10">
+                  <c:v>Month 11</c:v>
+                </c:pt>
+                <c:pt idx="11">
+                  <c:v>Month 12</c:v>
+                </c:pt>
+              </c:strCache>
+            </c:strRef>
+          </c:cat>
+          <c:val>
+            <c:numRef>
+              <c:f>Sheet1!$F$2:$F$13</c:f>
+              <c:numCache>
+                <c:formatCode>General</c:formatCode>
+                <c:ptCount val="12"/>
+                <c:pt idx="0">
+                  <c:v>0.5</c:v>
+                </c:pt>
+                <c:pt idx="1">
+                  <c:v>0.5</c:v>
+                </c:pt>
+                <c:pt idx="2">
+                  <c:v>0.5</c:v>
+                </c:pt>
+                <c:pt idx="3">
+                  <c:v>0.5</c:v>
+                </c:pt>
+                <c:pt idx="4">
+                  <c:v>0.5</c:v>
+                </c:pt>
+                <c:pt idx="5">
+                  <c:v>0.5</c:v>
+                </c:pt>
+                <c:pt idx="6">
+                  <c:v>0.5</c:v>
+                </c:pt>
+                <c:pt idx="7">
+                  <c:v>0.5</c:v>
+                </c:pt>
+                <c:pt idx="8">
+                  <c:v>0.5</c:v>
+                </c:pt>
+                <c:pt idx="9">
+                  <c:v>0.5</c:v>
+                </c:pt>
+                <c:pt idx="10">
+                  <c:v>0.5</c:v>
+                </c:pt>
+                <c:pt idx="11">
+                  <c:v>0.5</c:v>
+                </c:pt>
+              </c:numCache>
+            </c:numRef>
+          </c:val>
+          <c:extLst>
+            <c:ext xmlns:c16="http://schemas.microsoft.com/office/drawing/2014/chart" uri="{C3380CC4-5D6E-409C-BE32-E72D297353CC}">
+              <c16:uniqueId val="{00000006-6147-E74A-AA7B-5531F0E4EE0C}"/>
+            </c:ext>
+          </c:extLst>
+        </c:ser>
+        <c:dLbls>
+          <c:showLegendKey val="0"/>
+          <c:showVal val="0"/>
+          <c:showCatName val="0"/>
+          <c:showSerName val="0"/>
+          <c:showPercent val="0"/>
+          <c:showBubbleSize val="0"/>
+        </c:dLbls>
+        <c:gapWidth val="20"/>
+        <c:overlap val="100"/>
+        <c:axId val="476387520"/>
+        <c:axId val="477616192"/>
+      </c:barChart>
+      <c:catAx>
+        <c:axId val="476387520"/>
+        <c:scaling>
+          <c:orientation val="minMax"/>
+        </c:scaling>
+        <c:delete val="0"/>
+        <c:axPos val="b"/>
+        <c:numFmt formatCode="General" sourceLinked="1"/>
+        <c:majorTickMark val="out"/>
+        <c:minorTickMark val="none"/>
+        <c:tickLblPos val="nextTo"/>
+        <c:spPr>
+          <a:noFill/>
+          <a:ln w="9525" cap="flat" cmpd="sng" algn="ctr">
+            <a:solidFill>
+              <a:schemeClr val="tx1">
+                <a:lumMod val="15000"/>
+                <a:lumOff val="85000"/>
+              </a:schemeClr>
+            </a:solidFill>
+            <a:round/>
+          </a:ln>
+          <a:effectLst/>
+        </c:spPr>
+        <c:txPr>
+          <a:bodyPr rot="-60000000" spcFirstLastPara="1" vertOverflow="ellipsis" vert="horz" wrap="square" anchor="ctr" anchorCtr="1"/>
+          <a:lstStyle/>
+          <a:p>
+            <a:pPr>
+              <a:defRPr sz="1400" b="0" i="0" u="none" strike="noStrike" kern="1200" baseline="0">
+                <a:solidFill>
+                  <a:schemeClr val="tx2"/>
+                </a:solidFill>
+                <a:latin typeface="+mn-lt"/>
+                <a:ea typeface="+mn-ea"/>
+                <a:cs typeface="+mn-cs"/>
+              </a:defRPr>
+            </a:pPr>
+            <a:endParaRPr lang="en-NL"/>
+          </a:p>
+        </c:txPr>
+        <c:crossAx val="477616192"/>
+        <c:crosses val="autoZero"/>
+        <c:auto val="1"/>
+        <c:lblAlgn val="ctr"/>
+        <c:lblOffset val="100"/>
+        <c:noMultiLvlLbl val="0"/>
+      </c:catAx>
+      <c:valAx>
+        <c:axId val="477616192"/>
+        <c:scaling>
+          <c:orientation val="minMax"/>
+        </c:scaling>
+        <c:delete val="0"/>
+        <c:axPos val="l"/>
+        <c:majorGridlines>
+          <c:spPr>
+            <a:ln w="9525" cap="flat" cmpd="sng" algn="ctr">
+              <a:solidFill>
+                <a:schemeClr val="tx1">
+                  <a:lumMod val="15000"/>
+                  <a:lumOff val="85000"/>
+                </a:schemeClr>
+              </a:solidFill>
+              <a:round/>
+            </a:ln>
+            <a:effectLst/>
+          </c:spPr>
+        </c:majorGridlines>
+        <c:numFmt formatCode="0%" sourceLinked="0"/>
+        <c:majorTickMark val="out"/>
+        <c:minorTickMark val="none"/>
+        <c:tickLblPos val="nextTo"/>
+        <c:spPr>
+          <a:noFill/>
+          <a:ln>
+            <a:noFill/>
+          </a:ln>
+          <a:effectLst/>
+        </c:spPr>
+        <c:txPr>
+          <a:bodyPr rot="-60000000" spcFirstLastPara="1" vertOverflow="ellipsis" vert="horz" wrap="square" anchor="ctr" anchorCtr="1"/>
+          <a:lstStyle/>
+          <a:p>
+            <a:pPr>
+              <a:defRPr sz="1197" b="0" i="0" u="none" strike="noStrike" kern="1200" baseline="0">
+                <a:solidFill>
+                  <a:schemeClr val="tx2"/>
+                </a:solidFill>
+                <a:latin typeface="+mn-lt"/>
+                <a:ea typeface="+mn-ea"/>
+                <a:cs typeface="+mn-cs"/>
+              </a:defRPr>
+            </a:pPr>
+            <a:endParaRPr lang="en-US"/>
+          </a:p>
+        </c:txPr>
+        <c:crossAx val="476387520"/>
+        <c:crosses val="autoZero"/>
+        <c:crossBetween val="between"/>
+      </c:valAx>
+      <c:spPr>
+        <a:solidFill>
+          <a:srgbClr val="F0F4F8"/>
+        </a:solidFill>
+        <a:ln>
+          <a:noFill/>
+        </a:ln>
+        <a:effectLst/>
+      </c:spPr>
+    </c:plotArea>
+    <c:plotVisOnly val="1"/>
+    <c:dispBlanksAs val="gap"/>
+    <c:showDLblsOverMax val="0"/>
+    <c:extLst xmlns:lc="http://schemas.openxmlformats.org/drawingml/2006/lockedCanvas" xmlns:comp="http://schemas.openxmlformats.org/drawingml/2006/compatibility" xmlns:we="http://schemas.microsoft.com/office/webextensions/webextension/2010/11" xmlns:wetp="http://schemas.microsoft.com/office/webextensions/taskpanes/2010/11" xmlns:w16cid="http://schemas.microsoft.com/office/word/2016/wordml/cid" xmlns:w16se="http://schemas.microsoft.com/office/word/2015/wordml/symex" xmlns:wps="http://schemas.microsoft.com/office/word/2010/wordprocessingShape" xmlns:b="http://schemas.openxmlformats.org/officeDocument/2006/bibliography" xmlns:odgm="http://opendope.org/SmartArt/DataHierarchy" xmlns:odi="http://opendope.org/components" xmlns:oda="http://opendope.org/answers" xmlns:odq="http://opendope.org/questions" xmlns:odc="http://opendope.org/conditions" xmlns:odx="http://opendope.org/xpaths" xmlns:cppr="http://schemas.microsoft.com/office/2006/coverPageProps" xmlns:pvml="urn:schemas-microsoft-com:office:powerpoint" xmlns:w10="urn:schemas-microsoft-com:office:word" xmlns:v="urn:schemas-microsoft-com:vml" xmlns:o="urn:schemas-microsoft-com:office:office" xmlns:xvml="urn:schemas-microsoft-com:office:excel" xmlns:dsp="http://schemas.microsoft.com/office/drawing/2008/diagram" xmlns:xdr="http://schemas.openxmlformats.org/drawingml/2006/spreadsheetDrawing" xmlns:pic="http://schemas.openxmlformats.org/drawingml/2006/picture" xmlns:dgm="http://schemas.openxmlformats.org/drawingml/2006/diagram" xmlns:c14="http://schemas.microsoft.com/office/drawing/2007/8/2/chart" xmlns:cdr="http://schemas.openxmlformats.org/drawingml/2006/chartDrawing" xmlns:wne="http://schemas.microsoft.com/office/word/2006/wordml" xmlns:sl="http://schemas.openxmlformats.org/schemaLibrary/2006/main" xmlns:mc="http://schemas.openxmlformats.org/markup-compatibility/2006" xmlns:wp14="http://schemas.microsoft.com/office/word/2010/wordprocessingDrawing" xmlns:wp="http://schemas.openxmlformats.org/drawingml/2006/wordprocessingDrawing" xmlns:m="http://schemas.openxmlformats.org/officeDocument/2006/math" xmlns:w14="http://schemas.microsoft.com/office/word/2010/wordml" xmlns:w15="http://schemas.microsoft.com/office/word/2012/wordml" xmlns:w="http://schemas.openxmlformats.org/wordprocessingml/2006/main">
+      <c:ext xmlns:c16r3="http://schemas.microsoft.com/office/drawing/2017/03/chart" uri="{56B9EC1D-385E-4148-901F-78D8002777C0}">
+        <c16r3:dataDisplayOptions16>
+          <c16r3:dispNaAsBlank val="1"/>
+        </c16r3:dataDisplayOptions16>
+      </c:ext>
+    </c:extLst>
+  </c:chart>
+  <c:spPr>
+    <a:noFill/>
+    <a:ln>
+      <a:noFill/>
+    </a:ln>
+    <a:effectLst/>
+  </c:spPr>
+  <c:txPr>
+    <a:bodyPr/>
+    <a:lstStyle/>
+    <a:p>
+      <a:pPr>
+        <a:defRPr/>
+      </a:pPr>
+      <a:endParaRPr lang="en-NL"/>
+    </a:p>
+  </c:txPr>
+  <c:externalData r:id="rId3">
+    <c:autoUpdate val="0"/>
+  </c:externalData>
+</c:chartSpace>
+</file>
+
+<file path=ppt/charts/chart13.xml><?xml version="1.0" encoding="utf-8"?>
 <c:chartSpace xmlns:c="http://schemas.openxmlformats.org/drawingml/2006/chart" xmlns:a="http://schemas.openxmlformats.org/drawingml/2006/main" xmlns:r="http://schemas.openxmlformats.org/officeDocument/2006/relationships" xmlns:c16r2="http://schemas.microsoft.com/office/drawing/2015/06/chart">
   <c:date1904 val="0"/>
   <c:lang val="en-US"/>
@@ -2386,7 +4002,7 @@
 </c:chartSpace>
 </file>
 
-<file path=ppt/charts/chart12.xml><?xml version="1.0" encoding="utf-8"?>
+<file path=ppt/charts/chart14.xml><?xml version="1.0" encoding="utf-8"?>
 <c:chartSpace xmlns:c="http://schemas.openxmlformats.org/drawingml/2006/chart" xmlns:a="http://schemas.openxmlformats.org/drawingml/2006/main" xmlns:r="http://schemas.openxmlformats.org/officeDocument/2006/relationships" xmlns:c16r2="http://schemas.microsoft.com/office/drawing/2015/06/chart">
   <c:date1904 val="0"/>
   <c:lang val="en-US"/>
@@ -3194,7 +4810,7 @@
 </c:chartSpace>
 </file>
 
-<file path=ppt/charts/chart13.xml><?xml version="1.0" encoding="utf-8"?>
+<file path=ppt/charts/chart15.xml><?xml version="1.0" encoding="utf-8"?>
 <c:chartSpace xmlns:c="http://schemas.openxmlformats.org/drawingml/2006/chart" xmlns:a="http://schemas.openxmlformats.org/drawingml/2006/main" xmlns:r="http://schemas.openxmlformats.org/officeDocument/2006/relationships" xmlns:c16r2="http://schemas.microsoft.com/office/drawing/2015/06/chart">
   <c:date1904 val="0"/>
   <c:lang val="en-US"/>
@@ -3265,7 +4881,7 @@
                 </a:outerShdw>
               </a:effectLst>
             </c:spPr>
-            <c:extLst xmlns:lc="http://schemas.openxmlformats.org/drawingml/2006/lockedCanvas" xmlns:comp="http://schemas.openxmlformats.org/drawingml/2006/compatibility" xmlns:we="http://schemas.microsoft.com/office/webextensions/webextension/2010/11" xmlns:wetp="http://schemas.microsoft.com/office/webextensions/taskpanes/2010/11" xmlns:w16cid="http://schemas.microsoft.com/office/word/2016/wordml/cid" xmlns:w16se="http://schemas.microsoft.com/office/word/2015/wordml/symex" xmlns:wps="http://schemas.microsoft.com/office/word/2010/wordprocessingShape" xmlns:b="http://schemas.openxmlformats.org/officeDocument/2006/bibliography" xmlns:odgm="http://opendope.org/SmartArt/DataHierarchy" xmlns:odi="http://opendope.org/components" xmlns:oda="http://opendope.org/answers" xmlns:odq="http://opendope.org/questions" xmlns:odc="http://opendope.org/conditions" xmlns:odx="http://opendope.org/xpaths" xmlns:cppr="http://schemas.microsoft.com/office/2006/coverPageProps" xmlns:pvml="urn:schemas-microsoft-com:office:powerpoint" xmlns:w10="urn:schemas-microsoft-com:office:word" xmlns:v="urn:schemas-microsoft-com:vml" xmlns:o="urn:schemas-microsoft-com:office:office" xmlns:xvml="urn:schemas-microsoft-com:office:excel" xmlns:dsp="http://schemas.microsoft.com/office/drawing/2008/diagram" xmlns:xdr="http://schemas.openxmlformats.org/drawingml/2006/spreadsheetDrawing" xmlns:pic="http://schemas.openxmlformats.org/drawingml/2006/picture" xmlns:dgm="http://schemas.openxmlformats.org/drawingml/2006/diagram" xmlns:c14="http://schemas.microsoft.com/office/drawing/2007/8/2/chart" xmlns:cdr="http://schemas.openxmlformats.org/drawingml/2006/chartDrawing" xmlns:wne="http://schemas.microsoft.com/office/word/2006/wordml" xmlns:sl="http://schemas.openxmlformats.org/schemaLibrary/2006/main" xmlns:mc="http://schemas.openxmlformats.org/markup-compatibility/2006" xmlns:wp14="http://schemas.microsoft.com/office/word/2010/wordprocessingDrawing" xmlns:wp="http://schemas.openxmlformats.org/drawingml/2006/wordprocessingDrawing" xmlns:m="http://schemas.openxmlformats.org/officeDocument/2006/math" xmlns:w14="http://schemas.microsoft.com/office/word/2010/wordml" xmlns:w15="http://schemas.microsoft.com/office/word/2012/wordml" xmlns:w="http://schemas.openxmlformats.org/wordprocessingml/2006/main">
+            <c:extLst xmlns:w="http://schemas.openxmlformats.org/wordprocessingml/2006/main" xmlns:w15="http://schemas.microsoft.com/office/word/2012/wordml" xmlns:w14="http://schemas.microsoft.com/office/word/2010/wordml" xmlns:m="http://schemas.openxmlformats.org/officeDocument/2006/math" xmlns:wp="http://schemas.openxmlformats.org/drawingml/2006/wordprocessingDrawing" xmlns:wp14="http://schemas.microsoft.com/office/word/2010/wordprocessingDrawing" xmlns:mc="http://schemas.openxmlformats.org/markup-compatibility/2006" xmlns:sl="http://schemas.openxmlformats.org/schemaLibrary/2006/main" xmlns:wne="http://schemas.microsoft.com/office/word/2006/wordml" xmlns:cdr="http://schemas.openxmlformats.org/drawingml/2006/chartDrawing" xmlns:c14="http://schemas.microsoft.com/office/drawing/2007/8/2/chart" xmlns:dgm="http://schemas.openxmlformats.org/drawingml/2006/diagram" xmlns:pic="http://schemas.openxmlformats.org/drawingml/2006/picture" xmlns:xdr="http://schemas.openxmlformats.org/drawingml/2006/spreadsheetDrawing" xmlns:dsp="http://schemas.microsoft.com/office/drawing/2008/diagram" xmlns:xvml="urn:schemas-microsoft-com:office:excel" xmlns:o="urn:schemas-microsoft-com:office:office" xmlns:v="urn:schemas-microsoft-com:vml" xmlns:w10="urn:schemas-microsoft-com:office:word" xmlns:pvml="urn:schemas-microsoft-com:office:powerpoint" xmlns:cppr="http://schemas.microsoft.com/office/2006/coverPageProps" xmlns:odx="http://opendope.org/xpaths" xmlns:odc="http://opendope.org/conditions" xmlns:odq="http://opendope.org/questions" xmlns:oda="http://opendope.org/answers" xmlns:odi="http://opendope.org/components" xmlns:odgm="http://opendope.org/SmartArt/DataHierarchy" xmlns:b="http://schemas.openxmlformats.org/officeDocument/2006/bibliography" xmlns:wps="http://schemas.microsoft.com/office/word/2010/wordprocessingShape" xmlns:w16se="http://schemas.microsoft.com/office/word/2015/wordml/symex" xmlns:w16cid="http://schemas.microsoft.com/office/word/2016/wordml/cid" xmlns:wetp="http://schemas.microsoft.com/office/webextensions/taskpanes/2010/11" xmlns:we="http://schemas.microsoft.com/office/webextensions/webextension/2010/11" xmlns:comp="http://schemas.openxmlformats.org/drawingml/2006/compatibility" xmlns:lc="http://schemas.openxmlformats.org/drawingml/2006/lockedCanvas">
               <c:ext xmlns:c16="http://schemas.microsoft.com/office/drawing/2014/chart" uri="{C3380CC4-5D6E-409C-BE32-E72D297353CC}">
                 <c16:uniqueId val="{00000001-6147-E74A-AA7B-5531F0E4EE0C}"/>
               </c:ext>
@@ -3360,7 +4976,7 @@
               </c:numCache>
             </c:numRef>
           </c:val>
-          <c:extLst xmlns:lc="http://schemas.openxmlformats.org/drawingml/2006/lockedCanvas" xmlns:comp="http://schemas.openxmlformats.org/drawingml/2006/compatibility" xmlns:we="http://schemas.microsoft.com/office/webextensions/webextension/2010/11" xmlns:wetp="http://schemas.microsoft.com/office/webextensions/taskpanes/2010/11" xmlns:w16cid="http://schemas.microsoft.com/office/word/2016/wordml/cid" xmlns:w16se="http://schemas.microsoft.com/office/word/2015/wordml/symex" xmlns:wps="http://schemas.microsoft.com/office/word/2010/wordprocessingShape" xmlns:b="http://schemas.openxmlformats.org/officeDocument/2006/bibliography" xmlns:odgm="http://opendope.org/SmartArt/DataHierarchy" xmlns:odi="http://opendope.org/components" xmlns:oda="http://opendope.org/answers" xmlns:odq="http://opendope.org/questions" xmlns:odc="http://opendope.org/conditions" xmlns:odx="http://opendope.org/xpaths" xmlns:cppr="http://schemas.microsoft.com/office/2006/coverPageProps" xmlns:pvml="urn:schemas-microsoft-com:office:powerpoint" xmlns:w10="urn:schemas-microsoft-com:office:word" xmlns:v="urn:schemas-microsoft-com:vml" xmlns:o="urn:schemas-microsoft-com:office:office" xmlns:xvml="urn:schemas-microsoft-com:office:excel" xmlns:dsp="http://schemas.microsoft.com/office/drawing/2008/diagram" xmlns:xdr="http://schemas.openxmlformats.org/drawingml/2006/spreadsheetDrawing" xmlns:pic="http://schemas.openxmlformats.org/drawingml/2006/picture" xmlns:dgm="http://schemas.openxmlformats.org/drawingml/2006/diagram" xmlns:c14="http://schemas.microsoft.com/office/drawing/2007/8/2/chart" xmlns:cdr="http://schemas.openxmlformats.org/drawingml/2006/chartDrawing" xmlns:wne="http://schemas.microsoft.com/office/word/2006/wordml" xmlns:sl="http://schemas.openxmlformats.org/schemaLibrary/2006/main" xmlns:mc="http://schemas.openxmlformats.org/markup-compatibility/2006" xmlns:wp14="http://schemas.microsoft.com/office/word/2010/wordprocessingDrawing" xmlns:wp="http://schemas.openxmlformats.org/drawingml/2006/wordprocessingDrawing" xmlns:m="http://schemas.openxmlformats.org/officeDocument/2006/math" xmlns:w14="http://schemas.microsoft.com/office/word/2010/wordml" xmlns:w15="http://schemas.microsoft.com/office/word/2012/wordml" xmlns:w="http://schemas.openxmlformats.org/wordprocessingml/2006/main">
+          <c:extLst xmlns:w="http://schemas.openxmlformats.org/wordprocessingml/2006/main" xmlns:w15="http://schemas.microsoft.com/office/word/2012/wordml" xmlns:w14="http://schemas.microsoft.com/office/word/2010/wordml" xmlns:m="http://schemas.openxmlformats.org/officeDocument/2006/math" xmlns:wp="http://schemas.openxmlformats.org/drawingml/2006/wordprocessingDrawing" xmlns:wp14="http://schemas.microsoft.com/office/word/2010/wordprocessingDrawing" xmlns:mc="http://schemas.openxmlformats.org/markup-compatibility/2006" xmlns:sl="http://schemas.openxmlformats.org/schemaLibrary/2006/main" xmlns:wne="http://schemas.microsoft.com/office/word/2006/wordml" xmlns:cdr="http://schemas.openxmlformats.org/drawingml/2006/chartDrawing" xmlns:c14="http://schemas.microsoft.com/office/drawing/2007/8/2/chart" xmlns:dgm="http://schemas.openxmlformats.org/drawingml/2006/diagram" xmlns:pic="http://schemas.openxmlformats.org/drawingml/2006/picture" xmlns:xdr="http://schemas.openxmlformats.org/drawingml/2006/spreadsheetDrawing" xmlns:dsp="http://schemas.microsoft.com/office/drawing/2008/diagram" xmlns:xvml="urn:schemas-microsoft-com:office:excel" xmlns:o="urn:schemas-microsoft-com:office:office" xmlns:v="urn:schemas-microsoft-com:vml" xmlns:w10="urn:schemas-microsoft-com:office:word" xmlns:pvml="urn:schemas-microsoft-com:office:powerpoint" xmlns:cppr="http://schemas.microsoft.com/office/2006/coverPageProps" xmlns:odx="http://opendope.org/xpaths" xmlns:odc="http://opendope.org/conditions" xmlns:odq="http://opendope.org/questions" xmlns:oda="http://opendope.org/answers" xmlns:odi="http://opendope.org/components" xmlns:odgm="http://opendope.org/SmartArt/DataHierarchy" xmlns:b="http://schemas.openxmlformats.org/officeDocument/2006/bibliography" xmlns:wps="http://schemas.microsoft.com/office/word/2010/wordprocessingShape" xmlns:w16se="http://schemas.microsoft.com/office/word/2015/wordml/symex" xmlns:w16cid="http://schemas.microsoft.com/office/word/2016/wordml/cid" xmlns:wetp="http://schemas.microsoft.com/office/webextensions/taskpanes/2010/11" xmlns:we="http://schemas.microsoft.com/office/webextensions/webextension/2010/11" xmlns:comp="http://schemas.openxmlformats.org/drawingml/2006/compatibility" xmlns:lc="http://schemas.openxmlformats.org/drawingml/2006/lockedCanvas">
             <c:ext xmlns:c16="http://schemas.microsoft.com/office/drawing/2014/chart" uri="{C3380CC4-5D6E-409C-BE32-E72D297353CC}">
               <c16:uniqueId val="{00000002-6147-E74A-AA7B-5531F0E4EE0C}"/>
             </c:ext>
@@ -3971,1623 +5587,7 @@
     <c:plotVisOnly val="1"/>
     <c:dispBlanksAs val="gap"/>
     <c:showDLblsOverMax val="0"/>
-    <c:extLst xmlns:lc="http://schemas.openxmlformats.org/drawingml/2006/lockedCanvas" xmlns:comp="http://schemas.openxmlformats.org/drawingml/2006/compatibility" xmlns:we="http://schemas.microsoft.com/office/webextensions/webextension/2010/11" xmlns:wetp="http://schemas.microsoft.com/office/webextensions/taskpanes/2010/11" xmlns:w16cid="http://schemas.microsoft.com/office/word/2016/wordml/cid" xmlns:w16se="http://schemas.microsoft.com/office/word/2015/wordml/symex" xmlns:wps="http://schemas.microsoft.com/office/word/2010/wordprocessingShape" xmlns:b="http://schemas.openxmlformats.org/officeDocument/2006/bibliography" xmlns:odgm="http://opendope.org/SmartArt/DataHierarchy" xmlns:odi="http://opendope.org/components" xmlns:oda="http://opendope.org/answers" xmlns:odq="http://opendope.org/questions" xmlns:odc="http://opendope.org/conditions" xmlns:odx="http://opendope.org/xpaths" xmlns:cppr="http://schemas.microsoft.com/office/2006/coverPageProps" xmlns:pvml="urn:schemas-microsoft-com:office:powerpoint" xmlns:w10="urn:schemas-microsoft-com:office:word" xmlns:v="urn:schemas-microsoft-com:vml" xmlns:o="urn:schemas-microsoft-com:office:office" xmlns:xvml="urn:schemas-microsoft-com:office:excel" xmlns:dsp="http://schemas.microsoft.com/office/drawing/2008/diagram" xmlns:xdr="http://schemas.openxmlformats.org/drawingml/2006/spreadsheetDrawing" xmlns:pic="http://schemas.openxmlformats.org/drawingml/2006/picture" xmlns:dgm="http://schemas.openxmlformats.org/drawingml/2006/diagram" xmlns:c14="http://schemas.microsoft.com/office/drawing/2007/8/2/chart" xmlns:cdr="http://schemas.openxmlformats.org/drawingml/2006/chartDrawing" xmlns:wne="http://schemas.microsoft.com/office/word/2006/wordml" xmlns:sl="http://schemas.openxmlformats.org/schemaLibrary/2006/main" xmlns:mc="http://schemas.openxmlformats.org/markup-compatibility/2006" xmlns:wp14="http://schemas.microsoft.com/office/word/2010/wordprocessingDrawing" xmlns:wp="http://schemas.openxmlformats.org/drawingml/2006/wordprocessingDrawing" xmlns:m="http://schemas.openxmlformats.org/officeDocument/2006/math" xmlns:w14="http://schemas.microsoft.com/office/word/2010/wordml" xmlns:w15="http://schemas.microsoft.com/office/word/2012/wordml" xmlns:w="http://schemas.openxmlformats.org/wordprocessingml/2006/main">
-      <c:ext xmlns:c16r3="http://schemas.microsoft.com/office/drawing/2017/03/chart" uri="{56B9EC1D-385E-4148-901F-78D8002777C0}">
-        <c16r3:dataDisplayOptions16>
-          <c16r3:dispNaAsBlank val="1"/>
-        </c16r3:dataDisplayOptions16>
-      </c:ext>
-    </c:extLst>
-  </c:chart>
-  <c:spPr>
-    <a:noFill/>
-    <a:ln>
-      <a:noFill/>
-    </a:ln>
-    <a:effectLst/>
-  </c:spPr>
-  <c:txPr>
-    <a:bodyPr/>
-    <a:lstStyle/>
-    <a:p>
-      <a:pPr>
-        <a:defRPr/>
-      </a:pPr>
-      <a:endParaRPr lang="en-NL"/>
-    </a:p>
-  </c:txPr>
-  <c:externalData r:id="rId3">
-    <c:autoUpdate val="0"/>
-  </c:externalData>
-</c:chartSpace>
-</file>
-
-<file path=ppt/charts/chart14.xml><?xml version="1.0" encoding="utf-8"?>
-<c:chartSpace xmlns:c="http://schemas.openxmlformats.org/drawingml/2006/chart" xmlns:a="http://schemas.openxmlformats.org/drawingml/2006/main" xmlns:r="http://schemas.openxmlformats.org/officeDocument/2006/relationships" xmlns:c16r2="http://schemas.microsoft.com/office/drawing/2015/06/chart">
-  <c:date1904 val="0"/>
-  <c:lang val="en-US"/>
-  <c:roundedCorners val="0"/>
-  <mc:AlternateContent xmlns:mc="http://schemas.openxmlformats.org/markup-compatibility/2006">
-    <mc:Choice xmlns:c14="http://schemas.microsoft.com/office/drawing/2007/8/2/chart" Requires="c14">
-      <c14:style val="104"/>
-    </mc:Choice>
-    <mc:Fallback>
-      <c:style val="4"/>
-    </mc:Fallback>
-  </mc:AlternateContent>
-  <c:chart>
-    <c:autoTitleDeleted val="1"/>
-    <c:plotArea>
-      <c:layout/>
-      <c:barChart>
-        <c:barDir val="col"/>
-        <c:grouping val="percentStacked"/>
-        <c:varyColors val="0"/>
-        <c:ser>
-          <c:idx val="0"/>
-          <c:order val="0"/>
-          <c:tx>
-            <c:strRef>
-              <c:f>Sheet1!$B$1</c:f>
-              <c:strCache>
-                <c:ptCount val="1"/>
-                <c:pt idx="0">
-                  <c:v>Objective met</c:v>
-                </c:pt>
-              </c:strCache>
-            </c:strRef>
-          </c:tx>
-          <c:spPr>
-            <a:solidFill>
-              <a:srgbClr val="0066FF"/>
-            </a:solidFill>
-            <a:ln w="19050">
-              <a:noFill/>
-            </a:ln>
-            <a:effectLst>
-              <a:outerShdw blurRad="241300" dist="38100" dir="2700000" algn="tl" rotWithShape="0">
-                <a:prstClr val="black">
-                  <a:alpha val="15000"/>
-                </a:prstClr>
-              </a:outerShdw>
-            </a:effectLst>
-          </c:spPr>
-          <c:invertIfNegative val="0"/>
-          <c:dPt>
-            <c:idx val="0"/>
-            <c:invertIfNegative val="0"/>
-            <c:bubble3D val="0"/>
-            <c:explosion val="6"/>
-            <c:spPr>
-              <a:solidFill>
-                <a:srgbClr val="0066FF"/>
-              </a:solidFill>
-              <a:ln w="19050">
-                <a:noFill/>
-              </a:ln>
-              <a:effectLst>
-                <a:outerShdw blurRad="241300" dist="38100" dir="2700000" algn="tl" rotWithShape="0">
-                  <a:prstClr val="black">
-                    <a:alpha val="15000"/>
-                  </a:prstClr>
-                </a:outerShdw>
-              </a:effectLst>
-            </c:spPr>
-            <c:extLst xmlns:lc="http://schemas.openxmlformats.org/drawingml/2006/lockedCanvas" xmlns:comp="http://schemas.openxmlformats.org/drawingml/2006/compatibility" xmlns:we="http://schemas.microsoft.com/office/webextensions/webextension/2010/11" xmlns:wetp="http://schemas.microsoft.com/office/webextensions/taskpanes/2010/11" xmlns:w16cid="http://schemas.microsoft.com/office/word/2016/wordml/cid" xmlns:w16se="http://schemas.microsoft.com/office/word/2015/wordml/symex" xmlns:wps="http://schemas.microsoft.com/office/word/2010/wordprocessingShape" xmlns:b="http://schemas.openxmlformats.org/officeDocument/2006/bibliography" xmlns:odgm="http://opendope.org/SmartArt/DataHierarchy" xmlns:odi="http://opendope.org/components" xmlns:oda="http://opendope.org/answers" xmlns:odq="http://opendope.org/questions" xmlns:odc="http://opendope.org/conditions" xmlns:odx="http://opendope.org/xpaths" xmlns:cppr="http://schemas.microsoft.com/office/2006/coverPageProps" xmlns:pvml="urn:schemas-microsoft-com:office:powerpoint" xmlns:w10="urn:schemas-microsoft-com:office:word" xmlns:v="urn:schemas-microsoft-com:vml" xmlns:o="urn:schemas-microsoft-com:office:office" xmlns:xvml="urn:schemas-microsoft-com:office:excel" xmlns:dsp="http://schemas.microsoft.com/office/drawing/2008/diagram" xmlns:xdr="http://schemas.openxmlformats.org/drawingml/2006/spreadsheetDrawing" xmlns:pic="http://schemas.openxmlformats.org/drawingml/2006/picture" xmlns:dgm="http://schemas.openxmlformats.org/drawingml/2006/diagram" xmlns:c14="http://schemas.microsoft.com/office/drawing/2007/8/2/chart" xmlns:cdr="http://schemas.openxmlformats.org/drawingml/2006/chartDrawing" xmlns:wne="http://schemas.microsoft.com/office/word/2006/wordml" xmlns:sl="http://schemas.openxmlformats.org/schemaLibrary/2006/main" xmlns:mc="http://schemas.openxmlformats.org/markup-compatibility/2006" xmlns:wp14="http://schemas.microsoft.com/office/word/2010/wordprocessingDrawing" xmlns:wp="http://schemas.openxmlformats.org/drawingml/2006/wordprocessingDrawing" xmlns:m="http://schemas.openxmlformats.org/officeDocument/2006/math" xmlns:w14="http://schemas.microsoft.com/office/word/2010/wordml" xmlns:w15="http://schemas.microsoft.com/office/word/2012/wordml" xmlns:w="http://schemas.openxmlformats.org/wordprocessingml/2006/main">
-              <c:ext xmlns:c16="http://schemas.microsoft.com/office/drawing/2014/chart" uri="{C3380CC4-5D6E-409C-BE32-E72D297353CC}">
-                <c16:uniqueId val="{00000001-6147-E74A-AA7B-5531F0E4EE0C}"/>
-              </c:ext>
-            </c:extLst>
-          </c:dPt>
-          <c:cat>
-            <c:strRef>
-              <c:f>Sheet1!$A$2:$A$13</c:f>
-              <c:strCache>
-                <c:ptCount val="12"/>
-                <c:pt idx="0">
-                  <c:v>Month 1</c:v>
-                </c:pt>
-                <c:pt idx="1">
-                  <c:v>Month 2</c:v>
-                </c:pt>
-                <c:pt idx="2">
-                  <c:v>Month 3</c:v>
-                </c:pt>
-                <c:pt idx="3">
-                  <c:v>Month 4</c:v>
-                </c:pt>
-                <c:pt idx="4">
-                  <c:v>Month 5</c:v>
-                </c:pt>
-                <c:pt idx="5">
-                  <c:v>Month 6</c:v>
-                </c:pt>
-                <c:pt idx="6">
-                  <c:v>Month 7</c:v>
-                </c:pt>
-                <c:pt idx="7">
-                  <c:v>Month 8</c:v>
-                </c:pt>
-                <c:pt idx="8">
-                  <c:v>Month 9</c:v>
-                </c:pt>
-                <c:pt idx="9">
-                  <c:v>Month 10</c:v>
-                </c:pt>
-                <c:pt idx="10">
-                  <c:v>Month 11</c:v>
-                </c:pt>
-                <c:pt idx="11">
-                  <c:v>Month 12</c:v>
-                </c:pt>
-              </c:strCache>
-            </c:strRef>
-          </c:cat>
-          <c:val>
-            <c:numRef>
-              <c:f>Sheet1!$B$2:$B$13</c:f>
-              <c:numCache>
-                <c:formatCode>0.0</c:formatCode>
-                <c:ptCount val="12"/>
-                <c:pt idx="0">
-                  <c:v>0.5</c:v>
-                </c:pt>
-                <c:pt idx="1">
-                  <c:v>0.5</c:v>
-                </c:pt>
-                <c:pt idx="2">
-                  <c:v>0.5</c:v>
-                </c:pt>
-                <c:pt idx="3">
-                  <c:v>0.5</c:v>
-                </c:pt>
-                <c:pt idx="4">
-                  <c:v>0.5</c:v>
-                </c:pt>
-                <c:pt idx="5">
-                  <c:v>0.5</c:v>
-                </c:pt>
-                <c:pt idx="6">
-                  <c:v>0.5</c:v>
-                </c:pt>
-                <c:pt idx="7">
-                  <c:v>0.5</c:v>
-                </c:pt>
-                <c:pt idx="8">
-                  <c:v>0.5</c:v>
-                </c:pt>
-                <c:pt idx="9">
-                  <c:v>0.5</c:v>
-                </c:pt>
-                <c:pt idx="10">
-                  <c:v>0.5</c:v>
-                </c:pt>
-                <c:pt idx="11">
-                  <c:v>0.5</c:v>
-                </c:pt>
-              </c:numCache>
-            </c:numRef>
-          </c:val>
-          <c:extLst xmlns:lc="http://schemas.openxmlformats.org/drawingml/2006/lockedCanvas" xmlns:comp="http://schemas.openxmlformats.org/drawingml/2006/compatibility" xmlns:we="http://schemas.microsoft.com/office/webextensions/webextension/2010/11" xmlns:wetp="http://schemas.microsoft.com/office/webextensions/taskpanes/2010/11" xmlns:w16cid="http://schemas.microsoft.com/office/word/2016/wordml/cid" xmlns:w16se="http://schemas.microsoft.com/office/word/2015/wordml/symex" xmlns:wps="http://schemas.microsoft.com/office/word/2010/wordprocessingShape" xmlns:b="http://schemas.openxmlformats.org/officeDocument/2006/bibliography" xmlns:odgm="http://opendope.org/SmartArt/DataHierarchy" xmlns:odi="http://opendope.org/components" xmlns:oda="http://opendope.org/answers" xmlns:odq="http://opendope.org/questions" xmlns:odc="http://opendope.org/conditions" xmlns:odx="http://opendope.org/xpaths" xmlns:cppr="http://schemas.microsoft.com/office/2006/coverPageProps" xmlns:pvml="urn:schemas-microsoft-com:office:powerpoint" xmlns:w10="urn:schemas-microsoft-com:office:word" xmlns:v="urn:schemas-microsoft-com:vml" xmlns:o="urn:schemas-microsoft-com:office:office" xmlns:xvml="urn:schemas-microsoft-com:office:excel" xmlns:dsp="http://schemas.microsoft.com/office/drawing/2008/diagram" xmlns:xdr="http://schemas.openxmlformats.org/drawingml/2006/spreadsheetDrawing" xmlns:pic="http://schemas.openxmlformats.org/drawingml/2006/picture" xmlns:dgm="http://schemas.openxmlformats.org/drawingml/2006/diagram" xmlns:c14="http://schemas.microsoft.com/office/drawing/2007/8/2/chart" xmlns:cdr="http://schemas.openxmlformats.org/drawingml/2006/chartDrawing" xmlns:wne="http://schemas.microsoft.com/office/word/2006/wordml" xmlns:sl="http://schemas.openxmlformats.org/schemaLibrary/2006/main" xmlns:mc="http://schemas.openxmlformats.org/markup-compatibility/2006" xmlns:wp14="http://schemas.microsoft.com/office/word/2010/wordprocessingDrawing" xmlns:wp="http://schemas.openxmlformats.org/drawingml/2006/wordprocessingDrawing" xmlns:m="http://schemas.openxmlformats.org/officeDocument/2006/math" xmlns:w14="http://schemas.microsoft.com/office/word/2010/wordml" xmlns:w15="http://schemas.microsoft.com/office/word/2012/wordml" xmlns:w="http://schemas.openxmlformats.org/wordprocessingml/2006/main">
-            <c:ext xmlns:c16="http://schemas.microsoft.com/office/drawing/2014/chart" uri="{C3380CC4-5D6E-409C-BE32-E72D297353CC}">
-              <c16:uniqueId val="{00000002-6147-E74A-AA7B-5531F0E4EE0C}"/>
-            </c:ext>
-          </c:extLst>
-        </c:ser>
-        <c:ser>
-          <c:idx val="1"/>
-          <c:order val="1"/>
-          <c:tx>
-            <c:strRef>
-              <c:f>Sheet1!$C$1</c:f>
-              <c:strCache>
-                <c:ptCount val="1"/>
-                <c:pt idx="0">
-                  <c:v>Improved</c:v>
-                </c:pt>
-              </c:strCache>
-            </c:strRef>
-          </c:tx>
-          <c:spPr>
-            <a:solidFill>
-              <a:srgbClr val="67E77F"/>
-            </a:solidFill>
-            <a:ln w="19050">
-              <a:noFill/>
-            </a:ln>
-            <a:effectLst/>
-          </c:spPr>
-          <c:invertIfNegative val="0"/>
-          <c:cat>
-            <c:strRef>
-              <c:f>Sheet1!$A$2:$A$13</c:f>
-              <c:strCache>
-                <c:ptCount val="12"/>
-                <c:pt idx="0">
-                  <c:v>Month 1</c:v>
-                </c:pt>
-                <c:pt idx="1">
-                  <c:v>Month 2</c:v>
-                </c:pt>
-                <c:pt idx="2">
-                  <c:v>Month 3</c:v>
-                </c:pt>
-                <c:pt idx="3">
-                  <c:v>Month 4</c:v>
-                </c:pt>
-                <c:pt idx="4">
-                  <c:v>Month 5</c:v>
-                </c:pt>
-                <c:pt idx="5">
-                  <c:v>Month 6</c:v>
-                </c:pt>
-                <c:pt idx="6">
-                  <c:v>Month 7</c:v>
-                </c:pt>
-                <c:pt idx="7">
-                  <c:v>Month 8</c:v>
-                </c:pt>
-                <c:pt idx="8">
-                  <c:v>Month 9</c:v>
-                </c:pt>
-                <c:pt idx="9">
-                  <c:v>Month 10</c:v>
-                </c:pt>
-                <c:pt idx="10">
-                  <c:v>Month 11</c:v>
-                </c:pt>
-                <c:pt idx="11">
-                  <c:v>Month 12</c:v>
-                </c:pt>
-              </c:strCache>
-            </c:strRef>
-          </c:cat>
-          <c:val>
-            <c:numRef>
-              <c:f>Sheet1!$C$2:$C$13</c:f>
-              <c:numCache>
-                <c:formatCode>0.0</c:formatCode>
-                <c:ptCount val="12"/>
-                <c:pt idx="0">
-                  <c:v>0.5</c:v>
-                </c:pt>
-                <c:pt idx="1">
-                  <c:v>0.5</c:v>
-                </c:pt>
-                <c:pt idx="2">
-                  <c:v>0.5</c:v>
-                </c:pt>
-                <c:pt idx="3">
-                  <c:v>0.5</c:v>
-                </c:pt>
-                <c:pt idx="4">
-                  <c:v>0.5</c:v>
-                </c:pt>
-                <c:pt idx="5">
-                  <c:v>0.5</c:v>
-                </c:pt>
-                <c:pt idx="6">
-                  <c:v>0.5</c:v>
-                </c:pt>
-                <c:pt idx="7">
-                  <c:v>0.5</c:v>
-                </c:pt>
-                <c:pt idx="8">
-                  <c:v>0.5</c:v>
-                </c:pt>
-                <c:pt idx="9">
-                  <c:v>0.5</c:v>
-                </c:pt>
-                <c:pt idx="10">
-                  <c:v>0.5</c:v>
-                </c:pt>
-                <c:pt idx="11">
-                  <c:v>0.5</c:v>
-                </c:pt>
-              </c:numCache>
-            </c:numRef>
-          </c:val>
-          <c:extLst>
-            <c:ext xmlns:c16="http://schemas.microsoft.com/office/drawing/2014/chart" uri="{C3380CC4-5D6E-409C-BE32-E72D297353CC}">
-              <c16:uniqueId val="{00000003-6147-E74A-AA7B-5531F0E4EE0C}"/>
-            </c:ext>
-          </c:extLst>
-        </c:ser>
-        <c:ser>
-          <c:idx val="2"/>
-          <c:order val="2"/>
-          <c:tx>
-            <c:strRef>
-              <c:f>Sheet1!$D$1</c:f>
-              <c:strCache>
-                <c:ptCount val="1"/>
-                <c:pt idx="0">
-                  <c:v>Unchanged</c:v>
-                </c:pt>
-              </c:strCache>
-            </c:strRef>
-          </c:tx>
-          <c:spPr>
-            <a:solidFill>
-              <a:srgbClr val="BFC4CF"/>
-            </a:solidFill>
-            <a:ln w="19050">
-              <a:noFill/>
-            </a:ln>
-            <a:effectLst/>
-          </c:spPr>
-          <c:invertIfNegative val="0"/>
-          <c:cat>
-            <c:strRef>
-              <c:f>Sheet1!$A$2:$A$13</c:f>
-              <c:strCache>
-                <c:ptCount val="12"/>
-                <c:pt idx="0">
-                  <c:v>Month 1</c:v>
-                </c:pt>
-                <c:pt idx="1">
-                  <c:v>Month 2</c:v>
-                </c:pt>
-                <c:pt idx="2">
-                  <c:v>Month 3</c:v>
-                </c:pt>
-                <c:pt idx="3">
-                  <c:v>Month 4</c:v>
-                </c:pt>
-                <c:pt idx="4">
-                  <c:v>Month 5</c:v>
-                </c:pt>
-                <c:pt idx="5">
-                  <c:v>Month 6</c:v>
-                </c:pt>
-                <c:pt idx="6">
-                  <c:v>Month 7</c:v>
-                </c:pt>
-                <c:pt idx="7">
-                  <c:v>Month 8</c:v>
-                </c:pt>
-                <c:pt idx="8">
-                  <c:v>Month 9</c:v>
-                </c:pt>
-                <c:pt idx="9">
-                  <c:v>Month 10</c:v>
-                </c:pt>
-                <c:pt idx="10">
-                  <c:v>Month 11</c:v>
-                </c:pt>
-                <c:pt idx="11">
-                  <c:v>Month 12</c:v>
-                </c:pt>
-              </c:strCache>
-            </c:strRef>
-          </c:cat>
-          <c:val>
-            <c:numRef>
-              <c:f>Sheet1!$D$2:$D$13</c:f>
-              <c:numCache>
-                <c:formatCode>General</c:formatCode>
-                <c:ptCount val="12"/>
-                <c:pt idx="0">
-                  <c:v>0.5</c:v>
-                </c:pt>
-                <c:pt idx="1">
-                  <c:v>0.5</c:v>
-                </c:pt>
-                <c:pt idx="2">
-                  <c:v>0.5</c:v>
-                </c:pt>
-                <c:pt idx="3">
-                  <c:v>0.5</c:v>
-                </c:pt>
-                <c:pt idx="4">
-                  <c:v>0.5</c:v>
-                </c:pt>
-                <c:pt idx="5">
-                  <c:v>0.5</c:v>
-                </c:pt>
-                <c:pt idx="6">
-                  <c:v>0.5</c:v>
-                </c:pt>
-                <c:pt idx="7">
-                  <c:v>0.5</c:v>
-                </c:pt>
-                <c:pt idx="8">
-                  <c:v>0.5</c:v>
-                </c:pt>
-                <c:pt idx="9">
-                  <c:v>0.5</c:v>
-                </c:pt>
-                <c:pt idx="10">
-                  <c:v>0.5</c:v>
-                </c:pt>
-                <c:pt idx="11">
-                  <c:v>0.5</c:v>
-                </c:pt>
-              </c:numCache>
-            </c:numRef>
-          </c:val>
-          <c:extLst>
-            <c:ext xmlns:c16="http://schemas.microsoft.com/office/drawing/2014/chart" uri="{C3380CC4-5D6E-409C-BE32-E72D297353CC}">
-              <c16:uniqueId val="{00000004-6147-E74A-AA7B-5531F0E4EE0C}"/>
-            </c:ext>
-          </c:extLst>
-        </c:ser>
-        <c:ser>
-          <c:idx val="3"/>
-          <c:order val="3"/>
-          <c:tx>
-            <c:strRef>
-              <c:f>Sheet1!$E$1</c:f>
-              <c:strCache>
-                <c:ptCount val="1"/>
-                <c:pt idx="0">
-                  <c:v>Worsened</c:v>
-                </c:pt>
-              </c:strCache>
-            </c:strRef>
-          </c:tx>
-          <c:spPr>
-            <a:solidFill>
-              <a:srgbClr val="F06241"/>
-            </a:solidFill>
-            <a:ln w="19050">
-              <a:noFill/>
-            </a:ln>
-            <a:effectLst/>
-          </c:spPr>
-          <c:invertIfNegative val="0"/>
-          <c:cat>
-            <c:strRef>
-              <c:f>Sheet1!$A$2:$A$13</c:f>
-              <c:strCache>
-                <c:ptCount val="12"/>
-                <c:pt idx="0">
-                  <c:v>Month 1</c:v>
-                </c:pt>
-                <c:pt idx="1">
-                  <c:v>Month 2</c:v>
-                </c:pt>
-                <c:pt idx="2">
-                  <c:v>Month 3</c:v>
-                </c:pt>
-                <c:pt idx="3">
-                  <c:v>Month 4</c:v>
-                </c:pt>
-                <c:pt idx="4">
-                  <c:v>Month 5</c:v>
-                </c:pt>
-                <c:pt idx="5">
-                  <c:v>Month 6</c:v>
-                </c:pt>
-                <c:pt idx="6">
-                  <c:v>Month 7</c:v>
-                </c:pt>
-                <c:pt idx="7">
-                  <c:v>Month 8</c:v>
-                </c:pt>
-                <c:pt idx="8">
-                  <c:v>Month 9</c:v>
-                </c:pt>
-                <c:pt idx="9">
-                  <c:v>Month 10</c:v>
-                </c:pt>
-                <c:pt idx="10">
-                  <c:v>Month 11</c:v>
-                </c:pt>
-                <c:pt idx="11">
-                  <c:v>Month 12</c:v>
-                </c:pt>
-              </c:strCache>
-            </c:strRef>
-          </c:cat>
-          <c:val>
-            <c:numRef>
-              <c:f>Sheet1!$E$2:$E$13</c:f>
-              <c:numCache>
-                <c:formatCode>General</c:formatCode>
-                <c:ptCount val="12"/>
-                <c:pt idx="0">
-                  <c:v>0.5</c:v>
-                </c:pt>
-                <c:pt idx="1">
-                  <c:v>0.5</c:v>
-                </c:pt>
-                <c:pt idx="2">
-                  <c:v>0.5</c:v>
-                </c:pt>
-                <c:pt idx="3">
-                  <c:v>0.5</c:v>
-                </c:pt>
-                <c:pt idx="4">
-                  <c:v>0.5</c:v>
-                </c:pt>
-                <c:pt idx="5">
-                  <c:v>0.5</c:v>
-                </c:pt>
-                <c:pt idx="6">
-                  <c:v>0.5</c:v>
-                </c:pt>
-                <c:pt idx="7">
-                  <c:v>0.5</c:v>
-                </c:pt>
-                <c:pt idx="8">
-                  <c:v>0.5</c:v>
-                </c:pt>
-                <c:pt idx="9">
-                  <c:v>0.5</c:v>
-                </c:pt>
-                <c:pt idx="10">
-                  <c:v>0.5</c:v>
-                </c:pt>
-                <c:pt idx="11">
-                  <c:v>0.5</c:v>
-                </c:pt>
-              </c:numCache>
-            </c:numRef>
-          </c:val>
-          <c:extLst>
-            <c:ext xmlns:c16="http://schemas.microsoft.com/office/drawing/2014/chart" uri="{C3380CC4-5D6E-409C-BE32-E72D297353CC}">
-              <c16:uniqueId val="{00000005-6147-E74A-AA7B-5531F0E4EE0C}"/>
-            </c:ext>
-          </c:extLst>
-        </c:ser>
-        <c:ser>
-          <c:idx val="4"/>
-          <c:order val="4"/>
-          <c:tx>
-            <c:strRef>
-              <c:f>Sheet1!$F$1</c:f>
-              <c:strCache>
-                <c:ptCount val="1"/>
-                <c:pt idx="0">
-                  <c:v>Unknown</c:v>
-                </c:pt>
-              </c:strCache>
-            </c:strRef>
-          </c:tx>
-          <c:spPr>
-            <a:solidFill>
-              <a:schemeClr val="bg1"/>
-            </a:solidFill>
-            <a:ln w="19050">
-              <a:solidFill>
-                <a:schemeClr val="lt1"/>
-              </a:solidFill>
-            </a:ln>
-            <a:effectLst/>
-          </c:spPr>
-          <c:invertIfNegative val="0"/>
-          <c:cat>
-            <c:strRef>
-              <c:f>Sheet1!$A$2:$A$13</c:f>
-              <c:strCache>
-                <c:ptCount val="12"/>
-                <c:pt idx="0">
-                  <c:v>Month 1</c:v>
-                </c:pt>
-                <c:pt idx="1">
-                  <c:v>Month 2</c:v>
-                </c:pt>
-                <c:pt idx="2">
-                  <c:v>Month 3</c:v>
-                </c:pt>
-                <c:pt idx="3">
-                  <c:v>Month 4</c:v>
-                </c:pt>
-                <c:pt idx="4">
-                  <c:v>Month 5</c:v>
-                </c:pt>
-                <c:pt idx="5">
-                  <c:v>Month 6</c:v>
-                </c:pt>
-                <c:pt idx="6">
-                  <c:v>Month 7</c:v>
-                </c:pt>
-                <c:pt idx="7">
-                  <c:v>Month 8</c:v>
-                </c:pt>
-                <c:pt idx="8">
-                  <c:v>Month 9</c:v>
-                </c:pt>
-                <c:pt idx="9">
-                  <c:v>Month 10</c:v>
-                </c:pt>
-                <c:pt idx="10">
-                  <c:v>Month 11</c:v>
-                </c:pt>
-                <c:pt idx="11">
-                  <c:v>Month 12</c:v>
-                </c:pt>
-              </c:strCache>
-            </c:strRef>
-          </c:cat>
-          <c:val>
-            <c:numRef>
-              <c:f>Sheet1!$F$2:$F$13</c:f>
-              <c:numCache>
-                <c:formatCode>General</c:formatCode>
-                <c:ptCount val="12"/>
-                <c:pt idx="0">
-                  <c:v>0.5</c:v>
-                </c:pt>
-                <c:pt idx="1">
-                  <c:v>0.5</c:v>
-                </c:pt>
-                <c:pt idx="2">
-                  <c:v>0.5</c:v>
-                </c:pt>
-                <c:pt idx="3">
-                  <c:v>0.5</c:v>
-                </c:pt>
-                <c:pt idx="4">
-                  <c:v>0.5</c:v>
-                </c:pt>
-                <c:pt idx="5">
-                  <c:v>0.5</c:v>
-                </c:pt>
-                <c:pt idx="6">
-                  <c:v>0.5</c:v>
-                </c:pt>
-                <c:pt idx="7">
-                  <c:v>0.5</c:v>
-                </c:pt>
-                <c:pt idx="8">
-                  <c:v>0.5</c:v>
-                </c:pt>
-                <c:pt idx="9">
-                  <c:v>0.5</c:v>
-                </c:pt>
-                <c:pt idx="10">
-                  <c:v>0.5</c:v>
-                </c:pt>
-                <c:pt idx="11">
-                  <c:v>0.5</c:v>
-                </c:pt>
-              </c:numCache>
-            </c:numRef>
-          </c:val>
-          <c:extLst>
-            <c:ext xmlns:c16="http://schemas.microsoft.com/office/drawing/2014/chart" uri="{C3380CC4-5D6E-409C-BE32-E72D297353CC}">
-              <c16:uniqueId val="{00000006-6147-E74A-AA7B-5531F0E4EE0C}"/>
-            </c:ext>
-          </c:extLst>
-        </c:ser>
-        <c:dLbls>
-          <c:showLegendKey val="0"/>
-          <c:showVal val="0"/>
-          <c:showCatName val="0"/>
-          <c:showSerName val="0"/>
-          <c:showPercent val="0"/>
-          <c:showBubbleSize val="0"/>
-        </c:dLbls>
-        <c:gapWidth val="20"/>
-        <c:overlap val="100"/>
-        <c:axId val="476387520"/>
-        <c:axId val="477616192"/>
-      </c:barChart>
-      <c:catAx>
-        <c:axId val="476387520"/>
-        <c:scaling>
-          <c:orientation val="minMax"/>
-        </c:scaling>
-        <c:delete val="0"/>
-        <c:axPos val="b"/>
-        <c:numFmt formatCode="General" sourceLinked="1"/>
-        <c:majorTickMark val="out"/>
-        <c:minorTickMark val="none"/>
-        <c:tickLblPos val="nextTo"/>
-        <c:spPr>
-          <a:noFill/>
-          <a:ln w="9525" cap="flat" cmpd="sng" algn="ctr">
-            <a:solidFill>
-              <a:schemeClr val="tx1">
-                <a:lumMod val="15000"/>
-                <a:lumOff val="85000"/>
-              </a:schemeClr>
-            </a:solidFill>
-            <a:round/>
-          </a:ln>
-          <a:effectLst/>
-        </c:spPr>
-        <c:txPr>
-          <a:bodyPr rot="-60000000" spcFirstLastPara="1" vertOverflow="ellipsis" vert="horz" wrap="square" anchor="ctr" anchorCtr="1"/>
-          <a:lstStyle/>
-          <a:p>
-            <a:pPr>
-              <a:defRPr sz="1400" b="0" i="0" u="none" strike="noStrike" kern="1200" baseline="0">
-                <a:solidFill>
-                  <a:schemeClr val="tx2"/>
-                </a:solidFill>
-                <a:latin typeface="+mn-lt"/>
-                <a:ea typeface="+mn-ea"/>
-                <a:cs typeface="+mn-cs"/>
-              </a:defRPr>
-            </a:pPr>
-            <a:endParaRPr lang="en-NL"/>
-          </a:p>
-        </c:txPr>
-        <c:crossAx val="477616192"/>
-        <c:crosses val="autoZero"/>
-        <c:auto val="1"/>
-        <c:lblAlgn val="ctr"/>
-        <c:lblOffset val="100"/>
-        <c:noMultiLvlLbl val="0"/>
-      </c:catAx>
-      <c:valAx>
-        <c:axId val="477616192"/>
-        <c:scaling>
-          <c:orientation val="minMax"/>
-        </c:scaling>
-        <c:delete val="0"/>
-        <c:axPos val="l"/>
-        <c:majorGridlines>
-          <c:spPr>
-            <a:ln w="9525" cap="flat" cmpd="sng" algn="ctr">
-              <a:solidFill>
-                <a:schemeClr val="tx1">
-                  <a:lumMod val="15000"/>
-                  <a:lumOff val="85000"/>
-                </a:schemeClr>
-              </a:solidFill>
-              <a:round/>
-            </a:ln>
-            <a:effectLst/>
-          </c:spPr>
-        </c:majorGridlines>
-        <c:numFmt formatCode="0%" sourceLinked="0"/>
-        <c:majorTickMark val="out"/>
-        <c:minorTickMark val="none"/>
-        <c:tickLblPos val="nextTo"/>
-        <c:spPr>
-          <a:noFill/>
-          <a:ln>
-            <a:noFill/>
-          </a:ln>
-          <a:effectLst/>
-        </c:spPr>
-        <c:txPr>
-          <a:bodyPr rot="-60000000" spcFirstLastPara="1" vertOverflow="ellipsis" vert="horz" wrap="square" anchor="ctr" anchorCtr="1"/>
-          <a:lstStyle/>
-          <a:p>
-            <a:pPr>
-              <a:defRPr sz="1197" b="0" i="0" u="none" strike="noStrike" kern="1200" baseline="0">
-                <a:solidFill>
-                  <a:schemeClr val="tx2"/>
-                </a:solidFill>
-                <a:latin typeface="+mn-lt"/>
-                <a:ea typeface="+mn-ea"/>
-                <a:cs typeface="+mn-cs"/>
-              </a:defRPr>
-            </a:pPr>
-            <a:endParaRPr lang="en-US"/>
-          </a:p>
-        </c:txPr>
-        <c:crossAx val="476387520"/>
-        <c:crosses val="autoZero"/>
-        <c:crossBetween val="between"/>
-      </c:valAx>
-      <c:spPr>
-        <a:solidFill>
-          <a:srgbClr val="F0F4F8"/>
-        </a:solidFill>
-        <a:ln>
-          <a:noFill/>
-        </a:ln>
-        <a:effectLst/>
-      </c:spPr>
-    </c:plotArea>
-    <c:plotVisOnly val="1"/>
-    <c:dispBlanksAs val="gap"/>
-    <c:showDLblsOverMax val="0"/>
-    <c:extLst xmlns:lc="http://schemas.openxmlformats.org/drawingml/2006/lockedCanvas" xmlns:comp="http://schemas.openxmlformats.org/drawingml/2006/compatibility" xmlns:we="http://schemas.microsoft.com/office/webextensions/webextension/2010/11" xmlns:wetp="http://schemas.microsoft.com/office/webextensions/taskpanes/2010/11" xmlns:w16cid="http://schemas.microsoft.com/office/word/2016/wordml/cid" xmlns:w16se="http://schemas.microsoft.com/office/word/2015/wordml/symex" xmlns:wps="http://schemas.microsoft.com/office/word/2010/wordprocessingShape" xmlns:b="http://schemas.openxmlformats.org/officeDocument/2006/bibliography" xmlns:odgm="http://opendope.org/SmartArt/DataHierarchy" xmlns:odi="http://opendope.org/components" xmlns:oda="http://opendope.org/answers" xmlns:odq="http://opendope.org/questions" xmlns:odc="http://opendope.org/conditions" xmlns:odx="http://opendope.org/xpaths" xmlns:cppr="http://schemas.microsoft.com/office/2006/coverPageProps" xmlns:pvml="urn:schemas-microsoft-com:office:powerpoint" xmlns:w10="urn:schemas-microsoft-com:office:word" xmlns:v="urn:schemas-microsoft-com:vml" xmlns:o="urn:schemas-microsoft-com:office:office" xmlns:xvml="urn:schemas-microsoft-com:office:excel" xmlns:dsp="http://schemas.microsoft.com/office/drawing/2008/diagram" xmlns:xdr="http://schemas.openxmlformats.org/drawingml/2006/spreadsheetDrawing" xmlns:pic="http://schemas.openxmlformats.org/drawingml/2006/picture" xmlns:dgm="http://schemas.openxmlformats.org/drawingml/2006/diagram" xmlns:c14="http://schemas.microsoft.com/office/drawing/2007/8/2/chart" xmlns:cdr="http://schemas.openxmlformats.org/drawingml/2006/chartDrawing" xmlns:wne="http://schemas.microsoft.com/office/word/2006/wordml" xmlns:sl="http://schemas.openxmlformats.org/schemaLibrary/2006/main" xmlns:mc="http://schemas.openxmlformats.org/markup-compatibility/2006" xmlns:wp14="http://schemas.microsoft.com/office/word/2010/wordprocessingDrawing" xmlns:wp="http://schemas.openxmlformats.org/drawingml/2006/wordprocessingDrawing" xmlns:m="http://schemas.openxmlformats.org/officeDocument/2006/math" xmlns:w14="http://schemas.microsoft.com/office/word/2010/wordml" xmlns:w15="http://schemas.microsoft.com/office/word/2012/wordml" xmlns:w="http://schemas.openxmlformats.org/wordprocessingml/2006/main">
-      <c:ext xmlns:c16r3="http://schemas.microsoft.com/office/drawing/2017/03/chart" uri="{56B9EC1D-385E-4148-901F-78D8002777C0}">
-        <c16r3:dataDisplayOptions16>
-          <c16r3:dispNaAsBlank val="1"/>
-        </c16r3:dataDisplayOptions16>
-      </c:ext>
-    </c:extLst>
-  </c:chart>
-  <c:spPr>
-    <a:noFill/>
-    <a:ln>
-      <a:noFill/>
-    </a:ln>
-    <a:effectLst/>
-  </c:spPr>
-  <c:txPr>
-    <a:bodyPr/>
-    <a:lstStyle/>
-    <a:p>
-      <a:pPr>
-        <a:defRPr/>
-      </a:pPr>
-      <a:endParaRPr lang="en-NL"/>
-    </a:p>
-  </c:txPr>
-  <c:externalData r:id="rId3">
-    <c:autoUpdate val="0"/>
-  </c:externalData>
-</c:chartSpace>
-</file>
-
-<file path=ppt/charts/chart15.xml><?xml version="1.0" encoding="utf-8"?>
-<c:chartSpace xmlns:c="http://schemas.openxmlformats.org/drawingml/2006/chart" xmlns:a="http://schemas.openxmlformats.org/drawingml/2006/main" xmlns:r="http://schemas.openxmlformats.org/officeDocument/2006/relationships" xmlns:c16r2="http://schemas.microsoft.com/office/drawing/2015/06/chart">
-  <c:date1904 val="0"/>
-  <c:lang val="en-US"/>
-  <c:roundedCorners val="0"/>
-  <mc:AlternateContent xmlns:mc="http://schemas.openxmlformats.org/markup-compatibility/2006">
-    <mc:Choice xmlns:c14="http://schemas.microsoft.com/office/drawing/2007/8/2/chart" Requires="c14">
-      <c14:style val="104"/>
-    </mc:Choice>
-    <mc:Fallback>
-      <c:style val="4"/>
-    </mc:Fallback>
-  </mc:AlternateContent>
-  <c:chart>
-    <c:autoTitleDeleted val="1"/>
-    <c:plotArea>
-      <c:layout/>
-      <c:barChart>
-        <c:barDir val="col"/>
-        <c:grouping val="percentStacked"/>
-        <c:varyColors val="0"/>
-        <c:ser>
-          <c:idx val="0"/>
-          <c:order val="0"/>
-          <c:tx>
-            <c:strRef>
-              <c:f>Sheet1!$B$1</c:f>
-              <c:strCache>
-                <c:ptCount val="1"/>
-                <c:pt idx="0">
-                  <c:v>Objective met</c:v>
-                </c:pt>
-              </c:strCache>
-            </c:strRef>
-          </c:tx>
-          <c:spPr>
-            <a:solidFill>
-              <a:srgbClr val="0066FF"/>
-            </a:solidFill>
-            <a:ln w="19050">
-              <a:noFill/>
-            </a:ln>
-            <a:effectLst>
-              <a:outerShdw blurRad="241300" dist="38100" dir="2700000" algn="tl" rotWithShape="0">
-                <a:prstClr val="black">
-                  <a:alpha val="15000"/>
-                </a:prstClr>
-              </a:outerShdw>
-            </a:effectLst>
-          </c:spPr>
-          <c:invertIfNegative val="0"/>
-          <c:dPt>
-            <c:idx val="0"/>
-            <c:invertIfNegative val="0"/>
-            <c:bubble3D val="0"/>
-            <c:explosion val="6"/>
-            <c:spPr>
-              <a:solidFill>
-                <a:srgbClr val="0066FF"/>
-              </a:solidFill>
-              <a:ln w="19050">
-                <a:noFill/>
-              </a:ln>
-              <a:effectLst>
-                <a:outerShdw blurRad="241300" dist="38100" dir="2700000" algn="tl" rotWithShape="0">
-                  <a:prstClr val="black">
-                    <a:alpha val="15000"/>
-                  </a:prstClr>
-                </a:outerShdw>
-              </a:effectLst>
-            </c:spPr>
-            <c:extLst xmlns:lc="http://schemas.openxmlformats.org/drawingml/2006/lockedCanvas" xmlns:comp="http://schemas.openxmlformats.org/drawingml/2006/compatibility" xmlns:we="http://schemas.microsoft.com/office/webextensions/webextension/2010/11" xmlns:wetp="http://schemas.microsoft.com/office/webextensions/taskpanes/2010/11" xmlns:w16cid="http://schemas.microsoft.com/office/word/2016/wordml/cid" xmlns:w16se="http://schemas.microsoft.com/office/word/2015/wordml/symex" xmlns:wps="http://schemas.microsoft.com/office/word/2010/wordprocessingShape" xmlns:b="http://schemas.openxmlformats.org/officeDocument/2006/bibliography" xmlns:odgm="http://opendope.org/SmartArt/DataHierarchy" xmlns:odi="http://opendope.org/components" xmlns:oda="http://opendope.org/answers" xmlns:odq="http://opendope.org/questions" xmlns:odc="http://opendope.org/conditions" xmlns:odx="http://opendope.org/xpaths" xmlns:cppr="http://schemas.microsoft.com/office/2006/coverPageProps" xmlns:pvml="urn:schemas-microsoft-com:office:powerpoint" xmlns:w10="urn:schemas-microsoft-com:office:word" xmlns:v="urn:schemas-microsoft-com:vml" xmlns:o="urn:schemas-microsoft-com:office:office" xmlns:xvml="urn:schemas-microsoft-com:office:excel" xmlns:dsp="http://schemas.microsoft.com/office/drawing/2008/diagram" xmlns:xdr="http://schemas.openxmlformats.org/drawingml/2006/spreadsheetDrawing" xmlns:pic="http://schemas.openxmlformats.org/drawingml/2006/picture" xmlns:dgm="http://schemas.openxmlformats.org/drawingml/2006/diagram" xmlns:c14="http://schemas.microsoft.com/office/drawing/2007/8/2/chart" xmlns:cdr="http://schemas.openxmlformats.org/drawingml/2006/chartDrawing" xmlns:wne="http://schemas.microsoft.com/office/word/2006/wordml" xmlns:sl="http://schemas.openxmlformats.org/schemaLibrary/2006/main" xmlns:mc="http://schemas.openxmlformats.org/markup-compatibility/2006" xmlns:wp14="http://schemas.microsoft.com/office/word/2010/wordprocessingDrawing" xmlns:wp="http://schemas.openxmlformats.org/drawingml/2006/wordprocessingDrawing" xmlns:m="http://schemas.openxmlformats.org/officeDocument/2006/math" xmlns:w14="http://schemas.microsoft.com/office/word/2010/wordml" xmlns:w15="http://schemas.microsoft.com/office/word/2012/wordml" xmlns:w="http://schemas.openxmlformats.org/wordprocessingml/2006/main">
-              <c:ext xmlns:c16="http://schemas.microsoft.com/office/drawing/2014/chart" uri="{C3380CC4-5D6E-409C-BE32-E72D297353CC}">
-                <c16:uniqueId val="{00000001-6147-E74A-AA7B-5531F0E4EE0C}"/>
-              </c:ext>
-            </c:extLst>
-          </c:dPt>
-          <c:cat>
-            <c:strRef>
-              <c:f>Sheet1!$A$2:$A$13</c:f>
-              <c:strCache>
-                <c:ptCount val="12"/>
-                <c:pt idx="0">
-                  <c:v>Month 1</c:v>
-                </c:pt>
-                <c:pt idx="1">
-                  <c:v>Month 2</c:v>
-                </c:pt>
-                <c:pt idx="2">
-                  <c:v>Month 3</c:v>
-                </c:pt>
-                <c:pt idx="3">
-                  <c:v>Month 4</c:v>
-                </c:pt>
-                <c:pt idx="4">
-                  <c:v>Month 5</c:v>
-                </c:pt>
-                <c:pt idx="5">
-                  <c:v>Month 6</c:v>
-                </c:pt>
-                <c:pt idx="6">
-                  <c:v>Month 7</c:v>
-                </c:pt>
-                <c:pt idx="7">
-                  <c:v>Month 8</c:v>
-                </c:pt>
-                <c:pt idx="8">
-                  <c:v>Month 9</c:v>
-                </c:pt>
-                <c:pt idx="9">
-                  <c:v>Month 10</c:v>
-                </c:pt>
-                <c:pt idx="10">
-                  <c:v>Month 11</c:v>
-                </c:pt>
-                <c:pt idx="11">
-                  <c:v>Month 12</c:v>
-                </c:pt>
-              </c:strCache>
-            </c:strRef>
-          </c:cat>
-          <c:val>
-            <c:numRef>
-              <c:f>Sheet1!$B$2:$B$13</c:f>
-              <c:numCache>
-                <c:formatCode>0.0</c:formatCode>
-                <c:ptCount val="12"/>
-                <c:pt idx="0">
-                  <c:v>0.5</c:v>
-                </c:pt>
-                <c:pt idx="1">
-                  <c:v>0.5</c:v>
-                </c:pt>
-                <c:pt idx="2">
-                  <c:v>0.5</c:v>
-                </c:pt>
-                <c:pt idx="3">
-                  <c:v>0.5</c:v>
-                </c:pt>
-                <c:pt idx="4">
-                  <c:v>0.5</c:v>
-                </c:pt>
-                <c:pt idx="5">
-                  <c:v>0.5</c:v>
-                </c:pt>
-                <c:pt idx="6">
-                  <c:v>0.5</c:v>
-                </c:pt>
-                <c:pt idx="7">
-                  <c:v>0.5</c:v>
-                </c:pt>
-                <c:pt idx="8">
-                  <c:v>0.5</c:v>
-                </c:pt>
-                <c:pt idx="9">
-                  <c:v>0.5</c:v>
-                </c:pt>
-                <c:pt idx="10">
-                  <c:v>0.5</c:v>
-                </c:pt>
-                <c:pt idx="11">
-                  <c:v>0.5</c:v>
-                </c:pt>
-              </c:numCache>
-            </c:numRef>
-          </c:val>
-          <c:extLst xmlns:lc="http://schemas.openxmlformats.org/drawingml/2006/lockedCanvas" xmlns:comp="http://schemas.openxmlformats.org/drawingml/2006/compatibility" xmlns:we="http://schemas.microsoft.com/office/webextensions/webextension/2010/11" xmlns:wetp="http://schemas.microsoft.com/office/webextensions/taskpanes/2010/11" xmlns:w16cid="http://schemas.microsoft.com/office/word/2016/wordml/cid" xmlns:w16se="http://schemas.microsoft.com/office/word/2015/wordml/symex" xmlns:wps="http://schemas.microsoft.com/office/word/2010/wordprocessingShape" xmlns:b="http://schemas.openxmlformats.org/officeDocument/2006/bibliography" xmlns:odgm="http://opendope.org/SmartArt/DataHierarchy" xmlns:odi="http://opendope.org/components" xmlns:oda="http://opendope.org/answers" xmlns:odq="http://opendope.org/questions" xmlns:odc="http://opendope.org/conditions" xmlns:odx="http://opendope.org/xpaths" xmlns:cppr="http://schemas.microsoft.com/office/2006/coverPageProps" xmlns:pvml="urn:schemas-microsoft-com:office:powerpoint" xmlns:w10="urn:schemas-microsoft-com:office:word" xmlns:v="urn:schemas-microsoft-com:vml" xmlns:o="urn:schemas-microsoft-com:office:office" xmlns:xvml="urn:schemas-microsoft-com:office:excel" xmlns:dsp="http://schemas.microsoft.com/office/drawing/2008/diagram" xmlns:xdr="http://schemas.openxmlformats.org/drawingml/2006/spreadsheetDrawing" xmlns:pic="http://schemas.openxmlformats.org/drawingml/2006/picture" xmlns:dgm="http://schemas.openxmlformats.org/drawingml/2006/diagram" xmlns:c14="http://schemas.microsoft.com/office/drawing/2007/8/2/chart" xmlns:cdr="http://schemas.openxmlformats.org/drawingml/2006/chartDrawing" xmlns:wne="http://schemas.microsoft.com/office/word/2006/wordml" xmlns:sl="http://schemas.openxmlformats.org/schemaLibrary/2006/main" xmlns:mc="http://schemas.openxmlformats.org/markup-compatibility/2006" xmlns:wp14="http://schemas.microsoft.com/office/word/2010/wordprocessingDrawing" xmlns:wp="http://schemas.openxmlformats.org/drawingml/2006/wordprocessingDrawing" xmlns:m="http://schemas.openxmlformats.org/officeDocument/2006/math" xmlns:w14="http://schemas.microsoft.com/office/word/2010/wordml" xmlns:w15="http://schemas.microsoft.com/office/word/2012/wordml" xmlns:w="http://schemas.openxmlformats.org/wordprocessingml/2006/main">
-            <c:ext xmlns:c16="http://schemas.microsoft.com/office/drawing/2014/chart" uri="{C3380CC4-5D6E-409C-BE32-E72D297353CC}">
-              <c16:uniqueId val="{00000002-6147-E74A-AA7B-5531F0E4EE0C}"/>
-            </c:ext>
-          </c:extLst>
-        </c:ser>
-        <c:ser>
-          <c:idx val="1"/>
-          <c:order val="1"/>
-          <c:tx>
-            <c:strRef>
-              <c:f>Sheet1!$C$1</c:f>
-              <c:strCache>
-                <c:ptCount val="1"/>
-                <c:pt idx="0">
-                  <c:v>Improved</c:v>
-                </c:pt>
-              </c:strCache>
-            </c:strRef>
-          </c:tx>
-          <c:spPr>
-            <a:solidFill>
-              <a:srgbClr val="67E77F"/>
-            </a:solidFill>
-            <a:ln w="19050">
-              <a:noFill/>
-            </a:ln>
-            <a:effectLst/>
-          </c:spPr>
-          <c:invertIfNegative val="0"/>
-          <c:cat>
-            <c:strRef>
-              <c:f>Sheet1!$A$2:$A$13</c:f>
-              <c:strCache>
-                <c:ptCount val="12"/>
-                <c:pt idx="0">
-                  <c:v>Month 1</c:v>
-                </c:pt>
-                <c:pt idx="1">
-                  <c:v>Month 2</c:v>
-                </c:pt>
-                <c:pt idx="2">
-                  <c:v>Month 3</c:v>
-                </c:pt>
-                <c:pt idx="3">
-                  <c:v>Month 4</c:v>
-                </c:pt>
-                <c:pt idx="4">
-                  <c:v>Month 5</c:v>
-                </c:pt>
-                <c:pt idx="5">
-                  <c:v>Month 6</c:v>
-                </c:pt>
-                <c:pt idx="6">
-                  <c:v>Month 7</c:v>
-                </c:pt>
-                <c:pt idx="7">
-                  <c:v>Month 8</c:v>
-                </c:pt>
-                <c:pt idx="8">
-                  <c:v>Month 9</c:v>
-                </c:pt>
-                <c:pt idx="9">
-                  <c:v>Month 10</c:v>
-                </c:pt>
-                <c:pt idx="10">
-                  <c:v>Month 11</c:v>
-                </c:pt>
-                <c:pt idx="11">
-                  <c:v>Month 12</c:v>
-                </c:pt>
-              </c:strCache>
-            </c:strRef>
-          </c:cat>
-          <c:val>
-            <c:numRef>
-              <c:f>Sheet1!$C$2:$C$13</c:f>
-              <c:numCache>
-                <c:formatCode>0.0</c:formatCode>
-                <c:ptCount val="12"/>
-                <c:pt idx="0">
-                  <c:v>0.5</c:v>
-                </c:pt>
-                <c:pt idx="1">
-                  <c:v>0.5</c:v>
-                </c:pt>
-                <c:pt idx="2">
-                  <c:v>0.5</c:v>
-                </c:pt>
-                <c:pt idx="3">
-                  <c:v>0.5</c:v>
-                </c:pt>
-                <c:pt idx="4">
-                  <c:v>0.5</c:v>
-                </c:pt>
-                <c:pt idx="5">
-                  <c:v>0.5</c:v>
-                </c:pt>
-                <c:pt idx="6">
-                  <c:v>0.5</c:v>
-                </c:pt>
-                <c:pt idx="7">
-                  <c:v>0.5</c:v>
-                </c:pt>
-                <c:pt idx="8">
-                  <c:v>0.5</c:v>
-                </c:pt>
-                <c:pt idx="9">
-                  <c:v>0.5</c:v>
-                </c:pt>
-                <c:pt idx="10">
-                  <c:v>0.5</c:v>
-                </c:pt>
-                <c:pt idx="11">
-                  <c:v>0.5</c:v>
-                </c:pt>
-              </c:numCache>
-            </c:numRef>
-          </c:val>
-          <c:extLst>
-            <c:ext xmlns:c16="http://schemas.microsoft.com/office/drawing/2014/chart" uri="{C3380CC4-5D6E-409C-BE32-E72D297353CC}">
-              <c16:uniqueId val="{00000003-6147-E74A-AA7B-5531F0E4EE0C}"/>
-            </c:ext>
-          </c:extLst>
-        </c:ser>
-        <c:ser>
-          <c:idx val="2"/>
-          <c:order val="2"/>
-          <c:tx>
-            <c:strRef>
-              <c:f>Sheet1!$D$1</c:f>
-              <c:strCache>
-                <c:ptCount val="1"/>
-                <c:pt idx="0">
-                  <c:v>Unchanged</c:v>
-                </c:pt>
-              </c:strCache>
-            </c:strRef>
-          </c:tx>
-          <c:spPr>
-            <a:solidFill>
-              <a:srgbClr val="BFC4CF"/>
-            </a:solidFill>
-            <a:ln w="19050">
-              <a:noFill/>
-            </a:ln>
-            <a:effectLst/>
-          </c:spPr>
-          <c:invertIfNegative val="0"/>
-          <c:cat>
-            <c:strRef>
-              <c:f>Sheet1!$A$2:$A$13</c:f>
-              <c:strCache>
-                <c:ptCount val="12"/>
-                <c:pt idx="0">
-                  <c:v>Month 1</c:v>
-                </c:pt>
-                <c:pt idx="1">
-                  <c:v>Month 2</c:v>
-                </c:pt>
-                <c:pt idx="2">
-                  <c:v>Month 3</c:v>
-                </c:pt>
-                <c:pt idx="3">
-                  <c:v>Month 4</c:v>
-                </c:pt>
-                <c:pt idx="4">
-                  <c:v>Month 5</c:v>
-                </c:pt>
-                <c:pt idx="5">
-                  <c:v>Month 6</c:v>
-                </c:pt>
-                <c:pt idx="6">
-                  <c:v>Month 7</c:v>
-                </c:pt>
-                <c:pt idx="7">
-                  <c:v>Month 8</c:v>
-                </c:pt>
-                <c:pt idx="8">
-                  <c:v>Month 9</c:v>
-                </c:pt>
-                <c:pt idx="9">
-                  <c:v>Month 10</c:v>
-                </c:pt>
-                <c:pt idx="10">
-                  <c:v>Month 11</c:v>
-                </c:pt>
-                <c:pt idx="11">
-                  <c:v>Month 12</c:v>
-                </c:pt>
-              </c:strCache>
-            </c:strRef>
-          </c:cat>
-          <c:val>
-            <c:numRef>
-              <c:f>Sheet1!$D$2:$D$13</c:f>
-              <c:numCache>
-                <c:formatCode>General</c:formatCode>
-                <c:ptCount val="12"/>
-                <c:pt idx="0">
-                  <c:v>0.5</c:v>
-                </c:pt>
-                <c:pt idx="1">
-                  <c:v>0.5</c:v>
-                </c:pt>
-                <c:pt idx="2">
-                  <c:v>0.5</c:v>
-                </c:pt>
-                <c:pt idx="3">
-                  <c:v>0.5</c:v>
-                </c:pt>
-                <c:pt idx="4">
-                  <c:v>0.5</c:v>
-                </c:pt>
-                <c:pt idx="5">
-                  <c:v>0.5</c:v>
-                </c:pt>
-                <c:pt idx="6">
-                  <c:v>0.5</c:v>
-                </c:pt>
-                <c:pt idx="7">
-                  <c:v>0.5</c:v>
-                </c:pt>
-                <c:pt idx="8">
-                  <c:v>0.5</c:v>
-                </c:pt>
-                <c:pt idx="9">
-                  <c:v>0.5</c:v>
-                </c:pt>
-                <c:pt idx="10">
-                  <c:v>0.5</c:v>
-                </c:pt>
-                <c:pt idx="11">
-                  <c:v>0.5</c:v>
-                </c:pt>
-              </c:numCache>
-            </c:numRef>
-          </c:val>
-          <c:extLst>
-            <c:ext xmlns:c16="http://schemas.microsoft.com/office/drawing/2014/chart" uri="{C3380CC4-5D6E-409C-BE32-E72D297353CC}">
-              <c16:uniqueId val="{00000004-6147-E74A-AA7B-5531F0E4EE0C}"/>
-            </c:ext>
-          </c:extLst>
-        </c:ser>
-        <c:ser>
-          <c:idx val="3"/>
-          <c:order val="3"/>
-          <c:tx>
-            <c:strRef>
-              <c:f>Sheet1!$E$1</c:f>
-              <c:strCache>
-                <c:ptCount val="1"/>
-                <c:pt idx="0">
-                  <c:v>Worsened</c:v>
-                </c:pt>
-              </c:strCache>
-            </c:strRef>
-          </c:tx>
-          <c:spPr>
-            <a:solidFill>
-              <a:srgbClr val="F06241"/>
-            </a:solidFill>
-            <a:ln w="19050">
-              <a:noFill/>
-            </a:ln>
-            <a:effectLst/>
-          </c:spPr>
-          <c:invertIfNegative val="0"/>
-          <c:cat>
-            <c:strRef>
-              <c:f>Sheet1!$A$2:$A$13</c:f>
-              <c:strCache>
-                <c:ptCount val="12"/>
-                <c:pt idx="0">
-                  <c:v>Month 1</c:v>
-                </c:pt>
-                <c:pt idx="1">
-                  <c:v>Month 2</c:v>
-                </c:pt>
-                <c:pt idx="2">
-                  <c:v>Month 3</c:v>
-                </c:pt>
-                <c:pt idx="3">
-                  <c:v>Month 4</c:v>
-                </c:pt>
-                <c:pt idx="4">
-                  <c:v>Month 5</c:v>
-                </c:pt>
-                <c:pt idx="5">
-                  <c:v>Month 6</c:v>
-                </c:pt>
-                <c:pt idx="6">
-                  <c:v>Month 7</c:v>
-                </c:pt>
-                <c:pt idx="7">
-                  <c:v>Month 8</c:v>
-                </c:pt>
-                <c:pt idx="8">
-                  <c:v>Month 9</c:v>
-                </c:pt>
-                <c:pt idx="9">
-                  <c:v>Month 10</c:v>
-                </c:pt>
-                <c:pt idx="10">
-                  <c:v>Month 11</c:v>
-                </c:pt>
-                <c:pt idx="11">
-                  <c:v>Month 12</c:v>
-                </c:pt>
-              </c:strCache>
-            </c:strRef>
-          </c:cat>
-          <c:val>
-            <c:numRef>
-              <c:f>Sheet1!$E$2:$E$13</c:f>
-              <c:numCache>
-                <c:formatCode>General</c:formatCode>
-                <c:ptCount val="12"/>
-                <c:pt idx="0">
-                  <c:v>0.5</c:v>
-                </c:pt>
-                <c:pt idx="1">
-                  <c:v>0.5</c:v>
-                </c:pt>
-                <c:pt idx="2">
-                  <c:v>0.5</c:v>
-                </c:pt>
-                <c:pt idx="3">
-                  <c:v>0.5</c:v>
-                </c:pt>
-                <c:pt idx="4">
-                  <c:v>0.5</c:v>
-                </c:pt>
-                <c:pt idx="5">
-                  <c:v>0.5</c:v>
-                </c:pt>
-                <c:pt idx="6">
-                  <c:v>0.5</c:v>
-                </c:pt>
-                <c:pt idx="7">
-                  <c:v>0.5</c:v>
-                </c:pt>
-                <c:pt idx="8">
-                  <c:v>0.5</c:v>
-                </c:pt>
-                <c:pt idx="9">
-                  <c:v>0.5</c:v>
-                </c:pt>
-                <c:pt idx="10">
-                  <c:v>0.5</c:v>
-                </c:pt>
-                <c:pt idx="11">
-                  <c:v>0.5</c:v>
-                </c:pt>
-              </c:numCache>
-            </c:numRef>
-          </c:val>
-          <c:extLst>
-            <c:ext xmlns:c16="http://schemas.microsoft.com/office/drawing/2014/chart" uri="{C3380CC4-5D6E-409C-BE32-E72D297353CC}">
-              <c16:uniqueId val="{00000005-6147-E74A-AA7B-5531F0E4EE0C}"/>
-            </c:ext>
-          </c:extLst>
-        </c:ser>
-        <c:ser>
-          <c:idx val="4"/>
-          <c:order val="4"/>
-          <c:tx>
-            <c:strRef>
-              <c:f>Sheet1!$F$1</c:f>
-              <c:strCache>
-                <c:ptCount val="1"/>
-                <c:pt idx="0">
-                  <c:v>Unknown</c:v>
-                </c:pt>
-              </c:strCache>
-            </c:strRef>
-          </c:tx>
-          <c:spPr>
-            <a:solidFill>
-              <a:schemeClr val="bg1"/>
-            </a:solidFill>
-            <a:ln w="19050">
-              <a:solidFill>
-                <a:schemeClr val="lt1"/>
-              </a:solidFill>
-            </a:ln>
-            <a:effectLst/>
-          </c:spPr>
-          <c:invertIfNegative val="0"/>
-          <c:cat>
-            <c:strRef>
-              <c:f>Sheet1!$A$2:$A$13</c:f>
-              <c:strCache>
-                <c:ptCount val="12"/>
-                <c:pt idx="0">
-                  <c:v>Month 1</c:v>
-                </c:pt>
-                <c:pt idx="1">
-                  <c:v>Month 2</c:v>
-                </c:pt>
-                <c:pt idx="2">
-                  <c:v>Month 3</c:v>
-                </c:pt>
-                <c:pt idx="3">
-                  <c:v>Month 4</c:v>
-                </c:pt>
-                <c:pt idx="4">
-                  <c:v>Month 5</c:v>
-                </c:pt>
-                <c:pt idx="5">
-                  <c:v>Month 6</c:v>
-                </c:pt>
-                <c:pt idx="6">
-                  <c:v>Month 7</c:v>
-                </c:pt>
-                <c:pt idx="7">
-                  <c:v>Month 8</c:v>
-                </c:pt>
-                <c:pt idx="8">
-                  <c:v>Month 9</c:v>
-                </c:pt>
-                <c:pt idx="9">
-                  <c:v>Month 10</c:v>
-                </c:pt>
-                <c:pt idx="10">
-                  <c:v>Month 11</c:v>
-                </c:pt>
-                <c:pt idx="11">
-                  <c:v>Month 12</c:v>
-                </c:pt>
-              </c:strCache>
-            </c:strRef>
-          </c:cat>
-          <c:val>
-            <c:numRef>
-              <c:f>Sheet1!$F$2:$F$13</c:f>
-              <c:numCache>
-                <c:formatCode>General</c:formatCode>
-                <c:ptCount val="12"/>
-                <c:pt idx="0">
-                  <c:v>0.5</c:v>
-                </c:pt>
-                <c:pt idx="1">
-                  <c:v>0.5</c:v>
-                </c:pt>
-                <c:pt idx="2">
-                  <c:v>0.5</c:v>
-                </c:pt>
-                <c:pt idx="3">
-                  <c:v>0.5</c:v>
-                </c:pt>
-                <c:pt idx="4">
-                  <c:v>0.5</c:v>
-                </c:pt>
-                <c:pt idx="5">
-                  <c:v>0.5</c:v>
-                </c:pt>
-                <c:pt idx="6">
-                  <c:v>0.5</c:v>
-                </c:pt>
-                <c:pt idx="7">
-                  <c:v>0.5</c:v>
-                </c:pt>
-                <c:pt idx="8">
-                  <c:v>0.5</c:v>
-                </c:pt>
-                <c:pt idx="9">
-                  <c:v>0.5</c:v>
-                </c:pt>
-                <c:pt idx="10">
-                  <c:v>0.5</c:v>
-                </c:pt>
-                <c:pt idx="11">
-                  <c:v>0.5</c:v>
-                </c:pt>
-              </c:numCache>
-            </c:numRef>
-          </c:val>
-          <c:extLst>
-            <c:ext xmlns:c16="http://schemas.microsoft.com/office/drawing/2014/chart" uri="{C3380CC4-5D6E-409C-BE32-E72D297353CC}">
-              <c16:uniqueId val="{00000006-6147-E74A-AA7B-5531F0E4EE0C}"/>
-            </c:ext>
-          </c:extLst>
-        </c:ser>
-        <c:dLbls>
-          <c:showLegendKey val="0"/>
-          <c:showVal val="0"/>
-          <c:showCatName val="0"/>
-          <c:showSerName val="0"/>
-          <c:showPercent val="0"/>
-          <c:showBubbleSize val="0"/>
-        </c:dLbls>
-        <c:gapWidth val="20"/>
-        <c:overlap val="100"/>
-        <c:axId val="476387520"/>
-        <c:axId val="477616192"/>
-      </c:barChart>
-      <c:catAx>
-        <c:axId val="476387520"/>
-        <c:scaling>
-          <c:orientation val="minMax"/>
-        </c:scaling>
-        <c:delete val="0"/>
-        <c:axPos val="b"/>
-        <c:numFmt formatCode="General" sourceLinked="1"/>
-        <c:majorTickMark val="out"/>
-        <c:minorTickMark val="none"/>
-        <c:tickLblPos val="nextTo"/>
-        <c:spPr>
-          <a:noFill/>
-          <a:ln w="9525" cap="flat" cmpd="sng" algn="ctr">
-            <a:solidFill>
-              <a:schemeClr val="tx1">
-                <a:lumMod val="15000"/>
-                <a:lumOff val="85000"/>
-              </a:schemeClr>
-            </a:solidFill>
-            <a:round/>
-          </a:ln>
-          <a:effectLst/>
-        </c:spPr>
-        <c:txPr>
-          <a:bodyPr rot="-60000000" spcFirstLastPara="1" vertOverflow="ellipsis" vert="horz" wrap="square" anchor="ctr" anchorCtr="1"/>
-          <a:lstStyle/>
-          <a:p>
-            <a:pPr>
-              <a:defRPr sz="1400" b="0" i="0" u="none" strike="noStrike" kern="1200" baseline="0">
-                <a:solidFill>
-                  <a:schemeClr val="tx2"/>
-                </a:solidFill>
-                <a:latin typeface="+mn-lt"/>
-                <a:ea typeface="+mn-ea"/>
-                <a:cs typeface="+mn-cs"/>
-              </a:defRPr>
-            </a:pPr>
-            <a:endParaRPr lang="en-NL"/>
-          </a:p>
-        </c:txPr>
-        <c:crossAx val="477616192"/>
-        <c:crosses val="autoZero"/>
-        <c:auto val="1"/>
-        <c:lblAlgn val="ctr"/>
-        <c:lblOffset val="100"/>
-        <c:noMultiLvlLbl val="0"/>
-      </c:catAx>
-      <c:valAx>
-        <c:axId val="477616192"/>
-        <c:scaling>
-          <c:orientation val="minMax"/>
-        </c:scaling>
-        <c:delete val="0"/>
-        <c:axPos val="l"/>
-        <c:majorGridlines>
-          <c:spPr>
-            <a:ln w="9525" cap="flat" cmpd="sng" algn="ctr">
-              <a:solidFill>
-                <a:schemeClr val="tx1">
-                  <a:lumMod val="15000"/>
-                  <a:lumOff val="85000"/>
-                </a:schemeClr>
-              </a:solidFill>
-              <a:round/>
-            </a:ln>
-            <a:effectLst/>
-          </c:spPr>
-        </c:majorGridlines>
-        <c:numFmt formatCode="0%" sourceLinked="0"/>
-        <c:majorTickMark val="out"/>
-        <c:minorTickMark val="none"/>
-        <c:tickLblPos val="nextTo"/>
-        <c:spPr>
-          <a:noFill/>
-          <a:ln>
-            <a:noFill/>
-          </a:ln>
-          <a:effectLst/>
-        </c:spPr>
-        <c:txPr>
-          <a:bodyPr rot="-60000000" spcFirstLastPara="1" vertOverflow="ellipsis" vert="horz" wrap="square" anchor="ctr" anchorCtr="1"/>
-          <a:lstStyle/>
-          <a:p>
-            <a:pPr>
-              <a:defRPr sz="1197" b="0" i="0" u="none" strike="noStrike" kern="1200" baseline="0">
-                <a:solidFill>
-                  <a:schemeClr val="tx2"/>
-                </a:solidFill>
-                <a:latin typeface="+mn-lt"/>
-                <a:ea typeface="+mn-ea"/>
-                <a:cs typeface="+mn-cs"/>
-              </a:defRPr>
-            </a:pPr>
-            <a:endParaRPr lang="en-US"/>
-          </a:p>
-        </c:txPr>
-        <c:crossAx val="476387520"/>
-        <c:crosses val="autoZero"/>
-        <c:crossBetween val="between"/>
-      </c:valAx>
-      <c:spPr>
-        <a:solidFill>
-          <a:srgbClr val="F0F4F8"/>
-        </a:solidFill>
-        <a:ln>
-          <a:noFill/>
-        </a:ln>
-        <a:effectLst/>
-      </c:spPr>
-    </c:plotArea>
-    <c:plotVisOnly val="1"/>
-    <c:dispBlanksAs val="gap"/>
-    <c:showDLblsOverMax val="0"/>
-    <c:extLst xmlns:lc="http://schemas.openxmlformats.org/drawingml/2006/lockedCanvas" xmlns:comp="http://schemas.openxmlformats.org/drawingml/2006/compatibility" xmlns:we="http://schemas.microsoft.com/office/webextensions/webextension/2010/11" xmlns:wetp="http://schemas.microsoft.com/office/webextensions/taskpanes/2010/11" xmlns:w16cid="http://schemas.microsoft.com/office/word/2016/wordml/cid" xmlns:w16se="http://schemas.microsoft.com/office/word/2015/wordml/symex" xmlns:wps="http://schemas.microsoft.com/office/word/2010/wordprocessingShape" xmlns:b="http://schemas.openxmlformats.org/officeDocument/2006/bibliography" xmlns:odgm="http://opendope.org/SmartArt/DataHierarchy" xmlns:odi="http://opendope.org/components" xmlns:oda="http://opendope.org/answers" xmlns:odq="http://opendope.org/questions" xmlns:odc="http://opendope.org/conditions" xmlns:odx="http://opendope.org/xpaths" xmlns:cppr="http://schemas.microsoft.com/office/2006/coverPageProps" xmlns:pvml="urn:schemas-microsoft-com:office:powerpoint" xmlns:w10="urn:schemas-microsoft-com:office:word" xmlns:v="urn:schemas-microsoft-com:vml" xmlns:o="urn:schemas-microsoft-com:office:office" xmlns:xvml="urn:schemas-microsoft-com:office:excel" xmlns:dsp="http://schemas.microsoft.com/office/drawing/2008/diagram" xmlns:xdr="http://schemas.openxmlformats.org/drawingml/2006/spreadsheetDrawing" xmlns:pic="http://schemas.openxmlformats.org/drawingml/2006/picture" xmlns:dgm="http://schemas.openxmlformats.org/drawingml/2006/diagram" xmlns:c14="http://schemas.microsoft.com/office/drawing/2007/8/2/chart" xmlns:cdr="http://schemas.openxmlformats.org/drawingml/2006/chartDrawing" xmlns:wne="http://schemas.microsoft.com/office/word/2006/wordml" xmlns:sl="http://schemas.openxmlformats.org/schemaLibrary/2006/main" xmlns:mc="http://schemas.openxmlformats.org/markup-compatibility/2006" xmlns:wp14="http://schemas.microsoft.com/office/word/2010/wordprocessingDrawing" xmlns:wp="http://schemas.openxmlformats.org/drawingml/2006/wordprocessingDrawing" xmlns:m="http://schemas.openxmlformats.org/officeDocument/2006/math" xmlns:w14="http://schemas.microsoft.com/office/word/2010/wordml" xmlns:w15="http://schemas.microsoft.com/office/word/2012/wordml" xmlns:w="http://schemas.openxmlformats.org/wordprocessingml/2006/main">
+    <c:extLst xmlns:w="http://schemas.openxmlformats.org/wordprocessingml/2006/main" xmlns:w15="http://schemas.microsoft.com/office/word/2012/wordml" xmlns:w14="http://schemas.microsoft.com/office/word/2010/wordml" xmlns:m="http://schemas.openxmlformats.org/officeDocument/2006/math" xmlns:wp="http://schemas.openxmlformats.org/drawingml/2006/wordprocessingDrawing" xmlns:wp14="http://schemas.microsoft.com/office/word/2010/wordprocessingDrawing" xmlns:mc="http://schemas.openxmlformats.org/markup-compatibility/2006" xmlns:sl="http://schemas.openxmlformats.org/schemaLibrary/2006/main" xmlns:wne="http://schemas.microsoft.com/office/word/2006/wordml" xmlns:cdr="http://schemas.openxmlformats.org/drawingml/2006/chartDrawing" xmlns:c14="http://schemas.microsoft.com/office/drawing/2007/8/2/chart" xmlns:dgm="http://schemas.openxmlformats.org/drawingml/2006/diagram" xmlns:pic="http://schemas.openxmlformats.org/drawingml/2006/picture" xmlns:xdr="http://schemas.openxmlformats.org/drawingml/2006/spreadsheetDrawing" xmlns:dsp="http://schemas.microsoft.com/office/drawing/2008/diagram" xmlns:xvml="urn:schemas-microsoft-com:office:excel" xmlns:o="urn:schemas-microsoft-com:office:office" xmlns:v="urn:schemas-microsoft-com:vml" xmlns:w10="urn:schemas-microsoft-com:office:word" xmlns:pvml="urn:schemas-microsoft-com:office:powerpoint" xmlns:cppr="http://schemas.microsoft.com/office/2006/coverPageProps" xmlns:odx="http://opendope.org/xpaths" xmlns:odc="http://opendope.org/conditions" xmlns:odq="http://opendope.org/questions" xmlns:oda="http://opendope.org/answers" xmlns:odi="http://opendope.org/components" xmlns:odgm="http://opendope.org/SmartArt/DataHierarchy" xmlns:b="http://schemas.openxmlformats.org/officeDocument/2006/bibliography" xmlns:wps="http://schemas.microsoft.com/office/word/2010/wordprocessingShape" xmlns:w16se="http://schemas.microsoft.com/office/word/2015/wordml/symex" xmlns:w16cid="http://schemas.microsoft.com/office/word/2016/wordml/cid" xmlns:wetp="http://schemas.microsoft.com/office/webextensions/taskpanes/2010/11" xmlns:we="http://schemas.microsoft.com/office/webextensions/webextension/2010/11" xmlns:comp="http://schemas.openxmlformats.org/drawingml/2006/compatibility" xmlns:lc="http://schemas.openxmlformats.org/drawingml/2006/lockedCanvas">
       <c:ext xmlns:c16r3="http://schemas.microsoft.com/office/drawing/2017/03/chart" uri="{56B9EC1D-385E-4148-901F-78D8002777C0}">
         <c16r3:dataDisplayOptions16>
           <c16r3:dispNaAsBlank val="1"/>
@@ -5716,7 +5716,7 @@
                 </a:outerShdw>
               </a:effectLst>
             </c:spPr>
-            <c:extLst xmlns:lc="http://schemas.openxmlformats.org/drawingml/2006/lockedCanvas" xmlns:comp="http://schemas.openxmlformats.org/drawingml/2006/compatibility" xmlns:we="http://schemas.microsoft.com/office/webextensions/webextension/2010/11" xmlns:wetp="http://schemas.microsoft.com/office/webextensions/taskpanes/2010/11" xmlns:w16cid="http://schemas.microsoft.com/office/word/2016/wordml/cid" xmlns:w16se="http://schemas.microsoft.com/office/word/2015/wordml/symex" xmlns:wps="http://schemas.microsoft.com/office/word/2010/wordprocessingShape" xmlns:b="http://schemas.openxmlformats.org/officeDocument/2006/bibliography" xmlns:odgm="http://opendope.org/SmartArt/DataHierarchy" xmlns:odi="http://opendope.org/components" xmlns:oda="http://opendope.org/answers" xmlns:odq="http://opendope.org/questions" xmlns:odc="http://opendope.org/conditions" xmlns:odx="http://opendope.org/xpaths" xmlns:cppr="http://schemas.microsoft.com/office/2006/coverPageProps" xmlns:pvml="urn:schemas-microsoft-com:office:powerpoint" xmlns:w10="urn:schemas-microsoft-com:office:word" xmlns:v="urn:schemas-microsoft-com:vml" xmlns:o="urn:schemas-microsoft-com:office:office" xmlns:xvml="urn:schemas-microsoft-com:office:excel" xmlns:dsp="http://schemas.microsoft.com/office/drawing/2008/diagram" xmlns:xdr="http://schemas.openxmlformats.org/drawingml/2006/spreadsheetDrawing" xmlns:pic="http://schemas.openxmlformats.org/drawingml/2006/picture" xmlns:dgm="http://schemas.openxmlformats.org/drawingml/2006/diagram" xmlns:c14="http://schemas.microsoft.com/office/drawing/2007/8/2/chart" xmlns:cdr="http://schemas.openxmlformats.org/drawingml/2006/chartDrawing" xmlns:wne="http://schemas.microsoft.com/office/word/2006/wordml" xmlns:sl="http://schemas.openxmlformats.org/schemaLibrary/2006/main" xmlns:mc="http://schemas.openxmlformats.org/markup-compatibility/2006" xmlns:wp14="http://schemas.microsoft.com/office/word/2010/wordprocessingDrawing" xmlns:wp="http://schemas.openxmlformats.org/drawingml/2006/wordprocessingDrawing" xmlns:m="http://schemas.openxmlformats.org/officeDocument/2006/math" xmlns:w14="http://schemas.microsoft.com/office/word/2010/wordml" xmlns:w15="http://schemas.microsoft.com/office/word/2012/wordml" xmlns:w="http://schemas.openxmlformats.org/wordprocessingml/2006/main">
+            <c:extLst xmlns:w="http://schemas.openxmlformats.org/wordprocessingml/2006/main" xmlns:w15="http://schemas.microsoft.com/office/word/2012/wordml" xmlns:w14="http://schemas.microsoft.com/office/word/2010/wordml" xmlns:m="http://schemas.openxmlformats.org/officeDocument/2006/math" xmlns:wp="http://schemas.openxmlformats.org/drawingml/2006/wordprocessingDrawing" xmlns:wp14="http://schemas.microsoft.com/office/word/2010/wordprocessingDrawing" xmlns:mc="http://schemas.openxmlformats.org/markup-compatibility/2006" xmlns:sl="http://schemas.openxmlformats.org/schemaLibrary/2006/main" xmlns:wne="http://schemas.microsoft.com/office/word/2006/wordml" xmlns:cdr="http://schemas.openxmlformats.org/drawingml/2006/chartDrawing" xmlns:c14="http://schemas.microsoft.com/office/drawing/2007/8/2/chart" xmlns:dgm="http://schemas.openxmlformats.org/drawingml/2006/diagram" xmlns:pic="http://schemas.openxmlformats.org/drawingml/2006/picture" xmlns:xdr="http://schemas.openxmlformats.org/drawingml/2006/spreadsheetDrawing" xmlns:dsp="http://schemas.microsoft.com/office/drawing/2008/diagram" xmlns:xvml="urn:schemas-microsoft-com:office:excel" xmlns:o="urn:schemas-microsoft-com:office:office" xmlns:v="urn:schemas-microsoft-com:vml" xmlns:w10="urn:schemas-microsoft-com:office:word" xmlns:pvml="urn:schemas-microsoft-com:office:powerpoint" xmlns:cppr="http://schemas.microsoft.com/office/2006/coverPageProps" xmlns:odx="http://opendope.org/xpaths" xmlns:odc="http://opendope.org/conditions" xmlns:odq="http://opendope.org/questions" xmlns:oda="http://opendope.org/answers" xmlns:odi="http://opendope.org/components" xmlns:odgm="http://opendope.org/SmartArt/DataHierarchy" xmlns:b="http://schemas.openxmlformats.org/officeDocument/2006/bibliography" xmlns:wps="http://schemas.microsoft.com/office/word/2010/wordprocessingShape" xmlns:w16se="http://schemas.microsoft.com/office/word/2015/wordml/symex" xmlns:w16cid="http://schemas.microsoft.com/office/word/2016/wordml/cid" xmlns:wetp="http://schemas.microsoft.com/office/webextensions/taskpanes/2010/11" xmlns:we="http://schemas.microsoft.com/office/webextensions/webextension/2010/11" xmlns:comp="http://schemas.openxmlformats.org/drawingml/2006/compatibility" xmlns:lc="http://schemas.openxmlformats.org/drawingml/2006/lockedCanvas">
               <c:ext xmlns:c16="http://schemas.microsoft.com/office/drawing/2014/chart" uri="{C3380CC4-5D6E-409C-BE32-E72D297353CC}">
                 <c16:uniqueId val="{00000001-6147-E74A-AA7B-5531F0E4EE0C}"/>
               </c:ext>
@@ -5862,7 +5862,7 @@
             </c:numRef>
           </c:val>
           <c:smooth val="0"/>
-          <c:extLst xmlns:lc="http://schemas.openxmlformats.org/drawingml/2006/lockedCanvas" xmlns:comp="http://schemas.openxmlformats.org/drawingml/2006/compatibility" xmlns:we="http://schemas.microsoft.com/office/webextensions/webextension/2010/11" xmlns:wetp="http://schemas.microsoft.com/office/webextensions/taskpanes/2010/11" xmlns:w16cid="http://schemas.microsoft.com/office/word/2016/wordml/cid" xmlns:w16se="http://schemas.microsoft.com/office/word/2015/wordml/symex" xmlns:wps="http://schemas.microsoft.com/office/word/2010/wordprocessingShape" xmlns:b="http://schemas.openxmlformats.org/officeDocument/2006/bibliography" xmlns:odgm="http://opendope.org/SmartArt/DataHierarchy" xmlns:odi="http://opendope.org/components" xmlns:oda="http://opendope.org/answers" xmlns:odq="http://opendope.org/questions" xmlns:odc="http://opendope.org/conditions" xmlns:odx="http://opendope.org/xpaths" xmlns:cppr="http://schemas.microsoft.com/office/2006/coverPageProps" xmlns:pvml="urn:schemas-microsoft-com:office:powerpoint" xmlns:w10="urn:schemas-microsoft-com:office:word" xmlns:v="urn:schemas-microsoft-com:vml" xmlns:o="urn:schemas-microsoft-com:office:office" xmlns:xvml="urn:schemas-microsoft-com:office:excel" xmlns:dsp="http://schemas.microsoft.com/office/drawing/2008/diagram" xmlns:xdr="http://schemas.openxmlformats.org/drawingml/2006/spreadsheetDrawing" xmlns:pic="http://schemas.openxmlformats.org/drawingml/2006/picture" xmlns:dgm="http://schemas.openxmlformats.org/drawingml/2006/diagram" xmlns:c14="http://schemas.microsoft.com/office/drawing/2007/8/2/chart" xmlns:cdr="http://schemas.openxmlformats.org/drawingml/2006/chartDrawing" xmlns:wne="http://schemas.microsoft.com/office/word/2006/wordml" xmlns:sl="http://schemas.openxmlformats.org/schemaLibrary/2006/main" xmlns:mc="http://schemas.openxmlformats.org/markup-compatibility/2006" xmlns:wp14="http://schemas.microsoft.com/office/word/2010/wordprocessingDrawing" xmlns:wp="http://schemas.openxmlformats.org/drawingml/2006/wordprocessingDrawing" xmlns:m="http://schemas.openxmlformats.org/officeDocument/2006/math" xmlns:w14="http://schemas.microsoft.com/office/word/2010/wordml" xmlns:w15="http://schemas.microsoft.com/office/word/2012/wordml" xmlns:w="http://schemas.openxmlformats.org/wordprocessingml/2006/main">
+          <c:extLst xmlns:w="http://schemas.openxmlformats.org/wordprocessingml/2006/main" xmlns:w15="http://schemas.microsoft.com/office/word/2012/wordml" xmlns:w14="http://schemas.microsoft.com/office/word/2010/wordml" xmlns:m="http://schemas.openxmlformats.org/officeDocument/2006/math" xmlns:wp="http://schemas.openxmlformats.org/drawingml/2006/wordprocessingDrawing" xmlns:wp14="http://schemas.microsoft.com/office/word/2010/wordprocessingDrawing" xmlns:mc="http://schemas.openxmlformats.org/markup-compatibility/2006" xmlns:sl="http://schemas.openxmlformats.org/schemaLibrary/2006/main" xmlns:wne="http://schemas.microsoft.com/office/word/2006/wordml" xmlns:cdr="http://schemas.openxmlformats.org/drawingml/2006/chartDrawing" xmlns:c14="http://schemas.microsoft.com/office/drawing/2007/8/2/chart" xmlns:dgm="http://schemas.openxmlformats.org/drawingml/2006/diagram" xmlns:pic="http://schemas.openxmlformats.org/drawingml/2006/picture" xmlns:xdr="http://schemas.openxmlformats.org/drawingml/2006/spreadsheetDrawing" xmlns:dsp="http://schemas.microsoft.com/office/drawing/2008/diagram" xmlns:xvml="urn:schemas-microsoft-com:office:excel" xmlns:o="urn:schemas-microsoft-com:office:office" xmlns:v="urn:schemas-microsoft-com:vml" xmlns:w10="urn:schemas-microsoft-com:office:word" xmlns:pvml="urn:schemas-microsoft-com:office:powerpoint" xmlns:cppr="http://schemas.microsoft.com/office/2006/coverPageProps" xmlns:odx="http://opendope.org/xpaths" xmlns:odc="http://opendope.org/conditions" xmlns:odq="http://opendope.org/questions" xmlns:oda="http://opendope.org/answers" xmlns:odi="http://opendope.org/components" xmlns:odgm="http://opendope.org/SmartArt/DataHierarchy" xmlns:b="http://schemas.openxmlformats.org/officeDocument/2006/bibliography" xmlns:wps="http://schemas.microsoft.com/office/word/2010/wordprocessingShape" xmlns:w16se="http://schemas.microsoft.com/office/word/2015/wordml/symex" xmlns:w16cid="http://schemas.microsoft.com/office/word/2016/wordml/cid" xmlns:wetp="http://schemas.microsoft.com/office/webextensions/taskpanes/2010/11" xmlns:we="http://schemas.microsoft.com/office/webextensions/webextension/2010/11" xmlns:comp="http://schemas.openxmlformats.org/drawingml/2006/compatibility" xmlns:lc="http://schemas.openxmlformats.org/drawingml/2006/lockedCanvas">
             <c:ext xmlns:c16="http://schemas.microsoft.com/office/drawing/2014/chart" uri="{C3380CC4-5D6E-409C-BE32-E72D297353CC}">
               <c16:uniqueId val="{00000002-6147-E74A-AA7B-5531F0E4EE0C}"/>
             </c:ext>
@@ -5995,7 +5995,7 @@
     <c:plotVisOnly val="1"/>
     <c:dispBlanksAs val="gap"/>
     <c:showDLblsOverMax val="0"/>
-    <c:extLst xmlns:lc="http://schemas.openxmlformats.org/drawingml/2006/lockedCanvas" xmlns:comp="http://schemas.openxmlformats.org/drawingml/2006/compatibility" xmlns:we="http://schemas.microsoft.com/office/webextensions/webextension/2010/11" xmlns:wetp="http://schemas.microsoft.com/office/webextensions/taskpanes/2010/11" xmlns:w16cid="http://schemas.microsoft.com/office/word/2016/wordml/cid" xmlns:w16se="http://schemas.microsoft.com/office/word/2015/wordml/symex" xmlns:wps="http://schemas.microsoft.com/office/word/2010/wordprocessingShape" xmlns:b="http://schemas.openxmlformats.org/officeDocument/2006/bibliography" xmlns:odgm="http://opendope.org/SmartArt/DataHierarchy" xmlns:odi="http://opendope.org/components" xmlns:oda="http://opendope.org/answers" xmlns:odq="http://opendope.org/questions" xmlns:odc="http://opendope.org/conditions" xmlns:odx="http://opendope.org/xpaths" xmlns:cppr="http://schemas.microsoft.com/office/2006/coverPageProps" xmlns:pvml="urn:schemas-microsoft-com:office:powerpoint" xmlns:w10="urn:schemas-microsoft-com:office:word" xmlns:v="urn:schemas-microsoft-com:vml" xmlns:o="urn:schemas-microsoft-com:office:office" xmlns:xvml="urn:schemas-microsoft-com:office:excel" xmlns:dsp="http://schemas.microsoft.com/office/drawing/2008/diagram" xmlns:xdr="http://schemas.openxmlformats.org/drawingml/2006/spreadsheetDrawing" xmlns:pic="http://schemas.openxmlformats.org/drawingml/2006/picture" xmlns:dgm="http://schemas.openxmlformats.org/drawingml/2006/diagram" xmlns:c14="http://schemas.microsoft.com/office/drawing/2007/8/2/chart" xmlns:cdr="http://schemas.openxmlformats.org/drawingml/2006/chartDrawing" xmlns:wne="http://schemas.microsoft.com/office/word/2006/wordml" xmlns:sl="http://schemas.openxmlformats.org/schemaLibrary/2006/main" xmlns:mc="http://schemas.openxmlformats.org/markup-compatibility/2006" xmlns:wp14="http://schemas.microsoft.com/office/word/2010/wordprocessingDrawing" xmlns:wp="http://schemas.openxmlformats.org/drawingml/2006/wordprocessingDrawing" xmlns:m="http://schemas.openxmlformats.org/officeDocument/2006/math" xmlns:w14="http://schemas.microsoft.com/office/word/2010/wordml" xmlns:w15="http://schemas.microsoft.com/office/word/2012/wordml" xmlns:w="http://schemas.openxmlformats.org/wordprocessingml/2006/main">
+    <c:extLst xmlns:w="http://schemas.openxmlformats.org/wordprocessingml/2006/main" xmlns:w15="http://schemas.microsoft.com/office/word/2012/wordml" xmlns:w14="http://schemas.microsoft.com/office/word/2010/wordml" xmlns:m="http://schemas.openxmlformats.org/officeDocument/2006/math" xmlns:wp="http://schemas.openxmlformats.org/drawingml/2006/wordprocessingDrawing" xmlns:wp14="http://schemas.microsoft.com/office/word/2010/wordprocessingDrawing" xmlns:mc="http://schemas.openxmlformats.org/markup-compatibility/2006" xmlns:sl="http://schemas.openxmlformats.org/schemaLibrary/2006/main" xmlns:wne="http://schemas.microsoft.com/office/word/2006/wordml" xmlns:cdr="http://schemas.openxmlformats.org/drawingml/2006/chartDrawing" xmlns:c14="http://schemas.microsoft.com/office/drawing/2007/8/2/chart" xmlns:dgm="http://schemas.openxmlformats.org/drawingml/2006/diagram" xmlns:pic="http://schemas.openxmlformats.org/drawingml/2006/picture" xmlns:xdr="http://schemas.openxmlformats.org/drawingml/2006/spreadsheetDrawing" xmlns:dsp="http://schemas.microsoft.com/office/drawing/2008/diagram" xmlns:xvml="urn:schemas-microsoft-com:office:excel" xmlns:o="urn:schemas-microsoft-com:office:office" xmlns:v="urn:schemas-microsoft-com:vml" xmlns:w10="urn:schemas-microsoft-com:office:word" xmlns:pvml="urn:schemas-microsoft-com:office:powerpoint" xmlns:cppr="http://schemas.microsoft.com/office/2006/coverPageProps" xmlns:odx="http://opendope.org/xpaths" xmlns:odc="http://opendope.org/conditions" xmlns:odq="http://opendope.org/questions" xmlns:oda="http://opendope.org/answers" xmlns:odi="http://opendope.org/components" xmlns:odgm="http://opendope.org/SmartArt/DataHierarchy" xmlns:b="http://schemas.openxmlformats.org/officeDocument/2006/bibliography" xmlns:wps="http://schemas.microsoft.com/office/word/2010/wordprocessingShape" xmlns:w16se="http://schemas.microsoft.com/office/word/2015/wordml/symex" xmlns:w16cid="http://schemas.microsoft.com/office/word/2016/wordml/cid" xmlns:wetp="http://schemas.microsoft.com/office/webextensions/taskpanes/2010/11" xmlns:we="http://schemas.microsoft.com/office/webextensions/webextension/2010/11" xmlns:comp="http://schemas.openxmlformats.org/drawingml/2006/compatibility" xmlns:lc="http://schemas.openxmlformats.org/drawingml/2006/lockedCanvas">
       <c:ext xmlns:c16r3="http://schemas.microsoft.com/office/drawing/2017/03/chart" uri="{56B9EC1D-385E-4148-901F-78D8002777C0}">
         <c16r3:dataDisplayOptions16>
           <c16r3:dispNaAsBlank val="1"/>
@@ -6097,7 +6097,7 @@
                 </a:outerShdw>
               </a:effectLst>
             </c:spPr>
-            <c:extLst xmlns:w="http://schemas.openxmlformats.org/wordprocessingml/2006/main" xmlns:w15="http://schemas.microsoft.com/office/word/2012/wordml" xmlns:w14="http://schemas.microsoft.com/office/word/2010/wordml" xmlns:m="http://schemas.openxmlformats.org/officeDocument/2006/math" xmlns:wp="http://schemas.openxmlformats.org/drawingml/2006/wordprocessingDrawing" xmlns:wp14="http://schemas.microsoft.com/office/word/2010/wordprocessingDrawing" xmlns:mc="http://schemas.openxmlformats.org/markup-compatibility/2006" xmlns:sl="http://schemas.openxmlformats.org/schemaLibrary/2006/main" xmlns:wne="http://schemas.microsoft.com/office/word/2006/wordml" xmlns:cdr="http://schemas.openxmlformats.org/drawingml/2006/chartDrawing" xmlns:c14="http://schemas.microsoft.com/office/drawing/2007/8/2/chart" xmlns:dgm="http://schemas.openxmlformats.org/drawingml/2006/diagram" xmlns:pic="http://schemas.openxmlformats.org/drawingml/2006/picture" xmlns:xdr="http://schemas.openxmlformats.org/drawingml/2006/spreadsheetDrawing" xmlns:dsp="http://schemas.microsoft.com/office/drawing/2008/diagram" xmlns:xvml="urn:schemas-microsoft-com:office:excel" xmlns:o="urn:schemas-microsoft-com:office:office" xmlns:v="urn:schemas-microsoft-com:vml" xmlns:w10="urn:schemas-microsoft-com:office:word" xmlns:pvml="urn:schemas-microsoft-com:office:powerpoint" xmlns:cppr="http://schemas.microsoft.com/office/2006/coverPageProps" xmlns:odx="http://opendope.org/xpaths" xmlns:odc="http://opendope.org/conditions" xmlns:odq="http://opendope.org/questions" xmlns:oda="http://opendope.org/answers" xmlns:odi="http://opendope.org/components" xmlns:odgm="http://opendope.org/SmartArt/DataHierarchy" xmlns:b="http://schemas.openxmlformats.org/officeDocument/2006/bibliography" xmlns:wps="http://schemas.microsoft.com/office/word/2010/wordprocessingShape" xmlns:w16se="http://schemas.microsoft.com/office/word/2015/wordml/symex" xmlns:w16cid="http://schemas.microsoft.com/office/word/2016/wordml/cid" xmlns:wetp="http://schemas.microsoft.com/office/webextensions/taskpanes/2010/11" xmlns:we="http://schemas.microsoft.com/office/webextensions/webextension/2010/11" xmlns:comp="http://schemas.openxmlformats.org/drawingml/2006/compatibility" xmlns:lc="http://schemas.openxmlformats.org/drawingml/2006/lockedCanvas">
+            <c:extLst xmlns:lc="http://schemas.openxmlformats.org/drawingml/2006/lockedCanvas" xmlns:comp="http://schemas.openxmlformats.org/drawingml/2006/compatibility" xmlns:we="http://schemas.microsoft.com/office/webextensions/webextension/2010/11" xmlns:wetp="http://schemas.microsoft.com/office/webextensions/taskpanes/2010/11" xmlns:w16cid="http://schemas.microsoft.com/office/word/2016/wordml/cid" xmlns:w16se="http://schemas.microsoft.com/office/word/2015/wordml/symex" xmlns:wps="http://schemas.microsoft.com/office/word/2010/wordprocessingShape" xmlns:b="http://schemas.openxmlformats.org/officeDocument/2006/bibliography" xmlns:odgm="http://opendope.org/SmartArt/DataHierarchy" xmlns:odi="http://opendope.org/components" xmlns:oda="http://opendope.org/answers" xmlns:odq="http://opendope.org/questions" xmlns:odc="http://opendope.org/conditions" xmlns:odx="http://opendope.org/xpaths" xmlns:cppr="http://schemas.microsoft.com/office/2006/coverPageProps" xmlns:pvml="urn:schemas-microsoft-com:office:powerpoint" xmlns:w10="urn:schemas-microsoft-com:office:word" xmlns:v="urn:schemas-microsoft-com:vml" xmlns:o="urn:schemas-microsoft-com:office:office" xmlns:xvml="urn:schemas-microsoft-com:office:excel" xmlns:dsp="http://schemas.microsoft.com/office/drawing/2008/diagram" xmlns:xdr="http://schemas.openxmlformats.org/drawingml/2006/spreadsheetDrawing" xmlns:pic="http://schemas.openxmlformats.org/drawingml/2006/picture" xmlns:dgm="http://schemas.openxmlformats.org/drawingml/2006/diagram" xmlns:c14="http://schemas.microsoft.com/office/drawing/2007/8/2/chart" xmlns:cdr="http://schemas.openxmlformats.org/drawingml/2006/chartDrawing" xmlns:wne="http://schemas.microsoft.com/office/word/2006/wordml" xmlns:sl="http://schemas.openxmlformats.org/schemaLibrary/2006/main" xmlns:mc="http://schemas.openxmlformats.org/markup-compatibility/2006" xmlns:wp14="http://schemas.microsoft.com/office/word/2010/wordprocessingDrawing" xmlns:wp="http://schemas.openxmlformats.org/drawingml/2006/wordprocessingDrawing" xmlns:m="http://schemas.openxmlformats.org/officeDocument/2006/math" xmlns:w14="http://schemas.microsoft.com/office/word/2010/wordml" xmlns:w15="http://schemas.microsoft.com/office/word/2012/wordml" xmlns:w="http://schemas.openxmlformats.org/wordprocessingml/2006/main">
               <c:ext xmlns:c16="http://schemas.microsoft.com/office/drawing/2014/chart" uri="{C3380CC4-5D6E-409C-BE32-E72D297353CC}">
                 <c16:uniqueId val="{00000001-6147-E74A-AA7B-5531F0E4EE0C}"/>
               </c:ext>
@@ -6236,7 +6236,7 @@
               </c:numCache>
             </c:numRef>
           </c:val>
-          <c:extLst xmlns:w="http://schemas.openxmlformats.org/wordprocessingml/2006/main" xmlns:w15="http://schemas.microsoft.com/office/word/2012/wordml" xmlns:w14="http://schemas.microsoft.com/office/word/2010/wordml" xmlns:m="http://schemas.openxmlformats.org/officeDocument/2006/math" xmlns:wp="http://schemas.openxmlformats.org/drawingml/2006/wordprocessingDrawing" xmlns:wp14="http://schemas.microsoft.com/office/word/2010/wordprocessingDrawing" xmlns:mc="http://schemas.openxmlformats.org/markup-compatibility/2006" xmlns:sl="http://schemas.openxmlformats.org/schemaLibrary/2006/main" xmlns:wne="http://schemas.microsoft.com/office/word/2006/wordml" xmlns:cdr="http://schemas.openxmlformats.org/drawingml/2006/chartDrawing" xmlns:c14="http://schemas.microsoft.com/office/drawing/2007/8/2/chart" xmlns:dgm="http://schemas.openxmlformats.org/drawingml/2006/diagram" xmlns:pic="http://schemas.openxmlformats.org/drawingml/2006/picture" xmlns:xdr="http://schemas.openxmlformats.org/drawingml/2006/spreadsheetDrawing" xmlns:dsp="http://schemas.microsoft.com/office/drawing/2008/diagram" xmlns:xvml="urn:schemas-microsoft-com:office:excel" xmlns:o="urn:schemas-microsoft-com:office:office" xmlns:v="urn:schemas-microsoft-com:vml" xmlns:w10="urn:schemas-microsoft-com:office:word" xmlns:pvml="urn:schemas-microsoft-com:office:powerpoint" xmlns:cppr="http://schemas.microsoft.com/office/2006/coverPageProps" xmlns:odx="http://opendope.org/xpaths" xmlns:odc="http://opendope.org/conditions" xmlns:odq="http://opendope.org/questions" xmlns:oda="http://opendope.org/answers" xmlns:odi="http://opendope.org/components" xmlns:odgm="http://opendope.org/SmartArt/DataHierarchy" xmlns:b="http://schemas.openxmlformats.org/officeDocument/2006/bibliography" xmlns:wps="http://schemas.microsoft.com/office/word/2010/wordprocessingShape" xmlns:w16se="http://schemas.microsoft.com/office/word/2015/wordml/symex" xmlns:w16cid="http://schemas.microsoft.com/office/word/2016/wordml/cid" xmlns:wetp="http://schemas.microsoft.com/office/webextensions/taskpanes/2010/11" xmlns:we="http://schemas.microsoft.com/office/webextensions/webextension/2010/11" xmlns:comp="http://schemas.openxmlformats.org/drawingml/2006/compatibility" xmlns:lc="http://schemas.openxmlformats.org/drawingml/2006/lockedCanvas">
+          <c:extLst xmlns:lc="http://schemas.openxmlformats.org/drawingml/2006/lockedCanvas" xmlns:comp="http://schemas.openxmlformats.org/drawingml/2006/compatibility" xmlns:we="http://schemas.microsoft.com/office/webextensions/webextension/2010/11" xmlns:wetp="http://schemas.microsoft.com/office/webextensions/taskpanes/2010/11" xmlns:w16cid="http://schemas.microsoft.com/office/word/2016/wordml/cid" xmlns:w16se="http://schemas.microsoft.com/office/word/2015/wordml/symex" xmlns:wps="http://schemas.microsoft.com/office/word/2010/wordprocessingShape" xmlns:b="http://schemas.openxmlformats.org/officeDocument/2006/bibliography" xmlns:odgm="http://opendope.org/SmartArt/DataHierarchy" xmlns:odi="http://opendope.org/components" xmlns:oda="http://opendope.org/answers" xmlns:odq="http://opendope.org/questions" xmlns:odc="http://opendope.org/conditions" xmlns:odx="http://opendope.org/xpaths" xmlns:cppr="http://schemas.microsoft.com/office/2006/coverPageProps" xmlns:pvml="urn:schemas-microsoft-com:office:powerpoint" xmlns:w10="urn:schemas-microsoft-com:office:word" xmlns:v="urn:schemas-microsoft-com:vml" xmlns:o="urn:schemas-microsoft-com:office:office" xmlns:xvml="urn:schemas-microsoft-com:office:excel" xmlns:dsp="http://schemas.microsoft.com/office/drawing/2008/diagram" xmlns:xdr="http://schemas.openxmlformats.org/drawingml/2006/spreadsheetDrawing" xmlns:pic="http://schemas.openxmlformats.org/drawingml/2006/picture" xmlns:dgm="http://schemas.openxmlformats.org/drawingml/2006/diagram" xmlns:c14="http://schemas.microsoft.com/office/drawing/2007/8/2/chart" xmlns:cdr="http://schemas.openxmlformats.org/drawingml/2006/chartDrawing" xmlns:wne="http://schemas.microsoft.com/office/word/2006/wordml" xmlns:sl="http://schemas.openxmlformats.org/schemaLibrary/2006/main" xmlns:mc="http://schemas.openxmlformats.org/markup-compatibility/2006" xmlns:wp14="http://schemas.microsoft.com/office/word/2010/wordprocessingDrawing" xmlns:wp="http://schemas.openxmlformats.org/drawingml/2006/wordprocessingDrawing" xmlns:m="http://schemas.openxmlformats.org/officeDocument/2006/math" xmlns:w14="http://schemas.microsoft.com/office/word/2010/wordml" xmlns:w15="http://schemas.microsoft.com/office/word/2012/wordml" xmlns:w="http://schemas.openxmlformats.org/wordprocessingml/2006/main">
             <c:ext xmlns:c16="http://schemas.microsoft.com/office/drawing/2014/chart" uri="{C3380CC4-5D6E-409C-BE32-E72D297353CC}">
               <c16:uniqueId val="{00000002-6147-E74A-AA7B-5531F0E4EE0C}"/>
             </c:ext>
@@ -6802,7 +6802,7 @@
     <c:plotVisOnly val="1"/>
     <c:dispBlanksAs val="gap"/>
     <c:showDLblsOverMax val="0"/>
-    <c:extLst xmlns:w="http://schemas.openxmlformats.org/wordprocessingml/2006/main" xmlns:w15="http://schemas.microsoft.com/office/word/2012/wordml" xmlns:w14="http://schemas.microsoft.com/office/word/2010/wordml" xmlns:m="http://schemas.openxmlformats.org/officeDocument/2006/math" xmlns:wp="http://schemas.openxmlformats.org/drawingml/2006/wordprocessingDrawing" xmlns:wp14="http://schemas.microsoft.com/office/word/2010/wordprocessingDrawing" xmlns:mc="http://schemas.openxmlformats.org/markup-compatibility/2006" xmlns:sl="http://schemas.openxmlformats.org/schemaLibrary/2006/main" xmlns:wne="http://schemas.microsoft.com/office/word/2006/wordml" xmlns:cdr="http://schemas.openxmlformats.org/drawingml/2006/chartDrawing" xmlns:c14="http://schemas.microsoft.com/office/drawing/2007/8/2/chart" xmlns:dgm="http://schemas.openxmlformats.org/drawingml/2006/diagram" xmlns:pic="http://schemas.openxmlformats.org/drawingml/2006/picture" xmlns:xdr="http://schemas.openxmlformats.org/drawingml/2006/spreadsheetDrawing" xmlns:dsp="http://schemas.microsoft.com/office/drawing/2008/diagram" xmlns:xvml="urn:schemas-microsoft-com:office:excel" xmlns:o="urn:schemas-microsoft-com:office:office" xmlns:v="urn:schemas-microsoft-com:vml" xmlns:w10="urn:schemas-microsoft-com:office:word" xmlns:pvml="urn:schemas-microsoft-com:office:powerpoint" xmlns:cppr="http://schemas.microsoft.com/office/2006/coverPageProps" xmlns:odx="http://opendope.org/xpaths" xmlns:odc="http://opendope.org/conditions" xmlns:odq="http://opendope.org/questions" xmlns:oda="http://opendope.org/answers" xmlns:odi="http://opendope.org/components" xmlns:odgm="http://opendope.org/SmartArt/DataHierarchy" xmlns:b="http://schemas.openxmlformats.org/officeDocument/2006/bibliography" xmlns:wps="http://schemas.microsoft.com/office/word/2010/wordprocessingShape" xmlns:w16se="http://schemas.microsoft.com/office/word/2015/wordml/symex" xmlns:w16cid="http://schemas.microsoft.com/office/word/2016/wordml/cid" xmlns:wetp="http://schemas.microsoft.com/office/webextensions/taskpanes/2010/11" xmlns:we="http://schemas.microsoft.com/office/webextensions/webextension/2010/11" xmlns:comp="http://schemas.openxmlformats.org/drawingml/2006/compatibility" xmlns:lc="http://schemas.openxmlformats.org/drawingml/2006/lockedCanvas">
+    <c:extLst xmlns:lc="http://schemas.openxmlformats.org/drawingml/2006/lockedCanvas" xmlns:comp="http://schemas.openxmlformats.org/drawingml/2006/compatibility" xmlns:we="http://schemas.microsoft.com/office/webextensions/webextension/2010/11" xmlns:wetp="http://schemas.microsoft.com/office/webextensions/taskpanes/2010/11" xmlns:w16cid="http://schemas.microsoft.com/office/word/2016/wordml/cid" xmlns:w16se="http://schemas.microsoft.com/office/word/2015/wordml/symex" xmlns:wps="http://schemas.microsoft.com/office/word/2010/wordprocessingShape" xmlns:b="http://schemas.openxmlformats.org/officeDocument/2006/bibliography" xmlns:odgm="http://opendope.org/SmartArt/DataHierarchy" xmlns:odi="http://opendope.org/components" xmlns:oda="http://opendope.org/answers" xmlns:odq="http://opendope.org/questions" xmlns:odc="http://opendope.org/conditions" xmlns:odx="http://opendope.org/xpaths" xmlns:cppr="http://schemas.microsoft.com/office/2006/coverPageProps" xmlns:pvml="urn:schemas-microsoft-com:office:powerpoint" xmlns:w10="urn:schemas-microsoft-com:office:word" xmlns:v="urn:schemas-microsoft-com:vml" xmlns:o="urn:schemas-microsoft-com:office:office" xmlns:xvml="urn:schemas-microsoft-com:office:excel" xmlns:dsp="http://schemas.microsoft.com/office/drawing/2008/diagram" xmlns:xdr="http://schemas.openxmlformats.org/drawingml/2006/spreadsheetDrawing" xmlns:pic="http://schemas.openxmlformats.org/drawingml/2006/picture" xmlns:dgm="http://schemas.openxmlformats.org/drawingml/2006/diagram" xmlns:c14="http://schemas.microsoft.com/office/drawing/2007/8/2/chart" xmlns:cdr="http://schemas.openxmlformats.org/drawingml/2006/chartDrawing" xmlns:wne="http://schemas.microsoft.com/office/word/2006/wordml" xmlns:sl="http://schemas.openxmlformats.org/schemaLibrary/2006/main" xmlns:mc="http://schemas.openxmlformats.org/markup-compatibility/2006" xmlns:wp14="http://schemas.microsoft.com/office/word/2010/wordprocessingDrawing" xmlns:wp="http://schemas.openxmlformats.org/drawingml/2006/wordprocessingDrawing" xmlns:m="http://schemas.openxmlformats.org/officeDocument/2006/math" xmlns:w14="http://schemas.microsoft.com/office/word/2010/wordml" xmlns:w15="http://schemas.microsoft.com/office/word/2012/wordml" xmlns:w="http://schemas.openxmlformats.org/wordprocessingml/2006/main">
       <c:ext xmlns:c16r3="http://schemas.microsoft.com/office/drawing/2017/03/chart" uri="{56B9EC1D-385E-4148-901F-78D8002777C0}">
         <c16r3:dataDisplayOptions16>
           <c16r3:dispNaAsBlank val="1"/>
@@ -6931,7 +6931,7 @@
                 </a:outerShdw>
               </a:effectLst>
             </c:spPr>
-            <c:extLst xmlns:lc="http://schemas.openxmlformats.org/drawingml/2006/lockedCanvas" xmlns:comp="http://schemas.openxmlformats.org/drawingml/2006/compatibility" xmlns:we="http://schemas.microsoft.com/office/webextensions/webextension/2010/11" xmlns:wetp="http://schemas.microsoft.com/office/webextensions/taskpanes/2010/11" xmlns:w16cid="http://schemas.microsoft.com/office/word/2016/wordml/cid" xmlns:w16se="http://schemas.microsoft.com/office/word/2015/wordml/symex" xmlns:wps="http://schemas.microsoft.com/office/word/2010/wordprocessingShape" xmlns:b="http://schemas.openxmlformats.org/officeDocument/2006/bibliography" xmlns:odgm="http://opendope.org/SmartArt/DataHierarchy" xmlns:odi="http://opendope.org/components" xmlns:oda="http://opendope.org/answers" xmlns:odq="http://opendope.org/questions" xmlns:odc="http://opendope.org/conditions" xmlns:odx="http://opendope.org/xpaths" xmlns:cppr="http://schemas.microsoft.com/office/2006/coverPageProps" xmlns:pvml="urn:schemas-microsoft-com:office:powerpoint" xmlns:w10="urn:schemas-microsoft-com:office:word" xmlns:v="urn:schemas-microsoft-com:vml" xmlns:o="urn:schemas-microsoft-com:office:office" xmlns:xvml="urn:schemas-microsoft-com:office:excel" xmlns:dsp="http://schemas.microsoft.com/office/drawing/2008/diagram" xmlns:xdr="http://schemas.openxmlformats.org/drawingml/2006/spreadsheetDrawing" xmlns:pic="http://schemas.openxmlformats.org/drawingml/2006/picture" xmlns:dgm="http://schemas.openxmlformats.org/drawingml/2006/diagram" xmlns:c14="http://schemas.microsoft.com/office/drawing/2007/8/2/chart" xmlns:cdr="http://schemas.openxmlformats.org/drawingml/2006/chartDrawing" xmlns:wne="http://schemas.microsoft.com/office/word/2006/wordml" xmlns:sl="http://schemas.openxmlformats.org/schemaLibrary/2006/main" xmlns:mc="http://schemas.openxmlformats.org/markup-compatibility/2006" xmlns:wp14="http://schemas.microsoft.com/office/word/2010/wordprocessingDrawing" xmlns:wp="http://schemas.openxmlformats.org/drawingml/2006/wordprocessingDrawing" xmlns:m="http://schemas.openxmlformats.org/officeDocument/2006/math" xmlns:w14="http://schemas.microsoft.com/office/word/2010/wordml" xmlns:w15="http://schemas.microsoft.com/office/word/2012/wordml" xmlns:w="http://schemas.openxmlformats.org/wordprocessingml/2006/main">
+            <c:extLst xmlns:w="http://schemas.openxmlformats.org/wordprocessingml/2006/main" xmlns:w15="http://schemas.microsoft.com/office/word/2012/wordml" xmlns:w14="http://schemas.microsoft.com/office/word/2010/wordml" xmlns:m="http://schemas.openxmlformats.org/officeDocument/2006/math" xmlns:wp="http://schemas.openxmlformats.org/drawingml/2006/wordprocessingDrawing" xmlns:wp14="http://schemas.microsoft.com/office/word/2010/wordprocessingDrawing" xmlns:mc="http://schemas.openxmlformats.org/markup-compatibility/2006" xmlns:sl="http://schemas.openxmlformats.org/schemaLibrary/2006/main" xmlns:wne="http://schemas.microsoft.com/office/word/2006/wordml" xmlns:cdr="http://schemas.openxmlformats.org/drawingml/2006/chartDrawing" xmlns:c14="http://schemas.microsoft.com/office/drawing/2007/8/2/chart" xmlns:dgm="http://schemas.openxmlformats.org/drawingml/2006/diagram" xmlns:pic="http://schemas.openxmlformats.org/drawingml/2006/picture" xmlns:xdr="http://schemas.openxmlformats.org/drawingml/2006/spreadsheetDrawing" xmlns:dsp="http://schemas.microsoft.com/office/drawing/2008/diagram" xmlns:xvml="urn:schemas-microsoft-com:office:excel" xmlns:o="urn:schemas-microsoft-com:office:office" xmlns:v="urn:schemas-microsoft-com:vml" xmlns:w10="urn:schemas-microsoft-com:office:word" xmlns:pvml="urn:schemas-microsoft-com:office:powerpoint" xmlns:cppr="http://schemas.microsoft.com/office/2006/coverPageProps" xmlns:odx="http://opendope.org/xpaths" xmlns:odc="http://opendope.org/conditions" xmlns:odq="http://opendope.org/questions" xmlns:oda="http://opendope.org/answers" xmlns:odi="http://opendope.org/components" xmlns:odgm="http://opendope.org/SmartArt/DataHierarchy" xmlns:b="http://schemas.openxmlformats.org/officeDocument/2006/bibliography" xmlns:wps="http://schemas.microsoft.com/office/word/2010/wordprocessingShape" xmlns:w16se="http://schemas.microsoft.com/office/word/2015/wordml/symex" xmlns:w16cid="http://schemas.microsoft.com/office/word/2016/wordml/cid" xmlns:wetp="http://schemas.microsoft.com/office/webextensions/taskpanes/2010/11" xmlns:we="http://schemas.microsoft.com/office/webextensions/webextension/2010/11" xmlns:comp="http://schemas.openxmlformats.org/drawingml/2006/compatibility" xmlns:lc="http://schemas.openxmlformats.org/drawingml/2006/lockedCanvas">
               <c:ext xmlns:c16="http://schemas.microsoft.com/office/drawing/2014/chart" uri="{C3380CC4-5D6E-409C-BE32-E72D297353CC}">
                 <c16:uniqueId val="{00000001-6147-E74A-AA7B-5531F0E4EE0C}"/>
               </c:ext>
@@ -7077,7 +7077,7 @@
             </c:numRef>
           </c:val>
           <c:smooth val="0"/>
-          <c:extLst xmlns:lc="http://schemas.openxmlformats.org/drawingml/2006/lockedCanvas" xmlns:comp="http://schemas.openxmlformats.org/drawingml/2006/compatibility" xmlns:we="http://schemas.microsoft.com/office/webextensions/webextension/2010/11" xmlns:wetp="http://schemas.microsoft.com/office/webextensions/taskpanes/2010/11" xmlns:w16cid="http://schemas.microsoft.com/office/word/2016/wordml/cid" xmlns:w16se="http://schemas.microsoft.com/office/word/2015/wordml/symex" xmlns:wps="http://schemas.microsoft.com/office/word/2010/wordprocessingShape" xmlns:b="http://schemas.openxmlformats.org/officeDocument/2006/bibliography" xmlns:odgm="http://opendope.org/SmartArt/DataHierarchy" xmlns:odi="http://opendope.org/components" xmlns:oda="http://opendope.org/answers" xmlns:odq="http://opendope.org/questions" xmlns:odc="http://opendope.org/conditions" xmlns:odx="http://opendope.org/xpaths" xmlns:cppr="http://schemas.microsoft.com/office/2006/coverPageProps" xmlns:pvml="urn:schemas-microsoft-com:office:powerpoint" xmlns:w10="urn:schemas-microsoft-com:office:word" xmlns:v="urn:schemas-microsoft-com:vml" xmlns:o="urn:schemas-microsoft-com:office:office" xmlns:xvml="urn:schemas-microsoft-com:office:excel" xmlns:dsp="http://schemas.microsoft.com/office/drawing/2008/diagram" xmlns:xdr="http://schemas.openxmlformats.org/drawingml/2006/spreadsheetDrawing" xmlns:pic="http://schemas.openxmlformats.org/drawingml/2006/picture" xmlns:dgm="http://schemas.openxmlformats.org/drawingml/2006/diagram" xmlns:c14="http://schemas.microsoft.com/office/drawing/2007/8/2/chart" xmlns:cdr="http://schemas.openxmlformats.org/drawingml/2006/chartDrawing" xmlns:wne="http://schemas.microsoft.com/office/word/2006/wordml" xmlns:sl="http://schemas.openxmlformats.org/schemaLibrary/2006/main" xmlns:mc="http://schemas.openxmlformats.org/markup-compatibility/2006" xmlns:wp14="http://schemas.microsoft.com/office/word/2010/wordprocessingDrawing" xmlns:wp="http://schemas.openxmlformats.org/drawingml/2006/wordprocessingDrawing" xmlns:m="http://schemas.openxmlformats.org/officeDocument/2006/math" xmlns:w14="http://schemas.microsoft.com/office/word/2010/wordml" xmlns:w15="http://schemas.microsoft.com/office/word/2012/wordml" xmlns:w="http://schemas.openxmlformats.org/wordprocessingml/2006/main">
+          <c:extLst xmlns:w="http://schemas.openxmlformats.org/wordprocessingml/2006/main" xmlns:w15="http://schemas.microsoft.com/office/word/2012/wordml" xmlns:w14="http://schemas.microsoft.com/office/word/2010/wordml" xmlns:m="http://schemas.openxmlformats.org/officeDocument/2006/math" xmlns:wp="http://schemas.openxmlformats.org/drawingml/2006/wordprocessingDrawing" xmlns:wp14="http://schemas.microsoft.com/office/word/2010/wordprocessingDrawing" xmlns:mc="http://schemas.openxmlformats.org/markup-compatibility/2006" xmlns:sl="http://schemas.openxmlformats.org/schemaLibrary/2006/main" xmlns:wne="http://schemas.microsoft.com/office/word/2006/wordml" xmlns:cdr="http://schemas.openxmlformats.org/drawingml/2006/chartDrawing" xmlns:c14="http://schemas.microsoft.com/office/drawing/2007/8/2/chart" xmlns:dgm="http://schemas.openxmlformats.org/drawingml/2006/diagram" xmlns:pic="http://schemas.openxmlformats.org/drawingml/2006/picture" xmlns:xdr="http://schemas.openxmlformats.org/drawingml/2006/spreadsheetDrawing" xmlns:dsp="http://schemas.microsoft.com/office/drawing/2008/diagram" xmlns:xvml="urn:schemas-microsoft-com:office:excel" xmlns:o="urn:schemas-microsoft-com:office:office" xmlns:v="urn:schemas-microsoft-com:vml" xmlns:w10="urn:schemas-microsoft-com:office:word" xmlns:pvml="urn:schemas-microsoft-com:office:powerpoint" xmlns:cppr="http://schemas.microsoft.com/office/2006/coverPageProps" xmlns:odx="http://opendope.org/xpaths" xmlns:odc="http://opendope.org/conditions" xmlns:odq="http://opendope.org/questions" xmlns:oda="http://opendope.org/answers" xmlns:odi="http://opendope.org/components" xmlns:odgm="http://opendope.org/SmartArt/DataHierarchy" xmlns:b="http://schemas.openxmlformats.org/officeDocument/2006/bibliography" xmlns:wps="http://schemas.microsoft.com/office/word/2010/wordprocessingShape" xmlns:w16se="http://schemas.microsoft.com/office/word/2015/wordml/symex" xmlns:w16cid="http://schemas.microsoft.com/office/word/2016/wordml/cid" xmlns:wetp="http://schemas.microsoft.com/office/webextensions/taskpanes/2010/11" xmlns:we="http://schemas.microsoft.com/office/webextensions/webextension/2010/11" xmlns:comp="http://schemas.openxmlformats.org/drawingml/2006/compatibility" xmlns:lc="http://schemas.openxmlformats.org/drawingml/2006/lockedCanvas">
             <c:ext xmlns:c16="http://schemas.microsoft.com/office/drawing/2014/chart" uri="{C3380CC4-5D6E-409C-BE32-E72D297353CC}">
               <c16:uniqueId val="{00000002-6147-E74A-AA7B-5531F0E4EE0C}"/>
             </c:ext>
@@ -7210,7 +7210,7 @@
     <c:plotVisOnly val="1"/>
     <c:dispBlanksAs val="gap"/>
     <c:showDLblsOverMax val="0"/>
-    <c:extLst xmlns:lc="http://schemas.openxmlformats.org/drawingml/2006/lockedCanvas" xmlns:comp="http://schemas.openxmlformats.org/drawingml/2006/compatibility" xmlns:we="http://schemas.microsoft.com/office/webextensions/webextension/2010/11" xmlns:wetp="http://schemas.microsoft.com/office/webextensions/taskpanes/2010/11" xmlns:w16cid="http://schemas.microsoft.com/office/word/2016/wordml/cid" xmlns:w16se="http://schemas.microsoft.com/office/word/2015/wordml/symex" xmlns:wps="http://schemas.microsoft.com/office/word/2010/wordprocessingShape" xmlns:b="http://schemas.openxmlformats.org/officeDocument/2006/bibliography" xmlns:odgm="http://opendope.org/SmartArt/DataHierarchy" xmlns:odi="http://opendope.org/components" xmlns:oda="http://opendope.org/answers" xmlns:odq="http://opendope.org/questions" xmlns:odc="http://opendope.org/conditions" xmlns:odx="http://opendope.org/xpaths" xmlns:cppr="http://schemas.microsoft.com/office/2006/coverPageProps" xmlns:pvml="urn:schemas-microsoft-com:office:powerpoint" xmlns:w10="urn:schemas-microsoft-com:office:word" xmlns:v="urn:schemas-microsoft-com:vml" xmlns:o="urn:schemas-microsoft-com:office:office" xmlns:xvml="urn:schemas-microsoft-com:office:excel" xmlns:dsp="http://schemas.microsoft.com/office/drawing/2008/diagram" xmlns:xdr="http://schemas.openxmlformats.org/drawingml/2006/spreadsheetDrawing" xmlns:pic="http://schemas.openxmlformats.org/drawingml/2006/picture" xmlns:dgm="http://schemas.openxmlformats.org/drawingml/2006/diagram" xmlns:c14="http://schemas.microsoft.com/office/drawing/2007/8/2/chart" xmlns:cdr="http://schemas.openxmlformats.org/drawingml/2006/chartDrawing" xmlns:wne="http://schemas.microsoft.com/office/word/2006/wordml" xmlns:sl="http://schemas.openxmlformats.org/schemaLibrary/2006/main" xmlns:mc="http://schemas.openxmlformats.org/markup-compatibility/2006" xmlns:wp14="http://schemas.microsoft.com/office/word/2010/wordprocessingDrawing" xmlns:wp="http://schemas.openxmlformats.org/drawingml/2006/wordprocessingDrawing" xmlns:m="http://schemas.openxmlformats.org/officeDocument/2006/math" xmlns:w14="http://schemas.microsoft.com/office/word/2010/wordml" xmlns:w15="http://schemas.microsoft.com/office/word/2012/wordml" xmlns:w="http://schemas.openxmlformats.org/wordprocessingml/2006/main">
+    <c:extLst xmlns:w="http://schemas.openxmlformats.org/wordprocessingml/2006/main" xmlns:w15="http://schemas.microsoft.com/office/word/2012/wordml" xmlns:w14="http://schemas.microsoft.com/office/word/2010/wordml" xmlns:m="http://schemas.openxmlformats.org/officeDocument/2006/math" xmlns:wp="http://schemas.openxmlformats.org/drawingml/2006/wordprocessingDrawing" xmlns:wp14="http://schemas.microsoft.com/office/word/2010/wordprocessingDrawing" xmlns:mc="http://schemas.openxmlformats.org/markup-compatibility/2006" xmlns:sl="http://schemas.openxmlformats.org/schemaLibrary/2006/main" xmlns:wne="http://schemas.microsoft.com/office/word/2006/wordml" xmlns:cdr="http://schemas.openxmlformats.org/drawingml/2006/chartDrawing" xmlns:c14="http://schemas.microsoft.com/office/drawing/2007/8/2/chart" xmlns:dgm="http://schemas.openxmlformats.org/drawingml/2006/diagram" xmlns:pic="http://schemas.openxmlformats.org/drawingml/2006/picture" xmlns:xdr="http://schemas.openxmlformats.org/drawingml/2006/spreadsheetDrawing" xmlns:dsp="http://schemas.microsoft.com/office/drawing/2008/diagram" xmlns:xvml="urn:schemas-microsoft-com:office:excel" xmlns:o="urn:schemas-microsoft-com:office:office" xmlns:v="urn:schemas-microsoft-com:vml" xmlns:w10="urn:schemas-microsoft-com:office:word" xmlns:pvml="urn:schemas-microsoft-com:office:powerpoint" xmlns:cppr="http://schemas.microsoft.com/office/2006/coverPageProps" xmlns:odx="http://opendope.org/xpaths" xmlns:odc="http://opendope.org/conditions" xmlns:odq="http://opendope.org/questions" xmlns:oda="http://opendope.org/answers" xmlns:odi="http://opendope.org/components" xmlns:odgm="http://opendope.org/SmartArt/DataHierarchy" xmlns:b="http://schemas.openxmlformats.org/officeDocument/2006/bibliography" xmlns:wps="http://schemas.microsoft.com/office/word/2010/wordprocessingShape" xmlns:w16se="http://schemas.microsoft.com/office/word/2015/wordml/symex" xmlns:w16cid="http://schemas.microsoft.com/office/word/2016/wordml/cid" xmlns:wetp="http://schemas.microsoft.com/office/webextensions/taskpanes/2010/11" xmlns:we="http://schemas.microsoft.com/office/webextensions/webextension/2010/11" xmlns:comp="http://schemas.openxmlformats.org/drawingml/2006/compatibility" xmlns:lc="http://schemas.openxmlformats.org/drawingml/2006/lockedCanvas">
       <c:ext xmlns:c16r3="http://schemas.microsoft.com/office/drawing/2017/03/chart" uri="{56B9EC1D-385E-4148-901F-78D8002777C0}">
         <c16r3:dataDisplayOptions16>
           <c16r3:dispNaAsBlank val="1"/>
@@ -7339,7 +7339,7 @@
                 </a:outerShdw>
               </a:effectLst>
             </c:spPr>
-            <c:extLst xmlns:lc="http://schemas.openxmlformats.org/drawingml/2006/lockedCanvas" xmlns:comp="http://schemas.openxmlformats.org/drawingml/2006/compatibility" xmlns:we="http://schemas.microsoft.com/office/webextensions/webextension/2010/11" xmlns:wetp="http://schemas.microsoft.com/office/webextensions/taskpanes/2010/11" xmlns:w16cid="http://schemas.microsoft.com/office/word/2016/wordml/cid" xmlns:w16se="http://schemas.microsoft.com/office/word/2015/wordml/symex" xmlns:wps="http://schemas.microsoft.com/office/word/2010/wordprocessingShape" xmlns:b="http://schemas.openxmlformats.org/officeDocument/2006/bibliography" xmlns:odgm="http://opendope.org/SmartArt/DataHierarchy" xmlns:odi="http://opendope.org/components" xmlns:oda="http://opendope.org/answers" xmlns:odq="http://opendope.org/questions" xmlns:odc="http://opendope.org/conditions" xmlns:odx="http://opendope.org/xpaths" xmlns:cppr="http://schemas.microsoft.com/office/2006/coverPageProps" xmlns:pvml="urn:schemas-microsoft-com:office:powerpoint" xmlns:w10="urn:schemas-microsoft-com:office:word" xmlns:v="urn:schemas-microsoft-com:vml" xmlns:o="urn:schemas-microsoft-com:office:office" xmlns:xvml="urn:schemas-microsoft-com:office:excel" xmlns:dsp="http://schemas.microsoft.com/office/drawing/2008/diagram" xmlns:xdr="http://schemas.openxmlformats.org/drawingml/2006/spreadsheetDrawing" xmlns:pic="http://schemas.openxmlformats.org/drawingml/2006/picture" xmlns:dgm="http://schemas.openxmlformats.org/drawingml/2006/diagram" xmlns:c14="http://schemas.microsoft.com/office/drawing/2007/8/2/chart" xmlns:cdr="http://schemas.openxmlformats.org/drawingml/2006/chartDrawing" xmlns:wne="http://schemas.microsoft.com/office/word/2006/wordml" xmlns:sl="http://schemas.openxmlformats.org/schemaLibrary/2006/main" xmlns:mc="http://schemas.openxmlformats.org/markup-compatibility/2006" xmlns:wp14="http://schemas.microsoft.com/office/word/2010/wordprocessingDrawing" xmlns:wp="http://schemas.openxmlformats.org/drawingml/2006/wordprocessingDrawing" xmlns:m="http://schemas.openxmlformats.org/officeDocument/2006/math" xmlns:w14="http://schemas.microsoft.com/office/word/2010/wordml" xmlns:w15="http://schemas.microsoft.com/office/word/2012/wordml" xmlns:w="http://schemas.openxmlformats.org/wordprocessingml/2006/main">
+            <c:extLst xmlns:w="http://schemas.openxmlformats.org/wordprocessingml/2006/main" xmlns:w15="http://schemas.microsoft.com/office/word/2012/wordml" xmlns:w14="http://schemas.microsoft.com/office/word/2010/wordml" xmlns:m="http://schemas.openxmlformats.org/officeDocument/2006/math" xmlns:wp="http://schemas.openxmlformats.org/drawingml/2006/wordprocessingDrawing" xmlns:wp14="http://schemas.microsoft.com/office/word/2010/wordprocessingDrawing" xmlns:mc="http://schemas.openxmlformats.org/markup-compatibility/2006" xmlns:sl="http://schemas.openxmlformats.org/schemaLibrary/2006/main" xmlns:wne="http://schemas.microsoft.com/office/word/2006/wordml" xmlns:cdr="http://schemas.openxmlformats.org/drawingml/2006/chartDrawing" xmlns:c14="http://schemas.microsoft.com/office/drawing/2007/8/2/chart" xmlns:dgm="http://schemas.openxmlformats.org/drawingml/2006/diagram" xmlns:pic="http://schemas.openxmlformats.org/drawingml/2006/picture" xmlns:xdr="http://schemas.openxmlformats.org/drawingml/2006/spreadsheetDrawing" xmlns:dsp="http://schemas.microsoft.com/office/drawing/2008/diagram" xmlns:xvml="urn:schemas-microsoft-com:office:excel" xmlns:o="urn:schemas-microsoft-com:office:office" xmlns:v="urn:schemas-microsoft-com:vml" xmlns:w10="urn:schemas-microsoft-com:office:word" xmlns:pvml="urn:schemas-microsoft-com:office:powerpoint" xmlns:cppr="http://schemas.microsoft.com/office/2006/coverPageProps" xmlns:odx="http://opendope.org/xpaths" xmlns:odc="http://opendope.org/conditions" xmlns:odq="http://opendope.org/questions" xmlns:oda="http://opendope.org/answers" xmlns:odi="http://opendope.org/components" xmlns:odgm="http://opendope.org/SmartArt/DataHierarchy" xmlns:b="http://schemas.openxmlformats.org/officeDocument/2006/bibliography" xmlns:wps="http://schemas.microsoft.com/office/word/2010/wordprocessingShape" xmlns:w16se="http://schemas.microsoft.com/office/word/2015/wordml/symex" xmlns:w16cid="http://schemas.microsoft.com/office/word/2016/wordml/cid" xmlns:wetp="http://schemas.microsoft.com/office/webextensions/taskpanes/2010/11" xmlns:we="http://schemas.microsoft.com/office/webextensions/webextension/2010/11" xmlns:comp="http://schemas.openxmlformats.org/drawingml/2006/compatibility" xmlns:lc="http://schemas.openxmlformats.org/drawingml/2006/lockedCanvas">
               <c:ext xmlns:c16="http://schemas.microsoft.com/office/drawing/2014/chart" uri="{C3380CC4-5D6E-409C-BE32-E72D297353CC}">
                 <c16:uniqueId val="{00000001-6147-E74A-AA7B-5531F0E4EE0C}"/>
               </c:ext>
@@ -7485,7 +7485,7 @@
             </c:numRef>
           </c:val>
           <c:smooth val="0"/>
-          <c:extLst xmlns:lc="http://schemas.openxmlformats.org/drawingml/2006/lockedCanvas" xmlns:comp="http://schemas.openxmlformats.org/drawingml/2006/compatibility" xmlns:we="http://schemas.microsoft.com/office/webextensions/webextension/2010/11" xmlns:wetp="http://schemas.microsoft.com/office/webextensions/taskpanes/2010/11" xmlns:w16cid="http://schemas.microsoft.com/office/word/2016/wordml/cid" xmlns:w16se="http://schemas.microsoft.com/office/word/2015/wordml/symex" xmlns:wps="http://schemas.microsoft.com/office/word/2010/wordprocessingShape" xmlns:b="http://schemas.openxmlformats.org/officeDocument/2006/bibliography" xmlns:odgm="http://opendope.org/SmartArt/DataHierarchy" xmlns:odi="http://opendope.org/components" xmlns:oda="http://opendope.org/answers" xmlns:odq="http://opendope.org/questions" xmlns:odc="http://opendope.org/conditions" xmlns:odx="http://opendope.org/xpaths" xmlns:cppr="http://schemas.microsoft.com/office/2006/coverPageProps" xmlns:pvml="urn:schemas-microsoft-com:office:powerpoint" xmlns:w10="urn:schemas-microsoft-com:office:word" xmlns:v="urn:schemas-microsoft-com:vml" xmlns:o="urn:schemas-microsoft-com:office:office" xmlns:xvml="urn:schemas-microsoft-com:office:excel" xmlns:dsp="http://schemas.microsoft.com/office/drawing/2008/diagram" xmlns:xdr="http://schemas.openxmlformats.org/drawingml/2006/spreadsheetDrawing" xmlns:pic="http://schemas.openxmlformats.org/drawingml/2006/picture" xmlns:dgm="http://schemas.openxmlformats.org/drawingml/2006/diagram" xmlns:c14="http://schemas.microsoft.com/office/drawing/2007/8/2/chart" xmlns:cdr="http://schemas.openxmlformats.org/drawingml/2006/chartDrawing" xmlns:wne="http://schemas.microsoft.com/office/word/2006/wordml" xmlns:sl="http://schemas.openxmlformats.org/schemaLibrary/2006/main" xmlns:mc="http://schemas.openxmlformats.org/markup-compatibility/2006" xmlns:wp14="http://schemas.microsoft.com/office/word/2010/wordprocessingDrawing" xmlns:wp="http://schemas.openxmlformats.org/drawingml/2006/wordprocessingDrawing" xmlns:m="http://schemas.openxmlformats.org/officeDocument/2006/math" xmlns:w14="http://schemas.microsoft.com/office/word/2010/wordml" xmlns:w15="http://schemas.microsoft.com/office/word/2012/wordml" xmlns:w="http://schemas.openxmlformats.org/wordprocessingml/2006/main">
+          <c:extLst xmlns:w="http://schemas.openxmlformats.org/wordprocessingml/2006/main" xmlns:w15="http://schemas.microsoft.com/office/word/2012/wordml" xmlns:w14="http://schemas.microsoft.com/office/word/2010/wordml" xmlns:m="http://schemas.openxmlformats.org/officeDocument/2006/math" xmlns:wp="http://schemas.openxmlformats.org/drawingml/2006/wordprocessingDrawing" xmlns:wp14="http://schemas.microsoft.com/office/word/2010/wordprocessingDrawing" xmlns:mc="http://schemas.openxmlformats.org/markup-compatibility/2006" xmlns:sl="http://schemas.openxmlformats.org/schemaLibrary/2006/main" xmlns:wne="http://schemas.microsoft.com/office/word/2006/wordml" xmlns:cdr="http://schemas.openxmlformats.org/drawingml/2006/chartDrawing" xmlns:c14="http://schemas.microsoft.com/office/drawing/2007/8/2/chart" xmlns:dgm="http://schemas.openxmlformats.org/drawingml/2006/diagram" xmlns:pic="http://schemas.openxmlformats.org/drawingml/2006/picture" xmlns:xdr="http://schemas.openxmlformats.org/drawingml/2006/spreadsheetDrawing" xmlns:dsp="http://schemas.microsoft.com/office/drawing/2008/diagram" xmlns:xvml="urn:schemas-microsoft-com:office:excel" xmlns:o="urn:schemas-microsoft-com:office:office" xmlns:v="urn:schemas-microsoft-com:vml" xmlns:w10="urn:schemas-microsoft-com:office:word" xmlns:pvml="urn:schemas-microsoft-com:office:powerpoint" xmlns:cppr="http://schemas.microsoft.com/office/2006/coverPageProps" xmlns:odx="http://opendope.org/xpaths" xmlns:odc="http://opendope.org/conditions" xmlns:odq="http://opendope.org/questions" xmlns:oda="http://opendope.org/answers" xmlns:odi="http://opendope.org/components" xmlns:odgm="http://opendope.org/SmartArt/DataHierarchy" xmlns:b="http://schemas.openxmlformats.org/officeDocument/2006/bibliography" xmlns:wps="http://schemas.microsoft.com/office/word/2010/wordprocessingShape" xmlns:w16se="http://schemas.microsoft.com/office/word/2015/wordml/symex" xmlns:w16cid="http://schemas.microsoft.com/office/word/2016/wordml/cid" xmlns:wetp="http://schemas.microsoft.com/office/webextensions/taskpanes/2010/11" xmlns:we="http://schemas.microsoft.com/office/webextensions/webextension/2010/11" xmlns:comp="http://schemas.openxmlformats.org/drawingml/2006/compatibility" xmlns:lc="http://schemas.openxmlformats.org/drawingml/2006/lockedCanvas">
             <c:ext xmlns:c16="http://schemas.microsoft.com/office/drawing/2014/chart" uri="{C3380CC4-5D6E-409C-BE32-E72D297353CC}">
               <c16:uniqueId val="{00000002-6147-E74A-AA7B-5531F0E4EE0C}"/>
             </c:ext>
@@ -7618,7 +7618,7 @@
     <c:plotVisOnly val="1"/>
     <c:dispBlanksAs val="gap"/>
     <c:showDLblsOverMax val="0"/>
-    <c:extLst xmlns:lc="http://schemas.openxmlformats.org/drawingml/2006/lockedCanvas" xmlns:comp="http://schemas.openxmlformats.org/drawingml/2006/compatibility" xmlns:we="http://schemas.microsoft.com/office/webextensions/webextension/2010/11" xmlns:wetp="http://schemas.microsoft.com/office/webextensions/taskpanes/2010/11" xmlns:w16cid="http://schemas.microsoft.com/office/word/2016/wordml/cid" xmlns:w16se="http://schemas.microsoft.com/office/word/2015/wordml/symex" xmlns:wps="http://schemas.microsoft.com/office/word/2010/wordprocessingShape" xmlns:b="http://schemas.openxmlformats.org/officeDocument/2006/bibliography" xmlns:odgm="http://opendope.org/SmartArt/DataHierarchy" xmlns:odi="http://opendope.org/components" xmlns:oda="http://opendope.org/answers" xmlns:odq="http://opendope.org/questions" xmlns:odc="http://opendope.org/conditions" xmlns:odx="http://opendope.org/xpaths" xmlns:cppr="http://schemas.microsoft.com/office/2006/coverPageProps" xmlns:pvml="urn:schemas-microsoft-com:office:powerpoint" xmlns:w10="urn:schemas-microsoft-com:office:word" xmlns:v="urn:schemas-microsoft-com:vml" xmlns:o="urn:schemas-microsoft-com:office:office" xmlns:xvml="urn:schemas-microsoft-com:office:excel" xmlns:dsp="http://schemas.microsoft.com/office/drawing/2008/diagram" xmlns:xdr="http://schemas.openxmlformats.org/drawingml/2006/spreadsheetDrawing" xmlns:pic="http://schemas.openxmlformats.org/drawingml/2006/picture" xmlns:dgm="http://schemas.openxmlformats.org/drawingml/2006/diagram" xmlns:c14="http://schemas.microsoft.com/office/drawing/2007/8/2/chart" xmlns:cdr="http://schemas.openxmlformats.org/drawingml/2006/chartDrawing" xmlns:wne="http://schemas.microsoft.com/office/word/2006/wordml" xmlns:sl="http://schemas.openxmlformats.org/schemaLibrary/2006/main" xmlns:mc="http://schemas.openxmlformats.org/markup-compatibility/2006" xmlns:wp14="http://schemas.microsoft.com/office/word/2010/wordprocessingDrawing" xmlns:wp="http://schemas.openxmlformats.org/drawingml/2006/wordprocessingDrawing" xmlns:m="http://schemas.openxmlformats.org/officeDocument/2006/math" xmlns:w14="http://schemas.microsoft.com/office/word/2010/wordml" xmlns:w15="http://schemas.microsoft.com/office/word/2012/wordml" xmlns:w="http://schemas.openxmlformats.org/wordprocessingml/2006/main">
+    <c:extLst xmlns:w="http://schemas.openxmlformats.org/wordprocessingml/2006/main" xmlns:w15="http://schemas.microsoft.com/office/word/2012/wordml" xmlns:w14="http://schemas.microsoft.com/office/word/2010/wordml" xmlns:m="http://schemas.openxmlformats.org/officeDocument/2006/math" xmlns:wp="http://schemas.openxmlformats.org/drawingml/2006/wordprocessingDrawing" xmlns:wp14="http://schemas.microsoft.com/office/word/2010/wordprocessingDrawing" xmlns:mc="http://schemas.openxmlformats.org/markup-compatibility/2006" xmlns:sl="http://schemas.openxmlformats.org/schemaLibrary/2006/main" xmlns:wne="http://schemas.microsoft.com/office/word/2006/wordml" xmlns:cdr="http://schemas.openxmlformats.org/drawingml/2006/chartDrawing" xmlns:c14="http://schemas.microsoft.com/office/drawing/2007/8/2/chart" xmlns:dgm="http://schemas.openxmlformats.org/drawingml/2006/diagram" xmlns:pic="http://schemas.openxmlformats.org/drawingml/2006/picture" xmlns:xdr="http://schemas.openxmlformats.org/drawingml/2006/spreadsheetDrawing" xmlns:dsp="http://schemas.microsoft.com/office/drawing/2008/diagram" xmlns:xvml="urn:schemas-microsoft-com:office:excel" xmlns:o="urn:schemas-microsoft-com:office:office" xmlns:v="urn:schemas-microsoft-com:vml" xmlns:w10="urn:schemas-microsoft-com:office:word" xmlns:pvml="urn:schemas-microsoft-com:office:powerpoint" xmlns:cppr="http://schemas.microsoft.com/office/2006/coverPageProps" xmlns:odx="http://opendope.org/xpaths" xmlns:odc="http://opendope.org/conditions" xmlns:odq="http://opendope.org/questions" xmlns:oda="http://opendope.org/answers" xmlns:odi="http://opendope.org/components" xmlns:odgm="http://opendope.org/SmartArt/DataHierarchy" xmlns:b="http://schemas.openxmlformats.org/officeDocument/2006/bibliography" xmlns:wps="http://schemas.microsoft.com/office/word/2010/wordprocessingShape" xmlns:w16se="http://schemas.microsoft.com/office/word/2015/wordml/symex" xmlns:w16cid="http://schemas.microsoft.com/office/word/2016/wordml/cid" xmlns:wetp="http://schemas.microsoft.com/office/webextensions/taskpanes/2010/11" xmlns:we="http://schemas.microsoft.com/office/webextensions/webextension/2010/11" xmlns:comp="http://schemas.openxmlformats.org/drawingml/2006/compatibility" xmlns:lc="http://schemas.openxmlformats.org/drawingml/2006/lockedCanvas">
       <c:ext xmlns:c16r3="http://schemas.microsoft.com/office/drawing/2017/03/chart" uri="{56B9EC1D-385E-4148-901F-78D8002777C0}">
         <c16r3:dataDisplayOptions16>
           <c16r3:dispNaAsBlank val="1"/>
@@ -7747,7 +7747,7 @@
                 </a:outerShdw>
               </a:effectLst>
             </c:spPr>
-            <c:extLst xmlns:lc="http://schemas.openxmlformats.org/drawingml/2006/lockedCanvas" xmlns:comp="http://schemas.openxmlformats.org/drawingml/2006/compatibility" xmlns:we="http://schemas.microsoft.com/office/webextensions/webextension/2010/11" xmlns:wetp="http://schemas.microsoft.com/office/webextensions/taskpanes/2010/11" xmlns:w16cid="http://schemas.microsoft.com/office/word/2016/wordml/cid" xmlns:w16se="http://schemas.microsoft.com/office/word/2015/wordml/symex" xmlns:wps="http://schemas.microsoft.com/office/word/2010/wordprocessingShape" xmlns:b="http://schemas.openxmlformats.org/officeDocument/2006/bibliography" xmlns:odgm="http://opendope.org/SmartArt/DataHierarchy" xmlns:odi="http://opendope.org/components" xmlns:oda="http://opendope.org/answers" xmlns:odq="http://opendope.org/questions" xmlns:odc="http://opendope.org/conditions" xmlns:odx="http://opendope.org/xpaths" xmlns:cppr="http://schemas.microsoft.com/office/2006/coverPageProps" xmlns:pvml="urn:schemas-microsoft-com:office:powerpoint" xmlns:w10="urn:schemas-microsoft-com:office:word" xmlns:v="urn:schemas-microsoft-com:vml" xmlns:o="urn:schemas-microsoft-com:office:office" xmlns:xvml="urn:schemas-microsoft-com:office:excel" xmlns:dsp="http://schemas.microsoft.com/office/drawing/2008/diagram" xmlns:xdr="http://schemas.openxmlformats.org/drawingml/2006/spreadsheetDrawing" xmlns:pic="http://schemas.openxmlformats.org/drawingml/2006/picture" xmlns:dgm="http://schemas.openxmlformats.org/drawingml/2006/diagram" xmlns:c14="http://schemas.microsoft.com/office/drawing/2007/8/2/chart" xmlns:cdr="http://schemas.openxmlformats.org/drawingml/2006/chartDrawing" xmlns:wne="http://schemas.microsoft.com/office/word/2006/wordml" xmlns:sl="http://schemas.openxmlformats.org/schemaLibrary/2006/main" xmlns:mc="http://schemas.openxmlformats.org/markup-compatibility/2006" xmlns:wp14="http://schemas.microsoft.com/office/word/2010/wordprocessingDrawing" xmlns:wp="http://schemas.openxmlformats.org/drawingml/2006/wordprocessingDrawing" xmlns:m="http://schemas.openxmlformats.org/officeDocument/2006/math" xmlns:w14="http://schemas.microsoft.com/office/word/2010/wordml" xmlns:w15="http://schemas.microsoft.com/office/word/2012/wordml" xmlns:w="http://schemas.openxmlformats.org/wordprocessingml/2006/main">
+            <c:extLst xmlns:w="http://schemas.openxmlformats.org/wordprocessingml/2006/main" xmlns:w15="http://schemas.microsoft.com/office/word/2012/wordml" xmlns:w14="http://schemas.microsoft.com/office/word/2010/wordml" xmlns:m="http://schemas.openxmlformats.org/officeDocument/2006/math" xmlns:wp="http://schemas.openxmlformats.org/drawingml/2006/wordprocessingDrawing" xmlns:wp14="http://schemas.microsoft.com/office/word/2010/wordprocessingDrawing" xmlns:mc="http://schemas.openxmlformats.org/markup-compatibility/2006" xmlns:sl="http://schemas.openxmlformats.org/schemaLibrary/2006/main" xmlns:wne="http://schemas.microsoft.com/office/word/2006/wordml" xmlns:cdr="http://schemas.openxmlformats.org/drawingml/2006/chartDrawing" xmlns:c14="http://schemas.microsoft.com/office/drawing/2007/8/2/chart" xmlns:dgm="http://schemas.openxmlformats.org/drawingml/2006/diagram" xmlns:pic="http://schemas.openxmlformats.org/drawingml/2006/picture" xmlns:xdr="http://schemas.openxmlformats.org/drawingml/2006/spreadsheetDrawing" xmlns:dsp="http://schemas.microsoft.com/office/drawing/2008/diagram" xmlns:xvml="urn:schemas-microsoft-com:office:excel" xmlns:o="urn:schemas-microsoft-com:office:office" xmlns:v="urn:schemas-microsoft-com:vml" xmlns:w10="urn:schemas-microsoft-com:office:word" xmlns:pvml="urn:schemas-microsoft-com:office:powerpoint" xmlns:cppr="http://schemas.microsoft.com/office/2006/coverPageProps" xmlns:odx="http://opendope.org/xpaths" xmlns:odc="http://opendope.org/conditions" xmlns:odq="http://opendope.org/questions" xmlns:oda="http://opendope.org/answers" xmlns:odi="http://opendope.org/components" xmlns:odgm="http://opendope.org/SmartArt/DataHierarchy" xmlns:b="http://schemas.openxmlformats.org/officeDocument/2006/bibliography" xmlns:wps="http://schemas.microsoft.com/office/word/2010/wordprocessingShape" xmlns:w16se="http://schemas.microsoft.com/office/word/2015/wordml/symex" xmlns:w16cid="http://schemas.microsoft.com/office/word/2016/wordml/cid" xmlns:wetp="http://schemas.microsoft.com/office/webextensions/taskpanes/2010/11" xmlns:we="http://schemas.microsoft.com/office/webextensions/webextension/2010/11" xmlns:comp="http://schemas.openxmlformats.org/drawingml/2006/compatibility" xmlns:lc="http://schemas.openxmlformats.org/drawingml/2006/lockedCanvas">
               <c:ext xmlns:c16="http://schemas.microsoft.com/office/drawing/2014/chart" uri="{C3380CC4-5D6E-409C-BE32-E72D297353CC}">
                 <c16:uniqueId val="{00000001-6147-E74A-AA7B-5531F0E4EE0C}"/>
               </c:ext>
@@ -7893,7 +7893,7 @@
             </c:numRef>
           </c:val>
           <c:smooth val="0"/>
-          <c:extLst xmlns:lc="http://schemas.openxmlformats.org/drawingml/2006/lockedCanvas" xmlns:comp="http://schemas.openxmlformats.org/drawingml/2006/compatibility" xmlns:we="http://schemas.microsoft.com/office/webextensions/webextension/2010/11" xmlns:wetp="http://schemas.microsoft.com/office/webextensions/taskpanes/2010/11" xmlns:w16cid="http://schemas.microsoft.com/office/word/2016/wordml/cid" xmlns:w16se="http://schemas.microsoft.com/office/word/2015/wordml/symex" xmlns:wps="http://schemas.microsoft.com/office/word/2010/wordprocessingShape" xmlns:b="http://schemas.openxmlformats.org/officeDocument/2006/bibliography" xmlns:odgm="http://opendope.org/SmartArt/DataHierarchy" xmlns:odi="http://opendope.org/components" xmlns:oda="http://opendope.org/answers" xmlns:odq="http://opendope.org/questions" xmlns:odc="http://opendope.org/conditions" xmlns:odx="http://opendope.org/xpaths" xmlns:cppr="http://schemas.microsoft.com/office/2006/coverPageProps" xmlns:pvml="urn:schemas-microsoft-com:office:powerpoint" xmlns:w10="urn:schemas-microsoft-com:office:word" xmlns:v="urn:schemas-microsoft-com:vml" xmlns:o="urn:schemas-microsoft-com:office:office" xmlns:xvml="urn:schemas-microsoft-com:office:excel" xmlns:dsp="http://schemas.microsoft.com/office/drawing/2008/diagram" xmlns:xdr="http://schemas.openxmlformats.org/drawingml/2006/spreadsheetDrawing" xmlns:pic="http://schemas.openxmlformats.org/drawingml/2006/picture" xmlns:dgm="http://schemas.openxmlformats.org/drawingml/2006/diagram" xmlns:c14="http://schemas.microsoft.com/office/drawing/2007/8/2/chart" xmlns:cdr="http://schemas.openxmlformats.org/drawingml/2006/chartDrawing" xmlns:wne="http://schemas.microsoft.com/office/word/2006/wordml" xmlns:sl="http://schemas.openxmlformats.org/schemaLibrary/2006/main" xmlns:mc="http://schemas.openxmlformats.org/markup-compatibility/2006" xmlns:wp14="http://schemas.microsoft.com/office/word/2010/wordprocessingDrawing" xmlns:wp="http://schemas.openxmlformats.org/drawingml/2006/wordprocessingDrawing" xmlns:m="http://schemas.openxmlformats.org/officeDocument/2006/math" xmlns:w14="http://schemas.microsoft.com/office/word/2010/wordml" xmlns:w15="http://schemas.microsoft.com/office/word/2012/wordml" xmlns:w="http://schemas.openxmlformats.org/wordprocessingml/2006/main">
+          <c:extLst xmlns:w="http://schemas.openxmlformats.org/wordprocessingml/2006/main" xmlns:w15="http://schemas.microsoft.com/office/word/2012/wordml" xmlns:w14="http://schemas.microsoft.com/office/word/2010/wordml" xmlns:m="http://schemas.openxmlformats.org/officeDocument/2006/math" xmlns:wp="http://schemas.openxmlformats.org/drawingml/2006/wordprocessingDrawing" xmlns:wp14="http://schemas.microsoft.com/office/word/2010/wordprocessingDrawing" xmlns:mc="http://schemas.openxmlformats.org/markup-compatibility/2006" xmlns:sl="http://schemas.openxmlformats.org/schemaLibrary/2006/main" xmlns:wne="http://schemas.microsoft.com/office/word/2006/wordml" xmlns:cdr="http://schemas.openxmlformats.org/drawingml/2006/chartDrawing" xmlns:c14="http://schemas.microsoft.com/office/drawing/2007/8/2/chart" xmlns:dgm="http://schemas.openxmlformats.org/drawingml/2006/diagram" xmlns:pic="http://schemas.openxmlformats.org/drawingml/2006/picture" xmlns:xdr="http://schemas.openxmlformats.org/drawingml/2006/spreadsheetDrawing" xmlns:dsp="http://schemas.microsoft.com/office/drawing/2008/diagram" xmlns:xvml="urn:schemas-microsoft-com:office:excel" xmlns:o="urn:schemas-microsoft-com:office:office" xmlns:v="urn:schemas-microsoft-com:vml" xmlns:w10="urn:schemas-microsoft-com:office:word" xmlns:pvml="urn:schemas-microsoft-com:office:powerpoint" xmlns:cppr="http://schemas.microsoft.com/office/2006/coverPageProps" xmlns:odx="http://opendope.org/xpaths" xmlns:odc="http://opendope.org/conditions" xmlns:odq="http://opendope.org/questions" xmlns:oda="http://opendope.org/answers" xmlns:odi="http://opendope.org/components" xmlns:odgm="http://opendope.org/SmartArt/DataHierarchy" xmlns:b="http://schemas.openxmlformats.org/officeDocument/2006/bibliography" xmlns:wps="http://schemas.microsoft.com/office/word/2010/wordprocessingShape" xmlns:w16se="http://schemas.microsoft.com/office/word/2015/wordml/symex" xmlns:w16cid="http://schemas.microsoft.com/office/word/2016/wordml/cid" xmlns:wetp="http://schemas.microsoft.com/office/webextensions/taskpanes/2010/11" xmlns:we="http://schemas.microsoft.com/office/webextensions/webextension/2010/11" xmlns:comp="http://schemas.openxmlformats.org/drawingml/2006/compatibility" xmlns:lc="http://schemas.openxmlformats.org/drawingml/2006/lockedCanvas">
             <c:ext xmlns:c16="http://schemas.microsoft.com/office/drawing/2014/chart" uri="{C3380CC4-5D6E-409C-BE32-E72D297353CC}">
               <c16:uniqueId val="{00000002-6147-E74A-AA7B-5531F0E4EE0C}"/>
             </c:ext>
@@ -8026,7 +8026,7 @@
     <c:plotVisOnly val="1"/>
     <c:dispBlanksAs val="gap"/>
     <c:showDLblsOverMax val="0"/>
-    <c:extLst xmlns:lc="http://schemas.openxmlformats.org/drawingml/2006/lockedCanvas" xmlns:comp="http://schemas.openxmlformats.org/drawingml/2006/compatibility" xmlns:we="http://schemas.microsoft.com/office/webextensions/webextension/2010/11" xmlns:wetp="http://schemas.microsoft.com/office/webextensions/taskpanes/2010/11" xmlns:w16cid="http://schemas.microsoft.com/office/word/2016/wordml/cid" xmlns:w16se="http://schemas.microsoft.com/office/word/2015/wordml/symex" xmlns:wps="http://schemas.microsoft.com/office/word/2010/wordprocessingShape" xmlns:b="http://schemas.openxmlformats.org/officeDocument/2006/bibliography" xmlns:odgm="http://opendope.org/SmartArt/DataHierarchy" xmlns:odi="http://opendope.org/components" xmlns:oda="http://opendope.org/answers" xmlns:odq="http://opendope.org/questions" xmlns:odc="http://opendope.org/conditions" xmlns:odx="http://opendope.org/xpaths" xmlns:cppr="http://schemas.microsoft.com/office/2006/coverPageProps" xmlns:pvml="urn:schemas-microsoft-com:office:powerpoint" xmlns:w10="urn:schemas-microsoft-com:office:word" xmlns:v="urn:schemas-microsoft-com:vml" xmlns:o="urn:schemas-microsoft-com:office:office" xmlns:xvml="urn:schemas-microsoft-com:office:excel" xmlns:dsp="http://schemas.microsoft.com/office/drawing/2008/diagram" xmlns:xdr="http://schemas.openxmlformats.org/drawingml/2006/spreadsheetDrawing" xmlns:pic="http://schemas.openxmlformats.org/drawingml/2006/picture" xmlns:dgm="http://schemas.openxmlformats.org/drawingml/2006/diagram" xmlns:c14="http://schemas.microsoft.com/office/drawing/2007/8/2/chart" xmlns:cdr="http://schemas.openxmlformats.org/drawingml/2006/chartDrawing" xmlns:wne="http://schemas.microsoft.com/office/word/2006/wordml" xmlns:sl="http://schemas.openxmlformats.org/schemaLibrary/2006/main" xmlns:mc="http://schemas.openxmlformats.org/markup-compatibility/2006" xmlns:wp14="http://schemas.microsoft.com/office/word/2010/wordprocessingDrawing" xmlns:wp="http://schemas.openxmlformats.org/drawingml/2006/wordprocessingDrawing" xmlns:m="http://schemas.openxmlformats.org/officeDocument/2006/math" xmlns:w14="http://schemas.microsoft.com/office/word/2010/wordml" xmlns:w15="http://schemas.microsoft.com/office/word/2012/wordml" xmlns:w="http://schemas.openxmlformats.org/wordprocessingml/2006/main">
+    <c:extLst xmlns:w="http://schemas.openxmlformats.org/wordprocessingml/2006/main" xmlns:w15="http://schemas.microsoft.com/office/word/2012/wordml" xmlns:w14="http://schemas.microsoft.com/office/word/2010/wordml" xmlns:m="http://schemas.openxmlformats.org/officeDocument/2006/math" xmlns:wp="http://schemas.openxmlformats.org/drawingml/2006/wordprocessingDrawing" xmlns:wp14="http://schemas.microsoft.com/office/word/2010/wordprocessingDrawing" xmlns:mc="http://schemas.openxmlformats.org/markup-compatibility/2006" xmlns:sl="http://schemas.openxmlformats.org/schemaLibrary/2006/main" xmlns:wne="http://schemas.microsoft.com/office/word/2006/wordml" xmlns:cdr="http://schemas.openxmlformats.org/drawingml/2006/chartDrawing" xmlns:c14="http://schemas.microsoft.com/office/drawing/2007/8/2/chart" xmlns:dgm="http://schemas.openxmlformats.org/drawingml/2006/diagram" xmlns:pic="http://schemas.openxmlformats.org/drawingml/2006/picture" xmlns:xdr="http://schemas.openxmlformats.org/drawingml/2006/spreadsheetDrawing" xmlns:dsp="http://schemas.microsoft.com/office/drawing/2008/diagram" xmlns:xvml="urn:schemas-microsoft-com:office:excel" xmlns:o="urn:schemas-microsoft-com:office:office" xmlns:v="urn:schemas-microsoft-com:vml" xmlns:w10="urn:schemas-microsoft-com:office:word" xmlns:pvml="urn:schemas-microsoft-com:office:powerpoint" xmlns:cppr="http://schemas.microsoft.com/office/2006/coverPageProps" xmlns:odx="http://opendope.org/xpaths" xmlns:odc="http://opendope.org/conditions" xmlns:odq="http://opendope.org/questions" xmlns:oda="http://opendope.org/answers" xmlns:odi="http://opendope.org/components" xmlns:odgm="http://opendope.org/SmartArt/DataHierarchy" xmlns:b="http://schemas.openxmlformats.org/officeDocument/2006/bibliography" xmlns:wps="http://schemas.microsoft.com/office/word/2010/wordprocessingShape" xmlns:w16se="http://schemas.microsoft.com/office/word/2015/wordml/symex" xmlns:w16cid="http://schemas.microsoft.com/office/word/2016/wordml/cid" xmlns:wetp="http://schemas.microsoft.com/office/webextensions/taskpanes/2010/11" xmlns:we="http://schemas.microsoft.com/office/webextensions/webextension/2010/11" xmlns:comp="http://schemas.openxmlformats.org/drawingml/2006/compatibility" xmlns:lc="http://schemas.openxmlformats.org/drawingml/2006/lockedCanvas">
       <c:ext xmlns:c16r3="http://schemas.microsoft.com/office/drawing/2017/03/chart" uri="{56B9EC1D-385E-4148-901F-78D8002777C0}">
         <c16r3:dataDisplayOptions16>
           <c16r3:dispNaAsBlank val="1"/>
@@ -8155,7 +8155,7 @@
                 </a:outerShdw>
               </a:effectLst>
             </c:spPr>
-            <c:extLst xmlns:lc="http://schemas.openxmlformats.org/drawingml/2006/lockedCanvas" xmlns:comp="http://schemas.openxmlformats.org/drawingml/2006/compatibility" xmlns:we="http://schemas.microsoft.com/office/webextensions/webextension/2010/11" xmlns:wetp="http://schemas.microsoft.com/office/webextensions/taskpanes/2010/11" xmlns:w16cid="http://schemas.microsoft.com/office/word/2016/wordml/cid" xmlns:w16se="http://schemas.microsoft.com/office/word/2015/wordml/symex" xmlns:wps="http://schemas.microsoft.com/office/word/2010/wordprocessingShape" xmlns:b="http://schemas.openxmlformats.org/officeDocument/2006/bibliography" xmlns:odgm="http://opendope.org/SmartArt/DataHierarchy" xmlns:odi="http://opendope.org/components" xmlns:oda="http://opendope.org/answers" xmlns:odq="http://opendope.org/questions" xmlns:odc="http://opendope.org/conditions" xmlns:odx="http://opendope.org/xpaths" xmlns:cppr="http://schemas.microsoft.com/office/2006/coverPageProps" xmlns:pvml="urn:schemas-microsoft-com:office:powerpoint" xmlns:w10="urn:schemas-microsoft-com:office:word" xmlns:v="urn:schemas-microsoft-com:vml" xmlns:o="urn:schemas-microsoft-com:office:office" xmlns:xvml="urn:schemas-microsoft-com:office:excel" xmlns:dsp="http://schemas.microsoft.com/office/drawing/2008/diagram" xmlns:xdr="http://schemas.openxmlformats.org/drawingml/2006/spreadsheetDrawing" xmlns:pic="http://schemas.openxmlformats.org/drawingml/2006/picture" xmlns:dgm="http://schemas.openxmlformats.org/drawingml/2006/diagram" xmlns:c14="http://schemas.microsoft.com/office/drawing/2007/8/2/chart" xmlns:cdr="http://schemas.openxmlformats.org/drawingml/2006/chartDrawing" xmlns:wne="http://schemas.microsoft.com/office/word/2006/wordml" xmlns:sl="http://schemas.openxmlformats.org/schemaLibrary/2006/main" xmlns:mc="http://schemas.openxmlformats.org/markup-compatibility/2006" xmlns:wp14="http://schemas.microsoft.com/office/word/2010/wordprocessingDrawing" xmlns:wp="http://schemas.openxmlformats.org/drawingml/2006/wordprocessingDrawing" xmlns:m="http://schemas.openxmlformats.org/officeDocument/2006/math" xmlns:w14="http://schemas.microsoft.com/office/word/2010/wordml" xmlns:w15="http://schemas.microsoft.com/office/word/2012/wordml" xmlns:w="http://schemas.openxmlformats.org/wordprocessingml/2006/main">
+            <c:extLst xmlns:w="http://schemas.openxmlformats.org/wordprocessingml/2006/main" xmlns:w15="http://schemas.microsoft.com/office/word/2012/wordml" xmlns:w14="http://schemas.microsoft.com/office/word/2010/wordml" xmlns:m="http://schemas.openxmlformats.org/officeDocument/2006/math" xmlns:wp="http://schemas.openxmlformats.org/drawingml/2006/wordprocessingDrawing" xmlns:wp14="http://schemas.microsoft.com/office/word/2010/wordprocessingDrawing" xmlns:mc="http://schemas.openxmlformats.org/markup-compatibility/2006" xmlns:sl="http://schemas.openxmlformats.org/schemaLibrary/2006/main" xmlns:wne="http://schemas.microsoft.com/office/word/2006/wordml" xmlns:cdr="http://schemas.openxmlformats.org/drawingml/2006/chartDrawing" xmlns:c14="http://schemas.microsoft.com/office/drawing/2007/8/2/chart" xmlns:dgm="http://schemas.openxmlformats.org/drawingml/2006/diagram" xmlns:pic="http://schemas.openxmlformats.org/drawingml/2006/picture" xmlns:xdr="http://schemas.openxmlformats.org/drawingml/2006/spreadsheetDrawing" xmlns:dsp="http://schemas.microsoft.com/office/drawing/2008/diagram" xmlns:xvml="urn:schemas-microsoft-com:office:excel" xmlns:o="urn:schemas-microsoft-com:office:office" xmlns:v="urn:schemas-microsoft-com:vml" xmlns:w10="urn:schemas-microsoft-com:office:word" xmlns:pvml="urn:schemas-microsoft-com:office:powerpoint" xmlns:cppr="http://schemas.microsoft.com/office/2006/coverPageProps" xmlns:odx="http://opendope.org/xpaths" xmlns:odc="http://opendope.org/conditions" xmlns:odq="http://opendope.org/questions" xmlns:oda="http://opendope.org/answers" xmlns:odi="http://opendope.org/components" xmlns:odgm="http://opendope.org/SmartArt/DataHierarchy" xmlns:b="http://schemas.openxmlformats.org/officeDocument/2006/bibliography" xmlns:wps="http://schemas.microsoft.com/office/word/2010/wordprocessingShape" xmlns:w16se="http://schemas.microsoft.com/office/word/2015/wordml/symex" xmlns:w16cid="http://schemas.microsoft.com/office/word/2016/wordml/cid" xmlns:wetp="http://schemas.microsoft.com/office/webextensions/taskpanes/2010/11" xmlns:we="http://schemas.microsoft.com/office/webextensions/webextension/2010/11" xmlns:comp="http://schemas.openxmlformats.org/drawingml/2006/compatibility" xmlns:lc="http://schemas.openxmlformats.org/drawingml/2006/lockedCanvas">
               <c:ext xmlns:c16="http://schemas.microsoft.com/office/drawing/2014/chart" uri="{C3380CC4-5D6E-409C-BE32-E72D297353CC}">
                 <c16:uniqueId val="{00000001-6147-E74A-AA7B-5531F0E4EE0C}"/>
               </c:ext>
@@ -8301,7 +8301,7 @@
             </c:numRef>
           </c:val>
           <c:smooth val="0"/>
-          <c:extLst xmlns:lc="http://schemas.openxmlformats.org/drawingml/2006/lockedCanvas" xmlns:comp="http://schemas.openxmlformats.org/drawingml/2006/compatibility" xmlns:we="http://schemas.microsoft.com/office/webextensions/webextension/2010/11" xmlns:wetp="http://schemas.microsoft.com/office/webextensions/taskpanes/2010/11" xmlns:w16cid="http://schemas.microsoft.com/office/word/2016/wordml/cid" xmlns:w16se="http://schemas.microsoft.com/office/word/2015/wordml/symex" xmlns:wps="http://schemas.microsoft.com/office/word/2010/wordprocessingShape" xmlns:b="http://schemas.openxmlformats.org/officeDocument/2006/bibliography" xmlns:odgm="http://opendope.org/SmartArt/DataHierarchy" xmlns:odi="http://opendope.org/components" xmlns:oda="http://opendope.org/answers" xmlns:odq="http://opendope.org/questions" xmlns:odc="http://opendope.org/conditions" xmlns:odx="http://opendope.org/xpaths" xmlns:cppr="http://schemas.microsoft.com/office/2006/coverPageProps" xmlns:pvml="urn:schemas-microsoft-com:office:powerpoint" xmlns:w10="urn:schemas-microsoft-com:office:word" xmlns:v="urn:schemas-microsoft-com:vml" xmlns:o="urn:schemas-microsoft-com:office:office" xmlns:xvml="urn:schemas-microsoft-com:office:excel" xmlns:dsp="http://schemas.microsoft.com/office/drawing/2008/diagram" xmlns:xdr="http://schemas.openxmlformats.org/drawingml/2006/spreadsheetDrawing" xmlns:pic="http://schemas.openxmlformats.org/drawingml/2006/picture" xmlns:dgm="http://schemas.openxmlformats.org/drawingml/2006/diagram" xmlns:c14="http://schemas.microsoft.com/office/drawing/2007/8/2/chart" xmlns:cdr="http://schemas.openxmlformats.org/drawingml/2006/chartDrawing" xmlns:wne="http://schemas.microsoft.com/office/word/2006/wordml" xmlns:sl="http://schemas.openxmlformats.org/schemaLibrary/2006/main" xmlns:mc="http://schemas.openxmlformats.org/markup-compatibility/2006" xmlns:wp14="http://schemas.microsoft.com/office/word/2010/wordprocessingDrawing" xmlns:wp="http://schemas.openxmlformats.org/drawingml/2006/wordprocessingDrawing" xmlns:m="http://schemas.openxmlformats.org/officeDocument/2006/math" xmlns:w14="http://schemas.microsoft.com/office/word/2010/wordml" xmlns:w15="http://schemas.microsoft.com/office/word/2012/wordml" xmlns:w="http://schemas.openxmlformats.org/wordprocessingml/2006/main">
+          <c:extLst xmlns:w="http://schemas.openxmlformats.org/wordprocessingml/2006/main" xmlns:w15="http://schemas.microsoft.com/office/word/2012/wordml" xmlns:w14="http://schemas.microsoft.com/office/word/2010/wordml" xmlns:m="http://schemas.openxmlformats.org/officeDocument/2006/math" xmlns:wp="http://schemas.openxmlformats.org/drawingml/2006/wordprocessingDrawing" xmlns:wp14="http://schemas.microsoft.com/office/word/2010/wordprocessingDrawing" xmlns:mc="http://schemas.openxmlformats.org/markup-compatibility/2006" xmlns:sl="http://schemas.openxmlformats.org/schemaLibrary/2006/main" xmlns:wne="http://schemas.microsoft.com/office/word/2006/wordml" xmlns:cdr="http://schemas.openxmlformats.org/drawingml/2006/chartDrawing" xmlns:c14="http://schemas.microsoft.com/office/drawing/2007/8/2/chart" xmlns:dgm="http://schemas.openxmlformats.org/drawingml/2006/diagram" xmlns:pic="http://schemas.openxmlformats.org/drawingml/2006/picture" xmlns:xdr="http://schemas.openxmlformats.org/drawingml/2006/spreadsheetDrawing" xmlns:dsp="http://schemas.microsoft.com/office/drawing/2008/diagram" xmlns:xvml="urn:schemas-microsoft-com:office:excel" xmlns:o="urn:schemas-microsoft-com:office:office" xmlns:v="urn:schemas-microsoft-com:vml" xmlns:w10="urn:schemas-microsoft-com:office:word" xmlns:pvml="urn:schemas-microsoft-com:office:powerpoint" xmlns:cppr="http://schemas.microsoft.com/office/2006/coverPageProps" xmlns:odx="http://opendope.org/xpaths" xmlns:odc="http://opendope.org/conditions" xmlns:odq="http://opendope.org/questions" xmlns:oda="http://opendope.org/answers" xmlns:odi="http://opendope.org/components" xmlns:odgm="http://opendope.org/SmartArt/DataHierarchy" xmlns:b="http://schemas.openxmlformats.org/officeDocument/2006/bibliography" xmlns:wps="http://schemas.microsoft.com/office/word/2010/wordprocessingShape" xmlns:w16se="http://schemas.microsoft.com/office/word/2015/wordml/symex" xmlns:w16cid="http://schemas.microsoft.com/office/word/2016/wordml/cid" xmlns:wetp="http://schemas.microsoft.com/office/webextensions/taskpanes/2010/11" xmlns:we="http://schemas.microsoft.com/office/webextensions/webextension/2010/11" xmlns:comp="http://schemas.openxmlformats.org/drawingml/2006/compatibility" xmlns:lc="http://schemas.openxmlformats.org/drawingml/2006/lockedCanvas">
             <c:ext xmlns:c16="http://schemas.microsoft.com/office/drawing/2014/chart" uri="{C3380CC4-5D6E-409C-BE32-E72D297353CC}">
               <c16:uniqueId val="{00000002-6147-E74A-AA7B-5531F0E4EE0C}"/>
             </c:ext>
@@ -8434,7 +8434,7 @@
     <c:plotVisOnly val="1"/>
     <c:dispBlanksAs val="gap"/>
     <c:showDLblsOverMax val="0"/>
-    <c:extLst xmlns:lc="http://schemas.openxmlformats.org/drawingml/2006/lockedCanvas" xmlns:comp="http://schemas.openxmlformats.org/drawingml/2006/compatibility" xmlns:we="http://schemas.microsoft.com/office/webextensions/webextension/2010/11" xmlns:wetp="http://schemas.microsoft.com/office/webextensions/taskpanes/2010/11" xmlns:w16cid="http://schemas.microsoft.com/office/word/2016/wordml/cid" xmlns:w16se="http://schemas.microsoft.com/office/word/2015/wordml/symex" xmlns:wps="http://schemas.microsoft.com/office/word/2010/wordprocessingShape" xmlns:b="http://schemas.openxmlformats.org/officeDocument/2006/bibliography" xmlns:odgm="http://opendope.org/SmartArt/DataHierarchy" xmlns:odi="http://opendope.org/components" xmlns:oda="http://opendope.org/answers" xmlns:odq="http://opendope.org/questions" xmlns:odc="http://opendope.org/conditions" xmlns:odx="http://opendope.org/xpaths" xmlns:cppr="http://schemas.microsoft.com/office/2006/coverPageProps" xmlns:pvml="urn:schemas-microsoft-com:office:powerpoint" xmlns:w10="urn:schemas-microsoft-com:office:word" xmlns:v="urn:schemas-microsoft-com:vml" xmlns:o="urn:schemas-microsoft-com:office:office" xmlns:xvml="urn:schemas-microsoft-com:office:excel" xmlns:dsp="http://schemas.microsoft.com/office/drawing/2008/diagram" xmlns:xdr="http://schemas.openxmlformats.org/drawingml/2006/spreadsheetDrawing" xmlns:pic="http://schemas.openxmlformats.org/drawingml/2006/picture" xmlns:dgm="http://schemas.openxmlformats.org/drawingml/2006/diagram" xmlns:c14="http://schemas.microsoft.com/office/drawing/2007/8/2/chart" xmlns:cdr="http://schemas.openxmlformats.org/drawingml/2006/chartDrawing" xmlns:wne="http://schemas.microsoft.com/office/word/2006/wordml" xmlns:sl="http://schemas.openxmlformats.org/schemaLibrary/2006/main" xmlns:mc="http://schemas.openxmlformats.org/markup-compatibility/2006" xmlns:wp14="http://schemas.microsoft.com/office/word/2010/wordprocessingDrawing" xmlns:wp="http://schemas.openxmlformats.org/drawingml/2006/wordprocessingDrawing" xmlns:m="http://schemas.openxmlformats.org/officeDocument/2006/math" xmlns:w14="http://schemas.microsoft.com/office/word/2010/wordml" xmlns:w15="http://schemas.microsoft.com/office/word/2012/wordml" xmlns:w="http://schemas.openxmlformats.org/wordprocessingml/2006/main">
+    <c:extLst xmlns:w="http://schemas.openxmlformats.org/wordprocessingml/2006/main" xmlns:w15="http://schemas.microsoft.com/office/word/2012/wordml" xmlns:w14="http://schemas.microsoft.com/office/word/2010/wordml" xmlns:m="http://schemas.openxmlformats.org/officeDocument/2006/math" xmlns:wp="http://schemas.openxmlformats.org/drawingml/2006/wordprocessingDrawing" xmlns:wp14="http://schemas.microsoft.com/office/word/2010/wordprocessingDrawing" xmlns:mc="http://schemas.openxmlformats.org/markup-compatibility/2006" xmlns:sl="http://schemas.openxmlformats.org/schemaLibrary/2006/main" xmlns:wne="http://schemas.microsoft.com/office/word/2006/wordml" xmlns:cdr="http://schemas.openxmlformats.org/drawingml/2006/chartDrawing" xmlns:c14="http://schemas.microsoft.com/office/drawing/2007/8/2/chart" xmlns:dgm="http://schemas.openxmlformats.org/drawingml/2006/diagram" xmlns:pic="http://schemas.openxmlformats.org/drawingml/2006/picture" xmlns:xdr="http://schemas.openxmlformats.org/drawingml/2006/spreadsheetDrawing" xmlns:dsp="http://schemas.microsoft.com/office/drawing/2008/diagram" xmlns:xvml="urn:schemas-microsoft-com:office:excel" xmlns:o="urn:schemas-microsoft-com:office:office" xmlns:v="urn:schemas-microsoft-com:vml" xmlns:w10="urn:schemas-microsoft-com:office:word" xmlns:pvml="urn:schemas-microsoft-com:office:powerpoint" xmlns:cppr="http://schemas.microsoft.com/office/2006/coverPageProps" xmlns:odx="http://opendope.org/xpaths" xmlns:odc="http://opendope.org/conditions" xmlns:odq="http://opendope.org/questions" xmlns:oda="http://opendope.org/answers" xmlns:odi="http://opendope.org/components" xmlns:odgm="http://opendope.org/SmartArt/DataHierarchy" xmlns:b="http://schemas.openxmlformats.org/officeDocument/2006/bibliography" xmlns:wps="http://schemas.microsoft.com/office/word/2010/wordprocessingShape" xmlns:w16se="http://schemas.microsoft.com/office/word/2015/wordml/symex" xmlns:w16cid="http://schemas.microsoft.com/office/word/2016/wordml/cid" xmlns:wetp="http://schemas.microsoft.com/office/webextensions/taskpanes/2010/11" xmlns:we="http://schemas.microsoft.com/office/webextensions/webextension/2010/11" xmlns:comp="http://schemas.openxmlformats.org/drawingml/2006/compatibility" xmlns:lc="http://schemas.openxmlformats.org/drawingml/2006/lockedCanvas">
       <c:ext xmlns:c16r3="http://schemas.microsoft.com/office/drawing/2017/03/chart" uri="{56B9EC1D-385E-4148-901F-78D8002777C0}">
         <c16r3:dataDisplayOptions16>
           <c16r3:dispNaAsBlank val="1"/>
@@ -8536,7 +8536,7 @@
                 </a:outerShdw>
               </a:effectLst>
             </c:spPr>
-            <c:extLst xmlns:lc="http://schemas.openxmlformats.org/drawingml/2006/lockedCanvas" xmlns:comp="http://schemas.openxmlformats.org/drawingml/2006/compatibility" xmlns:we="http://schemas.microsoft.com/office/webextensions/webextension/2010/11" xmlns:wetp="http://schemas.microsoft.com/office/webextensions/taskpanes/2010/11" xmlns:w16cid="http://schemas.microsoft.com/office/word/2016/wordml/cid" xmlns:w16se="http://schemas.microsoft.com/office/word/2015/wordml/symex" xmlns:wps="http://schemas.microsoft.com/office/word/2010/wordprocessingShape" xmlns:b="http://schemas.openxmlformats.org/officeDocument/2006/bibliography" xmlns:odgm="http://opendope.org/SmartArt/DataHierarchy" xmlns:odi="http://opendope.org/components" xmlns:oda="http://opendope.org/answers" xmlns:odq="http://opendope.org/questions" xmlns:odc="http://opendope.org/conditions" xmlns:odx="http://opendope.org/xpaths" xmlns:cppr="http://schemas.microsoft.com/office/2006/coverPageProps" xmlns:pvml="urn:schemas-microsoft-com:office:powerpoint" xmlns:w10="urn:schemas-microsoft-com:office:word" xmlns:v="urn:schemas-microsoft-com:vml" xmlns:o="urn:schemas-microsoft-com:office:office" xmlns:xvml="urn:schemas-microsoft-com:office:excel" xmlns:dsp="http://schemas.microsoft.com/office/drawing/2008/diagram" xmlns:xdr="http://schemas.openxmlformats.org/drawingml/2006/spreadsheetDrawing" xmlns:pic="http://schemas.openxmlformats.org/drawingml/2006/picture" xmlns:dgm="http://schemas.openxmlformats.org/drawingml/2006/diagram" xmlns:c14="http://schemas.microsoft.com/office/drawing/2007/8/2/chart" xmlns:cdr="http://schemas.openxmlformats.org/drawingml/2006/chartDrawing" xmlns:wne="http://schemas.microsoft.com/office/word/2006/wordml" xmlns:sl="http://schemas.openxmlformats.org/schemaLibrary/2006/main" xmlns:mc="http://schemas.openxmlformats.org/markup-compatibility/2006" xmlns:wp14="http://schemas.microsoft.com/office/word/2010/wordprocessingDrawing" xmlns:wp="http://schemas.openxmlformats.org/drawingml/2006/wordprocessingDrawing" xmlns:m="http://schemas.openxmlformats.org/officeDocument/2006/math" xmlns:w14="http://schemas.microsoft.com/office/word/2010/wordml" xmlns:w15="http://schemas.microsoft.com/office/word/2012/wordml" xmlns:w="http://schemas.openxmlformats.org/wordprocessingml/2006/main">
+            <c:extLst xmlns:w="http://schemas.openxmlformats.org/wordprocessingml/2006/main" xmlns:w15="http://schemas.microsoft.com/office/word/2012/wordml" xmlns:w14="http://schemas.microsoft.com/office/word/2010/wordml" xmlns:m="http://schemas.openxmlformats.org/officeDocument/2006/math" xmlns:wp="http://schemas.openxmlformats.org/drawingml/2006/wordprocessingDrawing" xmlns:wp14="http://schemas.microsoft.com/office/word/2010/wordprocessingDrawing" xmlns:mc="http://schemas.openxmlformats.org/markup-compatibility/2006" xmlns:sl="http://schemas.openxmlformats.org/schemaLibrary/2006/main" xmlns:wne="http://schemas.microsoft.com/office/word/2006/wordml" xmlns:cdr="http://schemas.openxmlformats.org/drawingml/2006/chartDrawing" xmlns:c14="http://schemas.microsoft.com/office/drawing/2007/8/2/chart" xmlns:dgm="http://schemas.openxmlformats.org/drawingml/2006/diagram" xmlns:pic="http://schemas.openxmlformats.org/drawingml/2006/picture" xmlns:xdr="http://schemas.openxmlformats.org/drawingml/2006/spreadsheetDrawing" xmlns:dsp="http://schemas.microsoft.com/office/drawing/2008/diagram" xmlns:xvml="urn:schemas-microsoft-com:office:excel" xmlns:o="urn:schemas-microsoft-com:office:office" xmlns:v="urn:schemas-microsoft-com:vml" xmlns:w10="urn:schemas-microsoft-com:office:word" xmlns:pvml="urn:schemas-microsoft-com:office:powerpoint" xmlns:cppr="http://schemas.microsoft.com/office/2006/coverPageProps" xmlns:odx="http://opendope.org/xpaths" xmlns:odc="http://opendope.org/conditions" xmlns:odq="http://opendope.org/questions" xmlns:oda="http://opendope.org/answers" xmlns:odi="http://opendope.org/components" xmlns:odgm="http://opendope.org/SmartArt/DataHierarchy" xmlns:b="http://schemas.openxmlformats.org/officeDocument/2006/bibliography" xmlns:wps="http://schemas.microsoft.com/office/word/2010/wordprocessingShape" xmlns:w16se="http://schemas.microsoft.com/office/word/2015/wordml/symex" xmlns:w16cid="http://schemas.microsoft.com/office/word/2016/wordml/cid" xmlns:wetp="http://schemas.microsoft.com/office/webextensions/taskpanes/2010/11" xmlns:we="http://schemas.microsoft.com/office/webextensions/webextension/2010/11" xmlns:comp="http://schemas.openxmlformats.org/drawingml/2006/compatibility" xmlns:lc="http://schemas.openxmlformats.org/drawingml/2006/lockedCanvas">
               <c:ext xmlns:c16="http://schemas.microsoft.com/office/drawing/2014/chart" uri="{C3380CC4-5D6E-409C-BE32-E72D297353CC}">
                 <c16:uniqueId val="{00000001-6147-E74A-AA7B-5531F0E4EE0C}"/>
               </c:ext>
@@ -8565,7 +8565,7 @@
               </c:numCache>
             </c:numRef>
           </c:val>
-          <c:extLst xmlns:lc="http://schemas.openxmlformats.org/drawingml/2006/lockedCanvas" xmlns:comp="http://schemas.openxmlformats.org/drawingml/2006/compatibility" xmlns:we="http://schemas.microsoft.com/office/webextensions/webextension/2010/11" xmlns:wetp="http://schemas.microsoft.com/office/webextensions/taskpanes/2010/11" xmlns:w16cid="http://schemas.microsoft.com/office/word/2016/wordml/cid" xmlns:w16se="http://schemas.microsoft.com/office/word/2015/wordml/symex" xmlns:wps="http://schemas.microsoft.com/office/word/2010/wordprocessingShape" xmlns:b="http://schemas.openxmlformats.org/officeDocument/2006/bibliography" xmlns:odgm="http://opendope.org/SmartArt/DataHierarchy" xmlns:odi="http://opendope.org/components" xmlns:oda="http://opendope.org/answers" xmlns:odq="http://opendope.org/questions" xmlns:odc="http://opendope.org/conditions" xmlns:odx="http://opendope.org/xpaths" xmlns:cppr="http://schemas.microsoft.com/office/2006/coverPageProps" xmlns:pvml="urn:schemas-microsoft-com:office:powerpoint" xmlns:w10="urn:schemas-microsoft-com:office:word" xmlns:v="urn:schemas-microsoft-com:vml" xmlns:o="urn:schemas-microsoft-com:office:office" xmlns:xvml="urn:schemas-microsoft-com:office:excel" xmlns:dsp="http://schemas.microsoft.com/office/drawing/2008/diagram" xmlns:xdr="http://schemas.openxmlformats.org/drawingml/2006/spreadsheetDrawing" xmlns:pic="http://schemas.openxmlformats.org/drawingml/2006/picture" xmlns:dgm="http://schemas.openxmlformats.org/drawingml/2006/diagram" xmlns:c14="http://schemas.microsoft.com/office/drawing/2007/8/2/chart" xmlns:cdr="http://schemas.openxmlformats.org/drawingml/2006/chartDrawing" xmlns:wne="http://schemas.microsoft.com/office/word/2006/wordml" xmlns:sl="http://schemas.openxmlformats.org/schemaLibrary/2006/main" xmlns:mc="http://schemas.openxmlformats.org/markup-compatibility/2006" xmlns:wp14="http://schemas.microsoft.com/office/word/2010/wordprocessingDrawing" xmlns:wp="http://schemas.openxmlformats.org/drawingml/2006/wordprocessingDrawing" xmlns:m="http://schemas.openxmlformats.org/officeDocument/2006/math" xmlns:w14="http://schemas.microsoft.com/office/word/2010/wordml" xmlns:w15="http://schemas.microsoft.com/office/word/2012/wordml" xmlns:w="http://schemas.openxmlformats.org/wordprocessingml/2006/main">
+          <c:extLst xmlns:w="http://schemas.openxmlformats.org/wordprocessingml/2006/main" xmlns:w15="http://schemas.microsoft.com/office/word/2012/wordml" xmlns:w14="http://schemas.microsoft.com/office/word/2010/wordml" xmlns:m="http://schemas.openxmlformats.org/officeDocument/2006/math" xmlns:wp="http://schemas.openxmlformats.org/drawingml/2006/wordprocessingDrawing" xmlns:wp14="http://schemas.microsoft.com/office/word/2010/wordprocessingDrawing" xmlns:mc="http://schemas.openxmlformats.org/markup-compatibility/2006" xmlns:sl="http://schemas.openxmlformats.org/schemaLibrary/2006/main" xmlns:wne="http://schemas.microsoft.com/office/word/2006/wordml" xmlns:cdr="http://schemas.openxmlformats.org/drawingml/2006/chartDrawing" xmlns:c14="http://schemas.microsoft.com/office/drawing/2007/8/2/chart" xmlns:dgm="http://schemas.openxmlformats.org/drawingml/2006/diagram" xmlns:pic="http://schemas.openxmlformats.org/drawingml/2006/picture" xmlns:xdr="http://schemas.openxmlformats.org/drawingml/2006/spreadsheetDrawing" xmlns:dsp="http://schemas.microsoft.com/office/drawing/2008/diagram" xmlns:xvml="urn:schemas-microsoft-com:office:excel" xmlns:o="urn:schemas-microsoft-com:office:office" xmlns:v="urn:schemas-microsoft-com:vml" xmlns:w10="urn:schemas-microsoft-com:office:word" xmlns:pvml="urn:schemas-microsoft-com:office:powerpoint" xmlns:cppr="http://schemas.microsoft.com/office/2006/coverPageProps" xmlns:odx="http://opendope.org/xpaths" xmlns:odc="http://opendope.org/conditions" xmlns:odq="http://opendope.org/questions" xmlns:oda="http://opendope.org/answers" xmlns:odi="http://opendope.org/components" xmlns:odgm="http://opendope.org/SmartArt/DataHierarchy" xmlns:b="http://schemas.openxmlformats.org/officeDocument/2006/bibliography" xmlns:wps="http://schemas.microsoft.com/office/word/2010/wordprocessingShape" xmlns:w16se="http://schemas.microsoft.com/office/word/2015/wordml/symex" xmlns:w16cid="http://schemas.microsoft.com/office/word/2016/wordml/cid" xmlns:wetp="http://schemas.microsoft.com/office/webextensions/taskpanes/2010/11" xmlns:we="http://schemas.microsoft.com/office/webextensions/webextension/2010/11" xmlns:comp="http://schemas.openxmlformats.org/drawingml/2006/compatibility" xmlns:lc="http://schemas.openxmlformats.org/drawingml/2006/lockedCanvas">
             <c:ext xmlns:c16="http://schemas.microsoft.com/office/drawing/2014/chart" uri="{C3380CC4-5D6E-409C-BE32-E72D297353CC}">
               <c16:uniqueId val="{00000002-6147-E74A-AA7B-5531F0E4EE0C}"/>
             </c:ext>
@@ -8882,7 +8882,7 @@
     <c:plotVisOnly val="1"/>
     <c:dispBlanksAs val="gap"/>
     <c:showDLblsOverMax val="0"/>
-    <c:extLst xmlns:lc="http://schemas.openxmlformats.org/drawingml/2006/lockedCanvas" xmlns:comp="http://schemas.openxmlformats.org/drawingml/2006/compatibility" xmlns:we="http://schemas.microsoft.com/office/webextensions/webextension/2010/11" xmlns:wetp="http://schemas.microsoft.com/office/webextensions/taskpanes/2010/11" xmlns:w16cid="http://schemas.microsoft.com/office/word/2016/wordml/cid" xmlns:w16se="http://schemas.microsoft.com/office/word/2015/wordml/symex" xmlns:wps="http://schemas.microsoft.com/office/word/2010/wordprocessingShape" xmlns:b="http://schemas.openxmlformats.org/officeDocument/2006/bibliography" xmlns:odgm="http://opendope.org/SmartArt/DataHierarchy" xmlns:odi="http://opendope.org/components" xmlns:oda="http://opendope.org/answers" xmlns:odq="http://opendope.org/questions" xmlns:odc="http://opendope.org/conditions" xmlns:odx="http://opendope.org/xpaths" xmlns:cppr="http://schemas.microsoft.com/office/2006/coverPageProps" xmlns:pvml="urn:schemas-microsoft-com:office:powerpoint" xmlns:w10="urn:schemas-microsoft-com:office:word" xmlns:v="urn:schemas-microsoft-com:vml" xmlns:o="urn:schemas-microsoft-com:office:office" xmlns:xvml="urn:schemas-microsoft-com:office:excel" xmlns:dsp="http://schemas.microsoft.com/office/drawing/2008/diagram" xmlns:xdr="http://schemas.openxmlformats.org/drawingml/2006/spreadsheetDrawing" xmlns:pic="http://schemas.openxmlformats.org/drawingml/2006/picture" xmlns:dgm="http://schemas.openxmlformats.org/drawingml/2006/diagram" xmlns:c14="http://schemas.microsoft.com/office/drawing/2007/8/2/chart" xmlns:cdr="http://schemas.openxmlformats.org/drawingml/2006/chartDrawing" xmlns:wne="http://schemas.microsoft.com/office/word/2006/wordml" xmlns:sl="http://schemas.openxmlformats.org/schemaLibrary/2006/main" xmlns:mc="http://schemas.openxmlformats.org/markup-compatibility/2006" xmlns:wp14="http://schemas.microsoft.com/office/word/2010/wordprocessingDrawing" xmlns:wp="http://schemas.openxmlformats.org/drawingml/2006/wordprocessingDrawing" xmlns:m="http://schemas.openxmlformats.org/officeDocument/2006/math" xmlns:w14="http://schemas.microsoft.com/office/word/2010/wordml" xmlns:w15="http://schemas.microsoft.com/office/word/2012/wordml" xmlns:w="http://schemas.openxmlformats.org/wordprocessingml/2006/main">
+    <c:extLst xmlns:w="http://schemas.openxmlformats.org/wordprocessingml/2006/main" xmlns:w15="http://schemas.microsoft.com/office/word/2012/wordml" xmlns:w14="http://schemas.microsoft.com/office/word/2010/wordml" xmlns:m="http://schemas.openxmlformats.org/officeDocument/2006/math" xmlns:wp="http://schemas.openxmlformats.org/drawingml/2006/wordprocessingDrawing" xmlns:wp14="http://schemas.microsoft.com/office/word/2010/wordprocessingDrawing" xmlns:mc="http://schemas.openxmlformats.org/markup-compatibility/2006" xmlns:sl="http://schemas.openxmlformats.org/schemaLibrary/2006/main" xmlns:wne="http://schemas.microsoft.com/office/word/2006/wordml" xmlns:cdr="http://schemas.openxmlformats.org/drawingml/2006/chartDrawing" xmlns:c14="http://schemas.microsoft.com/office/drawing/2007/8/2/chart" xmlns:dgm="http://schemas.openxmlformats.org/drawingml/2006/diagram" xmlns:pic="http://schemas.openxmlformats.org/drawingml/2006/picture" xmlns:xdr="http://schemas.openxmlformats.org/drawingml/2006/spreadsheetDrawing" xmlns:dsp="http://schemas.microsoft.com/office/drawing/2008/diagram" xmlns:xvml="urn:schemas-microsoft-com:office:excel" xmlns:o="urn:schemas-microsoft-com:office:office" xmlns:v="urn:schemas-microsoft-com:vml" xmlns:w10="urn:schemas-microsoft-com:office:word" xmlns:pvml="urn:schemas-microsoft-com:office:powerpoint" xmlns:cppr="http://schemas.microsoft.com/office/2006/coverPageProps" xmlns:odx="http://opendope.org/xpaths" xmlns:odc="http://opendope.org/conditions" xmlns:odq="http://opendope.org/questions" xmlns:oda="http://opendope.org/answers" xmlns:odi="http://opendope.org/components" xmlns:odgm="http://opendope.org/SmartArt/DataHierarchy" xmlns:b="http://schemas.openxmlformats.org/officeDocument/2006/bibliography" xmlns:wps="http://schemas.microsoft.com/office/word/2010/wordprocessingShape" xmlns:w16se="http://schemas.microsoft.com/office/word/2015/wordml/symex" xmlns:w16cid="http://schemas.microsoft.com/office/word/2016/wordml/cid" xmlns:wetp="http://schemas.microsoft.com/office/webextensions/taskpanes/2010/11" xmlns:we="http://schemas.microsoft.com/office/webextensions/webextension/2010/11" xmlns:comp="http://schemas.openxmlformats.org/drawingml/2006/compatibility" xmlns:lc="http://schemas.openxmlformats.org/drawingml/2006/lockedCanvas">
       <c:ext xmlns:c16r3="http://schemas.microsoft.com/office/drawing/2017/03/chart" uri="{56B9EC1D-385E-4148-901F-78D8002777C0}">
         <c16r3:dataDisplayOptions16>
           <c16r3:dispNaAsBlank val="1"/>
@@ -8984,7 +8984,7 @@
                 </a:outerShdw>
               </a:effectLst>
             </c:spPr>
-            <c:extLst xmlns:w="http://schemas.openxmlformats.org/wordprocessingml/2006/main" xmlns:w15="http://schemas.microsoft.com/office/word/2012/wordml" xmlns:w14="http://schemas.microsoft.com/office/word/2010/wordml" xmlns:m="http://schemas.openxmlformats.org/officeDocument/2006/math" xmlns:wp="http://schemas.openxmlformats.org/drawingml/2006/wordprocessingDrawing" xmlns:wp14="http://schemas.microsoft.com/office/word/2010/wordprocessingDrawing" xmlns:mc="http://schemas.openxmlformats.org/markup-compatibility/2006" xmlns:sl="http://schemas.openxmlformats.org/schemaLibrary/2006/main" xmlns:wne="http://schemas.microsoft.com/office/word/2006/wordml" xmlns:cdr="http://schemas.openxmlformats.org/drawingml/2006/chartDrawing" xmlns:c14="http://schemas.microsoft.com/office/drawing/2007/8/2/chart" xmlns:dgm="http://schemas.openxmlformats.org/drawingml/2006/diagram" xmlns:pic="http://schemas.openxmlformats.org/drawingml/2006/picture" xmlns:xdr="http://schemas.openxmlformats.org/drawingml/2006/spreadsheetDrawing" xmlns:dsp="http://schemas.microsoft.com/office/drawing/2008/diagram" xmlns:xvml="urn:schemas-microsoft-com:office:excel" xmlns:o="urn:schemas-microsoft-com:office:office" xmlns:v="urn:schemas-microsoft-com:vml" xmlns:w10="urn:schemas-microsoft-com:office:word" xmlns:pvml="urn:schemas-microsoft-com:office:powerpoint" xmlns:cppr="http://schemas.microsoft.com/office/2006/coverPageProps" xmlns:odx="http://opendope.org/xpaths" xmlns:odc="http://opendope.org/conditions" xmlns:odq="http://opendope.org/questions" xmlns:oda="http://opendope.org/answers" xmlns:odi="http://opendope.org/components" xmlns:odgm="http://opendope.org/SmartArt/DataHierarchy" xmlns:b="http://schemas.openxmlformats.org/officeDocument/2006/bibliography" xmlns:wps="http://schemas.microsoft.com/office/word/2010/wordprocessingShape" xmlns:w16se="http://schemas.microsoft.com/office/word/2015/wordml/symex" xmlns:w16cid="http://schemas.microsoft.com/office/word/2016/wordml/cid" xmlns:wetp="http://schemas.microsoft.com/office/webextensions/taskpanes/2010/11" xmlns:we="http://schemas.microsoft.com/office/webextensions/webextension/2010/11" xmlns:comp="http://schemas.openxmlformats.org/drawingml/2006/compatibility" xmlns:lc="http://schemas.openxmlformats.org/drawingml/2006/lockedCanvas">
+            <c:extLst xmlns:lc="http://schemas.openxmlformats.org/drawingml/2006/lockedCanvas" xmlns:comp="http://schemas.openxmlformats.org/drawingml/2006/compatibility" xmlns:we="http://schemas.microsoft.com/office/webextensions/webextension/2010/11" xmlns:wetp="http://schemas.microsoft.com/office/webextensions/taskpanes/2010/11" xmlns:w16cid="http://schemas.microsoft.com/office/word/2016/wordml/cid" xmlns:w16se="http://schemas.microsoft.com/office/word/2015/wordml/symex" xmlns:wps="http://schemas.microsoft.com/office/word/2010/wordprocessingShape" xmlns:b="http://schemas.openxmlformats.org/officeDocument/2006/bibliography" xmlns:odgm="http://opendope.org/SmartArt/DataHierarchy" xmlns:odi="http://opendope.org/components" xmlns:oda="http://opendope.org/answers" xmlns:odq="http://opendope.org/questions" xmlns:odc="http://opendope.org/conditions" xmlns:odx="http://opendope.org/xpaths" xmlns:cppr="http://schemas.microsoft.com/office/2006/coverPageProps" xmlns:pvml="urn:schemas-microsoft-com:office:powerpoint" xmlns:w10="urn:schemas-microsoft-com:office:word" xmlns:v="urn:schemas-microsoft-com:vml" xmlns:o="urn:schemas-microsoft-com:office:office" xmlns:xvml="urn:schemas-microsoft-com:office:excel" xmlns:dsp="http://schemas.microsoft.com/office/drawing/2008/diagram" xmlns:xdr="http://schemas.openxmlformats.org/drawingml/2006/spreadsheetDrawing" xmlns:pic="http://schemas.openxmlformats.org/drawingml/2006/picture" xmlns:dgm="http://schemas.openxmlformats.org/drawingml/2006/diagram" xmlns:c14="http://schemas.microsoft.com/office/drawing/2007/8/2/chart" xmlns:cdr="http://schemas.openxmlformats.org/drawingml/2006/chartDrawing" xmlns:wne="http://schemas.microsoft.com/office/word/2006/wordml" xmlns:sl="http://schemas.openxmlformats.org/schemaLibrary/2006/main" xmlns:mc="http://schemas.openxmlformats.org/markup-compatibility/2006" xmlns:wp14="http://schemas.microsoft.com/office/word/2010/wordprocessingDrawing" xmlns:wp="http://schemas.openxmlformats.org/drawingml/2006/wordprocessingDrawing" xmlns:m="http://schemas.openxmlformats.org/officeDocument/2006/math" xmlns:w14="http://schemas.microsoft.com/office/word/2010/wordml" xmlns:w15="http://schemas.microsoft.com/office/word/2012/wordml" xmlns:w="http://schemas.openxmlformats.org/wordprocessingml/2006/main">
               <c:ext xmlns:c16="http://schemas.microsoft.com/office/drawing/2014/chart" uri="{C3380CC4-5D6E-409C-BE32-E72D297353CC}">
                 <c16:uniqueId val="{00000001-6147-E74A-AA7B-5531F0E4EE0C}"/>
               </c:ext>
@@ -9067,7 +9067,7 @@
               </c:numCache>
             </c:numRef>
           </c:val>
-          <c:extLst xmlns:w="http://schemas.openxmlformats.org/wordprocessingml/2006/main" xmlns:w15="http://schemas.microsoft.com/office/word/2012/wordml" xmlns:w14="http://schemas.microsoft.com/office/word/2010/wordml" xmlns:m="http://schemas.openxmlformats.org/officeDocument/2006/math" xmlns:wp="http://schemas.openxmlformats.org/drawingml/2006/wordprocessingDrawing" xmlns:wp14="http://schemas.microsoft.com/office/word/2010/wordprocessingDrawing" xmlns:mc="http://schemas.openxmlformats.org/markup-compatibility/2006" xmlns:sl="http://schemas.openxmlformats.org/schemaLibrary/2006/main" xmlns:wne="http://schemas.microsoft.com/office/word/2006/wordml" xmlns:cdr="http://schemas.openxmlformats.org/drawingml/2006/chartDrawing" xmlns:c14="http://schemas.microsoft.com/office/drawing/2007/8/2/chart" xmlns:dgm="http://schemas.openxmlformats.org/drawingml/2006/diagram" xmlns:pic="http://schemas.openxmlformats.org/drawingml/2006/picture" xmlns:xdr="http://schemas.openxmlformats.org/drawingml/2006/spreadsheetDrawing" xmlns:dsp="http://schemas.microsoft.com/office/drawing/2008/diagram" xmlns:xvml="urn:schemas-microsoft-com:office:excel" xmlns:o="urn:schemas-microsoft-com:office:office" xmlns:v="urn:schemas-microsoft-com:vml" xmlns:w10="urn:schemas-microsoft-com:office:word" xmlns:pvml="urn:schemas-microsoft-com:office:powerpoint" xmlns:cppr="http://schemas.microsoft.com/office/2006/coverPageProps" xmlns:odx="http://opendope.org/xpaths" xmlns:odc="http://opendope.org/conditions" xmlns:odq="http://opendope.org/questions" xmlns:oda="http://opendope.org/answers" xmlns:odi="http://opendope.org/components" xmlns:odgm="http://opendope.org/SmartArt/DataHierarchy" xmlns:b="http://schemas.openxmlformats.org/officeDocument/2006/bibliography" xmlns:wps="http://schemas.microsoft.com/office/word/2010/wordprocessingShape" xmlns:w16se="http://schemas.microsoft.com/office/word/2015/wordml/symex" xmlns:w16cid="http://schemas.microsoft.com/office/word/2016/wordml/cid" xmlns:wetp="http://schemas.microsoft.com/office/webextensions/taskpanes/2010/11" xmlns:we="http://schemas.microsoft.com/office/webextensions/webextension/2010/11" xmlns:comp="http://schemas.openxmlformats.org/drawingml/2006/compatibility" xmlns:lc="http://schemas.openxmlformats.org/drawingml/2006/lockedCanvas">
+          <c:extLst xmlns:lc="http://schemas.openxmlformats.org/drawingml/2006/lockedCanvas" xmlns:comp="http://schemas.openxmlformats.org/drawingml/2006/compatibility" xmlns:we="http://schemas.microsoft.com/office/webextensions/webextension/2010/11" xmlns:wetp="http://schemas.microsoft.com/office/webextensions/taskpanes/2010/11" xmlns:w16cid="http://schemas.microsoft.com/office/word/2016/wordml/cid" xmlns:w16se="http://schemas.microsoft.com/office/word/2015/wordml/symex" xmlns:wps="http://schemas.microsoft.com/office/word/2010/wordprocessingShape" xmlns:b="http://schemas.openxmlformats.org/officeDocument/2006/bibliography" xmlns:odgm="http://opendope.org/SmartArt/DataHierarchy" xmlns:odi="http://opendope.org/components" xmlns:oda="http://opendope.org/answers" xmlns:odq="http://opendope.org/questions" xmlns:odc="http://opendope.org/conditions" xmlns:odx="http://opendope.org/xpaths" xmlns:cppr="http://schemas.microsoft.com/office/2006/coverPageProps" xmlns:pvml="urn:schemas-microsoft-com:office:powerpoint" xmlns:w10="urn:schemas-microsoft-com:office:word" xmlns:v="urn:schemas-microsoft-com:vml" xmlns:o="urn:schemas-microsoft-com:office:office" xmlns:xvml="urn:schemas-microsoft-com:office:excel" xmlns:dsp="http://schemas.microsoft.com/office/drawing/2008/diagram" xmlns:xdr="http://schemas.openxmlformats.org/drawingml/2006/spreadsheetDrawing" xmlns:pic="http://schemas.openxmlformats.org/drawingml/2006/picture" xmlns:dgm="http://schemas.openxmlformats.org/drawingml/2006/diagram" xmlns:c14="http://schemas.microsoft.com/office/drawing/2007/8/2/chart" xmlns:cdr="http://schemas.openxmlformats.org/drawingml/2006/chartDrawing" xmlns:wne="http://schemas.microsoft.com/office/word/2006/wordml" xmlns:sl="http://schemas.openxmlformats.org/schemaLibrary/2006/main" xmlns:mc="http://schemas.openxmlformats.org/markup-compatibility/2006" xmlns:wp14="http://schemas.microsoft.com/office/word/2010/wordprocessingDrawing" xmlns:wp="http://schemas.openxmlformats.org/drawingml/2006/wordprocessingDrawing" xmlns:m="http://schemas.openxmlformats.org/officeDocument/2006/math" xmlns:w14="http://schemas.microsoft.com/office/word/2010/wordml" xmlns:w15="http://schemas.microsoft.com/office/word/2012/wordml" xmlns:w="http://schemas.openxmlformats.org/wordprocessingml/2006/main">
             <c:ext xmlns:c16="http://schemas.microsoft.com/office/drawing/2014/chart" uri="{C3380CC4-5D6E-409C-BE32-E72D297353CC}">
               <c16:uniqueId val="{00000002-6147-E74A-AA7B-5531F0E4EE0C}"/>
             </c:ext>
@@ -9630,7 +9630,7 @@
     <c:plotVisOnly val="1"/>
     <c:dispBlanksAs val="gap"/>
     <c:showDLblsOverMax val="0"/>
-    <c:extLst xmlns:w="http://schemas.openxmlformats.org/wordprocessingml/2006/main" xmlns:w15="http://schemas.microsoft.com/office/word/2012/wordml" xmlns:w14="http://schemas.microsoft.com/office/word/2010/wordml" xmlns:m="http://schemas.openxmlformats.org/officeDocument/2006/math" xmlns:wp="http://schemas.openxmlformats.org/drawingml/2006/wordprocessingDrawing" xmlns:wp14="http://schemas.microsoft.com/office/word/2010/wordprocessingDrawing" xmlns:mc="http://schemas.openxmlformats.org/markup-compatibility/2006" xmlns:sl="http://schemas.openxmlformats.org/schemaLibrary/2006/main" xmlns:wne="http://schemas.microsoft.com/office/word/2006/wordml" xmlns:cdr="http://schemas.openxmlformats.org/drawingml/2006/chartDrawing" xmlns:c14="http://schemas.microsoft.com/office/drawing/2007/8/2/chart" xmlns:dgm="http://schemas.openxmlformats.org/drawingml/2006/diagram" xmlns:pic="http://schemas.openxmlformats.org/drawingml/2006/picture" xmlns:xdr="http://schemas.openxmlformats.org/drawingml/2006/spreadsheetDrawing" xmlns:dsp="http://schemas.microsoft.com/office/drawing/2008/diagram" xmlns:xvml="urn:schemas-microsoft-com:office:excel" xmlns:o="urn:schemas-microsoft-com:office:office" xmlns:v="urn:schemas-microsoft-com:vml" xmlns:w10="urn:schemas-microsoft-com:office:word" xmlns:pvml="urn:schemas-microsoft-com:office:powerpoint" xmlns:cppr="http://schemas.microsoft.com/office/2006/coverPageProps" xmlns:odx="http://opendope.org/xpaths" xmlns:odc="http://opendope.org/conditions" xmlns:odq="http://opendope.org/questions" xmlns:oda="http://opendope.org/answers" xmlns:odi="http://opendope.org/components" xmlns:odgm="http://opendope.org/SmartArt/DataHierarchy" xmlns:b="http://schemas.openxmlformats.org/officeDocument/2006/bibliography" xmlns:wps="http://schemas.microsoft.com/office/word/2010/wordprocessingShape" xmlns:w16se="http://schemas.microsoft.com/office/word/2015/wordml/symex" xmlns:w16cid="http://schemas.microsoft.com/office/word/2016/wordml/cid" xmlns:wetp="http://schemas.microsoft.com/office/webextensions/taskpanes/2010/11" xmlns:we="http://schemas.microsoft.com/office/webextensions/webextension/2010/11" xmlns:comp="http://schemas.openxmlformats.org/drawingml/2006/compatibility" xmlns:lc="http://schemas.openxmlformats.org/drawingml/2006/lockedCanvas">
+    <c:extLst xmlns:lc="http://schemas.openxmlformats.org/drawingml/2006/lockedCanvas" xmlns:comp="http://schemas.openxmlformats.org/drawingml/2006/compatibility" xmlns:we="http://schemas.microsoft.com/office/webextensions/webextension/2010/11" xmlns:wetp="http://schemas.microsoft.com/office/webextensions/taskpanes/2010/11" xmlns:w16cid="http://schemas.microsoft.com/office/word/2016/wordml/cid" xmlns:w16se="http://schemas.microsoft.com/office/word/2015/wordml/symex" xmlns:wps="http://schemas.microsoft.com/office/word/2010/wordprocessingShape" xmlns:b="http://schemas.openxmlformats.org/officeDocument/2006/bibliography" xmlns:odgm="http://opendope.org/SmartArt/DataHierarchy" xmlns:odi="http://opendope.org/components" xmlns:oda="http://opendope.org/answers" xmlns:odq="http://opendope.org/questions" xmlns:odc="http://opendope.org/conditions" xmlns:odx="http://opendope.org/xpaths" xmlns:cppr="http://schemas.microsoft.com/office/2006/coverPageProps" xmlns:pvml="urn:schemas-microsoft-com:office:powerpoint" xmlns:w10="urn:schemas-microsoft-com:office:word" xmlns:v="urn:schemas-microsoft-com:vml" xmlns:o="urn:schemas-microsoft-com:office:office" xmlns:xvml="urn:schemas-microsoft-com:office:excel" xmlns:dsp="http://schemas.microsoft.com/office/drawing/2008/diagram" xmlns:xdr="http://schemas.openxmlformats.org/drawingml/2006/spreadsheetDrawing" xmlns:pic="http://schemas.openxmlformats.org/drawingml/2006/picture" xmlns:dgm="http://schemas.openxmlformats.org/drawingml/2006/diagram" xmlns:c14="http://schemas.microsoft.com/office/drawing/2007/8/2/chart" xmlns:cdr="http://schemas.openxmlformats.org/drawingml/2006/chartDrawing" xmlns:wne="http://schemas.microsoft.com/office/word/2006/wordml" xmlns:sl="http://schemas.openxmlformats.org/schemaLibrary/2006/main" xmlns:mc="http://schemas.openxmlformats.org/markup-compatibility/2006" xmlns:wp14="http://schemas.microsoft.com/office/word/2010/wordprocessingDrawing" xmlns:wp="http://schemas.openxmlformats.org/drawingml/2006/wordprocessingDrawing" xmlns:m="http://schemas.openxmlformats.org/officeDocument/2006/math" xmlns:w14="http://schemas.microsoft.com/office/word/2010/wordml" xmlns:w15="http://schemas.microsoft.com/office/word/2012/wordml" xmlns:w="http://schemas.openxmlformats.org/wordprocessingml/2006/main">
       <c:ext xmlns:c16r3="http://schemas.microsoft.com/office/drawing/2017/03/chart" uri="{56B9EC1D-385E-4148-901F-78D8002777C0}">
         <c16r3:dataDisplayOptions16>
           <c16r3:dispNaAsBlank val="1"/>
@@ -17788,7 +17788,7 @@
           <a:p>
             <a:fld id="{D672B8B4-E227-994A-A2C0-477E986EF4F1}" type="datetimeFigureOut">
               <a:rPr lang="nl-NL" smtClean="0"/>
-              <a:t>04-12-2025</a:t>
+              <a:t>11-12-2025</a:t>
             </a:fld>
             <a:endParaRPr lang="nl-NL"/>
           </a:p>
@@ -20785,7 +20785,7 @@
           <a:p>
             <a:fld id="{542F8156-3D1B-1047-9A3D-372BE84AD46C}" type="datetimeFigureOut">
               <a:rPr lang="nl-NL" smtClean="0"/>
-              <a:t>04-12-2025</a:t>
+              <a:t>11-12-2025</a:t>
             </a:fld>
             <a:endParaRPr lang="nl-NL"/>
           </a:p>
@@ -20985,7 +20985,7 @@
           <a:p>
             <a:fld id="{542F8156-3D1B-1047-9A3D-372BE84AD46C}" type="datetimeFigureOut">
               <a:rPr lang="nl-NL" smtClean="0"/>
-              <a:t>04-12-2025</a:t>
+              <a:t>11-12-2025</a:t>
             </a:fld>
             <a:endParaRPr lang="nl-NL"/>
           </a:p>
@@ -21195,7 +21195,7 @@
           <a:p>
             <a:fld id="{542F8156-3D1B-1047-9A3D-372BE84AD46C}" type="datetimeFigureOut">
               <a:rPr lang="nl-NL" smtClean="0"/>
-              <a:t>04-12-2025</a:t>
+              <a:t>11-12-2025</a:t>
             </a:fld>
             <a:endParaRPr lang="nl-NL"/>
           </a:p>
@@ -22120,7 +22120,7 @@
           <a:p>
             <a:fld id="{542F8156-3D1B-1047-9A3D-372BE84AD46C}" type="datetimeFigureOut">
               <a:rPr lang="nl-NL" smtClean="0"/>
-              <a:t>04-12-2025</a:t>
+              <a:t>11-12-2025</a:t>
             </a:fld>
             <a:endParaRPr lang="nl-NL"/>
           </a:p>
@@ -22396,7 +22396,7 @@
           <a:p>
             <a:fld id="{542F8156-3D1B-1047-9A3D-372BE84AD46C}" type="datetimeFigureOut">
               <a:rPr lang="nl-NL" smtClean="0"/>
-              <a:t>04-12-2025</a:t>
+              <a:t>11-12-2025</a:t>
             </a:fld>
             <a:endParaRPr lang="nl-NL"/>
           </a:p>
@@ -22664,7 +22664,7 @@
           <a:p>
             <a:fld id="{542F8156-3D1B-1047-9A3D-372BE84AD46C}" type="datetimeFigureOut">
               <a:rPr lang="nl-NL" smtClean="0"/>
-              <a:t>04-12-2025</a:t>
+              <a:t>11-12-2025</a:t>
             </a:fld>
             <a:endParaRPr lang="nl-NL"/>
           </a:p>
@@ -23079,7 +23079,7 @@
           <a:p>
             <a:fld id="{542F8156-3D1B-1047-9A3D-372BE84AD46C}" type="datetimeFigureOut">
               <a:rPr lang="nl-NL" smtClean="0"/>
-              <a:t>04-12-2025</a:t>
+              <a:t>11-12-2025</a:t>
             </a:fld>
             <a:endParaRPr lang="nl-NL"/>
           </a:p>
@@ -23221,7 +23221,7 @@
           <a:p>
             <a:fld id="{542F8156-3D1B-1047-9A3D-372BE84AD46C}" type="datetimeFigureOut">
               <a:rPr lang="nl-NL" smtClean="0"/>
-              <a:t>04-12-2025</a:t>
+              <a:t>11-12-2025</a:t>
             </a:fld>
             <a:endParaRPr lang="nl-NL"/>
           </a:p>
@@ -23334,7 +23334,7 @@
           <a:p>
             <a:fld id="{542F8156-3D1B-1047-9A3D-372BE84AD46C}" type="datetimeFigureOut">
               <a:rPr lang="nl-NL" smtClean="0"/>
-              <a:t>04-12-2025</a:t>
+              <a:t>11-12-2025</a:t>
             </a:fld>
             <a:endParaRPr lang="nl-NL"/>
           </a:p>
@@ -23647,7 +23647,7 @@
           <a:p>
             <a:fld id="{542F8156-3D1B-1047-9A3D-372BE84AD46C}" type="datetimeFigureOut">
               <a:rPr lang="nl-NL" smtClean="0"/>
-              <a:t>04-12-2025</a:t>
+              <a:t>11-12-2025</a:t>
             </a:fld>
             <a:endParaRPr lang="nl-NL"/>
           </a:p>
@@ -23936,7 +23936,7 @@
           <a:p>
             <a:fld id="{542F8156-3D1B-1047-9A3D-372BE84AD46C}" type="datetimeFigureOut">
               <a:rPr lang="nl-NL" smtClean="0"/>
-              <a:t>04-12-2025</a:t>
+              <a:t>11-12-2025</a:t>
             </a:fld>
             <a:endParaRPr lang="nl-NL"/>
           </a:p>
@@ -24179,7 +24179,7 @@
           <a:p>
             <a:fld id="{542F8156-3D1B-1047-9A3D-372BE84AD46C}" type="datetimeFigureOut">
               <a:rPr lang="nl-NL" smtClean="0"/>
-              <a:t>04-12-2025</a:t>
+              <a:t>11-12-2025</a:t>
             </a:fld>
             <a:endParaRPr lang="nl-NL"/>
           </a:p>
@@ -35820,7 +35820,7 @@
         <p:spPr>
           <a:xfrm>
             <a:off x="8958648" y="-525758"/>
-            <a:ext cx="4158724" cy="369332"/>
+            <a:ext cx="3191728" cy="369332"/>
           </a:xfrm>
           <a:prstGeom prst="rect">
             <a:avLst/>
@@ -35835,7 +35835,7 @@
           <a:p>
             <a:r>
               <a:rPr lang="en-US" b="1" dirty="0"/>
-              <a:t>OBJECTIVES_STATUS_CHART_SIGRID</a:t>
+              <a:t>PROGRESS_STATUS_CHART</a:t>
             </a:r>
             <a:endParaRPr lang="en-US" dirty="0"/>
           </a:p>
@@ -37787,7 +37787,7 @@
         <p:spPr>
           <a:xfrm>
             <a:off x="8958648" y="-525758"/>
-            <a:ext cx="4233488" cy="369332"/>
+            <a:ext cx="2911716" cy="369332"/>
           </a:xfrm>
           <a:prstGeom prst="rect">
             <a:avLst/>
@@ -37802,7 +37802,7 @@
           <a:p>
             <a:r>
               <a:rPr lang="en-US" b="1" dirty="0"/>
-              <a:t>OBJECTIVES_OVERALL_CHART_SIGRID</a:t>
+              <a:t>PROGRESS_TIME_CHART</a:t>
             </a:r>
             <a:endParaRPr lang="en-US" dirty="0"/>
           </a:p>
@@ -38042,7 +38042,7 @@
         <p:spPr>
           <a:xfrm>
             <a:off x="8958648" y="-525758"/>
-            <a:ext cx="4488878" cy="369332"/>
+            <a:ext cx="3627681" cy="369332"/>
           </a:xfrm>
           <a:prstGeom prst="rect">
             <a:avLst/>
@@ -38057,7 +38057,7 @@
           <a:p>
             <a:r>
               <a:rPr lang="en-US" b="1" dirty="0"/>
-              <a:t>OBJECTIVES_CAPABILITY_CHART_SIGRID</a:t>
+              <a:t>PROGRESS_CAPABILITY_CHART</a:t>
             </a:r>
             <a:endParaRPr lang="en-US" dirty="0"/>
           </a:p>
@@ -38345,7 +38345,7 @@
         <p:spPr>
           <a:xfrm>
             <a:off x="8958648" y="-525758"/>
-            <a:ext cx="5105072" cy="369332"/>
+            <a:ext cx="4856222" cy="369332"/>
           </a:xfrm>
           <a:prstGeom prst="rect">
             <a:avLst/>
@@ -38360,7 +38360,7 @@
           <a:p>
             <a:r>
               <a:rPr lang="en-US" b="1" dirty="0"/>
-              <a:t>OBJECTIVES_MAINTAINABILITY_CHART_SIGRID</a:t>
+              <a:t>PROGRESS_MAINTAINABILITY_TIME_CHART</a:t>
             </a:r>
             <a:endParaRPr lang="en-US" dirty="0"/>
           </a:p>
@@ -38605,7 +38605,7 @@
         <p:spPr>
           <a:xfrm>
             <a:off x="8958648" y="-525758"/>
-            <a:ext cx="4913802" cy="369332"/>
+            <a:ext cx="4664952" cy="369332"/>
           </a:xfrm>
           <a:prstGeom prst="rect">
             <a:avLst/>
@@ -38620,7 +38620,7 @@
           <a:p>
             <a:r>
               <a:rPr lang="en-US" b="1" dirty="0"/>
-              <a:t>OBJECTIVES_ARCHITECTURE_CHART_SIGRID</a:t>
+              <a:t>PROGRESS_ARCHITECTURE_TIME_CHART</a:t>
             </a:r>
             <a:endParaRPr lang="en-US" dirty="0"/>
           </a:p>
@@ -38860,7 +38860,7 @@
         <p:spPr>
           <a:xfrm>
             <a:off x="8958648" y="-525758"/>
-            <a:ext cx="3742456" cy="369332"/>
+            <a:ext cx="3493605" cy="369332"/>
           </a:xfrm>
           <a:prstGeom prst="rect">
             <a:avLst/>
@@ -38875,7 +38875,7 @@
           <a:p>
             <a:r>
               <a:rPr lang="en-US" b="1" dirty="0"/>
-              <a:t>OBJECTIVES_OSH_CHART_SIGRID</a:t>
+              <a:t>PROGRESS_OSH_TIME_CHART</a:t>
             </a:r>
             <a:endParaRPr lang="en-US" dirty="0"/>
           </a:p>
@@ -39115,7 +39115,7 @@
         <p:spPr>
           <a:xfrm>
             <a:off x="8958648" y="-525758"/>
-            <a:ext cx="4323704" cy="369332"/>
+            <a:ext cx="4074855" cy="369332"/>
           </a:xfrm>
           <a:prstGeom prst="rect">
             <a:avLst/>
@@ -39130,7 +39130,7 @@
           <a:p>
             <a:r>
               <a:rPr lang="en-US" b="1" dirty="0"/>
-              <a:t>OBJECTIVES_SECURITY_CHART_SIGRID</a:t>
+              <a:t>PROGRESS_SECURITY_TIME_CHART</a:t>
             </a:r>
             <a:endParaRPr lang="en-US" dirty="0"/>
           </a:p>

</xml_diff>